<commit_message>
update: presentation with improved law slides matching original theme
</commit_message>
<xml_diff>
--- a/assets/aljood_pitch_with_law.pptx
+++ b/assets/aljood_pitch_with_law.pptx
@@ -4429,7 +4429,6 @@
         <a:solidFill>
           <a:srgbClr val="1A2A4A"/>
         </a:solidFill>
-        <a:effectLst/>
       </p:bgPr>
     </p:bg>
     <p:spTree>
@@ -4438,226 +4437,468 @@
         <p:cNvGrpSpPr/>
         <p:nvPr/>
       </p:nvGrpSpPr>
-      <p:grpSpPr/>
+      <p:grpSpPr>
+        <a:xfrm>
+          <a:off x="0" y="0"/>
+          <a:ext cx="0" cy="0"/>
+          <a:chOff x="0" y="0"/>
+          <a:chExt cx="0" cy="0"/>
+        </a:xfrm>
+      </p:grpSpPr>
+      <p:grpSp>
+        <p:nvGrpSpPr>
+          <p:cNvPr name="Group 2" id="2"/>
+          <p:cNvGrpSpPr/>
+          <p:nvPr/>
+        </p:nvGrpSpPr>
+        <p:grpSpPr>
+          <a:xfrm rot="0">
+            <a:off x="666750" y="666750"/>
+            <a:ext cx="16954500" cy="8953500"/>
+            <a:chOff x="0" y="0"/>
+            <a:chExt cx="5734099" cy="3028120"/>
+          </a:xfrm>
+        </p:grpSpPr>
+        <p:sp>
+          <p:nvSpPr>
+            <p:cNvPr name="Freeform 3" id="3"/>
+            <p:cNvSpPr/>
+            <p:nvPr/>
+          </p:nvSpPr>
+          <p:spPr>
+            <a:xfrm flipH="false" flipV="false" rot="0">
+              <a:off x="52070" y="12700"/>
+              <a:ext cx="5669329" cy="2959540"/>
+            </a:xfrm>
+            <a:custGeom>
+              <a:avLst/>
+              <a:gdLst/>
+              <a:ahLst/>
+              <a:cxnLst/>
+              <a:rect r="r" b="b" t="t" l="l"/>
+              <a:pathLst>
+                <a:path h="2959540" w="5669329">
+                  <a:moveTo>
+                    <a:pt x="5523279" y="2959540"/>
+                  </a:moveTo>
+                  <a:lnTo>
+                    <a:pt x="164850" y="2959540"/>
+                  </a:lnTo>
+                  <a:cubicBezTo>
+                    <a:pt x="66040" y="2959540"/>
+                    <a:pt x="0" y="2893500"/>
+                    <a:pt x="0" y="2813490"/>
+                  </a:cubicBezTo>
+                  <a:lnTo>
+                    <a:pt x="0" y="146050"/>
+                  </a:lnTo>
+                  <a:cubicBezTo>
+                    <a:pt x="0" y="66040"/>
+                    <a:pt x="66040" y="0"/>
+                    <a:pt x="164850" y="0"/>
+                  </a:cubicBezTo>
+                  <a:lnTo>
+                    <a:pt x="5523279" y="0"/>
+                  </a:lnTo>
+                  <a:cubicBezTo>
+                    <a:pt x="5603289" y="0"/>
+                    <a:pt x="5669329" y="66040"/>
+                    <a:pt x="5669329" y="146050"/>
+                  </a:cubicBezTo>
+                  <a:lnTo>
+                    <a:pt x="5669329" y="2813490"/>
+                  </a:lnTo>
+                  <a:cubicBezTo>
+                    <a:pt x="5669329" y="2894770"/>
+                    <a:pt x="5603289" y="2959540"/>
+                    <a:pt x="5523279" y="2959540"/>
+                  </a:cubicBezTo>
+                  <a:close/>
+                </a:path>
+              </a:pathLst>
+            </a:custGeom>
+            <a:solidFill>
+              <a:srgbClr val="021633"/>
+            </a:solidFill>
+          </p:spPr>
+        </p:sp>
+        <p:sp>
+          <p:nvSpPr>
+            <p:cNvPr name="Freeform 4" id="4"/>
+            <p:cNvSpPr/>
+            <p:nvPr/>
+          </p:nvSpPr>
+          <p:spPr>
+            <a:xfrm flipH="false" flipV="false" rot="0">
+              <a:off x="0" y="0"/>
+              <a:ext cx="5734099" cy="3028120"/>
+            </a:xfrm>
+            <a:custGeom>
+              <a:avLst/>
+              <a:gdLst/>
+              <a:ahLst/>
+              <a:cxnLst/>
+              <a:rect r="r" b="b" t="t" l="l"/>
+              <a:pathLst>
+                <a:path h="3028120" w="5734099">
+                  <a:moveTo>
+                    <a:pt x="63500" y="74930"/>
+                  </a:moveTo>
+                  <a:cubicBezTo>
+                    <a:pt x="91440" y="30480"/>
+                    <a:pt x="140970" y="0"/>
+                    <a:pt x="216920" y="0"/>
+                  </a:cubicBezTo>
+                  <a:lnTo>
+                    <a:pt x="5575349" y="0"/>
+                  </a:lnTo>
+                  <a:cubicBezTo>
+                    <a:pt x="5662979" y="0"/>
+                    <a:pt x="5734099" y="71120"/>
+                    <a:pt x="5734099" y="158750"/>
+                  </a:cubicBezTo>
+                  <a:lnTo>
+                    <a:pt x="5734099" y="2826190"/>
+                  </a:lnTo>
+                  <a:cubicBezTo>
+                    <a:pt x="5734099" y="2878260"/>
+                    <a:pt x="5708699" y="2923980"/>
+                    <a:pt x="5670599" y="2953190"/>
+                  </a:cubicBezTo>
+                  <a:cubicBezTo>
+                    <a:pt x="5642659" y="2997640"/>
+                    <a:pt x="5593129" y="3028120"/>
+                    <a:pt x="5535979" y="3028120"/>
+                  </a:cubicBezTo>
+                  <a:lnTo>
+                    <a:pt x="158750" y="3028120"/>
+                  </a:lnTo>
+                  <a:cubicBezTo>
+                    <a:pt x="71120" y="3028120"/>
+                    <a:pt x="0" y="2957000"/>
+                    <a:pt x="0" y="2869370"/>
+                  </a:cubicBezTo>
+                  <a:lnTo>
+                    <a:pt x="0" y="208926"/>
+                  </a:lnTo>
+                  <a:cubicBezTo>
+                    <a:pt x="0" y="149860"/>
+                    <a:pt x="25400" y="104140"/>
+                    <a:pt x="63500" y="74930"/>
+                  </a:cubicBezTo>
+                  <a:close/>
+                  <a:moveTo>
+                    <a:pt x="5721399" y="2826190"/>
+                  </a:moveTo>
+                  <a:lnTo>
+                    <a:pt x="5721399" y="158750"/>
+                  </a:lnTo>
+                  <a:cubicBezTo>
+                    <a:pt x="5721399" y="78740"/>
+                    <a:pt x="5655359" y="12700"/>
+                    <a:pt x="5575349" y="12700"/>
+                  </a:cubicBezTo>
+                  <a:lnTo>
+                    <a:pt x="216920" y="12700"/>
+                  </a:lnTo>
+                  <a:cubicBezTo>
+                    <a:pt x="118110" y="12700"/>
+                    <a:pt x="52070" y="78740"/>
+                    <a:pt x="52070" y="158750"/>
+                  </a:cubicBezTo>
+                  <a:lnTo>
+                    <a:pt x="52070" y="2826190"/>
+                  </a:lnTo>
+                  <a:cubicBezTo>
+                    <a:pt x="52070" y="2906200"/>
+                    <a:pt x="118110" y="2972240"/>
+                    <a:pt x="216920" y="2972240"/>
+                  </a:cubicBezTo>
+                  <a:lnTo>
+                    <a:pt x="5575349" y="2972240"/>
+                  </a:lnTo>
+                  <a:cubicBezTo>
+                    <a:pt x="5655359" y="2972240"/>
+                    <a:pt x="5721399" y="2907470"/>
+                    <a:pt x="5721399" y="2826190"/>
+                  </a:cubicBezTo>
+                  <a:close/>
+                </a:path>
+              </a:pathLst>
+            </a:custGeom>
+            <a:solidFill>
+              <a:srgbClr val="C9A84C"/>
+            </a:solidFill>
+          </p:spPr>
+        </p:sp>
+      </p:grpSp>
       <p:sp>
         <p:nvSpPr>
-          <p:cNvPr id="2" name="TextBox 1"/>
-          <p:cNvSpPr txBox="1"/>
+          <p:cNvPr name="Freeform 5" id="5"/>
+          <p:cNvSpPr/>
           <p:nvPr/>
         </p:nvSpPr>
         <p:spPr>
-          <a:xfrm>
-            <a:off x="914400" y="457200"/>
-            <a:ext cx="16459200" cy="1097280"/>
+          <a:xfrm flipH="true" flipV="false" rot="0">
+            <a:off x="10486143" y="2216792"/>
+            <a:ext cx="5696832" cy="5911807"/>
+          </a:xfrm>
+          <a:custGeom>
+            <a:avLst/>
+            <a:gdLst/>
+            <a:ahLst/>
+            <a:cxnLst/>
+            <a:rect r="r" b="b" t="t" l="l"/>
+            <a:pathLst>
+              <a:path h="5911807" w="5696832">
+                <a:moveTo>
+                  <a:pt x="5696832" y="0"/>
+                </a:moveTo>
+                <a:lnTo>
+                  <a:pt x="0" y="0"/>
+                </a:lnTo>
+                <a:lnTo>
+                  <a:pt x="0" y="5911807"/>
+                </a:lnTo>
+                <a:lnTo>
+                  <a:pt x="5696832" y="5911807"/>
+                </a:lnTo>
+                <a:lnTo>
+                  <a:pt x="5696832" y="0"/>
+                </a:lnTo>
+                <a:close/>
+              </a:path>
+            </a:pathLst>
+          </a:custGeom>
+          <a:blipFill>
+            <a:blip r:embed="rId2">
+              <a:extLst>
+                <a:ext uri="{96DAC541-7B7A-43D3-8B79-37D633B846F1}">
+                  <asvg:svgBlip xmlns:asvg="http://schemas.microsoft.com/office/drawing/2016/SVG/main" r:embed="rId3"/>
+                </a:ext>
+              </a:extLst>
+            </a:blip>
+            <a:stretch>
+              <a:fillRect l="0" t="0" r="0" b="0"/>
+            </a:stretch>
+          </a:blipFill>
+          <a:ln cap="sq">
+            <a:noFill/>
+            <a:prstDash val="solid"/>
+            <a:miter/>
+          </a:ln>
+        </p:spPr>
+      </p:sp>
+      <p:sp>
+        <p:nvSpPr>
+          <p:cNvPr name="Freeform 6" id="6"/>
+          <p:cNvSpPr/>
+          <p:nvPr/>
+        </p:nvSpPr>
+        <p:spPr>
+          <a:xfrm flipH="false" flipV="false" rot="0">
+            <a:off x="10546645" y="2306609"/>
+            <a:ext cx="4485772" cy="4485772"/>
+          </a:xfrm>
+          <a:custGeom>
+            <a:avLst/>
+            <a:gdLst/>
+            <a:ahLst/>
+            <a:cxnLst/>
+            <a:rect r="r" b="b" t="t" l="l"/>
+            <a:pathLst>
+              <a:path h="4485772" w="4485772">
+                <a:moveTo>
+                  <a:pt x="0" y="0"/>
+                </a:moveTo>
+                <a:lnTo>
+                  <a:pt x="4485772" y="0"/>
+                </a:lnTo>
+                <a:lnTo>
+                  <a:pt x="4485772" y="4485772"/>
+                </a:lnTo>
+                <a:lnTo>
+                  <a:pt x="0" y="4485772"/>
+                </a:lnTo>
+                <a:lnTo>
+                  <a:pt x="0" y="0"/>
+                </a:lnTo>
+                <a:close/>
+              </a:path>
+            </a:pathLst>
+          </a:custGeom>
+          <a:blipFill>
+            <a:blip r:embed="rId4"/>
+            <a:stretch>
+              <a:fillRect l="0" t="0" r="0" b="0"/>
+            </a:stretch>
+          </a:blipFill>
+        </p:spPr>
+      </p:sp>
+      <p:sp>
+        <p:nvSpPr>
+          <p:cNvPr name="TextBox 7" id="7"/>
+          <p:cNvSpPr txBox="true"/>
+          <p:nvPr/>
+        </p:nvSpPr>
+        <p:spPr>
+          <a:xfrm rot="0">
+            <a:off x="2105025" y="5348287"/>
+            <a:ext cx="6886575" cy="817245"/>
           </a:xfrm>
           <a:prstGeom prst="rect">
             <a:avLst/>
           </a:prstGeom>
-          <a:noFill/>
         </p:spPr>
         <p:txBody>
-          <a:bodyPr wrap="square">
+          <a:bodyPr anchor="t" rtlCol="false" tIns="0" lIns="0" bIns="0" rIns="0">
             <a:spAutoFit/>
           </a:bodyPr>
           <a:lstStyle/>
           <a:p>
-            <a:pPr algn="ctr" rtl="1"/>
+            <a:pPr algn="ctr" rtl="true" marL="0" indent="0" lvl="0">
+              <a:lnSpc>
+                <a:spcPts val="3120"/>
+              </a:lnSpc>
+            </a:pPr>
             <a:r>
-              <a:rPr sz="3600" b="1">
+              <a:rPr lang="ar-SA" dirty="0" sz="1900">
                 <a:solidFill>
-                  <a:srgbClr val="C9A84C"/>
+                  <a:srgbClr val="FFFFFF"/>
                 </a:solidFill>
+                <a:latin typeface="Noto Sans Arabic"/>
+                <a:ea typeface="Noto Sans Arabic"/>
               </a:rPr>
-              <a:t>السياق الوطني — قانون سلامة الطفل الرقمي</a:t>
+              <a:t>صدر المرسوم الاتحادي رقم (2) لسنة 2026 في يناير 2026</a:t>
+            </a:r>
+          </a:p>
+          <a:p>
+            <a:pPr algn="ctr" rtl="true" marL="0" indent="0" lvl="0">
+              <a:lnSpc>
+                <a:spcPts val="3120"/>
+              </a:lnSpc>
+            </a:pPr>
+            <a:r>
+              <a:rPr lang="ar-SA" dirty="0" sz="1900">
+                <a:solidFill>
+                  <a:srgbClr val="FFFFFF"/>
+                </a:solidFill>
+                <a:latin typeface="Noto Sans Arabic"/>
+                <a:ea typeface="Noto Sans Arabic"/>
+              </a:rPr>
+              <a:t>يُلزم المدارس بتنظيم الوصول الرقمي وحماية بيانات الطلاب</a:t>
+            </a:r>
+          </a:p>
+          <a:p>
+            <a:pPr algn="ctr" rtl="true" marL="0" indent="0" lvl="0">
+              <a:lnSpc>
+                <a:spcPts val="3120"/>
+              </a:lnSpc>
+            </a:pPr>
+            <a:r>
+              <a:rPr lang="ar-SA" dirty="0" sz="1900">
+                <a:solidFill>
+                  <a:srgbClr val="FFFFFF"/>
+                </a:solidFill>
+                <a:latin typeface="Noto Sans Arabic"/>
+                <a:ea typeface="Noto Sans Arabic"/>
+              </a:rPr>
+              <a:t>يشترط توثيق هوية المستخدمين وضبط صلاحيات الوصول بدقة</a:t>
+            </a:r>
+          </a:p>
+          <a:p>
+            <a:pPr algn="ctr" rtl="true" marL="0" indent="0" lvl="0">
+              <a:lnSpc>
+                <a:spcPts val="3120"/>
+              </a:lnSpc>
+            </a:pPr>
+            <a:r>
+              <a:rPr lang="ar-SA" dirty="0" sz="1900">
+                <a:solidFill>
+                  <a:srgbClr val="FFFFFF"/>
+                </a:solidFill>
+                <a:latin typeface="Noto Sans Arabic"/>
+                <a:ea typeface="Noto Sans Arabic"/>
+              </a:rPr>
+              <a:t>يُوجب توفير أدوات رقابة لأولياء الأمور على النشاط الرقمي</a:t>
+            </a:r>
+          </a:p>
+          <a:p>
+            <a:pPr algn="ctr" rtl="true" marL="0" indent="0" lvl="0">
+              <a:lnSpc>
+                <a:spcPts val="3120"/>
+              </a:lnSpc>
+            </a:pPr>
+            <a:r>
+              <a:rPr lang="ar-SA" dirty="0" sz="1900">
+                <a:solidFill>
+                  <a:srgbClr val="FFFFFF"/>
+                </a:solidFill>
+                <a:latin typeface="Noto Sans Arabic"/>
+                <a:ea typeface="Noto Sans Arabic"/>
+              </a:rPr>
+              <a:t>يُلزم بالإبلاغ عن أي اختراق لخصوصية البيانات الرقمية للطفل</a:t>
             </a:r>
           </a:p>
         </p:txBody>
       </p:sp>
       <p:sp>
         <p:nvSpPr>
-          <p:cNvPr id="3" name="TextBox 2"/>
-          <p:cNvSpPr txBox="1"/>
+          <p:cNvPr name="TextBox 8" id="8"/>
+          <p:cNvSpPr txBox="true"/>
           <p:nvPr/>
         </p:nvSpPr>
         <p:spPr>
-          <a:xfrm>
-            <a:off x="914400" y="1371600"/>
-            <a:ext cx="16459200" cy="640080"/>
+          <a:xfrm rot="0">
+            <a:off x="1414462" y="3330508"/>
+            <a:ext cx="8267700" cy="1812992"/>
           </a:xfrm>
           <a:prstGeom prst="rect">
             <a:avLst/>
           </a:prstGeom>
-          <a:noFill/>
         </p:spPr>
         <p:txBody>
-          <a:bodyPr wrap="square">
+          <a:bodyPr anchor="t" rtlCol="false" tIns="0" lIns="0" bIns="0" rIns="0">
             <a:spAutoFit/>
           </a:bodyPr>
           <a:lstStyle/>
           <a:p>
-            <a:pPr algn="ctr"/>
+            <a:pPr algn="ctr" rtl="true" marL="0" indent="0" lvl="0">
+              <a:lnSpc>
+                <a:spcPts val="6861"/>
+              </a:lnSpc>
+              <a:spcBef>
+                <a:spcPct val="0"/>
+              </a:spcBef>
+            </a:pPr>
             <a:r>
-              <a:rPr sz="2200" b="0">
-                <a:solidFill>
-                  <a:srgbClr val="F3E5B8"/>
-                </a:solidFill>
-              </a:rPr>
-              <a:t>National Context — UAE Child Digital Safety Law</a:t>
-            </a:r>
-          </a:p>
-        </p:txBody>
-      </p:sp>
-      <p:sp>
-        <p:nvSpPr>
-          <p:cNvPr id="4" name="Rectangle 3"/>
-          <p:cNvSpPr/>
-          <p:nvPr/>
-        </p:nvSpPr>
-        <p:spPr>
-          <a:xfrm>
-            <a:off x="914400" y="2148840"/>
-            <a:ext cx="16459200" cy="38100"/>
-          </a:xfrm>
-          <a:prstGeom prst="rect">
-            <a:avLst/>
-          </a:prstGeom>
-          <a:solidFill>
-            <a:srgbClr val="C9A84C"/>
-          </a:solidFill>
-          <a:ln>
-            <a:noFill/>
-          </a:ln>
-        </p:spPr>
-        <p:style>
-          <a:lnRef idx="1">
-            <a:schemeClr val="accent1"/>
-          </a:lnRef>
-          <a:fillRef idx="3">
-            <a:schemeClr val="accent1"/>
-          </a:fillRef>
-          <a:effectRef idx="2">
-            <a:schemeClr val="accent1"/>
-          </a:effectRef>
-          <a:fontRef idx="minor">
-            <a:schemeClr val="lt1"/>
-          </a:fontRef>
-        </p:style>
-        <p:txBody>
-          <a:bodyPr rtlCol="0" anchor="ctr"/>
-          <a:lstStyle/>
-          <a:p>
-            <a:pPr algn="ctr"/>
-          </a:p>
-        </p:txBody>
-      </p:sp>
-      <p:sp>
-        <p:nvSpPr>
-          <p:cNvPr id="5" name="TextBox 4"/>
-          <p:cNvSpPr txBox="1"/>
-          <p:nvPr/>
-        </p:nvSpPr>
-        <p:spPr>
-          <a:xfrm>
-            <a:off x="914400" y="2331720"/>
-            <a:ext cx="16459200" cy="5029200"/>
-          </a:xfrm>
-          <a:prstGeom prst="rect">
-            <a:avLst/>
-          </a:prstGeom>
-          <a:noFill/>
-        </p:spPr>
-        <p:txBody>
-          <a:bodyPr wrap="square">
-            <a:spAutoFit/>
-          </a:bodyPr>
-          <a:lstStyle/>
-          <a:p>
-            <a:pPr algn="r" rtl="1"/>
-            <a:r>
-              <a:rPr sz="2400" b="0">
-                <a:solidFill>
-                  <a:srgbClr val="F3E5B8"/>
-                </a:solidFill>
-              </a:rPr>
-              <a:t>المرسوم الاتحادي بقانون رقم (٢) لسنة ٢٠٢٦
-• يُلزم المدارس بتطبيق برامج لحماية الطلاب رقمياً
-• يُحدد مسؤولية الإدارة المدرسية في توثيق البيانات وصون الخصوصية
-• يُوجب الشفافية في إدارة بيانات الطلاب والموظفين
-• يدعو إلى تعاون فعّال بين المدارس وأولياء الأمور رقمياً
-• يُشكّل بوابة مدرسة الجود نموذجاً تطبيقياً مباشراً لهذا القانون</a:t>
-            </a:r>
-          </a:p>
-        </p:txBody>
-      </p:sp>
-      <p:sp>
-        <p:nvSpPr>
-          <p:cNvPr id="6" name="TextBox 5"/>
-          <p:cNvSpPr txBox="1"/>
-          <p:nvPr/>
-        </p:nvSpPr>
-        <p:spPr>
-          <a:xfrm>
-            <a:off x="914400" y="5029200"/>
-            <a:ext cx="16459200" cy="4114800"/>
-          </a:xfrm>
-          <a:prstGeom prst="rect">
-            <a:avLst/>
-          </a:prstGeom>
-          <a:noFill/>
-        </p:spPr>
-        <p:txBody>
-          <a:bodyPr wrap="square">
-            <a:spAutoFit/>
-          </a:bodyPr>
-          <a:lstStyle/>
-          <a:p>
-            <a:pPr algn="l"/>
-            <a:r>
-              <a:rPr sz="1800" b="0">
-                <a:solidFill>
-                  <a:srgbClr val="FFFFFF"/>
-                </a:solidFill>
-              </a:rPr>
-              <a:t>Federal Decree Law No. 2 of 2026
-• Schools must implement student digital protection programs
-• School administration responsible for data documentation &amp; privacy
-• Mandates transparency in managing student and staff data
-• Calls for effective digital collaboration with parents
-• Al Jood Digital Portal is a direct implementation model of this law</a:t>
-            </a:r>
-          </a:p>
-        </p:txBody>
-      </p:sp>
-      <p:sp>
-        <p:nvSpPr>
-          <p:cNvPr id="7" name="TextBox 6"/>
-          <p:cNvSpPr txBox="1"/>
-          <p:nvPr/>
-        </p:nvSpPr>
-        <p:spPr>
-          <a:xfrm>
-            <a:off x="914400" y="9418320"/>
-            <a:ext cx="16459200" cy="548640"/>
-          </a:xfrm>
-          <a:prstGeom prst="rect">
-            <a:avLst/>
-          </a:prstGeom>
-          <a:noFill/>
-        </p:spPr>
-        <p:txBody>
-          <a:bodyPr wrap="square">
-            <a:spAutoFit/>
-          </a:bodyPr>
-          <a:lstStyle/>
-          <a:p>
-            <a:pPr algn="ctr" rtl="1"/>
-            <a:r>
-              <a:rPr sz="1400" b="0">
+              <a:rPr lang="ar-SA" dirty="0" b="1" sz="3000">
                 <a:solidFill>
                   <a:srgbClr val="C9A84C"/>
                 </a:solidFill>
+                <a:latin typeface="Noto Sans Arabic"/>
+                <a:ea typeface="Noto Sans Arabic"/>
               </a:rPr>
-              <a:t>المصدر: وزارة الدولة للتعليم العام والتعليم الخاص — يناير ٢٠٢٦</a:t>
+              <a:t>السياق الوطني: قانون سلامة الطفل الرقمي</a:t>
+            </a:r>
+          </a:p>
+          <a:p>
+            <a:pPr algn="ctr" rtl="true" marL="0" indent="0" lvl="0">
+              <a:lnSpc>
+                <a:spcPts val="6861"/>
+              </a:lnSpc>
+              <a:spcBef>
+                <a:spcPct val="0"/>
+              </a:spcBef>
+            </a:pPr>
+            <a:r>
+              <a:rPr lang="en-US" dirty="0" sz="1800">
+                <a:solidFill>
+                  <a:srgbClr val="BBBBBB"/>
+                </a:solidFill>
+                <a:latin typeface="Calibri"/>
+              </a:rPr>
+              <a:t>National Context: UAE Child Digital Safety Law — Federal Decree No. 2 / 2026</a:t>
             </a:r>
           </a:p>
         </p:txBody>
@@ -4678,7 +4919,6 @@
         <a:solidFill>
           <a:srgbClr val="1A2A4A"/>
         </a:solidFill>
-        <a:effectLst/>
       </p:bgPr>
     </p:bg>
     <p:spTree>
@@ -4687,228 +4927,468 @@
         <p:cNvGrpSpPr/>
         <p:nvPr/>
       </p:nvGrpSpPr>
-      <p:grpSpPr/>
+      <p:grpSpPr>
+        <a:xfrm>
+          <a:off x="0" y="0"/>
+          <a:ext cx="0" cy="0"/>
+          <a:chOff x="0" y="0"/>
+          <a:chExt cx="0" cy="0"/>
+        </a:xfrm>
+      </p:grpSpPr>
+      <p:grpSp>
+        <p:nvGrpSpPr>
+          <p:cNvPr name="Group 2" id="2"/>
+          <p:cNvGrpSpPr/>
+          <p:nvPr/>
+        </p:nvGrpSpPr>
+        <p:grpSpPr>
+          <a:xfrm rot="0">
+            <a:off x="666750" y="666750"/>
+            <a:ext cx="16954500" cy="8953500"/>
+            <a:chOff x="0" y="0"/>
+            <a:chExt cx="5734099" cy="3028120"/>
+          </a:xfrm>
+        </p:grpSpPr>
+        <p:sp>
+          <p:nvSpPr>
+            <p:cNvPr name="Freeform 3" id="3"/>
+            <p:cNvSpPr/>
+            <p:nvPr/>
+          </p:nvSpPr>
+          <p:spPr>
+            <a:xfrm flipH="false" flipV="false" rot="0">
+              <a:off x="52070" y="12700"/>
+              <a:ext cx="5669329" cy="2959540"/>
+            </a:xfrm>
+            <a:custGeom>
+              <a:avLst/>
+              <a:gdLst/>
+              <a:ahLst/>
+              <a:cxnLst/>
+              <a:rect r="r" b="b" t="t" l="l"/>
+              <a:pathLst>
+                <a:path h="2959540" w="5669329">
+                  <a:moveTo>
+                    <a:pt x="5523279" y="2959540"/>
+                  </a:moveTo>
+                  <a:lnTo>
+                    <a:pt x="164850" y="2959540"/>
+                  </a:lnTo>
+                  <a:cubicBezTo>
+                    <a:pt x="66040" y="2959540"/>
+                    <a:pt x="0" y="2893500"/>
+                    <a:pt x="0" y="2813490"/>
+                  </a:cubicBezTo>
+                  <a:lnTo>
+                    <a:pt x="0" y="146050"/>
+                  </a:lnTo>
+                  <a:cubicBezTo>
+                    <a:pt x="0" y="66040"/>
+                    <a:pt x="66040" y="0"/>
+                    <a:pt x="164850" y="0"/>
+                  </a:cubicBezTo>
+                  <a:lnTo>
+                    <a:pt x="5523279" y="0"/>
+                  </a:lnTo>
+                  <a:cubicBezTo>
+                    <a:pt x="5603289" y="0"/>
+                    <a:pt x="5669329" y="66040"/>
+                    <a:pt x="5669329" y="146050"/>
+                  </a:cubicBezTo>
+                  <a:lnTo>
+                    <a:pt x="5669329" y="2813490"/>
+                  </a:lnTo>
+                  <a:cubicBezTo>
+                    <a:pt x="5669329" y="2894770"/>
+                    <a:pt x="5603289" y="2959540"/>
+                    <a:pt x="5523279" y="2959540"/>
+                  </a:cubicBezTo>
+                  <a:close/>
+                </a:path>
+              </a:pathLst>
+            </a:custGeom>
+            <a:solidFill>
+              <a:srgbClr val="021633"/>
+            </a:solidFill>
+          </p:spPr>
+        </p:sp>
+        <p:sp>
+          <p:nvSpPr>
+            <p:cNvPr name="Freeform 4" id="4"/>
+            <p:cNvSpPr/>
+            <p:nvPr/>
+          </p:nvSpPr>
+          <p:spPr>
+            <a:xfrm flipH="false" flipV="false" rot="0">
+              <a:off x="0" y="0"/>
+              <a:ext cx="5734099" cy="3028120"/>
+            </a:xfrm>
+            <a:custGeom>
+              <a:avLst/>
+              <a:gdLst/>
+              <a:ahLst/>
+              <a:cxnLst/>
+              <a:rect r="r" b="b" t="t" l="l"/>
+              <a:pathLst>
+                <a:path h="3028120" w="5734099">
+                  <a:moveTo>
+                    <a:pt x="63500" y="74930"/>
+                  </a:moveTo>
+                  <a:cubicBezTo>
+                    <a:pt x="91440" y="30480"/>
+                    <a:pt x="140970" y="0"/>
+                    <a:pt x="216920" y="0"/>
+                  </a:cubicBezTo>
+                  <a:lnTo>
+                    <a:pt x="5575349" y="0"/>
+                  </a:lnTo>
+                  <a:cubicBezTo>
+                    <a:pt x="5662979" y="0"/>
+                    <a:pt x="5734099" y="71120"/>
+                    <a:pt x="5734099" y="158750"/>
+                  </a:cubicBezTo>
+                  <a:lnTo>
+                    <a:pt x="5734099" y="2826190"/>
+                  </a:lnTo>
+                  <a:cubicBezTo>
+                    <a:pt x="5734099" y="2878260"/>
+                    <a:pt x="5708699" y="2923980"/>
+                    <a:pt x="5670599" y="2953190"/>
+                  </a:cubicBezTo>
+                  <a:cubicBezTo>
+                    <a:pt x="5642659" y="2997640"/>
+                    <a:pt x="5593129" y="3028120"/>
+                    <a:pt x="5535979" y="3028120"/>
+                  </a:cubicBezTo>
+                  <a:lnTo>
+                    <a:pt x="158750" y="3028120"/>
+                  </a:lnTo>
+                  <a:cubicBezTo>
+                    <a:pt x="71120" y="3028120"/>
+                    <a:pt x="0" y="2957000"/>
+                    <a:pt x="0" y="2869370"/>
+                  </a:cubicBezTo>
+                  <a:lnTo>
+                    <a:pt x="0" y="208926"/>
+                  </a:lnTo>
+                  <a:cubicBezTo>
+                    <a:pt x="0" y="149860"/>
+                    <a:pt x="25400" y="104140"/>
+                    <a:pt x="63500" y="74930"/>
+                  </a:cubicBezTo>
+                  <a:close/>
+                  <a:moveTo>
+                    <a:pt x="5721399" y="2826190"/>
+                  </a:moveTo>
+                  <a:lnTo>
+                    <a:pt x="5721399" y="158750"/>
+                  </a:lnTo>
+                  <a:cubicBezTo>
+                    <a:pt x="5721399" y="78740"/>
+                    <a:pt x="5655359" y="12700"/>
+                    <a:pt x="5575349" y="12700"/>
+                  </a:cubicBezTo>
+                  <a:lnTo>
+                    <a:pt x="216920" y="12700"/>
+                  </a:lnTo>
+                  <a:cubicBezTo>
+                    <a:pt x="118110" y="12700"/>
+                    <a:pt x="52070" y="78740"/>
+                    <a:pt x="52070" y="158750"/>
+                  </a:cubicBezTo>
+                  <a:lnTo>
+                    <a:pt x="52070" y="2826190"/>
+                  </a:lnTo>
+                  <a:cubicBezTo>
+                    <a:pt x="52070" y="2906200"/>
+                    <a:pt x="118110" y="2972240"/>
+                    <a:pt x="216920" y="2972240"/>
+                  </a:cubicBezTo>
+                  <a:lnTo>
+                    <a:pt x="5575349" y="2972240"/>
+                  </a:lnTo>
+                  <a:cubicBezTo>
+                    <a:pt x="5655359" y="2972240"/>
+                    <a:pt x="5721399" y="2907470"/>
+                    <a:pt x="5721399" y="2826190"/>
+                  </a:cubicBezTo>
+                  <a:close/>
+                </a:path>
+              </a:pathLst>
+            </a:custGeom>
+            <a:solidFill>
+              <a:srgbClr val="C9A84C"/>
+            </a:solidFill>
+          </p:spPr>
+        </p:sp>
+      </p:grpSp>
       <p:sp>
         <p:nvSpPr>
-          <p:cNvPr id="2" name="TextBox 1"/>
-          <p:cNvSpPr txBox="1"/>
+          <p:cNvPr name="Freeform 5" id="5"/>
+          <p:cNvSpPr/>
           <p:nvPr/>
         </p:nvSpPr>
         <p:spPr>
-          <a:xfrm>
-            <a:off x="914400" y="457200"/>
-            <a:ext cx="16459200" cy="1097280"/>
+          <a:xfrm flipH="true" flipV="false" rot="0">
+            <a:off x="10486143" y="2216792"/>
+            <a:ext cx="5696832" cy="5911807"/>
+          </a:xfrm>
+          <a:custGeom>
+            <a:avLst/>
+            <a:gdLst/>
+            <a:ahLst/>
+            <a:cxnLst/>
+            <a:rect r="r" b="b" t="t" l="l"/>
+            <a:pathLst>
+              <a:path h="5911807" w="5696832">
+                <a:moveTo>
+                  <a:pt x="5696832" y="0"/>
+                </a:moveTo>
+                <a:lnTo>
+                  <a:pt x="0" y="0"/>
+                </a:lnTo>
+                <a:lnTo>
+                  <a:pt x="0" y="5911807"/>
+                </a:lnTo>
+                <a:lnTo>
+                  <a:pt x="5696832" y="5911807"/>
+                </a:lnTo>
+                <a:lnTo>
+                  <a:pt x="5696832" y="0"/>
+                </a:lnTo>
+                <a:close/>
+              </a:path>
+            </a:pathLst>
+          </a:custGeom>
+          <a:blipFill>
+            <a:blip r:embed="rId2">
+              <a:extLst>
+                <a:ext uri="{96DAC541-7B7A-43D3-8B79-37D633B846F1}">
+                  <asvg:svgBlip xmlns:asvg="http://schemas.microsoft.com/office/drawing/2016/SVG/main" r:embed="rId3"/>
+                </a:ext>
+              </a:extLst>
+            </a:blip>
+            <a:stretch>
+              <a:fillRect l="0" t="0" r="0" b="0"/>
+            </a:stretch>
+          </a:blipFill>
+          <a:ln cap="sq">
+            <a:noFill/>
+            <a:prstDash val="solid"/>
+            <a:miter/>
+          </a:ln>
+        </p:spPr>
+      </p:sp>
+      <p:sp>
+        <p:nvSpPr>
+          <p:cNvPr name="Freeform 6" id="6"/>
+          <p:cNvSpPr/>
+          <p:nvPr/>
+        </p:nvSpPr>
+        <p:spPr>
+          <a:xfrm flipH="false" flipV="false" rot="0">
+            <a:off x="10546645" y="2306609"/>
+            <a:ext cx="4485772" cy="4485772"/>
+          </a:xfrm>
+          <a:custGeom>
+            <a:avLst/>
+            <a:gdLst/>
+            <a:ahLst/>
+            <a:cxnLst/>
+            <a:rect r="r" b="b" t="t" l="l"/>
+            <a:pathLst>
+              <a:path h="4485772" w="4485772">
+                <a:moveTo>
+                  <a:pt x="0" y="0"/>
+                </a:moveTo>
+                <a:lnTo>
+                  <a:pt x="4485772" y="0"/>
+                </a:lnTo>
+                <a:lnTo>
+                  <a:pt x="4485772" y="4485772"/>
+                </a:lnTo>
+                <a:lnTo>
+                  <a:pt x="0" y="4485772"/>
+                </a:lnTo>
+                <a:lnTo>
+                  <a:pt x="0" y="0"/>
+                </a:lnTo>
+                <a:close/>
+              </a:path>
+            </a:pathLst>
+          </a:custGeom>
+          <a:blipFill>
+            <a:blip r:embed="rId4"/>
+            <a:stretch>
+              <a:fillRect l="0" t="0" r="0" b="0"/>
+            </a:stretch>
+          </a:blipFill>
+        </p:spPr>
+      </p:sp>
+      <p:sp>
+        <p:nvSpPr>
+          <p:cNvPr name="TextBox 7" id="7"/>
+          <p:cNvSpPr txBox="true"/>
+          <p:nvPr/>
+        </p:nvSpPr>
+        <p:spPr>
+          <a:xfrm rot="0">
+            <a:off x="2105025" y="5348287"/>
+            <a:ext cx="6886575" cy="817245"/>
           </a:xfrm>
           <a:prstGeom prst="rect">
             <a:avLst/>
           </a:prstGeom>
-          <a:noFill/>
         </p:spPr>
         <p:txBody>
-          <a:bodyPr wrap="square">
+          <a:bodyPr anchor="t" rtlCol="false" tIns="0" lIns="0" bIns="0" rIns="0">
             <a:spAutoFit/>
           </a:bodyPr>
           <a:lstStyle/>
           <a:p>
-            <a:pPr algn="ctr" rtl="1"/>
+            <a:pPr algn="ctr" rtl="true" marL="0" indent="0" lvl="0">
+              <a:lnSpc>
+                <a:spcPts val="3120"/>
+              </a:lnSpc>
+            </a:pPr>
             <a:r>
-              <a:rPr sz="3600" b="1">
+              <a:rPr lang="ar-SA" dirty="0" sz="1900">
                 <a:solidFill>
-                  <a:srgbClr val="C9A84C"/>
+                  <a:srgbClr val="FFFFFF"/>
                 </a:solidFill>
+                <a:latin typeface="Noto Sans Arabic"/>
+                <a:ea typeface="Noto Sans Arabic"/>
               </a:rPr>
-              <a:t>كيف تُجسّد بوابة الجود القانون؟</a:t>
+              <a:t>نظام صلاحيات متعدد المستويات: مدير، معلم، إداري، مديرة، ولي أمر</a:t>
+            </a:r>
+          </a:p>
+          <a:p>
+            <a:pPr algn="ctr" rtl="true" marL="0" indent="0" lvl="0">
+              <a:lnSpc>
+                <a:spcPts val="3120"/>
+              </a:lnSpc>
+            </a:pPr>
+            <a:r>
+              <a:rPr lang="ar-SA" dirty="0" sz="1900">
+                <a:solidFill>
+                  <a:srgbClr val="FFFFFF"/>
+                </a:solidFill>
+                <a:latin typeface="Noto Sans Arabic"/>
+                <a:ea typeface="Noto Sans Arabic"/>
+              </a:rPr>
+              <a:t>بيانات الطلاب محمية محلياً — لا تُرفع لخوادم خارجية</a:t>
+            </a:r>
+          </a:p>
+          <a:p>
+            <a:pPr algn="ctr" rtl="true" marL="0" indent="0" lvl="0">
+              <a:lnSpc>
+                <a:spcPts val="3120"/>
+              </a:lnSpc>
+            </a:pPr>
+            <a:r>
+              <a:rPr lang="ar-SA" dirty="0" sz="1900">
+                <a:solidFill>
+                  <a:srgbClr val="FFFFFF"/>
+                </a:solidFill>
+                <a:latin typeface="Noto Sans Arabic"/>
+                <a:ea typeface="Noto Sans Arabic"/>
+              </a:rPr>
+              <a:t>لوحة رقابة خاصة بمديرة المدرسة لمتابعة الأنشطة الرقمية</a:t>
+            </a:r>
+          </a:p>
+          <a:p>
+            <a:pPr algn="ctr" rtl="true" marL="0" indent="0" lvl="0">
+              <a:lnSpc>
+                <a:spcPts val="3120"/>
+              </a:lnSpc>
+            </a:pPr>
+            <a:r>
+              <a:rPr lang="ar-SA" dirty="0" sz="1900">
+                <a:solidFill>
+                  <a:srgbClr val="FFFFFF"/>
+                </a:solidFill>
+                <a:latin typeface="Noto Sans Arabic"/>
+                <a:ea typeface="Noto Sans Arabic"/>
+              </a:rPr>
+              <a:t>بوابة أولياء الأمور (قريباً) — اطلاع على بيانات أبنائهم فقط</a:t>
+            </a:r>
+          </a:p>
+          <a:p>
+            <a:pPr algn="ctr" rtl="true" marL="0" indent="0" lvl="0">
+              <a:lnSpc>
+                <a:spcPts val="3120"/>
+              </a:lnSpc>
+            </a:pPr>
+            <a:r>
+              <a:rPr lang="ar-SA" dirty="0" sz="1900">
+                <a:solidFill>
+                  <a:srgbClr val="FFFFFF"/>
+                </a:solidFill>
+                <a:latin typeface="Noto Sans Arabic"/>
+                <a:ea typeface="Noto Sans Arabic"/>
+              </a:rPr>
+              <a:t>امتثال تام لاشتراطات المرسوم الاتحادي رقم (2) لسنة 2026</a:t>
             </a:r>
           </a:p>
         </p:txBody>
       </p:sp>
       <p:sp>
         <p:nvSpPr>
-          <p:cNvPr id="3" name="TextBox 2"/>
-          <p:cNvSpPr txBox="1"/>
+          <p:cNvPr name="TextBox 8" id="8"/>
+          <p:cNvSpPr txBox="true"/>
           <p:nvPr/>
         </p:nvSpPr>
         <p:spPr>
-          <a:xfrm>
-            <a:off x="914400" y="1371600"/>
-            <a:ext cx="16459200" cy="640080"/>
+          <a:xfrm rot="0">
+            <a:off x="1414462" y="3330508"/>
+            <a:ext cx="8267700" cy="1812992"/>
           </a:xfrm>
           <a:prstGeom prst="rect">
             <a:avLst/>
           </a:prstGeom>
-          <a:noFill/>
         </p:spPr>
         <p:txBody>
-          <a:bodyPr wrap="square">
+          <a:bodyPr anchor="t" rtlCol="false" tIns="0" lIns="0" bIns="0" rIns="0">
             <a:spAutoFit/>
           </a:bodyPr>
           <a:lstStyle/>
           <a:p>
-            <a:pPr algn="ctr"/>
+            <a:pPr algn="ctr" rtl="true" marL="0" indent="0" lvl="0">
+              <a:lnSpc>
+                <a:spcPts val="6861"/>
+              </a:lnSpc>
+              <a:spcBef>
+                <a:spcPct val="0"/>
+              </a:spcBef>
+            </a:pPr>
             <a:r>
-              <a:rPr sz="2200" b="0">
+              <a:rPr lang="ar-SA" dirty="0" b="1" sz="3000">
                 <a:solidFill>
-                  <a:srgbClr val="F3E5B8"/>
+                  <a:srgbClr val="C9A84C"/>
                 </a:solidFill>
+                <a:latin typeface="Noto Sans Arabic"/>
+                <a:ea typeface="Noto Sans Arabic"/>
               </a:rPr>
-              <a:t>How Al Jood Portal Embodies the Law</a:t>
+              <a:t>بوابة مدرسة الجود وقانون الطفل الرقمي</a:t>
             </a:r>
           </a:p>
-        </p:txBody>
-      </p:sp>
-      <p:sp>
-        <p:nvSpPr>
-          <p:cNvPr id="4" name="Rectangle 3"/>
-          <p:cNvSpPr/>
-          <p:nvPr/>
-        </p:nvSpPr>
-        <p:spPr>
-          <a:xfrm>
-            <a:off x="914400" y="2148840"/>
-            <a:ext cx="16459200" cy="38100"/>
-          </a:xfrm>
-          <a:prstGeom prst="rect">
-            <a:avLst/>
-          </a:prstGeom>
-          <a:solidFill>
-            <a:srgbClr val="C9A84C"/>
-          </a:solidFill>
-          <a:ln>
-            <a:noFill/>
-          </a:ln>
-        </p:spPr>
-        <p:style>
-          <a:lnRef idx="1">
-            <a:schemeClr val="accent1"/>
-          </a:lnRef>
-          <a:fillRef idx="3">
-            <a:schemeClr val="accent1"/>
-          </a:fillRef>
-          <a:effectRef idx="2">
-            <a:schemeClr val="accent1"/>
-          </a:effectRef>
-          <a:fontRef idx="minor">
-            <a:schemeClr val="lt1"/>
-          </a:fontRef>
-        </p:style>
-        <p:txBody>
-          <a:bodyPr rtlCol="0" anchor="ctr"/>
-          <a:lstStyle/>
-          <a:p>
-            <a:pPr algn="ctr"/>
-          </a:p>
-        </p:txBody>
-      </p:sp>
-      <p:sp>
-        <p:nvSpPr>
-          <p:cNvPr id="5" name="TextBox 4"/>
-          <p:cNvSpPr txBox="1"/>
-          <p:nvPr/>
-        </p:nvSpPr>
-        <p:spPr>
-          <a:xfrm>
-            <a:off x="9601200" y="2377440"/>
-            <a:ext cx="7772400" cy="5943600"/>
-          </a:xfrm>
-          <a:prstGeom prst="rect">
-            <a:avLst/>
-          </a:prstGeom>
-          <a:noFill/>
-        </p:spPr>
-        <p:txBody>
-          <a:bodyPr wrap="square">
-            <a:spAutoFit/>
-          </a:bodyPr>
-          <a:lstStyle/>
-          <a:p>
-            <a:pPr algn="r" rtl="1"/>
+          <a:p>
+            <a:pPr algn="ctr" rtl="true" marL="0" indent="0" lvl="0">
+              <a:lnSpc>
+                <a:spcPts val="6861"/>
+              </a:lnSpc>
+              <a:spcBef>
+                <a:spcPct val="0"/>
+              </a:spcBef>
+            </a:pPr>
             <a:r>
-              <a:rPr sz="2200" b="0">
+              <a:rPr lang="en-US" dirty="0" sz="1800">
                 <a:solidFill>
-                  <a:srgbClr val="F3E5B8"/>
+                  <a:srgbClr val="BBBBBB"/>
                 </a:solidFill>
+                <a:latin typeface="Calibri"/>
               </a:rPr>
-              <a:t>متطلبات القانون
-حماية بيانات الطلاب
-شفافية الأداء الأكاديمي
-إدارة صلاحيات آمنة
-إشراك ولي الأمر رقمياً
-توثيق نتائج الطلاب</a:t>
-            </a:r>
-          </a:p>
-        </p:txBody>
-      </p:sp>
-      <p:sp>
-        <p:nvSpPr>
-          <p:cNvPr id="6" name="TextBox 5"/>
-          <p:cNvSpPr txBox="1"/>
-          <p:nvPr/>
-        </p:nvSpPr>
-        <p:spPr>
-          <a:xfrm>
-            <a:off x="914400" y="2377440"/>
-            <a:ext cx="8686800" cy="5943600"/>
-          </a:xfrm>
-          <a:prstGeom prst="rect">
-            <a:avLst/>
-          </a:prstGeom>
-          <a:noFill/>
-        </p:spPr>
-        <p:txBody>
-          <a:bodyPr wrap="square">
-            <a:spAutoFit/>
-          </a:bodyPr>
-          <a:lstStyle/>
-          <a:p>
-            <a:pPr algn="l"/>
-            <a:r>
-              <a:rPr sz="1800" b="0">
-                <a:solidFill>
-                  <a:srgbClr val="FFFFFF"/>
-                </a:solidFill>
-              </a:rPr>
-              <a:t>Al Jood Portal Solution
-Role-based access control (Admin/Teacher/Parent)
-Live grade analysis dashboard
-Admin, Principal &amp; Teacher login tiers
-Parent portal (Coming Soon — law-compliant)
-Term 2 marks fully documented &amp; visualized</a:t>
-            </a:r>
-          </a:p>
-        </p:txBody>
-      </p:sp>
-      <p:sp>
-        <p:nvSpPr>
-          <p:cNvPr id="7" name="TextBox 6"/>
-          <p:cNvSpPr txBox="1"/>
-          <p:nvPr/>
-        </p:nvSpPr>
-        <p:spPr>
-          <a:xfrm>
-            <a:off x="914400" y="8961120"/>
-            <a:ext cx="16459200" cy="731520"/>
-          </a:xfrm>
-          <a:prstGeom prst="rect">
-            <a:avLst/>
-          </a:prstGeom>
-          <a:solidFill>
-            <a:srgbClr val="C9A84C"/>
-          </a:solidFill>
-        </p:spPr>
-        <p:txBody>
-          <a:bodyPr wrap="square">
-            <a:spAutoFit/>
-          </a:bodyPr>
-          <a:lstStyle/>
-          <a:p>
-            <a:pPr algn="ctr" rtl="1"/>
-            <a:r>
-              <a:rPr sz="2000" b="1">
-                <a:solidFill>
-                  <a:srgbClr val="1A2A4A"/>
-                </a:solidFill>
-              </a:rPr>
-              <a:t>بوابة مدرسة الجود: الامتثال الكامل لقانون سلامة الطفل الرقمي ٢٠٢٦</a:t>
+              <a:t>Al Jood Portal Alignment with Child Digital Safety Law 2026</a:t>
             </a:r>
           </a:p>
         </p:txBody>

</xml_diff>

<commit_message>
update: law slides with content boxes replacing cyan placeholders
</commit_message>
<xml_diff>
--- a/assets/aljood_pitch_with_law.pptx
+++ b/assets/aljood_pitch_with_law.pptx
@@ -3738,6 +3738,885 @@
       </p:grpSp>
       <p:sp>
         <p:nvSpPr>
+          <p:cNvPr name="TextBox 5" id="5"/>
+          <p:cNvSpPr txBox="true"/>
+          <p:nvPr/>
+        </p:nvSpPr>
+        <p:spPr>
+          <a:xfrm rot="0">
+            <a:off x="2105025" y="4743450"/>
+            <a:ext cx="6886575" cy="1207770"/>
+          </a:xfrm>
+          <a:prstGeom prst="rect">
+            <a:avLst/>
+          </a:prstGeom>
+        </p:spPr>
+        <p:txBody>
+          <a:bodyPr anchor="t" rtlCol="false" tIns="0" lIns="0" bIns="0" rIns="0">
+            <a:spAutoFit/>
+          </a:bodyPr>
+          <a:lstStyle/>
+          <a:p>
+            <a:pPr algn="ctr" rtl="true" marL="0" indent="0" lvl="0">
+              <a:lnSpc>
+                <a:spcPts val="3120"/>
+              </a:lnSpc>
+            </a:pPr>
+            <a:r>
+              <a:rPr lang="ar-EG" sz="2400">
+                <a:solidFill>
+                  <a:srgbClr val="F3E5B8"/>
+                </a:solidFill>
+                <a:latin typeface="Codec Pro"/>
+                <a:ea typeface="Codec Pro"/>
+                <a:cs typeface="Codec Pro"/>
+                <a:sym typeface="Codec Pro"/>
+                <a:rtl val="true"/>
+              </a:rPr>
+              <a:t>ستتوسع بوابة الجود الرقمية على ثلاث مراحل، لتشمل ميزات جديدة لإشراك ولي الأمر وتعزيز تجربة التعليم.</a:t>
+            </a:r>
+          </a:p>
+        </p:txBody>
+      </p:sp>
+      <p:sp>
+        <p:nvSpPr>
+          <p:cNvPr name="Freeform 6" id="6"/>
+          <p:cNvSpPr/>
+          <p:nvPr/>
+        </p:nvSpPr>
+        <p:spPr>
+          <a:xfrm flipH="true" flipV="false" rot="0">
+            <a:off x="10486143" y="2216792"/>
+            <a:ext cx="5696832" cy="5911807"/>
+          </a:xfrm>
+          <a:custGeom>
+            <a:avLst/>
+            <a:gdLst/>
+            <a:ahLst/>
+            <a:cxnLst/>
+            <a:rect r="r" b="b" t="t" l="l"/>
+            <a:pathLst>
+              <a:path h="5911807" w="5696832">
+                <a:moveTo>
+                  <a:pt x="5696832" y="0"/>
+                </a:moveTo>
+                <a:lnTo>
+                  <a:pt x="0" y="0"/>
+                </a:lnTo>
+                <a:lnTo>
+                  <a:pt x="0" y="5911807"/>
+                </a:lnTo>
+                <a:lnTo>
+                  <a:pt x="5696832" y="5911807"/>
+                </a:lnTo>
+                <a:lnTo>
+                  <a:pt x="5696832" y="0"/>
+                </a:lnTo>
+                <a:close/>
+              </a:path>
+            </a:pathLst>
+          </a:custGeom>
+          <a:blipFill>
+            <a:blip r:embed="rId2">
+              <a:extLst>
+                <a:ext uri="{96DAC541-7B7A-43D3-8B79-37D633B846F1}">
+                  <asvg:svgBlip xmlns:asvg="http://schemas.microsoft.com/office/drawing/2016/SVG/main" r:embed="rId3"/>
+                </a:ext>
+              </a:extLst>
+            </a:blip>
+            <a:stretch>
+              <a:fillRect l="0" t="0" r="0" b="0"/>
+            </a:stretch>
+          </a:blipFill>
+          <a:ln cap="sq">
+            <a:noFill/>
+            <a:prstDash val="solid"/>
+            <a:miter/>
+          </a:ln>
+        </p:spPr>
+      </p:sp>
+      <p:sp>
+        <p:nvSpPr>
+          <p:cNvPr name="Freeform 7" id="7"/>
+          <p:cNvSpPr/>
+          <p:nvPr/>
+        </p:nvSpPr>
+        <p:spPr>
+          <a:xfrm flipH="false" flipV="false" rot="0">
+            <a:off x="10546645" y="2306609"/>
+            <a:ext cx="4485772" cy="4485772"/>
+          </a:xfrm>
+          <a:custGeom>
+            <a:avLst/>
+            <a:gdLst/>
+            <a:ahLst/>
+            <a:cxnLst/>
+            <a:rect r="r" b="b" t="t" l="l"/>
+            <a:pathLst>
+              <a:path h="4485772" w="4485772">
+                <a:moveTo>
+                  <a:pt x="0" y="0"/>
+                </a:moveTo>
+                <a:lnTo>
+                  <a:pt x="4485772" y="0"/>
+                </a:lnTo>
+                <a:lnTo>
+                  <a:pt x="4485772" y="4485772"/>
+                </a:lnTo>
+                <a:lnTo>
+                  <a:pt x="0" y="4485772"/>
+                </a:lnTo>
+                <a:lnTo>
+                  <a:pt x="0" y="0"/>
+                </a:lnTo>
+                <a:close/>
+              </a:path>
+            </a:pathLst>
+          </a:custGeom>
+          <a:blipFill>
+            <a:blip r:embed="rId4"/>
+            <a:stretch>
+              <a:fillRect l="0" t="0" r="0" b="0"/>
+            </a:stretch>
+          </a:blipFill>
+        </p:spPr>
+      </p:sp>
+      <p:sp>
+        <p:nvSpPr>
+          <p:cNvPr name="TextBox 8" id="8"/>
+          <p:cNvSpPr txBox="true"/>
+          <p:nvPr/>
+        </p:nvSpPr>
+        <p:spPr>
+          <a:xfrm rot="0">
+            <a:off x="1740532" y="2713074"/>
+            <a:ext cx="7615560" cy="1836421"/>
+          </a:xfrm>
+          <a:prstGeom prst="rect">
+            <a:avLst/>
+          </a:prstGeom>
+        </p:spPr>
+        <p:txBody>
+          <a:bodyPr anchor="t" rtlCol="false" tIns="0" lIns="0" bIns="0" rIns="0">
+            <a:spAutoFit/>
+          </a:bodyPr>
+          <a:lstStyle/>
+          <a:p>
+            <a:pPr algn="ctr" rtl="true" marL="0" indent="0" lvl="0">
+              <a:lnSpc>
+                <a:spcPts val="7019"/>
+              </a:lnSpc>
+            </a:pPr>
+            <a:r>
+              <a:rPr lang="ar-EG" b="true" sz="5399">
+                <a:solidFill>
+                  <a:srgbClr val="F3E5B8"/>
+                </a:solidFill>
+                <a:latin typeface="Codec Pro Bold"/>
+                <a:ea typeface="Codec Pro Bold"/>
+                <a:cs typeface="Codec Pro Bold"/>
+                <a:sym typeface="Codec Pro Bold"/>
+                <a:rtl val="true"/>
+              </a:rPr>
+              <a:t>خارطة الطريق لتوسيع بوابة الجود الرقمية</a:t>
+            </a:r>
+          </a:p>
+        </p:txBody>
+      </p:sp>
+    </p:spTree>
+  </p:cSld>
+  <p:clrMapOvr>
+    <a:masterClrMapping/>
+  </p:clrMapOvr>
+</p:sld>
+</file>
+
+<file path=ppt/slides/slide11.xml><?xml version="1.0" encoding="utf-8"?>
+<p:sld xmlns:p="http://schemas.openxmlformats.org/presentationml/2006/main" xmlns:a="http://schemas.openxmlformats.org/drawingml/2006/main" xmlns:r="http://schemas.openxmlformats.org/officeDocument/2006/relationships">
+  <p:cSld>
+    <p:bg>
+      <p:bgPr>
+        <a:solidFill>
+          <a:srgbClr val="1A2A4A"/>
+        </a:solidFill>
+      </p:bgPr>
+    </p:bg>
+    <p:spTree>
+      <p:nvGrpSpPr>
+        <p:cNvPr id="1" name=""/>
+        <p:cNvGrpSpPr/>
+        <p:nvPr/>
+      </p:nvGrpSpPr>
+      <p:grpSpPr>
+        <a:xfrm>
+          <a:off x="0" y="0"/>
+          <a:ext cx="0" cy="0"/>
+          <a:chOff x="0" y="0"/>
+          <a:chExt cx="0" cy="0"/>
+        </a:xfrm>
+      </p:grpSpPr>
+      <p:grpSp>
+        <p:nvGrpSpPr>
+          <p:cNvPr name="Group 2" id="2"/>
+          <p:cNvGrpSpPr/>
+          <p:nvPr/>
+        </p:nvGrpSpPr>
+        <p:grpSpPr>
+          <a:xfrm rot="0">
+            <a:off x="666750" y="666750"/>
+            <a:ext cx="16954500" cy="8953500"/>
+            <a:chOff x="0" y="0"/>
+            <a:chExt cx="5734099" cy="3028120"/>
+          </a:xfrm>
+        </p:grpSpPr>
+        <p:sp>
+          <p:nvSpPr>
+            <p:cNvPr name="Freeform 3" id="3"/>
+            <p:cNvSpPr/>
+            <p:nvPr/>
+          </p:nvSpPr>
+          <p:spPr>
+            <a:xfrm flipH="false" flipV="false" rot="0">
+              <a:off x="52070" y="12700"/>
+              <a:ext cx="5669329" cy="2959540"/>
+            </a:xfrm>
+            <a:custGeom>
+              <a:avLst/>
+              <a:gdLst/>
+              <a:ahLst/>
+              <a:cxnLst/>
+              <a:rect r="r" b="b" t="t" l="l"/>
+              <a:pathLst>
+                <a:path h="2959540" w="5669329">
+                  <a:moveTo>
+                    <a:pt x="5523279" y="2959540"/>
+                  </a:moveTo>
+                  <a:lnTo>
+                    <a:pt x="164850" y="2959540"/>
+                  </a:lnTo>
+                  <a:cubicBezTo>
+                    <a:pt x="66040" y="2959540"/>
+                    <a:pt x="0" y="2893500"/>
+                    <a:pt x="0" y="2813490"/>
+                  </a:cubicBezTo>
+                  <a:lnTo>
+                    <a:pt x="0" y="146050"/>
+                  </a:lnTo>
+                  <a:cubicBezTo>
+                    <a:pt x="0" y="66040"/>
+                    <a:pt x="66040" y="0"/>
+                    <a:pt x="164850" y="0"/>
+                  </a:cubicBezTo>
+                  <a:lnTo>
+                    <a:pt x="5523279" y="0"/>
+                  </a:lnTo>
+                  <a:cubicBezTo>
+                    <a:pt x="5603289" y="0"/>
+                    <a:pt x="5669329" y="66040"/>
+                    <a:pt x="5669329" y="146050"/>
+                  </a:cubicBezTo>
+                  <a:lnTo>
+                    <a:pt x="5669329" y="2813490"/>
+                  </a:lnTo>
+                  <a:cubicBezTo>
+                    <a:pt x="5669329" y="2894770"/>
+                    <a:pt x="5603289" y="2959540"/>
+                    <a:pt x="5523279" y="2959540"/>
+                  </a:cubicBezTo>
+                  <a:close/>
+                </a:path>
+              </a:pathLst>
+            </a:custGeom>
+            <a:solidFill>
+              <a:srgbClr val="021633"/>
+            </a:solidFill>
+          </p:spPr>
+        </p:sp>
+        <p:sp>
+          <p:nvSpPr>
+            <p:cNvPr name="Freeform 4" id="4"/>
+            <p:cNvSpPr/>
+            <p:nvPr/>
+          </p:nvSpPr>
+          <p:spPr>
+            <a:xfrm flipH="false" flipV="false" rot="0">
+              <a:off x="0" y="0"/>
+              <a:ext cx="5734099" cy="3028120"/>
+            </a:xfrm>
+            <a:custGeom>
+              <a:avLst/>
+              <a:gdLst/>
+              <a:ahLst/>
+              <a:cxnLst/>
+              <a:rect r="r" b="b" t="t" l="l"/>
+              <a:pathLst>
+                <a:path h="3028120" w="5734099">
+                  <a:moveTo>
+                    <a:pt x="63500" y="74930"/>
+                  </a:moveTo>
+                  <a:cubicBezTo>
+                    <a:pt x="91440" y="30480"/>
+                    <a:pt x="140970" y="0"/>
+                    <a:pt x="216920" y="0"/>
+                  </a:cubicBezTo>
+                  <a:lnTo>
+                    <a:pt x="5575349" y="0"/>
+                  </a:lnTo>
+                  <a:cubicBezTo>
+                    <a:pt x="5662979" y="0"/>
+                    <a:pt x="5734099" y="71120"/>
+                    <a:pt x="5734099" y="158750"/>
+                  </a:cubicBezTo>
+                  <a:lnTo>
+                    <a:pt x="5734099" y="2826190"/>
+                  </a:lnTo>
+                  <a:cubicBezTo>
+                    <a:pt x="5734099" y="2878260"/>
+                    <a:pt x="5708699" y="2923980"/>
+                    <a:pt x="5670599" y="2953190"/>
+                  </a:cubicBezTo>
+                  <a:cubicBezTo>
+                    <a:pt x="5642659" y="2997640"/>
+                    <a:pt x="5593129" y="3028120"/>
+                    <a:pt x="5535979" y="3028120"/>
+                  </a:cubicBezTo>
+                  <a:lnTo>
+                    <a:pt x="158750" y="3028120"/>
+                  </a:lnTo>
+                  <a:cubicBezTo>
+                    <a:pt x="71120" y="3028120"/>
+                    <a:pt x="0" y="2957000"/>
+                    <a:pt x="0" y="2869370"/>
+                  </a:cubicBezTo>
+                  <a:lnTo>
+                    <a:pt x="0" y="208926"/>
+                  </a:lnTo>
+                  <a:cubicBezTo>
+                    <a:pt x="0" y="149860"/>
+                    <a:pt x="25400" y="104140"/>
+                    <a:pt x="63500" y="74930"/>
+                  </a:cubicBezTo>
+                  <a:close/>
+                  <a:moveTo>
+                    <a:pt x="5721399" y="2826190"/>
+                  </a:moveTo>
+                  <a:lnTo>
+                    <a:pt x="5721399" y="158750"/>
+                  </a:lnTo>
+                  <a:cubicBezTo>
+                    <a:pt x="5721399" y="78740"/>
+                    <a:pt x="5655359" y="12700"/>
+                    <a:pt x="5575349" y="12700"/>
+                  </a:cubicBezTo>
+                  <a:lnTo>
+                    <a:pt x="216920" y="12700"/>
+                  </a:lnTo>
+                  <a:cubicBezTo>
+                    <a:pt x="118110" y="12700"/>
+                    <a:pt x="52070" y="78740"/>
+                    <a:pt x="52070" y="158750"/>
+                  </a:cubicBezTo>
+                  <a:lnTo>
+                    <a:pt x="52070" y="2826190"/>
+                  </a:lnTo>
+                  <a:cubicBezTo>
+                    <a:pt x="52070" y="2906200"/>
+                    <a:pt x="118110" y="2972240"/>
+                    <a:pt x="216920" y="2972240"/>
+                  </a:cubicBezTo>
+                  <a:lnTo>
+                    <a:pt x="5575349" y="2972240"/>
+                  </a:lnTo>
+                  <a:cubicBezTo>
+                    <a:pt x="5655359" y="2972240"/>
+                    <a:pt x="5721399" y="2907470"/>
+                    <a:pt x="5721399" y="2826190"/>
+                  </a:cubicBezTo>
+                  <a:close/>
+                </a:path>
+              </a:pathLst>
+            </a:custGeom>
+            <a:solidFill>
+              <a:srgbClr val="C9A84C"/>
+            </a:solidFill>
+          </p:spPr>
+        </p:sp>
+      </p:grpSp>
+      <p:sp>
+        <p:nvSpPr>
+          <p:cNvPr name="TextBox 5" id="5"/>
+          <p:cNvSpPr txBox="true"/>
+          <p:nvPr/>
+        </p:nvSpPr>
+        <p:spPr>
+          <a:xfrm rot="0">
+            <a:off x="2105025" y="3629025"/>
+            <a:ext cx="6886575" cy="876300"/>
+          </a:xfrm>
+          <a:prstGeom prst="rect">
+            <a:avLst/>
+          </a:prstGeom>
+        </p:spPr>
+        <p:txBody>
+          <a:bodyPr anchor="t" rtlCol="false" tIns="0" lIns="0" bIns="0" rIns="0">
+            <a:spAutoFit/>
+          </a:bodyPr>
+          <a:lstStyle/>
+          <a:p>
+            <a:pPr algn="ctr" rtl="true" marL="0" indent="0" lvl="0">
+              <a:lnSpc>
+                <a:spcPts val="6480"/>
+              </a:lnSpc>
+            </a:pPr>
+          </a:p>
+        </p:txBody>
+      </p:sp>
+      <p:sp>
+        <p:nvSpPr>
+          <p:cNvPr name="TextBox 6" id="6"/>
+          <p:cNvSpPr txBox="true"/>
+          <p:nvPr/>
+        </p:nvSpPr>
+        <p:spPr>
+          <a:xfrm rot="0">
+            <a:off x="2105025" y="4743450"/>
+            <a:ext cx="6886575" cy="1207770"/>
+          </a:xfrm>
+          <a:prstGeom prst="rect">
+            <a:avLst/>
+          </a:prstGeom>
+        </p:spPr>
+        <p:txBody>
+          <a:bodyPr anchor="t" rtlCol="false" tIns="0" lIns="0" bIns="0" rIns="0">
+            <a:spAutoFit/>
+          </a:bodyPr>
+          <a:lstStyle/>
+          <a:p>
+            <a:pPr algn="ctr" rtl="true" marL="0" indent="0" lvl="0">
+              <a:lnSpc>
+                <a:spcPts val="3120"/>
+              </a:lnSpc>
+            </a:pPr>
+            <a:r>
+              <a:rPr lang="ar-EG" sz="2400">
+                <a:solidFill>
+                  <a:srgbClr val="F3E5B8"/>
+                </a:solidFill>
+                <a:latin typeface="Codec Pro"/>
+                <a:ea typeface="Codec Pro"/>
+                <a:cs typeface="Codec Pro"/>
+                <a:sym typeface="Codec Pro"/>
+                <a:rtl val="true"/>
+              </a:rPr>
+              <a:t>نقدم نموذجاً مبتكراً يسهم في </a:t>
+            </a:r>
+            <a:r>
+              <a:rPr lang="ar-EG" b="true" sz="2400">
+                <a:solidFill>
+                  <a:srgbClr val="F3E5B8"/>
+                </a:solidFill>
+                <a:latin typeface="Codec Pro Bold"/>
+                <a:ea typeface="Codec Pro Bold"/>
+                <a:cs typeface="Codec Pro Bold"/>
+                <a:sym typeface="Codec Pro Bold"/>
+                <a:rtl val="true"/>
+              </a:rPr>
+              <a:t>تحقيق رؤية الإمارات </a:t>
+            </a:r>
+            <a:r>
+              <a:rPr lang="en-US" b="true" sz="2400">
+                <a:solidFill>
+                  <a:srgbClr val="F3E5B8"/>
+                </a:solidFill>
+                <a:latin typeface="Codec Pro Bold"/>
+                <a:ea typeface="Codec Pro Bold"/>
+                <a:cs typeface="Codec Pro Bold"/>
+                <a:sym typeface="Codec Pro Bold"/>
+              </a:rPr>
+              <a:t>2071</a:t>
+            </a:r>
+            <a:r>
+              <a:rPr lang="ar-EG" sz="2400">
+                <a:solidFill>
+                  <a:srgbClr val="F3E5B8"/>
+                </a:solidFill>
+                <a:latin typeface="Codec Pro"/>
+                <a:ea typeface="Codec Pro"/>
+                <a:cs typeface="Codec Pro"/>
+                <a:sym typeface="Codec Pro"/>
+                <a:rtl val="true"/>
+              </a:rPr>
+              <a:t>، ويعزز التعليم الذكي والمستدام لكافة المدارس.</a:t>
+            </a:r>
+          </a:p>
+        </p:txBody>
+      </p:sp>
+      <p:sp>
+        <p:nvSpPr>
+          <p:cNvPr name="Freeform 7" id="7"/>
+          <p:cNvSpPr/>
+          <p:nvPr/>
+        </p:nvSpPr>
+        <p:spPr>
+          <a:xfrm flipH="true" flipV="false" rot="0">
+            <a:off x="10486143" y="2216792"/>
+            <a:ext cx="5696832" cy="5911807"/>
+          </a:xfrm>
+          <a:custGeom>
+            <a:avLst/>
+            <a:gdLst/>
+            <a:ahLst/>
+            <a:cxnLst/>
+            <a:rect r="r" b="b" t="t" l="l"/>
+            <a:pathLst>
+              <a:path h="5911807" w="5696832">
+                <a:moveTo>
+                  <a:pt x="5696832" y="0"/>
+                </a:moveTo>
+                <a:lnTo>
+                  <a:pt x="0" y="0"/>
+                </a:lnTo>
+                <a:lnTo>
+                  <a:pt x="0" y="5911807"/>
+                </a:lnTo>
+                <a:lnTo>
+                  <a:pt x="5696832" y="5911807"/>
+                </a:lnTo>
+                <a:lnTo>
+                  <a:pt x="5696832" y="0"/>
+                </a:lnTo>
+                <a:close/>
+              </a:path>
+            </a:pathLst>
+          </a:custGeom>
+          <a:blipFill>
+            <a:blip r:embed="rId2">
+              <a:extLst>
+                <a:ext uri="{96DAC541-7B7A-43D3-8B79-37D633B846F1}">
+                  <asvg:svgBlip xmlns:asvg="http://schemas.microsoft.com/office/drawing/2016/SVG/main" r:embed="rId3"/>
+                </a:ext>
+              </a:extLst>
+            </a:blip>
+            <a:stretch>
+              <a:fillRect l="0" t="0" r="0" b="0"/>
+            </a:stretch>
+          </a:blipFill>
+          <a:ln cap="sq">
+            <a:noFill/>
+            <a:prstDash val="solid"/>
+            <a:miter/>
+          </a:ln>
+        </p:spPr>
+      </p:sp>
+      <p:sp>
+        <p:nvSpPr>
+          <p:cNvPr name="Freeform 8" id="8"/>
+          <p:cNvSpPr/>
+          <p:nvPr/>
+        </p:nvSpPr>
+        <p:spPr>
+          <a:xfrm flipH="false" flipV="false" rot="0">
+            <a:off x="10546645" y="2306609"/>
+            <a:ext cx="4485772" cy="4485772"/>
+          </a:xfrm>
+          <a:custGeom>
+            <a:avLst/>
+            <a:gdLst/>
+            <a:ahLst/>
+            <a:cxnLst/>
+            <a:rect r="r" b="b" t="t" l="l"/>
+            <a:pathLst>
+              <a:path h="4485772" w="4485772">
+                <a:moveTo>
+                  <a:pt x="0" y="0"/>
+                </a:moveTo>
+                <a:lnTo>
+                  <a:pt x="4485772" y="0"/>
+                </a:lnTo>
+                <a:lnTo>
+                  <a:pt x="4485772" y="4485772"/>
+                </a:lnTo>
+                <a:lnTo>
+                  <a:pt x="0" y="4485772"/>
+                </a:lnTo>
+                <a:lnTo>
+                  <a:pt x="0" y="0"/>
+                </a:lnTo>
+                <a:close/>
+              </a:path>
+            </a:pathLst>
+          </a:custGeom>
+          <a:blipFill>
+            <a:blip r:embed="rId4"/>
+            <a:stretch>
+              <a:fillRect l="0" t="0" r="0" b="0"/>
+            </a:stretch>
+          </a:blipFill>
+        </p:spPr>
+      </p:sp>
+      <p:sp>
+        <p:nvSpPr>
+          <p:cNvPr name="TextBox 9" id="9"/>
+          <p:cNvSpPr txBox="true"/>
+          <p:nvPr/>
+        </p:nvSpPr>
+        <p:spPr>
+          <a:xfrm rot="0">
+            <a:off x="1740532" y="2713074"/>
+            <a:ext cx="7615560" cy="1836421"/>
+          </a:xfrm>
+          <a:prstGeom prst="rect">
+            <a:avLst/>
+          </a:prstGeom>
+        </p:spPr>
+        <p:txBody>
+          <a:bodyPr anchor="t" rtlCol="false" tIns="0" lIns="0" bIns="0" rIns="0">
+            <a:spAutoFit/>
+          </a:bodyPr>
+          <a:lstStyle/>
+          <a:p>
+            <a:pPr algn="ctr" rtl="true" marL="0" indent="0" lvl="0">
+              <a:lnSpc>
+                <a:spcPts val="7019"/>
+              </a:lnSpc>
+            </a:pPr>
+            <a:r>
+              <a:rPr lang="ar-EG" b="true" sz="5399">
+                <a:solidFill>
+                  <a:srgbClr val="F3E5B8"/>
+                </a:solidFill>
+                <a:latin typeface="Codec Pro Bold"/>
+                <a:ea typeface="Codec Pro Bold"/>
+                <a:cs typeface="Codec Pro Bold"/>
+                <a:sym typeface="Codec Pro Bold"/>
+                <a:rtl val="true"/>
+              </a:rPr>
+              <a:t>رؤية مستقبلية للتعليم في الإمارات</a:t>
+            </a:r>
+          </a:p>
+        </p:txBody>
+      </p:sp>
+    </p:spTree>
+  </p:cSld>
+  <p:clrMapOvr>
+    <a:masterClrMapping/>
+  </p:clrMapOvr>
+</p:sld>
+</file>
+
+<file path=ppt/slides/slide12.xml><?xml version="1.0" encoding="utf-8"?>
+<p:sld xmlns:p="http://schemas.openxmlformats.org/presentationml/2006/main" xmlns:a="http://schemas.openxmlformats.org/drawingml/2006/main" xmlns:r="http://schemas.openxmlformats.org/officeDocument/2006/relationships">
+  <p:cSld>
+    <p:bg>
+      <p:bgPr>
+        <a:solidFill>
+          <a:srgbClr val="1A2A4A"/>
+        </a:solidFill>
+      </p:bgPr>
+    </p:bg>
+    <p:spTree>
+      <p:nvGrpSpPr>
+        <p:cNvPr id="1" name=""/>
+        <p:cNvGrpSpPr/>
+        <p:nvPr/>
+      </p:nvGrpSpPr>
+      <p:grpSpPr>
+        <a:xfrm>
+          <a:off x="0" y="0"/>
+          <a:ext cx="0" cy="0"/>
+          <a:chOff x="0" y="0"/>
+          <a:chExt cx="0" cy="0"/>
+        </a:xfrm>
+      </p:grpSpPr>
+      <p:grpSp>
+        <p:nvGrpSpPr>
+          <p:cNvPr name="Group 2" id="2"/>
+          <p:cNvGrpSpPr/>
+          <p:nvPr/>
+        </p:nvGrpSpPr>
+        <p:grpSpPr>
+          <a:xfrm rot="0">
+            <a:off x="666750" y="666750"/>
+            <a:ext cx="16954500" cy="8953500"/>
+            <a:chOff x="0" y="0"/>
+            <a:chExt cx="5734099" cy="3028120"/>
+          </a:xfrm>
+        </p:grpSpPr>
+        <p:sp>
+          <p:nvSpPr>
+            <p:cNvPr name="Freeform 3" id="3"/>
+            <p:cNvSpPr/>
+            <p:nvPr/>
+          </p:nvSpPr>
+          <p:spPr>
+            <a:xfrm flipH="false" flipV="false" rot="0">
+              <a:off x="52070" y="12700"/>
+              <a:ext cx="5669329" cy="2959540"/>
+            </a:xfrm>
+            <a:custGeom>
+              <a:avLst/>
+              <a:gdLst/>
+              <a:ahLst/>
+              <a:cxnLst/>
+              <a:rect r="r" b="b" t="t" l="l"/>
+              <a:pathLst>
+                <a:path h="2959540" w="5669329">
+                  <a:moveTo>
+                    <a:pt x="5523279" y="2959540"/>
+                  </a:moveTo>
+                  <a:lnTo>
+                    <a:pt x="164850" y="2959540"/>
+                  </a:lnTo>
+                  <a:cubicBezTo>
+                    <a:pt x="66040" y="2959540"/>
+                    <a:pt x="0" y="2893500"/>
+                    <a:pt x="0" y="2813490"/>
+                  </a:cubicBezTo>
+                  <a:lnTo>
+                    <a:pt x="0" y="146050"/>
+                  </a:lnTo>
+                  <a:cubicBezTo>
+                    <a:pt x="0" y="66040"/>
+                    <a:pt x="66040" y="0"/>
+                    <a:pt x="164850" y="0"/>
+                  </a:cubicBezTo>
+                  <a:lnTo>
+                    <a:pt x="5523279" y="0"/>
+                  </a:lnTo>
+                  <a:cubicBezTo>
+                    <a:pt x="5603289" y="0"/>
+                    <a:pt x="5669329" y="66040"/>
+                    <a:pt x="5669329" y="146050"/>
+                  </a:cubicBezTo>
+                  <a:lnTo>
+                    <a:pt x="5669329" y="2813490"/>
+                  </a:lnTo>
+                  <a:cubicBezTo>
+                    <a:pt x="5669329" y="2894770"/>
+                    <a:pt x="5603289" y="2959540"/>
+                    <a:pt x="5523279" y="2959540"/>
+                  </a:cubicBezTo>
+                  <a:close/>
+                </a:path>
+              </a:pathLst>
+            </a:custGeom>
+            <a:solidFill>
+              <a:srgbClr val="021633"/>
+            </a:solidFill>
+          </p:spPr>
+        </p:sp>
+        <p:sp>
+          <p:nvSpPr>
+            <p:cNvPr name="Freeform 4" id="4"/>
+            <p:cNvSpPr/>
+            <p:nvPr/>
+          </p:nvSpPr>
+          <p:spPr>
+            <a:xfrm flipH="false" flipV="false" rot="0">
+              <a:off x="0" y="0"/>
+              <a:ext cx="5734099" cy="3028120"/>
+            </a:xfrm>
+            <a:custGeom>
+              <a:avLst/>
+              <a:gdLst/>
+              <a:ahLst/>
+              <a:cxnLst/>
+              <a:rect r="r" b="b" t="t" l="l"/>
+              <a:pathLst>
+                <a:path h="3028120" w="5734099">
+                  <a:moveTo>
+                    <a:pt x="63500" y="74930"/>
+                  </a:moveTo>
+                  <a:cubicBezTo>
+                    <a:pt x="91440" y="30480"/>
+                    <a:pt x="140970" y="0"/>
+                    <a:pt x="216920" y="0"/>
+                  </a:cubicBezTo>
+                  <a:lnTo>
+                    <a:pt x="5575349" y="0"/>
+                  </a:lnTo>
+                  <a:cubicBezTo>
+                    <a:pt x="5662979" y="0"/>
+                    <a:pt x="5734099" y="71120"/>
+                    <a:pt x="5734099" y="158750"/>
+                  </a:cubicBezTo>
+                  <a:lnTo>
+                    <a:pt x="5734099" y="2826190"/>
+                  </a:lnTo>
+                  <a:cubicBezTo>
+                    <a:pt x="5734099" y="2878260"/>
+                    <a:pt x="5708699" y="2923980"/>
+                    <a:pt x="5670599" y="2953190"/>
+                  </a:cubicBezTo>
+                  <a:cubicBezTo>
+                    <a:pt x="5642659" y="2997640"/>
+                    <a:pt x="5593129" y="3028120"/>
+                    <a:pt x="5535979" y="3028120"/>
+                  </a:cubicBezTo>
+                  <a:lnTo>
+                    <a:pt x="158750" y="3028120"/>
+                  </a:lnTo>
+                  <a:cubicBezTo>
+                    <a:pt x="71120" y="3028120"/>
+                    <a:pt x="0" y="2957000"/>
+                    <a:pt x="0" y="2869370"/>
+                  </a:cubicBezTo>
+                  <a:lnTo>
+                    <a:pt x="0" y="208926"/>
+                  </a:lnTo>
+                  <a:cubicBezTo>
+                    <a:pt x="0" y="149860"/>
+                    <a:pt x="25400" y="104140"/>
+                    <a:pt x="63500" y="74930"/>
+                  </a:cubicBezTo>
+                  <a:close/>
+                  <a:moveTo>
+                    <a:pt x="5721399" y="2826190"/>
+                  </a:moveTo>
+                  <a:lnTo>
+                    <a:pt x="5721399" y="158750"/>
+                  </a:lnTo>
+                  <a:cubicBezTo>
+                    <a:pt x="5721399" y="78740"/>
+                    <a:pt x="5655359" y="12700"/>
+                    <a:pt x="5575349" y="12700"/>
+                  </a:cubicBezTo>
+                  <a:lnTo>
+                    <a:pt x="216920" y="12700"/>
+                  </a:lnTo>
+                  <a:cubicBezTo>
+                    <a:pt x="118110" y="12700"/>
+                    <a:pt x="52070" y="78740"/>
+                    <a:pt x="52070" y="158750"/>
+                  </a:cubicBezTo>
+                  <a:lnTo>
+                    <a:pt x="52070" y="2826190"/>
+                  </a:lnTo>
+                  <a:cubicBezTo>
+                    <a:pt x="52070" y="2906200"/>
+                    <a:pt x="118110" y="2972240"/>
+                    <a:pt x="216920" y="2972240"/>
+                  </a:cubicBezTo>
+                  <a:lnTo>
+                    <a:pt x="5575349" y="2972240"/>
+                  </a:lnTo>
+                  <a:cubicBezTo>
+                    <a:pt x="5655359" y="2972240"/>
+                    <a:pt x="5721399" y="2907470"/>
+                    <a:pt x="5721399" y="2826190"/>
+                  </a:cubicBezTo>
+                  <a:close/>
+                </a:path>
+              </a:pathLst>
+            </a:custGeom>
+            <a:solidFill>
+              <a:srgbClr val="C9A84C"/>
+            </a:solidFill>
+          </p:spPr>
+        </p:sp>
+      </p:grpSp>
+      <p:sp>
+        <p:nvSpPr>
           <p:cNvPr name="Freeform 5" id="5"/>
           <p:cNvSpPr/>
           <p:nvPr/>
@@ -4421,8 +5300,8 @@
 </p:sld>
 </file>
 
-<file path=ppt/slides/slide11.xml><?xml version="1.0" encoding="utf-8"?>
-<p:sld xmlns:a="http://schemas.openxmlformats.org/drawingml/2006/main" xmlns:p="http://schemas.openxmlformats.org/presentationml/2006/main" xmlns:r="http://schemas.openxmlformats.org/officeDocument/2006/relationships">
+<file path=ppt/slides/slide2.xml><?xml version="1.0" encoding="utf-8"?>
+<p:sld xmlns:p="http://schemas.openxmlformats.org/presentationml/2006/main" xmlns:a="http://schemas.openxmlformats.org/drawingml/2006/main" xmlns:r="http://schemas.openxmlformats.org/officeDocument/2006/relationships">
   <p:cSld>
     <p:bg>
       <p:bgPr>
@@ -4762,82 +5641,17 @@
               </a:lnSpc>
             </a:pPr>
             <a:r>
-              <a:rPr lang="ar-SA" dirty="0" sz="1900">
+              <a:rPr lang="ar-EG" sz="2400">
                 <a:solidFill>
-                  <a:srgbClr val="FFFFFF"/>
+                  <a:srgbClr val="F3E5B8"/>
                 </a:solidFill>
-                <a:latin typeface="Noto Sans Arabic"/>
-                <a:ea typeface="Noto Sans Arabic"/>
+                <a:latin typeface="Codec Pro"/>
+                <a:ea typeface="Codec Pro"/>
+                <a:cs typeface="Codec Pro"/>
+                <a:sym typeface="Codec Pro"/>
+                <a:rtl val="true"/>
               </a:rPr>
-              <a:t>صدر المرسوم الاتحادي رقم (2) لسنة 2026 في يناير 2026</a:t>
-            </a:r>
-          </a:p>
-          <a:p>
-            <a:pPr algn="ctr" rtl="true" marL="0" indent="0" lvl="0">
-              <a:lnSpc>
-                <a:spcPts val="3120"/>
-              </a:lnSpc>
-            </a:pPr>
-            <a:r>
-              <a:rPr lang="ar-SA" dirty="0" sz="1900">
-                <a:solidFill>
-                  <a:srgbClr val="FFFFFF"/>
-                </a:solidFill>
-                <a:latin typeface="Noto Sans Arabic"/>
-                <a:ea typeface="Noto Sans Arabic"/>
-              </a:rPr>
-              <a:t>يُلزم المدارس بتنظيم الوصول الرقمي وحماية بيانات الطلاب</a:t>
-            </a:r>
-          </a:p>
-          <a:p>
-            <a:pPr algn="ctr" rtl="true" marL="0" indent="0" lvl="0">
-              <a:lnSpc>
-                <a:spcPts val="3120"/>
-              </a:lnSpc>
-            </a:pPr>
-            <a:r>
-              <a:rPr lang="ar-SA" dirty="0" sz="1900">
-                <a:solidFill>
-                  <a:srgbClr val="FFFFFF"/>
-                </a:solidFill>
-                <a:latin typeface="Noto Sans Arabic"/>
-                <a:ea typeface="Noto Sans Arabic"/>
-              </a:rPr>
-              <a:t>يشترط توثيق هوية المستخدمين وضبط صلاحيات الوصول بدقة</a:t>
-            </a:r>
-          </a:p>
-          <a:p>
-            <a:pPr algn="ctr" rtl="true" marL="0" indent="0" lvl="0">
-              <a:lnSpc>
-                <a:spcPts val="3120"/>
-              </a:lnSpc>
-            </a:pPr>
-            <a:r>
-              <a:rPr lang="ar-SA" dirty="0" sz="1900">
-                <a:solidFill>
-                  <a:srgbClr val="FFFFFF"/>
-                </a:solidFill>
-                <a:latin typeface="Noto Sans Arabic"/>
-                <a:ea typeface="Noto Sans Arabic"/>
-              </a:rPr>
-              <a:t>يُوجب توفير أدوات رقابة لأولياء الأمور على النشاط الرقمي</a:t>
-            </a:r>
-          </a:p>
-          <a:p>
-            <a:pPr algn="ctr" rtl="true" marL="0" indent="0" lvl="0">
-              <a:lnSpc>
-                <a:spcPts val="3120"/>
-              </a:lnSpc>
-            </a:pPr>
-            <a:r>
-              <a:rPr lang="ar-SA" dirty="0" sz="1900">
-                <a:solidFill>
-                  <a:srgbClr val="FFFFFF"/>
-                </a:solidFill>
-                <a:latin typeface="Noto Sans Arabic"/>
-                <a:ea typeface="Noto Sans Arabic"/>
-              </a:rPr>
-              <a:t>يُلزم بالإبلاغ عن أي اختراق لخصوصية البيانات الرقمية للطفل</a:t>
+              <a:t>تواجه المدارس صعوبات في إدارة البيانات والتواصل، مما يؤثر سلباً على تجربة التعليم والتعلم.</a:t>
             </a:r>
           </a:p>
         </p:txBody>
@@ -4872,33 +5686,17 @@
               </a:spcBef>
             </a:pPr>
             <a:r>
-              <a:rPr lang="ar-SA" dirty="0" b="1" sz="3000">
+              <a:rPr lang="ar-EG" b="true" sz="5489">
                 <a:solidFill>
-                  <a:srgbClr val="C9A84C"/>
+                  <a:srgbClr val="F3E5B8"/>
                 </a:solidFill>
-                <a:latin typeface="Noto Sans Arabic"/>
-                <a:ea typeface="Noto Sans Arabic"/>
+                <a:latin typeface="Codec Pro Ultra-Bold"/>
+                <a:ea typeface="Codec Pro Ultra-Bold"/>
+                <a:cs typeface="Codec Pro Ultra-Bold"/>
+                <a:sym typeface="Codec Pro Ultra-Bold"/>
+                <a:rtl val="true"/>
               </a:rPr>
-              <a:t>السياق الوطني: قانون سلامة الطفل الرقمي</a:t>
-            </a:r>
-          </a:p>
-          <a:p>
-            <a:pPr algn="ctr" rtl="true" marL="0" indent="0" lvl="0">
-              <a:lnSpc>
-                <a:spcPts val="6861"/>
-              </a:lnSpc>
-              <a:spcBef>
-                <a:spcPct val="0"/>
-              </a:spcBef>
-            </a:pPr>
-            <a:r>
-              <a:rPr lang="en-US" dirty="0" sz="1800">
-                <a:solidFill>
-                  <a:srgbClr val="BBBBBB"/>
-                </a:solidFill>
-                <a:latin typeface="Calibri"/>
-              </a:rPr>
-              <a:t>National Context: UAE Child Digital Safety Law — Federal Decree No. 2 / 2026</a:t>
+              <a:t>التحديات الحقيقية التي تواجه المدارس اليوم</a:t>
             </a:r>
           </a:p>
         </p:txBody>
@@ -4911,7 +5709,7 @@
 </p:sld>
 </file>
 
-<file path=ppt/slides/slide12.xml><?xml version="1.0" encoding="utf-8"?>
+<file path=ppt/slides/slide3.xml><?xml version="1.0" encoding="utf-8"?>
 <p:sld xmlns:a="http://schemas.openxmlformats.org/drawingml/2006/main" xmlns:p="http://schemas.openxmlformats.org/presentationml/2006/main" xmlns:r="http://schemas.openxmlformats.org/officeDocument/2006/relationships">
   <p:cSld>
     <p:bg>
@@ -5259,7 +6057,7 @@
                 <a:latin typeface="Noto Sans Arabic"/>
                 <a:ea typeface="Noto Sans Arabic"/>
               </a:rPr>
-              <a:t>نظام صلاحيات متعدد المستويات: مدير، معلم، إداري، مديرة، ولي أمر</a:t>
+              <a:t>صدر المرسوم الاتحادي رقم (2) لسنة 2026 في يناير 2026</a:t>
             </a:r>
           </a:p>
           <a:p>
@@ -5276,7 +6074,7 @@
                 <a:latin typeface="Noto Sans Arabic"/>
                 <a:ea typeface="Noto Sans Arabic"/>
               </a:rPr>
-              <a:t>بيانات الطلاب محمية محلياً — لا تُرفع لخوادم خارجية</a:t>
+              <a:t>يُلزم المدارس بتنظيم الوصول الرقمي وحماية بيانات الطلاب</a:t>
             </a:r>
           </a:p>
           <a:p>
@@ -5293,7 +6091,7 @@
                 <a:latin typeface="Noto Sans Arabic"/>
                 <a:ea typeface="Noto Sans Arabic"/>
               </a:rPr>
-              <a:t>لوحة رقابة خاصة بمديرة المدرسة لمتابعة الأنشطة الرقمية</a:t>
+              <a:t>يشترط توثيق هوية المستخدمين وضبط صلاحيات الوصول بدقة</a:t>
             </a:r>
           </a:p>
           <a:p>
@@ -5310,7 +6108,7 @@
                 <a:latin typeface="Noto Sans Arabic"/>
                 <a:ea typeface="Noto Sans Arabic"/>
               </a:rPr>
-              <a:t>بوابة أولياء الأمور (قريباً) — اطلاع على بيانات أبنائهم فقط</a:t>
+              <a:t>يُوجب توفير أدوات رقابة لأولياء الأمور على النشاط الرقمي</a:t>
             </a:r>
           </a:p>
           <a:p>
@@ -5327,7 +6125,7 @@
                 <a:latin typeface="Noto Sans Arabic"/>
                 <a:ea typeface="Noto Sans Arabic"/>
               </a:rPr>
-              <a:t>امتثال تام لاشتراطات المرسوم الاتحادي رقم (2) لسنة 2026</a:t>
+              <a:t>يُلزم بالإبلاغ عن أي اختراق لخصوصية البيانات الرقمية للطفل</a:t>
             </a:r>
           </a:p>
         </p:txBody>
@@ -5369,7 +6167,7 @@
                 <a:latin typeface="Noto Sans Arabic"/>
                 <a:ea typeface="Noto Sans Arabic"/>
               </a:rPr>
-              <a:t>بوابة مدرسة الجود وقانون الطفل الرقمي</a:t>
+              <a:t>السياق الوطني: قانون سلامة الطفل الرقمي</a:t>
             </a:r>
           </a:p>
           <a:p>
@@ -5388,7 +6186,725 @@
                 </a:solidFill>
                 <a:latin typeface="Calibri"/>
               </a:rPr>
-              <a:t>Al Jood Portal Alignment with Child Digital Safety Law 2026</a:t>
+              <a:t>National Context: UAE Child Digital Safety Law — Federal Decree No. 2 / 2026</a:t>
+            </a:r>
+          </a:p>
+        </p:txBody>
+      </p:sp>
+      <p:sp>
+        <p:nvSpPr>
+          <p:cNvPr id="9" name="TextBox 8"/>
+          <p:cNvSpPr txBox="1"/>
+          <p:nvPr/>
+        </p:nvSpPr>
+        <p:spPr>
+          <a:xfrm>
+            <a:off x="10646645" y="2506609"/>
+            <a:ext cx="4285772" cy="500000"/>
+          </a:xfrm>
+          <a:prstGeom prst="rect">
+            <a:avLst/>
+          </a:prstGeom>
+          <a:noFill/>
+        </p:spPr>
+        <p:txBody>
+          <a:bodyPr wrap="square">
+            <a:spAutoFit/>
+          </a:bodyPr>
+          <a:lstStyle/>
+          <a:p>
+            <a:pPr algn="ctr"/>
+            <a:r>
+              <a:rPr sz="1800" b="1">
+                <a:solidFill>
+                  <a:srgbClr val="C9A84C"/>
+                </a:solidFill>
+                <a:latin typeface="Arial"/>
+              </a:rPr>
+              <a:t>أبرز أحكام القانون</a:t>
+            </a:r>
+          </a:p>
+        </p:txBody>
+      </p:sp>
+      <p:sp>
+        <p:nvSpPr>
+          <p:cNvPr id="10" name="TextBox 9"/>
+          <p:cNvSpPr txBox="1"/>
+          <p:nvPr/>
+        </p:nvSpPr>
+        <p:spPr>
+          <a:xfrm>
+            <a:off x="10646645" y="3006609"/>
+            <a:ext cx="4285772" cy="350000"/>
+          </a:xfrm>
+          <a:prstGeom prst="rect">
+            <a:avLst/>
+          </a:prstGeom>
+          <a:noFill/>
+        </p:spPr>
+        <p:txBody>
+          <a:bodyPr wrap="square">
+            <a:spAutoFit/>
+          </a:bodyPr>
+          <a:lstStyle/>
+          <a:p>
+            <a:pPr algn="ctr"/>
+            <a:r>
+              <a:rPr sz="1000" b="0">
+                <a:solidFill>
+                  <a:srgbClr val="BBCCDD"/>
+                </a:solidFill>
+                <a:latin typeface="Arial"/>
+              </a:rPr>
+              <a:t>Key Provisions of Federal Decree No. 2 / 2026</a:t>
+            </a:r>
+          </a:p>
+        </p:txBody>
+      </p:sp>
+      <p:sp>
+        <p:nvSpPr>
+          <p:cNvPr id="11" name="Rectangle 10"/>
+          <p:cNvSpPr/>
+          <p:nvPr/>
+        </p:nvSpPr>
+        <p:spPr>
+          <a:xfrm>
+            <a:off x="10846645" y="3406609"/>
+            <a:ext cx="3885772" cy="30000"/>
+          </a:xfrm>
+          <a:prstGeom prst="rect">
+            <a:avLst/>
+          </a:prstGeom>
+          <a:solidFill>
+            <a:srgbClr val="C9A84C"/>
+          </a:solidFill>
+          <a:ln>
+            <a:noFill/>
+          </a:ln>
+        </p:spPr>
+        <p:style>
+          <a:lnRef idx="1">
+            <a:schemeClr val="accent1"/>
+          </a:lnRef>
+          <a:fillRef idx="3">
+            <a:schemeClr val="accent1"/>
+          </a:fillRef>
+          <a:effectRef idx="2">
+            <a:schemeClr val="accent1"/>
+          </a:effectRef>
+          <a:fontRef idx="minor">
+            <a:schemeClr val="lt1"/>
+          </a:fontRef>
+        </p:style>
+        <p:txBody>
+          <a:bodyPr rtlCol="0" anchor="ctr"/>
+          <a:lstStyle/>
+          <a:p>
+            <a:pPr algn="ctr"/>
+          </a:p>
+        </p:txBody>
+      </p:sp>
+      <p:sp>
+        <p:nvSpPr>
+          <p:cNvPr id="12" name="Rectangle 11"/>
+          <p:cNvSpPr/>
+          <p:nvPr/>
+        </p:nvSpPr>
+        <p:spPr>
+          <a:xfrm>
+            <a:off x="10746645" y="3526609"/>
+            <a:ext cx="380000" cy="380000"/>
+          </a:xfrm>
+          <a:prstGeom prst="rect">
+            <a:avLst/>
+          </a:prstGeom>
+          <a:solidFill>
+            <a:srgbClr val="C9A84C"/>
+          </a:solidFill>
+          <a:ln>
+            <a:noFill/>
+          </a:ln>
+        </p:spPr>
+        <p:style>
+          <a:lnRef idx="1">
+            <a:schemeClr val="accent1"/>
+          </a:lnRef>
+          <a:fillRef idx="3">
+            <a:schemeClr val="accent1"/>
+          </a:fillRef>
+          <a:effectRef idx="2">
+            <a:schemeClr val="accent1"/>
+          </a:effectRef>
+          <a:fontRef idx="minor">
+            <a:schemeClr val="lt1"/>
+          </a:fontRef>
+        </p:style>
+        <p:txBody>
+          <a:bodyPr rtlCol="0" anchor="ctr"/>
+          <a:lstStyle/>
+          <a:p>
+            <a:pPr algn="ctr"/>
+            <a:r>
+              <a:rPr sz="1400" b="1">
+                <a:solidFill>
+                  <a:srgbClr val="1A2A4A"/>
+                </a:solidFill>
+              </a:rPr>
+              <a:t>1</a:t>
+            </a:r>
+          </a:p>
+        </p:txBody>
+      </p:sp>
+      <p:sp>
+        <p:nvSpPr>
+          <p:cNvPr id="13" name="TextBox 12"/>
+          <p:cNvSpPr txBox="1"/>
+          <p:nvPr/>
+        </p:nvSpPr>
+        <p:spPr>
+          <a:xfrm>
+            <a:off x="11196645" y="3506609"/>
+            <a:ext cx="3735772" cy="240000"/>
+          </a:xfrm>
+          <a:prstGeom prst="rect">
+            <a:avLst/>
+          </a:prstGeom>
+          <a:noFill/>
+        </p:spPr>
+        <p:txBody>
+          <a:bodyPr wrap="square">
+            <a:spAutoFit/>
+          </a:bodyPr>
+          <a:lstStyle/>
+          <a:p>
+            <a:pPr algn="r"/>
+            <a:r>
+              <a:rPr sz="1300" b="1">
+                <a:solidFill>
+                  <a:srgbClr val="FFFFFF"/>
+                </a:solidFill>
+                <a:latin typeface="Arial"/>
+              </a:rPr>
+              <a:t>حماية بيانات الطلاب الرقمية</a:t>
+            </a:r>
+          </a:p>
+        </p:txBody>
+      </p:sp>
+      <p:sp>
+        <p:nvSpPr>
+          <p:cNvPr id="14" name="TextBox 13"/>
+          <p:cNvSpPr txBox="1"/>
+          <p:nvPr/>
+        </p:nvSpPr>
+        <p:spPr>
+          <a:xfrm>
+            <a:off x="11196645" y="3766609"/>
+            <a:ext cx="3735772" cy="200000"/>
+          </a:xfrm>
+          <a:prstGeom prst="rect">
+            <a:avLst/>
+          </a:prstGeom>
+          <a:noFill/>
+        </p:spPr>
+        <p:txBody>
+          <a:bodyPr wrap="square">
+            <a:spAutoFit/>
+          </a:bodyPr>
+          <a:lstStyle/>
+          <a:p>
+            <a:pPr algn="l"/>
+            <a:r>
+              <a:rPr sz="900" b="0">
+                <a:solidFill>
+                  <a:srgbClr val="BBCCDD"/>
+                </a:solidFill>
+                <a:latin typeface="Arial"/>
+              </a:rPr>
+              <a:t>Student Digital Data Protection</a:t>
+            </a:r>
+          </a:p>
+        </p:txBody>
+      </p:sp>
+      <p:sp>
+        <p:nvSpPr>
+          <p:cNvPr id="15" name="Rectangle 14"/>
+          <p:cNvSpPr/>
+          <p:nvPr/>
+        </p:nvSpPr>
+        <p:spPr>
+          <a:xfrm>
+            <a:off x="10746645" y="4156609"/>
+            <a:ext cx="380000" cy="380000"/>
+          </a:xfrm>
+          <a:prstGeom prst="rect">
+            <a:avLst/>
+          </a:prstGeom>
+          <a:solidFill>
+            <a:srgbClr val="C9A84C"/>
+          </a:solidFill>
+          <a:ln>
+            <a:noFill/>
+          </a:ln>
+        </p:spPr>
+        <p:style>
+          <a:lnRef idx="1">
+            <a:schemeClr val="accent1"/>
+          </a:lnRef>
+          <a:fillRef idx="3">
+            <a:schemeClr val="accent1"/>
+          </a:fillRef>
+          <a:effectRef idx="2">
+            <a:schemeClr val="accent1"/>
+          </a:effectRef>
+          <a:fontRef idx="minor">
+            <a:schemeClr val="lt1"/>
+          </a:fontRef>
+        </p:style>
+        <p:txBody>
+          <a:bodyPr rtlCol="0" anchor="ctr"/>
+          <a:lstStyle/>
+          <a:p>
+            <a:pPr algn="ctr"/>
+            <a:r>
+              <a:rPr sz="1400" b="1">
+                <a:solidFill>
+                  <a:srgbClr val="1A2A4A"/>
+                </a:solidFill>
+              </a:rPr>
+              <a:t>2</a:t>
+            </a:r>
+          </a:p>
+        </p:txBody>
+      </p:sp>
+      <p:sp>
+        <p:nvSpPr>
+          <p:cNvPr id="16" name="TextBox 15"/>
+          <p:cNvSpPr txBox="1"/>
+          <p:nvPr/>
+        </p:nvSpPr>
+        <p:spPr>
+          <a:xfrm>
+            <a:off x="11196645" y="4136609"/>
+            <a:ext cx="3735772" cy="240000"/>
+          </a:xfrm>
+          <a:prstGeom prst="rect">
+            <a:avLst/>
+          </a:prstGeom>
+          <a:noFill/>
+        </p:spPr>
+        <p:txBody>
+          <a:bodyPr wrap="square">
+            <a:spAutoFit/>
+          </a:bodyPr>
+          <a:lstStyle/>
+          <a:p>
+            <a:pPr algn="r"/>
+            <a:r>
+              <a:rPr sz="1300" b="1">
+                <a:solidFill>
+                  <a:srgbClr val="FFFFFF"/>
+                </a:solidFill>
+                <a:latin typeface="Arial"/>
+              </a:rPr>
+              <a:t>توثيق هوية المستخدمين</a:t>
+            </a:r>
+          </a:p>
+        </p:txBody>
+      </p:sp>
+      <p:sp>
+        <p:nvSpPr>
+          <p:cNvPr id="17" name="TextBox 16"/>
+          <p:cNvSpPr txBox="1"/>
+          <p:nvPr/>
+        </p:nvSpPr>
+        <p:spPr>
+          <a:xfrm>
+            <a:off x="11196645" y="4396609"/>
+            <a:ext cx="3735772" cy="200000"/>
+          </a:xfrm>
+          <a:prstGeom prst="rect">
+            <a:avLst/>
+          </a:prstGeom>
+          <a:noFill/>
+        </p:spPr>
+        <p:txBody>
+          <a:bodyPr wrap="square">
+            <a:spAutoFit/>
+          </a:bodyPr>
+          <a:lstStyle/>
+          <a:p>
+            <a:pPr algn="l"/>
+            <a:r>
+              <a:rPr sz="900" b="0">
+                <a:solidFill>
+                  <a:srgbClr val="BBCCDD"/>
+                </a:solidFill>
+                <a:latin typeface="Arial"/>
+              </a:rPr>
+              <a:t>User Identity Verification</a:t>
+            </a:r>
+          </a:p>
+        </p:txBody>
+      </p:sp>
+      <p:sp>
+        <p:nvSpPr>
+          <p:cNvPr id="18" name="Rectangle 17"/>
+          <p:cNvSpPr/>
+          <p:nvPr/>
+        </p:nvSpPr>
+        <p:spPr>
+          <a:xfrm>
+            <a:off x="10746645" y="4786609"/>
+            <a:ext cx="380000" cy="380000"/>
+          </a:xfrm>
+          <a:prstGeom prst="rect">
+            <a:avLst/>
+          </a:prstGeom>
+          <a:solidFill>
+            <a:srgbClr val="C9A84C"/>
+          </a:solidFill>
+          <a:ln>
+            <a:noFill/>
+          </a:ln>
+        </p:spPr>
+        <p:style>
+          <a:lnRef idx="1">
+            <a:schemeClr val="accent1"/>
+          </a:lnRef>
+          <a:fillRef idx="3">
+            <a:schemeClr val="accent1"/>
+          </a:fillRef>
+          <a:effectRef idx="2">
+            <a:schemeClr val="accent1"/>
+          </a:effectRef>
+          <a:fontRef idx="minor">
+            <a:schemeClr val="lt1"/>
+          </a:fontRef>
+        </p:style>
+        <p:txBody>
+          <a:bodyPr rtlCol="0" anchor="ctr"/>
+          <a:lstStyle/>
+          <a:p>
+            <a:pPr algn="ctr"/>
+            <a:r>
+              <a:rPr sz="1400" b="1">
+                <a:solidFill>
+                  <a:srgbClr val="1A2A4A"/>
+                </a:solidFill>
+              </a:rPr>
+              <a:t>3</a:t>
+            </a:r>
+          </a:p>
+        </p:txBody>
+      </p:sp>
+      <p:sp>
+        <p:nvSpPr>
+          <p:cNvPr id="19" name="TextBox 18"/>
+          <p:cNvSpPr txBox="1"/>
+          <p:nvPr/>
+        </p:nvSpPr>
+        <p:spPr>
+          <a:xfrm>
+            <a:off x="11196645" y="4766609"/>
+            <a:ext cx="3735772" cy="240000"/>
+          </a:xfrm>
+          <a:prstGeom prst="rect">
+            <a:avLst/>
+          </a:prstGeom>
+          <a:noFill/>
+        </p:spPr>
+        <p:txBody>
+          <a:bodyPr wrap="square">
+            <a:spAutoFit/>
+          </a:bodyPr>
+          <a:lstStyle/>
+          <a:p>
+            <a:pPr algn="r"/>
+            <a:r>
+              <a:rPr sz="1300" b="1">
+                <a:solidFill>
+                  <a:srgbClr val="FFFFFF"/>
+                </a:solidFill>
+                <a:latin typeface="Arial"/>
+              </a:rPr>
+              <a:t>رقابة أولياء الأمور</a:t>
+            </a:r>
+          </a:p>
+        </p:txBody>
+      </p:sp>
+      <p:sp>
+        <p:nvSpPr>
+          <p:cNvPr id="20" name="TextBox 19"/>
+          <p:cNvSpPr txBox="1"/>
+          <p:nvPr/>
+        </p:nvSpPr>
+        <p:spPr>
+          <a:xfrm>
+            <a:off x="11196645" y="5026609"/>
+            <a:ext cx="3735772" cy="200000"/>
+          </a:xfrm>
+          <a:prstGeom prst="rect">
+            <a:avLst/>
+          </a:prstGeom>
+          <a:noFill/>
+        </p:spPr>
+        <p:txBody>
+          <a:bodyPr wrap="square">
+            <a:spAutoFit/>
+          </a:bodyPr>
+          <a:lstStyle/>
+          <a:p>
+            <a:pPr algn="l"/>
+            <a:r>
+              <a:rPr sz="900" b="0">
+                <a:solidFill>
+                  <a:srgbClr val="BBCCDD"/>
+                </a:solidFill>
+                <a:latin typeface="Arial"/>
+              </a:rPr>
+              <a:t>Parental Monitoring Tools</a:t>
+            </a:r>
+          </a:p>
+        </p:txBody>
+      </p:sp>
+      <p:sp>
+        <p:nvSpPr>
+          <p:cNvPr id="21" name="Rectangle 20"/>
+          <p:cNvSpPr/>
+          <p:nvPr/>
+        </p:nvSpPr>
+        <p:spPr>
+          <a:xfrm>
+            <a:off x="10746645" y="5416609"/>
+            <a:ext cx="380000" cy="380000"/>
+          </a:xfrm>
+          <a:prstGeom prst="rect">
+            <a:avLst/>
+          </a:prstGeom>
+          <a:solidFill>
+            <a:srgbClr val="C9A84C"/>
+          </a:solidFill>
+          <a:ln>
+            <a:noFill/>
+          </a:ln>
+        </p:spPr>
+        <p:style>
+          <a:lnRef idx="1">
+            <a:schemeClr val="accent1"/>
+          </a:lnRef>
+          <a:fillRef idx="3">
+            <a:schemeClr val="accent1"/>
+          </a:fillRef>
+          <a:effectRef idx="2">
+            <a:schemeClr val="accent1"/>
+          </a:effectRef>
+          <a:fontRef idx="minor">
+            <a:schemeClr val="lt1"/>
+          </a:fontRef>
+        </p:style>
+        <p:txBody>
+          <a:bodyPr rtlCol="0" anchor="ctr"/>
+          <a:lstStyle/>
+          <a:p>
+            <a:pPr algn="ctr"/>
+            <a:r>
+              <a:rPr sz="1400" b="1">
+                <a:solidFill>
+                  <a:srgbClr val="1A2A4A"/>
+                </a:solidFill>
+              </a:rPr>
+              <a:t>4</a:t>
+            </a:r>
+          </a:p>
+        </p:txBody>
+      </p:sp>
+      <p:sp>
+        <p:nvSpPr>
+          <p:cNvPr id="22" name="TextBox 21"/>
+          <p:cNvSpPr txBox="1"/>
+          <p:nvPr/>
+        </p:nvSpPr>
+        <p:spPr>
+          <a:xfrm>
+            <a:off x="11196645" y="5396609"/>
+            <a:ext cx="3735772" cy="240000"/>
+          </a:xfrm>
+          <a:prstGeom prst="rect">
+            <a:avLst/>
+          </a:prstGeom>
+          <a:noFill/>
+        </p:spPr>
+        <p:txBody>
+          <a:bodyPr wrap="square">
+            <a:spAutoFit/>
+          </a:bodyPr>
+          <a:lstStyle/>
+          <a:p>
+            <a:pPr algn="r"/>
+            <a:r>
+              <a:rPr sz="1300" b="1">
+                <a:solidFill>
+                  <a:srgbClr val="FFFFFF"/>
+                </a:solidFill>
+                <a:latin typeface="Arial"/>
+              </a:rPr>
+              <a:t>الإبلاغ عن الاختراقات</a:t>
+            </a:r>
+          </a:p>
+        </p:txBody>
+      </p:sp>
+      <p:sp>
+        <p:nvSpPr>
+          <p:cNvPr id="23" name="TextBox 22"/>
+          <p:cNvSpPr txBox="1"/>
+          <p:nvPr/>
+        </p:nvSpPr>
+        <p:spPr>
+          <a:xfrm>
+            <a:off x="11196645" y="5656609"/>
+            <a:ext cx="3735772" cy="200000"/>
+          </a:xfrm>
+          <a:prstGeom prst="rect">
+            <a:avLst/>
+          </a:prstGeom>
+          <a:noFill/>
+        </p:spPr>
+        <p:txBody>
+          <a:bodyPr wrap="square">
+            <a:spAutoFit/>
+          </a:bodyPr>
+          <a:lstStyle/>
+          <a:p>
+            <a:pPr algn="l"/>
+            <a:r>
+              <a:rPr sz="900" b="0">
+                <a:solidFill>
+                  <a:srgbClr val="BBCCDD"/>
+                </a:solidFill>
+                <a:latin typeface="Arial"/>
+              </a:rPr>
+              <a:t>Breach Reporting Obligation</a:t>
+            </a:r>
+          </a:p>
+        </p:txBody>
+      </p:sp>
+      <p:sp>
+        <p:nvSpPr>
+          <p:cNvPr id="24" name="Rectangle 23"/>
+          <p:cNvSpPr/>
+          <p:nvPr/>
+        </p:nvSpPr>
+        <p:spPr>
+          <a:xfrm>
+            <a:off x="10746645" y="6046609"/>
+            <a:ext cx="380000" cy="380000"/>
+          </a:xfrm>
+          <a:prstGeom prst="rect">
+            <a:avLst/>
+          </a:prstGeom>
+          <a:solidFill>
+            <a:srgbClr val="C9A84C"/>
+          </a:solidFill>
+          <a:ln>
+            <a:noFill/>
+          </a:ln>
+        </p:spPr>
+        <p:style>
+          <a:lnRef idx="1">
+            <a:schemeClr val="accent1"/>
+          </a:lnRef>
+          <a:fillRef idx="3">
+            <a:schemeClr val="accent1"/>
+          </a:fillRef>
+          <a:effectRef idx="2">
+            <a:schemeClr val="accent1"/>
+          </a:effectRef>
+          <a:fontRef idx="minor">
+            <a:schemeClr val="lt1"/>
+          </a:fontRef>
+        </p:style>
+        <p:txBody>
+          <a:bodyPr rtlCol="0" anchor="ctr"/>
+          <a:lstStyle/>
+          <a:p>
+            <a:pPr algn="ctr"/>
+            <a:r>
+              <a:rPr sz="1400" b="1">
+                <a:solidFill>
+                  <a:srgbClr val="1A2A4A"/>
+                </a:solidFill>
+              </a:rPr>
+              <a:t>5</a:t>
+            </a:r>
+          </a:p>
+        </p:txBody>
+      </p:sp>
+      <p:sp>
+        <p:nvSpPr>
+          <p:cNvPr id="25" name="TextBox 24"/>
+          <p:cNvSpPr txBox="1"/>
+          <p:nvPr/>
+        </p:nvSpPr>
+        <p:spPr>
+          <a:xfrm>
+            <a:off x="11196645" y="6026609"/>
+            <a:ext cx="3735772" cy="240000"/>
+          </a:xfrm>
+          <a:prstGeom prst="rect">
+            <a:avLst/>
+          </a:prstGeom>
+          <a:noFill/>
+        </p:spPr>
+        <p:txBody>
+          <a:bodyPr wrap="square">
+            <a:spAutoFit/>
+          </a:bodyPr>
+          <a:lstStyle/>
+          <a:p>
+            <a:pPr algn="r"/>
+            <a:r>
+              <a:rPr sz="1300" b="1">
+                <a:solidFill>
+                  <a:srgbClr val="FFFFFF"/>
+                </a:solidFill>
+                <a:latin typeface="Arial"/>
+              </a:rPr>
+              <a:t>ضبط صلاحيات الوصول</a:t>
+            </a:r>
+          </a:p>
+        </p:txBody>
+      </p:sp>
+      <p:sp>
+        <p:nvSpPr>
+          <p:cNvPr id="26" name="TextBox 25"/>
+          <p:cNvSpPr txBox="1"/>
+          <p:nvPr/>
+        </p:nvSpPr>
+        <p:spPr>
+          <a:xfrm>
+            <a:off x="11196645" y="6286609"/>
+            <a:ext cx="3735772" cy="200000"/>
+          </a:xfrm>
+          <a:prstGeom prst="rect">
+            <a:avLst/>
+          </a:prstGeom>
+          <a:noFill/>
+        </p:spPr>
+        <p:txBody>
+          <a:bodyPr wrap="square">
+            <a:spAutoFit/>
+          </a:bodyPr>
+          <a:lstStyle/>
+          <a:p>
+            <a:pPr algn="l"/>
+            <a:r>
+              <a:rPr sz="900" b="0">
+                <a:solidFill>
+                  <a:srgbClr val="BBCCDD"/>
+                </a:solidFill>
+                <a:latin typeface="Arial"/>
+              </a:rPr>
+              <a:t>Access Control Management</a:t>
             </a:r>
           </a:p>
         </p:txBody>
@@ -5401,8 +6917,8 @@
 </p:sld>
 </file>
 
-<file path=ppt/slides/slide2.xml><?xml version="1.0" encoding="utf-8"?>
-<p:sld xmlns:p="http://schemas.openxmlformats.org/presentationml/2006/main" xmlns:a="http://schemas.openxmlformats.org/drawingml/2006/main" xmlns:r="http://schemas.openxmlformats.org/officeDocument/2006/relationships">
+<file path=ppt/slides/slide4.xml><?xml version="1.0" encoding="utf-8"?>
+<p:sld xmlns:a="http://schemas.openxmlformats.org/drawingml/2006/main" xmlns:p="http://schemas.openxmlformats.org/presentationml/2006/main" xmlns:r="http://schemas.openxmlformats.org/officeDocument/2006/relationships">
   <p:cSld>
     <p:bg>
       <p:bgPr>
@@ -5742,17 +7258,82 @@
               </a:lnSpc>
             </a:pPr>
             <a:r>
-              <a:rPr lang="ar-EG" sz="2400">
+              <a:rPr lang="ar-SA" dirty="0" sz="1900">
                 <a:solidFill>
-                  <a:srgbClr val="F3E5B8"/>
+                  <a:srgbClr val="FFFFFF"/>
                 </a:solidFill>
-                <a:latin typeface="Codec Pro"/>
-                <a:ea typeface="Codec Pro"/>
-                <a:cs typeface="Codec Pro"/>
-                <a:sym typeface="Codec Pro"/>
-                <a:rtl val="true"/>
+                <a:latin typeface="Noto Sans Arabic"/>
+                <a:ea typeface="Noto Sans Arabic"/>
               </a:rPr>
-              <a:t>تواجه المدارس صعوبات في إدارة البيانات والتواصل، مما يؤثر سلباً على تجربة التعليم والتعلم.</a:t>
+              <a:t>نظام صلاحيات متعدد المستويات: مدير، معلم، إداري، مديرة، ولي أمر</a:t>
+            </a:r>
+          </a:p>
+          <a:p>
+            <a:pPr algn="ctr" rtl="true" marL="0" indent="0" lvl="0">
+              <a:lnSpc>
+                <a:spcPts val="3120"/>
+              </a:lnSpc>
+            </a:pPr>
+            <a:r>
+              <a:rPr lang="ar-SA" dirty="0" sz="1900">
+                <a:solidFill>
+                  <a:srgbClr val="FFFFFF"/>
+                </a:solidFill>
+                <a:latin typeface="Noto Sans Arabic"/>
+                <a:ea typeface="Noto Sans Arabic"/>
+              </a:rPr>
+              <a:t>بيانات الطلاب محمية محلياً — لا تُرفع لخوادم خارجية</a:t>
+            </a:r>
+          </a:p>
+          <a:p>
+            <a:pPr algn="ctr" rtl="true" marL="0" indent="0" lvl="0">
+              <a:lnSpc>
+                <a:spcPts val="3120"/>
+              </a:lnSpc>
+            </a:pPr>
+            <a:r>
+              <a:rPr lang="ar-SA" dirty="0" sz="1900">
+                <a:solidFill>
+                  <a:srgbClr val="FFFFFF"/>
+                </a:solidFill>
+                <a:latin typeface="Noto Sans Arabic"/>
+                <a:ea typeface="Noto Sans Arabic"/>
+              </a:rPr>
+              <a:t>لوحة رقابة خاصة بمديرة المدرسة لمتابعة الأنشطة الرقمية</a:t>
+            </a:r>
+          </a:p>
+          <a:p>
+            <a:pPr algn="ctr" rtl="true" marL="0" indent="0" lvl="0">
+              <a:lnSpc>
+                <a:spcPts val="3120"/>
+              </a:lnSpc>
+            </a:pPr>
+            <a:r>
+              <a:rPr lang="ar-SA" dirty="0" sz="1900">
+                <a:solidFill>
+                  <a:srgbClr val="FFFFFF"/>
+                </a:solidFill>
+                <a:latin typeface="Noto Sans Arabic"/>
+                <a:ea typeface="Noto Sans Arabic"/>
+              </a:rPr>
+              <a:t>بوابة أولياء الأمور (قريباً) — اطلاع على بيانات أبنائهم فقط</a:t>
+            </a:r>
+          </a:p>
+          <a:p>
+            <a:pPr algn="ctr" rtl="true" marL="0" indent="0" lvl="0">
+              <a:lnSpc>
+                <a:spcPts val="3120"/>
+              </a:lnSpc>
+            </a:pPr>
+            <a:r>
+              <a:rPr lang="ar-SA" dirty="0" sz="1900">
+                <a:solidFill>
+                  <a:srgbClr val="FFFFFF"/>
+                </a:solidFill>
+                <a:latin typeface="Noto Sans Arabic"/>
+                <a:ea typeface="Noto Sans Arabic"/>
+              </a:rPr>
+              <a:t>امتثال تام لاشتراطات المرسوم الاتحادي رقم (2) لسنة 2026</a:t>
             </a:r>
           </a:p>
         </p:txBody>
@@ -5787,17 +7368,671 @@
               </a:spcBef>
             </a:pPr>
             <a:r>
-              <a:rPr lang="ar-EG" b="true" sz="5489">
+              <a:rPr lang="ar-SA" dirty="0" b="1" sz="3000">
                 <a:solidFill>
-                  <a:srgbClr val="F3E5B8"/>
+                  <a:srgbClr val="C9A84C"/>
                 </a:solidFill>
-                <a:latin typeface="Codec Pro Ultra-Bold"/>
-                <a:ea typeface="Codec Pro Ultra-Bold"/>
-                <a:cs typeface="Codec Pro Ultra-Bold"/>
-                <a:sym typeface="Codec Pro Ultra-Bold"/>
-                <a:rtl val="true"/>
+                <a:latin typeface="Noto Sans Arabic"/>
+                <a:ea typeface="Noto Sans Arabic"/>
               </a:rPr>
-              <a:t>التحديات الحقيقية التي تواجه المدارس اليوم</a:t>
+              <a:t>بوابة مدرسة الجود وقانون الطفل الرقمي</a:t>
+            </a:r>
+          </a:p>
+          <a:p>
+            <a:pPr algn="ctr" rtl="true" marL="0" indent="0" lvl="0">
+              <a:lnSpc>
+                <a:spcPts val="6861"/>
+              </a:lnSpc>
+              <a:spcBef>
+                <a:spcPct val="0"/>
+              </a:spcBef>
+            </a:pPr>
+            <a:r>
+              <a:rPr lang="en-US" dirty="0" sz="1800">
+                <a:solidFill>
+                  <a:srgbClr val="BBBBBB"/>
+                </a:solidFill>
+                <a:latin typeface="Calibri"/>
+              </a:rPr>
+              <a:t>Al Jood Portal Alignment with Child Digital Safety Law 2026</a:t>
+            </a:r>
+          </a:p>
+        </p:txBody>
+      </p:sp>
+      <p:sp>
+        <p:nvSpPr>
+          <p:cNvPr id="9" name="TextBox 8"/>
+          <p:cNvSpPr txBox="1"/>
+          <p:nvPr/>
+        </p:nvSpPr>
+        <p:spPr>
+          <a:xfrm>
+            <a:off x="10646645" y="2506609"/>
+            <a:ext cx="4285772" cy="500000"/>
+          </a:xfrm>
+          <a:prstGeom prst="rect">
+            <a:avLst/>
+          </a:prstGeom>
+          <a:noFill/>
+        </p:spPr>
+        <p:txBody>
+          <a:bodyPr wrap="square">
+            <a:spAutoFit/>
+          </a:bodyPr>
+          <a:lstStyle/>
+          <a:p>
+            <a:pPr algn="ctr"/>
+            <a:r>
+              <a:rPr sz="1700" b="1">
+                <a:solidFill>
+                  <a:srgbClr val="C9A84C"/>
+                </a:solidFill>
+                <a:latin typeface="Arial"/>
+              </a:rPr>
+              <a:t>مقارنة: القانون vs البوابة</a:t>
+            </a:r>
+          </a:p>
+        </p:txBody>
+      </p:sp>
+      <p:sp>
+        <p:nvSpPr>
+          <p:cNvPr id="10" name="TextBox 9"/>
+          <p:cNvSpPr txBox="1"/>
+          <p:nvPr/>
+        </p:nvSpPr>
+        <p:spPr>
+          <a:xfrm>
+            <a:off x="10646645" y="3006609"/>
+            <a:ext cx="4285772" cy="300000"/>
+          </a:xfrm>
+          <a:prstGeom prst="rect">
+            <a:avLst/>
+          </a:prstGeom>
+          <a:noFill/>
+        </p:spPr>
+        <p:txBody>
+          <a:bodyPr wrap="square">
+            <a:spAutoFit/>
+          </a:bodyPr>
+          <a:lstStyle/>
+          <a:p>
+            <a:pPr algn="ctr"/>
+            <a:r>
+              <a:rPr sz="1000" b="0">
+                <a:solidFill>
+                  <a:srgbClr val="BBCCDD"/>
+                </a:solidFill>
+                <a:latin typeface="Arial"/>
+              </a:rPr>
+              <a:t>Law Requirement  vs  Portal Feature</a:t>
+            </a:r>
+          </a:p>
+        </p:txBody>
+      </p:sp>
+      <p:sp>
+        <p:nvSpPr>
+          <p:cNvPr id="11" name="Rectangle 10"/>
+          <p:cNvSpPr/>
+          <p:nvPr/>
+        </p:nvSpPr>
+        <p:spPr>
+          <a:xfrm>
+            <a:off x="10846645" y="3356609"/>
+            <a:ext cx="3885772" cy="30000"/>
+          </a:xfrm>
+          <a:prstGeom prst="rect">
+            <a:avLst/>
+          </a:prstGeom>
+          <a:solidFill>
+            <a:srgbClr val="C9A84C"/>
+          </a:solidFill>
+          <a:ln>
+            <a:noFill/>
+          </a:ln>
+        </p:spPr>
+        <p:style>
+          <a:lnRef idx="1">
+            <a:schemeClr val="accent1"/>
+          </a:lnRef>
+          <a:fillRef idx="3">
+            <a:schemeClr val="accent1"/>
+          </a:fillRef>
+          <a:effectRef idx="2">
+            <a:schemeClr val="accent1"/>
+          </a:effectRef>
+          <a:fontRef idx="minor">
+            <a:schemeClr val="lt1"/>
+          </a:fontRef>
+        </p:style>
+        <p:txBody>
+          <a:bodyPr rtlCol="0" anchor="ctr"/>
+          <a:lstStyle/>
+          <a:p>
+            <a:pPr algn="ctr"/>
+          </a:p>
+        </p:txBody>
+      </p:sp>
+      <p:sp>
+        <p:nvSpPr>
+          <p:cNvPr id="12" name="TextBox 11"/>
+          <p:cNvSpPr txBox="1"/>
+          <p:nvPr/>
+        </p:nvSpPr>
+        <p:spPr>
+          <a:xfrm>
+            <a:off x="10696645" y="3406609"/>
+            <a:ext cx="350000" cy="320000"/>
+          </a:xfrm>
+          <a:prstGeom prst="rect">
+            <a:avLst/>
+          </a:prstGeom>
+          <a:noFill/>
+        </p:spPr>
+        <p:txBody>
+          <a:bodyPr wrap="square">
+            <a:spAutoFit/>
+          </a:bodyPr>
+          <a:lstStyle/>
+          <a:p>
+            <a:pPr algn="ctr"/>
+            <a:r>
+              <a:rPr sz="1600" b="1">
+                <a:solidFill>
+                  <a:srgbClr val="5DD39F"/>
+                </a:solidFill>
+                <a:latin typeface="Arial"/>
+              </a:rPr>
+              <a:t>✓</a:t>
+            </a:r>
+          </a:p>
+        </p:txBody>
+      </p:sp>
+      <p:sp>
+        <p:nvSpPr>
+          <p:cNvPr id="13" name="TextBox 12"/>
+          <p:cNvSpPr txBox="1"/>
+          <p:nvPr/>
+        </p:nvSpPr>
+        <p:spPr>
+          <a:xfrm>
+            <a:off x="11046645" y="3406609"/>
+            <a:ext cx="3885772" cy="250000"/>
+          </a:xfrm>
+          <a:prstGeom prst="rect">
+            <a:avLst/>
+          </a:prstGeom>
+          <a:noFill/>
+        </p:spPr>
+        <p:txBody>
+          <a:bodyPr wrap="square">
+            <a:spAutoFit/>
+          </a:bodyPr>
+          <a:lstStyle/>
+          <a:p>
+            <a:pPr algn="r"/>
+            <a:r>
+              <a:rPr sz="1200" b="1">
+                <a:solidFill>
+                  <a:srgbClr val="FFFFFF"/>
+                </a:solidFill>
+                <a:latin typeface="Arial"/>
+              </a:rPr>
+              <a:t>حماية البيانات</a:t>
+            </a:r>
+          </a:p>
+        </p:txBody>
+      </p:sp>
+      <p:sp>
+        <p:nvSpPr>
+          <p:cNvPr id="14" name="TextBox 13"/>
+          <p:cNvSpPr txBox="1"/>
+          <p:nvPr/>
+        </p:nvSpPr>
+        <p:spPr>
+          <a:xfrm>
+            <a:off x="11046645" y="3666609"/>
+            <a:ext cx="3885772" cy="220000"/>
+          </a:xfrm>
+          <a:prstGeom prst="rect">
+            <a:avLst/>
+          </a:prstGeom>
+          <a:noFill/>
+        </p:spPr>
+        <p:txBody>
+          <a:bodyPr wrap="square">
+            <a:spAutoFit/>
+          </a:bodyPr>
+          <a:lstStyle/>
+          <a:p>
+            <a:pPr algn="r"/>
+            <a:r>
+              <a:rPr sz="1000" b="0">
+                <a:solidFill>
+                  <a:srgbClr val="C9A84C"/>
+                </a:solidFill>
+                <a:latin typeface="Arial"/>
+              </a:rPr>
+              <a:t>localStorage — لا سحابة</a:t>
+            </a:r>
+          </a:p>
+        </p:txBody>
+      </p:sp>
+      <p:sp>
+        <p:nvSpPr>
+          <p:cNvPr id="15" name="TextBox 14"/>
+          <p:cNvSpPr txBox="1"/>
+          <p:nvPr/>
+        </p:nvSpPr>
+        <p:spPr>
+          <a:xfrm>
+            <a:off x="10696645" y="4086609"/>
+            <a:ext cx="350000" cy="320000"/>
+          </a:xfrm>
+          <a:prstGeom prst="rect">
+            <a:avLst/>
+          </a:prstGeom>
+          <a:noFill/>
+        </p:spPr>
+        <p:txBody>
+          <a:bodyPr wrap="square">
+            <a:spAutoFit/>
+          </a:bodyPr>
+          <a:lstStyle/>
+          <a:p>
+            <a:pPr algn="ctr"/>
+            <a:r>
+              <a:rPr sz="1600" b="1">
+                <a:solidFill>
+                  <a:srgbClr val="5DD39F"/>
+                </a:solidFill>
+                <a:latin typeface="Arial"/>
+              </a:rPr>
+              <a:t>✓</a:t>
+            </a:r>
+          </a:p>
+        </p:txBody>
+      </p:sp>
+      <p:sp>
+        <p:nvSpPr>
+          <p:cNvPr id="16" name="TextBox 15"/>
+          <p:cNvSpPr txBox="1"/>
+          <p:nvPr/>
+        </p:nvSpPr>
+        <p:spPr>
+          <a:xfrm>
+            <a:off x="11046645" y="4086609"/>
+            <a:ext cx="3885772" cy="250000"/>
+          </a:xfrm>
+          <a:prstGeom prst="rect">
+            <a:avLst/>
+          </a:prstGeom>
+          <a:noFill/>
+        </p:spPr>
+        <p:txBody>
+          <a:bodyPr wrap="square">
+            <a:spAutoFit/>
+          </a:bodyPr>
+          <a:lstStyle/>
+          <a:p>
+            <a:pPr algn="r"/>
+            <a:r>
+              <a:rPr sz="1200" b="1">
+                <a:solidFill>
+                  <a:srgbClr val="FFFFFF"/>
+                </a:solidFill>
+                <a:latin typeface="Arial"/>
+              </a:rPr>
+              <a:t>توثيق الهوية</a:t>
+            </a:r>
+          </a:p>
+        </p:txBody>
+      </p:sp>
+      <p:sp>
+        <p:nvSpPr>
+          <p:cNvPr id="17" name="TextBox 16"/>
+          <p:cNvSpPr txBox="1"/>
+          <p:nvPr/>
+        </p:nvSpPr>
+        <p:spPr>
+          <a:xfrm>
+            <a:off x="11046645" y="4346609"/>
+            <a:ext cx="3885772" cy="220000"/>
+          </a:xfrm>
+          <a:prstGeom prst="rect">
+            <a:avLst/>
+          </a:prstGeom>
+          <a:noFill/>
+        </p:spPr>
+        <p:txBody>
+          <a:bodyPr wrap="square">
+            <a:spAutoFit/>
+          </a:bodyPr>
+          <a:lstStyle/>
+          <a:p>
+            <a:pPr algn="r"/>
+            <a:r>
+              <a:rPr sz="1000" b="0">
+                <a:solidFill>
+                  <a:srgbClr val="C9A84C"/>
+                </a:solidFill>
+                <a:latin typeface="Arial"/>
+              </a:rPr>
+              <a:t>تسجيل دخول متعدد الأدوار</a:t>
+            </a:r>
+          </a:p>
+        </p:txBody>
+      </p:sp>
+      <p:sp>
+        <p:nvSpPr>
+          <p:cNvPr id="18" name="TextBox 17"/>
+          <p:cNvSpPr txBox="1"/>
+          <p:nvPr/>
+        </p:nvSpPr>
+        <p:spPr>
+          <a:xfrm>
+            <a:off x="10696645" y="4766609"/>
+            <a:ext cx="350000" cy="320000"/>
+          </a:xfrm>
+          <a:prstGeom prst="rect">
+            <a:avLst/>
+          </a:prstGeom>
+          <a:noFill/>
+        </p:spPr>
+        <p:txBody>
+          <a:bodyPr wrap="square">
+            <a:spAutoFit/>
+          </a:bodyPr>
+          <a:lstStyle/>
+          <a:p>
+            <a:pPr algn="ctr"/>
+            <a:r>
+              <a:rPr sz="1600" b="1">
+                <a:solidFill>
+                  <a:srgbClr val="5DD39F"/>
+                </a:solidFill>
+                <a:latin typeface="Arial"/>
+              </a:rPr>
+              <a:t>✓</a:t>
+            </a:r>
+          </a:p>
+        </p:txBody>
+      </p:sp>
+      <p:sp>
+        <p:nvSpPr>
+          <p:cNvPr id="19" name="TextBox 18"/>
+          <p:cNvSpPr txBox="1"/>
+          <p:nvPr/>
+        </p:nvSpPr>
+        <p:spPr>
+          <a:xfrm>
+            <a:off x="11046645" y="4766609"/>
+            <a:ext cx="3885772" cy="250000"/>
+          </a:xfrm>
+          <a:prstGeom prst="rect">
+            <a:avLst/>
+          </a:prstGeom>
+          <a:noFill/>
+        </p:spPr>
+        <p:txBody>
+          <a:bodyPr wrap="square">
+            <a:spAutoFit/>
+          </a:bodyPr>
+          <a:lstStyle/>
+          <a:p>
+            <a:pPr algn="r"/>
+            <a:r>
+              <a:rPr sz="1200" b="1">
+                <a:solidFill>
+                  <a:srgbClr val="FFFFFF"/>
+                </a:solidFill>
+                <a:latin typeface="Arial"/>
+              </a:rPr>
+              <a:t>رقابة أولياء الأمور</a:t>
+            </a:r>
+          </a:p>
+        </p:txBody>
+      </p:sp>
+      <p:sp>
+        <p:nvSpPr>
+          <p:cNvPr id="20" name="TextBox 19"/>
+          <p:cNvSpPr txBox="1"/>
+          <p:nvPr/>
+        </p:nvSpPr>
+        <p:spPr>
+          <a:xfrm>
+            <a:off x="11046645" y="5026609"/>
+            <a:ext cx="3885772" cy="220000"/>
+          </a:xfrm>
+          <a:prstGeom prst="rect">
+            <a:avLst/>
+          </a:prstGeom>
+          <a:noFill/>
+        </p:spPr>
+        <p:txBody>
+          <a:bodyPr wrap="square">
+            <a:spAutoFit/>
+          </a:bodyPr>
+          <a:lstStyle/>
+          <a:p>
+            <a:pPr algn="r"/>
+            <a:r>
+              <a:rPr sz="1000" b="0">
+                <a:solidFill>
+                  <a:srgbClr val="C9A84C"/>
+                </a:solidFill>
+                <a:latin typeface="Arial"/>
+              </a:rPr>
+              <a:t>بوابة ولي الأمر قريباً</a:t>
+            </a:r>
+          </a:p>
+        </p:txBody>
+      </p:sp>
+      <p:sp>
+        <p:nvSpPr>
+          <p:cNvPr id="21" name="TextBox 20"/>
+          <p:cNvSpPr txBox="1"/>
+          <p:nvPr/>
+        </p:nvSpPr>
+        <p:spPr>
+          <a:xfrm>
+            <a:off x="10696645" y="5446609"/>
+            <a:ext cx="350000" cy="320000"/>
+          </a:xfrm>
+          <a:prstGeom prst="rect">
+            <a:avLst/>
+          </a:prstGeom>
+          <a:noFill/>
+        </p:spPr>
+        <p:txBody>
+          <a:bodyPr wrap="square">
+            <a:spAutoFit/>
+          </a:bodyPr>
+          <a:lstStyle/>
+          <a:p>
+            <a:pPr algn="ctr"/>
+            <a:r>
+              <a:rPr sz="1600" b="1">
+                <a:solidFill>
+                  <a:srgbClr val="5DD39F"/>
+                </a:solidFill>
+                <a:latin typeface="Arial"/>
+              </a:rPr>
+              <a:t>✓</a:t>
+            </a:r>
+          </a:p>
+        </p:txBody>
+      </p:sp>
+      <p:sp>
+        <p:nvSpPr>
+          <p:cNvPr id="22" name="TextBox 21"/>
+          <p:cNvSpPr txBox="1"/>
+          <p:nvPr/>
+        </p:nvSpPr>
+        <p:spPr>
+          <a:xfrm>
+            <a:off x="11046645" y="5446609"/>
+            <a:ext cx="3885772" cy="250000"/>
+          </a:xfrm>
+          <a:prstGeom prst="rect">
+            <a:avLst/>
+          </a:prstGeom>
+          <a:noFill/>
+        </p:spPr>
+        <p:txBody>
+          <a:bodyPr wrap="square">
+            <a:spAutoFit/>
+          </a:bodyPr>
+          <a:lstStyle/>
+          <a:p>
+            <a:pPr algn="r"/>
+            <a:r>
+              <a:rPr sz="1200" b="1">
+                <a:solidFill>
+                  <a:srgbClr val="FFFFFF"/>
+                </a:solidFill>
+                <a:latin typeface="Arial"/>
+              </a:rPr>
+              <a:t>ضبط الصلاحيات</a:t>
+            </a:r>
+          </a:p>
+        </p:txBody>
+      </p:sp>
+      <p:sp>
+        <p:nvSpPr>
+          <p:cNvPr id="23" name="TextBox 22"/>
+          <p:cNvSpPr txBox="1"/>
+          <p:nvPr/>
+        </p:nvSpPr>
+        <p:spPr>
+          <a:xfrm>
+            <a:off x="11046645" y="5706609"/>
+            <a:ext cx="3885772" cy="220000"/>
+          </a:xfrm>
+          <a:prstGeom prst="rect">
+            <a:avLst/>
+          </a:prstGeom>
+          <a:noFill/>
+        </p:spPr>
+        <p:txBody>
+          <a:bodyPr wrap="square">
+            <a:spAutoFit/>
+          </a:bodyPr>
+          <a:lstStyle/>
+          <a:p>
+            <a:pPr algn="r"/>
+            <a:r>
+              <a:rPr sz="1000" b="0">
+                <a:solidFill>
+                  <a:srgbClr val="C9A84C"/>
+                </a:solidFill>
+                <a:latin typeface="Arial"/>
+              </a:rPr>
+              <a:t>5 مستويات وصول</a:t>
+            </a:r>
+          </a:p>
+        </p:txBody>
+      </p:sp>
+      <p:sp>
+        <p:nvSpPr>
+          <p:cNvPr id="24" name="TextBox 23"/>
+          <p:cNvSpPr txBox="1"/>
+          <p:nvPr/>
+        </p:nvSpPr>
+        <p:spPr>
+          <a:xfrm>
+            <a:off x="10696645" y="6126609"/>
+            <a:ext cx="350000" cy="320000"/>
+          </a:xfrm>
+          <a:prstGeom prst="rect">
+            <a:avLst/>
+          </a:prstGeom>
+          <a:noFill/>
+        </p:spPr>
+        <p:txBody>
+          <a:bodyPr wrap="square">
+            <a:spAutoFit/>
+          </a:bodyPr>
+          <a:lstStyle/>
+          <a:p>
+            <a:pPr algn="ctr"/>
+            <a:r>
+              <a:rPr sz="1600" b="1">
+                <a:solidFill>
+                  <a:srgbClr val="5DD39F"/>
+                </a:solidFill>
+                <a:latin typeface="Arial"/>
+              </a:rPr>
+              <a:t>✓</a:t>
+            </a:r>
+          </a:p>
+        </p:txBody>
+      </p:sp>
+      <p:sp>
+        <p:nvSpPr>
+          <p:cNvPr id="25" name="TextBox 24"/>
+          <p:cNvSpPr txBox="1"/>
+          <p:nvPr/>
+        </p:nvSpPr>
+        <p:spPr>
+          <a:xfrm>
+            <a:off x="11046645" y="6126609"/>
+            <a:ext cx="3885772" cy="250000"/>
+          </a:xfrm>
+          <a:prstGeom prst="rect">
+            <a:avLst/>
+          </a:prstGeom>
+          <a:noFill/>
+        </p:spPr>
+        <p:txBody>
+          <a:bodyPr wrap="square">
+            <a:spAutoFit/>
+          </a:bodyPr>
+          <a:lstStyle/>
+          <a:p>
+            <a:pPr algn="r"/>
+            <a:r>
+              <a:rPr sz="1200" b="1">
+                <a:solidFill>
+                  <a:srgbClr val="FFFFFF"/>
+                </a:solidFill>
+                <a:latin typeface="Arial"/>
+              </a:rPr>
+              <a:t>الشفافية</a:t>
+            </a:r>
+          </a:p>
+        </p:txBody>
+      </p:sp>
+      <p:sp>
+        <p:nvSpPr>
+          <p:cNvPr id="26" name="TextBox 25"/>
+          <p:cNvSpPr txBox="1"/>
+          <p:nvPr/>
+        </p:nvSpPr>
+        <p:spPr>
+          <a:xfrm>
+            <a:off x="11046645" y="6386609"/>
+            <a:ext cx="3885772" cy="220000"/>
+          </a:xfrm>
+          <a:prstGeom prst="rect">
+            <a:avLst/>
+          </a:prstGeom>
+          <a:noFill/>
+        </p:spPr>
+        <p:txBody>
+          <a:bodyPr wrap="square">
+            <a:spAutoFit/>
+          </a:bodyPr>
+          <a:lstStyle/>
+          <a:p>
+            <a:pPr algn="r"/>
+            <a:r>
+              <a:rPr sz="1000" b="0">
+                <a:solidFill>
+                  <a:srgbClr val="C9A84C"/>
+                </a:solidFill>
+                <a:latin typeface="Arial"/>
+              </a:rPr>
+              <a:t>لوحة تحليل النتائج</a:t>
             </a:r>
           </a:p>
         </p:txBody>
@@ -5810,7 +8045,7 @@
 </p:sld>
 </file>
 
-<file path=ppt/slides/slide3.xml><?xml version="1.0" encoding="utf-8"?>
+<file path=ppt/slides/slide5.xml><?xml version="1.0" encoding="utf-8"?>
 <p:sld xmlns:p="http://schemas.openxmlformats.org/presentationml/2006/main" xmlns:a="http://schemas.openxmlformats.org/drawingml/2006/main" xmlns:r="http://schemas.openxmlformats.org/officeDocument/2006/relationships">
   <p:cSld>
     <p:bg>
@@ -6793,7 +9028,7 @@
 </p:sld>
 </file>
 
-<file path=ppt/slides/slide4.xml><?xml version="1.0" encoding="utf-8"?>
+<file path=ppt/slides/slide6.xml><?xml version="1.0" encoding="utf-8"?>
 <p:sld xmlns:p="http://schemas.openxmlformats.org/presentationml/2006/main" xmlns:a="http://schemas.openxmlformats.org/drawingml/2006/main" xmlns:r="http://schemas.openxmlformats.org/officeDocument/2006/relationships">
   <p:cSld>
     <p:bg>
@@ -7711,7 +9946,7 @@
 </p:sld>
 </file>
 
-<file path=ppt/slides/slide5.xml><?xml version="1.0" encoding="utf-8"?>
+<file path=ppt/slides/slide7.xml><?xml version="1.0" encoding="utf-8"?>
 <p:sld xmlns:p="http://schemas.openxmlformats.org/presentationml/2006/main" xmlns:a="http://schemas.openxmlformats.org/drawingml/2006/main" xmlns:r="http://schemas.openxmlformats.org/officeDocument/2006/relationships">
   <p:cSld>
     <p:bg>
@@ -8161,7 +10396,7 @@
 </p:sld>
 </file>
 
-<file path=ppt/slides/slide6.xml><?xml version="1.0" encoding="utf-8"?>
+<file path=ppt/slides/slide8.xml><?xml version="1.0" encoding="utf-8"?>
 <p:sld xmlns:p="http://schemas.openxmlformats.org/presentationml/2006/main" xmlns:a="http://schemas.openxmlformats.org/drawingml/2006/main" xmlns:r="http://schemas.openxmlformats.org/officeDocument/2006/relationships">
   <p:cSld>
     <p:bg>
@@ -8642,7 +10877,7 @@
 </p:sld>
 </file>
 
-<file path=ppt/slides/slide7.xml><?xml version="1.0" encoding="utf-8"?>
+<file path=ppt/slides/slide9.xml><?xml version="1.0" encoding="utf-8"?>
 <p:sld xmlns:p="http://schemas.openxmlformats.org/presentationml/2006/main" xmlns:a="http://schemas.openxmlformats.org/drawingml/2006/main" xmlns:r="http://schemas.openxmlformats.org/officeDocument/2006/relationships">
   <p:cSld>
     <p:bg>
@@ -9548,885 +11783,6 @@
                 <a:rtl val="true"/>
               </a:rPr>
               <a:t>مميزات إضافية</a:t>
-            </a:r>
-          </a:p>
-        </p:txBody>
-      </p:sp>
-    </p:spTree>
-  </p:cSld>
-  <p:clrMapOvr>
-    <a:masterClrMapping/>
-  </p:clrMapOvr>
-</p:sld>
-</file>
-
-<file path=ppt/slides/slide8.xml><?xml version="1.0" encoding="utf-8"?>
-<p:sld xmlns:p="http://schemas.openxmlformats.org/presentationml/2006/main" xmlns:a="http://schemas.openxmlformats.org/drawingml/2006/main" xmlns:r="http://schemas.openxmlformats.org/officeDocument/2006/relationships">
-  <p:cSld>
-    <p:bg>
-      <p:bgPr>
-        <a:solidFill>
-          <a:srgbClr val="1A2A4A"/>
-        </a:solidFill>
-      </p:bgPr>
-    </p:bg>
-    <p:spTree>
-      <p:nvGrpSpPr>
-        <p:cNvPr id="1" name=""/>
-        <p:cNvGrpSpPr/>
-        <p:nvPr/>
-      </p:nvGrpSpPr>
-      <p:grpSpPr>
-        <a:xfrm>
-          <a:off x="0" y="0"/>
-          <a:ext cx="0" cy="0"/>
-          <a:chOff x="0" y="0"/>
-          <a:chExt cx="0" cy="0"/>
-        </a:xfrm>
-      </p:grpSpPr>
-      <p:grpSp>
-        <p:nvGrpSpPr>
-          <p:cNvPr name="Group 2" id="2"/>
-          <p:cNvGrpSpPr/>
-          <p:nvPr/>
-        </p:nvGrpSpPr>
-        <p:grpSpPr>
-          <a:xfrm rot="0">
-            <a:off x="666750" y="666750"/>
-            <a:ext cx="16954500" cy="8953500"/>
-            <a:chOff x="0" y="0"/>
-            <a:chExt cx="5734099" cy="3028120"/>
-          </a:xfrm>
-        </p:grpSpPr>
-        <p:sp>
-          <p:nvSpPr>
-            <p:cNvPr name="Freeform 3" id="3"/>
-            <p:cNvSpPr/>
-            <p:nvPr/>
-          </p:nvSpPr>
-          <p:spPr>
-            <a:xfrm flipH="false" flipV="false" rot="0">
-              <a:off x="52070" y="12700"/>
-              <a:ext cx="5669329" cy="2959540"/>
-            </a:xfrm>
-            <a:custGeom>
-              <a:avLst/>
-              <a:gdLst/>
-              <a:ahLst/>
-              <a:cxnLst/>
-              <a:rect r="r" b="b" t="t" l="l"/>
-              <a:pathLst>
-                <a:path h="2959540" w="5669329">
-                  <a:moveTo>
-                    <a:pt x="5523279" y="2959540"/>
-                  </a:moveTo>
-                  <a:lnTo>
-                    <a:pt x="164850" y="2959540"/>
-                  </a:lnTo>
-                  <a:cubicBezTo>
-                    <a:pt x="66040" y="2959540"/>
-                    <a:pt x="0" y="2893500"/>
-                    <a:pt x="0" y="2813490"/>
-                  </a:cubicBezTo>
-                  <a:lnTo>
-                    <a:pt x="0" y="146050"/>
-                  </a:lnTo>
-                  <a:cubicBezTo>
-                    <a:pt x="0" y="66040"/>
-                    <a:pt x="66040" y="0"/>
-                    <a:pt x="164850" y="0"/>
-                  </a:cubicBezTo>
-                  <a:lnTo>
-                    <a:pt x="5523279" y="0"/>
-                  </a:lnTo>
-                  <a:cubicBezTo>
-                    <a:pt x="5603289" y="0"/>
-                    <a:pt x="5669329" y="66040"/>
-                    <a:pt x="5669329" y="146050"/>
-                  </a:cubicBezTo>
-                  <a:lnTo>
-                    <a:pt x="5669329" y="2813490"/>
-                  </a:lnTo>
-                  <a:cubicBezTo>
-                    <a:pt x="5669329" y="2894770"/>
-                    <a:pt x="5603289" y="2959540"/>
-                    <a:pt x="5523279" y="2959540"/>
-                  </a:cubicBezTo>
-                  <a:close/>
-                </a:path>
-              </a:pathLst>
-            </a:custGeom>
-            <a:solidFill>
-              <a:srgbClr val="021633"/>
-            </a:solidFill>
-          </p:spPr>
-        </p:sp>
-        <p:sp>
-          <p:nvSpPr>
-            <p:cNvPr name="Freeform 4" id="4"/>
-            <p:cNvSpPr/>
-            <p:nvPr/>
-          </p:nvSpPr>
-          <p:spPr>
-            <a:xfrm flipH="false" flipV="false" rot="0">
-              <a:off x="0" y="0"/>
-              <a:ext cx="5734099" cy="3028120"/>
-            </a:xfrm>
-            <a:custGeom>
-              <a:avLst/>
-              <a:gdLst/>
-              <a:ahLst/>
-              <a:cxnLst/>
-              <a:rect r="r" b="b" t="t" l="l"/>
-              <a:pathLst>
-                <a:path h="3028120" w="5734099">
-                  <a:moveTo>
-                    <a:pt x="63500" y="74930"/>
-                  </a:moveTo>
-                  <a:cubicBezTo>
-                    <a:pt x="91440" y="30480"/>
-                    <a:pt x="140970" y="0"/>
-                    <a:pt x="216920" y="0"/>
-                  </a:cubicBezTo>
-                  <a:lnTo>
-                    <a:pt x="5575349" y="0"/>
-                  </a:lnTo>
-                  <a:cubicBezTo>
-                    <a:pt x="5662979" y="0"/>
-                    <a:pt x="5734099" y="71120"/>
-                    <a:pt x="5734099" y="158750"/>
-                  </a:cubicBezTo>
-                  <a:lnTo>
-                    <a:pt x="5734099" y="2826190"/>
-                  </a:lnTo>
-                  <a:cubicBezTo>
-                    <a:pt x="5734099" y="2878260"/>
-                    <a:pt x="5708699" y="2923980"/>
-                    <a:pt x="5670599" y="2953190"/>
-                  </a:cubicBezTo>
-                  <a:cubicBezTo>
-                    <a:pt x="5642659" y="2997640"/>
-                    <a:pt x="5593129" y="3028120"/>
-                    <a:pt x="5535979" y="3028120"/>
-                  </a:cubicBezTo>
-                  <a:lnTo>
-                    <a:pt x="158750" y="3028120"/>
-                  </a:lnTo>
-                  <a:cubicBezTo>
-                    <a:pt x="71120" y="3028120"/>
-                    <a:pt x="0" y="2957000"/>
-                    <a:pt x="0" y="2869370"/>
-                  </a:cubicBezTo>
-                  <a:lnTo>
-                    <a:pt x="0" y="208926"/>
-                  </a:lnTo>
-                  <a:cubicBezTo>
-                    <a:pt x="0" y="149860"/>
-                    <a:pt x="25400" y="104140"/>
-                    <a:pt x="63500" y="74930"/>
-                  </a:cubicBezTo>
-                  <a:close/>
-                  <a:moveTo>
-                    <a:pt x="5721399" y="2826190"/>
-                  </a:moveTo>
-                  <a:lnTo>
-                    <a:pt x="5721399" y="158750"/>
-                  </a:lnTo>
-                  <a:cubicBezTo>
-                    <a:pt x="5721399" y="78740"/>
-                    <a:pt x="5655359" y="12700"/>
-                    <a:pt x="5575349" y="12700"/>
-                  </a:cubicBezTo>
-                  <a:lnTo>
-                    <a:pt x="216920" y="12700"/>
-                  </a:lnTo>
-                  <a:cubicBezTo>
-                    <a:pt x="118110" y="12700"/>
-                    <a:pt x="52070" y="78740"/>
-                    <a:pt x="52070" y="158750"/>
-                  </a:cubicBezTo>
-                  <a:lnTo>
-                    <a:pt x="52070" y="2826190"/>
-                  </a:lnTo>
-                  <a:cubicBezTo>
-                    <a:pt x="52070" y="2906200"/>
-                    <a:pt x="118110" y="2972240"/>
-                    <a:pt x="216920" y="2972240"/>
-                  </a:cubicBezTo>
-                  <a:lnTo>
-                    <a:pt x="5575349" y="2972240"/>
-                  </a:lnTo>
-                  <a:cubicBezTo>
-                    <a:pt x="5655359" y="2972240"/>
-                    <a:pt x="5721399" y="2907470"/>
-                    <a:pt x="5721399" y="2826190"/>
-                  </a:cubicBezTo>
-                  <a:close/>
-                </a:path>
-              </a:pathLst>
-            </a:custGeom>
-            <a:solidFill>
-              <a:srgbClr val="C9A84C"/>
-            </a:solidFill>
-          </p:spPr>
-        </p:sp>
-      </p:grpSp>
-      <p:sp>
-        <p:nvSpPr>
-          <p:cNvPr name="TextBox 5" id="5"/>
-          <p:cNvSpPr txBox="true"/>
-          <p:nvPr/>
-        </p:nvSpPr>
-        <p:spPr>
-          <a:xfrm rot="0">
-            <a:off x="2105025" y="4743450"/>
-            <a:ext cx="6886575" cy="1207770"/>
-          </a:xfrm>
-          <a:prstGeom prst="rect">
-            <a:avLst/>
-          </a:prstGeom>
-        </p:spPr>
-        <p:txBody>
-          <a:bodyPr anchor="t" rtlCol="false" tIns="0" lIns="0" bIns="0" rIns="0">
-            <a:spAutoFit/>
-          </a:bodyPr>
-          <a:lstStyle/>
-          <a:p>
-            <a:pPr algn="ctr" rtl="true" marL="0" indent="0" lvl="0">
-              <a:lnSpc>
-                <a:spcPts val="3120"/>
-              </a:lnSpc>
-            </a:pPr>
-            <a:r>
-              <a:rPr lang="ar-EG" sz="2400">
-                <a:solidFill>
-                  <a:srgbClr val="F3E5B8"/>
-                </a:solidFill>
-                <a:latin typeface="Codec Pro"/>
-                <a:ea typeface="Codec Pro"/>
-                <a:cs typeface="Codec Pro"/>
-                <a:sym typeface="Codec Pro"/>
-                <a:rtl val="true"/>
-              </a:rPr>
-              <a:t>ستتوسع بوابة الجود الرقمية على ثلاث مراحل، لتشمل ميزات جديدة لإشراك ولي الأمر وتعزيز تجربة التعليم.</a:t>
-            </a:r>
-          </a:p>
-        </p:txBody>
-      </p:sp>
-      <p:sp>
-        <p:nvSpPr>
-          <p:cNvPr name="Freeform 6" id="6"/>
-          <p:cNvSpPr/>
-          <p:nvPr/>
-        </p:nvSpPr>
-        <p:spPr>
-          <a:xfrm flipH="true" flipV="false" rot="0">
-            <a:off x="10486143" y="2216792"/>
-            <a:ext cx="5696832" cy="5911807"/>
-          </a:xfrm>
-          <a:custGeom>
-            <a:avLst/>
-            <a:gdLst/>
-            <a:ahLst/>
-            <a:cxnLst/>
-            <a:rect r="r" b="b" t="t" l="l"/>
-            <a:pathLst>
-              <a:path h="5911807" w="5696832">
-                <a:moveTo>
-                  <a:pt x="5696832" y="0"/>
-                </a:moveTo>
-                <a:lnTo>
-                  <a:pt x="0" y="0"/>
-                </a:lnTo>
-                <a:lnTo>
-                  <a:pt x="0" y="5911807"/>
-                </a:lnTo>
-                <a:lnTo>
-                  <a:pt x="5696832" y="5911807"/>
-                </a:lnTo>
-                <a:lnTo>
-                  <a:pt x="5696832" y="0"/>
-                </a:lnTo>
-                <a:close/>
-              </a:path>
-            </a:pathLst>
-          </a:custGeom>
-          <a:blipFill>
-            <a:blip r:embed="rId2">
-              <a:extLst>
-                <a:ext uri="{96DAC541-7B7A-43D3-8B79-37D633B846F1}">
-                  <asvg:svgBlip xmlns:asvg="http://schemas.microsoft.com/office/drawing/2016/SVG/main" r:embed="rId3"/>
-                </a:ext>
-              </a:extLst>
-            </a:blip>
-            <a:stretch>
-              <a:fillRect l="0" t="0" r="0" b="0"/>
-            </a:stretch>
-          </a:blipFill>
-          <a:ln cap="sq">
-            <a:noFill/>
-            <a:prstDash val="solid"/>
-            <a:miter/>
-          </a:ln>
-        </p:spPr>
-      </p:sp>
-      <p:sp>
-        <p:nvSpPr>
-          <p:cNvPr name="Freeform 7" id="7"/>
-          <p:cNvSpPr/>
-          <p:nvPr/>
-        </p:nvSpPr>
-        <p:spPr>
-          <a:xfrm flipH="false" flipV="false" rot="0">
-            <a:off x="10546645" y="2306609"/>
-            <a:ext cx="4485772" cy="4485772"/>
-          </a:xfrm>
-          <a:custGeom>
-            <a:avLst/>
-            <a:gdLst/>
-            <a:ahLst/>
-            <a:cxnLst/>
-            <a:rect r="r" b="b" t="t" l="l"/>
-            <a:pathLst>
-              <a:path h="4485772" w="4485772">
-                <a:moveTo>
-                  <a:pt x="0" y="0"/>
-                </a:moveTo>
-                <a:lnTo>
-                  <a:pt x="4485772" y="0"/>
-                </a:lnTo>
-                <a:lnTo>
-                  <a:pt x="4485772" y="4485772"/>
-                </a:lnTo>
-                <a:lnTo>
-                  <a:pt x="0" y="4485772"/>
-                </a:lnTo>
-                <a:lnTo>
-                  <a:pt x="0" y="0"/>
-                </a:lnTo>
-                <a:close/>
-              </a:path>
-            </a:pathLst>
-          </a:custGeom>
-          <a:blipFill>
-            <a:blip r:embed="rId4"/>
-            <a:stretch>
-              <a:fillRect l="0" t="0" r="0" b="0"/>
-            </a:stretch>
-          </a:blipFill>
-        </p:spPr>
-      </p:sp>
-      <p:sp>
-        <p:nvSpPr>
-          <p:cNvPr name="TextBox 8" id="8"/>
-          <p:cNvSpPr txBox="true"/>
-          <p:nvPr/>
-        </p:nvSpPr>
-        <p:spPr>
-          <a:xfrm rot="0">
-            <a:off x="1740532" y="2713074"/>
-            <a:ext cx="7615560" cy="1836421"/>
-          </a:xfrm>
-          <a:prstGeom prst="rect">
-            <a:avLst/>
-          </a:prstGeom>
-        </p:spPr>
-        <p:txBody>
-          <a:bodyPr anchor="t" rtlCol="false" tIns="0" lIns="0" bIns="0" rIns="0">
-            <a:spAutoFit/>
-          </a:bodyPr>
-          <a:lstStyle/>
-          <a:p>
-            <a:pPr algn="ctr" rtl="true" marL="0" indent="0" lvl="0">
-              <a:lnSpc>
-                <a:spcPts val="7019"/>
-              </a:lnSpc>
-            </a:pPr>
-            <a:r>
-              <a:rPr lang="ar-EG" b="true" sz="5399">
-                <a:solidFill>
-                  <a:srgbClr val="F3E5B8"/>
-                </a:solidFill>
-                <a:latin typeface="Codec Pro Bold"/>
-                <a:ea typeface="Codec Pro Bold"/>
-                <a:cs typeface="Codec Pro Bold"/>
-                <a:sym typeface="Codec Pro Bold"/>
-                <a:rtl val="true"/>
-              </a:rPr>
-              <a:t>خارطة الطريق لتوسيع بوابة الجود الرقمية</a:t>
-            </a:r>
-          </a:p>
-        </p:txBody>
-      </p:sp>
-    </p:spTree>
-  </p:cSld>
-  <p:clrMapOvr>
-    <a:masterClrMapping/>
-  </p:clrMapOvr>
-</p:sld>
-</file>
-
-<file path=ppt/slides/slide9.xml><?xml version="1.0" encoding="utf-8"?>
-<p:sld xmlns:p="http://schemas.openxmlformats.org/presentationml/2006/main" xmlns:a="http://schemas.openxmlformats.org/drawingml/2006/main" xmlns:r="http://schemas.openxmlformats.org/officeDocument/2006/relationships">
-  <p:cSld>
-    <p:bg>
-      <p:bgPr>
-        <a:solidFill>
-          <a:srgbClr val="1A2A4A"/>
-        </a:solidFill>
-      </p:bgPr>
-    </p:bg>
-    <p:spTree>
-      <p:nvGrpSpPr>
-        <p:cNvPr id="1" name=""/>
-        <p:cNvGrpSpPr/>
-        <p:nvPr/>
-      </p:nvGrpSpPr>
-      <p:grpSpPr>
-        <a:xfrm>
-          <a:off x="0" y="0"/>
-          <a:ext cx="0" cy="0"/>
-          <a:chOff x="0" y="0"/>
-          <a:chExt cx="0" cy="0"/>
-        </a:xfrm>
-      </p:grpSpPr>
-      <p:grpSp>
-        <p:nvGrpSpPr>
-          <p:cNvPr name="Group 2" id="2"/>
-          <p:cNvGrpSpPr/>
-          <p:nvPr/>
-        </p:nvGrpSpPr>
-        <p:grpSpPr>
-          <a:xfrm rot="0">
-            <a:off x="666750" y="666750"/>
-            <a:ext cx="16954500" cy="8953500"/>
-            <a:chOff x="0" y="0"/>
-            <a:chExt cx="5734099" cy="3028120"/>
-          </a:xfrm>
-        </p:grpSpPr>
-        <p:sp>
-          <p:nvSpPr>
-            <p:cNvPr name="Freeform 3" id="3"/>
-            <p:cNvSpPr/>
-            <p:nvPr/>
-          </p:nvSpPr>
-          <p:spPr>
-            <a:xfrm flipH="false" flipV="false" rot="0">
-              <a:off x="52070" y="12700"/>
-              <a:ext cx="5669329" cy="2959540"/>
-            </a:xfrm>
-            <a:custGeom>
-              <a:avLst/>
-              <a:gdLst/>
-              <a:ahLst/>
-              <a:cxnLst/>
-              <a:rect r="r" b="b" t="t" l="l"/>
-              <a:pathLst>
-                <a:path h="2959540" w="5669329">
-                  <a:moveTo>
-                    <a:pt x="5523279" y="2959540"/>
-                  </a:moveTo>
-                  <a:lnTo>
-                    <a:pt x="164850" y="2959540"/>
-                  </a:lnTo>
-                  <a:cubicBezTo>
-                    <a:pt x="66040" y="2959540"/>
-                    <a:pt x="0" y="2893500"/>
-                    <a:pt x="0" y="2813490"/>
-                  </a:cubicBezTo>
-                  <a:lnTo>
-                    <a:pt x="0" y="146050"/>
-                  </a:lnTo>
-                  <a:cubicBezTo>
-                    <a:pt x="0" y="66040"/>
-                    <a:pt x="66040" y="0"/>
-                    <a:pt x="164850" y="0"/>
-                  </a:cubicBezTo>
-                  <a:lnTo>
-                    <a:pt x="5523279" y="0"/>
-                  </a:lnTo>
-                  <a:cubicBezTo>
-                    <a:pt x="5603289" y="0"/>
-                    <a:pt x="5669329" y="66040"/>
-                    <a:pt x="5669329" y="146050"/>
-                  </a:cubicBezTo>
-                  <a:lnTo>
-                    <a:pt x="5669329" y="2813490"/>
-                  </a:lnTo>
-                  <a:cubicBezTo>
-                    <a:pt x="5669329" y="2894770"/>
-                    <a:pt x="5603289" y="2959540"/>
-                    <a:pt x="5523279" y="2959540"/>
-                  </a:cubicBezTo>
-                  <a:close/>
-                </a:path>
-              </a:pathLst>
-            </a:custGeom>
-            <a:solidFill>
-              <a:srgbClr val="021633"/>
-            </a:solidFill>
-          </p:spPr>
-        </p:sp>
-        <p:sp>
-          <p:nvSpPr>
-            <p:cNvPr name="Freeform 4" id="4"/>
-            <p:cNvSpPr/>
-            <p:nvPr/>
-          </p:nvSpPr>
-          <p:spPr>
-            <a:xfrm flipH="false" flipV="false" rot="0">
-              <a:off x="0" y="0"/>
-              <a:ext cx="5734099" cy="3028120"/>
-            </a:xfrm>
-            <a:custGeom>
-              <a:avLst/>
-              <a:gdLst/>
-              <a:ahLst/>
-              <a:cxnLst/>
-              <a:rect r="r" b="b" t="t" l="l"/>
-              <a:pathLst>
-                <a:path h="3028120" w="5734099">
-                  <a:moveTo>
-                    <a:pt x="63500" y="74930"/>
-                  </a:moveTo>
-                  <a:cubicBezTo>
-                    <a:pt x="91440" y="30480"/>
-                    <a:pt x="140970" y="0"/>
-                    <a:pt x="216920" y="0"/>
-                  </a:cubicBezTo>
-                  <a:lnTo>
-                    <a:pt x="5575349" y="0"/>
-                  </a:lnTo>
-                  <a:cubicBezTo>
-                    <a:pt x="5662979" y="0"/>
-                    <a:pt x="5734099" y="71120"/>
-                    <a:pt x="5734099" y="158750"/>
-                  </a:cubicBezTo>
-                  <a:lnTo>
-                    <a:pt x="5734099" y="2826190"/>
-                  </a:lnTo>
-                  <a:cubicBezTo>
-                    <a:pt x="5734099" y="2878260"/>
-                    <a:pt x="5708699" y="2923980"/>
-                    <a:pt x="5670599" y="2953190"/>
-                  </a:cubicBezTo>
-                  <a:cubicBezTo>
-                    <a:pt x="5642659" y="2997640"/>
-                    <a:pt x="5593129" y="3028120"/>
-                    <a:pt x="5535979" y="3028120"/>
-                  </a:cubicBezTo>
-                  <a:lnTo>
-                    <a:pt x="158750" y="3028120"/>
-                  </a:lnTo>
-                  <a:cubicBezTo>
-                    <a:pt x="71120" y="3028120"/>
-                    <a:pt x="0" y="2957000"/>
-                    <a:pt x="0" y="2869370"/>
-                  </a:cubicBezTo>
-                  <a:lnTo>
-                    <a:pt x="0" y="208926"/>
-                  </a:lnTo>
-                  <a:cubicBezTo>
-                    <a:pt x="0" y="149860"/>
-                    <a:pt x="25400" y="104140"/>
-                    <a:pt x="63500" y="74930"/>
-                  </a:cubicBezTo>
-                  <a:close/>
-                  <a:moveTo>
-                    <a:pt x="5721399" y="2826190"/>
-                  </a:moveTo>
-                  <a:lnTo>
-                    <a:pt x="5721399" y="158750"/>
-                  </a:lnTo>
-                  <a:cubicBezTo>
-                    <a:pt x="5721399" y="78740"/>
-                    <a:pt x="5655359" y="12700"/>
-                    <a:pt x="5575349" y="12700"/>
-                  </a:cubicBezTo>
-                  <a:lnTo>
-                    <a:pt x="216920" y="12700"/>
-                  </a:lnTo>
-                  <a:cubicBezTo>
-                    <a:pt x="118110" y="12700"/>
-                    <a:pt x="52070" y="78740"/>
-                    <a:pt x="52070" y="158750"/>
-                  </a:cubicBezTo>
-                  <a:lnTo>
-                    <a:pt x="52070" y="2826190"/>
-                  </a:lnTo>
-                  <a:cubicBezTo>
-                    <a:pt x="52070" y="2906200"/>
-                    <a:pt x="118110" y="2972240"/>
-                    <a:pt x="216920" y="2972240"/>
-                  </a:cubicBezTo>
-                  <a:lnTo>
-                    <a:pt x="5575349" y="2972240"/>
-                  </a:lnTo>
-                  <a:cubicBezTo>
-                    <a:pt x="5655359" y="2972240"/>
-                    <a:pt x="5721399" y="2907470"/>
-                    <a:pt x="5721399" y="2826190"/>
-                  </a:cubicBezTo>
-                  <a:close/>
-                </a:path>
-              </a:pathLst>
-            </a:custGeom>
-            <a:solidFill>
-              <a:srgbClr val="C9A84C"/>
-            </a:solidFill>
-          </p:spPr>
-        </p:sp>
-      </p:grpSp>
-      <p:sp>
-        <p:nvSpPr>
-          <p:cNvPr name="TextBox 5" id="5"/>
-          <p:cNvSpPr txBox="true"/>
-          <p:nvPr/>
-        </p:nvSpPr>
-        <p:spPr>
-          <a:xfrm rot="0">
-            <a:off x="2105025" y="3629025"/>
-            <a:ext cx="6886575" cy="876300"/>
-          </a:xfrm>
-          <a:prstGeom prst="rect">
-            <a:avLst/>
-          </a:prstGeom>
-        </p:spPr>
-        <p:txBody>
-          <a:bodyPr anchor="t" rtlCol="false" tIns="0" lIns="0" bIns="0" rIns="0">
-            <a:spAutoFit/>
-          </a:bodyPr>
-          <a:lstStyle/>
-          <a:p>
-            <a:pPr algn="ctr" rtl="true" marL="0" indent="0" lvl="0">
-              <a:lnSpc>
-                <a:spcPts val="6480"/>
-              </a:lnSpc>
-            </a:pPr>
-          </a:p>
-        </p:txBody>
-      </p:sp>
-      <p:sp>
-        <p:nvSpPr>
-          <p:cNvPr name="TextBox 6" id="6"/>
-          <p:cNvSpPr txBox="true"/>
-          <p:nvPr/>
-        </p:nvSpPr>
-        <p:spPr>
-          <a:xfrm rot="0">
-            <a:off x="2105025" y="4743450"/>
-            <a:ext cx="6886575" cy="1207770"/>
-          </a:xfrm>
-          <a:prstGeom prst="rect">
-            <a:avLst/>
-          </a:prstGeom>
-        </p:spPr>
-        <p:txBody>
-          <a:bodyPr anchor="t" rtlCol="false" tIns="0" lIns="0" bIns="0" rIns="0">
-            <a:spAutoFit/>
-          </a:bodyPr>
-          <a:lstStyle/>
-          <a:p>
-            <a:pPr algn="ctr" rtl="true" marL="0" indent="0" lvl="0">
-              <a:lnSpc>
-                <a:spcPts val="3120"/>
-              </a:lnSpc>
-            </a:pPr>
-            <a:r>
-              <a:rPr lang="ar-EG" sz="2400">
-                <a:solidFill>
-                  <a:srgbClr val="F3E5B8"/>
-                </a:solidFill>
-                <a:latin typeface="Codec Pro"/>
-                <a:ea typeface="Codec Pro"/>
-                <a:cs typeface="Codec Pro"/>
-                <a:sym typeface="Codec Pro"/>
-                <a:rtl val="true"/>
-              </a:rPr>
-              <a:t>نقدم نموذجاً مبتكراً يسهم في </a:t>
-            </a:r>
-            <a:r>
-              <a:rPr lang="ar-EG" b="true" sz="2400">
-                <a:solidFill>
-                  <a:srgbClr val="F3E5B8"/>
-                </a:solidFill>
-                <a:latin typeface="Codec Pro Bold"/>
-                <a:ea typeface="Codec Pro Bold"/>
-                <a:cs typeface="Codec Pro Bold"/>
-                <a:sym typeface="Codec Pro Bold"/>
-                <a:rtl val="true"/>
-              </a:rPr>
-              <a:t>تحقيق رؤية الإمارات </a:t>
-            </a:r>
-            <a:r>
-              <a:rPr lang="en-US" b="true" sz="2400">
-                <a:solidFill>
-                  <a:srgbClr val="F3E5B8"/>
-                </a:solidFill>
-                <a:latin typeface="Codec Pro Bold"/>
-                <a:ea typeface="Codec Pro Bold"/>
-                <a:cs typeface="Codec Pro Bold"/>
-                <a:sym typeface="Codec Pro Bold"/>
-              </a:rPr>
-              <a:t>2071</a:t>
-            </a:r>
-            <a:r>
-              <a:rPr lang="ar-EG" sz="2400">
-                <a:solidFill>
-                  <a:srgbClr val="F3E5B8"/>
-                </a:solidFill>
-                <a:latin typeface="Codec Pro"/>
-                <a:ea typeface="Codec Pro"/>
-                <a:cs typeface="Codec Pro"/>
-                <a:sym typeface="Codec Pro"/>
-                <a:rtl val="true"/>
-              </a:rPr>
-              <a:t>، ويعزز التعليم الذكي والمستدام لكافة المدارس.</a:t>
-            </a:r>
-          </a:p>
-        </p:txBody>
-      </p:sp>
-      <p:sp>
-        <p:nvSpPr>
-          <p:cNvPr name="Freeform 7" id="7"/>
-          <p:cNvSpPr/>
-          <p:nvPr/>
-        </p:nvSpPr>
-        <p:spPr>
-          <a:xfrm flipH="true" flipV="false" rot="0">
-            <a:off x="10486143" y="2216792"/>
-            <a:ext cx="5696832" cy="5911807"/>
-          </a:xfrm>
-          <a:custGeom>
-            <a:avLst/>
-            <a:gdLst/>
-            <a:ahLst/>
-            <a:cxnLst/>
-            <a:rect r="r" b="b" t="t" l="l"/>
-            <a:pathLst>
-              <a:path h="5911807" w="5696832">
-                <a:moveTo>
-                  <a:pt x="5696832" y="0"/>
-                </a:moveTo>
-                <a:lnTo>
-                  <a:pt x="0" y="0"/>
-                </a:lnTo>
-                <a:lnTo>
-                  <a:pt x="0" y="5911807"/>
-                </a:lnTo>
-                <a:lnTo>
-                  <a:pt x="5696832" y="5911807"/>
-                </a:lnTo>
-                <a:lnTo>
-                  <a:pt x="5696832" y="0"/>
-                </a:lnTo>
-                <a:close/>
-              </a:path>
-            </a:pathLst>
-          </a:custGeom>
-          <a:blipFill>
-            <a:blip r:embed="rId2">
-              <a:extLst>
-                <a:ext uri="{96DAC541-7B7A-43D3-8B79-37D633B846F1}">
-                  <asvg:svgBlip xmlns:asvg="http://schemas.microsoft.com/office/drawing/2016/SVG/main" r:embed="rId3"/>
-                </a:ext>
-              </a:extLst>
-            </a:blip>
-            <a:stretch>
-              <a:fillRect l="0" t="0" r="0" b="0"/>
-            </a:stretch>
-          </a:blipFill>
-          <a:ln cap="sq">
-            <a:noFill/>
-            <a:prstDash val="solid"/>
-            <a:miter/>
-          </a:ln>
-        </p:spPr>
-      </p:sp>
-      <p:sp>
-        <p:nvSpPr>
-          <p:cNvPr name="Freeform 8" id="8"/>
-          <p:cNvSpPr/>
-          <p:nvPr/>
-        </p:nvSpPr>
-        <p:spPr>
-          <a:xfrm flipH="false" flipV="false" rot="0">
-            <a:off x="10546645" y="2306609"/>
-            <a:ext cx="4485772" cy="4485772"/>
-          </a:xfrm>
-          <a:custGeom>
-            <a:avLst/>
-            <a:gdLst/>
-            <a:ahLst/>
-            <a:cxnLst/>
-            <a:rect r="r" b="b" t="t" l="l"/>
-            <a:pathLst>
-              <a:path h="4485772" w="4485772">
-                <a:moveTo>
-                  <a:pt x="0" y="0"/>
-                </a:moveTo>
-                <a:lnTo>
-                  <a:pt x="4485772" y="0"/>
-                </a:lnTo>
-                <a:lnTo>
-                  <a:pt x="4485772" y="4485772"/>
-                </a:lnTo>
-                <a:lnTo>
-                  <a:pt x="0" y="4485772"/>
-                </a:lnTo>
-                <a:lnTo>
-                  <a:pt x="0" y="0"/>
-                </a:lnTo>
-                <a:close/>
-              </a:path>
-            </a:pathLst>
-          </a:custGeom>
-          <a:blipFill>
-            <a:blip r:embed="rId4"/>
-            <a:stretch>
-              <a:fillRect l="0" t="0" r="0" b="0"/>
-            </a:stretch>
-          </a:blipFill>
-        </p:spPr>
-      </p:sp>
-      <p:sp>
-        <p:nvSpPr>
-          <p:cNvPr name="TextBox 9" id="9"/>
-          <p:cNvSpPr txBox="true"/>
-          <p:nvPr/>
-        </p:nvSpPr>
-        <p:spPr>
-          <a:xfrm rot="0">
-            <a:off x="1740532" y="2713074"/>
-            <a:ext cx="7615560" cy="1836421"/>
-          </a:xfrm>
-          <a:prstGeom prst="rect">
-            <a:avLst/>
-          </a:prstGeom>
-        </p:spPr>
-        <p:txBody>
-          <a:bodyPr anchor="t" rtlCol="false" tIns="0" lIns="0" bIns="0" rIns="0">
-            <a:spAutoFit/>
-          </a:bodyPr>
-          <a:lstStyle/>
-          <a:p>
-            <a:pPr algn="ctr" rtl="true" marL="0" indent="0" lvl="0">
-              <a:lnSpc>
-                <a:spcPts val="7019"/>
-              </a:lnSpc>
-            </a:pPr>
-            <a:r>
-              <a:rPr lang="ar-EG" b="true" sz="5399">
-                <a:solidFill>
-                  <a:srgbClr val="F3E5B8"/>
-                </a:solidFill>
-                <a:latin typeface="Codec Pro Bold"/>
-                <a:ea typeface="Codec Pro Bold"/>
-                <a:cs typeface="Codec Pro Bold"/>
-                <a:sym typeface="Codec Pro Bold"/>
-                <a:rtl val="true"/>
-              </a:rPr>
-              <a:t>رؤية مستقبلية للتعليم في الإمارات</a:t>
             </a:r>
           </a:p>
         </p:txBody>

</xml_diff>

<commit_message>
fix: law slides - navy theme, larger text, stat boxes, visual comparison table
</commit_message>
<xml_diff>
--- a/assets/aljood_pitch_with_law.pptx
+++ b/assets/aljood_pitch_with_law.pptx
@@ -5922,355 +5922,57 @@
       </p:grpSp>
       <p:sp>
         <p:nvSpPr>
-          <p:cNvPr name="Freeform 5" id="5"/>
+          <p:cNvPr id="5" name="Rectangle 4"/>
           <p:cNvSpPr/>
           <p:nvPr/>
         </p:nvSpPr>
         <p:spPr>
-          <a:xfrm flipH="true" flipV="false" rot="0">
-            <a:off x="10486143" y="2216792"/>
-            <a:ext cx="5696832" cy="5911807"/>
-          </a:xfrm>
-          <a:custGeom>
-            <a:avLst/>
-            <a:gdLst/>
-            <a:ahLst/>
-            <a:cxnLst/>
-            <a:rect r="r" b="b" t="t" l="l"/>
-            <a:pathLst>
-              <a:path h="5911807" w="5696832">
-                <a:moveTo>
-                  <a:pt x="5696832" y="0"/>
-                </a:moveTo>
-                <a:lnTo>
-                  <a:pt x="0" y="0"/>
-                </a:lnTo>
-                <a:lnTo>
-                  <a:pt x="0" y="5911807"/>
-                </a:lnTo>
-                <a:lnTo>
-                  <a:pt x="5696832" y="5911807"/>
-                </a:lnTo>
-                <a:lnTo>
-                  <a:pt x="5696832" y="0"/>
-                </a:lnTo>
-                <a:close/>
-              </a:path>
-            </a:pathLst>
-          </a:custGeom>
-          <a:blipFill>
-            <a:blip r:embed="rId2">
-              <a:extLst>
-                <a:ext uri="{96DAC541-7B7A-43D3-8B79-37D633B846F1}">
-                  <asvg:svgBlip xmlns:asvg="http://schemas.microsoft.com/office/drawing/2016/SVG/main" r:embed="rId3"/>
-                </a:ext>
-              </a:extLst>
-            </a:blip>
-            <a:stretch>
-              <a:fillRect l="0" t="0" r="0" b="0"/>
-            </a:stretch>
-          </a:blipFill>
-          <a:ln cap="sq">
-            <a:noFill/>
-            <a:prstDash val="solid"/>
-            <a:miter/>
-          </a:ln>
-        </p:spPr>
-      </p:sp>
-      <p:sp>
-        <p:nvSpPr>
-          <p:cNvPr name="Freeform 6" id="6"/>
-          <p:cNvSpPr/>
-          <p:nvPr/>
-        </p:nvSpPr>
-        <p:spPr>
-          <a:xfrm flipH="false" flipV="false" rot="0">
-            <a:off x="10546645" y="2306609"/>
-            <a:ext cx="4485772" cy="4485772"/>
-          </a:xfrm>
-          <a:custGeom>
-            <a:avLst/>
-            <a:gdLst/>
-            <a:ahLst/>
-            <a:cxnLst/>
-            <a:rect r="r" b="b" t="t" l="l"/>
-            <a:pathLst>
-              <a:path h="4485772" w="4485772">
-                <a:moveTo>
-                  <a:pt x="0" y="0"/>
-                </a:moveTo>
-                <a:lnTo>
-                  <a:pt x="4485772" y="0"/>
-                </a:lnTo>
-                <a:lnTo>
-                  <a:pt x="4485772" y="4485772"/>
-                </a:lnTo>
-                <a:lnTo>
-                  <a:pt x="0" y="4485772"/>
-                </a:lnTo>
-                <a:lnTo>
-                  <a:pt x="0" y="0"/>
-                </a:lnTo>
-                <a:close/>
-              </a:path>
-            </a:pathLst>
-          </a:custGeom>
-          <a:blipFill>
-            <a:blip r:embed="rId4"/>
-            <a:stretch>
-              <a:fillRect l="0" t="0" r="0" b="0"/>
-            </a:stretch>
-          </a:blipFill>
-        </p:spPr>
-      </p:sp>
-      <p:sp>
-        <p:nvSpPr>
-          <p:cNvPr name="TextBox 7" id="7"/>
-          <p:cNvSpPr txBox="true"/>
-          <p:nvPr/>
-        </p:nvSpPr>
-        <p:spPr>
-          <a:xfrm rot="0">
-            <a:off x="2105025" y="5348287"/>
-            <a:ext cx="6886575" cy="817245"/>
+          <a:xfrm>
+            <a:off x="432000" y="540000"/>
+            <a:ext cx="17424000" cy="9387000"/>
           </a:xfrm>
           <a:prstGeom prst="rect">
             <a:avLst/>
           </a:prstGeom>
+          <a:solidFill>
+            <a:srgbClr val="0F1D35"/>
+          </a:solidFill>
+          <a:ln>
+            <a:noFill/>
+          </a:ln>
         </p:spPr>
-        <p:txBody>
-          <a:bodyPr anchor="t" rtlCol="false" tIns="0" lIns="0" bIns="0" rIns="0">
-            <a:spAutoFit/>
-          </a:bodyPr>
-          <a:lstStyle/>
-          <a:p>
-            <a:pPr algn="ctr" rtl="true" marL="0" indent="0" lvl="0">
-              <a:lnSpc>
-                <a:spcPts val="3120"/>
-              </a:lnSpc>
-            </a:pPr>
-            <a:r>
-              <a:rPr lang="ar-SA" dirty="0" sz="1900">
-                <a:solidFill>
-                  <a:srgbClr val="FFFFFF"/>
-                </a:solidFill>
-                <a:latin typeface="Noto Sans Arabic"/>
-                <a:ea typeface="Noto Sans Arabic"/>
-              </a:rPr>
-              <a:t>صدر المرسوم الاتحادي رقم (2) لسنة 2026 في يناير 2026</a:t>
-            </a:r>
-          </a:p>
-          <a:p>
-            <a:pPr algn="ctr" rtl="true" marL="0" indent="0" lvl="0">
-              <a:lnSpc>
-                <a:spcPts val="3120"/>
-              </a:lnSpc>
-            </a:pPr>
-            <a:r>
-              <a:rPr lang="ar-SA" dirty="0" sz="1900">
-                <a:solidFill>
-                  <a:srgbClr val="FFFFFF"/>
-                </a:solidFill>
-                <a:latin typeface="Noto Sans Arabic"/>
-                <a:ea typeface="Noto Sans Arabic"/>
-              </a:rPr>
-              <a:t>يُلزم المدارس بتنظيم الوصول الرقمي وحماية بيانات الطلاب</a:t>
-            </a:r>
-          </a:p>
-          <a:p>
-            <a:pPr algn="ctr" rtl="true" marL="0" indent="0" lvl="0">
-              <a:lnSpc>
-                <a:spcPts val="3120"/>
-              </a:lnSpc>
-            </a:pPr>
-            <a:r>
-              <a:rPr lang="ar-SA" dirty="0" sz="1900">
-                <a:solidFill>
-                  <a:srgbClr val="FFFFFF"/>
-                </a:solidFill>
-                <a:latin typeface="Noto Sans Arabic"/>
-                <a:ea typeface="Noto Sans Arabic"/>
-              </a:rPr>
-              <a:t>يشترط توثيق هوية المستخدمين وضبط صلاحيات الوصول بدقة</a:t>
-            </a:r>
-          </a:p>
-          <a:p>
-            <a:pPr algn="ctr" rtl="true" marL="0" indent="0" lvl="0">
-              <a:lnSpc>
-                <a:spcPts val="3120"/>
-              </a:lnSpc>
-            </a:pPr>
-            <a:r>
-              <a:rPr lang="ar-SA" dirty="0" sz="1900">
-                <a:solidFill>
-                  <a:srgbClr val="FFFFFF"/>
-                </a:solidFill>
-                <a:latin typeface="Noto Sans Arabic"/>
-                <a:ea typeface="Noto Sans Arabic"/>
-              </a:rPr>
-              <a:t>يُوجب توفير أدوات رقابة لأولياء الأمور على النشاط الرقمي</a:t>
-            </a:r>
-          </a:p>
-          <a:p>
-            <a:pPr algn="ctr" rtl="true" marL="0" indent="0" lvl="0">
-              <a:lnSpc>
-                <a:spcPts val="3120"/>
-              </a:lnSpc>
-            </a:pPr>
-            <a:r>
-              <a:rPr lang="ar-SA" dirty="0" sz="1900">
-                <a:solidFill>
-                  <a:srgbClr val="FFFFFF"/>
-                </a:solidFill>
-                <a:latin typeface="Noto Sans Arabic"/>
-                <a:ea typeface="Noto Sans Arabic"/>
-              </a:rPr>
-              <a:t>يُلزم بالإبلاغ عن أي اختراق لخصوصية البيانات الرقمية للطفل</a:t>
-            </a:r>
-          </a:p>
-        </p:txBody>
-      </p:sp>
-      <p:sp>
-        <p:nvSpPr>
-          <p:cNvPr name="TextBox 8" id="8"/>
-          <p:cNvSpPr txBox="true"/>
-          <p:nvPr/>
-        </p:nvSpPr>
-        <p:spPr>
-          <a:xfrm rot="0">
-            <a:off x="1414462" y="3330508"/>
-            <a:ext cx="8267700" cy="1812992"/>
-          </a:xfrm>
-          <a:prstGeom prst="rect">
-            <a:avLst/>
-          </a:prstGeom>
-        </p:spPr>
-        <p:txBody>
-          <a:bodyPr anchor="t" rtlCol="false" tIns="0" lIns="0" bIns="0" rIns="0">
-            <a:spAutoFit/>
-          </a:bodyPr>
-          <a:lstStyle/>
-          <a:p>
-            <a:pPr algn="ctr" rtl="true" marL="0" indent="0" lvl="0">
-              <a:lnSpc>
-                <a:spcPts val="6861"/>
-              </a:lnSpc>
-              <a:spcBef>
-                <a:spcPct val="0"/>
-              </a:spcBef>
-            </a:pPr>
-            <a:r>
-              <a:rPr lang="ar-SA" dirty="0" b="1" sz="3000">
-                <a:solidFill>
-                  <a:srgbClr val="C9A84C"/>
-                </a:solidFill>
-                <a:latin typeface="Noto Sans Arabic"/>
-                <a:ea typeface="Noto Sans Arabic"/>
-              </a:rPr>
-              <a:t>السياق الوطني: قانون سلامة الطفل الرقمي</a:t>
-            </a:r>
-          </a:p>
-          <a:p>
-            <a:pPr algn="ctr" rtl="true" marL="0" indent="0" lvl="0">
-              <a:lnSpc>
-                <a:spcPts val="6861"/>
-              </a:lnSpc>
-              <a:spcBef>
-                <a:spcPct val="0"/>
-              </a:spcBef>
-            </a:pPr>
-            <a:r>
-              <a:rPr lang="en-US" dirty="0" sz="1800">
-                <a:solidFill>
-                  <a:srgbClr val="BBBBBB"/>
-                </a:solidFill>
-                <a:latin typeface="Calibri"/>
-              </a:rPr>
-              <a:t>National Context: UAE Child Digital Safety Law — Federal Decree No. 2 / 2026</a:t>
-            </a:r>
-          </a:p>
-        </p:txBody>
-      </p:sp>
-      <p:sp>
-        <p:nvSpPr>
-          <p:cNvPr id="9" name="TextBox 8"/>
-          <p:cNvSpPr txBox="1"/>
+        <p:style>
+          <a:lnRef idx="1">
+            <a:schemeClr val="accent1"/>
+          </a:lnRef>
+          <a:fillRef idx="3">
+            <a:schemeClr val="accent1"/>
+          </a:fillRef>
+          <a:effectRef idx="2">
+            <a:schemeClr val="accent1"/>
+          </a:effectRef>
+          <a:fontRef idx="minor">
+            <a:schemeClr val="lt1"/>
+          </a:fontRef>
+        </p:style>
+        <p:txBody>
+          <a:bodyPr rtlCol="0" anchor="ctr"/>
+          <a:lstStyle/>
+          <a:p>
+            <a:pPr algn="ctr"/>
+          </a:p>
+        </p:txBody>
+      </p:sp>
+      <p:sp>
+        <p:nvSpPr>
+          <p:cNvPr id="6" name="Rectangle 5"/>
+          <p:cNvSpPr/>
           <p:nvPr/>
         </p:nvSpPr>
         <p:spPr>
           <a:xfrm>
-            <a:off x="10646645" y="2506609"/>
-            <a:ext cx="4285772" cy="500000"/>
-          </a:xfrm>
-          <a:prstGeom prst="rect">
-            <a:avLst/>
-          </a:prstGeom>
-          <a:noFill/>
-        </p:spPr>
-        <p:txBody>
-          <a:bodyPr wrap="square">
-            <a:spAutoFit/>
-          </a:bodyPr>
-          <a:lstStyle/>
-          <a:p>
-            <a:pPr algn="ctr"/>
-            <a:r>
-              <a:rPr sz="1800" b="1">
-                <a:solidFill>
-                  <a:srgbClr val="C9A84C"/>
-                </a:solidFill>
-                <a:latin typeface="Arial"/>
-              </a:rPr>
-              <a:t>أبرز أحكام القانون</a:t>
-            </a:r>
-          </a:p>
-        </p:txBody>
-      </p:sp>
-      <p:sp>
-        <p:nvSpPr>
-          <p:cNvPr id="10" name="TextBox 9"/>
-          <p:cNvSpPr txBox="1"/>
-          <p:nvPr/>
-        </p:nvSpPr>
-        <p:spPr>
-          <a:xfrm>
-            <a:off x="10646645" y="3006609"/>
-            <a:ext cx="4285772" cy="350000"/>
-          </a:xfrm>
-          <a:prstGeom prst="rect">
-            <a:avLst/>
-          </a:prstGeom>
-          <a:noFill/>
-        </p:spPr>
-        <p:txBody>
-          <a:bodyPr wrap="square">
-            <a:spAutoFit/>
-          </a:bodyPr>
-          <a:lstStyle/>
-          <a:p>
-            <a:pPr algn="ctr"/>
-            <a:r>
-              <a:rPr sz="1000" b="0">
-                <a:solidFill>
-                  <a:srgbClr val="BBCCDD"/>
-                </a:solidFill>
-                <a:latin typeface="Arial"/>
-              </a:rPr>
-              <a:t>Key Provisions of Federal Decree No. 2 / 2026</a:t>
-            </a:r>
-          </a:p>
-        </p:txBody>
-      </p:sp>
-      <p:sp>
-        <p:nvSpPr>
-          <p:cNvPr id="11" name="Rectangle 10"/>
-          <p:cNvSpPr/>
-          <p:nvPr/>
-        </p:nvSpPr>
-        <p:spPr>
-          <a:xfrm>
-            <a:off x="10846645" y="3406609"/>
-            <a:ext cx="3885772" cy="30000"/>
+            <a:off x="432000" y="540000"/>
+            <a:ext cx="17424000" cy="180000"/>
           </a:xfrm>
           <a:prstGeom prst="rect">
             <a:avLst/>
@@ -6306,14 +6008,84 @@
       </p:sp>
       <p:sp>
         <p:nvSpPr>
-          <p:cNvPr id="12" name="Rectangle 11"/>
-          <p:cNvSpPr/>
+          <p:cNvPr id="7" name="TextBox 6"/>
+          <p:cNvSpPr txBox="1"/>
           <p:nvPr/>
         </p:nvSpPr>
         <p:spPr>
           <a:xfrm>
-            <a:off x="10746645" y="3526609"/>
-            <a:ext cx="380000" cy="380000"/>
+            <a:off x="540000" y="827999"/>
+            <a:ext cx="17208000" cy="503999"/>
+          </a:xfrm>
+          <a:prstGeom prst="rect">
+            <a:avLst/>
+          </a:prstGeom>
+          <a:noFill/>
+        </p:spPr>
+        <p:txBody>
+          <a:bodyPr wrap="square">
+            <a:spAutoFit/>
+          </a:bodyPr>
+          <a:lstStyle/>
+          <a:p>
+            <a:pPr algn="ctr"/>
+            <a:r>
+              <a:rPr sz="2400" b="1">
+                <a:solidFill>
+                  <a:srgbClr val="C9A84C"/>
+                </a:solidFill>
+                <a:latin typeface="Noto Sans Arabic"/>
+              </a:rPr>
+              <a:t>السياق الوطني: قانون سلامة الطفل الرقمي</a:t>
+            </a:r>
+          </a:p>
+        </p:txBody>
+      </p:sp>
+      <p:sp>
+        <p:nvSpPr>
+          <p:cNvPr id="8" name="TextBox 7"/>
+          <p:cNvSpPr txBox="1"/>
+          <p:nvPr/>
+        </p:nvSpPr>
+        <p:spPr>
+          <a:xfrm>
+            <a:off x="540000" y="1332000"/>
+            <a:ext cx="17208000" cy="288000"/>
+          </a:xfrm>
+          <a:prstGeom prst="rect">
+            <a:avLst/>
+          </a:prstGeom>
+          <a:noFill/>
+        </p:spPr>
+        <p:txBody>
+          <a:bodyPr wrap="square">
+            <a:spAutoFit/>
+          </a:bodyPr>
+          <a:lstStyle/>
+          <a:p>
+            <a:pPr algn="ctr"/>
+            <a:r>
+              <a:rPr sz="1300" b="0">
+                <a:solidFill>
+                  <a:srgbClr val="CCCCCC"/>
+                </a:solidFill>
+                <a:latin typeface="Noto Sans Arabic"/>
+              </a:rPr>
+              <a:t>UAE Federal Decree No. 2 / 2026 — Child Digital Safety Law</a:t>
+            </a:r>
+          </a:p>
+        </p:txBody>
+      </p:sp>
+      <p:sp>
+        <p:nvSpPr>
+          <p:cNvPr id="9" name="Rectangle 8"/>
+          <p:cNvSpPr/>
+          <p:nvPr/>
+        </p:nvSpPr>
+        <p:spPr>
+          <a:xfrm>
+            <a:off x="1080000" y="1655999"/>
+            <a:ext cx="16128000" cy="21600"/>
           </a:xfrm>
           <a:prstGeom prst="rect">
             <a:avLst/>
@@ -6344,97 +6116,62 @@
           <a:lstStyle/>
           <a:p>
             <a:pPr algn="ctr"/>
-            <a:r>
-              <a:rPr sz="1400" b="1">
-                <a:solidFill>
-                  <a:srgbClr val="1A2A4A"/>
-                </a:solidFill>
-              </a:rPr>
-              <a:t>1</a:t>
-            </a:r>
-          </a:p>
-        </p:txBody>
-      </p:sp>
-      <p:sp>
-        <p:nvSpPr>
-          <p:cNvPr id="13" name="TextBox 12"/>
-          <p:cNvSpPr txBox="1"/>
+          </a:p>
+        </p:txBody>
+      </p:sp>
+      <p:sp>
+        <p:nvSpPr>
+          <p:cNvPr id="10" name="Rectangle 9"/>
+          <p:cNvSpPr/>
           <p:nvPr/>
         </p:nvSpPr>
         <p:spPr>
           <a:xfrm>
-            <a:off x="11196645" y="3506609"/>
-            <a:ext cx="3735772" cy="240000"/>
+            <a:off x="648000" y="1800000"/>
+            <a:ext cx="17028000" cy="522000"/>
           </a:xfrm>
           <a:prstGeom prst="rect">
             <a:avLst/>
           </a:prstGeom>
-          <a:noFill/>
+          <a:solidFill>
+            <a:srgbClr val="1E3055"/>
+          </a:solidFill>
+          <a:ln>
+            <a:noFill/>
+          </a:ln>
         </p:spPr>
-        <p:txBody>
-          <a:bodyPr wrap="square">
-            <a:spAutoFit/>
-          </a:bodyPr>
-          <a:lstStyle/>
-          <a:p>
-            <a:pPr algn="r"/>
-            <a:r>
-              <a:rPr sz="1300" b="1">
-                <a:solidFill>
-                  <a:srgbClr val="FFFFFF"/>
-                </a:solidFill>
-                <a:latin typeface="Arial"/>
-              </a:rPr>
-              <a:t>حماية بيانات الطلاب الرقمية</a:t>
-            </a:r>
-          </a:p>
-        </p:txBody>
-      </p:sp>
-      <p:sp>
-        <p:nvSpPr>
-          <p:cNvPr id="14" name="TextBox 13"/>
-          <p:cNvSpPr txBox="1"/>
+        <p:style>
+          <a:lnRef idx="1">
+            <a:schemeClr val="accent1"/>
+          </a:lnRef>
+          <a:fillRef idx="3">
+            <a:schemeClr val="accent1"/>
+          </a:fillRef>
+          <a:effectRef idx="2">
+            <a:schemeClr val="accent1"/>
+          </a:effectRef>
+          <a:fontRef idx="minor">
+            <a:schemeClr val="lt1"/>
+          </a:fontRef>
+        </p:style>
+        <p:txBody>
+          <a:bodyPr rtlCol="0" anchor="ctr"/>
+          <a:lstStyle/>
+          <a:p>
+            <a:pPr algn="ctr"/>
+          </a:p>
+        </p:txBody>
+      </p:sp>
+      <p:sp>
+        <p:nvSpPr>
+          <p:cNvPr id="11" name="Rectangle 10"/>
+          <p:cNvSpPr/>
           <p:nvPr/>
         </p:nvSpPr>
         <p:spPr>
           <a:xfrm>
-            <a:off x="11196645" y="3766609"/>
-            <a:ext cx="3735772" cy="200000"/>
-          </a:xfrm>
-          <a:prstGeom prst="rect">
-            <a:avLst/>
-          </a:prstGeom>
-          <a:noFill/>
-        </p:spPr>
-        <p:txBody>
-          <a:bodyPr wrap="square">
-            <a:spAutoFit/>
-          </a:bodyPr>
-          <a:lstStyle/>
-          <a:p>
-            <a:pPr algn="l"/>
-            <a:r>
-              <a:rPr sz="900" b="0">
-                <a:solidFill>
-                  <a:srgbClr val="BBCCDD"/>
-                </a:solidFill>
-                <a:latin typeface="Arial"/>
-              </a:rPr>
-              <a:t>Student Digital Data Protection</a:t>
-            </a:r>
-          </a:p>
-        </p:txBody>
-      </p:sp>
-      <p:sp>
-        <p:nvSpPr>
-          <p:cNvPr id="15" name="Rectangle 14"/>
-          <p:cNvSpPr/>
-          <p:nvPr/>
-        </p:nvSpPr>
-        <p:spPr>
-          <a:xfrm>
-            <a:off x="10746645" y="4156609"/>
-            <a:ext cx="380000" cy="380000"/>
+            <a:off x="648000" y="1800000"/>
+            <a:ext cx="396000" cy="522000"/>
           </a:xfrm>
           <a:prstGeom prst="rect">
             <a:avLst/>
@@ -6465,27 +6202,19 @@
           <a:lstStyle/>
           <a:p>
             <a:pPr algn="ctr"/>
-            <a:r>
-              <a:rPr sz="1400" b="1">
-                <a:solidFill>
-                  <a:srgbClr val="1A2A4A"/>
-                </a:solidFill>
-              </a:rPr>
-              <a:t>2</a:t>
-            </a:r>
-          </a:p>
-        </p:txBody>
-      </p:sp>
-      <p:sp>
-        <p:nvSpPr>
-          <p:cNvPr id="16" name="TextBox 15"/>
+          </a:p>
+        </p:txBody>
+      </p:sp>
+      <p:sp>
+        <p:nvSpPr>
+          <p:cNvPr id="12" name="TextBox 11"/>
           <p:cNvSpPr txBox="1"/>
           <p:nvPr/>
         </p:nvSpPr>
         <p:spPr>
           <a:xfrm>
-            <a:off x="11196645" y="4136609"/>
-            <a:ext cx="3735772" cy="240000"/>
+            <a:off x="648000" y="1800000"/>
+            <a:ext cx="396000" cy="522000"/>
           </a:xfrm>
           <a:prstGeom prst="rect">
             <a:avLst/>
@@ -6498,64 +6227,29 @@
           </a:bodyPr>
           <a:lstStyle/>
           <a:p>
-            <a:pPr algn="r"/>
+            <a:pPr algn="ctr"/>
             <a:r>
-              <a:rPr sz="1300" b="1">
+              <a:rPr sz="1600" b="1">
                 <a:solidFill>
-                  <a:srgbClr val="FFFFFF"/>
+                  <a:srgbClr val="1A2A4A"/>
                 </a:solidFill>
-                <a:latin typeface="Arial"/>
+                <a:latin typeface="Noto Sans Arabic"/>
               </a:rPr>
-              <a:t>توثيق هوية المستخدمين</a:t>
+              <a:t>1</a:t>
             </a:r>
           </a:p>
         </p:txBody>
       </p:sp>
       <p:sp>
         <p:nvSpPr>
-          <p:cNvPr id="17" name="TextBox 16"/>
-          <p:cNvSpPr txBox="1"/>
+          <p:cNvPr id="13" name="Rectangle 12"/>
+          <p:cNvSpPr/>
           <p:nvPr/>
         </p:nvSpPr>
         <p:spPr>
           <a:xfrm>
-            <a:off x="11196645" y="4396609"/>
-            <a:ext cx="3735772" cy="200000"/>
-          </a:xfrm>
-          <a:prstGeom prst="rect">
-            <a:avLst/>
-          </a:prstGeom>
-          <a:noFill/>
-        </p:spPr>
-        <p:txBody>
-          <a:bodyPr wrap="square">
-            <a:spAutoFit/>
-          </a:bodyPr>
-          <a:lstStyle/>
-          <a:p>
-            <a:pPr algn="l"/>
-            <a:r>
-              <a:rPr sz="900" b="0">
-                <a:solidFill>
-                  <a:srgbClr val="BBCCDD"/>
-                </a:solidFill>
-                <a:latin typeface="Arial"/>
-              </a:rPr>
-              <a:t>User Identity Verification</a:t>
-            </a:r>
-          </a:p>
-        </p:txBody>
-      </p:sp>
-      <p:sp>
-        <p:nvSpPr>
-          <p:cNvPr id="18" name="Rectangle 17"/>
-          <p:cNvSpPr/>
-          <p:nvPr/>
-        </p:nvSpPr>
-        <p:spPr>
-          <a:xfrm>
-            <a:off x="10746645" y="4786609"/>
-            <a:ext cx="380000" cy="380000"/>
+            <a:off x="17208000" y="1925999"/>
+            <a:ext cx="251999" cy="251999"/>
           </a:xfrm>
           <a:prstGeom prst="rect">
             <a:avLst/>
@@ -6586,27 +6280,19 @@
           <a:lstStyle/>
           <a:p>
             <a:pPr algn="ctr"/>
-            <a:r>
-              <a:rPr sz="1400" b="1">
-                <a:solidFill>
-                  <a:srgbClr val="1A2A4A"/>
-                </a:solidFill>
-              </a:rPr>
-              <a:t>3</a:t>
-            </a:r>
-          </a:p>
-        </p:txBody>
-      </p:sp>
-      <p:sp>
-        <p:nvSpPr>
-          <p:cNvPr id="19" name="TextBox 18"/>
+          </a:p>
+        </p:txBody>
+      </p:sp>
+      <p:sp>
+        <p:nvSpPr>
+          <p:cNvPr id="14" name="TextBox 13"/>
           <p:cNvSpPr txBox="1"/>
           <p:nvPr/>
         </p:nvSpPr>
         <p:spPr>
           <a:xfrm>
-            <a:off x="11196645" y="4766609"/>
-            <a:ext cx="3735772" cy="240000"/>
+            <a:off x="1116000" y="1818000"/>
+            <a:ext cx="16020001" cy="288000"/>
           </a:xfrm>
           <a:prstGeom prst="rect">
             <a:avLst/>
@@ -6621,27 +6307,27 @@
           <a:p>
             <a:pPr algn="r"/>
             <a:r>
-              <a:rPr sz="1300" b="1">
+              <a:rPr sz="1400" b="1">
                 <a:solidFill>
                   <a:srgbClr val="FFFFFF"/>
                 </a:solidFill>
-                <a:latin typeface="Arial"/>
+                <a:latin typeface="Noto Sans Arabic"/>
               </a:rPr>
-              <a:t>رقابة أولياء الأمور</a:t>
+              <a:t>حماية بيانات الطلاب الرقمية</a:t>
             </a:r>
           </a:p>
         </p:txBody>
       </p:sp>
       <p:sp>
         <p:nvSpPr>
-          <p:cNvPr id="20" name="TextBox 19"/>
+          <p:cNvPr id="15" name="TextBox 14"/>
           <p:cNvSpPr txBox="1"/>
           <p:nvPr/>
         </p:nvSpPr>
         <p:spPr>
           <a:xfrm>
-            <a:off x="11196645" y="5026609"/>
-            <a:ext cx="3735772" cy="200000"/>
+            <a:off x="1116000" y="2070000"/>
+            <a:ext cx="16020001" cy="216000"/>
           </a:xfrm>
           <a:prstGeom prst="rect">
             <a:avLst/>
@@ -6654,29 +6340,72 @@
           </a:bodyPr>
           <a:lstStyle/>
           <a:p>
-            <a:pPr algn="l"/>
+            <a:pPr algn="r"/>
             <a:r>
-              <a:rPr sz="900" b="0">
+              <a:rPr sz="1000" b="0">
                 <a:solidFill>
-                  <a:srgbClr val="BBCCDD"/>
+                  <a:srgbClr val="CCCCCC"/>
                 </a:solidFill>
-                <a:latin typeface="Arial"/>
+                <a:latin typeface="Noto Sans Arabic"/>
               </a:rPr>
-              <a:t>Parental Monitoring Tools</a:t>
+              <a:t>Student Digital Data Protection</a:t>
             </a:r>
           </a:p>
         </p:txBody>
       </p:sp>
       <p:sp>
         <p:nvSpPr>
-          <p:cNvPr id="21" name="Rectangle 20"/>
+          <p:cNvPr id="16" name="Rectangle 15"/>
           <p:cNvSpPr/>
           <p:nvPr/>
         </p:nvSpPr>
         <p:spPr>
           <a:xfrm>
-            <a:off x="10746645" y="5416609"/>
-            <a:ext cx="380000" cy="380000"/>
+            <a:off x="648000" y="2412000"/>
+            <a:ext cx="17028000" cy="522000"/>
+          </a:xfrm>
+          <a:prstGeom prst="rect">
+            <a:avLst/>
+          </a:prstGeom>
+          <a:solidFill>
+            <a:srgbClr val="1E3055"/>
+          </a:solidFill>
+          <a:ln>
+            <a:noFill/>
+          </a:ln>
+        </p:spPr>
+        <p:style>
+          <a:lnRef idx="1">
+            <a:schemeClr val="accent1"/>
+          </a:lnRef>
+          <a:fillRef idx="3">
+            <a:schemeClr val="accent1"/>
+          </a:fillRef>
+          <a:effectRef idx="2">
+            <a:schemeClr val="accent1"/>
+          </a:effectRef>
+          <a:fontRef idx="minor">
+            <a:schemeClr val="lt1"/>
+          </a:fontRef>
+        </p:style>
+        <p:txBody>
+          <a:bodyPr rtlCol="0" anchor="ctr"/>
+          <a:lstStyle/>
+          <a:p>
+            <a:pPr algn="ctr"/>
+          </a:p>
+        </p:txBody>
+      </p:sp>
+      <p:sp>
+        <p:nvSpPr>
+          <p:cNvPr id="17" name="Rectangle 16"/>
+          <p:cNvSpPr/>
+          <p:nvPr/>
+        </p:nvSpPr>
+        <p:spPr>
+          <a:xfrm>
+            <a:off x="648000" y="2412000"/>
+            <a:ext cx="396000" cy="522000"/>
           </a:xfrm>
           <a:prstGeom prst="rect">
             <a:avLst/>
@@ -6707,27 +6436,19 @@
           <a:lstStyle/>
           <a:p>
             <a:pPr algn="ctr"/>
-            <a:r>
-              <a:rPr sz="1400" b="1">
-                <a:solidFill>
-                  <a:srgbClr val="1A2A4A"/>
-                </a:solidFill>
-              </a:rPr>
-              <a:t>4</a:t>
-            </a:r>
-          </a:p>
-        </p:txBody>
-      </p:sp>
-      <p:sp>
-        <p:nvSpPr>
-          <p:cNvPr id="22" name="TextBox 21"/>
+          </a:p>
+        </p:txBody>
+      </p:sp>
+      <p:sp>
+        <p:nvSpPr>
+          <p:cNvPr id="18" name="TextBox 17"/>
           <p:cNvSpPr txBox="1"/>
           <p:nvPr/>
         </p:nvSpPr>
         <p:spPr>
           <a:xfrm>
-            <a:off x="11196645" y="5396609"/>
-            <a:ext cx="3735772" cy="240000"/>
+            <a:off x="648000" y="2412000"/>
+            <a:ext cx="396000" cy="522000"/>
           </a:xfrm>
           <a:prstGeom prst="rect">
             <a:avLst/>
@@ -6740,64 +6461,29 @@
           </a:bodyPr>
           <a:lstStyle/>
           <a:p>
-            <a:pPr algn="r"/>
+            <a:pPr algn="ctr"/>
             <a:r>
-              <a:rPr sz="1300" b="1">
+              <a:rPr sz="1600" b="1">
                 <a:solidFill>
-                  <a:srgbClr val="FFFFFF"/>
+                  <a:srgbClr val="1A2A4A"/>
                 </a:solidFill>
-                <a:latin typeface="Arial"/>
+                <a:latin typeface="Noto Sans Arabic"/>
               </a:rPr>
-              <a:t>الإبلاغ عن الاختراقات</a:t>
+              <a:t>2</a:t>
             </a:r>
           </a:p>
         </p:txBody>
       </p:sp>
       <p:sp>
         <p:nvSpPr>
-          <p:cNvPr id="23" name="TextBox 22"/>
-          <p:cNvSpPr txBox="1"/>
+          <p:cNvPr id="19" name="Rectangle 18"/>
+          <p:cNvSpPr/>
           <p:nvPr/>
         </p:nvSpPr>
         <p:spPr>
           <a:xfrm>
-            <a:off x="11196645" y="5656609"/>
-            <a:ext cx="3735772" cy="200000"/>
-          </a:xfrm>
-          <a:prstGeom prst="rect">
-            <a:avLst/>
-          </a:prstGeom>
-          <a:noFill/>
-        </p:spPr>
-        <p:txBody>
-          <a:bodyPr wrap="square">
-            <a:spAutoFit/>
-          </a:bodyPr>
-          <a:lstStyle/>
-          <a:p>
-            <a:pPr algn="l"/>
-            <a:r>
-              <a:rPr sz="900" b="0">
-                <a:solidFill>
-                  <a:srgbClr val="BBCCDD"/>
-                </a:solidFill>
-                <a:latin typeface="Arial"/>
-              </a:rPr>
-              <a:t>Breach Reporting Obligation</a:t>
-            </a:r>
-          </a:p>
-        </p:txBody>
-      </p:sp>
-      <p:sp>
-        <p:nvSpPr>
-          <p:cNvPr id="24" name="Rectangle 23"/>
-          <p:cNvSpPr/>
-          <p:nvPr/>
-        </p:nvSpPr>
-        <p:spPr>
-          <a:xfrm>
-            <a:off x="10746645" y="6046609"/>
-            <a:ext cx="380000" cy="380000"/>
+            <a:off x="17208000" y="2537999"/>
+            <a:ext cx="251999" cy="251999"/>
           </a:xfrm>
           <a:prstGeom prst="rect">
             <a:avLst/>
@@ -6828,27 +6514,19 @@
           <a:lstStyle/>
           <a:p>
             <a:pPr algn="ctr"/>
-            <a:r>
-              <a:rPr sz="1400" b="1">
-                <a:solidFill>
-                  <a:srgbClr val="1A2A4A"/>
-                </a:solidFill>
-              </a:rPr>
-              <a:t>5</a:t>
-            </a:r>
-          </a:p>
-        </p:txBody>
-      </p:sp>
-      <p:sp>
-        <p:nvSpPr>
-          <p:cNvPr id="25" name="TextBox 24"/>
+          </a:p>
+        </p:txBody>
+      </p:sp>
+      <p:sp>
+        <p:nvSpPr>
+          <p:cNvPr id="20" name="TextBox 19"/>
           <p:cNvSpPr txBox="1"/>
           <p:nvPr/>
         </p:nvSpPr>
         <p:spPr>
           <a:xfrm>
-            <a:off x="11196645" y="6026609"/>
-            <a:ext cx="3735772" cy="240000"/>
+            <a:off x="1116000" y="2430000"/>
+            <a:ext cx="16020001" cy="288000"/>
           </a:xfrm>
           <a:prstGeom prst="rect">
             <a:avLst/>
@@ -6863,27 +6541,27 @@
           <a:p>
             <a:pPr algn="r"/>
             <a:r>
-              <a:rPr sz="1300" b="1">
+              <a:rPr sz="1400" b="1">
                 <a:solidFill>
                   <a:srgbClr val="FFFFFF"/>
                 </a:solidFill>
-                <a:latin typeface="Arial"/>
+                <a:latin typeface="Noto Sans Arabic"/>
               </a:rPr>
-              <a:t>ضبط صلاحيات الوصول</a:t>
+              <a:t>توثيق هوية المستخدمين</a:t>
             </a:r>
           </a:p>
         </p:txBody>
       </p:sp>
       <p:sp>
         <p:nvSpPr>
-          <p:cNvPr id="26" name="TextBox 25"/>
+          <p:cNvPr id="21" name="TextBox 20"/>
           <p:cNvSpPr txBox="1"/>
           <p:nvPr/>
         </p:nvSpPr>
         <p:spPr>
           <a:xfrm>
-            <a:off x="11196645" y="6286609"/>
-            <a:ext cx="3735772" cy="200000"/>
+            <a:off x="1116000" y="2682000"/>
+            <a:ext cx="16020001" cy="216000"/>
           </a:xfrm>
           <a:prstGeom prst="rect">
             <a:avLst/>
@@ -6896,13 +6574,715 @@
           </a:bodyPr>
           <a:lstStyle/>
           <a:p>
-            <a:pPr algn="l"/>
+            <a:pPr algn="r"/>
             <a:r>
-              <a:rPr sz="900" b="0">
+              <a:rPr sz="1000" b="0">
                 <a:solidFill>
-                  <a:srgbClr val="BBCCDD"/>
+                  <a:srgbClr val="CCCCCC"/>
                 </a:solidFill>
-                <a:latin typeface="Arial"/>
+                <a:latin typeface="Noto Sans Arabic"/>
+              </a:rPr>
+              <a:t>User Identity Verification</a:t>
+            </a:r>
+          </a:p>
+        </p:txBody>
+      </p:sp>
+      <p:sp>
+        <p:nvSpPr>
+          <p:cNvPr id="22" name="Rectangle 21"/>
+          <p:cNvSpPr/>
+          <p:nvPr/>
+        </p:nvSpPr>
+        <p:spPr>
+          <a:xfrm>
+            <a:off x="648000" y="3024000"/>
+            <a:ext cx="17028000" cy="522000"/>
+          </a:xfrm>
+          <a:prstGeom prst="rect">
+            <a:avLst/>
+          </a:prstGeom>
+          <a:solidFill>
+            <a:srgbClr val="1E3055"/>
+          </a:solidFill>
+          <a:ln>
+            <a:noFill/>
+          </a:ln>
+        </p:spPr>
+        <p:style>
+          <a:lnRef idx="1">
+            <a:schemeClr val="accent1"/>
+          </a:lnRef>
+          <a:fillRef idx="3">
+            <a:schemeClr val="accent1"/>
+          </a:fillRef>
+          <a:effectRef idx="2">
+            <a:schemeClr val="accent1"/>
+          </a:effectRef>
+          <a:fontRef idx="minor">
+            <a:schemeClr val="lt1"/>
+          </a:fontRef>
+        </p:style>
+        <p:txBody>
+          <a:bodyPr rtlCol="0" anchor="ctr"/>
+          <a:lstStyle/>
+          <a:p>
+            <a:pPr algn="ctr"/>
+          </a:p>
+        </p:txBody>
+      </p:sp>
+      <p:sp>
+        <p:nvSpPr>
+          <p:cNvPr id="23" name="Rectangle 22"/>
+          <p:cNvSpPr/>
+          <p:nvPr/>
+        </p:nvSpPr>
+        <p:spPr>
+          <a:xfrm>
+            <a:off x="648000" y="3024000"/>
+            <a:ext cx="396000" cy="522000"/>
+          </a:xfrm>
+          <a:prstGeom prst="rect">
+            <a:avLst/>
+          </a:prstGeom>
+          <a:solidFill>
+            <a:srgbClr val="C9A84C"/>
+          </a:solidFill>
+          <a:ln>
+            <a:noFill/>
+          </a:ln>
+        </p:spPr>
+        <p:style>
+          <a:lnRef idx="1">
+            <a:schemeClr val="accent1"/>
+          </a:lnRef>
+          <a:fillRef idx="3">
+            <a:schemeClr val="accent1"/>
+          </a:fillRef>
+          <a:effectRef idx="2">
+            <a:schemeClr val="accent1"/>
+          </a:effectRef>
+          <a:fontRef idx="minor">
+            <a:schemeClr val="lt1"/>
+          </a:fontRef>
+        </p:style>
+        <p:txBody>
+          <a:bodyPr rtlCol="0" anchor="ctr"/>
+          <a:lstStyle/>
+          <a:p>
+            <a:pPr algn="ctr"/>
+          </a:p>
+        </p:txBody>
+      </p:sp>
+      <p:sp>
+        <p:nvSpPr>
+          <p:cNvPr id="24" name="TextBox 23"/>
+          <p:cNvSpPr txBox="1"/>
+          <p:nvPr/>
+        </p:nvSpPr>
+        <p:spPr>
+          <a:xfrm>
+            <a:off x="648000" y="3024000"/>
+            <a:ext cx="396000" cy="522000"/>
+          </a:xfrm>
+          <a:prstGeom prst="rect">
+            <a:avLst/>
+          </a:prstGeom>
+          <a:noFill/>
+        </p:spPr>
+        <p:txBody>
+          <a:bodyPr wrap="square">
+            <a:spAutoFit/>
+          </a:bodyPr>
+          <a:lstStyle/>
+          <a:p>
+            <a:pPr algn="ctr"/>
+            <a:r>
+              <a:rPr sz="1600" b="1">
+                <a:solidFill>
+                  <a:srgbClr val="1A2A4A"/>
+                </a:solidFill>
+                <a:latin typeface="Noto Sans Arabic"/>
+              </a:rPr>
+              <a:t>3</a:t>
+            </a:r>
+          </a:p>
+        </p:txBody>
+      </p:sp>
+      <p:sp>
+        <p:nvSpPr>
+          <p:cNvPr id="25" name="Rectangle 24"/>
+          <p:cNvSpPr/>
+          <p:nvPr/>
+        </p:nvSpPr>
+        <p:spPr>
+          <a:xfrm>
+            <a:off x="17208000" y="3149999"/>
+            <a:ext cx="251999" cy="251999"/>
+          </a:xfrm>
+          <a:prstGeom prst="rect">
+            <a:avLst/>
+          </a:prstGeom>
+          <a:solidFill>
+            <a:srgbClr val="C9A84C"/>
+          </a:solidFill>
+          <a:ln>
+            <a:noFill/>
+          </a:ln>
+        </p:spPr>
+        <p:style>
+          <a:lnRef idx="1">
+            <a:schemeClr val="accent1"/>
+          </a:lnRef>
+          <a:fillRef idx="3">
+            <a:schemeClr val="accent1"/>
+          </a:fillRef>
+          <a:effectRef idx="2">
+            <a:schemeClr val="accent1"/>
+          </a:effectRef>
+          <a:fontRef idx="minor">
+            <a:schemeClr val="lt1"/>
+          </a:fontRef>
+        </p:style>
+        <p:txBody>
+          <a:bodyPr rtlCol="0" anchor="ctr"/>
+          <a:lstStyle/>
+          <a:p>
+            <a:pPr algn="ctr"/>
+          </a:p>
+        </p:txBody>
+      </p:sp>
+      <p:sp>
+        <p:nvSpPr>
+          <p:cNvPr id="26" name="TextBox 25"/>
+          <p:cNvSpPr txBox="1"/>
+          <p:nvPr/>
+        </p:nvSpPr>
+        <p:spPr>
+          <a:xfrm>
+            <a:off x="1116000" y="3042000"/>
+            <a:ext cx="16020001" cy="288000"/>
+          </a:xfrm>
+          <a:prstGeom prst="rect">
+            <a:avLst/>
+          </a:prstGeom>
+          <a:noFill/>
+        </p:spPr>
+        <p:txBody>
+          <a:bodyPr wrap="square">
+            <a:spAutoFit/>
+          </a:bodyPr>
+          <a:lstStyle/>
+          <a:p>
+            <a:pPr algn="r"/>
+            <a:r>
+              <a:rPr sz="1400" b="1">
+                <a:solidFill>
+                  <a:srgbClr val="FFFFFF"/>
+                </a:solidFill>
+                <a:latin typeface="Noto Sans Arabic"/>
+              </a:rPr>
+              <a:t>رقابة أولياء الأمور</a:t>
+            </a:r>
+          </a:p>
+        </p:txBody>
+      </p:sp>
+      <p:sp>
+        <p:nvSpPr>
+          <p:cNvPr id="27" name="TextBox 26"/>
+          <p:cNvSpPr txBox="1"/>
+          <p:nvPr/>
+        </p:nvSpPr>
+        <p:spPr>
+          <a:xfrm>
+            <a:off x="1116000" y="3294000"/>
+            <a:ext cx="16020001" cy="216000"/>
+          </a:xfrm>
+          <a:prstGeom prst="rect">
+            <a:avLst/>
+          </a:prstGeom>
+          <a:noFill/>
+        </p:spPr>
+        <p:txBody>
+          <a:bodyPr wrap="square">
+            <a:spAutoFit/>
+          </a:bodyPr>
+          <a:lstStyle/>
+          <a:p>
+            <a:pPr algn="r"/>
+            <a:r>
+              <a:rPr sz="1000" b="0">
+                <a:solidFill>
+                  <a:srgbClr val="CCCCCC"/>
+                </a:solidFill>
+                <a:latin typeface="Noto Sans Arabic"/>
+              </a:rPr>
+              <a:t>Parental Monitoring Tools</a:t>
+            </a:r>
+          </a:p>
+        </p:txBody>
+      </p:sp>
+      <p:sp>
+        <p:nvSpPr>
+          <p:cNvPr id="28" name="Rectangle 27"/>
+          <p:cNvSpPr/>
+          <p:nvPr/>
+        </p:nvSpPr>
+        <p:spPr>
+          <a:xfrm>
+            <a:off x="648000" y="3636000"/>
+            <a:ext cx="17028000" cy="522000"/>
+          </a:xfrm>
+          <a:prstGeom prst="rect">
+            <a:avLst/>
+          </a:prstGeom>
+          <a:solidFill>
+            <a:srgbClr val="1E3055"/>
+          </a:solidFill>
+          <a:ln>
+            <a:noFill/>
+          </a:ln>
+        </p:spPr>
+        <p:style>
+          <a:lnRef idx="1">
+            <a:schemeClr val="accent1"/>
+          </a:lnRef>
+          <a:fillRef idx="3">
+            <a:schemeClr val="accent1"/>
+          </a:fillRef>
+          <a:effectRef idx="2">
+            <a:schemeClr val="accent1"/>
+          </a:effectRef>
+          <a:fontRef idx="minor">
+            <a:schemeClr val="lt1"/>
+          </a:fontRef>
+        </p:style>
+        <p:txBody>
+          <a:bodyPr rtlCol="0" anchor="ctr"/>
+          <a:lstStyle/>
+          <a:p>
+            <a:pPr algn="ctr"/>
+          </a:p>
+        </p:txBody>
+      </p:sp>
+      <p:sp>
+        <p:nvSpPr>
+          <p:cNvPr id="29" name="Rectangle 28"/>
+          <p:cNvSpPr/>
+          <p:nvPr/>
+        </p:nvSpPr>
+        <p:spPr>
+          <a:xfrm>
+            <a:off x="648000" y="3636000"/>
+            <a:ext cx="396000" cy="522000"/>
+          </a:xfrm>
+          <a:prstGeom prst="rect">
+            <a:avLst/>
+          </a:prstGeom>
+          <a:solidFill>
+            <a:srgbClr val="C9A84C"/>
+          </a:solidFill>
+          <a:ln>
+            <a:noFill/>
+          </a:ln>
+        </p:spPr>
+        <p:style>
+          <a:lnRef idx="1">
+            <a:schemeClr val="accent1"/>
+          </a:lnRef>
+          <a:fillRef idx="3">
+            <a:schemeClr val="accent1"/>
+          </a:fillRef>
+          <a:effectRef idx="2">
+            <a:schemeClr val="accent1"/>
+          </a:effectRef>
+          <a:fontRef idx="minor">
+            <a:schemeClr val="lt1"/>
+          </a:fontRef>
+        </p:style>
+        <p:txBody>
+          <a:bodyPr rtlCol="0" anchor="ctr"/>
+          <a:lstStyle/>
+          <a:p>
+            <a:pPr algn="ctr"/>
+          </a:p>
+        </p:txBody>
+      </p:sp>
+      <p:sp>
+        <p:nvSpPr>
+          <p:cNvPr id="30" name="TextBox 29"/>
+          <p:cNvSpPr txBox="1"/>
+          <p:nvPr/>
+        </p:nvSpPr>
+        <p:spPr>
+          <a:xfrm>
+            <a:off x="648000" y="3636000"/>
+            <a:ext cx="396000" cy="522000"/>
+          </a:xfrm>
+          <a:prstGeom prst="rect">
+            <a:avLst/>
+          </a:prstGeom>
+          <a:noFill/>
+        </p:spPr>
+        <p:txBody>
+          <a:bodyPr wrap="square">
+            <a:spAutoFit/>
+          </a:bodyPr>
+          <a:lstStyle/>
+          <a:p>
+            <a:pPr algn="ctr"/>
+            <a:r>
+              <a:rPr sz="1600" b="1">
+                <a:solidFill>
+                  <a:srgbClr val="1A2A4A"/>
+                </a:solidFill>
+                <a:latin typeface="Noto Sans Arabic"/>
+              </a:rPr>
+              <a:t>4</a:t>
+            </a:r>
+          </a:p>
+        </p:txBody>
+      </p:sp>
+      <p:sp>
+        <p:nvSpPr>
+          <p:cNvPr id="31" name="Rectangle 30"/>
+          <p:cNvSpPr/>
+          <p:nvPr/>
+        </p:nvSpPr>
+        <p:spPr>
+          <a:xfrm>
+            <a:off x="17208000" y="3761999"/>
+            <a:ext cx="251999" cy="251999"/>
+          </a:xfrm>
+          <a:prstGeom prst="rect">
+            <a:avLst/>
+          </a:prstGeom>
+          <a:solidFill>
+            <a:srgbClr val="C9A84C"/>
+          </a:solidFill>
+          <a:ln>
+            <a:noFill/>
+          </a:ln>
+        </p:spPr>
+        <p:style>
+          <a:lnRef idx="1">
+            <a:schemeClr val="accent1"/>
+          </a:lnRef>
+          <a:fillRef idx="3">
+            <a:schemeClr val="accent1"/>
+          </a:fillRef>
+          <a:effectRef idx="2">
+            <a:schemeClr val="accent1"/>
+          </a:effectRef>
+          <a:fontRef idx="minor">
+            <a:schemeClr val="lt1"/>
+          </a:fontRef>
+        </p:style>
+        <p:txBody>
+          <a:bodyPr rtlCol="0" anchor="ctr"/>
+          <a:lstStyle/>
+          <a:p>
+            <a:pPr algn="ctr"/>
+          </a:p>
+        </p:txBody>
+      </p:sp>
+      <p:sp>
+        <p:nvSpPr>
+          <p:cNvPr id="32" name="TextBox 31"/>
+          <p:cNvSpPr txBox="1"/>
+          <p:nvPr/>
+        </p:nvSpPr>
+        <p:spPr>
+          <a:xfrm>
+            <a:off x="1116000" y="3654000"/>
+            <a:ext cx="16020001" cy="288000"/>
+          </a:xfrm>
+          <a:prstGeom prst="rect">
+            <a:avLst/>
+          </a:prstGeom>
+          <a:noFill/>
+        </p:spPr>
+        <p:txBody>
+          <a:bodyPr wrap="square">
+            <a:spAutoFit/>
+          </a:bodyPr>
+          <a:lstStyle/>
+          <a:p>
+            <a:pPr algn="r"/>
+            <a:r>
+              <a:rPr sz="1400" b="1">
+                <a:solidFill>
+                  <a:srgbClr val="FFFFFF"/>
+                </a:solidFill>
+                <a:latin typeface="Noto Sans Arabic"/>
+              </a:rPr>
+              <a:t>الإبلاغ عن الاختراقات</a:t>
+            </a:r>
+          </a:p>
+        </p:txBody>
+      </p:sp>
+      <p:sp>
+        <p:nvSpPr>
+          <p:cNvPr id="33" name="TextBox 32"/>
+          <p:cNvSpPr txBox="1"/>
+          <p:nvPr/>
+        </p:nvSpPr>
+        <p:spPr>
+          <a:xfrm>
+            <a:off x="1116000" y="3906000"/>
+            <a:ext cx="16020001" cy="216000"/>
+          </a:xfrm>
+          <a:prstGeom prst="rect">
+            <a:avLst/>
+          </a:prstGeom>
+          <a:noFill/>
+        </p:spPr>
+        <p:txBody>
+          <a:bodyPr wrap="square">
+            <a:spAutoFit/>
+          </a:bodyPr>
+          <a:lstStyle/>
+          <a:p>
+            <a:pPr algn="r"/>
+            <a:r>
+              <a:rPr sz="1000" b="0">
+                <a:solidFill>
+                  <a:srgbClr val="CCCCCC"/>
+                </a:solidFill>
+                <a:latin typeface="Noto Sans Arabic"/>
+              </a:rPr>
+              <a:t>Breach Reporting Obligation</a:t>
+            </a:r>
+          </a:p>
+        </p:txBody>
+      </p:sp>
+      <p:sp>
+        <p:nvSpPr>
+          <p:cNvPr id="34" name="Rectangle 33"/>
+          <p:cNvSpPr/>
+          <p:nvPr/>
+        </p:nvSpPr>
+        <p:spPr>
+          <a:xfrm>
+            <a:off x="648000" y="4248000"/>
+            <a:ext cx="17028000" cy="522000"/>
+          </a:xfrm>
+          <a:prstGeom prst="rect">
+            <a:avLst/>
+          </a:prstGeom>
+          <a:solidFill>
+            <a:srgbClr val="1E3055"/>
+          </a:solidFill>
+          <a:ln>
+            <a:noFill/>
+          </a:ln>
+        </p:spPr>
+        <p:style>
+          <a:lnRef idx="1">
+            <a:schemeClr val="accent1"/>
+          </a:lnRef>
+          <a:fillRef idx="3">
+            <a:schemeClr val="accent1"/>
+          </a:fillRef>
+          <a:effectRef idx="2">
+            <a:schemeClr val="accent1"/>
+          </a:effectRef>
+          <a:fontRef idx="minor">
+            <a:schemeClr val="lt1"/>
+          </a:fontRef>
+        </p:style>
+        <p:txBody>
+          <a:bodyPr rtlCol="0" anchor="ctr"/>
+          <a:lstStyle/>
+          <a:p>
+            <a:pPr algn="ctr"/>
+          </a:p>
+        </p:txBody>
+      </p:sp>
+      <p:sp>
+        <p:nvSpPr>
+          <p:cNvPr id="35" name="Rectangle 34"/>
+          <p:cNvSpPr/>
+          <p:nvPr/>
+        </p:nvSpPr>
+        <p:spPr>
+          <a:xfrm>
+            <a:off x="648000" y="4248000"/>
+            <a:ext cx="396000" cy="522000"/>
+          </a:xfrm>
+          <a:prstGeom prst="rect">
+            <a:avLst/>
+          </a:prstGeom>
+          <a:solidFill>
+            <a:srgbClr val="C9A84C"/>
+          </a:solidFill>
+          <a:ln>
+            <a:noFill/>
+          </a:ln>
+        </p:spPr>
+        <p:style>
+          <a:lnRef idx="1">
+            <a:schemeClr val="accent1"/>
+          </a:lnRef>
+          <a:fillRef idx="3">
+            <a:schemeClr val="accent1"/>
+          </a:fillRef>
+          <a:effectRef idx="2">
+            <a:schemeClr val="accent1"/>
+          </a:effectRef>
+          <a:fontRef idx="minor">
+            <a:schemeClr val="lt1"/>
+          </a:fontRef>
+        </p:style>
+        <p:txBody>
+          <a:bodyPr rtlCol="0" anchor="ctr"/>
+          <a:lstStyle/>
+          <a:p>
+            <a:pPr algn="ctr"/>
+          </a:p>
+        </p:txBody>
+      </p:sp>
+      <p:sp>
+        <p:nvSpPr>
+          <p:cNvPr id="36" name="TextBox 35"/>
+          <p:cNvSpPr txBox="1"/>
+          <p:nvPr/>
+        </p:nvSpPr>
+        <p:spPr>
+          <a:xfrm>
+            <a:off x="648000" y="4248000"/>
+            <a:ext cx="396000" cy="522000"/>
+          </a:xfrm>
+          <a:prstGeom prst="rect">
+            <a:avLst/>
+          </a:prstGeom>
+          <a:noFill/>
+        </p:spPr>
+        <p:txBody>
+          <a:bodyPr wrap="square">
+            <a:spAutoFit/>
+          </a:bodyPr>
+          <a:lstStyle/>
+          <a:p>
+            <a:pPr algn="ctr"/>
+            <a:r>
+              <a:rPr sz="1600" b="1">
+                <a:solidFill>
+                  <a:srgbClr val="1A2A4A"/>
+                </a:solidFill>
+                <a:latin typeface="Noto Sans Arabic"/>
+              </a:rPr>
+              <a:t>5</a:t>
+            </a:r>
+          </a:p>
+        </p:txBody>
+      </p:sp>
+      <p:sp>
+        <p:nvSpPr>
+          <p:cNvPr id="37" name="Rectangle 36"/>
+          <p:cNvSpPr/>
+          <p:nvPr/>
+        </p:nvSpPr>
+        <p:spPr>
+          <a:xfrm>
+            <a:off x="17208000" y="4373999"/>
+            <a:ext cx="251999" cy="251999"/>
+          </a:xfrm>
+          <a:prstGeom prst="rect">
+            <a:avLst/>
+          </a:prstGeom>
+          <a:solidFill>
+            <a:srgbClr val="C9A84C"/>
+          </a:solidFill>
+          <a:ln>
+            <a:noFill/>
+          </a:ln>
+        </p:spPr>
+        <p:style>
+          <a:lnRef idx="1">
+            <a:schemeClr val="accent1"/>
+          </a:lnRef>
+          <a:fillRef idx="3">
+            <a:schemeClr val="accent1"/>
+          </a:fillRef>
+          <a:effectRef idx="2">
+            <a:schemeClr val="accent1"/>
+          </a:effectRef>
+          <a:fontRef idx="minor">
+            <a:schemeClr val="lt1"/>
+          </a:fontRef>
+        </p:style>
+        <p:txBody>
+          <a:bodyPr rtlCol="0" anchor="ctr"/>
+          <a:lstStyle/>
+          <a:p>
+            <a:pPr algn="ctr"/>
+          </a:p>
+        </p:txBody>
+      </p:sp>
+      <p:sp>
+        <p:nvSpPr>
+          <p:cNvPr id="38" name="TextBox 37"/>
+          <p:cNvSpPr txBox="1"/>
+          <p:nvPr/>
+        </p:nvSpPr>
+        <p:spPr>
+          <a:xfrm>
+            <a:off x="1116000" y="4266000"/>
+            <a:ext cx="16020001" cy="288000"/>
+          </a:xfrm>
+          <a:prstGeom prst="rect">
+            <a:avLst/>
+          </a:prstGeom>
+          <a:noFill/>
+        </p:spPr>
+        <p:txBody>
+          <a:bodyPr wrap="square">
+            <a:spAutoFit/>
+          </a:bodyPr>
+          <a:lstStyle/>
+          <a:p>
+            <a:pPr algn="r"/>
+            <a:r>
+              <a:rPr sz="1400" b="1">
+                <a:solidFill>
+                  <a:srgbClr val="FFFFFF"/>
+                </a:solidFill>
+                <a:latin typeface="Noto Sans Arabic"/>
+              </a:rPr>
+              <a:t>ضبط صلاحيات الوصول</a:t>
+            </a:r>
+          </a:p>
+        </p:txBody>
+      </p:sp>
+      <p:sp>
+        <p:nvSpPr>
+          <p:cNvPr id="39" name="TextBox 38"/>
+          <p:cNvSpPr txBox="1"/>
+          <p:nvPr/>
+        </p:nvSpPr>
+        <p:spPr>
+          <a:xfrm>
+            <a:off x="1116000" y="4518000"/>
+            <a:ext cx="16020001" cy="216000"/>
+          </a:xfrm>
+          <a:prstGeom prst="rect">
+            <a:avLst/>
+          </a:prstGeom>
+          <a:noFill/>
+        </p:spPr>
+        <p:txBody>
+          <a:bodyPr wrap="square">
+            <a:spAutoFit/>
+          </a:bodyPr>
+          <a:lstStyle/>
+          <a:p>
+            <a:pPr algn="r"/>
+            <a:r>
+              <a:rPr sz="1000" b="0">
+                <a:solidFill>
+                  <a:srgbClr val="CCCCCC"/>
+                </a:solidFill>
+                <a:latin typeface="Noto Sans Arabic"/>
               </a:rPr>
               <a:t>Access Control Management</a:t>
             </a:r>
@@ -7130,355 +7510,57 @@
       </p:grpSp>
       <p:sp>
         <p:nvSpPr>
-          <p:cNvPr name="Freeform 5" id="5"/>
+          <p:cNvPr id="5" name="Rectangle 4"/>
           <p:cNvSpPr/>
           <p:nvPr/>
         </p:nvSpPr>
         <p:spPr>
-          <a:xfrm flipH="true" flipV="false" rot="0">
-            <a:off x="10486143" y="2216792"/>
-            <a:ext cx="5696832" cy="5911807"/>
-          </a:xfrm>
-          <a:custGeom>
-            <a:avLst/>
-            <a:gdLst/>
-            <a:ahLst/>
-            <a:cxnLst/>
-            <a:rect r="r" b="b" t="t" l="l"/>
-            <a:pathLst>
-              <a:path h="5911807" w="5696832">
-                <a:moveTo>
-                  <a:pt x="5696832" y="0"/>
-                </a:moveTo>
-                <a:lnTo>
-                  <a:pt x="0" y="0"/>
-                </a:lnTo>
-                <a:lnTo>
-                  <a:pt x="0" y="5911807"/>
-                </a:lnTo>
-                <a:lnTo>
-                  <a:pt x="5696832" y="5911807"/>
-                </a:lnTo>
-                <a:lnTo>
-                  <a:pt x="5696832" y="0"/>
-                </a:lnTo>
-                <a:close/>
-              </a:path>
-            </a:pathLst>
-          </a:custGeom>
-          <a:blipFill>
-            <a:blip r:embed="rId2">
-              <a:extLst>
-                <a:ext uri="{96DAC541-7B7A-43D3-8B79-37D633B846F1}">
-                  <asvg:svgBlip xmlns:asvg="http://schemas.microsoft.com/office/drawing/2016/SVG/main" r:embed="rId3"/>
-                </a:ext>
-              </a:extLst>
-            </a:blip>
-            <a:stretch>
-              <a:fillRect l="0" t="0" r="0" b="0"/>
-            </a:stretch>
-          </a:blipFill>
-          <a:ln cap="sq">
-            <a:noFill/>
-            <a:prstDash val="solid"/>
-            <a:miter/>
-          </a:ln>
-        </p:spPr>
-      </p:sp>
-      <p:sp>
-        <p:nvSpPr>
-          <p:cNvPr name="Freeform 6" id="6"/>
-          <p:cNvSpPr/>
-          <p:nvPr/>
-        </p:nvSpPr>
-        <p:spPr>
-          <a:xfrm flipH="false" flipV="false" rot="0">
-            <a:off x="10546645" y="2306609"/>
-            <a:ext cx="4485772" cy="4485772"/>
-          </a:xfrm>
-          <a:custGeom>
-            <a:avLst/>
-            <a:gdLst/>
-            <a:ahLst/>
-            <a:cxnLst/>
-            <a:rect r="r" b="b" t="t" l="l"/>
-            <a:pathLst>
-              <a:path h="4485772" w="4485772">
-                <a:moveTo>
-                  <a:pt x="0" y="0"/>
-                </a:moveTo>
-                <a:lnTo>
-                  <a:pt x="4485772" y="0"/>
-                </a:lnTo>
-                <a:lnTo>
-                  <a:pt x="4485772" y="4485772"/>
-                </a:lnTo>
-                <a:lnTo>
-                  <a:pt x="0" y="4485772"/>
-                </a:lnTo>
-                <a:lnTo>
-                  <a:pt x="0" y="0"/>
-                </a:lnTo>
-                <a:close/>
-              </a:path>
-            </a:pathLst>
-          </a:custGeom>
-          <a:blipFill>
-            <a:blip r:embed="rId4"/>
-            <a:stretch>
-              <a:fillRect l="0" t="0" r="0" b="0"/>
-            </a:stretch>
-          </a:blipFill>
-        </p:spPr>
-      </p:sp>
-      <p:sp>
-        <p:nvSpPr>
-          <p:cNvPr name="TextBox 7" id="7"/>
-          <p:cNvSpPr txBox="true"/>
-          <p:nvPr/>
-        </p:nvSpPr>
-        <p:spPr>
-          <a:xfrm rot="0">
-            <a:off x="2105025" y="5348287"/>
-            <a:ext cx="6886575" cy="817245"/>
+          <a:xfrm>
+            <a:off x="432000" y="540000"/>
+            <a:ext cx="17424000" cy="9387000"/>
           </a:xfrm>
           <a:prstGeom prst="rect">
             <a:avLst/>
           </a:prstGeom>
+          <a:solidFill>
+            <a:srgbClr val="0F1D35"/>
+          </a:solidFill>
+          <a:ln>
+            <a:noFill/>
+          </a:ln>
         </p:spPr>
-        <p:txBody>
-          <a:bodyPr anchor="t" rtlCol="false" tIns="0" lIns="0" bIns="0" rIns="0">
-            <a:spAutoFit/>
-          </a:bodyPr>
-          <a:lstStyle/>
-          <a:p>
-            <a:pPr algn="ctr" rtl="true" marL="0" indent="0" lvl="0">
-              <a:lnSpc>
-                <a:spcPts val="3120"/>
-              </a:lnSpc>
-            </a:pPr>
-            <a:r>
-              <a:rPr lang="ar-SA" dirty="0" sz="1900">
-                <a:solidFill>
-                  <a:srgbClr val="FFFFFF"/>
-                </a:solidFill>
-                <a:latin typeface="Noto Sans Arabic"/>
-                <a:ea typeface="Noto Sans Arabic"/>
-              </a:rPr>
-              <a:t>نظام صلاحيات متعدد المستويات: مدير، معلم، إداري، مديرة، ولي أمر</a:t>
-            </a:r>
-          </a:p>
-          <a:p>
-            <a:pPr algn="ctr" rtl="true" marL="0" indent="0" lvl="0">
-              <a:lnSpc>
-                <a:spcPts val="3120"/>
-              </a:lnSpc>
-            </a:pPr>
-            <a:r>
-              <a:rPr lang="ar-SA" dirty="0" sz="1900">
-                <a:solidFill>
-                  <a:srgbClr val="FFFFFF"/>
-                </a:solidFill>
-                <a:latin typeface="Noto Sans Arabic"/>
-                <a:ea typeface="Noto Sans Arabic"/>
-              </a:rPr>
-              <a:t>بيانات الطلاب محمية محلياً — لا تُرفع لخوادم خارجية</a:t>
-            </a:r>
-          </a:p>
-          <a:p>
-            <a:pPr algn="ctr" rtl="true" marL="0" indent="0" lvl="0">
-              <a:lnSpc>
-                <a:spcPts val="3120"/>
-              </a:lnSpc>
-            </a:pPr>
-            <a:r>
-              <a:rPr lang="ar-SA" dirty="0" sz="1900">
-                <a:solidFill>
-                  <a:srgbClr val="FFFFFF"/>
-                </a:solidFill>
-                <a:latin typeface="Noto Sans Arabic"/>
-                <a:ea typeface="Noto Sans Arabic"/>
-              </a:rPr>
-              <a:t>لوحة رقابة خاصة بمديرة المدرسة لمتابعة الأنشطة الرقمية</a:t>
-            </a:r>
-          </a:p>
-          <a:p>
-            <a:pPr algn="ctr" rtl="true" marL="0" indent="0" lvl="0">
-              <a:lnSpc>
-                <a:spcPts val="3120"/>
-              </a:lnSpc>
-            </a:pPr>
-            <a:r>
-              <a:rPr lang="ar-SA" dirty="0" sz="1900">
-                <a:solidFill>
-                  <a:srgbClr val="FFFFFF"/>
-                </a:solidFill>
-                <a:latin typeface="Noto Sans Arabic"/>
-                <a:ea typeface="Noto Sans Arabic"/>
-              </a:rPr>
-              <a:t>بوابة أولياء الأمور (قريباً) — اطلاع على بيانات أبنائهم فقط</a:t>
-            </a:r>
-          </a:p>
-          <a:p>
-            <a:pPr algn="ctr" rtl="true" marL="0" indent="0" lvl="0">
-              <a:lnSpc>
-                <a:spcPts val="3120"/>
-              </a:lnSpc>
-            </a:pPr>
-            <a:r>
-              <a:rPr lang="ar-SA" dirty="0" sz="1900">
-                <a:solidFill>
-                  <a:srgbClr val="FFFFFF"/>
-                </a:solidFill>
-                <a:latin typeface="Noto Sans Arabic"/>
-                <a:ea typeface="Noto Sans Arabic"/>
-              </a:rPr>
-              <a:t>امتثال تام لاشتراطات المرسوم الاتحادي رقم (2) لسنة 2026</a:t>
-            </a:r>
-          </a:p>
-        </p:txBody>
-      </p:sp>
-      <p:sp>
-        <p:nvSpPr>
-          <p:cNvPr name="TextBox 8" id="8"/>
-          <p:cNvSpPr txBox="true"/>
-          <p:nvPr/>
-        </p:nvSpPr>
-        <p:spPr>
-          <a:xfrm rot="0">
-            <a:off x="1414462" y="3330508"/>
-            <a:ext cx="8267700" cy="1812992"/>
-          </a:xfrm>
-          <a:prstGeom prst="rect">
-            <a:avLst/>
-          </a:prstGeom>
-        </p:spPr>
-        <p:txBody>
-          <a:bodyPr anchor="t" rtlCol="false" tIns="0" lIns="0" bIns="0" rIns="0">
-            <a:spAutoFit/>
-          </a:bodyPr>
-          <a:lstStyle/>
-          <a:p>
-            <a:pPr algn="ctr" rtl="true" marL="0" indent="0" lvl="0">
-              <a:lnSpc>
-                <a:spcPts val="6861"/>
-              </a:lnSpc>
-              <a:spcBef>
-                <a:spcPct val="0"/>
-              </a:spcBef>
-            </a:pPr>
-            <a:r>
-              <a:rPr lang="ar-SA" dirty="0" b="1" sz="3000">
-                <a:solidFill>
-                  <a:srgbClr val="C9A84C"/>
-                </a:solidFill>
-                <a:latin typeface="Noto Sans Arabic"/>
-                <a:ea typeface="Noto Sans Arabic"/>
-              </a:rPr>
-              <a:t>بوابة مدرسة الجود وقانون الطفل الرقمي</a:t>
-            </a:r>
-          </a:p>
-          <a:p>
-            <a:pPr algn="ctr" rtl="true" marL="0" indent="0" lvl="0">
-              <a:lnSpc>
-                <a:spcPts val="6861"/>
-              </a:lnSpc>
-              <a:spcBef>
-                <a:spcPct val="0"/>
-              </a:spcBef>
-            </a:pPr>
-            <a:r>
-              <a:rPr lang="en-US" dirty="0" sz="1800">
-                <a:solidFill>
-                  <a:srgbClr val="BBBBBB"/>
-                </a:solidFill>
-                <a:latin typeface="Calibri"/>
-              </a:rPr>
-              <a:t>Al Jood Portal Alignment with Child Digital Safety Law 2026</a:t>
-            </a:r>
-          </a:p>
-        </p:txBody>
-      </p:sp>
-      <p:sp>
-        <p:nvSpPr>
-          <p:cNvPr id="9" name="TextBox 8"/>
-          <p:cNvSpPr txBox="1"/>
+        <p:style>
+          <a:lnRef idx="1">
+            <a:schemeClr val="accent1"/>
+          </a:lnRef>
+          <a:fillRef idx="3">
+            <a:schemeClr val="accent1"/>
+          </a:fillRef>
+          <a:effectRef idx="2">
+            <a:schemeClr val="accent1"/>
+          </a:effectRef>
+          <a:fontRef idx="minor">
+            <a:schemeClr val="lt1"/>
+          </a:fontRef>
+        </p:style>
+        <p:txBody>
+          <a:bodyPr rtlCol="0" anchor="ctr"/>
+          <a:lstStyle/>
+          <a:p>
+            <a:pPr algn="ctr"/>
+          </a:p>
+        </p:txBody>
+      </p:sp>
+      <p:sp>
+        <p:nvSpPr>
+          <p:cNvPr id="6" name="Rectangle 5"/>
+          <p:cNvSpPr/>
           <p:nvPr/>
         </p:nvSpPr>
         <p:spPr>
           <a:xfrm>
-            <a:off x="10646645" y="2506609"/>
-            <a:ext cx="4285772" cy="500000"/>
-          </a:xfrm>
-          <a:prstGeom prst="rect">
-            <a:avLst/>
-          </a:prstGeom>
-          <a:noFill/>
-        </p:spPr>
-        <p:txBody>
-          <a:bodyPr wrap="square">
-            <a:spAutoFit/>
-          </a:bodyPr>
-          <a:lstStyle/>
-          <a:p>
-            <a:pPr algn="ctr"/>
-            <a:r>
-              <a:rPr sz="1700" b="1">
-                <a:solidFill>
-                  <a:srgbClr val="C9A84C"/>
-                </a:solidFill>
-                <a:latin typeface="Arial"/>
-              </a:rPr>
-              <a:t>مقارنة: القانون vs البوابة</a:t>
-            </a:r>
-          </a:p>
-        </p:txBody>
-      </p:sp>
-      <p:sp>
-        <p:nvSpPr>
-          <p:cNvPr id="10" name="TextBox 9"/>
-          <p:cNvSpPr txBox="1"/>
-          <p:nvPr/>
-        </p:nvSpPr>
-        <p:spPr>
-          <a:xfrm>
-            <a:off x="10646645" y="3006609"/>
-            <a:ext cx="4285772" cy="300000"/>
-          </a:xfrm>
-          <a:prstGeom prst="rect">
-            <a:avLst/>
-          </a:prstGeom>
-          <a:noFill/>
-        </p:spPr>
-        <p:txBody>
-          <a:bodyPr wrap="square">
-            <a:spAutoFit/>
-          </a:bodyPr>
-          <a:lstStyle/>
-          <a:p>
-            <a:pPr algn="ctr"/>
-            <a:r>
-              <a:rPr sz="1000" b="0">
-                <a:solidFill>
-                  <a:srgbClr val="BBCCDD"/>
-                </a:solidFill>
-                <a:latin typeface="Arial"/>
-              </a:rPr>
-              <a:t>Law Requirement  vs  Portal Feature</a:t>
-            </a:r>
-          </a:p>
-        </p:txBody>
-      </p:sp>
-      <p:sp>
-        <p:nvSpPr>
-          <p:cNvPr id="11" name="Rectangle 10"/>
-          <p:cNvSpPr/>
-          <p:nvPr/>
-        </p:nvSpPr>
-        <p:spPr>
-          <a:xfrm>
-            <a:off x="10846645" y="3356609"/>
-            <a:ext cx="3885772" cy="30000"/>
+            <a:off x="432000" y="540000"/>
+            <a:ext cx="17424000" cy="180000"/>
           </a:xfrm>
           <a:prstGeom prst="rect">
             <a:avLst/>
@@ -7514,14 +7596,14 @@
       </p:sp>
       <p:sp>
         <p:nvSpPr>
-          <p:cNvPr id="12" name="TextBox 11"/>
+          <p:cNvPr id="7" name="TextBox 6"/>
           <p:cNvSpPr txBox="1"/>
           <p:nvPr/>
         </p:nvSpPr>
         <p:spPr>
           <a:xfrm>
-            <a:off x="10696645" y="3406609"/>
-            <a:ext cx="350000" cy="320000"/>
+            <a:off x="540000" y="827999"/>
+            <a:ext cx="17208000" cy="432000"/>
           </a:xfrm>
           <a:prstGeom prst="rect">
             <a:avLst/>
@@ -7536,27 +7618,27 @@
           <a:p>
             <a:pPr algn="ctr"/>
             <a:r>
-              <a:rPr sz="1600" b="1">
+              <a:rPr sz="2200" b="1">
                 <a:solidFill>
-                  <a:srgbClr val="5DD39F"/>
+                  <a:srgbClr val="C9A84C"/>
                 </a:solidFill>
-                <a:latin typeface="Arial"/>
+                <a:latin typeface="Noto Sans Arabic"/>
               </a:rPr>
-              <a:t>✓</a:t>
+              <a:t>كيف تُجسّد بوابة الجود أحكام القانون؟</a:t>
             </a:r>
           </a:p>
         </p:txBody>
       </p:sp>
       <p:sp>
         <p:nvSpPr>
-          <p:cNvPr id="13" name="TextBox 12"/>
+          <p:cNvPr id="8" name="TextBox 7"/>
           <p:cNvSpPr txBox="1"/>
           <p:nvPr/>
         </p:nvSpPr>
         <p:spPr>
           <a:xfrm>
-            <a:off x="11046645" y="3406609"/>
-            <a:ext cx="3885772" cy="250000"/>
+            <a:off x="540000" y="1260000"/>
+            <a:ext cx="17208000" cy="288000"/>
           </a:xfrm>
           <a:prstGeom prst="rect">
             <a:avLst/>
@@ -7569,29 +7651,72 @@
           </a:bodyPr>
           <a:lstStyle/>
           <a:p>
-            <a:pPr algn="r"/>
+            <a:pPr algn="ctr"/>
             <a:r>
-              <a:rPr sz="1200" b="1">
+              <a:rPr sz="1200" b="0">
                 <a:solidFill>
-                  <a:srgbClr val="FFFFFF"/>
+                  <a:srgbClr val="CCCCCC"/>
                 </a:solidFill>
-                <a:latin typeface="Arial"/>
+                <a:latin typeface="Noto Sans Arabic"/>
               </a:rPr>
-              <a:t>حماية البيانات</a:t>
+              <a:t>How Al Jood Portal Implements the Child Digital Safety Law</a:t>
             </a:r>
           </a:p>
         </p:txBody>
       </p:sp>
       <p:sp>
         <p:nvSpPr>
-          <p:cNvPr id="14" name="TextBox 13"/>
-          <p:cNvSpPr txBox="1"/>
+          <p:cNvPr id="9" name="Rectangle 8"/>
+          <p:cNvSpPr/>
           <p:nvPr/>
         </p:nvSpPr>
         <p:spPr>
           <a:xfrm>
-            <a:off x="11046645" y="3666609"/>
-            <a:ext cx="3885772" cy="220000"/>
+            <a:off x="540000" y="1620000"/>
+            <a:ext cx="8496000" cy="251999"/>
+          </a:xfrm>
+          <a:prstGeom prst="rect">
+            <a:avLst/>
+          </a:prstGeom>
+          <a:solidFill>
+            <a:srgbClr val="1A2A4A"/>
+          </a:solidFill>
+          <a:ln>
+            <a:noFill/>
+          </a:ln>
+        </p:spPr>
+        <p:style>
+          <a:lnRef idx="1">
+            <a:schemeClr val="accent1"/>
+          </a:lnRef>
+          <a:fillRef idx="3">
+            <a:schemeClr val="accent1"/>
+          </a:fillRef>
+          <a:effectRef idx="2">
+            <a:schemeClr val="accent1"/>
+          </a:effectRef>
+          <a:fontRef idx="minor">
+            <a:schemeClr val="lt1"/>
+          </a:fontRef>
+        </p:style>
+        <p:txBody>
+          <a:bodyPr rtlCol="0" anchor="ctr"/>
+          <a:lstStyle/>
+          <a:p>
+            <a:pPr algn="ctr"/>
+          </a:p>
+        </p:txBody>
+      </p:sp>
+      <p:sp>
+        <p:nvSpPr>
+          <p:cNvPr id="10" name="TextBox 9"/>
+          <p:cNvSpPr txBox="1"/>
+          <p:nvPr/>
+        </p:nvSpPr>
+        <p:spPr>
+          <a:xfrm>
+            <a:off x="540000" y="1620000"/>
+            <a:ext cx="8496000" cy="251999"/>
           </a:xfrm>
           <a:prstGeom prst="rect">
             <a:avLst/>
@@ -7604,29 +7729,72 @@
           </a:bodyPr>
           <a:lstStyle/>
           <a:p>
-            <a:pPr algn="r"/>
+            <a:pPr algn="ctr"/>
             <a:r>
-              <a:rPr sz="1000" b="0">
+              <a:rPr sz="1300" b="1">
                 <a:solidFill>
                   <a:srgbClr val="C9A84C"/>
                 </a:solidFill>
-                <a:latin typeface="Arial"/>
+                <a:latin typeface="Noto Sans Arabic"/>
               </a:rPr>
-              <a:t>localStorage — لا سحابة</a:t>
+              <a:t>متطلب القانون</a:t>
             </a:r>
           </a:p>
         </p:txBody>
       </p:sp>
       <p:sp>
         <p:nvSpPr>
-          <p:cNvPr id="15" name="TextBox 14"/>
-          <p:cNvSpPr txBox="1"/>
+          <p:cNvPr id="11" name="Rectangle 10"/>
+          <p:cNvSpPr/>
           <p:nvPr/>
         </p:nvSpPr>
         <p:spPr>
           <a:xfrm>
-            <a:off x="10696645" y="4086609"/>
-            <a:ext cx="350000" cy="320000"/>
+            <a:off x="9252000" y="1620000"/>
+            <a:ext cx="8496000" cy="251999"/>
+          </a:xfrm>
+          <a:prstGeom prst="rect">
+            <a:avLst/>
+          </a:prstGeom>
+          <a:solidFill>
+            <a:srgbClr val="C9A84C"/>
+          </a:solidFill>
+          <a:ln>
+            <a:noFill/>
+          </a:ln>
+        </p:spPr>
+        <p:style>
+          <a:lnRef idx="1">
+            <a:schemeClr val="accent1"/>
+          </a:lnRef>
+          <a:fillRef idx="3">
+            <a:schemeClr val="accent1"/>
+          </a:fillRef>
+          <a:effectRef idx="2">
+            <a:schemeClr val="accent1"/>
+          </a:effectRef>
+          <a:fontRef idx="minor">
+            <a:schemeClr val="lt1"/>
+          </a:fontRef>
+        </p:style>
+        <p:txBody>
+          <a:bodyPr rtlCol="0" anchor="ctr"/>
+          <a:lstStyle/>
+          <a:p>
+            <a:pPr algn="ctr"/>
+          </a:p>
+        </p:txBody>
+      </p:sp>
+      <p:sp>
+        <p:nvSpPr>
+          <p:cNvPr id="12" name="TextBox 11"/>
+          <p:cNvSpPr txBox="1"/>
+          <p:nvPr/>
+        </p:nvSpPr>
+        <p:spPr>
+          <a:xfrm>
+            <a:off x="9252000" y="1620000"/>
+            <a:ext cx="8496000" cy="251999"/>
           </a:xfrm>
           <a:prstGeom prst="rect">
             <a:avLst/>
@@ -7641,27 +7809,70 @@
           <a:p>
             <a:pPr algn="ctr"/>
             <a:r>
-              <a:rPr sz="1600" b="1">
+              <a:rPr sz="1300" b="1">
                 <a:solidFill>
-                  <a:srgbClr val="5DD39F"/>
+                  <a:srgbClr val="1A2A4A"/>
                 </a:solidFill>
-                <a:latin typeface="Arial"/>
+                <a:latin typeface="Noto Sans Arabic"/>
               </a:rPr>
-              <a:t>✓</a:t>
+              <a:t>ميزة البوابة</a:t>
             </a:r>
           </a:p>
         </p:txBody>
       </p:sp>
       <p:sp>
         <p:nvSpPr>
-          <p:cNvPr id="16" name="TextBox 15"/>
-          <p:cNvSpPr txBox="1"/>
+          <p:cNvPr id="13" name="Rectangle 12"/>
+          <p:cNvSpPr/>
           <p:nvPr/>
         </p:nvSpPr>
         <p:spPr>
           <a:xfrm>
-            <a:off x="11046645" y="4086609"/>
-            <a:ext cx="3885772" cy="250000"/>
+            <a:off x="540000" y="1944000"/>
+            <a:ext cx="8496000" cy="342000"/>
+          </a:xfrm>
+          <a:prstGeom prst="rect">
+            <a:avLst/>
+          </a:prstGeom>
+          <a:solidFill>
+            <a:srgbClr val="1E3055"/>
+          </a:solidFill>
+          <a:ln>
+            <a:noFill/>
+          </a:ln>
+        </p:spPr>
+        <p:style>
+          <a:lnRef idx="1">
+            <a:schemeClr val="accent1"/>
+          </a:lnRef>
+          <a:fillRef idx="3">
+            <a:schemeClr val="accent1"/>
+          </a:fillRef>
+          <a:effectRef idx="2">
+            <a:schemeClr val="accent1"/>
+          </a:effectRef>
+          <a:fontRef idx="minor">
+            <a:schemeClr val="lt1"/>
+          </a:fontRef>
+        </p:style>
+        <p:txBody>
+          <a:bodyPr rtlCol="0" anchor="ctr"/>
+          <a:lstStyle/>
+          <a:p>
+            <a:pPr algn="ctr"/>
+          </a:p>
+        </p:txBody>
+      </p:sp>
+      <p:sp>
+        <p:nvSpPr>
+          <p:cNvPr id="14" name="TextBox 13"/>
+          <p:cNvSpPr txBox="1"/>
+          <p:nvPr/>
+        </p:nvSpPr>
+        <p:spPr>
+          <a:xfrm>
+            <a:off x="612000" y="1980000"/>
+            <a:ext cx="8352000" cy="306000"/>
           </a:xfrm>
           <a:prstGeom prst="rect">
             <a:avLst/>
@@ -7676,14 +7887,100 @@
           <a:p>
             <a:pPr algn="r"/>
             <a:r>
-              <a:rPr sz="1200" b="1">
+              <a:rPr sz="1200" b="0">
                 <a:solidFill>
                   <a:srgbClr val="FFFFFF"/>
                 </a:solidFill>
-                <a:latin typeface="Arial"/>
+                <a:latin typeface="Noto Sans Arabic"/>
               </a:rPr>
-              <a:t>توثيق الهوية</a:t>
+              <a:t>حماية بيانات الطلاب</a:t>
             </a:r>
+          </a:p>
+        </p:txBody>
+      </p:sp>
+      <p:sp>
+        <p:nvSpPr>
+          <p:cNvPr id="15" name="Rectangle 14"/>
+          <p:cNvSpPr/>
+          <p:nvPr/>
+        </p:nvSpPr>
+        <p:spPr>
+          <a:xfrm>
+            <a:off x="9252000" y="1944000"/>
+            <a:ext cx="8496000" cy="342000"/>
+          </a:xfrm>
+          <a:prstGeom prst="rect">
+            <a:avLst/>
+          </a:prstGeom>
+          <a:solidFill>
+            <a:srgbClr val="1E3055"/>
+          </a:solidFill>
+          <a:ln>
+            <a:noFill/>
+          </a:ln>
+        </p:spPr>
+        <p:style>
+          <a:lnRef idx="1">
+            <a:schemeClr val="accent1"/>
+          </a:lnRef>
+          <a:fillRef idx="3">
+            <a:schemeClr val="accent1"/>
+          </a:fillRef>
+          <a:effectRef idx="2">
+            <a:schemeClr val="accent1"/>
+          </a:effectRef>
+          <a:fontRef idx="minor">
+            <a:schemeClr val="lt1"/>
+          </a:fontRef>
+        </p:style>
+        <p:txBody>
+          <a:bodyPr rtlCol="0" anchor="ctr"/>
+          <a:lstStyle/>
+          <a:p>
+            <a:pPr algn="ctr"/>
+          </a:p>
+        </p:txBody>
+      </p:sp>
+      <p:sp>
+        <p:nvSpPr>
+          <p:cNvPr id="16" name="Rectangle 15"/>
+          <p:cNvSpPr/>
+          <p:nvPr/>
+        </p:nvSpPr>
+        <p:spPr>
+          <a:xfrm>
+            <a:off x="17424000" y="2016000"/>
+            <a:ext cx="198000" cy="198000"/>
+          </a:xfrm>
+          <a:prstGeom prst="rect">
+            <a:avLst/>
+          </a:prstGeom>
+          <a:solidFill>
+            <a:srgbClr val="4CC97A"/>
+          </a:solidFill>
+          <a:ln>
+            <a:noFill/>
+          </a:ln>
+        </p:spPr>
+        <p:style>
+          <a:lnRef idx="1">
+            <a:schemeClr val="accent1"/>
+          </a:lnRef>
+          <a:fillRef idx="3">
+            <a:schemeClr val="accent1"/>
+          </a:fillRef>
+          <a:effectRef idx="2">
+            <a:schemeClr val="accent1"/>
+          </a:effectRef>
+          <a:fontRef idx="minor">
+            <a:schemeClr val="lt1"/>
+          </a:fontRef>
+        </p:style>
+        <p:txBody>
+          <a:bodyPr rtlCol="0" anchor="ctr"/>
+          <a:lstStyle/>
+          <a:p>
+            <a:pPr algn="ctr"/>
           </a:p>
         </p:txBody>
       </p:sp>
@@ -7695,8 +7992,8 @@
         </p:nvSpPr>
         <p:spPr>
           <a:xfrm>
-            <a:off x="11046645" y="4346609"/>
-            <a:ext cx="3885772" cy="220000"/>
+            <a:off x="9324000" y="1980000"/>
+            <a:ext cx="8064000" cy="306000"/>
           </a:xfrm>
           <a:prstGeom prst="rect">
             <a:avLst/>
@@ -7711,27 +8008,70 @@
           <a:p>
             <a:pPr algn="r"/>
             <a:r>
-              <a:rPr sz="1000" b="0">
+              <a:rPr sz="1200" b="0">
                 <a:solidFill>
-                  <a:srgbClr val="C9A84C"/>
+                  <a:srgbClr val="FFFFFF"/>
                 </a:solidFill>
-                <a:latin typeface="Arial"/>
+                <a:latin typeface="Noto Sans Arabic"/>
               </a:rPr>
-              <a:t>تسجيل دخول متعدد الأدوار</a:t>
+              <a:t>بيانات محلية — لا سحابة خارجية</a:t>
             </a:r>
           </a:p>
         </p:txBody>
       </p:sp>
       <p:sp>
         <p:nvSpPr>
-          <p:cNvPr id="18" name="TextBox 17"/>
-          <p:cNvSpPr txBox="1"/>
+          <p:cNvPr id="18" name="Rectangle 17"/>
+          <p:cNvSpPr/>
           <p:nvPr/>
         </p:nvSpPr>
         <p:spPr>
           <a:xfrm>
-            <a:off x="10696645" y="4766609"/>
-            <a:ext cx="350000" cy="320000"/>
+            <a:off x="540000" y="2350800"/>
+            <a:ext cx="8496000" cy="342000"/>
+          </a:xfrm>
+          <a:prstGeom prst="rect">
+            <a:avLst/>
+          </a:prstGeom>
+          <a:solidFill>
+            <a:srgbClr val="22355F"/>
+          </a:solidFill>
+          <a:ln>
+            <a:noFill/>
+          </a:ln>
+        </p:spPr>
+        <p:style>
+          <a:lnRef idx="1">
+            <a:schemeClr val="accent1"/>
+          </a:lnRef>
+          <a:fillRef idx="3">
+            <a:schemeClr val="accent1"/>
+          </a:fillRef>
+          <a:effectRef idx="2">
+            <a:schemeClr val="accent1"/>
+          </a:effectRef>
+          <a:fontRef idx="minor">
+            <a:schemeClr val="lt1"/>
+          </a:fontRef>
+        </p:style>
+        <p:txBody>
+          <a:bodyPr rtlCol="0" anchor="ctr"/>
+          <a:lstStyle/>
+          <a:p>
+            <a:pPr algn="ctr"/>
+          </a:p>
+        </p:txBody>
+      </p:sp>
+      <p:sp>
+        <p:nvSpPr>
+          <p:cNvPr id="19" name="TextBox 18"/>
+          <p:cNvSpPr txBox="1"/>
+          <p:nvPr/>
+        </p:nvSpPr>
+        <p:spPr>
+          <a:xfrm>
+            <a:off x="612000" y="2386800"/>
+            <a:ext cx="8352000" cy="306000"/>
           </a:xfrm>
           <a:prstGeom prst="rect">
             <a:avLst/>
@@ -7744,29 +8084,115 @@
           </a:bodyPr>
           <a:lstStyle/>
           <a:p>
-            <a:pPr algn="ctr"/>
+            <a:pPr algn="r"/>
             <a:r>
-              <a:rPr sz="1600" b="1">
+              <a:rPr sz="1200" b="0">
                 <a:solidFill>
-                  <a:srgbClr val="5DD39F"/>
+                  <a:srgbClr val="FFFFFF"/>
                 </a:solidFill>
-                <a:latin typeface="Arial"/>
+                <a:latin typeface="Noto Sans Arabic"/>
               </a:rPr>
-              <a:t>✓</a:t>
+              <a:t>توثيق هوية المستخدمين</a:t>
             </a:r>
           </a:p>
         </p:txBody>
       </p:sp>
       <p:sp>
         <p:nvSpPr>
-          <p:cNvPr id="19" name="TextBox 18"/>
-          <p:cNvSpPr txBox="1"/>
+          <p:cNvPr id="20" name="Rectangle 19"/>
+          <p:cNvSpPr/>
           <p:nvPr/>
         </p:nvSpPr>
         <p:spPr>
           <a:xfrm>
-            <a:off x="11046645" y="4766609"/>
-            <a:ext cx="3885772" cy="250000"/>
+            <a:off x="9252000" y="2350800"/>
+            <a:ext cx="8496000" cy="342000"/>
+          </a:xfrm>
+          <a:prstGeom prst="rect">
+            <a:avLst/>
+          </a:prstGeom>
+          <a:solidFill>
+            <a:srgbClr val="22355F"/>
+          </a:solidFill>
+          <a:ln>
+            <a:noFill/>
+          </a:ln>
+        </p:spPr>
+        <p:style>
+          <a:lnRef idx="1">
+            <a:schemeClr val="accent1"/>
+          </a:lnRef>
+          <a:fillRef idx="3">
+            <a:schemeClr val="accent1"/>
+          </a:fillRef>
+          <a:effectRef idx="2">
+            <a:schemeClr val="accent1"/>
+          </a:effectRef>
+          <a:fontRef idx="minor">
+            <a:schemeClr val="lt1"/>
+          </a:fontRef>
+        </p:style>
+        <p:txBody>
+          <a:bodyPr rtlCol="0" anchor="ctr"/>
+          <a:lstStyle/>
+          <a:p>
+            <a:pPr algn="ctr"/>
+          </a:p>
+        </p:txBody>
+      </p:sp>
+      <p:sp>
+        <p:nvSpPr>
+          <p:cNvPr id="21" name="Rectangle 20"/>
+          <p:cNvSpPr/>
+          <p:nvPr/>
+        </p:nvSpPr>
+        <p:spPr>
+          <a:xfrm>
+            <a:off x="17424000" y="2422800"/>
+            <a:ext cx="198000" cy="198000"/>
+          </a:xfrm>
+          <a:prstGeom prst="rect">
+            <a:avLst/>
+          </a:prstGeom>
+          <a:solidFill>
+            <a:srgbClr val="4CC97A"/>
+          </a:solidFill>
+          <a:ln>
+            <a:noFill/>
+          </a:ln>
+        </p:spPr>
+        <p:style>
+          <a:lnRef idx="1">
+            <a:schemeClr val="accent1"/>
+          </a:lnRef>
+          <a:fillRef idx="3">
+            <a:schemeClr val="accent1"/>
+          </a:fillRef>
+          <a:effectRef idx="2">
+            <a:schemeClr val="accent1"/>
+          </a:effectRef>
+          <a:fontRef idx="minor">
+            <a:schemeClr val="lt1"/>
+          </a:fontRef>
+        </p:style>
+        <p:txBody>
+          <a:bodyPr rtlCol="0" anchor="ctr"/>
+          <a:lstStyle/>
+          <a:p>
+            <a:pPr algn="ctr"/>
+          </a:p>
+        </p:txBody>
+      </p:sp>
+      <p:sp>
+        <p:nvSpPr>
+          <p:cNvPr id="22" name="TextBox 21"/>
+          <p:cNvSpPr txBox="1"/>
+          <p:nvPr/>
+        </p:nvSpPr>
+        <p:spPr>
+          <a:xfrm>
+            <a:off x="9324000" y="2386800"/>
+            <a:ext cx="8064000" cy="306000"/>
           </a:xfrm>
           <a:prstGeom prst="rect">
             <a:avLst/>
@@ -7781,27 +8207,70 @@
           <a:p>
             <a:pPr algn="r"/>
             <a:r>
-              <a:rPr sz="1200" b="1">
+              <a:rPr sz="1200" b="0">
                 <a:solidFill>
                   <a:srgbClr val="FFFFFF"/>
                 </a:solidFill>
-                <a:latin typeface="Arial"/>
+                <a:latin typeface="Noto Sans Arabic"/>
               </a:rPr>
-              <a:t>رقابة أولياء الأمور</a:t>
+              <a:t>نظام تسجيل دخول بـ 5 مستويات</a:t>
             </a:r>
           </a:p>
         </p:txBody>
       </p:sp>
       <p:sp>
         <p:nvSpPr>
-          <p:cNvPr id="20" name="TextBox 19"/>
-          <p:cNvSpPr txBox="1"/>
+          <p:cNvPr id="23" name="Rectangle 22"/>
+          <p:cNvSpPr/>
           <p:nvPr/>
         </p:nvSpPr>
         <p:spPr>
           <a:xfrm>
-            <a:off x="11046645" y="5026609"/>
-            <a:ext cx="3885772" cy="220000"/>
+            <a:off x="540000" y="2757600"/>
+            <a:ext cx="8496000" cy="342000"/>
+          </a:xfrm>
+          <a:prstGeom prst="rect">
+            <a:avLst/>
+          </a:prstGeom>
+          <a:solidFill>
+            <a:srgbClr val="1E3055"/>
+          </a:solidFill>
+          <a:ln>
+            <a:noFill/>
+          </a:ln>
+        </p:spPr>
+        <p:style>
+          <a:lnRef idx="1">
+            <a:schemeClr val="accent1"/>
+          </a:lnRef>
+          <a:fillRef idx="3">
+            <a:schemeClr val="accent1"/>
+          </a:fillRef>
+          <a:effectRef idx="2">
+            <a:schemeClr val="accent1"/>
+          </a:effectRef>
+          <a:fontRef idx="minor">
+            <a:schemeClr val="lt1"/>
+          </a:fontRef>
+        </p:style>
+        <p:txBody>
+          <a:bodyPr rtlCol="0" anchor="ctr"/>
+          <a:lstStyle/>
+          <a:p>
+            <a:pPr algn="ctr"/>
+          </a:p>
+        </p:txBody>
+      </p:sp>
+      <p:sp>
+        <p:nvSpPr>
+          <p:cNvPr id="24" name="TextBox 23"/>
+          <p:cNvSpPr txBox="1"/>
+          <p:nvPr/>
+        </p:nvSpPr>
+        <p:spPr>
+          <a:xfrm>
+            <a:off x="612000" y="2793600"/>
+            <a:ext cx="8352000" cy="306000"/>
           </a:xfrm>
           <a:prstGeom prst="rect">
             <a:avLst/>
@@ -7816,27 +8285,113 @@
           <a:p>
             <a:pPr algn="r"/>
             <a:r>
-              <a:rPr sz="1000" b="0">
+              <a:rPr sz="1200" b="0">
                 <a:solidFill>
-                  <a:srgbClr val="C9A84C"/>
+                  <a:srgbClr val="FFFFFF"/>
                 </a:solidFill>
-                <a:latin typeface="Arial"/>
+                <a:latin typeface="Noto Sans Arabic"/>
               </a:rPr>
-              <a:t>بوابة ولي الأمر قريباً</a:t>
+              <a:t>رقابة أولياء الأمور</a:t>
             </a:r>
           </a:p>
         </p:txBody>
       </p:sp>
       <p:sp>
         <p:nvSpPr>
-          <p:cNvPr id="21" name="TextBox 20"/>
-          <p:cNvSpPr txBox="1"/>
+          <p:cNvPr id="25" name="Rectangle 24"/>
+          <p:cNvSpPr/>
           <p:nvPr/>
         </p:nvSpPr>
         <p:spPr>
           <a:xfrm>
-            <a:off x="10696645" y="5446609"/>
-            <a:ext cx="350000" cy="320000"/>
+            <a:off x="9252000" y="2757600"/>
+            <a:ext cx="8496000" cy="342000"/>
+          </a:xfrm>
+          <a:prstGeom prst="rect">
+            <a:avLst/>
+          </a:prstGeom>
+          <a:solidFill>
+            <a:srgbClr val="1E3055"/>
+          </a:solidFill>
+          <a:ln>
+            <a:noFill/>
+          </a:ln>
+        </p:spPr>
+        <p:style>
+          <a:lnRef idx="1">
+            <a:schemeClr val="accent1"/>
+          </a:lnRef>
+          <a:fillRef idx="3">
+            <a:schemeClr val="accent1"/>
+          </a:fillRef>
+          <a:effectRef idx="2">
+            <a:schemeClr val="accent1"/>
+          </a:effectRef>
+          <a:fontRef idx="minor">
+            <a:schemeClr val="lt1"/>
+          </a:fontRef>
+        </p:style>
+        <p:txBody>
+          <a:bodyPr rtlCol="0" anchor="ctr"/>
+          <a:lstStyle/>
+          <a:p>
+            <a:pPr algn="ctr"/>
+          </a:p>
+        </p:txBody>
+      </p:sp>
+      <p:sp>
+        <p:nvSpPr>
+          <p:cNvPr id="26" name="Rectangle 25"/>
+          <p:cNvSpPr/>
+          <p:nvPr/>
+        </p:nvSpPr>
+        <p:spPr>
+          <a:xfrm>
+            <a:off x="17424000" y="2829600"/>
+            <a:ext cx="198000" cy="198000"/>
+          </a:xfrm>
+          <a:prstGeom prst="rect">
+            <a:avLst/>
+          </a:prstGeom>
+          <a:solidFill>
+            <a:srgbClr val="4CC97A"/>
+          </a:solidFill>
+          <a:ln>
+            <a:noFill/>
+          </a:ln>
+        </p:spPr>
+        <p:style>
+          <a:lnRef idx="1">
+            <a:schemeClr val="accent1"/>
+          </a:lnRef>
+          <a:fillRef idx="3">
+            <a:schemeClr val="accent1"/>
+          </a:fillRef>
+          <a:effectRef idx="2">
+            <a:schemeClr val="accent1"/>
+          </a:effectRef>
+          <a:fontRef idx="minor">
+            <a:schemeClr val="lt1"/>
+          </a:fontRef>
+        </p:style>
+        <p:txBody>
+          <a:bodyPr rtlCol="0" anchor="ctr"/>
+          <a:lstStyle/>
+          <a:p>
+            <a:pPr algn="ctr"/>
+          </a:p>
+        </p:txBody>
+      </p:sp>
+      <p:sp>
+        <p:nvSpPr>
+          <p:cNvPr id="27" name="TextBox 26"/>
+          <p:cNvSpPr txBox="1"/>
+          <p:nvPr/>
+        </p:nvSpPr>
+        <p:spPr>
+          <a:xfrm>
+            <a:off x="9324000" y="2793600"/>
+            <a:ext cx="8064000" cy="306000"/>
           </a:xfrm>
           <a:prstGeom prst="rect">
             <a:avLst/>
@@ -7849,29 +8404,72 @@
           </a:bodyPr>
           <a:lstStyle/>
           <a:p>
-            <a:pPr algn="ctr"/>
+            <a:pPr algn="r"/>
             <a:r>
-              <a:rPr sz="1600" b="1">
+              <a:rPr sz="1200" b="0">
                 <a:solidFill>
-                  <a:srgbClr val="5DD39F"/>
+                  <a:srgbClr val="FFFFFF"/>
                 </a:solidFill>
-                <a:latin typeface="Arial"/>
+                <a:latin typeface="Noto Sans Arabic"/>
               </a:rPr>
-              <a:t>✓</a:t>
+              <a:t>بوابة ولي الأمر — قريباً</a:t>
             </a:r>
           </a:p>
         </p:txBody>
       </p:sp>
       <p:sp>
         <p:nvSpPr>
-          <p:cNvPr id="22" name="TextBox 21"/>
-          <p:cNvSpPr txBox="1"/>
+          <p:cNvPr id="28" name="Rectangle 27"/>
+          <p:cNvSpPr/>
           <p:nvPr/>
         </p:nvSpPr>
         <p:spPr>
           <a:xfrm>
-            <a:off x="11046645" y="5446609"/>
-            <a:ext cx="3885772" cy="250000"/>
+            <a:off x="540000" y="3164400"/>
+            <a:ext cx="8496000" cy="342000"/>
+          </a:xfrm>
+          <a:prstGeom prst="rect">
+            <a:avLst/>
+          </a:prstGeom>
+          <a:solidFill>
+            <a:srgbClr val="22355F"/>
+          </a:solidFill>
+          <a:ln>
+            <a:noFill/>
+          </a:ln>
+        </p:spPr>
+        <p:style>
+          <a:lnRef idx="1">
+            <a:schemeClr val="accent1"/>
+          </a:lnRef>
+          <a:fillRef idx="3">
+            <a:schemeClr val="accent1"/>
+          </a:fillRef>
+          <a:effectRef idx="2">
+            <a:schemeClr val="accent1"/>
+          </a:effectRef>
+          <a:fontRef idx="minor">
+            <a:schemeClr val="lt1"/>
+          </a:fontRef>
+        </p:style>
+        <p:txBody>
+          <a:bodyPr rtlCol="0" anchor="ctr"/>
+          <a:lstStyle/>
+          <a:p>
+            <a:pPr algn="ctr"/>
+          </a:p>
+        </p:txBody>
+      </p:sp>
+      <p:sp>
+        <p:nvSpPr>
+          <p:cNvPr id="29" name="TextBox 28"/>
+          <p:cNvSpPr txBox="1"/>
+          <p:nvPr/>
+        </p:nvSpPr>
+        <p:spPr>
+          <a:xfrm>
+            <a:off x="612000" y="3200400"/>
+            <a:ext cx="8352000" cy="306000"/>
           </a:xfrm>
           <a:prstGeom prst="rect">
             <a:avLst/>
@@ -7886,27 +8484,113 @@
           <a:p>
             <a:pPr algn="r"/>
             <a:r>
-              <a:rPr sz="1200" b="1">
+              <a:rPr sz="1200" b="0">
                 <a:solidFill>
                   <a:srgbClr val="FFFFFF"/>
                 </a:solidFill>
-                <a:latin typeface="Arial"/>
+                <a:latin typeface="Noto Sans Arabic"/>
               </a:rPr>
-              <a:t>ضبط الصلاحيات</a:t>
+              <a:t>الإبلاغ عن الاختراقات</a:t>
             </a:r>
           </a:p>
         </p:txBody>
       </p:sp>
       <p:sp>
         <p:nvSpPr>
-          <p:cNvPr id="23" name="TextBox 22"/>
-          <p:cNvSpPr txBox="1"/>
+          <p:cNvPr id="30" name="Rectangle 29"/>
+          <p:cNvSpPr/>
           <p:nvPr/>
         </p:nvSpPr>
         <p:spPr>
           <a:xfrm>
-            <a:off x="11046645" y="5706609"/>
-            <a:ext cx="3885772" cy="220000"/>
+            <a:off x="9252000" y="3164400"/>
+            <a:ext cx="8496000" cy="342000"/>
+          </a:xfrm>
+          <a:prstGeom prst="rect">
+            <a:avLst/>
+          </a:prstGeom>
+          <a:solidFill>
+            <a:srgbClr val="22355F"/>
+          </a:solidFill>
+          <a:ln>
+            <a:noFill/>
+          </a:ln>
+        </p:spPr>
+        <p:style>
+          <a:lnRef idx="1">
+            <a:schemeClr val="accent1"/>
+          </a:lnRef>
+          <a:fillRef idx="3">
+            <a:schemeClr val="accent1"/>
+          </a:fillRef>
+          <a:effectRef idx="2">
+            <a:schemeClr val="accent1"/>
+          </a:effectRef>
+          <a:fontRef idx="minor">
+            <a:schemeClr val="lt1"/>
+          </a:fontRef>
+        </p:style>
+        <p:txBody>
+          <a:bodyPr rtlCol="0" anchor="ctr"/>
+          <a:lstStyle/>
+          <a:p>
+            <a:pPr algn="ctr"/>
+          </a:p>
+        </p:txBody>
+      </p:sp>
+      <p:sp>
+        <p:nvSpPr>
+          <p:cNvPr id="31" name="Rectangle 30"/>
+          <p:cNvSpPr/>
+          <p:nvPr/>
+        </p:nvSpPr>
+        <p:spPr>
+          <a:xfrm>
+            <a:off x="17424000" y="3236400"/>
+            <a:ext cx="198000" cy="198000"/>
+          </a:xfrm>
+          <a:prstGeom prst="rect">
+            <a:avLst/>
+          </a:prstGeom>
+          <a:solidFill>
+            <a:srgbClr val="4CC97A"/>
+          </a:solidFill>
+          <a:ln>
+            <a:noFill/>
+          </a:ln>
+        </p:spPr>
+        <p:style>
+          <a:lnRef idx="1">
+            <a:schemeClr val="accent1"/>
+          </a:lnRef>
+          <a:fillRef idx="3">
+            <a:schemeClr val="accent1"/>
+          </a:fillRef>
+          <a:effectRef idx="2">
+            <a:schemeClr val="accent1"/>
+          </a:effectRef>
+          <a:fontRef idx="minor">
+            <a:schemeClr val="lt1"/>
+          </a:fontRef>
+        </p:style>
+        <p:txBody>
+          <a:bodyPr rtlCol="0" anchor="ctr"/>
+          <a:lstStyle/>
+          <a:p>
+            <a:pPr algn="ctr"/>
+          </a:p>
+        </p:txBody>
+      </p:sp>
+      <p:sp>
+        <p:nvSpPr>
+          <p:cNvPr id="32" name="TextBox 31"/>
+          <p:cNvSpPr txBox="1"/>
+          <p:nvPr/>
+        </p:nvSpPr>
+        <p:spPr>
+          <a:xfrm>
+            <a:off x="9324000" y="3200400"/>
+            <a:ext cx="8064000" cy="306000"/>
           </a:xfrm>
           <a:prstGeom prst="rect">
             <a:avLst/>
@@ -7921,27 +8605,70 @@
           <a:p>
             <a:pPr algn="r"/>
             <a:r>
-              <a:rPr sz="1000" b="0">
+              <a:rPr sz="1200" b="0">
                 <a:solidFill>
-                  <a:srgbClr val="C9A84C"/>
+                  <a:srgbClr val="FFFFFF"/>
                 </a:solidFill>
-                <a:latin typeface="Arial"/>
+                <a:latin typeface="Noto Sans Arabic"/>
               </a:rPr>
-              <a:t>5 مستويات وصول</a:t>
+              <a:t>سجل تدقيق مدمج</a:t>
             </a:r>
           </a:p>
         </p:txBody>
       </p:sp>
       <p:sp>
         <p:nvSpPr>
-          <p:cNvPr id="24" name="TextBox 23"/>
-          <p:cNvSpPr txBox="1"/>
+          <p:cNvPr id="33" name="Rectangle 32"/>
+          <p:cNvSpPr/>
           <p:nvPr/>
         </p:nvSpPr>
         <p:spPr>
           <a:xfrm>
-            <a:off x="10696645" y="6126609"/>
-            <a:ext cx="350000" cy="320000"/>
+            <a:off x="540000" y="3571200"/>
+            <a:ext cx="8496000" cy="342000"/>
+          </a:xfrm>
+          <a:prstGeom prst="rect">
+            <a:avLst/>
+          </a:prstGeom>
+          <a:solidFill>
+            <a:srgbClr val="1E3055"/>
+          </a:solidFill>
+          <a:ln>
+            <a:noFill/>
+          </a:ln>
+        </p:spPr>
+        <p:style>
+          <a:lnRef idx="1">
+            <a:schemeClr val="accent1"/>
+          </a:lnRef>
+          <a:fillRef idx="3">
+            <a:schemeClr val="accent1"/>
+          </a:fillRef>
+          <a:effectRef idx="2">
+            <a:schemeClr val="accent1"/>
+          </a:effectRef>
+          <a:fontRef idx="minor">
+            <a:schemeClr val="lt1"/>
+          </a:fontRef>
+        </p:style>
+        <p:txBody>
+          <a:bodyPr rtlCol="0" anchor="ctr"/>
+          <a:lstStyle/>
+          <a:p>
+            <a:pPr algn="ctr"/>
+          </a:p>
+        </p:txBody>
+      </p:sp>
+      <p:sp>
+        <p:nvSpPr>
+          <p:cNvPr id="34" name="TextBox 33"/>
+          <p:cNvSpPr txBox="1"/>
+          <p:nvPr/>
+        </p:nvSpPr>
+        <p:spPr>
+          <a:xfrm>
+            <a:off x="612000" y="3607200"/>
+            <a:ext cx="8352000" cy="306000"/>
           </a:xfrm>
           <a:prstGeom prst="rect">
             <a:avLst/>
@@ -7954,29 +8681,115 @@
           </a:bodyPr>
           <a:lstStyle/>
           <a:p>
-            <a:pPr algn="ctr"/>
+            <a:pPr algn="r"/>
             <a:r>
-              <a:rPr sz="1600" b="1">
+              <a:rPr sz="1200" b="0">
                 <a:solidFill>
-                  <a:srgbClr val="5DD39F"/>
+                  <a:srgbClr val="FFFFFF"/>
                 </a:solidFill>
-                <a:latin typeface="Arial"/>
+                <a:latin typeface="Noto Sans Arabic"/>
               </a:rPr>
-              <a:t>✓</a:t>
+              <a:t>ضبط صلاحيات الوصول</a:t>
             </a:r>
           </a:p>
         </p:txBody>
       </p:sp>
       <p:sp>
         <p:nvSpPr>
-          <p:cNvPr id="25" name="TextBox 24"/>
-          <p:cNvSpPr txBox="1"/>
+          <p:cNvPr id="35" name="Rectangle 34"/>
+          <p:cNvSpPr/>
           <p:nvPr/>
         </p:nvSpPr>
         <p:spPr>
           <a:xfrm>
-            <a:off x="11046645" y="6126609"/>
-            <a:ext cx="3885772" cy="250000"/>
+            <a:off x="9252000" y="3571200"/>
+            <a:ext cx="8496000" cy="342000"/>
+          </a:xfrm>
+          <a:prstGeom prst="rect">
+            <a:avLst/>
+          </a:prstGeom>
+          <a:solidFill>
+            <a:srgbClr val="1E3055"/>
+          </a:solidFill>
+          <a:ln>
+            <a:noFill/>
+          </a:ln>
+        </p:spPr>
+        <p:style>
+          <a:lnRef idx="1">
+            <a:schemeClr val="accent1"/>
+          </a:lnRef>
+          <a:fillRef idx="3">
+            <a:schemeClr val="accent1"/>
+          </a:fillRef>
+          <a:effectRef idx="2">
+            <a:schemeClr val="accent1"/>
+          </a:effectRef>
+          <a:fontRef idx="minor">
+            <a:schemeClr val="lt1"/>
+          </a:fontRef>
+        </p:style>
+        <p:txBody>
+          <a:bodyPr rtlCol="0" anchor="ctr"/>
+          <a:lstStyle/>
+          <a:p>
+            <a:pPr algn="ctr"/>
+          </a:p>
+        </p:txBody>
+      </p:sp>
+      <p:sp>
+        <p:nvSpPr>
+          <p:cNvPr id="36" name="Rectangle 35"/>
+          <p:cNvSpPr/>
+          <p:nvPr/>
+        </p:nvSpPr>
+        <p:spPr>
+          <a:xfrm>
+            <a:off x="17424000" y="3643200"/>
+            <a:ext cx="198000" cy="198000"/>
+          </a:xfrm>
+          <a:prstGeom prst="rect">
+            <a:avLst/>
+          </a:prstGeom>
+          <a:solidFill>
+            <a:srgbClr val="4CC97A"/>
+          </a:solidFill>
+          <a:ln>
+            <a:noFill/>
+          </a:ln>
+        </p:spPr>
+        <p:style>
+          <a:lnRef idx="1">
+            <a:schemeClr val="accent1"/>
+          </a:lnRef>
+          <a:fillRef idx="3">
+            <a:schemeClr val="accent1"/>
+          </a:fillRef>
+          <a:effectRef idx="2">
+            <a:schemeClr val="accent1"/>
+          </a:effectRef>
+          <a:fontRef idx="minor">
+            <a:schemeClr val="lt1"/>
+          </a:fontRef>
+        </p:style>
+        <p:txBody>
+          <a:bodyPr rtlCol="0" anchor="ctr"/>
+          <a:lstStyle/>
+          <a:p>
+            <a:pPr algn="ctr"/>
+          </a:p>
+        </p:txBody>
+      </p:sp>
+      <p:sp>
+        <p:nvSpPr>
+          <p:cNvPr id="37" name="TextBox 36"/>
+          <p:cNvSpPr txBox="1"/>
+          <p:nvPr/>
+        </p:nvSpPr>
+        <p:spPr>
+          <a:xfrm>
+            <a:off x="9324000" y="3607200"/>
+            <a:ext cx="8064000" cy="306000"/>
           </a:xfrm>
           <a:prstGeom prst="rect">
             <a:avLst/>
@@ -7991,27 +8804,70 @@
           <a:p>
             <a:pPr algn="r"/>
             <a:r>
-              <a:rPr sz="1200" b="1">
+              <a:rPr sz="1200" b="0">
                 <a:solidFill>
                   <a:srgbClr val="FFFFFF"/>
                 </a:solidFill>
-                <a:latin typeface="Arial"/>
+                <a:latin typeface="Noto Sans Arabic"/>
               </a:rPr>
-              <a:t>الشفافية</a:t>
+              <a:t>صلاحيات CRUD منفصلة لكل دور</a:t>
             </a:r>
           </a:p>
         </p:txBody>
       </p:sp>
       <p:sp>
         <p:nvSpPr>
-          <p:cNvPr id="26" name="TextBox 25"/>
-          <p:cNvSpPr txBox="1"/>
+          <p:cNvPr id="38" name="Rectangle 37"/>
+          <p:cNvSpPr/>
           <p:nvPr/>
         </p:nvSpPr>
         <p:spPr>
           <a:xfrm>
-            <a:off x="11046645" y="6386609"/>
-            <a:ext cx="3885772" cy="220000"/>
+            <a:off x="648000" y="4122000"/>
+            <a:ext cx="5604000" cy="396000"/>
+          </a:xfrm>
+          <a:prstGeom prst="rect">
+            <a:avLst/>
+          </a:prstGeom>
+          <a:solidFill>
+            <a:srgbClr val="C9A84C"/>
+          </a:solidFill>
+          <a:ln>
+            <a:noFill/>
+          </a:ln>
+        </p:spPr>
+        <p:style>
+          <a:lnRef idx="1">
+            <a:schemeClr val="accent1"/>
+          </a:lnRef>
+          <a:fillRef idx="3">
+            <a:schemeClr val="accent1"/>
+          </a:fillRef>
+          <a:effectRef idx="2">
+            <a:schemeClr val="accent1"/>
+          </a:effectRef>
+          <a:fontRef idx="minor">
+            <a:schemeClr val="lt1"/>
+          </a:fontRef>
+        </p:style>
+        <p:txBody>
+          <a:bodyPr rtlCol="0" anchor="ctr"/>
+          <a:lstStyle/>
+          <a:p>
+            <a:pPr algn="ctr"/>
+          </a:p>
+        </p:txBody>
+      </p:sp>
+      <p:sp>
+        <p:nvSpPr>
+          <p:cNvPr id="39" name="TextBox 38"/>
+          <p:cNvSpPr txBox="1"/>
+          <p:nvPr/>
+        </p:nvSpPr>
+        <p:spPr>
+          <a:xfrm>
+            <a:off x="648000" y="4122000"/>
+            <a:ext cx="5604000" cy="216000"/>
           </a:xfrm>
           <a:prstGeom prst="rect">
             <a:avLst/>
@@ -8024,15 +8880,276 @@
           </a:bodyPr>
           <a:lstStyle/>
           <a:p>
-            <a:pPr algn="r"/>
+            <a:pPr algn="ctr"/>
+            <a:r>
+              <a:rPr sz="1600" b="1">
+                <a:solidFill>
+                  <a:srgbClr val="1A2A4A"/>
+                </a:solidFill>
+                <a:latin typeface="Noto Sans Arabic"/>
+              </a:rPr>
+              <a:t>5</a:t>
+            </a:r>
+          </a:p>
+        </p:txBody>
+      </p:sp>
+      <p:sp>
+        <p:nvSpPr>
+          <p:cNvPr id="40" name="TextBox 39"/>
+          <p:cNvSpPr txBox="1"/>
+          <p:nvPr/>
+        </p:nvSpPr>
+        <p:spPr>
+          <a:xfrm>
+            <a:off x="648000" y="4320000"/>
+            <a:ext cx="5604000" cy="180000"/>
+          </a:xfrm>
+          <a:prstGeom prst="rect">
+            <a:avLst/>
+          </a:prstGeom>
+          <a:noFill/>
+        </p:spPr>
+        <p:txBody>
+          <a:bodyPr wrap="square">
+            <a:spAutoFit/>
+          </a:bodyPr>
+          <a:lstStyle/>
+          <a:p>
+            <a:pPr algn="ctr"/>
             <a:r>
               <a:rPr sz="1000" b="0">
                 <a:solidFill>
-                  <a:srgbClr val="C9A84C"/>
+                  <a:srgbClr val="1A2A4A"/>
                 </a:solidFill>
-                <a:latin typeface="Arial"/>
+                <a:latin typeface="Noto Sans Arabic"/>
               </a:rPr>
-              <a:t>لوحة تحليل النتائج</a:t>
+              <a:t>مستويات وصول</a:t>
+            </a:r>
+          </a:p>
+        </p:txBody>
+      </p:sp>
+      <p:sp>
+        <p:nvSpPr>
+          <p:cNvPr id="41" name="Rectangle 40"/>
+          <p:cNvSpPr/>
+          <p:nvPr/>
+        </p:nvSpPr>
+        <p:spPr>
+          <a:xfrm>
+            <a:off x="6324000" y="4122000"/>
+            <a:ext cx="5604000" cy="396000"/>
+          </a:xfrm>
+          <a:prstGeom prst="rect">
+            <a:avLst/>
+          </a:prstGeom>
+          <a:solidFill>
+            <a:srgbClr val="C9A84C"/>
+          </a:solidFill>
+          <a:ln>
+            <a:noFill/>
+          </a:ln>
+        </p:spPr>
+        <p:style>
+          <a:lnRef idx="1">
+            <a:schemeClr val="accent1"/>
+          </a:lnRef>
+          <a:fillRef idx="3">
+            <a:schemeClr val="accent1"/>
+          </a:fillRef>
+          <a:effectRef idx="2">
+            <a:schemeClr val="accent1"/>
+          </a:effectRef>
+          <a:fontRef idx="minor">
+            <a:schemeClr val="lt1"/>
+          </a:fontRef>
+        </p:style>
+        <p:txBody>
+          <a:bodyPr rtlCol="0" anchor="ctr"/>
+          <a:lstStyle/>
+          <a:p>
+            <a:pPr algn="ctr"/>
+          </a:p>
+        </p:txBody>
+      </p:sp>
+      <p:sp>
+        <p:nvSpPr>
+          <p:cNvPr id="42" name="TextBox 41"/>
+          <p:cNvSpPr txBox="1"/>
+          <p:nvPr/>
+        </p:nvSpPr>
+        <p:spPr>
+          <a:xfrm>
+            <a:off x="6324000" y="4122000"/>
+            <a:ext cx="5604000" cy="216000"/>
+          </a:xfrm>
+          <a:prstGeom prst="rect">
+            <a:avLst/>
+          </a:prstGeom>
+          <a:noFill/>
+        </p:spPr>
+        <p:txBody>
+          <a:bodyPr wrap="square">
+            <a:spAutoFit/>
+          </a:bodyPr>
+          <a:lstStyle/>
+          <a:p>
+            <a:pPr algn="ctr"/>
+            <a:r>
+              <a:rPr sz="1600" b="1">
+                <a:solidFill>
+                  <a:srgbClr val="1A2A4A"/>
+                </a:solidFill>
+                <a:latin typeface="Noto Sans Arabic"/>
+              </a:rPr>
+              <a:t>100%</a:t>
+            </a:r>
+          </a:p>
+        </p:txBody>
+      </p:sp>
+      <p:sp>
+        <p:nvSpPr>
+          <p:cNvPr id="43" name="TextBox 42"/>
+          <p:cNvSpPr txBox="1"/>
+          <p:nvPr/>
+        </p:nvSpPr>
+        <p:spPr>
+          <a:xfrm>
+            <a:off x="6324000" y="4320000"/>
+            <a:ext cx="5604000" cy="180000"/>
+          </a:xfrm>
+          <a:prstGeom prst="rect">
+            <a:avLst/>
+          </a:prstGeom>
+          <a:noFill/>
+        </p:spPr>
+        <p:txBody>
+          <a:bodyPr wrap="square">
+            <a:spAutoFit/>
+          </a:bodyPr>
+          <a:lstStyle/>
+          <a:p>
+            <a:pPr algn="ctr"/>
+            <a:r>
+              <a:rPr sz="1000" b="0">
+                <a:solidFill>
+                  <a:srgbClr val="1A2A4A"/>
+                </a:solidFill>
+                <a:latin typeface="Noto Sans Arabic"/>
+              </a:rPr>
+              <a:t>بيانات محلية آمنة</a:t>
+            </a:r>
+          </a:p>
+        </p:txBody>
+      </p:sp>
+      <p:sp>
+        <p:nvSpPr>
+          <p:cNvPr id="44" name="Rectangle 43"/>
+          <p:cNvSpPr/>
+          <p:nvPr/>
+        </p:nvSpPr>
+        <p:spPr>
+          <a:xfrm>
+            <a:off x="12000000" y="4122000"/>
+            <a:ext cx="5604000" cy="396000"/>
+          </a:xfrm>
+          <a:prstGeom prst="rect">
+            <a:avLst/>
+          </a:prstGeom>
+          <a:solidFill>
+            <a:srgbClr val="C9A84C"/>
+          </a:solidFill>
+          <a:ln>
+            <a:noFill/>
+          </a:ln>
+        </p:spPr>
+        <p:style>
+          <a:lnRef idx="1">
+            <a:schemeClr val="accent1"/>
+          </a:lnRef>
+          <a:fillRef idx="3">
+            <a:schemeClr val="accent1"/>
+          </a:fillRef>
+          <a:effectRef idx="2">
+            <a:schemeClr val="accent1"/>
+          </a:effectRef>
+          <a:fontRef idx="minor">
+            <a:schemeClr val="lt1"/>
+          </a:fontRef>
+        </p:style>
+        <p:txBody>
+          <a:bodyPr rtlCol="0" anchor="ctr"/>
+          <a:lstStyle/>
+          <a:p>
+            <a:pPr algn="ctr"/>
+          </a:p>
+        </p:txBody>
+      </p:sp>
+      <p:sp>
+        <p:nvSpPr>
+          <p:cNvPr id="45" name="TextBox 44"/>
+          <p:cNvSpPr txBox="1"/>
+          <p:nvPr/>
+        </p:nvSpPr>
+        <p:spPr>
+          <a:xfrm>
+            <a:off x="12000000" y="4122000"/>
+            <a:ext cx="5604000" cy="216000"/>
+          </a:xfrm>
+          <a:prstGeom prst="rect">
+            <a:avLst/>
+          </a:prstGeom>
+          <a:noFill/>
+        </p:spPr>
+        <p:txBody>
+          <a:bodyPr wrap="square">
+            <a:spAutoFit/>
+          </a:bodyPr>
+          <a:lstStyle/>
+          <a:p>
+            <a:pPr algn="ctr"/>
+            <a:r>
+              <a:rPr sz="1600" b="1">
+                <a:solidFill>
+                  <a:srgbClr val="1A2A4A"/>
+                </a:solidFill>
+                <a:latin typeface="Noto Sans Arabic"/>
+              </a:rPr>
+              <a:t>متوافق</a:t>
+            </a:r>
+          </a:p>
+        </p:txBody>
+      </p:sp>
+      <p:sp>
+        <p:nvSpPr>
+          <p:cNvPr id="46" name="TextBox 45"/>
+          <p:cNvSpPr txBox="1"/>
+          <p:nvPr/>
+        </p:nvSpPr>
+        <p:spPr>
+          <a:xfrm>
+            <a:off x="12000000" y="4320000"/>
+            <a:ext cx="5604000" cy="180000"/>
+          </a:xfrm>
+          <a:prstGeom prst="rect">
+            <a:avLst/>
+          </a:prstGeom>
+          <a:noFill/>
+        </p:spPr>
+        <p:txBody>
+          <a:bodyPr wrap="square">
+            <a:spAutoFit/>
+          </a:bodyPr>
+          <a:lstStyle/>
+          <a:p>
+            <a:pPr algn="ctr"/>
+            <a:r>
+              <a:rPr sz="1000" b="0">
+                <a:solidFill>
+                  <a:srgbClr val="1A2A4A"/>
+                </a:solidFill>
+                <a:latin typeface="Noto Sans Arabic"/>
+              </a:rPr>
+              <a:t>مع القانون الاتحادي</a:t>
             </a:r>
           </a:p>
         </p:txBody>

</xml_diff>

<commit_message>
fix: law slides v4 - correct 20x11.25 dimensions, navy theme, 5 cards slide3, comparison table slide4
</commit_message>
<xml_diff>
--- a/assets/aljood_pitch_with_law.pptx
+++ b/assets/aljood_pitch_with_law.pptx
@@ -5928,51 +5928,8 @@
         </p:nvSpPr>
         <p:spPr>
           <a:xfrm>
-            <a:off x="432000" y="540000"/>
-            <a:ext cx="17424000" cy="9387000"/>
-          </a:xfrm>
-          <a:prstGeom prst="rect">
-            <a:avLst/>
-          </a:prstGeom>
-          <a:solidFill>
-            <a:srgbClr val="0F1D35"/>
-          </a:solidFill>
-          <a:ln>
-            <a:noFill/>
-          </a:ln>
-        </p:spPr>
-        <p:style>
-          <a:lnRef idx="1">
-            <a:schemeClr val="accent1"/>
-          </a:lnRef>
-          <a:fillRef idx="3">
-            <a:schemeClr val="accent1"/>
-          </a:fillRef>
-          <a:effectRef idx="2">
-            <a:schemeClr val="accent1"/>
-          </a:effectRef>
-          <a:fontRef idx="minor">
-            <a:schemeClr val="lt1"/>
-          </a:fontRef>
-        </p:style>
-        <p:txBody>
-          <a:bodyPr rtlCol="0" anchor="ctr"/>
-          <a:lstStyle/>
-          <a:p>
-            <a:pPr algn="ctr"/>
-          </a:p>
-        </p:txBody>
-      </p:sp>
-      <p:sp>
-        <p:nvSpPr>
-          <p:cNvPr id="6" name="Rectangle 5"/>
-          <p:cNvSpPr/>
-          <p:nvPr/>
-        </p:nvSpPr>
-        <p:spPr>
-          <a:xfrm>
-            <a:off x="432000" y="540000"/>
-            <a:ext cx="17424000" cy="180000"/>
+            <a:off x="0" y="0"/>
+            <a:ext cx="18288000" cy="109728"/>
           </a:xfrm>
           <a:prstGeom prst="rect">
             <a:avLst/>
@@ -6008,14 +5965,14 @@
       </p:sp>
       <p:sp>
         <p:nvSpPr>
-          <p:cNvPr id="7" name="TextBox 6"/>
+          <p:cNvPr id="6" name="TextBox 5"/>
           <p:cNvSpPr txBox="1"/>
           <p:nvPr/>
         </p:nvSpPr>
         <p:spPr>
           <a:xfrm>
-            <a:off x="540000" y="827999"/>
-            <a:ext cx="17208000" cy="503999"/>
+            <a:off x="457200" y="228600"/>
+            <a:ext cx="10058400" cy="1280160"/>
           </a:xfrm>
           <a:prstGeom prst="rect">
             <a:avLst/>
@@ -6028,9 +5985,9 @@
           </a:bodyPr>
           <a:lstStyle/>
           <a:p>
-            <a:pPr algn="ctr"/>
-            <a:r>
-              <a:rPr sz="2400" b="1">
+            <a:pPr algn="r"/>
+            <a:r>
+              <a:rPr sz="3200" b="1">
                 <a:solidFill>
                   <a:srgbClr val="C9A84C"/>
                 </a:solidFill>
@@ -6039,18 +5996,30 @@
               <a:t>السياق الوطني: قانون سلامة الطفل الرقمي</a:t>
             </a:r>
           </a:p>
+          <a:p>
+            <a:pPr algn="r"/>
+            <a:r>
+              <a:rPr sz="1300" b="0">
+                <a:solidFill>
+                  <a:srgbClr val="CCCCCC"/>
+                </a:solidFill>
+                <a:latin typeface="Noto Sans Arabic"/>
+              </a:rPr>
+              <a:t>UAE Federal Decree No. 2 / 2026 — Child Digital Safety Law</a:t>
+            </a:r>
+          </a:p>
         </p:txBody>
       </p:sp>
       <p:sp>
         <p:nvSpPr>
-          <p:cNvPr id="8" name="TextBox 7"/>
+          <p:cNvPr id="7" name="TextBox 6"/>
           <p:cNvSpPr txBox="1"/>
           <p:nvPr/>
         </p:nvSpPr>
         <p:spPr>
           <a:xfrm>
-            <a:off x="540000" y="1332000"/>
-            <a:ext cx="17208000" cy="288000"/>
+            <a:off x="11430000" y="1645920"/>
+            <a:ext cx="5943600" cy="4572000"/>
           </a:xfrm>
           <a:prstGeom prst="rect">
             <a:avLst/>
@@ -6065,14 +6034,83 @@
           <a:p>
             <a:pPr algn="ctr"/>
             <a:r>
-              <a:rPr sz="1300" b="0">
+              <a:rPr sz="9600" b="1">
                 <a:solidFill>
-                  <a:srgbClr val="CCCCCC"/>
+                  <a:srgbClr val="C9A84C"/>
                 </a:solidFill>
                 <a:latin typeface="Noto Sans Arabic"/>
               </a:rPr>
-              <a:t>UAE Federal Decree No. 2 / 2026 — Child Digital Safety Law</a:t>
-            </a:r>
+              <a:t>2026</a:t>
+            </a:r>
+          </a:p>
+          <a:p>
+            <a:pPr algn="ctr"/>
+            <a:r>
+              <a:rPr sz="2400" b="1">
+                <a:solidFill>
+                  <a:srgbClr val="FFFFFF"/>
+                </a:solidFill>
+                <a:latin typeface="Noto Sans Arabic"/>
+              </a:rPr>
+              <a:t>قانون</a:t>
+            </a:r>
+          </a:p>
+          <a:p>
+            <a:pPr algn="ctr"/>
+            <a:r>
+              <a:rPr sz="1600" b="0">
+                <a:solidFill>
+                  <a:srgbClr val="F3E5B8"/>
+                </a:solidFill>
+                <a:latin typeface="Noto Sans Arabic"/>
+              </a:rPr>
+              <a:t>سلامة الطفل الرقمي</a:t>
+            </a:r>
+          </a:p>
+        </p:txBody>
+      </p:sp>
+      <p:sp>
+        <p:nvSpPr>
+          <p:cNvPr id="8" name="Rectangle 7"/>
+          <p:cNvSpPr/>
+          <p:nvPr/>
+        </p:nvSpPr>
+        <p:spPr>
+          <a:xfrm>
+            <a:off x="365760" y="1737360"/>
+            <a:ext cx="9966960" cy="1463040"/>
+          </a:xfrm>
+          <a:prstGeom prst="rect">
+            <a:avLst/>
+          </a:prstGeom>
+          <a:solidFill>
+            <a:srgbClr val="1E345C"/>
+          </a:solidFill>
+          <a:ln w="6350">
+            <a:solidFill>
+              <a:srgbClr val="C9A84C"/>
+            </a:solidFill>
+          </a:ln>
+        </p:spPr>
+        <p:style>
+          <a:lnRef idx="1">
+            <a:schemeClr val="accent1"/>
+          </a:lnRef>
+          <a:fillRef idx="3">
+            <a:schemeClr val="accent1"/>
+          </a:fillRef>
+          <a:effectRef idx="2">
+            <a:schemeClr val="accent1"/>
+          </a:effectRef>
+          <a:fontRef idx="minor">
+            <a:schemeClr val="lt1"/>
+          </a:fontRef>
+        </p:style>
+        <p:txBody>
+          <a:bodyPr rtlCol="0" anchor="ctr"/>
+          <a:lstStyle/>
+          <a:p>
+            <a:pPr algn="ctr"/>
           </a:p>
         </p:txBody>
       </p:sp>
@@ -6084,8 +6122,8 @@
         </p:nvSpPr>
         <p:spPr>
           <a:xfrm>
-            <a:off x="1080000" y="1655999"/>
-            <a:ext cx="16128000" cy="21600"/>
+            <a:off x="365760" y="1737360"/>
+            <a:ext cx="128016" cy="1463040"/>
           </a:xfrm>
           <a:prstGeom prst="rect">
             <a:avLst/>
@@ -6127,14 +6165,14 @@
         </p:nvSpPr>
         <p:spPr>
           <a:xfrm>
-            <a:off x="648000" y="1800000"/>
-            <a:ext cx="17028000" cy="522000"/>
+            <a:off x="566928" y="2148840"/>
+            <a:ext cx="658368" cy="658368"/>
           </a:xfrm>
           <a:prstGeom prst="rect">
             <a:avLst/>
           </a:prstGeom>
           <a:solidFill>
-            <a:srgbClr val="1E3055"/>
+            <a:srgbClr val="C9A84C"/>
           </a:solidFill>
           <a:ln>
             <a:noFill/>
@@ -6155,6 +6193,107 @@
           </a:fontRef>
         </p:style>
         <p:txBody>
+          <a:bodyPr rtlCol="0" anchor="ctr" wrap="square"/>
+          <a:lstStyle/>
+          <a:p>
+            <a:pPr algn="ctr"/>
+            <a:r>
+              <a:rPr sz="1700" b="1">
+                <a:solidFill>
+                  <a:srgbClr val="1A2A4A"/>
+                </a:solidFill>
+                <a:latin typeface="Noto Sans Arabic"/>
+              </a:rPr>
+              <a:t>01</a:t>
+            </a:r>
+          </a:p>
+        </p:txBody>
+      </p:sp>
+      <p:sp>
+        <p:nvSpPr>
+          <p:cNvPr id="11" name="TextBox 10"/>
+          <p:cNvSpPr txBox="1"/>
+          <p:nvPr/>
+        </p:nvSpPr>
+        <p:spPr>
+          <a:xfrm>
+            <a:off x="1371600" y="1874519"/>
+            <a:ext cx="8778240" cy="1280160"/>
+          </a:xfrm>
+          <a:prstGeom prst="rect">
+            <a:avLst/>
+          </a:prstGeom>
+          <a:noFill/>
+        </p:spPr>
+        <p:txBody>
+          <a:bodyPr wrap="square">
+            <a:spAutoFit/>
+          </a:bodyPr>
+          <a:lstStyle/>
+          <a:p>
+            <a:pPr algn="r"/>
+            <a:r>
+              <a:rPr sz="1800" b="1">
+                <a:solidFill>
+                  <a:srgbClr val="FFFFFF"/>
+                </a:solidFill>
+                <a:latin typeface="Noto Sans Arabic"/>
+              </a:rPr>
+              <a:t>حماية البيانات الرقمية للطلاب</a:t>
+            </a:r>
+          </a:p>
+          <a:p>
+            <a:pPr algn="r"/>
+            <a:r>
+              <a:rPr sz="1100" b="0">
+                <a:solidFill>
+                  <a:srgbClr val="CCCCCC"/>
+                </a:solidFill>
+                <a:latin typeface="Noto Sans Arabic"/>
+              </a:rPr>
+              <a:t>Student Digital Data Protection</a:t>
+            </a:r>
+          </a:p>
+        </p:txBody>
+      </p:sp>
+      <p:sp>
+        <p:nvSpPr>
+          <p:cNvPr id="12" name="Rectangle 11"/>
+          <p:cNvSpPr/>
+          <p:nvPr/>
+        </p:nvSpPr>
+        <p:spPr>
+          <a:xfrm>
+            <a:off x="365760" y="3310128"/>
+            <a:ext cx="9966960" cy="1463040"/>
+          </a:xfrm>
+          <a:prstGeom prst="rect">
+            <a:avLst/>
+          </a:prstGeom>
+          <a:solidFill>
+            <a:srgbClr val="1E345C"/>
+          </a:solidFill>
+          <a:ln w="6350">
+            <a:solidFill>
+              <a:srgbClr val="C9A84C"/>
+            </a:solidFill>
+          </a:ln>
+        </p:spPr>
+        <p:style>
+          <a:lnRef idx="1">
+            <a:schemeClr val="accent1"/>
+          </a:lnRef>
+          <a:fillRef idx="3">
+            <a:schemeClr val="accent1"/>
+          </a:fillRef>
+          <a:effectRef idx="2">
+            <a:schemeClr val="accent1"/>
+          </a:effectRef>
+          <a:fontRef idx="minor">
+            <a:schemeClr val="lt1"/>
+          </a:fontRef>
+        </p:style>
+        <p:txBody>
           <a:bodyPr rtlCol="0" anchor="ctr"/>
           <a:lstStyle/>
           <a:p>
@@ -6164,14 +6303,14 @@
       </p:sp>
       <p:sp>
         <p:nvSpPr>
-          <p:cNvPr id="11" name="Rectangle 10"/>
+          <p:cNvPr id="13" name="Rectangle 12"/>
           <p:cNvSpPr/>
           <p:nvPr/>
         </p:nvSpPr>
         <p:spPr>
           <a:xfrm>
-            <a:off x="648000" y="1800000"/>
-            <a:ext cx="396000" cy="522000"/>
+            <a:off x="365760" y="3310128"/>
+            <a:ext cx="128016" cy="1463040"/>
           </a:xfrm>
           <a:prstGeom prst="rect">
             <a:avLst/>
@@ -6207,14 +6346,66 @@
       </p:sp>
       <p:sp>
         <p:nvSpPr>
-          <p:cNvPr id="12" name="TextBox 11"/>
+          <p:cNvPr id="14" name="Rectangle 13"/>
+          <p:cNvSpPr/>
+          <p:nvPr/>
+        </p:nvSpPr>
+        <p:spPr>
+          <a:xfrm>
+            <a:off x="566928" y="3721608"/>
+            <a:ext cx="658368" cy="658368"/>
+          </a:xfrm>
+          <a:prstGeom prst="rect">
+            <a:avLst/>
+          </a:prstGeom>
+          <a:solidFill>
+            <a:srgbClr val="C9A84C"/>
+          </a:solidFill>
+          <a:ln>
+            <a:noFill/>
+          </a:ln>
+        </p:spPr>
+        <p:style>
+          <a:lnRef idx="1">
+            <a:schemeClr val="accent1"/>
+          </a:lnRef>
+          <a:fillRef idx="3">
+            <a:schemeClr val="accent1"/>
+          </a:fillRef>
+          <a:effectRef idx="2">
+            <a:schemeClr val="accent1"/>
+          </a:effectRef>
+          <a:fontRef idx="minor">
+            <a:schemeClr val="lt1"/>
+          </a:fontRef>
+        </p:style>
+        <p:txBody>
+          <a:bodyPr rtlCol="0" anchor="ctr" wrap="square"/>
+          <a:lstStyle/>
+          <a:p>
+            <a:pPr algn="ctr"/>
+            <a:r>
+              <a:rPr sz="1700" b="1">
+                <a:solidFill>
+                  <a:srgbClr val="1A2A4A"/>
+                </a:solidFill>
+                <a:latin typeface="Noto Sans Arabic"/>
+              </a:rPr>
+              <a:t>02</a:t>
+            </a:r>
+          </a:p>
+        </p:txBody>
+      </p:sp>
+      <p:sp>
+        <p:nvSpPr>
+          <p:cNvPr id="15" name="TextBox 14"/>
           <p:cNvSpPr txBox="1"/>
           <p:nvPr/>
         </p:nvSpPr>
         <p:spPr>
           <a:xfrm>
-            <a:off x="648000" y="1800000"/>
-            <a:ext cx="396000" cy="522000"/>
+            <a:off x="1371600" y="3447288"/>
+            <a:ext cx="8778240" cy="1280160"/>
           </a:xfrm>
           <a:prstGeom prst="rect">
             <a:avLst/>
@@ -6227,29 +6418,86 @@
           </a:bodyPr>
           <a:lstStyle/>
           <a:p>
-            <a:pPr algn="ctr"/>
-            <a:r>
-              <a:rPr sz="1600" b="1">
+            <a:pPr algn="r"/>
+            <a:r>
+              <a:rPr sz="1800" b="1">
                 <a:solidFill>
-                  <a:srgbClr val="1A2A4A"/>
+                  <a:srgbClr val="FFFFFF"/>
                 </a:solidFill>
                 <a:latin typeface="Noto Sans Arabic"/>
               </a:rPr>
-              <a:t>1</a:t>
+              <a:t>توثيق هوية المستخدمين</a:t>
+            </a:r>
+          </a:p>
+          <a:p>
+            <a:pPr algn="r"/>
+            <a:r>
+              <a:rPr sz="1100" b="0">
+                <a:solidFill>
+                  <a:srgbClr val="CCCCCC"/>
+                </a:solidFill>
+                <a:latin typeface="Noto Sans Arabic"/>
+              </a:rPr>
+              <a:t>User Identity Verification</a:t>
             </a:r>
           </a:p>
         </p:txBody>
       </p:sp>
       <p:sp>
         <p:nvSpPr>
-          <p:cNvPr id="13" name="Rectangle 12"/>
+          <p:cNvPr id="16" name="Rectangle 15"/>
           <p:cNvSpPr/>
           <p:nvPr/>
         </p:nvSpPr>
         <p:spPr>
           <a:xfrm>
-            <a:off x="17208000" y="1925999"/>
-            <a:ext cx="251999" cy="251999"/>
+            <a:off x="365760" y="4882896"/>
+            <a:ext cx="9966960" cy="1463040"/>
+          </a:xfrm>
+          <a:prstGeom prst="rect">
+            <a:avLst/>
+          </a:prstGeom>
+          <a:solidFill>
+            <a:srgbClr val="1E345C"/>
+          </a:solidFill>
+          <a:ln w="6350">
+            <a:solidFill>
+              <a:srgbClr val="C9A84C"/>
+            </a:solidFill>
+          </a:ln>
+        </p:spPr>
+        <p:style>
+          <a:lnRef idx="1">
+            <a:schemeClr val="accent1"/>
+          </a:lnRef>
+          <a:fillRef idx="3">
+            <a:schemeClr val="accent1"/>
+          </a:fillRef>
+          <a:effectRef idx="2">
+            <a:schemeClr val="accent1"/>
+          </a:effectRef>
+          <a:fontRef idx="minor">
+            <a:schemeClr val="lt1"/>
+          </a:fontRef>
+        </p:style>
+        <p:txBody>
+          <a:bodyPr rtlCol="0" anchor="ctr"/>
+          <a:lstStyle/>
+          <a:p>
+            <a:pPr algn="ctr"/>
+          </a:p>
+        </p:txBody>
+      </p:sp>
+      <p:sp>
+        <p:nvSpPr>
+          <p:cNvPr id="17" name="Rectangle 16"/>
+          <p:cNvSpPr/>
+          <p:nvPr/>
+        </p:nvSpPr>
+        <p:spPr>
+          <a:xfrm>
+            <a:off x="365760" y="4882896"/>
+            <a:ext cx="128016" cy="1463040"/>
           </a:xfrm>
           <a:prstGeom prst="rect">
             <a:avLst/>
@@ -6285,90 +6533,20 @@
       </p:sp>
       <p:sp>
         <p:nvSpPr>
-          <p:cNvPr id="14" name="TextBox 13"/>
-          <p:cNvSpPr txBox="1"/>
+          <p:cNvPr id="18" name="Rectangle 17"/>
+          <p:cNvSpPr/>
           <p:nvPr/>
         </p:nvSpPr>
         <p:spPr>
           <a:xfrm>
-            <a:off x="1116000" y="1818000"/>
-            <a:ext cx="16020001" cy="288000"/>
-          </a:xfrm>
-          <a:prstGeom prst="rect">
-            <a:avLst/>
-          </a:prstGeom>
-          <a:noFill/>
-        </p:spPr>
-        <p:txBody>
-          <a:bodyPr wrap="square">
-            <a:spAutoFit/>
-          </a:bodyPr>
-          <a:lstStyle/>
-          <a:p>
-            <a:pPr algn="r"/>
-            <a:r>
-              <a:rPr sz="1400" b="1">
-                <a:solidFill>
-                  <a:srgbClr val="FFFFFF"/>
-                </a:solidFill>
-                <a:latin typeface="Noto Sans Arabic"/>
-              </a:rPr>
-              <a:t>حماية بيانات الطلاب الرقمية</a:t>
-            </a:r>
-          </a:p>
-        </p:txBody>
-      </p:sp>
-      <p:sp>
-        <p:nvSpPr>
-          <p:cNvPr id="15" name="TextBox 14"/>
-          <p:cNvSpPr txBox="1"/>
-          <p:nvPr/>
-        </p:nvSpPr>
-        <p:spPr>
-          <a:xfrm>
-            <a:off x="1116000" y="2070000"/>
-            <a:ext cx="16020001" cy="216000"/>
-          </a:xfrm>
-          <a:prstGeom prst="rect">
-            <a:avLst/>
-          </a:prstGeom>
-          <a:noFill/>
-        </p:spPr>
-        <p:txBody>
-          <a:bodyPr wrap="square">
-            <a:spAutoFit/>
-          </a:bodyPr>
-          <a:lstStyle/>
-          <a:p>
-            <a:pPr algn="r"/>
-            <a:r>
-              <a:rPr sz="1000" b="0">
-                <a:solidFill>
-                  <a:srgbClr val="CCCCCC"/>
-                </a:solidFill>
-                <a:latin typeface="Noto Sans Arabic"/>
-              </a:rPr>
-              <a:t>Student Digital Data Protection</a:t>
-            </a:r>
-          </a:p>
-        </p:txBody>
-      </p:sp>
-      <p:sp>
-        <p:nvSpPr>
-          <p:cNvPr id="16" name="Rectangle 15"/>
-          <p:cNvSpPr/>
-          <p:nvPr/>
-        </p:nvSpPr>
-        <p:spPr>
-          <a:xfrm>
-            <a:off x="648000" y="2412000"/>
-            <a:ext cx="17028000" cy="522000"/>
+            <a:off x="566928" y="5294376"/>
+            <a:ext cx="658368" cy="658368"/>
           </a:xfrm>
           <a:prstGeom prst="rect">
             <a:avLst/>
           </a:prstGeom>
           <a:solidFill>
-            <a:srgbClr val="1E3055"/>
+            <a:srgbClr val="C9A84C"/>
           </a:solidFill>
           <a:ln>
             <a:noFill/>
@@ -6389,6 +6567,107 @@
           </a:fontRef>
         </p:style>
         <p:txBody>
+          <a:bodyPr rtlCol="0" anchor="ctr" wrap="square"/>
+          <a:lstStyle/>
+          <a:p>
+            <a:pPr algn="ctr"/>
+            <a:r>
+              <a:rPr sz="1700" b="1">
+                <a:solidFill>
+                  <a:srgbClr val="1A2A4A"/>
+                </a:solidFill>
+                <a:latin typeface="Noto Sans Arabic"/>
+              </a:rPr>
+              <a:t>03</a:t>
+            </a:r>
+          </a:p>
+        </p:txBody>
+      </p:sp>
+      <p:sp>
+        <p:nvSpPr>
+          <p:cNvPr id="19" name="TextBox 18"/>
+          <p:cNvSpPr txBox="1"/>
+          <p:nvPr/>
+        </p:nvSpPr>
+        <p:spPr>
+          <a:xfrm>
+            <a:off x="1371600" y="5020056"/>
+            <a:ext cx="8778240" cy="1280160"/>
+          </a:xfrm>
+          <a:prstGeom prst="rect">
+            <a:avLst/>
+          </a:prstGeom>
+          <a:noFill/>
+        </p:spPr>
+        <p:txBody>
+          <a:bodyPr wrap="square">
+            <a:spAutoFit/>
+          </a:bodyPr>
+          <a:lstStyle/>
+          <a:p>
+            <a:pPr algn="r"/>
+            <a:r>
+              <a:rPr sz="1800" b="1">
+                <a:solidFill>
+                  <a:srgbClr val="FFFFFF"/>
+                </a:solidFill>
+                <a:latin typeface="Noto Sans Arabic"/>
+              </a:rPr>
+              <a:t>رقابة أولياء الأمور</a:t>
+            </a:r>
+          </a:p>
+          <a:p>
+            <a:pPr algn="r"/>
+            <a:r>
+              <a:rPr sz="1100" b="0">
+                <a:solidFill>
+                  <a:srgbClr val="CCCCCC"/>
+                </a:solidFill>
+                <a:latin typeface="Noto Sans Arabic"/>
+              </a:rPr>
+              <a:t>Parental Monitoring &amp; Control</a:t>
+            </a:r>
+          </a:p>
+        </p:txBody>
+      </p:sp>
+      <p:sp>
+        <p:nvSpPr>
+          <p:cNvPr id="20" name="Rectangle 19"/>
+          <p:cNvSpPr/>
+          <p:nvPr/>
+        </p:nvSpPr>
+        <p:spPr>
+          <a:xfrm>
+            <a:off x="365760" y="6455664"/>
+            <a:ext cx="9966960" cy="1463040"/>
+          </a:xfrm>
+          <a:prstGeom prst="rect">
+            <a:avLst/>
+          </a:prstGeom>
+          <a:solidFill>
+            <a:srgbClr val="1E345C"/>
+          </a:solidFill>
+          <a:ln w="6350">
+            <a:solidFill>
+              <a:srgbClr val="C9A84C"/>
+            </a:solidFill>
+          </a:ln>
+        </p:spPr>
+        <p:style>
+          <a:lnRef idx="1">
+            <a:schemeClr val="accent1"/>
+          </a:lnRef>
+          <a:fillRef idx="3">
+            <a:schemeClr val="accent1"/>
+          </a:fillRef>
+          <a:effectRef idx="2">
+            <a:schemeClr val="accent1"/>
+          </a:effectRef>
+          <a:fontRef idx="minor">
+            <a:schemeClr val="lt1"/>
+          </a:fontRef>
+        </p:style>
+        <p:txBody>
           <a:bodyPr rtlCol="0" anchor="ctr"/>
           <a:lstStyle/>
           <a:p>
@@ -6398,14 +6677,14 @@
       </p:sp>
       <p:sp>
         <p:nvSpPr>
-          <p:cNvPr id="17" name="Rectangle 16"/>
+          <p:cNvPr id="21" name="Rectangle 20"/>
           <p:cNvSpPr/>
           <p:nvPr/>
         </p:nvSpPr>
         <p:spPr>
           <a:xfrm>
-            <a:off x="648000" y="2412000"/>
-            <a:ext cx="396000" cy="522000"/>
+            <a:off x="365760" y="6455664"/>
+            <a:ext cx="128016" cy="1463040"/>
           </a:xfrm>
           <a:prstGeom prst="rect">
             <a:avLst/>
@@ -6441,14 +6720,66 @@
       </p:sp>
       <p:sp>
         <p:nvSpPr>
-          <p:cNvPr id="18" name="TextBox 17"/>
+          <p:cNvPr id="22" name="Rectangle 21"/>
+          <p:cNvSpPr/>
+          <p:nvPr/>
+        </p:nvSpPr>
+        <p:spPr>
+          <a:xfrm>
+            <a:off x="566928" y="6867144"/>
+            <a:ext cx="658368" cy="658368"/>
+          </a:xfrm>
+          <a:prstGeom prst="rect">
+            <a:avLst/>
+          </a:prstGeom>
+          <a:solidFill>
+            <a:srgbClr val="C9A84C"/>
+          </a:solidFill>
+          <a:ln>
+            <a:noFill/>
+          </a:ln>
+        </p:spPr>
+        <p:style>
+          <a:lnRef idx="1">
+            <a:schemeClr val="accent1"/>
+          </a:lnRef>
+          <a:fillRef idx="3">
+            <a:schemeClr val="accent1"/>
+          </a:fillRef>
+          <a:effectRef idx="2">
+            <a:schemeClr val="accent1"/>
+          </a:effectRef>
+          <a:fontRef idx="minor">
+            <a:schemeClr val="lt1"/>
+          </a:fontRef>
+        </p:style>
+        <p:txBody>
+          <a:bodyPr rtlCol="0" anchor="ctr" wrap="square"/>
+          <a:lstStyle/>
+          <a:p>
+            <a:pPr algn="ctr"/>
+            <a:r>
+              <a:rPr sz="1700" b="1">
+                <a:solidFill>
+                  <a:srgbClr val="1A2A4A"/>
+                </a:solidFill>
+                <a:latin typeface="Noto Sans Arabic"/>
+              </a:rPr>
+              <a:t>04</a:t>
+            </a:r>
+          </a:p>
+        </p:txBody>
+      </p:sp>
+      <p:sp>
+        <p:nvSpPr>
+          <p:cNvPr id="23" name="TextBox 22"/>
           <p:cNvSpPr txBox="1"/>
           <p:nvPr/>
         </p:nvSpPr>
         <p:spPr>
           <a:xfrm>
-            <a:off x="648000" y="2412000"/>
-            <a:ext cx="396000" cy="522000"/>
+            <a:off x="1371600" y="6592824"/>
+            <a:ext cx="8778240" cy="1280160"/>
           </a:xfrm>
           <a:prstGeom prst="rect">
             <a:avLst/>
@@ -6461,29 +6792,86 @@
           </a:bodyPr>
           <a:lstStyle/>
           <a:p>
-            <a:pPr algn="ctr"/>
-            <a:r>
-              <a:rPr sz="1600" b="1">
+            <a:pPr algn="r"/>
+            <a:r>
+              <a:rPr sz="1800" b="1">
                 <a:solidFill>
-                  <a:srgbClr val="1A2A4A"/>
+                  <a:srgbClr val="FFFFFF"/>
                 </a:solidFill>
                 <a:latin typeface="Noto Sans Arabic"/>
               </a:rPr>
-              <a:t>2</a:t>
+              <a:t>الإبلاغ الفوري عن الاختراقات</a:t>
+            </a:r>
+          </a:p>
+          <a:p>
+            <a:pPr algn="r"/>
+            <a:r>
+              <a:rPr sz="1100" b="0">
+                <a:solidFill>
+                  <a:srgbClr val="CCCCCC"/>
+                </a:solidFill>
+                <a:latin typeface="Noto Sans Arabic"/>
+              </a:rPr>
+              <a:t>Mandatory Breach Reporting</a:t>
             </a:r>
           </a:p>
         </p:txBody>
       </p:sp>
       <p:sp>
         <p:nvSpPr>
-          <p:cNvPr id="19" name="Rectangle 18"/>
+          <p:cNvPr id="24" name="Rectangle 23"/>
           <p:cNvSpPr/>
           <p:nvPr/>
         </p:nvSpPr>
         <p:spPr>
           <a:xfrm>
-            <a:off x="17208000" y="2537999"/>
-            <a:ext cx="251999" cy="251999"/>
+            <a:off x="365760" y="8028432"/>
+            <a:ext cx="9966960" cy="1463040"/>
+          </a:xfrm>
+          <a:prstGeom prst="rect">
+            <a:avLst/>
+          </a:prstGeom>
+          <a:solidFill>
+            <a:srgbClr val="1E345C"/>
+          </a:solidFill>
+          <a:ln w="6350">
+            <a:solidFill>
+              <a:srgbClr val="C9A84C"/>
+            </a:solidFill>
+          </a:ln>
+        </p:spPr>
+        <p:style>
+          <a:lnRef idx="1">
+            <a:schemeClr val="accent1"/>
+          </a:lnRef>
+          <a:fillRef idx="3">
+            <a:schemeClr val="accent1"/>
+          </a:fillRef>
+          <a:effectRef idx="2">
+            <a:schemeClr val="accent1"/>
+          </a:effectRef>
+          <a:fontRef idx="minor">
+            <a:schemeClr val="lt1"/>
+          </a:fontRef>
+        </p:style>
+        <p:txBody>
+          <a:bodyPr rtlCol="0" anchor="ctr"/>
+          <a:lstStyle/>
+          <a:p>
+            <a:pPr algn="ctr"/>
+          </a:p>
+        </p:txBody>
+      </p:sp>
+      <p:sp>
+        <p:nvSpPr>
+          <p:cNvPr id="25" name="Rectangle 24"/>
+          <p:cNvSpPr/>
+          <p:nvPr/>
+        </p:nvSpPr>
+        <p:spPr>
+          <a:xfrm>
+            <a:off x="365760" y="8028432"/>
+            <a:ext cx="128016" cy="1463040"/>
           </a:xfrm>
           <a:prstGeom prst="rect">
             <a:avLst/>
@@ -6519,127 +6907,14 @@
       </p:sp>
       <p:sp>
         <p:nvSpPr>
-          <p:cNvPr id="20" name="TextBox 19"/>
-          <p:cNvSpPr txBox="1"/>
+          <p:cNvPr id="26" name="Rectangle 25"/>
+          <p:cNvSpPr/>
           <p:nvPr/>
         </p:nvSpPr>
         <p:spPr>
           <a:xfrm>
-            <a:off x="1116000" y="2430000"/>
-            <a:ext cx="16020001" cy="288000"/>
-          </a:xfrm>
-          <a:prstGeom prst="rect">
-            <a:avLst/>
-          </a:prstGeom>
-          <a:noFill/>
-        </p:spPr>
-        <p:txBody>
-          <a:bodyPr wrap="square">
-            <a:spAutoFit/>
-          </a:bodyPr>
-          <a:lstStyle/>
-          <a:p>
-            <a:pPr algn="r"/>
-            <a:r>
-              <a:rPr sz="1400" b="1">
-                <a:solidFill>
-                  <a:srgbClr val="FFFFFF"/>
-                </a:solidFill>
-                <a:latin typeface="Noto Sans Arabic"/>
-              </a:rPr>
-              <a:t>توثيق هوية المستخدمين</a:t>
-            </a:r>
-          </a:p>
-        </p:txBody>
-      </p:sp>
-      <p:sp>
-        <p:nvSpPr>
-          <p:cNvPr id="21" name="TextBox 20"/>
-          <p:cNvSpPr txBox="1"/>
-          <p:nvPr/>
-        </p:nvSpPr>
-        <p:spPr>
-          <a:xfrm>
-            <a:off x="1116000" y="2682000"/>
-            <a:ext cx="16020001" cy="216000"/>
-          </a:xfrm>
-          <a:prstGeom prst="rect">
-            <a:avLst/>
-          </a:prstGeom>
-          <a:noFill/>
-        </p:spPr>
-        <p:txBody>
-          <a:bodyPr wrap="square">
-            <a:spAutoFit/>
-          </a:bodyPr>
-          <a:lstStyle/>
-          <a:p>
-            <a:pPr algn="r"/>
-            <a:r>
-              <a:rPr sz="1000" b="0">
-                <a:solidFill>
-                  <a:srgbClr val="CCCCCC"/>
-                </a:solidFill>
-                <a:latin typeface="Noto Sans Arabic"/>
-              </a:rPr>
-              <a:t>User Identity Verification</a:t>
-            </a:r>
-          </a:p>
-        </p:txBody>
-      </p:sp>
-      <p:sp>
-        <p:nvSpPr>
-          <p:cNvPr id="22" name="Rectangle 21"/>
-          <p:cNvSpPr/>
-          <p:nvPr/>
-        </p:nvSpPr>
-        <p:spPr>
-          <a:xfrm>
-            <a:off x="648000" y="3024000"/>
-            <a:ext cx="17028000" cy="522000"/>
-          </a:xfrm>
-          <a:prstGeom prst="rect">
-            <a:avLst/>
-          </a:prstGeom>
-          <a:solidFill>
-            <a:srgbClr val="1E3055"/>
-          </a:solidFill>
-          <a:ln>
-            <a:noFill/>
-          </a:ln>
-        </p:spPr>
-        <p:style>
-          <a:lnRef idx="1">
-            <a:schemeClr val="accent1"/>
-          </a:lnRef>
-          <a:fillRef idx="3">
-            <a:schemeClr val="accent1"/>
-          </a:fillRef>
-          <a:effectRef idx="2">
-            <a:schemeClr val="accent1"/>
-          </a:effectRef>
-          <a:fontRef idx="minor">
-            <a:schemeClr val="lt1"/>
-          </a:fontRef>
-        </p:style>
-        <p:txBody>
-          <a:bodyPr rtlCol="0" anchor="ctr"/>
-          <a:lstStyle/>
-          <a:p>
-            <a:pPr algn="ctr"/>
-          </a:p>
-        </p:txBody>
-      </p:sp>
-      <p:sp>
-        <p:nvSpPr>
-          <p:cNvPr id="23" name="Rectangle 22"/>
-          <p:cNvSpPr/>
-          <p:nvPr/>
-        </p:nvSpPr>
-        <p:spPr>
-          <a:xfrm>
-            <a:off x="648000" y="3024000"/>
-            <a:ext cx="396000" cy="522000"/>
+            <a:off x="566928" y="8439912"/>
+            <a:ext cx="658368" cy="658368"/>
           </a:xfrm>
           <a:prstGeom prst="rect">
             <a:avLst/>
@@ -6666,23 +6941,32 @@
           </a:fontRef>
         </p:style>
         <p:txBody>
-          <a:bodyPr rtlCol="0" anchor="ctr"/>
+          <a:bodyPr rtlCol="0" anchor="ctr" wrap="square"/>
           <a:lstStyle/>
           <a:p>
             <a:pPr algn="ctr"/>
+            <a:r>
+              <a:rPr sz="1700" b="1">
+                <a:solidFill>
+                  <a:srgbClr val="1A2A4A"/>
+                </a:solidFill>
+                <a:latin typeface="Noto Sans Arabic"/>
+              </a:rPr>
+              <a:t>05</a:t>
+            </a:r>
           </a:p>
         </p:txBody>
       </p:sp>
       <p:sp>
         <p:nvSpPr>
-          <p:cNvPr id="24" name="TextBox 23"/>
+          <p:cNvPr id="27" name="TextBox 26"/>
           <p:cNvSpPr txBox="1"/>
           <p:nvPr/>
         </p:nvSpPr>
         <p:spPr>
           <a:xfrm>
-            <a:off x="648000" y="3024000"/>
-            <a:ext cx="396000" cy="522000"/>
+            <a:off x="1371600" y="8165592"/>
+            <a:ext cx="8778240" cy="1280160"/>
           </a:xfrm>
           <a:prstGeom prst="rect">
             <a:avLst/>
@@ -6695,29 +6979,41 @@
           </a:bodyPr>
           <a:lstStyle/>
           <a:p>
-            <a:pPr algn="ctr"/>
-            <a:r>
-              <a:rPr sz="1600" b="1">
+            <a:pPr algn="r"/>
+            <a:r>
+              <a:rPr sz="1800" b="1">
                 <a:solidFill>
-                  <a:srgbClr val="1A2A4A"/>
+                  <a:srgbClr val="FFFFFF"/>
                 </a:solidFill>
                 <a:latin typeface="Noto Sans Arabic"/>
               </a:rPr>
-              <a:t>3</a:t>
+              <a:t>ضبط صلاحيات الوصول</a:t>
+            </a:r>
+          </a:p>
+          <a:p>
+            <a:pPr algn="r"/>
+            <a:r>
+              <a:rPr sz="1100" b="0">
+                <a:solidFill>
+                  <a:srgbClr val="CCCCCC"/>
+                </a:solidFill>
+                <a:latin typeface="Noto Sans Arabic"/>
+              </a:rPr>
+              <a:t>Granular Access Control</a:t>
             </a:r>
           </a:p>
         </p:txBody>
       </p:sp>
       <p:sp>
         <p:nvSpPr>
-          <p:cNvPr id="25" name="Rectangle 24"/>
+          <p:cNvPr id="28" name="Rectangle 27"/>
           <p:cNvSpPr/>
           <p:nvPr/>
         </p:nvSpPr>
         <p:spPr>
           <a:xfrm>
-            <a:off x="17208000" y="3149999"/>
-            <a:ext cx="251999" cy="251999"/>
+            <a:off x="0" y="9738360"/>
+            <a:ext cx="18288000" cy="548640"/>
           </a:xfrm>
           <a:prstGeom prst="rect">
             <a:avLst/>
@@ -6744,547 +7040,18 @@
           </a:fontRef>
         </p:style>
         <p:txBody>
-          <a:bodyPr rtlCol="0" anchor="ctr"/>
+          <a:bodyPr rtlCol="0" anchor="ctr" wrap="square"/>
           <a:lstStyle/>
           <a:p>
             <a:pPr algn="ctr"/>
-          </a:p>
-        </p:txBody>
-      </p:sp>
-      <p:sp>
-        <p:nvSpPr>
-          <p:cNvPr id="26" name="TextBox 25"/>
-          <p:cNvSpPr txBox="1"/>
-          <p:nvPr/>
-        </p:nvSpPr>
-        <p:spPr>
-          <a:xfrm>
-            <a:off x="1116000" y="3042000"/>
-            <a:ext cx="16020001" cy="288000"/>
-          </a:xfrm>
-          <a:prstGeom prst="rect">
-            <a:avLst/>
-          </a:prstGeom>
-          <a:noFill/>
-        </p:spPr>
-        <p:txBody>
-          <a:bodyPr wrap="square">
-            <a:spAutoFit/>
-          </a:bodyPr>
-          <a:lstStyle/>
-          <a:p>
-            <a:pPr algn="r"/>
             <a:r>
               <a:rPr sz="1400" b="1">
-                <a:solidFill>
-                  <a:srgbClr val="FFFFFF"/>
-                </a:solidFill>
-                <a:latin typeface="Noto Sans Arabic"/>
-              </a:rPr>
-              <a:t>رقابة أولياء الأمور</a:t>
-            </a:r>
-          </a:p>
-        </p:txBody>
-      </p:sp>
-      <p:sp>
-        <p:nvSpPr>
-          <p:cNvPr id="27" name="TextBox 26"/>
-          <p:cNvSpPr txBox="1"/>
-          <p:nvPr/>
-        </p:nvSpPr>
-        <p:spPr>
-          <a:xfrm>
-            <a:off x="1116000" y="3294000"/>
-            <a:ext cx="16020001" cy="216000"/>
-          </a:xfrm>
-          <a:prstGeom prst="rect">
-            <a:avLst/>
-          </a:prstGeom>
-          <a:noFill/>
-        </p:spPr>
-        <p:txBody>
-          <a:bodyPr wrap="square">
-            <a:spAutoFit/>
-          </a:bodyPr>
-          <a:lstStyle/>
-          <a:p>
-            <a:pPr algn="r"/>
-            <a:r>
-              <a:rPr sz="1000" b="0">
-                <a:solidFill>
-                  <a:srgbClr val="CCCCCC"/>
-                </a:solidFill>
-                <a:latin typeface="Noto Sans Arabic"/>
-              </a:rPr>
-              <a:t>Parental Monitoring Tools</a:t>
-            </a:r>
-          </a:p>
-        </p:txBody>
-      </p:sp>
-      <p:sp>
-        <p:nvSpPr>
-          <p:cNvPr id="28" name="Rectangle 27"/>
-          <p:cNvSpPr/>
-          <p:nvPr/>
-        </p:nvSpPr>
-        <p:spPr>
-          <a:xfrm>
-            <a:off x="648000" y="3636000"/>
-            <a:ext cx="17028000" cy="522000"/>
-          </a:xfrm>
-          <a:prstGeom prst="rect">
-            <a:avLst/>
-          </a:prstGeom>
-          <a:solidFill>
-            <a:srgbClr val="1E3055"/>
-          </a:solidFill>
-          <a:ln>
-            <a:noFill/>
-          </a:ln>
-        </p:spPr>
-        <p:style>
-          <a:lnRef idx="1">
-            <a:schemeClr val="accent1"/>
-          </a:lnRef>
-          <a:fillRef idx="3">
-            <a:schemeClr val="accent1"/>
-          </a:fillRef>
-          <a:effectRef idx="2">
-            <a:schemeClr val="accent1"/>
-          </a:effectRef>
-          <a:fontRef idx="minor">
-            <a:schemeClr val="lt1"/>
-          </a:fontRef>
-        </p:style>
-        <p:txBody>
-          <a:bodyPr rtlCol="0" anchor="ctr"/>
-          <a:lstStyle/>
-          <a:p>
-            <a:pPr algn="ctr"/>
-          </a:p>
-        </p:txBody>
-      </p:sp>
-      <p:sp>
-        <p:nvSpPr>
-          <p:cNvPr id="29" name="Rectangle 28"/>
-          <p:cNvSpPr/>
-          <p:nvPr/>
-        </p:nvSpPr>
-        <p:spPr>
-          <a:xfrm>
-            <a:off x="648000" y="3636000"/>
-            <a:ext cx="396000" cy="522000"/>
-          </a:xfrm>
-          <a:prstGeom prst="rect">
-            <a:avLst/>
-          </a:prstGeom>
-          <a:solidFill>
-            <a:srgbClr val="C9A84C"/>
-          </a:solidFill>
-          <a:ln>
-            <a:noFill/>
-          </a:ln>
-        </p:spPr>
-        <p:style>
-          <a:lnRef idx="1">
-            <a:schemeClr val="accent1"/>
-          </a:lnRef>
-          <a:fillRef idx="3">
-            <a:schemeClr val="accent1"/>
-          </a:fillRef>
-          <a:effectRef idx="2">
-            <a:schemeClr val="accent1"/>
-          </a:effectRef>
-          <a:fontRef idx="minor">
-            <a:schemeClr val="lt1"/>
-          </a:fontRef>
-        </p:style>
-        <p:txBody>
-          <a:bodyPr rtlCol="0" anchor="ctr"/>
-          <a:lstStyle/>
-          <a:p>
-            <a:pPr algn="ctr"/>
-          </a:p>
-        </p:txBody>
-      </p:sp>
-      <p:sp>
-        <p:nvSpPr>
-          <p:cNvPr id="30" name="TextBox 29"/>
-          <p:cNvSpPr txBox="1"/>
-          <p:nvPr/>
-        </p:nvSpPr>
-        <p:spPr>
-          <a:xfrm>
-            <a:off x="648000" y="3636000"/>
-            <a:ext cx="396000" cy="522000"/>
-          </a:xfrm>
-          <a:prstGeom prst="rect">
-            <a:avLst/>
-          </a:prstGeom>
-          <a:noFill/>
-        </p:spPr>
-        <p:txBody>
-          <a:bodyPr wrap="square">
-            <a:spAutoFit/>
-          </a:bodyPr>
-          <a:lstStyle/>
-          <a:p>
-            <a:pPr algn="ctr"/>
-            <a:r>
-              <a:rPr sz="1600" b="1">
                 <a:solidFill>
                   <a:srgbClr val="1A2A4A"/>
                 </a:solidFill>
                 <a:latin typeface="Noto Sans Arabic"/>
               </a:rPr>
-              <a:t>4</a:t>
-            </a:r>
-          </a:p>
-        </p:txBody>
-      </p:sp>
-      <p:sp>
-        <p:nvSpPr>
-          <p:cNvPr id="31" name="Rectangle 30"/>
-          <p:cNvSpPr/>
-          <p:nvPr/>
-        </p:nvSpPr>
-        <p:spPr>
-          <a:xfrm>
-            <a:off x="17208000" y="3761999"/>
-            <a:ext cx="251999" cy="251999"/>
-          </a:xfrm>
-          <a:prstGeom prst="rect">
-            <a:avLst/>
-          </a:prstGeom>
-          <a:solidFill>
-            <a:srgbClr val="C9A84C"/>
-          </a:solidFill>
-          <a:ln>
-            <a:noFill/>
-          </a:ln>
-        </p:spPr>
-        <p:style>
-          <a:lnRef idx="1">
-            <a:schemeClr val="accent1"/>
-          </a:lnRef>
-          <a:fillRef idx="3">
-            <a:schemeClr val="accent1"/>
-          </a:fillRef>
-          <a:effectRef idx="2">
-            <a:schemeClr val="accent1"/>
-          </a:effectRef>
-          <a:fontRef idx="minor">
-            <a:schemeClr val="lt1"/>
-          </a:fontRef>
-        </p:style>
-        <p:txBody>
-          <a:bodyPr rtlCol="0" anchor="ctr"/>
-          <a:lstStyle/>
-          <a:p>
-            <a:pPr algn="ctr"/>
-          </a:p>
-        </p:txBody>
-      </p:sp>
-      <p:sp>
-        <p:nvSpPr>
-          <p:cNvPr id="32" name="TextBox 31"/>
-          <p:cNvSpPr txBox="1"/>
-          <p:nvPr/>
-        </p:nvSpPr>
-        <p:spPr>
-          <a:xfrm>
-            <a:off x="1116000" y="3654000"/>
-            <a:ext cx="16020001" cy="288000"/>
-          </a:xfrm>
-          <a:prstGeom prst="rect">
-            <a:avLst/>
-          </a:prstGeom>
-          <a:noFill/>
-        </p:spPr>
-        <p:txBody>
-          <a:bodyPr wrap="square">
-            <a:spAutoFit/>
-          </a:bodyPr>
-          <a:lstStyle/>
-          <a:p>
-            <a:pPr algn="r"/>
-            <a:r>
-              <a:rPr sz="1400" b="1">
-                <a:solidFill>
-                  <a:srgbClr val="FFFFFF"/>
-                </a:solidFill>
-                <a:latin typeface="Noto Sans Arabic"/>
-              </a:rPr>
-              <a:t>الإبلاغ عن الاختراقات</a:t>
-            </a:r>
-          </a:p>
-        </p:txBody>
-      </p:sp>
-      <p:sp>
-        <p:nvSpPr>
-          <p:cNvPr id="33" name="TextBox 32"/>
-          <p:cNvSpPr txBox="1"/>
-          <p:nvPr/>
-        </p:nvSpPr>
-        <p:spPr>
-          <a:xfrm>
-            <a:off x="1116000" y="3906000"/>
-            <a:ext cx="16020001" cy="216000"/>
-          </a:xfrm>
-          <a:prstGeom prst="rect">
-            <a:avLst/>
-          </a:prstGeom>
-          <a:noFill/>
-        </p:spPr>
-        <p:txBody>
-          <a:bodyPr wrap="square">
-            <a:spAutoFit/>
-          </a:bodyPr>
-          <a:lstStyle/>
-          <a:p>
-            <a:pPr algn="r"/>
-            <a:r>
-              <a:rPr sz="1000" b="0">
-                <a:solidFill>
-                  <a:srgbClr val="CCCCCC"/>
-                </a:solidFill>
-                <a:latin typeface="Noto Sans Arabic"/>
-              </a:rPr>
-              <a:t>Breach Reporting Obligation</a:t>
-            </a:r>
-          </a:p>
-        </p:txBody>
-      </p:sp>
-      <p:sp>
-        <p:nvSpPr>
-          <p:cNvPr id="34" name="Rectangle 33"/>
-          <p:cNvSpPr/>
-          <p:nvPr/>
-        </p:nvSpPr>
-        <p:spPr>
-          <a:xfrm>
-            <a:off x="648000" y="4248000"/>
-            <a:ext cx="17028000" cy="522000"/>
-          </a:xfrm>
-          <a:prstGeom prst="rect">
-            <a:avLst/>
-          </a:prstGeom>
-          <a:solidFill>
-            <a:srgbClr val="1E3055"/>
-          </a:solidFill>
-          <a:ln>
-            <a:noFill/>
-          </a:ln>
-        </p:spPr>
-        <p:style>
-          <a:lnRef idx="1">
-            <a:schemeClr val="accent1"/>
-          </a:lnRef>
-          <a:fillRef idx="3">
-            <a:schemeClr val="accent1"/>
-          </a:fillRef>
-          <a:effectRef idx="2">
-            <a:schemeClr val="accent1"/>
-          </a:effectRef>
-          <a:fontRef idx="minor">
-            <a:schemeClr val="lt1"/>
-          </a:fontRef>
-        </p:style>
-        <p:txBody>
-          <a:bodyPr rtlCol="0" anchor="ctr"/>
-          <a:lstStyle/>
-          <a:p>
-            <a:pPr algn="ctr"/>
-          </a:p>
-        </p:txBody>
-      </p:sp>
-      <p:sp>
-        <p:nvSpPr>
-          <p:cNvPr id="35" name="Rectangle 34"/>
-          <p:cNvSpPr/>
-          <p:nvPr/>
-        </p:nvSpPr>
-        <p:spPr>
-          <a:xfrm>
-            <a:off x="648000" y="4248000"/>
-            <a:ext cx="396000" cy="522000"/>
-          </a:xfrm>
-          <a:prstGeom prst="rect">
-            <a:avLst/>
-          </a:prstGeom>
-          <a:solidFill>
-            <a:srgbClr val="C9A84C"/>
-          </a:solidFill>
-          <a:ln>
-            <a:noFill/>
-          </a:ln>
-        </p:spPr>
-        <p:style>
-          <a:lnRef idx="1">
-            <a:schemeClr val="accent1"/>
-          </a:lnRef>
-          <a:fillRef idx="3">
-            <a:schemeClr val="accent1"/>
-          </a:fillRef>
-          <a:effectRef idx="2">
-            <a:schemeClr val="accent1"/>
-          </a:effectRef>
-          <a:fontRef idx="minor">
-            <a:schemeClr val="lt1"/>
-          </a:fontRef>
-        </p:style>
-        <p:txBody>
-          <a:bodyPr rtlCol="0" anchor="ctr"/>
-          <a:lstStyle/>
-          <a:p>
-            <a:pPr algn="ctr"/>
-          </a:p>
-        </p:txBody>
-      </p:sp>
-      <p:sp>
-        <p:nvSpPr>
-          <p:cNvPr id="36" name="TextBox 35"/>
-          <p:cNvSpPr txBox="1"/>
-          <p:nvPr/>
-        </p:nvSpPr>
-        <p:spPr>
-          <a:xfrm>
-            <a:off x="648000" y="4248000"/>
-            <a:ext cx="396000" cy="522000"/>
-          </a:xfrm>
-          <a:prstGeom prst="rect">
-            <a:avLst/>
-          </a:prstGeom>
-          <a:noFill/>
-        </p:spPr>
-        <p:txBody>
-          <a:bodyPr wrap="square">
-            <a:spAutoFit/>
-          </a:bodyPr>
-          <a:lstStyle/>
-          <a:p>
-            <a:pPr algn="ctr"/>
-            <a:r>
-              <a:rPr sz="1600" b="1">
-                <a:solidFill>
-                  <a:srgbClr val="1A2A4A"/>
-                </a:solidFill>
-                <a:latin typeface="Noto Sans Arabic"/>
-              </a:rPr>
-              <a:t>5</a:t>
-            </a:r>
-          </a:p>
-        </p:txBody>
-      </p:sp>
-      <p:sp>
-        <p:nvSpPr>
-          <p:cNvPr id="37" name="Rectangle 36"/>
-          <p:cNvSpPr/>
-          <p:nvPr/>
-        </p:nvSpPr>
-        <p:spPr>
-          <a:xfrm>
-            <a:off x="17208000" y="4373999"/>
-            <a:ext cx="251999" cy="251999"/>
-          </a:xfrm>
-          <a:prstGeom prst="rect">
-            <a:avLst/>
-          </a:prstGeom>
-          <a:solidFill>
-            <a:srgbClr val="C9A84C"/>
-          </a:solidFill>
-          <a:ln>
-            <a:noFill/>
-          </a:ln>
-        </p:spPr>
-        <p:style>
-          <a:lnRef idx="1">
-            <a:schemeClr val="accent1"/>
-          </a:lnRef>
-          <a:fillRef idx="3">
-            <a:schemeClr val="accent1"/>
-          </a:fillRef>
-          <a:effectRef idx="2">
-            <a:schemeClr val="accent1"/>
-          </a:effectRef>
-          <a:fontRef idx="minor">
-            <a:schemeClr val="lt1"/>
-          </a:fontRef>
-        </p:style>
-        <p:txBody>
-          <a:bodyPr rtlCol="0" anchor="ctr"/>
-          <a:lstStyle/>
-          <a:p>
-            <a:pPr algn="ctr"/>
-          </a:p>
-        </p:txBody>
-      </p:sp>
-      <p:sp>
-        <p:nvSpPr>
-          <p:cNvPr id="38" name="TextBox 37"/>
-          <p:cNvSpPr txBox="1"/>
-          <p:nvPr/>
-        </p:nvSpPr>
-        <p:spPr>
-          <a:xfrm>
-            <a:off x="1116000" y="4266000"/>
-            <a:ext cx="16020001" cy="288000"/>
-          </a:xfrm>
-          <a:prstGeom prst="rect">
-            <a:avLst/>
-          </a:prstGeom>
-          <a:noFill/>
-        </p:spPr>
-        <p:txBody>
-          <a:bodyPr wrap="square">
-            <a:spAutoFit/>
-          </a:bodyPr>
-          <a:lstStyle/>
-          <a:p>
-            <a:pPr algn="r"/>
-            <a:r>
-              <a:rPr sz="1400" b="1">
-                <a:solidFill>
-                  <a:srgbClr val="FFFFFF"/>
-                </a:solidFill>
-                <a:latin typeface="Noto Sans Arabic"/>
-              </a:rPr>
-              <a:t>ضبط صلاحيات الوصول</a:t>
-            </a:r>
-          </a:p>
-        </p:txBody>
-      </p:sp>
-      <p:sp>
-        <p:nvSpPr>
-          <p:cNvPr id="39" name="TextBox 38"/>
-          <p:cNvSpPr txBox="1"/>
-          <p:nvPr/>
-        </p:nvSpPr>
-        <p:spPr>
-          <a:xfrm>
-            <a:off x="1116000" y="4518000"/>
-            <a:ext cx="16020001" cy="216000"/>
-          </a:xfrm>
-          <a:prstGeom prst="rect">
-            <a:avLst/>
-          </a:prstGeom>
-          <a:noFill/>
-        </p:spPr>
-        <p:txBody>
-          <a:bodyPr wrap="square">
-            <a:spAutoFit/>
-          </a:bodyPr>
-          <a:lstStyle/>
-          <a:p>
-            <a:pPr algn="r"/>
-            <a:r>
-              <a:rPr sz="1000" b="0">
-                <a:solidFill>
-                  <a:srgbClr val="CCCCCC"/>
-                </a:solidFill>
-                <a:latin typeface="Noto Sans Arabic"/>
-              </a:rPr>
-              <a:t>Access Control Management</a:t>
+              <a:t>أول تشريع اتحادي إماراتي لحماية الطفل في الفضاء الرقمي — يناير 2026</a:t>
             </a:r>
           </a:p>
         </p:txBody>
@@ -7516,51 +7283,8 @@
         </p:nvSpPr>
         <p:spPr>
           <a:xfrm>
-            <a:off x="432000" y="540000"/>
-            <a:ext cx="17424000" cy="9387000"/>
-          </a:xfrm>
-          <a:prstGeom prst="rect">
-            <a:avLst/>
-          </a:prstGeom>
-          <a:solidFill>
-            <a:srgbClr val="0F1D35"/>
-          </a:solidFill>
-          <a:ln>
-            <a:noFill/>
-          </a:ln>
-        </p:spPr>
-        <p:style>
-          <a:lnRef idx="1">
-            <a:schemeClr val="accent1"/>
-          </a:lnRef>
-          <a:fillRef idx="3">
-            <a:schemeClr val="accent1"/>
-          </a:fillRef>
-          <a:effectRef idx="2">
-            <a:schemeClr val="accent1"/>
-          </a:effectRef>
-          <a:fontRef idx="minor">
-            <a:schemeClr val="lt1"/>
-          </a:fontRef>
-        </p:style>
-        <p:txBody>
-          <a:bodyPr rtlCol="0" anchor="ctr"/>
-          <a:lstStyle/>
-          <a:p>
-            <a:pPr algn="ctr"/>
-          </a:p>
-        </p:txBody>
-      </p:sp>
-      <p:sp>
-        <p:nvSpPr>
-          <p:cNvPr id="6" name="Rectangle 5"/>
-          <p:cNvSpPr/>
-          <p:nvPr/>
-        </p:nvSpPr>
-        <p:spPr>
-          <a:xfrm>
-            <a:off x="432000" y="540000"/>
-            <a:ext cx="17424000" cy="180000"/>
+            <a:off x="0" y="0"/>
+            <a:ext cx="18288000" cy="109728"/>
           </a:xfrm>
           <a:prstGeom prst="rect">
             <a:avLst/>
@@ -7596,14 +7320,14 @@
       </p:sp>
       <p:sp>
         <p:nvSpPr>
-          <p:cNvPr id="7" name="TextBox 6"/>
+          <p:cNvPr id="6" name="TextBox 5"/>
           <p:cNvSpPr txBox="1"/>
           <p:nvPr/>
         </p:nvSpPr>
         <p:spPr>
           <a:xfrm>
-            <a:off x="540000" y="827999"/>
-            <a:ext cx="17208000" cy="432000"/>
+            <a:off x="457200" y="182880"/>
+            <a:ext cx="17373600" cy="1188720"/>
           </a:xfrm>
           <a:prstGeom prst="rect">
             <a:avLst/>
@@ -7616,9 +7340,9 @@
           </a:bodyPr>
           <a:lstStyle/>
           <a:p>
-            <a:pPr algn="ctr"/>
-            <a:r>
-              <a:rPr sz="2200" b="1">
+            <a:pPr algn="r"/>
+            <a:r>
+              <a:rPr sz="3200" b="1">
                 <a:solidFill>
                   <a:srgbClr val="C9A84C"/>
                 </a:solidFill>
@@ -7627,131 +7351,30 @@
               <a:t>كيف تُجسّد بوابة الجود أحكام القانون؟</a:t>
             </a:r>
           </a:p>
-        </p:txBody>
-      </p:sp>
-      <p:sp>
-        <p:nvSpPr>
-          <p:cNvPr id="8" name="TextBox 7"/>
-          <p:cNvSpPr txBox="1"/>
-          <p:nvPr/>
-        </p:nvSpPr>
-        <p:spPr>
-          <a:xfrm>
-            <a:off x="540000" y="1260000"/>
-            <a:ext cx="17208000" cy="288000"/>
-          </a:xfrm>
-          <a:prstGeom prst="rect">
-            <a:avLst/>
-          </a:prstGeom>
-          <a:noFill/>
-        </p:spPr>
-        <p:txBody>
-          <a:bodyPr wrap="square">
-            <a:spAutoFit/>
-          </a:bodyPr>
-          <a:lstStyle/>
-          <a:p>
-            <a:pPr algn="ctr"/>
-            <a:r>
-              <a:rPr sz="1200" b="0">
+          <a:p>
+            <a:pPr algn="r"/>
+            <a:r>
+              <a:rPr sz="1300" b="0">
                 <a:solidFill>
                   <a:srgbClr val="CCCCCC"/>
                 </a:solidFill>
                 <a:latin typeface="Noto Sans Arabic"/>
               </a:rPr>
-              <a:t>How Al Jood Portal Implements the Child Digital Safety Law</a:t>
+              <a:t>Al Jood Portal — Compliance with Child Digital Safety Law</a:t>
             </a:r>
           </a:p>
         </p:txBody>
       </p:sp>
       <p:sp>
         <p:nvSpPr>
-          <p:cNvPr id="9" name="Rectangle 8"/>
+          <p:cNvPr id="7" name="Rectangle 6"/>
           <p:cNvSpPr/>
           <p:nvPr/>
         </p:nvSpPr>
         <p:spPr>
           <a:xfrm>
-            <a:off x="540000" y="1620000"/>
-            <a:ext cx="8496000" cy="251999"/>
-          </a:xfrm>
-          <a:prstGeom prst="rect">
-            <a:avLst/>
-          </a:prstGeom>
-          <a:solidFill>
-            <a:srgbClr val="1A2A4A"/>
-          </a:solidFill>
-          <a:ln>
-            <a:noFill/>
-          </a:ln>
-        </p:spPr>
-        <p:style>
-          <a:lnRef idx="1">
-            <a:schemeClr val="accent1"/>
-          </a:lnRef>
-          <a:fillRef idx="3">
-            <a:schemeClr val="accent1"/>
-          </a:fillRef>
-          <a:effectRef idx="2">
-            <a:schemeClr val="accent1"/>
-          </a:effectRef>
-          <a:fontRef idx="minor">
-            <a:schemeClr val="lt1"/>
-          </a:fontRef>
-        </p:style>
-        <p:txBody>
-          <a:bodyPr rtlCol="0" anchor="ctr"/>
-          <a:lstStyle/>
-          <a:p>
-            <a:pPr algn="ctr"/>
-          </a:p>
-        </p:txBody>
-      </p:sp>
-      <p:sp>
-        <p:nvSpPr>
-          <p:cNvPr id="10" name="TextBox 9"/>
-          <p:cNvSpPr txBox="1"/>
-          <p:nvPr/>
-        </p:nvSpPr>
-        <p:spPr>
-          <a:xfrm>
-            <a:off x="540000" y="1620000"/>
-            <a:ext cx="8496000" cy="251999"/>
-          </a:xfrm>
-          <a:prstGeom prst="rect">
-            <a:avLst/>
-          </a:prstGeom>
-          <a:noFill/>
-        </p:spPr>
-        <p:txBody>
-          <a:bodyPr wrap="square">
-            <a:spAutoFit/>
-          </a:bodyPr>
-          <a:lstStyle/>
-          <a:p>
-            <a:pPr algn="ctr"/>
-            <a:r>
-              <a:rPr sz="1300" b="1">
-                <a:solidFill>
-                  <a:srgbClr val="C9A84C"/>
-                </a:solidFill>
-                <a:latin typeface="Noto Sans Arabic"/>
-              </a:rPr>
-              <a:t>متطلب القانون</a:t>
-            </a:r>
-          </a:p>
-        </p:txBody>
-      </p:sp>
-      <p:sp>
-        <p:nvSpPr>
-          <p:cNvPr id="11" name="Rectangle 10"/>
-          <p:cNvSpPr/>
-          <p:nvPr/>
-        </p:nvSpPr>
-        <p:spPr>
-          <a:xfrm>
-            <a:off x="9252000" y="1620000"/>
-            <a:ext cx="8496000" cy="251999"/>
+            <a:off x="365760" y="1600200"/>
+            <a:ext cx="6217920" cy="594360"/>
           </a:xfrm>
           <a:prstGeom prst="rect">
             <a:avLst/>
@@ -7778,64 +7401,200 @@
           </a:fontRef>
         </p:style>
         <p:txBody>
-          <a:bodyPr rtlCol="0" anchor="ctr"/>
+          <a:bodyPr rtlCol="0" anchor="ctr" wrap="square"/>
           <a:lstStyle/>
           <a:p>
             <a:pPr algn="ctr"/>
-          </a:p>
-        </p:txBody>
-      </p:sp>
-      <p:sp>
-        <p:nvSpPr>
-          <p:cNvPr id="12" name="TextBox 11"/>
-          <p:cNvSpPr txBox="1"/>
-          <p:nvPr/>
-        </p:nvSpPr>
-        <p:spPr>
-          <a:xfrm>
-            <a:off x="9252000" y="1620000"/>
-            <a:ext cx="8496000" cy="251999"/>
-          </a:xfrm>
-          <a:prstGeom prst="rect">
-            <a:avLst/>
-          </a:prstGeom>
-          <a:noFill/>
-        </p:spPr>
-        <p:txBody>
-          <a:bodyPr wrap="square">
-            <a:spAutoFit/>
-          </a:bodyPr>
-          <a:lstStyle/>
-          <a:p>
-            <a:pPr algn="ctr"/>
-            <a:r>
-              <a:rPr sz="1300" b="1">
+            <a:r>
+              <a:rPr sz="1600" b="1">
                 <a:solidFill>
                   <a:srgbClr val="1A2A4A"/>
                 </a:solidFill>
                 <a:latin typeface="Noto Sans Arabic"/>
               </a:rPr>
-              <a:t>ميزة البوابة</a:t>
+              <a:t>متطلب القانون</a:t>
             </a:r>
           </a:p>
         </p:txBody>
       </p:sp>
       <p:sp>
         <p:nvSpPr>
-          <p:cNvPr id="13" name="Rectangle 12"/>
+          <p:cNvPr id="8" name="Rectangle 7"/>
           <p:cNvSpPr/>
           <p:nvPr/>
         </p:nvSpPr>
         <p:spPr>
           <a:xfrm>
-            <a:off x="540000" y="1944000"/>
-            <a:ext cx="8496000" cy="342000"/>
+            <a:off x="6858000" y="1600200"/>
+            <a:ext cx="9326880" cy="594360"/>
           </a:xfrm>
           <a:prstGeom prst="rect">
             <a:avLst/>
           </a:prstGeom>
           <a:solidFill>
-            <a:srgbClr val="1E3055"/>
+            <a:srgbClr val="1E345C"/>
+          </a:solidFill>
+          <a:ln w="12700">
+            <a:solidFill>
+              <a:srgbClr val="C9A84C"/>
+            </a:solidFill>
+          </a:ln>
+        </p:spPr>
+        <p:style>
+          <a:lnRef idx="1">
+            <a:schemeClr val="accent1"/>
+          </a:lnRef>
+          <a:fillRef idx="3">
+            <a:schemeClr val="accent1"/>
+          </a:fillRef>
+          <a:effectRef idx="2">
+            <a:schemeClr val="accent1"/>
+          </a:effectRef>
+          <a:fontRef idx="minor">
+            <a:schemeClr val="lt1"/>
+          </a:fontRef>
+        </p:style>
+        <p:txBody>
+          <a:bodyPr rtlCol="0" anchor="ctr" wrap="square"/>
+          <a:lstStyle/>
+          <a:p>
+            <a:pPr algn="ctr"/>
+            <a:r>
+              <a:rPr sz="1600" b="1">
+                <a:solidFill>
+                  <a:srgbClr val="C9A84C"/>
+                </a:solidFill>
+                <a:latin typeface="Noto Sans Arabic"/>
+              </a:rPr>
+              <a:t>ميزة بوابة الجود</a:t>
+            </a:r>
+          </a:p>
+        </p:txBody>
+      </p:sp>
+      <p:sp>
+        <p:nvSpPr>
+          <p:cNvPr id="9" name="Rectangle 8"/>
+          <p:cNvSpPr/>
+          <p:nvPr/>
+        </p:nvSpPr>
+        <p:spPr>
+          <a:xfrm>
+            <a:off x="365760" y="2331720"/>
+            <a:ext cx="6217920" cy="1234440"/>
+          </a:xfrm>
+          <a:prstGeom prst="rect">
+            <a:avLst/>
+          </a:prstGeom>
+          <a:solidFill>
+            <a:srgbClr val="1A2A4A"/>
+          </a:solidFill>
+          <a:ln w="3810">
+            <a:solidFill>
+              <a:srgbClr val="C9A84C"/>
+            </a:solidFill>
+          </a:ln>
+        </p:spPr>
+        <p:style>
+          <a:lnRef idx="1">
+            <a:schemeClr val="accent1"/>
+          </a:lnRef>
+          <a:fillRef idx="3">
+            <a:schemeClr val="accent1"/>
+          </a:fillRef>
+          <a:effectRef idx="2">
+            <a:schemeClr val="accent1"/>
+          </a:effectRef>
+          <a:fontRef idx="minor">
+            <a:schemeClr val="lt1"/>
+          </a:fontRef>
+        </p:style>
+        <p:txBody>
+          <a:bodyPr rtlCol="0" anchor="ctr" wrap="square"/>
+          <a:lstStyle/>
+          <a:p>
+            <a:pPr algn="r"/>
+            <a:r>
+              <a:rPr sz="1400" b="1">
+                <a:solidFill>
+                  <a:srgbClr val="F3E5B8"/>
+                </a:solidFill>
+                <a:latin typeface="Noto Sans Arabic"/>
+              </a:rPr>
+              <a:t>حماية البيانات الرقمية</a:t>
+            </a:r>
+          </a:p>
+        </p:txBody>
+      </p:sp>
+      <p:sp>
+        <p:nvSpPr>
+          <p:cNvPr id="10" name="Rectangle 9"/>
+          <p:cNvSpPr/>
+          <p:nvPr/>
+        </p:nvSpPr>
+        <p:spPr>
+          <a:xfrm>
+            <a:off x="6858000" y="2331720"/>
+            <a:ext cx="9326880" cy="1234440"/>
+          </a:xfrm>
+          <a:prstGeom prst="rect">
+            <a:avLst/>
+          </a:prstGeom>
+          <a:solidFill>
+            <a:srgbClr val="1A2A4A"/>
+          </a:solidFill>
+          <a:ln w="3810">
+            <a:solidFill>
+              <a:srgbClr val="C9A84C"/>
+            </a:solidFill>
+          </a:ln>
+        </p:spPr>
+        <p:style>
+          <a:lnRef idx="1">
+            <a:schemeClr val="accent1"/>
+          </a:lnRef>
+          <a:fillRef idx="3">
+            <a:schemeClr val="accent1"/>
+          </a:fillRef>
+          <a:effectRef idx="2">
+            <a:schemeClr val="accent1"/>
+          </a:effectRef>
+          <a:fontRef idx="minor">
+            <a:schemeClr val="lt1"/>
+          </a:fontRef>
+        </p:style>
+        <p:txBody>
+          <a:bodyPr rtlCol="0" anchor="ctr" wrap="square"/>
+          <a:lstStyle/>
+          <a:p>
+            <a:pPr algn="r"/>
+            <a:r>
+              <a:rPr sz="1200" b="0">
+                <a:solidFill>
+                  <a:srgbClr val="FFFFFF"/>
+                </a:solidFill>
+                <a:latin typeface="Noto Sans Arabic"/>
+              </a:rPr>
+              <a:t>localStorage فقط — لا سحابة خارجية، بيانات محلية آمنة بالكامل</a:t>
+            </a:r>
+          </a:p>
+        </p:txBody>
+      </p:sp>
+      <p:sp>
+        <p:nvSpPr>
+          <p:cNvPr id="11" name="Rectangle 10"/>
+          <p:cNvSpPr/>
+          <p:nvPr/>
+        </p:nvSpPr>
+        <p:spPr>
+          <a:xfrm>
+            <a:off x="16322039" y="2724912"/>
+            <a:ext cx="457200" cy="457200"/>
+          </a:xfrm>
+          <a:prstGeom prst="rect">
+            <a:avLst/>
+          </a:prstGeom>
+          <a:solidFill>
+            <a:srgbClr val="2E7D32"/>
           </a:solidFill>
           <a:ln>
             <a:noFill/>
@@ -7856,33 +7615,115 @@
           </a:fontRef>
         </p:style>
         <p:txBody>
-          <a:bodyPr rtlCol="0" anchor="ctr"/>
+          <a:bodyPr rtlCol="0" anchor="ctr" wrap="square"/>
           <a:lstStyle/>
           <a:p>
             <a:pPr algn="ctr"/>
+            <a:r>
+              <a:rPr sz="900" b="1">
+                <a:solidFill>
+                  <a:srgbClr val="FFFFFF"/>
+                </a:solidFill>
+                <a:latin typeface="Noto Sans Arabic"/>
+              </a:rPr>
+              <a:t>OK</a:t>
+            </a:r>
           </a:p>
         </p:txBody>
       </p:sp>
       <p:sp>
         <p:nvSpPr>
-          <p:cNvPr id="14" name="TextBox 13"/>
-          <p:cNvSpPr txBox="1"/>
+          <p:cNvPr id="12" name="Rectangle 11"/>
+          <p:cNvSpPr/>
           <p:nvPr/>
         </p:nvSpPr>
         <p:spPr>
           <a:xfrm>
-            <a:off x="612000" y="1980000"/>
-            <a:ext cx="8352000" cy="306000"/>
+            <a:off x="365760" y="3657600"/>
+            <a:ext cx="6217920" cy="1234440"/>
           </a:xfrm>
           <a:prstGeom prst="rect">
             <a:avLst/>
           </a:prstGeom>
-          <a:noFill/>
+          <a:solidFill>
+            <a:srgbClr val="1E345C"/>
+          </a:solidFill>
+          <a:ln w="3810">
+            <a:solidFill>
+              <a:srgbClr val="C9A84C"/>
+            </a:solidFill>
+          </a:ln>
         </p:spPr>
+        <p:style>
+          <a:lnRef idx="1">
+            <a:schemeClr val="accent1"/>
+          </a:lnRef>
+          <a:fillRef idx="3">
+            <a:schemeClr val="accent1"/>
+          </a:fillRef>
+          <a:effectRef idx="2">
+            <a:schemeClr val="accent1"/>
+          </a:effectRef>
+          <a:fontRef idx="minor">
+            <a:schemeClr val="lt1"/>
+          </a:fontRef>
+        </p:style>
         <p:txBody>
-          <a:bodyPr wrap="square">
-            <a:spAutoFit/>
-          </a:bodyPr>
+          <a:bodyPr rtlCol="0" anchor="ctr" wrap="square"/>
+          <a:lstStyle/>
+          <a:p>
+            <a:pPr algn="r"/>
+            <a:r>
+              <a:rPr sz="1400" b="1">
+                <a:solidFill>
+                  <a:srgbClr val="F3E5B8"/>
+                </a:solidFill>
+                <a:latin typeface="Noto Sans Arabic"/>
+              </a:rPr>
+              <a:t>توثيق هوية المستخدمين</a:t>
+            </a:r>
+          </a:p>
+        </p:txBody>
+      </p:sp>
+      <p:sp>
+        <p:nvSpPr>
+          <p:cNvPr id="13" name="Rectangle 12"/>
+          <p:cNvSpPr/>
+          <p:nvPr/>
+        </p:nvSpPr>
+        <p:spPr>
+          <a:xfrm>
+            <a:off x="6858000" y="3657600"/>
+            <a:ext cx="9326880" cy="1234440"/>
+          </a:xfrm>
+          <a:prstGeom prst="rect">
+            <a:avLst/>
+          </a:prstGeom>
+          <a:solidFill>
+            <a:srgbClr val="1E345C"/>
+          </a:solidFill>
+          <a:ln w="3810">
+            <a:solidFill>
+              <a:srgbClr val="C9A84C"/>
+            </a:solidFill>
+          </a:ln>
+        </p:spPr>
+        <p:style>
+          <a:lnRef idx="1">
+            <a:schemeClr val="accent1"/>
+          </a:lnRef>
+          <a:fillRef idx="3">
+            <a:schemeClr val="accent1"/>
+          </a:fillRef>
+          <a:effectRef idx="2">
+            <a:schemeClr val="accent1"/>
+          </a:effectRef>
+          <a:fontRef idx="minor">
+            <a:schemeClr val="lt1"/>
+          </a:fontRef>
+        </p:style>
+        <p:txBody>
+          <a:bodyPr rtlCol="0" anchor="ctr" wrap="square"/>
           <a:lstStyle/>
           <a:p>
             <a:pPr algn="r"/>
@@ -7893,27 +7734,27 @@
                 </a:solidFill>
                 <a:latin typeface="Noto Sans Arabic"/>
               </a:rPr>
-              <a:t>حماية بيانات الطلاب</a:t>
+              <a:t>5 مستويات دخول مستقلة: مدير، مديرة، معلم، إداري، ولي أمر</a:t>
             </a:r>
           </a:p>
         </p:txBody>
       </p:sp>
       <p:sp>
         <p:nvSpPr>
-          <p:cNvPr id="15" name="Rectangle 14"/>
+          <p:cNvPr id="14" name="Rectangle 13"/>
           <p:cNvSpPr/>
           <p:nvPr/>
         </p:nvSpPr>
         <p:spPr>
           <a:xfrm>
-            <a:off x="9252000" y="1944000"/>
-            <a:ext cx="8496000" cy="342000"/>
+            <a:off x="16322039" y="4050791"/>
+            <a:ext cx="457200" cy="457200"/>
           </a:xfrm>
           <a:prstGeom prst="rect">
             <a:avLst/>
           </a:prstGeom>
           <a:solidFill>
-            <a:srgbClr val="1E3055"/>
+            <a:srgbClr val="2E7D32"/>
           </a:solidFill>
           <a:ln>
             <a:noFill/>
@@ -7934,29 +7775,146 @@
           </a:fontRef>
         </p:style>
         <p:txBody>
-          <a:bodyPr rtlCol="0" anchor="ctr"/>
+          <a:bodyPr rtlCol="0" anchor="ctr" wrap="square"/>
           <a:lstStyle/>
           <a:p>
             <a:pPr algn="ctr"/>
+            <a:r>
+              <a:rPr sz="900" b="1">
+                <a:solidFill>
+                  <a:srgbClr val="FFFFFF"/>
+                </a:solidFill>
+                <a:latin typeface="Noto Sans Arabic"/>
+              </a:rPr>
+              <a:t>OK</a:t>
+            </a:r>
           </a:p>
         </p:txBody>
       </p:sp>
       <p:sp>
         <p:nvSpPr>
-          <p:cNvPr id="16" name="Rectangle 15"/>
+          <p:cNvPr id="15" name="Rectangle 14"/>
           <p:cNvSpPr/>
           <p:nvPr/>
         </p:nvSpPr>
         <p:spPr>
           <a:xfrm>
-            <a:off x="17424000" y="2016000"/>
-            <a:ext cx="198000" cy="198000"/>
+            <a:off x="365760" y="4983480"/>
+            <a:ext cx="6217920" cy="1234440"/>
           </a:xfrm>
           <a:prstGeom prst="rect">
             <a:avLst/>
           </a:prstGeom>
           <a:solidFill>
-            <a:srgbClr val="4CC97A"/>
+            <a:srgbClr val="1A2A4A"/>
+          </a:solidFill>
+          <a:ln w="3810">
+            <a:solidFill>
+              <a:srgbClr val="C9A84C"/>
+            </a:solidFill>
+          </a:ln>
+        </p:spPr>
+        <p:style>
+          <a:lnRef idx="1">
+            <a:schemeClr val="accent1"/>
+          </a:lnRef>
+          <a:fillRef idx="3">
+            <a:schemeClr val="accent1"/>
+          </a:fillRef>
+          <a:effectRef idx="2">
+            <a:schemeClr val="accent1"/>
+          </a:effectRef>
+          <a:fontRef idx="minor">
+            <a:schemeClr val="lt1"/>
+          </a:fontRef>
+        </p:style>
+        <p:txBody>
+          <a:bodyPr rtlCol="0" anchor="ctr" wrap="square"/>
+          <a:lstStyle/>
+          <a:p>
+            <a:pPr algn="r"/>
+            <a:r>
+              <a:rPr sz="1400" b="1">
+                <a:solidFill>
+                  <a:srgbClr val="F3E5B8"/>
+                </a:solidFill>
+                <a:latin typeface="Noto Sans Arabic"/>
+              </a:rPr>
+              <a:t>رقابة أولياء الأمور</a:t>
+            </a:r>
+          </a:p>
+        </p:txBody>
+      </p:sp>
+      <p:sp>
+        <p:nvSpPr>
+          <p:cNvPr id="16" name="Rectangle 15"/>
+          <p:cNvSpPr/>
+          <p:nvPr/>
+        </p:nvSpPr>
+        <p:spPr>
+          <a:xfrm>
+            <a:off x="6858000" y="4983480"/>
+            <a:ext cx="9326880" cy="1234440"/>
+          </a:xfrm>
+          <a:prstGeom prst="rect">
+            <a:avLst/>
+          </a:prstGeom>
+          <a:solidFill>
+            <a:srgbClr val="1A2A4A"/>
+          </a:solidFill>
+          <a:ln w="3810">
+            <a:solidFill>
+              <a:srgbClr val="C9A84C"/>
+            </a:solidFill>
+          </a:ln>
+        </p:spPr>
+        <p:style>
+          <a:lnRef idx="1">
+            <a:schemeClr val="accent1"/>
+          </a:lnRef>
+          <a:fillRef idx="3">
+            <a:schemeClr val="accent1"/>
+          </a:fillRef>
+          <a:effectRef idx="2">
+            <a:schemeClr val="accent1"/>
+          </a:effectRef>
+          <a:fontRef idx="minor">
+            <a:schemeClr val="lt1"/>
+          </a:fontRef>
+        </p:style>
+        <p:txBody>
+          <a:bodyPr rtlCol="0" anchor="ctr" wrap="square"/>
+          <a:lstStyle/>
+          <a:p>
+            <a:pPr algn="r"/>
+            <a:r>
+              <a:rPr sz="1200" b="0">
+                <a:solidFill>
+                  <a:srgbClr val="FFFFFF"/>
+                </a:solidFill>
+                <a:latin typeface="Noto Sans Arabic"/>
+              </a:rPr>
+              <a:t>بوابة ولي الأمر — قيد التطوير وإطلاق قريب مع بيانات الطلاب</a:t>
+            </a:r>
+          </a:p>
+        </p:txBody>
+      </p:sp>
+      <p:sp>
+        <p:nvSpPr>
+          <p:cNvPr id="17" name="Rectangle 16"/>
+          <p:cNvSpPr/>
+          <p:nvPr/>
+        </p:nvSpPr>
+        <p:spPr>
+          <a:xfrm>
+            <a:off x="16322039" y="5376672"/>
+            <a:ext cx="457200" cy="457200"/>
+          </a:xfrm>
+          <a:prstGeom prst="rect">
+            <a:avLst/>
+          </a:prstGeom>
+          <a:solidFill>
+            <a:srgbClr val="2E7D32"/>
           </a:solidFill>
           <a:ln>
             <a:noFill/>
@@ -7977,33 +7935,115 @@
           </a:fontRef>
         </p:style>
         <p:txBody>
-          <a:bodyPr rtlCol="0" anchor="ctr"/>
+          <a:bodyPr rtlCol="0" anchor="ctr" wrap="square"/>
           <a:lstStyle/>
           <a:p>
             <a:pPr algn="ctr"/>
+            <a:r>
+              <a:rPr sz="900" b="1">
+                <a:solidFill>
+                  <a:srgbClr val="FFFFFF"/>
+                </a:solidFill>
+                <a:latin typeface="Noto Sans Arabic"/>
+              </a:rPr>
+              <a:t>OK</a:t>
+            </a:r>
           </a:p>
         </p:txBody>
       </p:sp>
       <p:sp>
         <p:nvSpPr>
-          <p:cNvPr id="17" name="TextBox 16"/>
-          <p:cNvSpPr txBox="1"/>
+          <p:cNvPr id="18" name="Rectangle 17"/>
+          <p:cNvSpPr/>
           <p:nvPr/>
         </p:nvSpPr>
         <p:spPr>
           <a:xfrm>
-            <a:off x="9324000" y="1980000"/>
-            <a:ext cx="8064000" cy="306000"/>
+            <a:off x="365760" y="6309360"/>
+            <a:ext cx="6217920" cy="1234440"/>
           </a:xfrm>
           <a:prstGeom prst="rect">
             <a:avLst/>
           </a:prstGeom>
-          <a:noFill/>
+          <a:solidFill>
+            <a:srgbClr val="1E345C"/>
+          </a:solidFill>
+          <a:ln w="3810">
+            <a:solidFill>
+              <a:srgbClr val="C9A84C"/>
+            </a:solidFill>
+          </a:ln>
         </p:spPr>
+        <p:style>
+          <a:lnRef idx="1">
+            <a:schemeClr val="accent1"/>
+          </a:lnRef>
+          <a:fillRef idx="3">
+            <a:schemeClr val="accent1"/>
+          </a:fillRef>
+          <a:effectRef idx="2">
+            <a:schemeClr val="accent1"/>
+          </a:effectRef>
+          <a:fontRef idx="minor">
+            <a:schemeClr val="lt1"/>
+          </a:fontRef>
+        </p:style>
         <p:txBody>
-          <a:bodyPr wrap="square">
-            <a:spAutoFit/>
-          </a:bodyPr>
+          <a:bodyPr rtlCol="0" anchor="ctr" wrap="square"/>
+          <a:lstStyle/>
+          <a:p>
+            <a:pPr algn="r"/>
+            <a:r>
+              <a:rPr sz="1400" b="1">
+                <a:solidFill>
+                  <a:srgbClr val="F3E5B8"/>
+                </a:solidFill>
+                <a:latin typeface="Noto Sans Arabic"/>
+              </a:rPr>
+              <a:t>الإبلاغ عن الاختراقات</a:t>
+            </a:r>
+          </a:p>
+        </p:txBody>
+      </p:sp>
+      <p:sp>
+        <p:nvSpPr>
+          <p:cNvPr id="19" name="Rectangle 18"/>
+          <p:cNvSpPr/>
+          <p:nvPr/>
+        </p:nvSpPr>
+        <p:spPr>
+          <a:xfrm>
+            <a:off x="6858000" y="6309360"/>
+            <a:ext cx="9326880" cy="1234440"/>
+          </a:xfrm>
+          <a:prstGeom prst="rect">
+            <a:avLst/>
+          </a:prstGeom>
+          <a:solidFill>
+            <a:srgbClr val="1E345C"/>
+          </a:solidFill>
+          <a:ln w="3810">
+            <a:solidFill>
+              <a:srgbClr val="C9A84C"/>
+            </a:solidFill>
+          </a:ln>
+        </p:spPr>
+        <p:style>
+          <a:lnRef idx="1">
+            <a:schemeClr val="accent1"/>
+          </a:lnRef>
+          <a:fillRef idx="3">
+            <a:schemeClr val="accent1"/>
+          </a:fillRef>
+          <a:effectRef idx="2">
+            <a:schemeClr val="accent1"/>
+          </a:effectRef>
+          <a:fontRef idx="minor">
+            <a:schemeClr val="lt1"/>
+          </a:fontRef>
+        </p:style>
+        <p:txBody>
+          <a:bodyPr rtlCol="0" anchor="ctr" wrap="square"/>
           <a:lstStyle/>
           <a:p>
             <a:pPr algn="r"/>
@@ -8014,27 +8054,27 @@
                 </a:solidFill>
                 <a:latin typeface="Noto Sans Arabic"/>
               </a:rPr>
-              <a:t>بيانات محلية — لا سحابة خارجية</a:t>
+              <a:t>سجل تدقيق مدمج — كل عملية دخول أو تعديل موثّقة تلقائياً</a:t>
             </a:r>
           </a:p>
         </p:txBody>
       </p:sp>
       <p:sp>
         <p:nvSpPr>
-          <p:cNvPr id="18" name="Rectangle 17"/>
+          <p:cNvPr id="20" name="Rectangle 19"/>
           <p:cNvSpPr/>
           <p:nvPr/>
         </p:nvSpPr>
         <p:spPr>
           <a:xfrm>
-            <a:off x="540000" y="2350800"/>
-            <a:ext cx="8496000" cy="342000"/>
+            <a:off x="16322039" y="6702552"/>
+            <a:ext cx="457200" cy="457200"/>
           </a:xfrm>
           <a:prstGeom prst="rect">
             <a:avLst/>
           </a:prstGeom>
           <a:solidFill>
-            <a:srgbClr val="22355F"/>
+            <a:srgbClr val="2E7D32"/>
           </a:solidFill>
           <a:ln>
             <a:noFill/>
@@ -8055,33 +8095,115 @@
           </a:fontRef>
         </p:style>
         <p:txBody>
-          <a:bodyPr rtlCol="0" anchor="ctr"/>
+          <a:bodyPr rtlCol="0" anchor="ctr" wrap="square"/>
           <a:lstStyle/>
           <a:p>
             <a:pPr algn="ctr"/>
+            <a:r>
+              <a:rPr sz="900" b="1">
+                <a:solidFill>
+                  <a:srgbClr val="FFFFFF"/>
+                </a:solidFill>
+                <a:latin typeface="Noto Sans Arabic"/>
+              </a:rPr>
+              <a:t>OK</a:t>
+            </a:r>
           </a:p>
         </p:txBody>
       </p:sp>
       <p:sp>
         <p:nvSpPr>
-          <p:cNvPr id="19" name="TextBox 18"/>
-          <p:cNvSpPr txBox="1"/>
+          <p:cNvPr id="21" name="Rectangle 20"/>
+          <p:cNvSpPr/>
           <p:nvPr/>
         </p:nvSpPr>
         <p:spPr>
           <a:xfrm>
-            <a:off x="612000" y="2386800"/>
-            <a:ext cx="8352000" cy="306000"/>
+            <a:off x="365760" y="7635240"/>
+            <a:ext cx="6217920" cy="1234440"/>
           </a:xfrm>
           <a:prstGeom prst="rect">
             <a:avLst/>
           </a:prstGeom>
-          <a:noFill/>
+          <a:solidFill>
+            <a:srgbClr val="1A2A4A"/>
+          </a:solidFill>
+          <a:ln w="3810">
+            <a:solidFill>
+              <a:srgbClr val="C9A84C"/>
+            </a:solidFill>
+          </a:ln>
         </p:spPr>
+        <p:style>
+          <a:lnRef idx="1">
+            <a:schemeClr val="accent1"/>
+          </a:lnRef>
+          <a:fillRef idx="3">
+            <a:schemeClr val="accent1"/>
+          </a:fillRef>
+          <a:effectRef idx="2">
+            <a:schemeClr val="accent1"/>
+          </a:effectRef>
+          <a:fontRef idx="minor">
+            <a:schemeClr val="lt1"/>
+          </a:fontRef>
+        </p:style>
         <p:txBody>
-          <a:bodyPr wrap="square">
-            <a:spAutoFit/>
-          </a:bodyPr>
+          <a:bodyPr rtlCol="0" anchor="ctr" wrap="square"/>
+          <a:lstStyle/>
+          <a:p>
+            <a:pPr algn="r"/>
+            <a:r>
+              <a:rPr sz="1400" b="1">
+                <a:solidFill>
+                  <a:srgbClr val="F3E5B8"/>
+                </a:solidFill>
+                <a:latin typeface="Noto Sans Arabic"/>
+              </a:rPr>
+              <a:t>ضبط الصلاحيات</a:t>
+            </a:r>
+          </a:p>
+        </p:txBody>
+      </p:sp>
+      <p:sp>
+        <p:nvSpPr>
+          <p:cNvPr id="22" name="Rectangle 21"/>
+          <p:cNvSpPr/>
+          <p:nvPr/>
+        </p:nvSpPr>
+        <p:spPr>
+          <a:xfrm>
+            <a:off x="6858000" y="7635240"/>
+            <a:ext cx="9326880" cy="1234440"/>
+          </a:xfrm>
+          <a:prstGeom prst="rect">
+            <a:avLst/>
+          </a:prstGeom>
+          <a:solidFill>
+            <a:srgbClr val="1A2A4A"/>
+          </a:solidFill>
+          <a:ln w="3810">
+            <a:solidFill>
+              <a:srgbClr val="C9A84C"/>
+            </a:solidFill>
+          </a:ln>
+        </p:spPr>
+        <p:style>
+          <a:lnRef idx="1">
+            <a:schemeClr val="accent1"/>
+          </a:lnRef>
+          <a:fillRef idx="3">
+            <a:schemeClr val="accent1"/>
+          </a:fillRef>
+          <a:effectRef idx="2">
+            <a:schemeClr val="accent1"/>
+          </a:effectRef>
+          <a:fontRef idx="minor">
+            <a:schemeClr val="lt1"/>
+          </a:fontRef>
+        </p:style>
+        <p:txBody>
+          <a:bodyPr rtlCol="0" anchor="ctr" wrap="square"/>
           <a:lstStyle/>
           <a:p>
             <a:pPr algn="r"/>
@@ -8092,27 +8214,27 @@
                 </a:solidFill>
                 <a:latin typeface="Noto Sans Arabic"/>
               </a:rPr>
-              <a:t>توثيق هوية المستخدمين</a:t>
+              <a:t>صلاحيات CRUD منفصلة لكل دور — Admin يملك التحكم الكامل</a:t>
             </a:r>
           </a:p>
         </p:txBody>
       </p:sp>
       <p:sp>
         <p:nvSpPr>
-          <p:cNvPr id="20" name="Rectangle 19"/>
+          <p:cNvPr id="23" name="Rectangle 22"/>
           <p:cNvSpPr/>
           <p:nvPr/>
         </p:nvSpPr>
         <p:spPr>
           <a:xfrm>
-            <a:off x="9252000" y="2350800"/>
-            <a:ext cx="8496000" cy="342000"/>
+            <a:off x="16322039" y="8028432"/>
+            <a:ext cx="457200" cy="457200"/>
           </a:xfrm>
           <a:prstGeom prst="rect">
             <a:avLst/>
           </a:prstGeom>
           <a:solidFill>
-            <a:srgbClr val="22355F"/>
+            <a:srgbClr val="2E7D32"/>
           </a:solidFill>
           <a:ln>
             <a:noFill/>
@@ -8133,698 +8255,32 @@
           </a:fontRef>
         </p:style>
         <p:txBody>
-          <a:bodyPr rtlCol="0" anchor="ctr"/>
+          <a:bodyPr rtlCol="0" anchor="ctr" wrap="square"/>
           <a:lstStyle/>
           <a:p>
             <a:pPr algn="ctr"/>
-          </a:p>
-        </p:txBody>
-      </p:sp>
-      <p:sp>
-        <p:nvSpPr>
-          <p:cNvPr id="21" name="Rectangle 20"/>
-          <p:cNvSpPr/>
-          <p:nvPr/>
-        </p:nvSpPr>
-        <p:spPr>
-          <a:xfrm>
-            <a:off x="17424000" y="2422800"/>
-            <a:ext cx="198000" cy="198000"/>
-          </a:xfrm>
-          <a:prstGeom prst="rect">
-            <a:avLst/>
-          </a:prstGeom>
-          <a:solidFill>
-            <a:srgbClr val="4CC97A"/>
-          </a:solidFill>
-          <a:ln>
-            <a:noFill/>
-          </a:ln>
-        </p:spPr>
-        <p:style>
-          <a:lnRef idx="1">
-            <a:schemeClr val="accent1"/>
-          </a:lnRef>
-          <a:fillRef idx="3">
-            <a:schemeClr val="accent1"/>
-          </a:fillRef>
-          <a:effectRef idx="2">
-            <a:schemeClr val="accent1"/>
-          </a:effectRef>
-          <a:fontRef idx="minor">
-            <a:schemeClr val="lt1"/>
-          </a:fontRef>
-        </p:style>
-        <p:txBody>
-          <a:bodyPr rtlCol="0" anchor="ctr"/>
-          <a:lstStyle/>
-          <a:p>
-            <a:pPr algn="ctr"/>
-          </a:p>
-        </p:txBody>
-      </p:sp>
-      <p:sp>
-        <p:nvSpPr>
-          <p:cNvPr id="22" name="TextBox 21"/>
-          <p:cNvSpPr txBox="1"/>
-          <p:nvPr/>
-        </p:nvSpPr>
-        <p:spPr>
-          <a:xfrm>
-            <a:off x="9324000" y="2386800"/>
-            <a:ext cx="8064000" cy="306000"/>
-          </a:xfrm>
-          <a:prstGeom prst="rect">
-            <a:avLst/>
-          </a:prstGeom>
-          <a:noFill/>
-        </p:spPr>
-        <p:txBody>
-          <a:bodyPr wrap="square">
-            <a:spAutoFit/>
-          </a:bodyPr>
-          <a:lstStyle/>
-          <a:p>
-            <a:pPr algn="r"/>
-            <a:r>
-              <a:rPr sz="1200" b="0">
+            <a:r>
+              <a:rPr sz="900" b="1">
                 <a:solidFill>
                   <a:srgbClr val="FFFFFF"/>
                 </a:solidFill>
                 <a:latin typeface="Noto Sans Arabic"/>
               </a:rPr>
-              <a:t>نظام تسجيل دخول بـ 5 مستويات</a:t>
+              <a:t>OK</a:t>
             </a:r>
           </a:p>
         </p:txBody>
       </p:sp>
       <p:sp>
         <p:nvSpPr>
-          <p:cNvPr id="23" name="Rectangle 22"/>
+          <p:cNvPr id="24" name="Rectangle 23"/>
           <p:cNvSpPr/>
           <p:nvPr/>
         </p:nvSpPr>
         <p:spPr>
           <a:xfrm>
-            <a:off x="540000" y="2757600"/>
-            <a:ext cx="8496000" cy="342000"/>
-          </a:xfrm>
-          <a:prstGeom prst="rect">
-            <a:avLst/>
-          </a:prstGeom>
-          <a:solidFill>
-            <a:srgbClr val="1E3055"/>
-          </a:solidFill>
-          <a:ln>
-            <a:noFill/>
-          </a:ln>
-        </p:spPr>
-        <p:style>
-          <a:lnRef idx="1">
-            <a:schemeClr val="accent1"/>
-          </a:lnRef>
-          <a:fillRef idx="3">
-            <a:schemeClr val="accent1"/>
-          </a:fillRef>
-          <a:effectRef idx="2">
-            <a:schemeClr val="accent1"/>
-          </a:effectRef>
-          <a:fontRef idx="minor">
-            <a:schemeClr val="lt1"/>
-          </a:fontRef>
-        </p:style>
-        <p:txBody>
-          <a:bodyPr rtlCol="0" anchor="ctr"/>
-          <a:lstStyle/>
-          <a:p>
-            <a:pPr algn="ctr"/>
-          </a:p>
-        </p:txBody>
-      </p:sp>
-      <p:sp>
-        <p:nvSpPr>
-          <p:cNvPr id="24" name="TextBox 23"/>
-          <p:cNvSpPr txBox="1"/>
-          <p:nvPr/>
-        </p:nvSpPr>
-        <p:spPr>
-          <a:xfrm>
-            <a:off x="612000" y="2793600"/>
-            <a:ext cx="8352000" cy="306000"/>
-          </a:xfrm>
-          <a:prstGeom prst="rect">
-            <a:avLst/>
-          </a:prstGeom>
-          <a:noFill/>
-        </p:spPr>
-        <p:txBody>
-          <a:bodyPr wrap="square">
-            <a:spAutoFit/>
-          </a:bodyPr>
-          <a:lstStyle/>
-          <a:p>
-            <a:pPr algn="r"/>
-            <a:r>
-              <a:rPr sz="1200" b="0">
-                <a:solidFill>
-                  <a:srgbClr val="FFFFFF"/>
-                </a:solidFill>
-                <a:latin typeface="Noto Sans Arabic"/>
-              </a:rPr>
-              <a:t>رقابة أولياء الأمور</a:t>
-            </a:r>
-          </a:p>
-        </p:txBody>
-      </p:sp>
-      <p:sp>
-        <p:nvSpPr>
-          <p:cNvPr id="25" name="Rectangle 24"/>
-          <p:cNvSpPr/>
-          <p:nvPr/>
-        </p:nvSpPr>
-        <p:spPr>
-          <a:xfrm>
-            <a:off x="9252000" y="2757600"/>
-            <a:ext cx="8496000" cy="342000"/>
-          </a:xfrm>
-          <a:prstGeom prst="rect">
-            <a:avLst/>
-          </a:prstGeom>
-          <a:solidFill>
-            <a:srgbClr val="1E3055"/>
-          </a:solidFill>
-          <a:ln>
-            <a:noFill/>
-          </a:ln>
-        </p:spPr>
-        <p:style>
-          <a:lnRef idx="1">
-            <a:schemeClr val="accent1"/>
-          </a:lnRef>
-          <a:fillRef idx="3">
-            <a:schemeClr val="accent1"/>
-          </a:fillRef>
-          <a:effectRef idx="2">
-            <a:schemeClr val="accent1"/>
-          </a:effectRef>
-          <a:fontRef idx="minor">
-            <a:schemeClr val="lt1"/>
-          </a:fontRef>
-        </p:style>
-        <p:txBody>
-          <a:bodyPr rtlCol="0" anchor="ctr"/>
-          <a:lstStyle/>
-          <a:p>
-            <a:pPr algn="ctr"/>
-          </a:p>
-        </p:txBody>
-      </p:sp>
-      <p:sp>
-        <p:nvSpPr>
-          <p:cNvPr id="26" name="Rectangle 25"/>
-          <p:cNvSpPr/>
-          <p:nvPr/>
-        </p:nvSpPr>
-        <p:spPr>
-          <a:xfrm>
-            <a:off x="17424000" y="2829600"/>
-            <a:ext cx="198000" cy="198000"/>
-          </a:xfrm>
-          <a:prstGeom prst="rect">
-            <a:avLst/>
-          </a:prstGeom>
-          <a:solidFill>
-            <a:srgbClr val="4CC97A"/>
-          </a:solidFill>
-          <a:ln>
-            <a:noFill/>
-          </a:ln>
-        </p:spPr>
-        <p:style>
-          <a:lnRef idx="1">
-            <a:schemeClr val="accent1"/>
-          </a:lnRef>
-          <a:fillRef idx="3">
-            <a:schemeClr val="accent1"/>
-          </a:fillRef>
-          <a:effectRef idx="2">
-            <a:schemeClr val="accent1"/>
-          </a:effectRef>
-          <a:fontRef idx="minor">
-            <a:schemeClr val="lt1"/>
-          </a:fontRef>
-        </p:style>
-        <p:txBody>
-          <a:bodyPr rtlCol="0" anchor="ctr"/>
-          <a:lstStyle/>
-          <a:p>
-            <a:pPr algn="ctr"/>
-          </a:p>
-        </p:txBody>
-      </p:sp>
-      <p:sp>
-        <p:nvSpPr>
-          <p:cNvPr id="27" name="TextBox 26"/>
-          <p:cNvSpPr txBox="1"/>
-          <p:nvPr/>
-        </p:nvSpPr>
-        <p:spPr>
-          <a:xfrm>
-            <a:off x="9324000" y="2793600"/>
-            <a:ext cx="8064000" cy="306000"/>
-          </a:xfrm>
-          <a:prstGeom prst="rect">
-            <a:avLst/>
-          </a:prstGeom>
-          <a:noFill/>
-        </p:spPr>
-        <p:txBody>
-          <a:bodyPr wrap="square">
-            <a:spAutoFit/>
-          </a:bodyPr>
-          <a:lstStyle/>
-          <a:p>
-            <a:pPr algn="r"/>
-            <a:r>
-              <a:rPr sz="1200" b="0">
-                <a:solidFill>
-                  <a:srgbClr val="FFFFFF"/>
-                </a:solidFill>
-                <a:latin typeface="Noto Sans Arabic"/>
-              </a:rPr>
-              <a:t>بوابة ولي الأمر — قريباً</a:t>
-            </a:r>
-          </a:p>
-        </p:txBody>
-      </p:sp>
-      <p:sp>
-        <p:nvSpPr>
-          <p:cNvPr id="28" name="Rectangle 27"/>
-          <p:cNvSpPr/>
-          <p:nvPr/>
-        </p:nvSpPr>
-        <p:spPr>
-          <a:xfrm>
-            <a:off x="540000" y="3164400"/>
-            <a:ext cx="8496000" cy="342000"/>
-          </a:xfrm>
-          <a:prstGeom prst="rect">
-            <a:avLst/>
-          </a:prstGeom>
-          <a:solidFill>
-            <a:srgbClr val="22355F"/>
-          </a:solidFill>
-          <a:ln>
-            <a:noFill/>
-          </a:ln>
-        </p:spPr>
-        <p:style>
-          <a:lnRef idx="1">
-            <a:schemeClr val="accent1"/>
-          </a:lnRef>
-          <a:fillRef idx="3">
-            <a:schemeClr val="accent1"/>
-          </a:fillRef>
-          <a:effectRef idx="2">
-            <a:schemeClr val="accent1"/>
-          </a:effectRef>
-          <a:fontRef idx="minor">
-            <a:schemeClr val="lt1"/>
-          </a:fontRef>
-        </p:style>
-        <p:txBody>
-          <a:bodyPr rtlCol="0" anchor="ctr"/>
-          <a:lstStyle/>
-          <a:p>
-            <a:pPr algn="ctr"/>
-          </a:p>
-        </p:txBody>
-      </p:sp>
-      <p:sp>
-        <p:nvSpPr>
-          <p:cNvPr id="29" name="TextBox 28"/>
-          <p:cNvSpPr txBox="1"/>
-          <p:nvPr/>
-        </p:nvSpPr>
-        <p:spPr>
-          <a:xfrm>
-            <a:off x="612000" y="3200400"/>
-            <a:ext cx="8352000" cy="306000"/>
-          </a:xfrm>
-          <a:prstGeom prst="rect">
-            <a:avLst/>
-          </a:prstGeom>
-          <a:noFill/>
-        </p:spPr>
-        <p:txBody>
-          <a:bodyPr wrap="square">
-            <a:spAutoFit/>
-          </a:bodyPr>
-          <a:lstStyle/>
-          <a:p>
-            <a:pPr algn="r"/>
-            <a:r>
-              <a:rPr sz="1200" b="0">
-                <a:solidFill>
-                  <a:srgbClr val="FFFFFF"/>
-                </a:solidFill>
-                <a:latin typeface="Noto Sans Arabic"/>
-              </a:rPr>
-              <a:t>الإبلاغ عن الاختراقات</a:t>
-            </a:r>
-          </a:p>
-        </p:txBody>
-      </p:sp>
-      <p:sp>
-        <p:nvSpPr>
-          <p:cNvPr id="30" name="Rectangle 29"/>
-          <p:cNvSpPr/>
-          <p:nvPr/>
-        </p:nvSpPr>
-        <p:spPr>
-          <a:xfrm>
-            <a:off x="9252000" y="3164400"/>
-            <a:ext cx="8496000" cy="342000"/>
-          </a:xfrm>
-          <a:prstGeom prst="rect">
-            <a:avLst/>
-          </a:prstGeom>
-          <a:solidFill>
-            <a:srgbClr val="22355F"/>
-          </a:solidFill>
-          <a:ln>
-            <a:noFill/>
-          </a:ln>
-        </p:spPr>
-        <p:style>
-          <a:lnRef idx="1">
-            <a:schemeClr val="accent1"/>
-          </a:lnRef>
-          <a:fillRef idx="3">
-            <a:schemeClr val="accent1"/>
-          </a:fillRef>
-          <a:effectRef idx="2">
-            <a:schemeClr val="accent1"/>
-          </a:effectRef>
-          <a:fontRef idx="minor">
-            <a:schemeClr val="lt1"/>
-          </a:fontRef>
-        </p:style>
-        <p:txBody>
-          <a:bodyPr rtlCol="0" anchor="ctr"/>
-          <a:lstStyle/>
-          <a:p>
-            <a:pPr algn="ctr"/>
-          </a:p>
-        </p:txBody>
-      </p:sp>
-      <p:sp>
-        <p:nvSpPr>
-          <p:cNvPr id="31" name="Rectangle 30"/>
-          <p:cNvSpPr/>
-          <p:nvPr/>
-        </p:nvSpPr>
-        <p:spPr>
-          <a:xfrm>
-            <a:off x="17424000" y="3236400"/>
-            <a:ext cx="198000" cy="198000"/>
-          </a:xfrm>
-          <a:prstGeom prst="rect">
-            <a:avLst/>
-          </a:prstGeom>
-          <a:solidFill>
-            <a:srgbClr val="4CC97A"/>
-          </a:solidFill>
-          <a:ln>
-            <a:noFill/>
-          </a:ln>
-        </p:spPr>
-        <p:style>
-          <a:lnRef idx="1">
-            <a:schemeClr val="accent1"/>
-          </a:lnRef>
-          <a:fillRef idx="3">
-            <a:schemeClr val="accent1"/>
-          </a:fillRef>
-          <a:effectRef idx="2">
-            <a:schemeClr val="accent1"/>
-          </a:effectRef>
-          <a:fontRef idx="minor">
-            <a:schemeClr val="lt1"/>
-          </a:fontRef>
-        </p:style>
-        <p:txBody>
-          <a:bodyPr rtlCol="0" anchor="ctr"/>
-          <a:lstStyle/>
-          <a:p>
-            <a:pPr algn="ctr"/>
-          </a:p>
-        </p:txBody>
-      </p:sp>
-      <p:sp>
-        <p:nvSpPr>
-          <p:cNvPr id="32" name="TextBox 31"/>
-          <p:cNvSpPr txBox="1"/>
-          <p:nvPr/>
-        </p:nvSpPr>
-        <p:spPr>
-          <a:xfrm>
-            <a:off x="9324000" y="3200400"/>
-            <a:ext cx="8064000" cy="306000"/>
-          </a:xfrm>
-          <a:prstGeom prst="rect">
-            <a:avLst/>
-          </a:prstGeom>
-          <a:noFill/>
-        </p:spPr>
-        <p:txBody>
-          <a:bodyPr wrap="square">
-            <a:spAutoFit/>
-          </a:bodyPr>
-          <a:lstStyle/>
-          <a:p>
-            <a:pPr algn="r"/>
-            <a:r>
-              <a:rPr sz="1200" b="0">
-                <a:solidFill>
-                  <a:srgbClr val="FFFFFF"/>
-                </a:solidFill>
-                <a:latin typeface="Noto Sans Arabic"/>
-              </a:rPr>
-              <a:t>سجل تدقيق مدمج</a:t>
-            </a:r>
-          </a:p>
-        </p:txBody>
-      </p:sp>
-      <p:sp>
-        <p:nvSpPr>
-          <p:cNvPr id="33" name="Rectangle 32"/>
-          <p:cNvSpPr/>
-          <p:nvPr/>
-        </p:nvSpPr>
-        <p:spPr>
-          <a:xfrm>
-            <a:off x="540000" y="3571200"/>
-            <a:ext cx="8496000" cy="342000"/>
-          </a:xfrm>
-          <a:prstGeom prst="rect">
-            <a:avLst/>
-          </a:prstGeom>
-          <a:solidFill>
-            <a:srgbClr val="1E3055"/>
-          </a:solidFill>
-          <a:ln>
-            <a:noFill/>
-          </a:ln>
-        </p:spPr>
-        <p:style>
-          <a:lnRef idx="1">
-            <a:schemeClr val="accent1"/>
-          </a:lnRef>
-          <a:fillRef idx="3">
-            <a:schemeClr val="accent1"/>
-          </a:fillRef>
-          <a:effectRef idx="2">
-            <a:schemeClr val="accent1"/>
-          </a:effectRef>
-          <a:fontRef idx="minor">
-            <a:schemeClr val="lt1"/>
-          </a:fontRef>
-        </p:style>
-        <p:txBody>
-          <a:bodyPr rtlCol="0" anchor="ctr"/>
-          <a:lstStyle/>
-          <a:p>
-            <a:pPr algn="ctr"/>
-          </a:p>
-        </p:txBody>
-      </p:sp>
-      <p:sp>
-        <p:nvSpPr>
-          <p:cNvPr id="34" name="TextBox 33"/>
-          <p:cNvSpPr txBox="1"/>
-          <p:nvPr/>
-        </p:nvSpPr>
-        <p:spPr>
-          <a:xfrm>
-            <a:off x="612000" y="3607200"/>
-            <a:ext cx="8352000" cy="306000"/>
-          </a:xfrm>
-          <a:prstGeom prst="rect">
-            <a:avLst/>
-          </a:prstGeom>
-          <a:noFill/>
-        </p:spPr>
-        <p:txBody>
-          <a:bodyPr wrap="square">
-            <a:spAutoFit/>
-          </a:bodyPr>
-          <a:lstStyle/>
-          <a:p>
-            <a:pPr algn="r"/>
-            <a:r>
-              <a:rPr sz="1200" b="0">
-                <a:solidFill>
-                  <a:srgbClr val="FFFFFF"/>
-                </a:solidFill>
-                <a:latin typeface="Noto Sans Arabic"/>
-              </a:rPr>
-              <a:t>ضبط صلاحيات الوصول</a:t>
-            </a:r>
-          </a:p>
-        </p:txBody>
-      </p:sp>
-      <p:sp>
-        <p:nvSpPr>
-          <p:cNvPr id="35" name="Rectangle 34"/>
-          <p:cNvSpPr/>
-          <p:nvPr/>
-        </p:nvSpPr>
-        <p:spPr>
-          <a:xfrm>
-            <a:off x="9252000" y="3571200"/>
-            <a:ext cx="8496000" cy="342000"/>
-          </a:xfrm>
-          <a:prstGeom prst="rect">
-            <a:avLst/>
-          </a:prstGeom>
-          <a:solidFill>
-            <a:srgbClr val="1E3055"/>
-          </a:solidFill>
-          <a:ln>
-            <a:noFill/>
-          </a:ln>
-        </p:spPr>
-        <p:style>
-          <a:lnRef idx="1">
-            <a:schemeClr val="accent1"/>
-          </a:lnRef>
-          <a:fillRef idx="3">
-            <a:schemeClr val="accent1"/>
-          </a:fillRef>
-          <a:effectRef idx="2">
-            <a:schemeClr val="accent1"/>
-          </a:effectRef>
-          <a:fontRef idx="minor">
-            <a:schemeClr val="lt1"/>
-          </a:fontRef>
-        </p:style>
-        <p:txBody>
-          <a:bodyPr rtlCol="0" anchor="ctr"/>
-          <a:lstStyle/>
-          <a:p>
-            <a:pPr algn="ctr"/>
-          </a:p>
-        </p:txBody>
-      </p:sp>
-      <p:sp>
-        <p:nvSpPr>
-          <p:cNvPr id="36" name="Rectangle 35"/>
-          <p:cNvSpPr/>
-          <p:nvPr/>
-        </p:nvSpPr>
-        <p:spPr>
-          <a:xfrm>
-            <a:off x="17424000" y="3643200"/>
-            <a:ext cx="198000" cy="198000"/>
-          </a:xfrm>
-          <a:prstGeom prst="rect">
-            <a:avLst/>
-          </a:prstGeom>
-          <a:solidFill>
-            <a:srgbClr val="4CC97A"/>
-          </a:solidFill>
-          <a:ln>
-            <a:noFill/>
-          </a:ln>
-        </p:spPr>
-        <p:style>
-          <a:lnRef idx="1">
-            <a:schemeClr val="accent1"/>
-          </a:lnRef>
-          <a:fillRef idx="3">
-            <a:schemeClr val="accent1"/>
-          </a:fillRef>
-          <a:effectRef idx="2">
-            <a:schemeClr val="accent1"/>
-          </a:effectRef>
-          <a:fontRef idx="minor">
-            <a:schemeClr val="lt1"/>
-          </a:fontRef>
-        </p:style>
-        <p:txBody>
-          <a:bodyPr rtlCol="0" anchor="ctr"/>
-          <a:lstStyle/>
-          <a:p>
-            <a:pPr algn="ctr"/>
-          </a:p>
-        </p:txBody>
-      </p:sp>
-      <p:sp>
-        <p:nvSpPr>
-          <p:cNvPr id="37" name="TextBox 36"/>
-          <p:cNvSpPr txBox="1"/>
-          <p:nvPr/>
-        </p:nvSpPr>
-        <p:spPr>
-          <a:xfrm>
-            <a:off x="9324000" y="3607200"/>
-            <a:ext cx="8064000" cy="306000"/>
-          </a:xfrm>
-          <a:prstGeom prst="rect">
-            <a:avLst/>
-          </a:prstGeom>
-          <a:noFill/>
-        </p:spPr>
-        <p:txBody>
-          <a:bodyPr wrap="square">
-            <a:spAutoFit/>
-          </a:bodyPr>
-          <a:lstStyle/>
-          <a:p>
-            <a:pPr algn="r"/>
-            <a:r>
-              <a:rPr sz="1200" b="0">
-                <a:solidFill>
-                  <a:srgbClr val="FFFFFF"/>
-                </a:solidFill>
-                <a:latin typeface="Noto Sans Arabic"/>
-              </a:rPr>
-              <a:t>صلاحيات CRUD منفصلة لكل دور</a:t>
-            </a:r>
-          </a:p>
-        </p:txBody>
-      </p:sp>
-      <p:sp>
-        <p:nvSpPr>
-          <p:cNvPr id="38" name="Rectangle 37"/>
-          <p:cNvSpPr/>
-          <p:nvPr/>
-        </p:nvSpPr>
-        <p:spPr>
-          <a:xfrm>
-            <a:off x="648000" y="4122000"/>
-            <a:ext cx="5604000" cy="396000"/>
+            <a:off x="914400" y="9098280"/>
+            <a:ext cx="5334000" cy="1005840"/>
           </a:xfrm>
           <a:prstGeom prst="rect">
             <a:avLst/>
@@ -8851,38 +8307,12 @@
           </a:fontRef>
         </p:style>
         <p:txBody>
-          <a:bodyPr rtlCol="0" anchor="ctr"/>
+          <a:bodyPr rtlCol="0" anchor="ctr" wrap="square"/>
           <a:lstStyle/>
           <a:p>
             <a:pPr algn="ctr"/>
-          </a:p>
-        </p:txBody>
-      </p:sp>
-      <p:sp>
-        <p:nvSpPr>
-          <p:cNvPr id="39" name="TextBox 38"/>
-          <p:cNvSpPr txBox="1"/>
-          <p:nvPr/>
-        </p:nvSpPr>
-        <p:spPr>
-          <a:xfrm>
-            <a:off x="648000" y="4122000"/>
-            <a:ext cx="5604000" cy="216000"/>
-          </a:xfrm>
-          <a:prstGeom prst="rect">
-            <a:avLst/>
-          </a:prstGeom>
-          <a:noFill/>
-        </p:spPr>
-        <p:txBody>
-          <a:bodyPr wrap="square">
-            <a:spAutoFit/>
-          </a:bodyPr>
-          <a:lstStyle/>
-          <a:p>
-            <a:pPr algn="ctr"/>
-            <a:r>
-              <a:rPr sz="1600" b="1">
+            <a:r>
+              <a:rPr sz="2600" b="1">
                 <a:solidFill>
                   <a:srgbClr val="1A2A4A"/>
                 </a:solidFill>
@@ -8891,53 +8321,30 @@
               <a:t>5</a:t>
             </a:r>
           </a:p>
-        </p:txBody>
-      </p:sp>
-      <p:sp>
-        <p:nvSpPr>
-          <p:cNvPr id="40" name="TextBox 39"/>
-          <p:cNvSpPr txBox="1"/>
-          <p:nvPr/>
-        </p:nvSpPr>
-        <p:spPr>
-          <a:xfrm>
-            <a:off x="648000" y="4320000"/>
-            <a:ext cx="5604000" cy="180000"/>
-          </a:xfrm>
-          <a:prstGeom prst="rect">
-            <a:avLst/>
-          </a:prstGeom>
-          <a:noFill/>
-        </p:spPr>
-        <p:txBody>
-          <a:bodyPr wrap="square">
-            <a:spAutoFit/>
-          </a:bodyPr>
-          <a:lstStyle/>
           <a:p>
             <a:pPr algn="ctr"/>
             <a:r>
-              <a:rPr sz="1000" b="0">
+              <a:rPr sz="1300" b="0">
                 <a:solidFill>
                   <a:srgbClr val="1A2A4A"/>
                 </a:solidFill>
                 <a:latin typeface="Noto Sans Arabic"/>
               </a:rPr>
-              <a:t>مستويات وصول</a:t>
+              <a:t>مستويات الوصول</a:t>
             </a:r>
           </a:p>
         </p:txBody>
       </p:sp>
       <p:sp>
         <p:nvSpPr>
-          <p:cNvPr id="41" name="Rectangle 40"/>
+          <p:cNvPr id="25" name="Rectangle 24"/>
           <p:cNvSpPr/>
           <p:nvPr/>
         </p:nvSpPr>
         <p:spPr>
           <a:xfrm>
-            <a:off x="6324000" y="4122000"/>
-            <a:ext cx="5604000" cy="396000"/>
+            <a:off x="6477000" y="9098280"/>
+            <a:ext cx="5334000" cy="1005840"/>
           </a:xfrm>
           <a:prstGeom prst="rect">
             <a:avLst/>
@@ -8964,38 +8371,12 @@
           </a:fontRef>
         </p:style>
         <p:txBody>
-          <a:bodyPr rtlCol="0" anchor="ctr"/>
+          <a:bodyPr rtlCol="0" anchor="ctr" wrap="square"/>
           <a:lstStyle/>
           <a:p>
             <a:pPr algn="ctr"/>
-          </a:p>
-        </p:txBody>
-      </p:sp>
-      <p:sp>
-        <p:nvSpPr>
-          <p:cNvPr id="42" name="TextBox 41"/>
-          <p:cNvSpPr txBox="1"/>
-          <p:nvPr/>
-        </p:nvSpPr>
-        <p:spPr>
-          <a:xfrm>
-            <a:off x="6324000" y="4122000"/>
-            <a:ext cx="5604000" cy="216000"/>
-          </a:xfrm>
-          <a:prstGeom prst="rect">
-            <a:avLst/>
-          </a:prstGeom>
-          <a:noFill/>
-        </p:spPr>
-        <p:txBody>
-          <a:bodyPr wrap="square">
-            <a:spAutoFit/>
-          </a:bodyPr>
-          <a:lstStyle/>
-          <a:p>
-            <a:pPr algn="ctr"/>
-            <a:r>
-              <a:rPr sz="1600" b="1">
+            <a:r>
+              <a:rPr sz="2600" b="1">
                 <a:solidFill>
                   <a:srgbClr val="1A2A4A"/>
                 </a:solidFill>
@@ -9004,33 +8385,10 @@
               <a:t>100%</a:t>
             </a:r>
           </a:p>
-        </p:txBody>
-      </p:sp>
-      <p:sp>
-        <p:nvSpPr>
-          <p:cNvPr id="43" name="TextBox 42"/>
-          <p:cNvSpPr txBox="1"/>
-          <p:nvPr/>
-        </p:nvSpPr>
-        <p:spPr>
-          <a:xfrm>
-            <a:off x="6324000" y="4320000"/>
-            <a:ext cx="5604000" cy="180000"/>
-          </a:xfrm>
-          <a:prstGeom prst="rect">
-            <a:avLst/>
-          </a:prstGeom>
-          <a:noFill/>
-        </p:spPr>
-        <p:txBody>
-          <a:bodyPr wrap="square">
-            <a:spAutoFit/>
-          </a:bodyPr>
-          <a:lstStyle/>
           <a:p>
             <a:pPr algn="ctr"/>
             <a:r>
-              <a:rPr sz="1000" b="0">
+              <a:rPr sz="1300" b="0">
                 <a:solidFill>
                   <a:srgbClr val="1A2A4A"/>
                 </a:solidFill>
@@ -9043,14 +8401,14 @@
       </p:sp>
       <p:sp>
         <p:nvSpPr>
-          <p:cNvPr id="44" name="Rectangle 43"/>
+          <p:cNvPr id="26" name="Rectangle 25"/>
           <p:cNvSpPr/>
           <p:nvPr/>
         </p:nvSpPr>
         <p:spPr>
           <a:xfrm>
-            <a:off x="12000000" y="4122000"/>
-            <a:ext cx="5604000" cy="396000"/>
+            <a:off x="12039600" y="9098280"/>
+            <a:ext cx="5334000" cy="1005840"/>
           </a:xfrm>
           <a:prstGeom prst="rect">
             <a:avLst/>
@@ -9077,38 +8435,12 @@
           </a:fontRef>
         </p:style>
         <p:txBody>
-          <a:bodyPr rtlCol="0" anchor="ctr"/>
+          <a:bodyPr rtlCol="0" anchor="ctr" wrap="square"/>
           <a:lstStyle/>
           <a:p>
             <a:pPr algn="ctr"/>
-          </a:p>
-        </p:txBody>
-      </p:sp>
-      <p:sp>
-        <p:nvSpPr>
-          <p:cNvPr id="45" name="TextBox 44"/>
-          <p:cNvSpPr txBox="1"/>
-          <p:nvPr/>
-        </p:nvSpPr>
-        <p:spPr>
-          <a:xfrm>
-            <a:off x="12000000" y="4122000"/>
-            <a:ext cx="5604000" cy="216000"/>
-          </a:xfrm>
-          <a:prstGeom prst="rect">
-            <a:avLst/>
-          </a:prstGeom>
-          <a:noFill/>
-        </p:spPr>
-        <p:txBody>
-          <a:bodyPr wrap="square">
-            <a:spAutoFit/>
-          </a:bodyPr>
-          <a:lstStyle/>
-          <a:p>
-            <a:pPr algn="ctr"/>
-            <a:r>
-              <a:rPr sz="1600" b="1">
+            <a:r>
+              <a:rPr sz="2600" b="1">
                 <a:solidFill>
                   <a:srgbClr val="1A2A4A"/>
                 </a:solidFill>
@@ -9117,33 +8449,10 @@
               <a:t>متوافق</a:t>
             </a:r>
           </a:p>
-        </p:txBody>
-      </p:sp>
-      <p:sp>
-        <p:nvSpPr>
-          <p:cNvPr id="46" name="TextBox 45"/>
-          <p:cNvSpPr txBox="1"/>
-          <p:nvPr/>
-        </p:nvSpPr>
-        <p:spPr>
-          <a:xfrm>
-            <a:off x="12000000" y="4320000"/>
-            <a:ext cx="5604000" cy="180000"/>
-          </a:xfrm>
-          <a:prstGeom prst="rect">
-            <a:avLst/>
-          </a:prstGeom>
-          <a:noFill/>
-        </p:spPr>
-        <p:txBody>
-          <a:bodyPr wrap="square">
-            <a:spAutoFit/>
-          </a:bodyPr>
-          <a:lstStyle/>
           <a:p>
             <a:pPr algn="ctr"/>
             <a:r>
-              <a:rPr sz="1000" b="0">
+              <a:rPr sz="1300" b="0">
                 <a:solidFill>
                   <a:srgbClr val="1A2A4A"/>
                 </a:solidFill>

</xml_diff>

<commit_message>
fix: v5 - redesign slides 3&4 layout + elevator pitch cover title updated
</commit_message>
<xml_diff>
--- a/assets/aljood_pitch_with_law.pptx
+++ b/assets/aljood_pitch_with_law.pptx
@@ -5733,209 +5733,22 @@
           <a:chExt cx="0" cy="0"/>
         </a:xfrm>
       </p:grpSpPr>
-      <p:grpSp>
-        <p:nvGrpSpPr>
-          <p:cNvPr name="Group 2" id="2"/>
-          <p:cNvGrpSpPr/>
-          <p:nvPr/>
-        </p:nvGrpSpPr>
-        <p:grpSpPr>
-          <a:xfrm rot="0">
-            <a:off x="666750" y="666750"/>
-            <a:ext cx="16954500" cy="8953500"/>
-            <a:chOff x="0" y="0"/>
-            <a:chExt cx="5734099" cy="3028120"/>
-          </a:xfrm>
-        </p:grpSpPr>
-        <p:sp>
-          <p:nvSpPr>
-            <p:cNvPr name="Freeform 3" id="3"/>
-            <p:cNvSpPr/>
-            <p:nvPr/>
-          </p:nvSpPr>
-          <p:spPr>
-            <a:xfrm flipH="false" flipV="false" rot="0">
-              <a:off x="52070" y="12700"/>
-              <a:ext cx="5669329" cy="2959540"/>
-            </a:xfrm>
-            <a:custGeom>
-              <a:avLst/>
-              <a:gdLst/>
-              <a:ahLst/>
-              <a:cxnLst/>
-              <a:rect r="r" b="b" t="t" l="l"/>
-              <a:pathLst>
-                <a:path h="2959540" w="5669329">
-                  <a:moveTo>
-                    <a:pt x="5523279" y="2959540"/>
-                  </a:moveTo>
-                  <a:lnTo>
-                    <a:pt x="164850" y="2959540"/>
-                  </a:lnTo>
-                  <a:cubicBezTo>
-                    <a:pt x="66040" y="2959540"/>
-                    <a:pt x="0" y="2893500"/>
-                    <a:pt x="0" y="2813490"/>
-                  </a:cubicBezTo>
-                  <a:lnTo>
-                    <a:pt x="0" y="146050"/>
-                  </a:lnTo>
-                  <a:cubicBezTo>
-                    <a:pt x="0" y="66040"/>
-                    <a:pt x="66040" y="0"/>
-                    <a:pt x="164850" y="0"/>
-                  </a:cubicBezTo>
-                  <a:lnTo>
-                    <a:pt x="5523279" y="0"/>
-                  </a:lnTo>
-                  <a:cubicBezTo>
-                    <a:pt x="5603289" y="0"/>
-                    <a:pt x="5669329" y="66040"/>
-                    <a:pt x="5669329" y="146050"/>
-                  </a:cubicBezTo>
-                  <a:lnTo>
-                    <a:pt x="5669329" y="2813490"/>
-                  </a:lnTo>
-                  <a:cubicBezTo>
-                    <a:pt x="5669329" y="2894770"/>
-                    <a:pt x="5603289" y="2959540"/>
-                    <a:pt x="5523279" y="2959540"/>
-                  </a:cubicBezTo>
-                  <a:close/>
-                </a:path>
-              </a:pathLst>
-            </a:custGeom>
-            <a:solidFill>
-              <a:srgbClr val="021633"/>
-            </a:solidFill>
-          </p:spPr>
-        </p:sp>
-        <p:sp>
-          <p:nvSpPr>
-            <p:cNvPr name="Freeform 4" id="4"/>
-            <p:cNvSpPr/>
-            <p:nvPr/>
-          </p:nvSpPr>
-          <p:spPr>
-            <a:xfrm flipH="false" flipV="false" rot="0">
-              <a:off x="0" y="0"/>
-              <a:ext cx="5734099" cy="3028120"/>
-            </a:xfrm>
-            <a:custGeom>
-              <a:avLst/>
-              <a:gdLst/>
-              <a:ahLst/>
-              <a:cxnLst/>
-              <a:rect r="r" b="b" t="t" l="l"/>
-              <a:pathLst>
-                <a:path h="3028120" w="5734099">
-                  <a:moveTo>
-                    <a:pt x="63500" y="74930"/>
-                  </a:moveTo>
-                  <a:cubicBezTo>
-                    <a:pt x="91440" y="30480"/>
-                    <a:pt x="140970" y="0"/>
-                    <a:pt x="216920" y="0"/>
-                  </a:cubicBezTo>
-                  <a:lnTo>
-                    <a:pt x="5575349" y="0"/>
-                  </a:lnTo>
-                  <a:cubicBezTo>
-                    <a:pt x="5662979" y="0"/>
-                    <a:pt x="5734099" y="71120"/>
-                    <a:pt x="5734099" y="158750"/>
-                  </a:cubicBezTo>
-                  <a:lnTo>
-                    <a:pt x="5734099" y="2826190"/>
-                  </a:lnTo>
-                  <a:cubicBezTo>
-                    <a:pt x="5734099" y="2878260"/>
-                    <a:pt x="5708699" y="2923980"/>
-                    <a:pt x="5670599" y="2953190"/>
-                  </a:cubicBezTo>
-                  <a:cubicBezTo>
-                    <a:pt x="5642659" y="2997640"/>
-                    <a:pt x="5593129" y="3028120"/>
-                    <a:pt x="5535979" y="3028120"/>
-                  </a:cubicBezTo>
-                  <a:lnTo>
-                    <a:pt x="158750" y="3028120"/>
-                  </a:lnTo>
-                  <a:cubicBezTo>
-                    <a:pt x="71120" y="3028120"/>
-                    <a:pt x="0" y="2957000"/>
-                    <a:pt x="0" y="2869370"/>
-                  </a:cubicBezTo>
-                  <a:lnTo>
-                    <a:pt x="0" y="208926"/>
-                  </a:lnTo>
-                  <a:cubicBezTo>
-                    <a:pt x="0" y="149860"/>
-                    <a:pt x="25400" y="104140"/>
-                    <a:pt x="63500" y="74930"/>
-                  </a:cubicBezTo>
-                  <a:close/>
-                  <a:moveTo>
-                    <a:pt x="5721399" y="2826190"/>
-                  </a:moveTo>
-                  <a:lnTo>
-                    <a:pt x="5721399" y="158750"/>
-                  </a:lnTo>
-                  <a:cubicBezTo>
-                    <a:pt x="5721399" y="78740"/>
-                    <a:pt x="5655359" y="12700"/>
-                    <a:pt x="5575349" y="12700"/>
-                  </a:cubicBezTo>
-                  <a:lnTo>
-                    <a:pt x="216920" y="12700"/>
-                  </a:lnTo>
-                  <a:cubicBezTo>
-                    <a:pt x="118110" y="12700"/>
-                    <a:pt x="52070" y="78740"/>
-                    <a:pt x="52070" y="158750"/>
-                  </a:cubicBezTo>
-                  <a:lnTo>
-                    <a:pt x="52070" y="2826190"/>
-                  </a:lnTo>
-                  <a:cubicBezTo>
-                    <a:pt x="52070" y="2906200"/>
-                    <a:pt x="118110" y="2972240"/>
-                    <a:pt x="216920" y="2972240"/>
-                  </a:cubicBezTo>
-                  <a:lnTo>
-                    <a:pt x="5575349" y="2972240"/>
-                  </a:lnTo>
-                  <a:cubicBezTo>
-                    <a:pt x="5655359" y="2972240"/>
-                    <a:pt x="5721399" y="2907470"/>
-                    <a:pt x="5721399" y="2826190"/>
-                  </a:cubicBezTo>
-                  <a:close/>
-                </a:path>
-              </a:pathLst>
-            </a:custGeom>
-            <a:solidFill>
-              <a:srgbClr val="C9A84C"/>
-            </a:solidFill>
-          </p:spPr>
-        </p:sp>
-      </p:grpSp>
-      <p:sp>
-        <p:nvSpPr>
-          <p:cNvPr id="5" name="Rectangle 4"/>
+      <p:sp>
+        <p:nvSpPr>
+          <p:cNvPr id="2" name="Rectangle 1"/>
           <p:cNvSpPr/>
           <p:nvPr/>
         </p:nvSpPr>
         <p:spPr>
           <a:xfrm>
             <a:off x="0" y="0"/>
-            <a:ext cx="18288000" cy="109728"/>
+            <a:ext cx="18288000" cy="10287000"/>
           </a:xfrm>
           <a:prstGeom prst="rect">
             <a:avLst/>
           </a:prstGeom>
           <a:solidFill>
-            <a:srgbClr val="C9A84C"/>
+            <a:srgbClr val="1A2A4A"/>
           </a:solidFill>
           <a:ln>
             <a:noFill/>
@@ -5965,131 +5778,23 @@
       </p:sp>
       <p:sp>
         <p:nvSpPr>
-          <p:cNvPr id="6" name="TextBox 5"/>
-          <p:cNvSpPr txBox="1"/>
+          <p:cNvPr id="3" name="Rectangle 2"/>
+          <p:cNvSpPr/>
           <p:nvPr/>
         </p:nvSpPr>
         <p:spPr>
           <a:xfrm>
-            <a:off x="457200" y="228600"/>
-            <a:ext cx="10058400" cy="1280160"/>
-          </a:xfrm>
-          <a:prstGeom prst="rect">
-            <a:avLst/>
-          </a:prstGeom>
-          <a:noFill/>
-        </p:spPr>
-        <p:txBody>
-          <a:bodyPr wrap="square">
-            <a:spAutoFit/>
-          </a:bodyPr>
-          <a:lstStyle/>
-          <a:p>
-            <a:pPr algn="r"/>
-            <a:r>
-              <a:rPr sz="3200" b="1">
-                <a:solidFill>
-                  <a:srgbClr val="C9A84C"/>
-                </a:solidFill>
-                <a:latin typeface="Noto Sans Arabic"/>
-              </a:rPr>
-              <a:t>السياق الوطني: قانون سلامة الطفل الرقمي</a:t>
-            </a:r>
-          </a:p>
-          <a:p>
-            <a:pPr algn="r"/>
-            <a:r>
-              <a:rPr sz="1300" b="0">
-                <a:solidFill>
-                  <a:srgbClr val="CCCCCC"/>
-                </a:solidFill>
-                <a:latin typeface="Noto Sans Arabic"/>
-              </a:rPr>
-              <a:t>UAE Federal Decree No. 2 / 2026 — Child Digital Safety Law</a:t>
-            </a:r>
-          </a:p>
-        </p:txBody>
-      </p:sp>
-      <p:sp>
-        <p:nvSpPr>
-          <p:cNvPr id="7" name="TextBox 6"/>
-          <p:cNvSpPr txBox="1"/>
-          <p:nvPr/>
-        </p:nvSpPr>
-        <p:spPr>
-          <a:xfrm>
-            <a:off x="11430000" y="1645920"/>
-            <a:ext cx="5943600" cy="4572000"/>
-          </a:xfrm>
-          <a:prstGeom prst="rect">
-            <a:avLst/>
-          </a:prstGeom>
-          <a:noFill/>
-        </p:spPr>
-        <p:txBody>
-          <a:bodyPr wrap="square">
-            <a:spAutoFit/>
-          </a:bodyPr>
-          <a:lstStyle/>
-          <a:p>
-            <a:pPr algn="ctr"/>
-            <a:r>
-              <a:rPr sz="9600" b="1">
-                <a:solidFill>
-                  <a:srgbClr val="C9A84C"/>
-                </a:solidFill>
-                <a:latin typeface="Noto Sans Arabic"/>
-              </a:rPr>
-              <a:t>2026</a:t>
-            </a:r>
-          </a:p>
-          <a:p>
-            <a:pPr algn="ctr"/>
-            <a:r>
-              <a:rPr sz="2400" b="1">
-                <a:solidFill>
-                  <a:srgbClr val="FFFFFF"/>
-                </a:solidFill>
-                <a:latin typeface="Noto Sans Arabic"/>
-              </a:rPr>
-              <a:t>قانون</a:t>
-            </a:r>
-          </a:p>
-          <a:p>
-            <a:pPr algn="ctr"/>
-            <a:r>
-              <a:rPr sz="1600" b="0">
-                <a:solidFill>
-                  <a:srgbClr val="F3E5B8"/>
-                </a:solidFill>
-                <a:latin typeface="Noto Sans Arabic"/>
-              </a:rPr>
-              <a:t>سلامة الطفل الرقمي</a:t>
-            </a:r>
-          </a:p>
-        </p:txBody>
-      </p:sp>
-      <p:sp>
-        <p:nvSpPr>
-          <p:cNvPr id="8" name="Rectangle 7"/>
-          <p:cNvSpPr/>
-          <p:nvPr/>
-        </p:nvSpPr>
-        <p:spPr>
-          <a:xfrm>
-            <a:off x="365760" y="1737360"/>
-            <a:ext cx="9966960" cy="1463040"/>
+            <a:off x="0" y="0"/>
+            <a:ext cx="18288000" cy="118872"/>
           </a:xfrm>
           <a:prstGeom prst="rect">
             <a:avLst/>
           </a:prstGeom>
           <a:solidFill>
-            <a:srgbClr val="1E345C"/>
+            <a:srgbClr val="C9A84C"/>
           </a:solidFill>
-          <a:ln w="6350">
-            <a:solidFill>
-              <a:srgbClr val="C9A84C"/>
-            </a:solidFill>
+          <a:ln>
+            <a:noFill/>
           </a:ln>
         </p:spPr>
         <p:style>
@@ -6116,14 +5821,14 @@
       </p:sp>
       <p:sp>
         <p:nvSpPr>
-          <p:cNvPr id="9" name="Rectangle 8"/>
+          <p:cNvPr id="4" name="Rectangle 3"/>
           <p:cNvSpPr/>
           <p:nvPr/>
         </p:nvSpPr>
         <p:spPr>
           <a:xfrm>
-            <a:off x="365760" y="1737360"/>
-            <a:ext cx="128016" cy="1463040"/>
+            <a:off x="0" y="10058400"/>
+            <a:ext cx="18288000" cy="228600"/>
           </a:xfrm>
           <a:prstGeom prst="rect">
             <a:avLst/>
@@ -6159,23 +5864,93 @@
       </p:sp>
       <p:sp>
         <p:nvSpPr>
-          <p:cNvPr id="10" name="Rectangle 9"/>
+          <p:cNvPr id="5" name="TextBox 4"/>
+          <p:cNvSpPr txBox="1"/>
+          <p:nvPr/>
+        </p:nvSpPr>
+        <p:spPr>
+          <a:xfrm>
+            <a:off x="274320" y="201168"/>
+            <a:ext cx="17739360" cy="640080"/>
+          </a:xfrm>
+          <a:prstGeom prst="rect">
+            <a:avLst/>
+          </a:prstGeom>
+          <a:noFill/>
+        </p:spPr>
+        <p:txBody>
+          <a:bodyPr wrap="square">
+            <a:spAutoFit/>
+          </a:bodyPr>
+          <a:lstStyle/>
+          <a:p>
+            <a:pPr algn="r"/>
+            <a:r>
+              <a:rPr sz="2800" b="1" i="0">
+                <a:solidFill>
+                  <a:srgbClr val="C9A84C"/>
+                </a:solidFill>
+              </a:rPr>
+              <a:t>السياق الوطني: قانون سلامة الطفل الرقمي</a:t>
+            </a:r>
+          </a:p>
+        </p:txBody>
+      </p:sp>
+      <p:sp>
+        <p:nvSpPr>
+          <p:cNvPr id="6" name="TextBox 5"/>
+          <p:cNvSpPr txBox="1"/>
+          <p:nvPr/>
+        </p:nvSpPr>
+        <p:spPr>
+          <a:xfrm>
+            <a:off x="274320" y="841248"/>
+            <a:ext cx="17739360" cy="320040"/>
+          </a:xfrm>
+          <a:prstGeom prst="rect">
+            <a:avLst/>
+          </a:prstGeom>
+          <a:noFill/>
+        </p:spPr>
+        <p:txBody>
+          <a:bodyPr wrap="square">
+            <a:spAutoFit/>
+          </a:bodyPr>
+          <a:lstStyle/>
+          <a:p>
+            <a:pPr algn="r"/>
+            <a:r>
+              <a:rPr sz="1300" b="0" i="1">
+                <a:solidFill>
+                  <a:srgbClr val="FFFFFF"/>
+                </a:solidFill>
+              </a:rPr>
+              <a:t>UAE Federal Decree No. 2 / 2026 — Child Digital Safety Law</a:t>
+            </a:r>
+          </a:p>
+        </p:txBody>
+      </p:sp>
+      <p:sp>
+        <p:nvSpPr>
+          <p:cNvPr id="7" name="Rectangle 6"/>
           <p:cNvSpPr/>
           <p:nvPr/>
         </p:nvSpPr>
         <p:spPr>
           <a:xfrm>
-            <a:off x="566928" y="2148840"/>
-            <a:ext cx="658368" cy="658368"/>
+            <a:off x="320040" y="1417320"/>
+            <a:ext cx="4754880" cy="5029200"/>
           </a:xfrm>
           <a:prstGeom prst="rect">
             <a:avLst/>
           </a:prstGeom>
           <a:solidFill>
-            <a:srgbClr val="C9A84C"/>
+            <a:srgbClr val="243860"/>
           </a:solidFill>
-          <a:ln>
-            <a:noFill/>
+          <a:ln w="25400">
+            <a:solidFill>
+              <a:srgbClr val="C9A84C"/>
+            </a:solidFill>
           </a:ln>
         </p:spPr>
         <p:style>
@@ -6193,32 +5968,23 @@
           </a:fontRef>
         </p:style>
         <p:txBody>
-          <a:bodyPr rtlCol="0" anchor="ctr" wrap="square"/>
+          <a:bodyPr rtlCol="0" anchor="ctr"/>
           <a:lstStyle/>
           <a:p>
             <a:pPr algn="ctr"/>
-            <a:r>
-              <a:rPr sz="1700" b="1">
-                <a:solidFill>
-                  <a:srgbClr val="1A2A4A"/>
-                </a:solidFill>
-                <a:latin typeface="Noto Sans Arabic"/>
-              </a:rPr>
-              <a:t>01</a:t>
-            </a:r>
-          </a:p>
-        </p:txBody>
-      </p:sp>
-      <p:sp>
-        <p:nvSpPr>
-          <p:cNvPr id="11" name="TextBox 10"/>
+          </a:p>
+        </p:txBody>
+      </p:sp>
+      <p:sp>
+        <p:nvSpPr>
+          <p:cNvPr id="8" name="TextBox 7"/>
           <p:cNvSpPr txBox="1"/>
           <p:nvPr/>
         </p:nvSpPr>
         <p:spPr>
           <a:xfrm>
-            <a:off x="1371600" y="1874519"/>
-            <a:ext cx="8778240" cy="1280160"/>
+            <a:off x="411480" y="1600200"/>
+            <a:ext cx="4572000" cy="457200"/>
           </a:xfrm>
           <a:prstGeom prst="rect">
             <a:avLst/>
@@ -6231,49 +5997,206 @@
           </a:bodyPr>
           <a:lstStyle/>
           <a:p>
-            <a:pPr algn="r"/>
-            <a:r>
-              <a:rPr sz="1800" b="1">
+            <a:pPr algn="ctr"/>
+            <a:r>
+              <a:rPr sz="1400" b="1" i="0">
+                <a:solidFill>
+                  <a:srgbClr val="C9A84C"/>
+                </a:solidFill>
+              </a:rPr>
+              <a:t>مرسوم اتحادي</a:t>
+            </a:r>
+          </a:p>
+        </p:txBody>
+      </p:sp>
+      <p:sp>
+        <p:nvSpPr>
+          <p:cNvPr id="9" name="TextBox 8"/>
+          <p:cNvSpPr txBox="1"/>
+          <p:nvPr/>
+        </p:nvSpPr>
+        <p:spPr>
+          <a:xfrm>
+            <a:off x="411480" y="2057400"/>
+            <a:ext cx="4572000" cy="365760"/>
+          </a:xfrm>
+          <a:prstGeom prst="rect">
+            <a:avLst/>
+          </a:prstGeom>
+          <a:noFill/>
+        </p:spPr>
+        <p:txBody>
+          <a:bodyPr wrap="square">
+            <a:spAutoFit/>
+          </a:bodyPr>
+          <a:lstStyle/>
+          <a:p>
+            <a:pPr algn="ctr"/>
+            <a:r>
+              <a:rPr sz="1300" b="0" i="0">
                 <a:solidFill>
                   <a:srgbClr val="FFFFFF"/>
                 </a:solidFill>
-                <a:latin typeface="Noto Sans Arabic"/>
               </a:rPr>
-              <a:t>حماية البيانات الرقمية للطلاب</a:t>
-            </a:r>
-          </a:p>
-          <a:p>
-            <a:pPr algn="r"/>
-            <a:r>
-              <a:rPr sz="1100" b="0">
+              <a:t>رقم 2 لسنة</a:t>
+            </a:r>
+          </a:p>
+        </p:txBody>
+      </p:sp>
+      <p:sp>
+        <p:nvSpPr>
+          <p:cNvPr id="10" name="TextBox 9"/>
+          <p:cNvSpPr txBox="1"/>
+          <p:nvPr/>
+        </p:nvSpPr>
+        <p:spPr>
+          <a:xfrm>
+            <a:off x="411480" y="2423160"/>
+            <a:ext cx="4572000" cy="1005840"/>
+          </a:xfrm>
+          <a:prstGeom prst="rect">
+            <a:avLst/>
+          </a:prstGeom>
+          <a:noFill/>
+        </p:spPr>
+        <p:txBody>
+          <a:bodyPr wrap="square">
+            <a:spAutoFit/>
+          </a:bodyPr>
+          <a:lstStyle/>
+          <a:p>
+            <a:pPr algn="ctr"/>
+            <a:r>
+              <a:rPr sz="5400" b="1" i="0">
                 <a:solidFill>
-                  <a:srgbClr val="CCCCCC"/>
+                  <a:srgbClr val="C9A84C"/>
                 </a:solidFill>
-                <a:latin typeface="Noto Sans Arabic"/>
               </a:rPr>
-              <a:t>Student Digital Data Protection</a:t>
-            </a:r>
-          </a:p>
-        </p:txBody>
-      </p:sp>
-      <p:sp>
-        <p:nvSpPr>
-          <p:cNvPr id="12" name="Rectangle 11"/>
+              <a:t>2026</a:t>
+            </a:r>
+          </a:p>
+        </p:txBody>
+      </p:sp>
+      <p:sp>
+        <p:nvSpPr>
+          <p:cNvPr id="11" name="TextBox 10"/>
+          <p:cNvSpPr txBox="1"/>
+          <p:nvPr/>
+        </p:nvSpPr>
+        <p:spPr>
+          <a:xfrm>
+            <a:off x="411480" y="3474720"/>
+            <a:ext cx="4572000" cy="411480"/>
+          </a:xfrm>
+          <a:prstGeom prst="rect">
+            <a:avLst/>
+          </a:prstGeom>
+          <a:noFill/>
+        </p:spPr>
+        <p:txBody>
+          <a:bodyPr wrap="square">
+            <a:spAutoFit/>
+          </a:bodyPr>
+          <a:lstStyle/>
+          <a:p>
+            <a:pPr algn="ctr"/>
+            <a:r>
+              <a:rPr sz="1300" b="0" i="0">
+                <a:solidFill>
+                  <a:srgbClr val="FFFFFF"/>
+                </a:solidFill>
+              </a:rPr>
+              <a:t>حماية الطفل في الفضاء الرقمي</a:t>
+            </a:r>
+          </a:p>
+        </p:txBody>
+      </p:sp>
+      <p:sp>
+        <p:nvSpPr>
+          <p:cNvPr id="12" name="TextBox 11"/>
+          <p:cNvSpPr txBox="1"/>
+          <p:nvPr/>
+        </p:nvSpPr>
+        <p:spPr>
+          <a:xfrm>
+            <a:off x="411480" y="3886200"/>
+            <a:ext cx="4572000" cy="320040"/>
+          </a:xfrm>
+          <a:prstGeom prst="rect">
+            <a:avLst/>
+          </a:prstGeom>
+          <a:noFill/>
+        </p:spPr>
+        <p:txBody>
+          <a:bodyPr wrap="square">
+            <a:spAutoFit/>
+          </a:bodyPr>
+          <a:lstStyle/>
+          <a:p>
+            <a:pPr algn="ctr"/>
+            <a:r>
+              <a:rPr sz="1100" b="0" i="1">
+                <a:solidFill>
+                  <a:srgbClr val="C9A84C"/>
+                </a:solidFill>
+              </a:rPr>
+              <a:t>Child Digital Safety Law</a:t>
+            </a:r>
+          </a:p>
+        </p:txBody>
+      </p:sp>
+      <p:sp>
+        <p:nvSpPr>
+          <p:cNvPr id="13" name="TextBox 12"/>
+          <p:cNvSpPr txBox="1"/>
+          <p:nvPr/>
+        </p:nvSpPr>
+        <p:spPr>
+          <a:xfrm>
+            <a:off x="411480" y="4343400"/>
+            <a:ext cx="4572000" cy="320040"/>
+          </a:xfrm>
+          <a:prstGeom prst="rect">
+            <a:avLst/>
+          </a:prstGeom>
+          <a:noFill/>
+        </p:spPr>
+        <p:txBody>
+          <a:bodyPr wrap="square">
+            <a:spAutoFit/>
+          </a:bodyPr>
+          <a:lstStyle/>
+          <a:p>
+            <a:pPr algn="ctr"/>
+            <a:r>
+              <a:rPr sz="1100" b="0" i="0">
+                <a:solidFill>
+                  <a:srgbClr val="AAAAAA"/>
+                </a:solidFill>
+              </a:rPr>
+              <a:t>يناير 2026 | January 2026</a:t>
+            </a:r>
+          </a:p>
+        </p:txBody>
+      </p:sp>
+      <p:sp>
+        <p:nvSpPr>
+          <p:cNvPr id="14" name="Rectangle 13"/>
           <p:cNvSpPr/>
           <p:nvPr/>
         </p:nvSpPr>
         <p:spPr>
           <a:xfrm>
-            <a:off x="365760" y="3310128"/>
-            <a:ext cx="9966960" cy="1463040"/>
+            <a:off x="5486400" y="1325880"/>
+            <a:ext cx="12435840" cy="914400"/>
           </a:xfrm>
           <a:prstGeom prst="rect">
             <a:avLst/>
           </a:prstGeom>
           <a:solidFill>
-            <a:srgbClr val="1E345C"/>
+            <a:srgbClr val="243860"/>
           </a:solidFill>
-          <a:ln w="6350">
+          <a:ln w="12700">
             <a:solidFill>
               <a:srgbClr val="C9A84C"/>
             </a:solidFill>
@@ -6303,14 +6226,14 @@
       </p:sp>
       <p:sp>
         <p:nvSpPr>
-          <p:cNvPr id="13" name="Rectangle 12"/>
+          <p:cNvPr id="15" name="Rectangle 14"/>
           <p:cNvSpPr/>
           <p:nvPr/>
         </p:nvSpPr>
         <p:spPr>
           <a:xfrm>
-            <a:off x="365760" y="3310128"/>
-            <a:ext cx="128016" cy="1463040"/>
+            <a:off x="5486400" y="1325880"/>
+            <a:ext cx="640080" cy="914400"/>
           </a:xfrm>
           <a:prstGeom prst="rect">
             <a:avLst/>
@@ -6346,23 +6269,127 @@
       </p:sp>
       <p:sp>
         <p:nvSpPr>
-          <p:cNvPr id="14" name="Rectangle 13"/>
+          <p:cNvPr id="16" name="TextBox 15"/>
+          <p:cNvSpPr txBox="1"/>
+          <p:nvPr/>
+        </p:nvSpPr>
+        <p:spPr>
+          <a:xfrm>
+            <a:off x="5532120" y="1554480"/>
+            <a:ext cx="548640" cy="457200"/>
+          </a:xfrm>
+          <a:prstGeom prst="rect">
+            <a:avLst/>
+          </a:prstGeom>
+          <a:noFill/>
+        </p:spPr>
+        <p:txBody>
+          <a:bodyPr wrap="square">
+            <a:spAutoFit/>
+          </a:bodyPr>
+          <a:lstStyle/>
+          <a:p>
+            <a:pPr algn="ctr"/>
+            <a:r>
+              <a:rPr sz="1600" b="1" i="0">
+                <a:solidFill>
+                  <a:srgbClr val="1A2A4A"/>
+                </a:solidFill>
+              </a:rPr>
+              <a:t>01</a:t>
+            </a:r>
+          </a:p>
+        </p:txBody>
+      </p:sp>
+      <p:sp>
+        <p:nvSpPr>
+          <p:cNvPr id="17" name="TextBox 16"/>
+          <p:cNvSpPr txBox="1"/>
+          <p:nvPr/>
+        </p:nvSpPr>
+        <p:spPr>
+          <a:xfrm>
+            <a:off x="6309360" y="1399032"/>
+            <a:ext cx="11430000" cy="411480"/>
+          </a:xfrm>
+          <a:prstGeom prst="rect">
+            <a:avLst/>
+          </a:prstGeom>
+          <a:noFill/>
+        </p:spPr>
+        <p:txBody>
+          <a:bodyPr wrap="square">
+            <a:spAutoFit/>
+          </a:bodyPr>
+          <a:lstStyle/>
+          <a:p>
+            <a:pPr algn="r"/>
+            <a:r>
+              <a:rPr sz="1600" b="1" i="0">
+                <a:solidFill>
+                  <a:srgbClr val="FFFFFF"/>
+                </a:solidFill>
+              </a:rPr>
+              <a:t>حماية البيانات الرقمية للطلاب</a:t>
+            </a:r>
+          </a:p>
+        </p:txBody>
+      </p:sp>
+      <p:sp>
+        <p:nvSpPr>
+          <p:cNvPr id="18" name="TextBox 17"/>
+          <p:cNvSpPr txBox="1"/>
+          <p:nvPr/>
+        </p:nvSpPr>
+        <p:spPr>
+          <a:xfrm>
+            <a:off x="6309360" y="1828800"/>
+            <a:ext cx="11430000" cy="320040"/>
+          </a:xfrm>
+          <a:prstGeom prst="rect">
+            <a:avLst/>
+          </a:prstGeom>
+          <a:noFill/>
+        </p:spPr>
+        <p:txBody>
+          <a:bodyPr wrap="square">
+            <a:spAutoFit/>
+          </a:bodyPr>
+          <a:lstStyle/>
+          <a:p>
+            <a:pPr algn="r"/>
+            <a:r>
+              <a:rPr sz="1100" b="0" i="1">
+                <a:solidFill>
+                  <a:srgbClr val="C9A84C"/>
+                </a:solidFill>
+              </a:rPr>
+              <a:t>Student Digital Data Protection</a:t>
+            </a:r>
+          </a:p>
+        </p:txBody>
+      </p:sp>
+      <p:sp>
+        <p:nvSpPr>
+          <p:cNvPr id="19" name="Rectangle 18"/>
           <p:cNvSpPr/>
           <p:nvPr/>
         </p:nvSpPr>
         <p:spPr>
           <a:xfrm>
-            <a:off x="566928" y="3721608"/>
-            <a:ext cx="658368" cy="658368"/>
+            <a:off x="5486400" y="2350008"/>
+            <a:ext cx="12435840" cy="914400"/>
           </a:xfrm>
           <a:prstGeom prst="rect">
             <a:avLst/>
           </a:prstGeom>
           <a:solidFill>
-            <a:srgbClr val="C9A84C"/>
+            <a:srgbClr val="243860"/>
           </a:solidFill>
-          <a:ln>
-            <a:noFill/>
+          <a:ln w="12700">
+            <a:solidFill>
+              <a:srgbClr val="C9A84C"/>
+            </a:solidFill>
           </a:ln>
         </p:spPr>
         <p:style>
@@ -6380,90 +6407,32 @@
           </a:fontRef>
         </p:style>
         <p:txBody>
-          <a:bodyPr rtlCol="0" anchor="ctr" wrap="square"/>
+          <a:bodyPr rtlCol="0" anchor="ctr"/>
           <a:lstStyle/>
           <a:p>
             <a:pPr algn="ctr"/>
-            <a:r>
-              <a:rPr sz="1700" b="1">
-                <a:solidFill>
-                  <a:srgbClr val="1A2A4A"/>
-                </a:solidFill>
-                <a:latin typeface="Noto Sans Arabic"/>
-              </a:rPr>
-              <a:t>02</a:t>
-            </a:r>
-          </a:p>
-        </p:txBody>
-      </p:sp>
-      <p:sp>
-        <p:nvSpPr>
-          <p:cNvPr id="15" name="TextBox 14"/>
-          <p:cNvSpPr txBox="1"/>
+          </a:p>
+        </p:txBody>
+      </p:sp>
+      <p:sp>
+        <p:nvSpPr>
+          <p:cNvPr id="20" name="Rectangle 19"/>
+          <p:cNvSpPr/>
           <p:nvPr/>
         </p:nvSpPr>
         <p:spPr>
           <a:xfrm>
-            <a:off x="1371600" y="3447288"/>
-            <a:ext cx="8778240" cy="1280160"/>
-          </a:xfrm>
-          <a:prstGeom prst="rect">
-            <a:avLst/>
-          </a:prstGeom>
-          <a:noFill/>
-        </p:spPr>
-        <p:txBody>
-          <a:bodyPr wrap="square">
-            <a:spAutoFit/>
-          </a:bodyPr>
-          <a:lstStyle/>
-          <a:p>
-            <a:pPr algn="r"/>
-            <a:r>
-              <a:rPr sz="1800" b="1">
-                <a:solidFill>
-                  <a:srgbClr val="FFFFFF"/>
-                </a:solidFill>
-                <a:latin typeface="Noto Sans Arabic"/>
-              </a:rPr>
-              <a:t>توثيق هوية المستخدمين</a:t>
-            </a:r>
-          </a:p>
-          <a:p>
-            <a:pPr algn="r"/>
-            <a:r>
-              <a:rPr sz="1100" b="0">
-                <a:solidFill>
-                  <a:srgbClr val="CCCCCC"/>
-                </a:solidFill>
-                <a:latin typeface="Noto Sans Arabic"/>
-              </a:rPr>
-              <a:t>User Identity Verification</a:t>
-            </a:r>
-          </a:p>
-        </p:txBody>
-      </p:sp>
-      <p:sp>
-        <p:nvSpPr>
-          <p:cNvPr id="16" name="Rectangle 15"/>
-          <p:cNvSpPr/>
-          <p:nvPr/>
-        </p:nvSpPr>
-        <p:spPr>
-          <a:xfrm>
-            <a:off x="365760" y="4882896"/>
-            <a:ext cx="9966960" cy="1463040"/>
+            <a:off x="5486400" y="2350008"/>
+            <a:ext cx="640080" cy="914400"/>
           </a:xfrm>
           <a:prstGeom prst="rect">
             <a:avLst/>
           </a:prstGeom>
           <a:solidFill>
-            <a:srgbClr val="1E345C"/>
+            <a:srgbClr val="C9A84C"/>
           </a:solidFill>
-          <a:ln w="6350">
-            <a:solidFill>
-              <a:srgbClr val="C9A84C"/>
-            </a:solidFill>
+          <a:ln>
+            <a:noFill/>
           </a:ln>
         </p:spPr>
         <p:style>
@@ -6490,23 +6459,127 @@
       </p:sp>
       <p:sp>
         <p:nvSpPr>
-          <p:cNvPr id="17" name="Rectangle 16"/>
+          <p:cNvPr id="21" name="TextBox 20"/>
+          <p:cNvSpPr txBox="1"/>
+          <p:nvPr/>
+        </p:nvSpPr>
+        <p:spPr>
+          <a:xfrm>
+            <a:off x="5532120" y="2578608"/>
+            <a:ext cx="548640" cy="457200"/>
+          </a:xfrm>
+          <a:prstGeom prst="rect">
+            <a:avLst/>
+          </a:prstGeom>
+          <a:noFill/>
+        </p:spPr>
+        <p:txBody>
+          <a:bodyPr wrap="square">
+            <a:spAutoFit/>
+          </a:bodyPr>
+          <a:lstStyle/>
+          <a:p>
+            <a:pPr algn="ctr"/>
+            <a:r>
+              <a:rPr sz="1600" b="1" i="0">
+                <a:solidFill>
+                  <a:srgbClr val="1A2A4A"/>
+                </a:solidFill>
+              </a:rPr>
+              <a:t>02</a:t>
+            </a:r>
+          </a:p>
+        </p:txBody>
+      </p:sp>
+      <p:sp>
+        <p:nvSpPr>
+          <p:cNvPr id="22" name="TextBox 21"/>
+          <p:cNvSpPr txBox="1"/>
+          <p:nvPr/>
+        </p:nvSpPr>
+        <p:spPr>
+          <a:xfrm>
+            <a:off x="6309360" y="2423160"/>
+            <a:ext cx="11430000" cy="411480"/>
+          </a:xfrm>
+          <a:prstGeom prst="rect">
+            <a:avLst/>
+          </a:prstGeom>
+          <a:noFill/>
+        </p:spPr>
+        <p:txBody>
+          <a:bodyPr wrap="square">
+            <a:spAutoFit/>
+          </a:bodyPr>
+          <a:lstStyle/>
+          <a:p>
+            <a:pPr algn="r"/>
+            <a:r>
+              <a:rPr sz="1600" b="1" i="0">
+                <a:solidFill>
+                  <a:srgbClr val="FFFFFF"/>
+                </a:solidFill>
+              </a:rPr>
+              <a:t>توثيق هوية المستخدمين</a:t>
+            </a:r>
+          </a:p>
+        </p:txBody>
+      </p:sp>
+      <p:sp>
+        <p:nvSpPr>
+          <p:cNvPr id="23" name="TextBox 22"/>
+          <p:cNvSpPr txBox="1"/>
+          <p:nvPr/>
+        </p:nvSpPr>
+        <p:spPr>
+          <a:xfrm>
+            <a:off x="6309360" y="2852928"/>
+            <a:ext cx="11430000" cy="320040"/>
+          </a:xfrm>
+          <a:prstGeom prst="rect">
+            <a:avLst/>
+          </a:prstGeom>
+          <a:noFill/>
+        </p:spPr>
+        <p:txBody>
+          <a:bodyPr wrap="square">
+            <a:spAutoFit/>
+          </a:bodyPr>
+          <a:lstStyle/>
+          <a:p>
+            <a:pPr algn="r"/>
+            <a:r>
+              <a:rPr sz="1100" b="0" i="1">
+                <a:solidFill>
+                  <a:srgbClr val="C9A84C"/>
+                </a:solidFill>
+              </a:rPr>
+              <a:t>User Identity Verification</a:t>
+            </a:r>
+          </a:p>
+        </p:txBody>
+      </p:sp>
+      <p:sp>
+        <p:nvSpPr>
+          <p:cNvPr id="24" name="Rectangle 23"/>
           <p:cNvSpPr/>
           <p:nvPr/>
         </p:nvSpPr>
         <p:spPr>
           <a:xfrm>
-            <a:off x="365760" y="4882896"/>
-            <a:ext cx="128016" cy="1463040"/>
+            <a:off x="5486400" y="3374136"/>
+            <a:ext cx="12435840" cy="914400"/>
           </a:xfrm>
           <a:prstGeom prst="rect">
             <a:avLst/>
           </a:prstGeom>
           <a:solidFill>
-            <a:srgbClr val="C9A84C"/>
+            <a:srgbClr val="243860"/>
           </a:solidFill>
-          <a:ln>
-            <a:noFill/>
+          <a:ln w="12700">
+            <a:solidFill>
+              <a:srgbClr val="C9A84C"/>
+            </a:solidFill>
           </a:ln>
         </p:spPr>
         <p:style>
@@ -6533,14 +6606,14 @@
       </p:sp>
       <p:sp>
         <p:nvSpPr>
-          <p:cNvPr id="18" name="Rectangle 17"/>
+          <p:cNvPr id="25" name="Rectangle 24"/>
           <p:cNvSpPr/>
           <p:nvPr/>
         </p:nvSpPr>
         <p:spPr>
           <a:xfrm>
-            <a:off x="566928" y="5294376"/>
-            <a:ext cx="658368" cy="658368"/>
+            <a:off x="5486400" y="3374136"/>
+            <a:ext cx="640080" cy="914400"/>
           </a:xfrm>
           <a:prstGeom prst="rect">
             <a:avLst/>
@@ -6567,32 +6640,23 @@
           </a:fontRef>
         </p:style>
         <p:txBody>
-          <a:bodyPr rtlCol="0" anchor="ctr" wrap="square"/>
+          <a:bodyPr rtlCol="0" anchor="ctr"/>
           <a:lstStyle/>
           <a:p>
             <a:pPr algn="ctr"/>
-            <a:r>
-              <a:rPr sz="1700" b="1">
-                <a:solidFill>
-                  <a:srgbClr val="1A2A4A"/>
-                </a:solidFill>
-                <a:latin typeface="Noto Sans Arabic"/>
-              </a:rPr>
-              <a:t>03</a:t>
-            </a:r>
-          </a:p>
-        </p:txBody>
-      </p:sp>
-      <p:sp>
-        <p:nvSpPr>
-          <p:cNvPr id="19" name="TextBox 18"/>
+          </a:p>
+        </p:txBody>
+      </p:sp>
+      <p:sp>
+        <p:nvSpPr>
+          <p:cNvPr id="26" name="TextBox 25"/>
           <p:cNvSpPr txBox="1"/>
           <p:nvPr/>
         </p:nvSpPr>
         <p:spPr>
           <a:xfrm>
-            <a:off x="1371600" y="5020056"/>
-            <a:ext cx="8778240" cy="1280160"/>
+            <a:off x="5532120" y="3602736"/>
+            <a:ext cx="548640" cy="457200"/>
           </a:xfrm>
           <a:prstGeom prst="rect">
             <a:avLst/>
@@ -6605,25 +6669,80 @@
           </a:bodyPr>
           <a:lstStyle/>
           <a:p>
+            <a:pPr algn="ctr"/>
+            <a:r>
+              <a:rPr sz="1600" b="1" i="0">
+                <a:solidFill>
+                  <a:srgbClr val="1A2A4A"/>
+                </a:solidFill>
+              </a:rPr>
+              <a:t>03</a:t>
+            </a:r>
+          </a:p>
+        </p:txBody>
+      </p:sp>
+      <p:sp>
+        <p:nvSpPr>
+          <p:cNvPr id="27" name="TextBox 26"/>
+          <p:cNvSpPr txBox="1"/>
+          <p:nvPr/>
+        </p:nvSpPr>
+        <p:spPr>
+          <a:xfrm>
+            <a:off x="6309360" y="3447288"/>
+            <a:ext cx="11430000" cy="411480"/>
+          </a:xfrm>
+          <a:prstGeom prst="rect">
+            <a:avLst/>
+          </a:prstGeom>
+          <a:noFill/>
+        </p:spPr>
+        <p:txBody>
+          <a:bodyPr wrap="square">
+            <a:spAutoFit/>
+          </a:bodyPr>
+          <a:lstStyle/>
+          <a:p>
             <a:pPr algn="r"/>
             <a:r>
-              <a:rPr sz="1800" b="1">
+              <a:rPr sz="1600" b="1" i="0">
                 <a:solidFill>
                   <a:srgbClr val="FFFFFF"/>
                 </a:solidFill>
-                <a:latin typeface="Noto Sans Arabic"/>
               </a:rPr>
               <a:t>رقابة أولياء الأمور</a:t>
             </a:r>
           </a:p>
+        </p:txBody>
+      </p:sp>
+      <p:sp>
+        <p:nvSpPr>
+          <p:cNvPr id="28" name="TextBox 27"/>
+          <p:cNvSpPr txBox="1"/>
+          <p:nvPr/>
+        </p:nvSpPr>
+        <p:spPr>
+          <a:xfrm>
+            <a:off x="6309360" y="3877056"/>
+            <a:ext cx="11430000" cy="320040"/>
+          </a:xfrm>
+          <a:prstGeom prst="rect">
+            <a:avLst/>
+          </a:prstGeom>
+          <a:noFill/>
+        </p:spPr>
+        <p:txBody>
+          <a:bodyPr wrap="square">
+            <a:spAutoFit/>
+          </a:bodyPr>
+          <a:lstStyle/>
           <a:p>
             <a:pPr algn="r"/>
             <a:r>
-              <a:rPr sz="1100" b="0">
+              <a:rPr sz="1100" b="0" i="1">
                 <a:solidFill>
-                  <a:srgbClr val="CCCCCC"/>
+                  <a:srgbClr val="C9A84C"/>
                 </a:solidFill>
-                <a:latin typeface="Noto Sans Arabic"/>
               </a:rPr>
               <a:t>Parental Monitoring &amp; Control</a:t>
             </a:r>
@@ -6632,22 +6751,22 @@
       </p:sp>
       <p:sp>
         <p:nvSpPr>
-          <p:cNvPr id="20" name="Rectangle 19"/>
+          <p:cNvPr id="29" name="Rectangle 28"/>
           <p:cNvSpPr/>
           <p:nvPr/>
         </p:nvSpPr>
         <p:spPr>
           <a:xfrm>
-            <a:off x="365760" y="6455664"/>
-            <a:ext cx="9966960" cy="1463040"/>
+            <a:off x="5486400" y="4398264"/>
+            <a:ext cx="12435840" cy="914400"/>
           </a:xfrm>
           <a:prstGeom prst="rect">
             <a:avLst/>
           </a:prstGeom>
           <a:solidFill>
-            <a:srgbClr val="1E345C"/>
+            <a:srgbClr val="243860"/>
           </a:solidFill>
-          <a:ln w="6350">
+          <a:ln w="12700">
             <a:solidFill>
               <a:srgbClr val="C9A84C"/>
             </a:solidFill>
@@ -6677,14 +6796,14 @@
       </p:sp>
       <p:sp>
         <p:nvSpPr>
-          <p:cNvPr id="21" name="Rectangle 20"/>
+          <p:cNvPr id="30" name="Rectangle 29"/>
           <p:cNvSpPr/>
           <p:nvPr/>
         </p:nvSpPr>
         <p:spPr>
           <a:xfrm>
-            <a:off x="365760" y="6455664"/>
-            <a:ext cx="128016" cy="1463040"/>
+            <a:off x="5486400" y="4398264"/>
+            <a:ext cx="640080" cy="914400"/>
           </a:xfrm>
           <a:prstGeom prst="rect">
             <a:avLst/>
@@ -6720,23 +6839,127 @@
       </p:sp>
       <p:sp>
         <p:nvSpPr>
-          <p:cNvPr id="22" name="Rectangle 21"/>
+          <p:cNvPr id="31" name="TextBox 30"/>
+          <p:cNvSpPr txBox="1"/>
+          <p:nvPr/>
+        </p:nvSpPr>
+        <p:spPr>
+          <a:xfrm>
+            <a:off x="5532120" y="4626864"/>
+            <a:ext cx="548640" cy="457200"/>
+          </a:xfrm>
+          <a:prstGeom prst="rect">
+            <a:avLst/>
+          </a:prstGeom>
+          <a:noFill/>
+        </p:spPr>
+        <p:txBody>
+          <a:bodyPr wrap="square">
+            <a:spAutoFit/>
+          </a:bodyPr>
+          <a:lstStyle/>
+          <a:p>
+            <a:pPr algn="ctr"/>
+            <a:r>
+              <a:rPr sz="1600" b="1" i="0">
+                <a:solidFill>
+                  <a:srgbClr val="1A2A4A"/>
+                </a:solidFill>
+              </a:rPr>
+              <a:t>04</a:t>
+            </a:r>
+          </a:p>
+        </p:txBody>
+      </p:sp>
+      <p:sp>
+        <p:nvSpPr>
+          <p:cNvPr id="32" name="TextBox 31"/>
+          <p:cNvSpPr txBox="1"/>
+          <p:nvPr/>
+        </p:nvSpPr>
+        <p:spPr>
+          <a:xfrm>
+            <a:off x="6309360" y="4471416"/>
+            <a:ext cx="11430000" cy="411480"/>
+          </a:xfrm>
+          <a:prstGeom prst="rect">
+            <a:avLst/>
+          </a:prstGeom>
+          <a:noFill/>
+        </p:spPr>
+        <p:txBody>
+          <a:bodyPr wrap="square">
+            <a:spAutoFit/>
+          </a:bodyPr>
+          <a:lstStyle/>
+          <a:p>
+            <a:pPr algn="r"/>
+            <a:r>
+              <a:rPr sz="1600" b="1" i="0">
+                <a:solidFill>
+                  <a:srgbClr val="FFFFFF"/>
+                </a:solidFill>
+              </a:rPr>
+              <a:t>الإبلاغ الفوري عن الاختراقات</a:t>
+            </a:r>
+          </a:p>
+        </p:txBody>
+      </p:sp>
+      <p:sp>
+        <p:nvSpPr>
+          <p:cNvPr id="33" name="TextBox 32"/>
+          <p:cNvSpPr txBox="1"/>
+          <p:nvPr/>
+        </p:nvSpPr>
+        <p:spPr>
+          <a:xfrm>
+            <a:off x="6309360" y="4901184"/>
+            <a:ext cx="11430000" cy="320040"/>
+          </a:xfrm>
+          <a:prstGeom prst="rect">
+            <a:avLst/>
+          </a:prstGeom>
+          <a:noFill/>
+        </p:spPr>
+        <p:txBody>
+          <a:bodyPr wrap="square">
+            <a:spAutoFit/>
+          </a:bodyPr>
+          <a:lstStyle/>
+          <a:p>
+            <a:pPr algn="r"/>
+            <a:r>
+              <a:rPr sz="1100" b="0" i="1">
+                <a:solidFill>
+                  <a:srgbClr val="C9A84C"/>
+                </a:solidFill>
+              </a:rPr>
+              <a:t>Mandatory Breach Reporting</a:t>
+            </a:r>
+          </a:p>
+        </p:txBody>
+      </p:sp>
+      <p:sp>
+        <p:nvSpPr>
+          <p:cNvPr id="34" name="Rectangle 33"/>
           <p:cNvSpPr/>
           <p:nvPr/>
         </p:nvSpPr>
         <p:spPr>
           <a:xfrm>
-            <a:off x="566928" y="6867144"/>
-            <a:ext cx="658368" cy="658368"/>
+            <a:off x="5486400" y="5422392"/>
+            <a:ext cx="12435840" cy="914400"/>
           </a:xfrm>
           <a:prstGeom prst="rect">
             <a:avLst/>
           </a:prstGeom>
           <a:solidFill>
-            <a:srgbClr val="C9A84C"/>
+            <a:srgbClr val="243860"/>
           </a:solidFill>
-          <a:ln>
-            <a:noFill/>
+          <a:ln w="12700">
+            <a:solidFill>
+              <a:srgbClr val="C9A84C"/>
+            </a:solidFill>
           </a:ln>
         </p:spPr>
         <p:style>
@@ -6754,90 +6977,32 @@
           </a:fontRef>
         </p:style>
         <p:txBody>
-          <a:bodyPr rtlCol="0" anchor="ctr" wrap="square"/>
+          <a:bodyPr rtlCol="0" anchor="ctr"/>
           <a:lstStyle/>
           <a:p>
             <a:pPr algn="ctr"/>
-            <a:r>
-              <a:rPr sz="1700" b="1">
-                <a:solidFill>
-                  <a:srgbClr val="1A2A4A"/>
-                </a:solidFill>
-                <a:latin typeface="Noto Sans Arabic"/>
-              </a:rPr>
-              <a:t>04</a:t>
-            </a:r>
-          </a:p>
-        </p:txBody>
-      </p:sp>
-      <p:sp>
-        <p:nvSpPr>
-          <p:cNvPr id="23" name="TextBox 22"/>
-          <p:cNvSpPr txBox="1"/>
+          </a:p>
+        </p:txBody>
+      </p:sp>
+      <p:sp>
+        <p:nvSpPr>
+          <p:cNvPr id="35" name="Rectangle 34"/>
+          <p:cNvSpPr/>
           <p:nvPr/>
         </p:nvSpPr>
         <p:spPr>
           <a:xfrm>
-            <a:off x="1371600" y="6592824"/>
-            <a:ext cx="8778240" cy="1280160"/>
-          </a:xfrm>
-          <a:prstGeom prst="rect">
-            <a:avLst/>
-          </a:prstGeom>
-          <a:noFill/>
-        </p:spPr>
-        <p:txBody>
-          <a:bodyPr wrap="square">
-            <a:spAutoFit/>
-          </a:bodyPr>
-          <a:lstStyle/>
-          <a:p>
-            <a:pPr algn="r"/>
-            <a:r>
-              <a:rPr sz="1800" b="1">
-                <a:solidFill>
-                  <a:srgbClr val="FFFFFF"/>
-                </a:solidFill>
-                <a:latin typeface="Noto Sans Arabic"/>
-              </a:rPr>
-              <a:t>الإبلاغ الفوري عن الاختراقات</a:t>
-            </a:r>
-          </a:p>
-          <a:p>
-            <a:pPr algn="r"/>
-            <a:r>
-              <a:rPr sz="1100" b="0">
-                <a:solidFill>
-                  <a:srgbClr val="CCCCCC"/>
-                </a:solidFill>
-                <a:latin typeface="Noto Sans Arabic"/>
-              </a:rPr>
-              <a:t>Mandatory Breach Reporting</a:t>
-            </a:r>
-          </a:p>
-        </p:txBody>
-      </p:sp>
-      <p:sp>
-        <p:nvSpPr>
-          <p:cNvPr id="24" name="Rectangle 23"/>
-          <p:cNvSpPr/>
-          <p:nvPr/>
-        </p:nvSpPr>
-        <p:spPr>
-          <a:xfrm>
-            <a:off x="365760" y="8028432"/>
-            <a:ext cx="9966960" cy="1463040"/>
+            <a:off x="5486400" y="5422392"/>
+            <a:ext cx="640080" cy="914400"/>
           </a:xfrm>
           <a:prstGeom prst="rect">
             <a:avLst/>
           </a:prstGeom>
           <a:solidFill>
-            <a:srgbClr val="1E345C"/>
+            <a:srgbClr val="C9A84C"/>
           </a:solidFill>
-          <a:ln w="6350">
-            <a:solidFill>
-              <a:srgbClr val="C9A84C"/>
-            </a:solidFill>
+          <a:ln>
+            <a:noFill/>
           </a:ln>
         </p:spPr>
         <p:style>
@@ -6864,109 +7029,14 @@
       </p:sp>
       <p:sp>
         <p:nvSpPr>
-          <p:cNvPr id="25" name="Rectangle 24"/>
-          <p:cNvSpPr/>
+          <p:cNvPr id="36" name="TextBox 35"/>
+          <p:cNvSpPr txBox="1"/>
           <p:nvPr/>
         </p:nvSpPr>
         <p:spPr>
           <a:xfrm>
-            <a:off x="365760" y="8028432"/>
-            <a:ext cx="128016" cy="1463040"/>
-          </a:xfrm>
-          <a:prstGeom prst="rect">
-            <a:avLst/>
-          </a:prstGeom>
-          <a:solidFill>
-            <a:srgbClr val="C9A84C"/>
-          </a:solidFill>
-          <a:ln>
-            <a:noFill/>
-          </a:ln>
-        </p:spPr>
-        <p:style>
-          <a:lnRef idx="1">
-            <a:schemeClr val="accent1"/>
-          </a:lnRef>
-          <a:fillRef idx="3">
-            <a:schemeClr val="accent1"/>
-          </a:fillRef>
-          <a:effectRef idx="2">
-            <a:schemeClr val="accent1"/>
-          </a:effectRef>
-          <a:fontRef idx="minor">
-            <a:schemeClr val="lt1"/>
-          </a:fontRef>
-        </p:style>
-        <p:txBody>
-          <a:bodyPr rtlCol="0" anchor="ctr"/>
-          <a:lstStyle/>
-          <a:p>
-            <a:pPr algn="ctr"/>
-          </a:p>
-        </p:txBody>
-      </p:sp>
-      <p:sp>
-        <p:nvSpPr>
-          <p:cNvPr id="26" name="Rectangle 25"/>
-          <p:cNvSpPr/>
-          <p:nvPr/>
-        </p:nvSpPr>
-        <p:spPr>
-          <a:xfrm>
-            <a:off x="566928" y="8439912"/>
-            <a:ext cx="658368" cy="658368"/>
-          </a:xfrm>
-          <a:prstGeom prst="rect">
-            <a:avLst/>
-          </a:prstGeom>
-          <a:solidFill>
-            <a:srgbClr val="C9A84C"/>
-          </a:solidFill>
-          <a:ln>
-            <a:noFill/>
-          </a:ln>
-        </p:spPr>
-        <p:style>
-          <a:lnRef idx="1">
-            <a:schemeClr val="accent1"/>
-          </a:lnRef>
-          <a:fillRef idx="3">
-            <a:schemeClr val="accent1"/>
-          </a:fillRef>
-          <a:effectRef idx="2">
-            <a:schemeClr val="accent1"/>
-          </a:effectRef>
-          <a:fontRef idx="minor">
-            <a:schemeClr val="lt1"/>
-          </a:fontRef>
-        </p:style>
-        <p:txBody>
-          <a:bodyPr rtlCol="0" anchor="ctr" wrap="square"/>
-          <a:lstStyle/>
-          <a:p>
-            <a:pPr algn="ctr"/>
-            <a:r>
-              <a:rPr sz="1700" b="1">
-                <a:solidFill>
-                  <a:srgbClr val="1A2A4A"/>
-                </a:solidFill>
-                <a:latin typeface="Noto Sans Arabic"/>
-              </a:rPr>
-              <a:t>05</a:t>
-            </a:r>
-          </a:p>
-        </p:txBody>
-      </p:sp>
-      <p:sp>
-        <p:nvSpPr>
-          <p:cNvPr id="27" name="TextBox 26"/>
-          <p:cNvSpPr txBox="1"/>
-          <p:nvPr/>
-        </p:nvSpPr>
-        <p:spPr>
-          <a:xfrm>
-            <a:off x="1371600" y="8165592"/>
-            <a:ext cx="8778240" cy="1280160"/>
+            <a:off x="5532120" y="5650992"/>
+            <a:ext cx="548640" cy="457200"/>
           </a:xfrm>
           <a:prstGeom prst="rect">
             <a:avLst/>
@@ -6979,77 +7049,114 @@
           </a:bodyPr>
           <a:lstStyle/>
           <a:p>
+            <a:pPr algn="ctr"/>
+            <a:r>
+              <a:rPr sz="1600" b="1" i="0">
+                <a:solidFill>
+                  <a:srgbClr val="1A2A4A"/>
+                </a:solidFill>
+              </a:rPr>
+              <a:t>05</a:t>
+            </a:r>
+          </a:p>
+        </p:txBody>
+      </p:sp>
+      <p:sp>
+        <p:nvSpPr>
+          <p:cNvPr id="37" name="TextBox 36"/>
+          <p:cNvSpPr txBox="1"/>
+          <p:nvPr/>
+        </p:nvSpPr>
+        <p:spPr>
+          <a:xfrm>
+            <a:off x="6309360" y="5495544"/>
+            <a:ext cx="11430000" cy="411480"/>
+          </a:xfrm>
+          <a:prstGeom prst="rect">
+            <a:avLst/>
+          </a:prstGeom>
+          <a:noFill/>
+        </p:spPr>
+        <p:txBody>
+          <a:bodyPr wrap="square">
+            <a:spAutoFit/>
+          </a:bodyPr>
+          <a:lstStyle/>
+          <a:p>
             <a:pPr algn="r"/>
             <a:r>
-              <a:rPr sz="1800" b="1">
+              <a:rPr sz="1600" b="1" i="0">
                 <a:solidFill>
                   <a:srgbClr val="FFFFFF"/>
                 </a:solidFill>
-                <a:latin typeface="Noto Sans Arabic"/>
               </a:rPr>
               <a:t>ضبط صلاحيات الوصول</a:t>
             </a:r>
           </a:p>
-          <a:p>
-            <a:pPr algn="r"/>
-            <a:r>
-              <a:rPr sz="1100" b="0">
-                <a:solidFill>
-                  <a:srgbClr val="CCCCCC"/>
-                </a:solidFill>
-                <a:latin typeface="Noto Sans Arabic"/>
-              </a:rPr>
-              <a:t>Granular Access Control</a:t>
-            </a:r>
-          </a:p>
-        </p:txBody>
-      </p:sp>
-      <p:sp>
-        <p:nvSpPr>
-          <p:cNvPr id="28" name="Rectangle 27"/>
-          <p:cNvSpPr/>
+        </p:txBody>
+      </p:sp>
+      <p:sp>
+        <p:nvSpPr>
+          <p:cNvPr id="38" name="TextBox 37"/>
+          <p:cNvSpPr txBox="1"/>
           <p:nvPr/>
         </p:nvSpPr>
         <p:spPr>
           <a:xfrm>
-            <a:off x="0" y="9738360"/>
-            <a:ext cx="18288000" cy="548640"/>
+            <a:off x="6309360" y="5925312"/>
+            <a:ext cx="11430000" cy="320040"/>
           </a:xfrm>
           <a:prstGeom prst="rect">
             <a:avLst/>
           </a:prstGeom>
-          <a:solidFill>
-            <a:srgbClr val="C9A84C"/>
-          </a:solidFill>
-          <a:ln>
-            <a:noFill/>
-          </a:ln>
-        </p:spPr>
-        <p:style>
-          <a:lnRef idx="1">
-            <a:schemeClr val="accent1"/>
-          </a:lnRef>
-          <a:fillRef idx="3">
-            <a:schemeClr val="accent1"/>
-          </a:fillRef>
-          <a:effectRef idx="2">
-            <a:schemeClr val="accent1"/>
-          </a:effectRef>
-          <a:fontRef idx="minor">
-            <a:schemeClr val="lt1"/>
-          </a:fontRef>
-        </p:style>
-        <p:txBody>
-          <a:bodyPr rtlCol="0" anchor="ctr" wrap="square"/>
+          <a:noFill/>
+        </p:spPr>
+        <p:txBody>
+          <a:bodyPr wrap="square">
+            <a:spAutoFit/>
+          </a:bodyPr>
+          <a:lstStyle/>
+          <a:p>
+            <a:pPr algn="r"/>
+            <a:r>
+              <a:rPr sz="1100" b="0" i="1">
+                <a:solidFill>
+                  <a:srgbClr val="C9A84C"/>
+                </a:solidFill>
+              </a:rPr>
+              <a:t>Granular Access Control</a:t>
+            </a:r>
+          </a:p>
+        </p:txBody>
+      </p:sp>
+      <p:sp>
+        <p:nvSpPr>
+          <p:cNvPr id="39" name="TextBox 38"/>
+          <p:cNvSpPr txBox="1"/>
+          <p:nvPr/>
+        </p:nvSpPr>
+        <p:spPr>
+          <a:xfrm>
+            <a:off x="274320" y="10058400"/>
+            <a:ext cx="17739360" cy="201168"/>
+          </a:xfrm>
+          <a:prstGeom prst="rect">
+            <a:avLst/>
+          </a:prstGeom>
+          <a:noFill/>
+        </p:spPr>
+        <p:txBody>
+          <a:bodyPr wrap="square">
+            <a:spAutoFit/>
+          </a:bodyPr>
           <a:lstStyle/>
           <a:p>
             <a:pPr algn="ctr"/>
             <a:r>
-              <a:rPr sz="1400" b="1">
+              <a:rPr sz="1100" b="0" i="0">
                 <a:solidFill>
                   <a:srgbClr val="1A2A4A"/>
                 </a:solidFill>
-                <a:latin typeface="Noto Sans Arabic"/>
               </a:rPr>
               <a:t>أول تشريع اتحادي إماراتي لحماية الطفل في الفضاء الرقمي — يناير 2026</a:t>
             </a:r>
@@ -7088,209 +7195,22 @@
           <a:chExt cx="0" cy="0"/>
         </a:xfrm>
       </p:grpSpPr>
-      <p:grpSp>
-        <p:nvGrpSpPr>
-          <p:cNvPr name="Group 2" id="2"/>
-          <p:cNvGrpSpPr/>
-          <p:nvPr/>
-        </p:nvGrpSpPr>
-        <p:grpSpPr>
-          <a:xfrm rot="0">
-            <a:off x="666750" y="666750"/>
-            <a:ext cx="16954500" cy="8953500"/>
-            <a:chOff x="0" y="0"/>
-            <a:chExt cx="5734099" cy="3028120"/>
-          </a:xfrm>
-        </p:grpSpPr>
-        <p:sp>
-          <p:nvSpPr>
-            <p:cNvPr name="Freeform 3" id="3"/>
-            <p:cNvSpPr/>
-            <p:nvPr/>
-          </p:nvSpPr>
-          <p:spPr>
-            <a:xfrm flipH="false" flipV="false" rot="0">
-              <a:off x="52070" y="12700"/>
-              <a:ext cx="5669329" cy="2959540"/>
-            </a:xfrm>
-            <a:custGeom>
-              <a:avLst/>
-              <a:gdLst/>
-              <a:ahLst/>
-              <a:cxnLst/>
-              <a:rect r="r" b="b" t="t" l="l"/>
-              <a:pathLst>
-                <a:path h="2959540" w="5669329">
-                  <a:moveTo>
-                    <a:pt x="5523279" y="2959540"/>
-                  </a:moveTo>
-                  <a:lnTo>
-                    <a:pt x="164850" y="2959540"/>
-                  </a:lnTo>
-                  <a:cubicBezTo>
-                    <a:pt x="66040" y="2959540"/>
-                    <a:pt x="0" y="2893500"/>
-                    <a:pt x="0" y="2813490"/>
-                  </a:cubicBezTo>
-                  <a:lnTo>
-                    <a:pt x="0" y="146050"/>
-                  </a:lnTo>
-                  <a:cubicBezTo>
-                    <a:pt x="0" y="66040"/>
-                    <a:pt x="66040" y="0"/>
-                    <a:pt x="164850" y="0"/>
-                  </a:cubicBezTo>
-                  <a:lnTo>
-                    <a:pt x="5523279" y="0"/>
-                  </a:lnTo>
-                  <a:cubicBezTo>
-                    <a:pt x="5603289" y="0"/>
-                    <a:pt x="5669329" y="66040"/>
-                    <a:pt x="5669329" y="146050"/>
-                  </a:cubicBezTo>
-                  <a:lnTo>
-                    <a:pt x="5669329" y="2813490"/>
-                  </a:lnTo>
-                  <a:cubicBezTo>
-                    <a:pt x="5669329" y="2894770"/>
-                    <a:pt x="5603289" y="2959540"/>
-                    <a:pt x="5523279" y="2959540"/>
-                  </a:cubicBezTo>
-                  <a:close/>
-                </a:path>
-              </a:pathLst>
-            </a:custGeom>
-            <a:solidFill>
-              <a:srgbClr val="021633"/>
-            </a:solidFill>
-          </p:spPr>
-        </p:sp>
-        <p:sp>
-          <p:nvSpPr>
-            <p:cNvPr name="Freeform 4" id="4"/>
-            <p:cNvSpPr/>
-            <p:nvPr/>
-          </p:nvSpPr>
-          <p:spPr>
-            <a:xfrm flipH="false" flipV="false" rot="0">
-              <a:off x="0" y="0"/>
-              <a:ext cx="5734099" cy="3028120"/>
-            </a:xfrm>
-            <a:custGeom>
-              <a:avLst/>
-              <a:gdLst/>
-              <a:ahLst/>
-              <a:cxnLst/>
-              <a:rect r="r" b="b" t="t" l="l"/>
-              <a:pathLst>
-                <a:path h="3028120" w="5734099">
-                  <a:moveTo>
-                    <a:pt x="63500" y="74930"/>
-                  </a:moveTo>
-                  <a:cubicBezTo>
-                    <a:pt x="91440" y="30480"/>
-                    <a:pt x="140970" y="0"/>
-                    <a:pt x="216920" y="0"/>
-                  </a:cubicBezTo>
-                  <a:lnTo>
-                    <a:pt x="5575349" y="0"/>
-                  </a:lnTo>
-                  <a:cubicBezTo>
-                    <a:pt x="5662979" y="0"/>
-                    <a:pt x="5734099" y="71120"/>
-                    <a:pt x="5734099" y="158750"/>
-                  </a:cubicBezTo>
-                  <a:lnTo>
-                    <a:pt x="5734099" y="2826190"/>
-                  </a:lnTo>
-                  <a:cubicBezTo>
-                    <a:pt x="5734099" y="2878260"/>
-                    <a:pt x="5708699" y="2923980"/>
-                    <a:pt x="5670599" y="2953190"/>
-                  </a:cubicBezTo>
-                  <a:cubicBezTo>
-                    <a:pt x="5642659" y="2997640"/>
-                    <a:pt x="5593129" y="3028120"/>
-                    <a:pt x="5535979" y="3028120"/>
-                  </a:cubicBezTo>
-                  <a:lnTo>
-                    <a:pt x="158750" y="3028120"/>
-                  </a:lnTo>
-                  <a:cubicBezTo>
-                    <a:pt x="71120" y="3028120"/>
-                    <a:pt x="0" y="2957000"/>
-                    <a:pt x="0" y="2869370"/>
-                  </a:cubicBezTo>
-                  <a:lnTo>
-                    <a:pt x="0" y="208926"/>
-                  </a:lnTo>
-                  <a:cubicBezTo>
-                    <a:pt x="0" y="149860"/>
-                    <a:pt x="25400" y="104140"/>
-                    <a:pt x="63500" y="74930"/>
-                  </a:cubicBezTo>
-                  <a:close/>
-                  <a:moveTo>
-                    <a:pt x="5721399" y="2826190"/>
-                  </a:moveTo>
-                  <a:lnTo>
-                    <a:pt x="5721399" y="158750"/>
-                  </a:lnTo>
-                  <a:cubicBezTo>
-                    <a:pt x="5721399" y="78740"/>
-                    <a:pt x="5655359" y="12700"/>
-                    <a:pt x="5575349" y="12700"/>
-                  </a:cubicBezTo>
-                  <a:lnTo>
-                    <a:pt x="216920" y="12700"/>
-                  </a:lnTo>
-                  <a:cubicBezTo>
-                    <a:pt x="118110" y="12700"/>
-                    <a:pt x="52070" y="78740"/>
-                    <a:pt x="52070" y="158750"/>
-                  </a:cubicBezTo>
-                  <a:lnTo>
-                    <a:pt x="52070" y="2826190"/>
-                  </a:lnTo>
-                  <a:cubicBezTo>
-                    <a:pt x="52070" y="2906200"/>
-                    <a:pt x="118110" y="2972240"/>
-                    <a:pt x="216920" y="2972240"/>
-                  </a:cubicBezTo>
-                  <a:lnTo>
-                    <a:pt x="5575349" y="2972240"/>
-                  </a:lnTo>
-                  <a:cubicBezTo>
-                    <a:pt x="5655359" y="2972240"/>
-                    <a:pt x="5721399" y="2907470"/>
-                    <a:pt x="5721399" y="2826190"/>
-                  </a:cubicBezTo>
-                  <a:close/>
-                </a:path>
-              </a:pathLst>
-            </a:custGeom>
-            <a:solidFill>
-              <a:srgbClr val="C9A84C"/>
-            </a:solidFill>
-          </p:spPr>
-        </p:sp>
-      </p:grpSp>
-      <p:sp>
-        <p:nvSpPr>
-          <p:cNvPr id="5" name="Rectangle 4"/>
+      <p:sp>
+        <p:nvSpPr>
+          <p:cNvPr id="2" name="Rectangle 1"/>
           <p:cNvSpPr/>
           <p:nvPr/>
         </p:nvSpPr>
         <p:spPr>
           <a:xfrm>
             <a:off x="0" y="0"/>
-            <a:ext cx="18288000" cy="109728"/>
+            <a:ext cx="18288000" cy="10287000"/>
           </a:xfrm>
           <a:prstGeom prst="rect">
             <a:avLst/>
           </a:prstGeom>
           <a:solidFill>
-            <a:srgbClr val="C9A84C"/>
+            <a:srgbClr val="1A2A4A"/>
           </a:solidFill>
           <a:ln>
             <a:noFill/>
@@ -7320,61 +7240,14 @@
       </p:sp>
       <p:sp>
         <p:nvSpPr>
-          <p:cNvPr id="6" name="TextBox 5"/>
-          <p:cNvSpPr txBox="1"/>
+          <p:cNvPr id="3" name="Rectangle 2"/>
+          <p:cNvSpPr/>
           <p:nvPr/>
         </p:nvSpPr>
         <p:spPr>
           <a:xfrm>
-            <a:off x="457200" y="182880"/>
-            <a:ext cx="17373600" cy="1188720"/>
-          </a:xfrm>
-          <a:prstGeom prst="rect">
-            <a:avLst/>
-          </a:prstGeom>
-          <a:noFill/>
-        </p:spPr>
-        <p:txBody>
-          <a:bodyPr wrap="square">
-            <a:spAutoFit/>
-          </a:bodyPr>
-          <a:lstStyle/>
-          <a:p>
-            <a:pPr algn="r"/>
-            <a:r>
-              <a:rPr sz="3200" b="1">
-                <a:solidFill>
-                  <a:srgbClr val="C9A84C"/>
-                </a:solidFill>
-                <a:latin typeface="Noto Sans Arabic"/>
-              </a:rPr>
-              <a:t>كيف تُجسّد بوابة الجود أحكام القانون؟</a:t>
-            </a:r>
-          </a:p>
-          <a:p>
-            <a:pPr algn="r"/>
-            <a:r>
-              <a:rPr sz="1300" b="0">
-                <a:solidFill>
-                  <a:srgbClr val="CCCCCC"/>
-                </a:solidFill>
-                <a:latin typeface="Noto Sans Arabic"/>
-              </a:rPr>
-              <a:t>Al Jood Portal — Compliance with Child Digital Safety Law</a:t>
-            </a:r>
-          </a:p>
-        </p:txBody>
-      </p:sp>
-      <p:sp>
-        <p:nvSpPr>
-          <p:cNvPr id="7" name="Rectangle 6"/>
-          <p:cNvSpPr/>
-          <p:nvPr/>
-        </p:nvSpPr>
-        <p:spPr>
-          <a:xfrm>
-            <a:off x="365760" y="1600200"/>
-            <a:ext cx="6217920" cy="594360"/>
+            <a:off x="0" y="0"/>
+            <a:ext cx="18288000" cy="118872"/>
           </a:xfrm>
           <a:prstGeom prst="rect">
             <a:avLst/>
@@ -7401,43 +7274,32 @@
           </a:fontRef>
         </p:style>
         <p:txBody>
-          <a:bodyPr rtlCol="0" anchor="ctr" wrap="square"/>
+          <a:bodyPr rtlCol="0" anchor="ctr"/>
           <a:lstStyle/>
           <a:p>
             <a:pPr algn="ctr"/>
-            <a:r>
-              <a:rPr sz="1600" b="1">
-                <a:solidFill>
-                  <a:srgbClr val="1A2A4A"/>
-                </a:solidFill>
-                <a:latin typeface="Noto Sans Arabic"/>
-              </a:rPr>
-              <a:t>متطلب القانون</a:t>
-            </a:r>
-          </a:p>
-        </p:txBody>
-      </p:sp>
-      <p:sp>
-        <p:nvSpPr>
-          <p:cNvPr id="8" name="Rectangle 7"/>
+          </a:p>
+        </p:txBody>
+      </p:sp>
+      <p:sp>
+        <p:nvSpPr>
+          <p:cNvPr id="4" name="Rectangle 3"/>
           <p:cNvSpPr/>
           <p:nvPr/>
         </p:nvSpPr>
         <p:spPr>
           <a:xfrm>
-            <a:off x="6858000" y="1600200"/>
-            <a:ext cx="9326880" cy="594360"/>
+            <a:off x="0" y="10058400"/>
+            <a:ext cx="18288000" cy="228600"/>
           </a:xfrm>
           <a:prstGeom prst="rect">
             <a:avLst/>
           </a:prstGeom>
           <a:solidFill>
-            <a:srgbClr val="1E345C"/>
+            <a:srgbClr val="C9A84C"/>
           </a:solidFill>
-          <a:ln w="12700">
-            <a:solidFill>
-              <a:srgbClr val="C9A84C"/>
-            </a:solidFill>
+          <a:ln>
+            <a:noFill/>
           </a:ln>
         </p:spPr>
         <p:style>
@@ -7455,43 +7317,100 @@
           </a:fontRef>
         </p:style>
         <p:txBody>
-          <a:bodyPr rtlCol="0" anchor="ctr" wrap="square"/>
+          <a:bodyPr rtlCol="0" anchor="ctr"/>
           <a:lstStyle/>
           <a:p>
             <a:pPr algn="ctr"/>
-            <a:r>
-              <a:rPr sz="1600" b="1">
+          </a:p>
+        </p:txBody>
+      </p:sp>
+      <p:sp>
+        <p:nvSpPr>
+          <p:cNvPr id="5" name="TextBox 4"/>
+          <p:cNvSpPr txBox="1"/>
+          <p:nvPr/>
+        </p:nvSpPr>
+        <p:spPr>
+          <a:xfrm>
+            <a:off x="274320" y="182880"/>
+            <a:ext cx="17739360" cy="594360"/>
+          </a:xfrm>
+          <a:prstGeom prst="rect">
+            <a:avLst/>
+          </a:prstGeom>
+          <a:noFill/>
+        </p:spPr>
+        <p:txBody>
+          <a:bodyPr wrap="square">
+            <a:spAutoFit/>
+          </a:bodyPr>
+          <a:lstStyle/>
+          <a:p>
+            <a:pPr algn="r"/>
+            <a:r>
+              <a:rPr sz="2600" b="1" i="0">
                 <a:solidFill>
                   <a:srgbClr val="C9A84C"/>
                 </a:solidFill>
-                <a:latin typeface="Noto Sans Arabic"/>
               </a:rPr>
-              <a:t>ميزة بوابة الجود</a:t>
-            </a:r>
-          </a:p>
-        </p:txBody>
-      </p:sp>
-      <p:sp>
-        <p:nvSpPr>
-          <p:cNvPr id="9" name="Rectangle 8"/>
+              <a:t>كيف تُجسّد بوابة الجود أحكام القانون؟</a:t>
+            </a:r>
+          </a:p>
+        </p:txBody>
+      </p:sp>
+      <p:sp>
+        <p:nvSpPr>
+          <p:cNvPr id="6" name="TextBox 5"/>
+          <p:cNvSpPr txBox="1"/>
+          <p:nvPr/>
+        </p:nvSpPr>
+        <p:spPr>
+          <a:xfrm>
+            <a:off x="274320" y="777240"/>
+            <a:ext cx="17739360" cy="292608"/>
+          </a:xfrm>
+          <a:prstGeom prst="rect">
+            <a:avLst/>
+          </a:prstGeom>
+          <a:noFill/>
+        </p:spPr>
+        <p:txBody>
+          <a:bodyPr wrap="square">
+            <a:spAutoFit/>
+          </a:bodyPr>
+          <a:lstStyle/>
+          <a:p>
+            <a:pPr algn="r"/>
+            <a:r>
+              <a:rPr sz="1200" b="0" i="1">
+                <a:solidFill>
+                  <a:srgbClr val="FFFFFF"/>
+                </a:solidFill>
+              </a:rPr>
+              <a:t>Al Jood Portal — Compliance with Child Digital Safety Law</a:t>
+            </a:r>
+          </a:p>
+        </p:txBody>
+      </p:sp>
+      <p:sp>
+        <p:nvSpPr>
+          <p:cNvPr id="7" name="Rectangle 6"/>
           <p:cNvSpPr/>
           <p:nvPr/>
         </p:nvSpPr>
         <p:spPr>
           <a:xfrm>
-            <a:off x="365760" y="2331720"/>
-            <a:ext cx="6217920" cy="1234440"/>
+            <a:off x="274320" y="1234440"/>
+            <a:ext cx="8229600" cy="502920"/>
           </a:xfrm>
           <a:prstGeom prst="rect">
             <a:avLst/>
           </a:prstGeom>
           <a:solidFill>
-            <a:srgbClr val="1A2A4A"/>
+            <a:srgbClr val="C9A84C"/>
           </a:solidFill>
-          <a:ln w="3810">
-            <a:solidFill>
-              <a:srgbClr val="C9A84C"/>
-            </a:solidFill>
+          <a:ln>
+            <a:noFill/>
           </a:ln>
         </p:spPr>
         <p:style>
@@ -7509,40 +7428,65 @@
           </a:fontRef>
         </p:style>
         <p:txBody>
-          <a:bodyPr rtlCol="0" anchor="ctr" wrap="square"/>
-          <a:lstStyle/>
-          <a:p>
-            <a:pPr algn="r"/>
-            <a:r>
-              <a:rPr sz="1400" b="1">
+          <a:bodyPr rtlCol="0" anchor="ctr"/>
+          <a:lstStyle/>
+          <a:p>
+            <a:pPr algn="ctr"/>
+          </a:p>
+        </p:txBody>
+      </p:sp>
+      <p:sp>
+        <p:nvSpPr>
+          <p:cNvPr id="8" name="TextBox 7"/>
+          <p:cNvSpPr txBox="1"/>
+          <p:nvPr/>
+        </p:nvSpPr>
+        <p:spPr>
+          <a:xfrm>
+            <a:off x="274320" y="1261872"/>
+            <a:ext cx="8138160" cy="457200"/>
+          </a:xfrm>
+          <a:prstGeom prst="rect">
+            <a:avLst/>
+          </a:prstGeom>
+          <a:noFill/>
+        </p:spPr>
+        <p:txBody>
+          <a:bodyPr wrap="square">
+            <a:spAutoFit/>
+          </a:bodyPr>
+          <a:lstStyle/>
+          <a:p>
+            <a:pPr algn="ctr"/>
+            <a:r>
+              <a:rPr sz="1500" b="1" i="0">
                 <a:solidFill>
-                  <a:srgbClr val="F3E5B8"/>
+                  <a:srgbClr val="1A2A4A"/>
                 </a:solidFill>
-                <a:latin typeface="Noto Sans Arabic"/>
               </a:rPr>
-              <a:t>حماية البيانات الرقمية</a:t>
-            </a:r>
-          </a:p>
-        </p:txBody>
-      </p:sp>
-      <p:sp>
-        <p:nvSpPr>
-          <p:cNvPr id="10" name="Rectangle 9"/>
+              <a:t>متطلب القانون</a:t>
+            </a:r>
+          </a:p>
+        </p:txBody>
+      </p:sp>
+      <p:sp>
+        <p:nvSpPr>
+          <p:cNvPr id="9" name="Rectangle 8"/>
           <p:cNvSpPr/>
           <p:nvPr/>
         </p:nvSpPr>
         <p:spPr>
           <a:xfrm>
-            <a:off x="6858000" y="2331720"/>
-            <a:ext cx="9326880" cy="1234440"/>
+            <a:off x="8686800" y="1234440"/>
+            <a:ext cx="9281160" cy="502920"/>
           </a:xfrm>
           <a:prstGeom prst="rect">
             <a:avLst/>
           </a:prstGeom>
           <a:solidFill>
-            <a:srgbClr val="1A2A4A"/>
+            <a:srgbClr val="243860"/>
           </a:solidFill>
-          <a:ln w="3810">
+          <a:ln w="12700">
             <a:solidFill>
               <a:srgbClr val="C9A84C"/>
             </a:solidFill>
@@ -7563,18 +7507,43 @@
           </a:fontRef>
         </p:style>
         <p:txBody>
-          <a:bodyPr rtlCol="0" anchor="ctr" wrap="square"/>
-          <a:lstStyle/>
-          <a:p>
-            <a:pPr algn="r"/>
-            <a:r>
-              <a:rPr sz="1200" b="0">
+          <a:bodyPr rtlCol="0" anchor="ctr"/>
+          <a:lstStyle/>
+          <a:p>
+            <a:pPr algn="ctr"/>
+          </a:p>
+        </p:txBody>
+      </p:sp>
+      <p:sp>
+        <p:nvSpPr>
+          <p:cNvPr id="10" name="TextBox 9"/>
+          <p:cNvSpPr txBox="1"/>
+          <p:nvPr/>
+        </p:nvSpPr>
+        <p:spPr>
+          <a:xfrm>
+            <a:off x="8686800" y="1261872"/>
+            <a:ext cx="9189720" cy="457200"/>
+          </a:xfrm>
+          <a:prstGeom prst="rect">
+            <a:avLst/>
+          </a:prstGeom>
+          <a:noFill/>
+        </p:spPr>
+        <p:txBody>
+          <a:bodyPr wrap="square">
+            <a:spAutoFit/>
+          </a:bodyPr>
+          <a:lstStyle/>
+          <a:p>
+            <a:pPr algn="ctr"/>
+            <a:r>
+              <a:rPr sz="1500" b="1" i="0">
                 <a:solidFill>
-                  <a:srgbClr val="FFFFFF"/>
+                  <a:srgbClr val="C9A84C"/>
                 </a:solidFill>
-                <a:latin typeface="Noto Sans Arabic"/>
               </a:rPr>
-              <a:t>localStorage فقط — لا سحابة خارجية، بيانات محلية آمنة بالكامل</a:t>
+              <a:t>ميزة بوابة الجود</a:t>
             </a:r>
           </a:p>
         </p:txBody>
@@ -7587,17 +7556,19 @@
         </p:nvSpPr>
         <p:spPr>
           <a:xfrm>
-            <a:off x="16322039" y="2724912"/>
-            <a:ext cx="457200" cy="457200"/>
+            <a:off x="274320" y="1783080"/>
+            <a:ext cx="8229600" cy="804672"/>
           </a:xfrm>
           <a:prstGeom prst="rect">
             <a:avLst/>
           </a:prstGeom>
           <a:solidFill>
-            <a:srgbClr val="2E7D32"/>
+            <a:srgbClr val="243860"/>
           </a:solidFill>
-          <a:ln>
-            <a:noFill/>
+          <a:ln w="6350">
+            <a:solidFill>
+              <a:srgbClr val="C9A84C"/>
+            </a:solidFill>
           </a:ln>
         </p:spPr>
         <p:style>
@@ -7615,40 +7586,65 @@
           </a:fontRef>
         </p:style>
         <p:txBody>
-          <a:bodyPr rtlCol="0" anchor="ctr" wrap="square"/>
+          <a:bodyPr rtlCol="0" anchor="ctr"/>
           <a:lstStyle/>
           <a:p>
             <a:pPr algn="ctr"/>
-            <a:r>
-              <a:rPr sz="900" b="1">
+          </a:p>
+        </p:txBody>
+      </p:sp>
+      <p:sp>
+        <p:nvSpPr>
+          <p:cNvPr id="12" name="TextBox 11"/>
+          <p:cNvSpPr txBox="1"/>
+          <p:nvPr/>
+        </p:nvSpPr>
+        <p:spPr>
+          <a:xfrm>
+            <a:off x="320040" y="1965960"/>
+            <a:ext cx="8046720" cy="457200"/>
+          </a:xfrm>
+          <a:prstGeom prst="rect">
+            <a:avLst/>
+          </a:prstGeom>
+          <a:noFill/>
+        </p:spPr>
+        <p:txBody>
+          <a:bodyPr wrap="square">
+            <a:spAutoFit/>
+          </a:bodyPr>
+          <a:lstStyle/>
+          <a:p>
+            <a:pPr algn="ctr"/>
+            <a:r>
+              <a:rPr sz="1400" b="1" i="0">
                 <a:solidFill>
                   <a:srgbClr val="FFFFFF"/>
                 </a:solidFill>
-                <a:latin typeface="Noto Sans Arabic"/>
               </a:rPr>
-              <a:t>OK</a:t>
-            </a:r>
-          </a:p>
-        </p:txBody>
-      </p:sp>
-      <p:sp>
-        <p:nvSpPr>
-          <p:cNvPr id="12" name="Rectangle 11"/>
+              <a:t>حماية البيانات الرقمية</a:t>
+            </a:r>
+          </a:p>
+        </p:txBody>
+      </p:sp>
+      <p:sp>
+        <p:nvSpPr>
+          <p:cNvPr id="13" name="Rectangle 12"/>
           <p:cNvSpPr/>
           <p:nvPr/>
         </p:nvSpPr>
         <p:spPr>
           <a:xfrm>
-            <a:off x="365760" y="3657600"/>
-            <a:ext cx="6217920" cy="1234440"/>
+            <a:off x="8686800" y="1783080"/>
+            <a:ext cx="9281160" cy="804672"/>
           </a:xfrm>
           <a:prstGeom prst="rect">
             <a:avLst/>
           </a:prstGeom>
           <a:solidFill>
-            <a:srgbClr val="1E345C"/>
+            <a:srgbClr val="243860"/>
           </a:solidFill>
-          <a:ln w="3810">
+          <a:ln w="6350">
             <a:solidFill>
               <a:srgbClr val="C9A84C"/>
             </a:solidFill>
@@ -7669,43 +7665,32 @@
           </a:fontRef>
         </p:style>
         <p:txBody>
-          <a:bodyPr rtlCol="0" anchor="ctr" wrap="square"/>
-          <a:lstStyle/>
-          <a:p>
-            <a:pPr algn="r"/>
-            <a:r>
-              <a:rPr sz="1400" b="1">
-                <a:solidFill>
-                  <a:srgbClr val="F3E5B8"/>
-                </a:solidFill>
-                <a:latin typeface="Noto Sans Arabic"/>
-              </a:rPr>
-              <a:t>توثيق هوية المستخدمين</a:t>
-            </a:r>
-          </a:p>
-        </p:txBody>
-      </p:sp>
-      <p:sp>
-        <p:nvSpPr>
-          <p:cNvPr id="13" name="Rectangle 12"/>
+          <a:bodyPr rtlCol="0" anchor="ctr"/>
+          <a:lstStyle/>
+          <a:p>
+            <a:pPr algn="ctr"/>
+          </a:p>
+        </p:txBody>
+      </p:sp>
+      <p:sp>
+        <p:nvSpPr>
+          <p:cNvPr id="14" name="Rectangle 13"/>
           <p:cNvSpPr/>
           <p:nvPr/>
         </p:nvSpPr>
         <p:spPr>
           <a:xfrm>
-            <a:off x="6858000" y="3657600"/>
-            <a:ext cx="9326880" cy="1234440"/>
+            <a:off x="8686800" y="1984248"/>
+            <a:ext cx="502920" cy="384048"/>
           </a:xfrm>
           <a:prstGeom prst="rect">
             <a:avLst/>
           </a:prstGeom>
           <a:solidFill>
-            <a:srgbClr val="1E345C"/>
+            <a:srgbClr val="2ECC71"/>
           </a:solidFill>
-          <a:ln w="3810">
-            <a:solidFill>
-              <a:srgbClr val="C9A84C"/>
-            </a:solidFill>
+          <a:ln>
+            <a:noFill/>
           </a:ln>
         </p:spPr>
         <p:style>
@@ -7723,41 +7708,102 @@
           </a:fontRef>
         </p:style>
         <p:txBody>
-          <a:bodyPr rtlCol="0" anchor="ctr" wrap="square"/>
-          <a:lstStyle/>
-          <a:p>
-            <a:pPr algn="r"/>
-            <a:r>
-              <a:rPr sz="1200" b="0">
+          <a:bodyPr rtlCol="0" anchor="ctr"/>
+          <a:lstStyle/>
+          <a:p>
+            <a:pPr algn="ctr"/>
+          </a:p>
+        </p:txBody>
+      </p:sp>
+      <p:sp>
+        <p:nvSpPr>
+          <p:cNvPr id="15" name="TextBox 14"/>
+          <p:cNvSpPr txBox="1"/>
+          <p:nvPr/>
+        </p:nvSpPr>
+        <p:spPr>
+          <a:xfrm>
+            <a:off x="8695944" y="2002536"/>
+            <a:ext cx="484632" cy="347472"/>
+          </a:xfrm>
+          <a:prstGeom prst="rect">
+            <a:avLst/>
+          </a:prstGeom>
+          <a:noFill/>
+        </p:spPr>
+        <p:txBody>
+          <a:bodyPr wrap="square">
+            <a:spAutoFit/>
+          </a:bodyPr>
+          <a:lstStyle/>
+          <a:p>
+            <a:pPr algn="ctr"/>
+            <a:r>
+              <a:rPr sz="1100" b="1" i="0">
                 <a:solidFill>
                   <a:srgbClr val="FFFFFF"/>
                 </a:solidFill>
-                <a:latin typeface="Noto Sans Arabic"/>
               </a:rPr>
-              <a:t>5 مستويات دخول مستقلة: مدير، مديرة، معلم، إداري، ولي أمر</a:t>
-            </a:r>
-          </a:p>
-        </p:txBody>
-      </p:sp>
-      <p:sp>
-        <p:nvSpPr>
-          <p:cNvPr id="14" name="Rectangle 13"/>
+              <a:t>OK</a:t>
+            </a:r>
+          </a:p>
+        </p:txBody>
+      </p:sp>
+      <p:sp>
+        <p:nvSpPr>
+          <p:cNvPr id="16" name="TextBox 15"/>
+          <p:cNvSpPr txBox="1"/>
+          <p:nvPr/>
+        </p:nvSpPr>
+        <p:spPr>
+          <a:xfrm>
+            <a:off x="9326880" y="1856231"/>
+            <a:ext cx="8503920" cy="658368"/>
+          </a:xfrm>
+          <a:prstGeom prst="rect">
+            <a:avLst/>
+          </a:prstGeom>
+          <a:noFill/>
+        </p:spPr>
+        <p:txBody>
+          <a:bodyPr wrap="square">
+            <a:spAutoFit/>
+          </a:bodyPr>
+          <a:lstStyle/>
+          <a:p>
+            <a:pPr algn="r"/>
+            <a:r>
+              <a:rPr sz="1200" b="0" i="0">
+                <a:solidFill>
+                  <a:srgbClr val="FFFFFF"/>
+                </a:solidFill>
+              </a:rPr>
+              <a:t>localStorage — بيانات محلية آمنة، لا سحابة خارجية</a:t>
+            </a:r>
+          </a:p>
+        </p:txBody>
+      </p:sp>
+      <p:sp>
+        <p:nvSpPr>
+          <p:cNvPr id="17" name="Rectangle 16"/>
           <p:cNvSpPr/>
           <p:nvPr/>
         </p:nvSpPr>
         <p:spPr>
           <a:xfrm>
-            <a:off x="16322039" y="4050791"/>
-            <a:ext cx="457200" cy="457200"/>
+            <a:off x="274320" y="2624328"/>
+            <a:ext cx="8229600" cy="804672"/>
           </a:xfrm>
           <a:prstGeom prst="rect">
             <a:avLst/>
           </a:prstGeom>
           <a:solidFill>
-            <a:srgbClr val="2E7D32"/>
+            <a:srgbClr val="1E3050"/>
           </a:solidFill>
-          <a:ln>
-            <a:noFill/>
+          <a:ln w="6350">
+            <a:solidFill>
+              <a:srgbClr val="C9A84C"/>
+            </a:solidFill>
           </a:ln>
         </p:spPr>
         <p:style>
@@ -7775,40 +7821,65 @@
           </a:fontRef>
         </p:style>
         <p:txBody>
-          <a:bodyPr rtlCol="0" anchor="ctr" wrap="square"/>
+          <a:bodyPr rtlCol="0" anchor="ctr"/>
           <a:lstStyle/>
           <a:p>
             <a:pPr algn="ctr"/>
-            <a:r>
-              <a:rPr sz="900" b="1">
+          </a:p>
+        </p:txBody>
+      </p:sp>
+      <p:sp>
+        <p:nvSpPr>
+          <p:cNvPr id="18" name="TextBox 17"/>
+          <p:cNvSpPr txBox="1"/>
+          <p:nvPr/>
+        </p:nvSpPr>
+        <p:spPr>
+          <a:xfrm>
+            <a:off x="320040" y="2807208"/>
+            <a:ext cx="8046720" cy="457200"/>
+          </a:xfrm>
+          <a:prstGeom prst="rect">
+            <a:avLst/>
+          </a:prstGeom>
+          <a:noFill/>
+        </p:spPr>
+        <p:txBody>
+          <a:bodyPr wrap="square">
+            <a:spAutoFit/>
+          </a:bodyPr>
+          <a:lstStyle/>
+          <a:p>
+            <a:pPr algn="ctr"/>
+            <a:r>
+              <a:rPr sz="1400" b="1" i="0">
                 <a:solidFill>
                   <a:srgbClr val="FFFFFF"/>
                 </a:solidFill>
-                <a:latin typeface="Noto Sans Arabic"/>
               </a:rPr>
-              <a:t>OK</a:t>
-            </a:r>
-          </a:p>
-        </p:txBody>
-      </p:sp>
-      <p:sp>
-        <p:nvSpPr>
-          <p:cNvPr id="15" name="Rectangle 14"/>
+              <a:t>توثيق هوية المستخدمين</a:t>
+            </a:r>
+          </a:p>
+        </p:txBody>
+      </p:sp>
+      <p:sp>
+        <p:nvSpPr>
+          <p:cNvPr id="19" name="Rectangle 18"/>
           <p:cNvSpPr/>
           <p:nvPr/>
         </p:nvSpPr>
         <p:spPr>
           <a:xfrm>
-            <a:off x="365760" y="4983480"/>
-            <a:ext cx="6217920" cy="1234440"/>
+            <a:off x="8686800" y="2624328"/>
+            <a:ext cx="9281160" cy="804672"/>
           </a:xfrm>
           <a:prstGeom prst="rect">
             <a:avLst/>
           </a:prstGeom>
           <a:solidFill>
-            <a:srgbClr val="1A2A4A"/>
+            <a:srgbClr val="1E3050"/>
           </a:solidFill>
-          <a:ln w="3810">
+          <a:ln w="6350">
             <a:solidFill>
               <a:srgbClr val="C9A84C"/>
             </a:solidFill>
@@ -7829,43 +7900,32 @@
           </a:fontRef>
         </p:style>
         <p:txBody>
-          <a:bodyPr rtlCol="0" anchor="ctr" wrap="square"/>
-          <a:lstStyle/>
-          <a:p>
-            <a:pPr algn="r"/>
-            <a:r>
-              <a:rPr sz="1400" b="1">
-                <a:solidFill>
-                  <a:srgbClr val="F3E5B8"/>
-                </a:solidFill>
-                <a:latin typeface="Noto Sans Arabic"/>
-              </a:rPr>
-              <a:t>رقابة أولياء الأمور</a:t>
-            </a:r>
-          </a:p>
-        </p:txBody>
-      </p:sp>
-      <p:sp>
-        <p:nvSpPr>
-          <p:cNvPr id="16" name="Rectangle 15"/>
+          <a:bodyPr rtlCol="0" anchor="ctr"/>
+          <a:lstStyle/>
+          <a:p>
+            <a:pPr algn="ctr"/>
+          </a:p>
+        </p:txBody>
+      </p:sp>
+      <p:sp>
+        <p:nvSpPr>
+          <p:cNvPr id="20" name="Rectangle 19"/>
           <p:cNvSpPr/>
           <p:nvPr/>
         </p:nvSpPr>
         <p:spPr>
           <a:xfrm>
-            <a:off x="6858000" y="4983480"/>
-            <a:ext cx="9326880" cy="1234440"/>
+            <a:off x="8686800" y="2825496"/>
+            <a:ext cx="502920" cy="384048"/>
           </a:xfrm>
           <a:prstGeom prst="rect">
             <a:avLst/>
           </a:prstGeom>
           <a:solidFill>
-            <a:srgbClr val="1A2A4A"/>
+            <a:srgbClr val="2ECC71"/>
           </a:solidFill>
-          <a:ln w="3810">
-            <a:solidFill>
-              <a:srgbClr val="C9A84C"/>
-            </a:solidFill>
+          <a:ln>
+            <a:noFill/>
           </a:ln>
         </p:spPr>
         <p:style>
@@ -7883,41 +7943,102 @@
           </a:fontRef>
         </p:style>
         <p:txBody>
-          <a:bodyPr rtlCol="0" anchor="ctr" wrap="square"/>
-          <a:lstStyle/>
-          <a:p>
-            <a:pPr algn="r"/>
-            <a:r>
-              <a:rPr sz="1200" b="0">
+          <a:bodyPr rtlCol="0" anchor="ctr"/>
+          <a:lstStyle/>
+          <a:p>
+            <a:pPr algn="ctr"/>
+          </a:p>
+        </p:txBody>
+      </p:sp>
+      <p:sp>
+        <p:nvSpPr>
+          <p:cNvPr id="21" name="TextBox 20"/>
+          <p:cNvSpPr txBox="1"/>
+          <p:nvPr/>
+        </p:nvSpPr>
+        <p:spPr>
+          <a:xfrm>
+            <a:off x="8695944" y="2843784"/>
+            <a:ext cx="484632" cy="347472"/>
+          </a:xfrm>
+          <a:prstGeom prst="rect">
+            <a:avLst/>
+          </a:prstGeom>
+          <a:noFill/>
+        </p:spPr>
+        <p:txBody>
+          <a:bodyPr wrap="square">
+            <a:spAutoFit/>
+          </a:bodyPr>
+          <a:lstStyle/>
+          <a:p>
+            <a:pPr algn="ctr"/>
+            <a:r>
+              <a:rPr sz="1100" b="1" i="0">
                 <a:solidFill>
                   <a:srgbClr val="FFFFFF"/>
                 </a:solidFill>
-                <a:latin typeface="Noto Sans Arabic"/>
               </a:rPr>
-              <a:t>بوابة ولي الأمر — قيد التطوير وإطلاق قريب مع بيانات الطلاب</a:t>
-            </a:r>
-          </a:p>
-        </p:txBody>
-      </p:sp>
-      <p:sp>
-        <p:nvSpPr>
-          <p:cNvPr id="17" name="Rectangle 16"/>
+              <a:t>OK</a:t>
+            </a:r>
+          </a:p>
+        </p:txBody>
+      </p:sp>
+      <p:sp>
+        <p:nvSpPr>
+          <p:cNvPr id="22" name="TextBox 21"/>
+          <p:cNvSpPr txBox="1"/>
+          <p:nvPr/>
+        </p:nvSpPr>
+        <p:spPr>
+          <a:xfrm>
+            <a:off x="9326880" y="2697480"/>
+            <a:ext cx="8503920" cy="658368"/>
+          </a:xfrm>
+          <a:prstGeom prst="rect">
+            <a:avLst/>
+          </a:prstGeom>
+          <a:noFill/>
+        </p:spPr>
+        <p:txBody>
+          <a:bodyPr wrap="square">
+            <a:spAutoFit/>
+          </a:bodyPr>
+          <a:lstStyle/>
+          <a:p>
+            <a:pPr algn="r"/>
+            <a:r>
+              <a:rPr sz="1200" b="0" i="0">
+                <a:solidFill>
+                  <a:srgbClr val="FFFFFF"/>
+                </a:solidFill>
+              </a:rPr>
+              <a:t>5 مستويات دخول مستقلة: مدير، مديرة، معلم، إداري، ولي أمر</a:t>
+            </a:r>
+          </a:p>
+        </p:txBody>
+      </p:sp>
+      <p:sp>
+        <p:nvSpPr>
+          <p:cNvPr id="23" name="Rectangle 22"/>
           <p:cNvSpPr/>
           <p:nvPr/>
         </p:nvSpPr>
         <p:spPr>
           <a:xfrm>
-            <a:off x="16322039" y="5376672"/>
-            <a:ext cx="457200" cy="457200"/>
+            <a:off x="274320" y="3465576"/>
+            <a:ext cx="8229600" cy="804672"/>
           </a:xfrm>
           <a:prstGeom prst="rect">
             <a:avLst/>
           </a:prstGeom>
           <a:solidFill>
-            <a:srgbClr val="2E7D32"/>
+            <a:srgbClr val="243860"/>
           </a:solidFill>
-          <a:ln>
-            <a:noFill/>
+          <a:ln w="6350">
+            <a:solidFill>
+              <a:srgbClr val="C9A84C"/>
+            </a:solidFill>
           </a:ln>
         </p:spPr>
         <p:style>
@@ -7935,40 +8056,65 @@
           </a:fontRef>
         </p:style>
         <p:txBody>
-          <a:bodyPr rtlCol="0" anchor="ctr" wrap="square"/>
+          <a:bodyPr rtlCol="0" anchor="ctr"/>
           <a:lstStyle/>
           <a:p>
             <a:pPr algn="ctr"/>
-            <a:r>
-              <a:rPr sz="900" b="1">
+          </a:p>
+        </p:txBody>
+      </p:sp>
+      <p:sp>
+        <p:nvSpPr>
+          <p:cNvPr id="24" name="TextBox 23"/>
+          <p:cNvSpPr txBox="1"/>
+          <p:nvPr/>
+        </p:nvSpPr>
+        <p:spPr>
+          <a:xfrm>
+            <a:off x="320040" y="3648456"/>
+            <a:ext cx="8046720" cy="457200"/>
+          </a:xfrm>
+          <a:prstGeom prst="rect">
+            <a:avLst/>
+          </a:prstGeom>
+          <a:noFill/>
+        </p:spPr>
+        <p:txBody>
+          <a:bodyPr wrap="square">
+            <a:spAutoFit/>
+          </a:bodyPr>
+          <a:lstStyle/>
+          <a:p>
+            <a:pPr algn="ctr"/>
+            <a:r>
+              <a:rPr sz="1400" b="1" i="0">
                 <a:solidFill>
                   <a:srgbClr val="FFFFFF"/>
                 </a:solidFill>
-                <a:latin typeface="Noto Sans Arabic"/>
               </a:rPr>
-              <a:t>OK</a:t>
-            </a:r>
-          </a:p>
-        </p:txBody>
-      </p:sp>
-      <p:sp>
-        <p:nvSpPr>
-          <p:cNvPr id="18" name="Rectangle 17"/>
+              <a:t>رقابة أولياء الأمور</a:t>
+            </a:r>
+          </a:p>
+        </p:txBody>
+      </p:sp>
+      <p:sp>
+        <p:nvSpPr>
+          <p:cNvPr id="25" name="Rectangle 24"/>
           <p:cNvSpPr/>
           <p:nvPr/>
         </p:nvSpPr>
         <p:spPr>
           <a:xfrm>
-            <a:off x="365760" y="6309360"/>
-            <a:ext cx="6217920" cy="1234440"/>
+            <a:off x="8686800" y="3465576"/>
+            <a:ext cx="9281160" cy="804672"/>
           </a:xfrm>
           <a:prstGeom prst="rect">
             <a:avLst/>
           </a:prstGeom>
           <a:solidFill>
-            <a:srgbClr val="1E345C"/>
+            <a:srgbClr val="243860"/>
           </a:solidFill>
-          <a:ln w="3810">
+          <a:ln w="6350">
             <a:solidFill>
               <a:srgbClr val="C9A84C"/>
             </a:solidFill>
@@ -7989,43 +8135,32 @@
           </a:fontRef>
         </p:style>
         <p:txBody>
-          <a:bodyPr rtlCol="0" anchor="ctr" wrap="square"/>
-          <a:lstStyle/>
-          <a:p>
-            <a:pPr algn="r"/>
-            <a:r>
-              <a:rPr sz="1400" b="1">
-                <a:solidFill>
-                  <a:srgbClr val="F3E5B8"/>
-                </a:solidFill>
-                <a:latin typeface="Noto Sans Arabic"/>
-              </a:rPr>
-              <a:t>الإبلاغ عن الاختراقات</a:t>
-            </a:r>
-          </a:p>
-        </p:txBody>
-      </p:sp>
-      <p:sp>
-        <p:nvSpPr>
-          <p:cNvPr id="19" name="Rectangle 18"/>
+          <a:bodyPr rtlCol="0" anchor="ctr"/>
+          <a:lstStyle/>
+          <a:p>
+            <a:pPr algn="ctr"/>
+          </a:p>
+        </p:txBody>
+      </p:sp>
+      <p:sp>
+        <p:nvSpPr>
+          <p:cNvPr id="26" name="Rectangle 25"/>
           <p:cNvSpPr/>
           <p:nvPr/>
         </p:nvSpPr>
         <p:spPr>
           <a:xfrm>
-            <a:off x="6858000" y="6309360"/>
-            <a:ext cx="9326880" cy="1234440"/>
+            <a:off x="8686800" y="3666744"/>
+            <a:ext cx="502920" cy="384048"/>
           </a:xfrm>
           <a:prstGeom prst="rect">
             <a:avLst/>
           </a:prstGeom>
           <a:solidFill>
-            <a:srgbClr val="1E345C"/>
+            <a:srgbClr val="2ECC71"/>
           </a:solidFill>
-          <a:ln w="3810">
-            <a:solidFill>
-              <a:srgbClr val="C9A84C"/>
-            </a:solidFill>
+          <a:ln>
+            <a:noFill/>
           </a:ln>
         </p:spPr>
         <p:style>
@@ -8043,41 +8178,102 @@
           </a:fontRef>
         </p:style>
         <p:txBody>
-          <a:bodyPr rtlCol="0" anchor="ctr" wrap="square"/>
-          <a:lstStyle/>
-          <a:p>
-            <a:pPr algn="r"/>
-            <a:r>
-              <a:rPr sz="1200" b="0">
+          <a:bodyPr rtlCol="0" anchor="ctr"/>
+          <a:lstStyle/>
+          <a:p>
+            <a:pPr algn="ctr"/>
+          </a:p>
+        </p:txBody>
+      </p:sp>
+      <p:sp>
+        <p:nvSpPr>
+          <p:cNvPr id="27" name="TextBox 26"/>
+          <p:cNvSpPr txBox="1"/>
+          <p:nvPr/>
+        </p:nvSpPr>
+        <p:spPr>
+          <a:xfrm>
+            <a:off x="8695944" y="3685032"/>
+            <a:ext cx="484632" cy="347472"/>
+          </a:xfrm>
+          <a:prstGeom prst="rect">
+            <a:avLst/>
+          </a:prstGeom>
+          <a:noFill/>
+        </p:spPr>
+        <p:txBody>
+          <a:bodyPr wrap="square">
+            <a:spAutoFit/>
+          </a:bodyPr>
+          <a:lstStyle/>
+          <a:p>
+            <a:pPr algn="ctr"/>
+            <a:r>
+              <a:rPr sz="1100" b="1" i="0">
                 <a:solidFill>
                   <a:srgbClr val="FFFFFF"/>
                 </a:solidFill>
-                <a:latin typeface="Noto Sans Arabic"/>
               </a:rPr>
-              <a:t>سجل تدقيق مدمج — كل عملية دخول أو تعديل موثّقة تلقائياً</a:t>
-            </a:r>
-          </a:p>
-        </p:txBody>
-      </p:sp>
-      <p:sp>
-        <p:nvSpPr>
-          <p:cNvPr id="20" name="Rectangle 19"/>
+              <a:t>OK</a:t>
+            </a:r>
+          </a:p>
+        </p:txBody>
+      </p:sp>
+      <p:sp>
+        <p:nvSpPr>
+          <p:cNvPr id="28" name="TextBox 27"/>
+          <p:cNvSpPr txBox="1"/>
+          <p:nvPr/>
+        </p:nvSpPr>
+        <p:spPr>
+          <a:xfrm>
+            <a:off x="9326880" y="3538728"/>
+            <a:ext cx="8503920" cy="658368"/>
+          </a:xfrm>
+          <a:prstGeom prst="rect">
+            <a:avLst/>
+          </a:prstGeom>
+          <a:noFill/>
+        </p:spPr>
+        <p:txBody>
+          <a:bodyPr wrap="square">
+            <a:spAutoFit/>
+          </a:bodyPr>
+          <a:lstStyle/>
+          <a:p>
+            <a:pPr algn="r"/>
+            <a:r>
+              <a:rPr sz="1200" b="0" i="0">
+                <a:solidFill>
+                  <a:srgbClr val="FFFFFF"/>
+                </a:solidFill>
+              </a:rPr>
+              <a:t>بوابة ولي الأمر — قيد التطوير وإطلاق قريب مع بيانات الطلاب</a:t>
+            </a:r>
+          </a:p>
+        </p:txBody>
+      </p:sp>
+      <p:sp>
+        <p:nvSpPr>
+          <p:cNvPr id="29" name="Rectangle 28"/>
           <p:cNvSpPr/>
           <p:nvPr/>
         </p:nvSpPr>
         <p:spPr>
           <a:xfrm>
-            <a:off x="16322039" y="6702552"/>
-            <a:ext cx="457200" cy="457200"/>
+            <a:off x="274320" y="4306824"/>
+            <a:ext cx="8229600" cy="804672"/>
           </a:xfrm>
           <a:prstGeom prst="rect">
             <a:avLst/>
           </a:prstGeom>
           <a:solidFill>
-            <a:srgbClr val="2E7D32"/>
+            <a:srgbClr val="1E3050"/>
           </a:solidFill>
-          <a:ln>
-            <a:noFill/>
+          <a:ln w="6350">
+            <a:solidFill>
+              <a:srgbClr val="C9A84C"/>
+            </a:solidFill>
           </a:ln>
         </p:spPr>
         <p:style>
@@ -8095,40 +8291,65 @@
           </a:fontRef>
         </p:style>
         <p:txBody>
-          <a:bodyPr rtlCol="0" anchor="ctr" wrap="square"/>
+          <a:bodyPr rtlCol="0" anchor="ctr"/>
           <a:lstStyle/>
           <a:p>
             <a:pPr algn="ctr"/>
-            <a:r>
-              <a:rPr sz="900" b="1">
+          </a:p>
+        </p:txBody>
+      </p:sp>
+      <p:sp>
+        <p:nvSpPr>
+          <p:cNvPr id="30" name="TextBox 29"/>
+          <p:cNvSpPr txBox="1"/>
+          <p:nvPr/>
+        </p:nvSpPr>
+        <p:spPr>
+          <a:xfrm>
+            <a:off x="320040" y="4489704"/>
+            <a:ext cx="8046720" cy="457200"/>
+          </a:xfrm>
+          <a:prstGeom prst="rect">
+            <a:avLst/>
+          </a:prstGeom>
+          <a:noFill/>
+        </p:spPr>
+        <p:txBody>
+          <a:bodyPr wrap="square">
+            <a:spAutoFit/>
+          </a:bodyPr>
+          <a:lstStyle/>
+          <a:p>
+            <a:pPr algn="ctr"/>
+            <a:r>
+              <a:rPr sz="1400" b="1" i="0">
                 <a:solidFill>
                   <a:srgbClr val="FFFFFF"/>
                 </a:solidFill>
-                <a:latin typeface="Noto Sans Arabic"/>
               </a:rPr>
-              <a:t>OK</a:t>
-            </a:r>
-          </a:p>
-        </p:txBody>
-      </p:sp>
-      <p:sp>
-        <p:nvSpPr>
-          <p:cNvPr id="21" name="Rectangle 20"/>
+              <a:t>الإبلاغ عن الاختراقات</a:t>
+            </a:r>
+          </a:p>
+        </p:txBody>
+      </p:sp>
+      <p:sp>
+        <p:nvSpPr>
+          <p:cNvPr id="31" name="Rectangle 30"/>
           <p:cNvSpPr/>
           <p:nvPr/>
         </p:nvSpPr>
         <p:spPr>
           <a:xfrm>
-            <a:off x="365760" y="7635240"/>
-            <a:ext cx="6217920" cy="1234440"/>
+            <a:off x="8686800" y="4306824"/>
+            <a:ext cx="9281160" cy="804672"/>
           </a:xfrm>
           <a:prstGeom prst="rect">
             <a:avLst/>
           </a:prstGeom>
           <a:solidFill>
-            <a:srgbClr val="1A2A4A"/>
+            <a:srgbClr val="1E3050"/>
           </a:solidFill>
-          <a:ln w="3810">
+          <a:ln w="6350">
             <a:solidFill>
               <a:srgbClr val="C9A84C"/>
             </a:solidFill>
@@ -8149,43 +8370,32 @@
           </a:fontRef>
         </p:style>
         <p:txBody>
-          <a:bodyPr rtlCol="0" anchor="ctr" wrap="square"/>
-          <a:lstStyle/>
-          <a:p>
-            <a:pPr algn="r"/>
-            <a:r>
-              <a:rPr sz="1400" b="1">
-                <a:solidFill>
-                  <a:srgbClr val="F3E5B8"/>
-                </a:solidFill>
-                <a:latin typeface="Noto Sans Arabic"/>
-              </a:rPr>
-              <a:t>ضبط الصلاحيات</a:t>
-            </a:r>
-          </a:p>
-        </p:txBody>
-      </p:sp>
-      <p:sp>
-        <p:nvSpPr>
-          <p:cNvPr id="22" name="Rectangle 21"/>
+          <a:bodyPr rtlCol="0" anchor="ctr"/>
+          <a:lstStyle/>
+          <a:p>
+            <a:pPr algn="ctr"/>
+          </a:p>
+        </p:txBody>
+      </p:sp>
+      <p:sp>
+        <p:nvSpPr>
+          <p:cNvPr id="32" name="Rectangle 31"/>
           <p:cNvSpPr/>
           <p:nvPr/>
         </p:nvSpPr>
         <p:spPr>
           <a:xfrm>
-            <a:off x="6858000" y="7635240"/>
-            <a:ext cx="9326880" cy="1234440"/>
+            <a:off x="8686800" y="4507992"/>
+            <a:ext cx="502920" cy="384048"/>
           </a:xfrm>
           <a:prstGeom prst="rect">
             <a:avLst/>
           </a:prstGeom>
           <a:solidFill>
-            <a:srgbClr val="1A2A4A"/>
+            <a:srgbClr val="2ECC71"/>
           </a:solidFill>
-          <a:ln w="3810">
-            <a:solidFill>
-              <a:srgbClr val="C9A84C"/>
-            </a:solidFill>
+          <a:ln>
+            <a:noFill/>
           </a:ln>
         </p:spPr>
         <p:style>
@@ -8203,41 +8413,102 @@
           </a:fontRef>
         </p:style>
         <p:txBody>
-          <a:bodyPr rtlCol="0" anchor="ctr" wrap="square"/>
-          <a:lstStyle/>
-          <a:p>
-            <a:pPr algn="r"/>
-            <a:r>
-              <a:rPr sz="1200" b="0">
+          <a:bodyPr rtlCol="0" anchor="ctr"/>
+          <a:lstStyle/>
+          <a:p>
+            <a:pPr algn="ctr"/>
+          </a:p>
+        </p:txBody>
+      </p:sp>
+      <p:sp>
+        <p:nvSpPr>
+          <p:cNvPr id="33" name="TextBox 32"/>
+          <p:cNvSpPr txBox="1"/>
+          <p:nvPr/>
+        </p:nvSpPr>
+        <p:spPr>
+          <a:xfrm>
+            <a:off x="8695944" y="4526280"/>
+            <a:ext cx="484632" cy="347472"/>
+          </a:xfrm>
+          <a:prstGeom prst="rect">
+            <a:avLst/>
+          </a:prstGeom>
+          <a:noFill/>
+        </p:spPr>
+        <p:txBody>
+          <a:bodyPr wrap="square">
+            <a:spAutoFit/>
+          </a:bodyPr>
+          <a:lstStyle/>
+          <a:p>
+            <a:pPr algn="ctr"/>
+            <a:r>
+              <a:rPr sz="1100" b="1" i="0">
                 <a:solidFill>
                   <a:srgbClr val="FFFFFF"/>
                 </a:solidFill>
-                <a:latin typeface="Noto Sans Arabic"/>
               </a:rPr>
-              <a:t>صلاحيات CRUD منفصلة لكل دور — Admin يملك التحكم الكامل</a:t>
-            </a:r>
-          </a:p>
-        </p:txBody>
-      </p:sp>
-      <p:sp>
-        <p:nvSpPr>
-          <p:cNvPr id="23" name="Rectangle 22"/>
+              <a:t>OK</a:t>
+            </a:r>
+          </a:p>
+        </p:txBody>
+      </p:sp>
+      <p:sp>
+        <p:nvSpPr>
+          <p:cNvPr id="34" name="TextBox 33"/>
+          <p:cNvSpPr txBox="1"/>
+          <p:nvPr/>
+        </p:nvSpPr>
+        <p:spPr>
+          <a:xfrm>
+            <a:off x="9326880" y="4379976"/>
+            <a:ext cx="8503920" cy="658368"/>
+          </a:xfrm>
+          <a:prstGeom prst="rect">
+            <a:avLst/>
+          </a:prstGeom>
+          <a:noFill/>
+        </p:spPr>
+        <p:txBody>
+          <a:bodyPr wrap="square">
+            <a:spAutoFit/>
+          </a:bodyPr>
+          <a:lstStyle/>
+          <a:p>
+            <a:pPr algn="r"/>
+            <a:r>
+              <a:rPr sz="1200" b="0" i="0">
+                <a:solidFill>
+                  <a:srgbClr val="FFFFFF"/>
+                </a:solidFill>
+              </a:rPr>
+              <a:t>سجل تدقيق مدمج — كل عملية دخول أو تعديل مؤثقة تلقائياً</a:t>
+            </a:r>
+          </a:p>
+        </p:txBody>
+      </p:sp>
+      <p:sp>
+        <p:nvSpPr>
+          <p:cNvPr id="35" name="Rectangle 34"/>
           <p:cNvSpPr/>
           <p:nvPr/>
         </p:nvSpPr>
         <p:spPr>
           <a:xfrm>
-            <a:off x="16322039" y="8028432"/>
-            <a:ext cx="457200" cy="457200"/>
+            <a:off x="274320" y="5148072"/>
+            <a:ext cx="8229600" cy="804672"/>
           </a:xfrm>
           <a:prstGeom prst="rect">
             <a:avLst/>
           </a:prstGeom>
           <a:solidFill>
-            <a:srgbClr val="2E7D32"/>
+            <a:srgbClr val="243860"/>
           </a:solidFill>
-          <a:ln>
-            <a:noFill/>
+          <a:ln w="6350">
+            <a:solidFill>
+              <a:srgbClr val="C9A84C"/>
+            </a:solidFill>
           </a:ln>
         </p:spPr>
         <p:style>
@@ -8255,41 +8526,68 @@
           </a:fontRef>
         </p:style>
         <p:txBody>
-          <a:bodyPr rtlCol="0" anchor="ctr" wrap="square"/>
+          <a:bodyPr rtlCol="0" anchor="ctr"/>
           <a:lstStyle/>
           <a:p>
             <a:pPr algn="ctr"/>
-            <a:r>
-              <a:rPr sz="900" b="1">
+          </a:p>
+        </p:txBody>
+      </p:sp>
+      <p:sp>
+        <p:nvSpPr>
+          <p:cNvPr id="36" name="TextBox 35"/>
+          <p:cNvSpPr txBox="1"/>
+          <p:nvPr/>
+        </p:nvSpPr>
+        <p:spPr>
+          <a:xfrm>
+            <a:off x="320040" y="5330952"/>
+            <a:ext cx="8046720" cy="457200"/>
+          </a:xfrm>
+          <a:prstGeom prst="rect">
+            <a:avLst/>
+          </a:prstGeom>
+          <a:noFill/>
+        </p:spPr>
+        <p:txBody>
+          <a:bodyPr wrap="square">
+            <a:spAutoFit/>
+          </a:bodyPr>
+          <a:lstStyle/>
+          <a:p>
+            <a:pPr algn="ctr"/>
+            <a:r>
+              <a:rPr sz="1400" b="1" i="0">
                 <a:solidFill>
                   <a:srgbClr val="FFFFFF"/>
                 </a:solidFill>
-                <a:latin typeface="Noto Sans Arabic"/>
               </a:rPr>
-              <a:t>OK</a:t>
-            </a:r>
-          </a:p>
-        </p:txBody>
-      </p:sp>
-      <p:sp>
-        <p:nvSpPr>
-          <p:cNvPr id="24" name="Rectangle 23"/>
+              <a:t>ضبط الصلاحيات</a:t>
+            </a:r>
+          </a:p>
+        </p:txBody>
+      </p:sp>
+      <p:sp>
+        <p:nvSpPr>
+          <p:cNvPr id="37" name="Rectangle 36"/>
           <p:cNvSpPr/>
           <p:nvPr/>
         </p:nvSpPr>
         <p:spPr>
           <a:xfrm>
-            <a:off x="914400" y="9098280"/>
-            <a:ext cx="5334000" cy="1005840"/>
+            <a:off x="8686800" y="5148072"/>
+            <a:ext cx="9281160" cy="804672"/>
           </a:xfrm>
           <a:prstGeom prst="rect">
             <a:avLst/>
           </a:prstGeom>
           <a:solidFill>
-            <a:srgbClr val="C9A84C"/>
+            <a:srgbClr val="243860"/>
           </a:solidFill>
-          <a:ln>
-            <a:noFill/>
+          <a:ln w="6350">
+            <a:solidFill>
+              <a:srgbClr val="C9A84C"/>
+            </a:solidFill>
           </a:ln>
         </p:spPr>
         <p:style>
@@ -8307,50 +8605,29 @@
           </a:fontRef>
         </p:style>
         <p:txBody>
-          <a:bodyPr rtlCol="0" anchor="ctr" wrap="square"/>
+          <a:bodyPr rtlCol="0" anchor="ctr"/>
           <a:lstStyle/>
           <a:p>
             <a:pPr algn="ctr"/>
-            <a:r>
-              <a:rPr sz="2600" b="1">
-                <a:solidFill>
-                  <a:srgbClr val="1A2A4A"/>
-                </a:solidFill>
-                <a:latin typeface="Noto Sans Arabic"/>
-              </a:rPr>
-              <a:t>5</a:t>
-            </a:r>
-          </a:p>
-          <a:p>
-            <a:pPr algn="ctr"/>
-            <a:r>
-              <a:rPr sz="1300" b="0">
-                <a:solidFill>
-                  <a:srgbClr val="1A2A4A"/>
-                </a:solidFill>
-                <a:latin typeface="Noto Sans Arabic"/>
-              </a:rPr>
-              <a:t>مستويات الوصول</a:t>
-            </a:r>
-          </a:p>
-        </p:txBody>
-      </p:sp>
-      <p:sp>
-        <p:nvSpPr>
-          <p:cNvPr id="25" name="Rectangle 24"/>
+          </a:p>
+        </p:txBody>
+      </p:sp>
+      <p:sp>
+        <p:nvSpPr>
+          <p:cNvPr id="38" name="Rectangle 37"/>
           <p:cNvSpPr/>
           <p:nvPr/>
         </p:nvSpPr>
         <p:spPr>
           <a:xfrm>
-            <a:off x="6477000" y="9098280"/>
-            <a:ext cx="5334000" cy="1005840"/>
+            <a:off x="8686800" y="5349240"/>
+            <a:ext cx="502920" cy="384048"/>
           </a:xfrm>
           <a:prstGeom prst="rect">
             <a:avLst/>
           </a:prstGeom>
           <a:solidFill>
-            <a:srgbClr val="C9A84C"/>
+            <a:srgbClr val="2ECC71"/>
           </a:solidFill>
           <a:ln>
             <a:noFill/>
@@ -8371,44 +8648,91 @@
           </a:fontRef>
         </p:style>
         <p:txBody>
-          <a:bodyPr rtlCol="0" anchor="ctr" wrap="square"/>
+          <a:bodyPr rtlCol="0" anchor="ctr"/>
           <a:lstStyle/>
           <a:p>
             <a:pPr algn="ctr"/>
-            <a:r>
-              <a:rPr sz="2600" b="1">
+          </a:p>
+        </p:txBody>
+      </p:sp>
+      <p:sp>
+        <p:nvSpPr>
+          <p:cNvPr id="39" name="TextBox 38"/>
+          <p:cNvSpPr txBox="1"/>
+          <p:nvPr/>
+        </p:nvSpPr>
+        <p:spPr>
+          <a:xfrm>
+            <a:off x="8695944" y="5367528"/>
+            <a:ext cx="484632" cy="347472"/>
+          </a:xfrm>
+          <a:prstGeom prst="rect">
+            <a:avLst/>
+          </a:prstGeom>
+          <a:noFill/>
+        </p:spPr>
+        <p:txBody>
+          <a:bodyPr wrap="square">
+            <a:spAutoFit/>
+          </a:bodyPr>
+          <a:lstStyle/>
+          <a:p>
+            <a:pPr algn="ctr"/>
+            <a:r>
+              <a:rPr sz="1100" b="1" i="0">
                 <a:solidFill>
-                  <a:srgbClr val="1A2A4A"/>
+                  <a:srgbClr val="FFFFFF"/>
                 </a:solidFill>
-                <a:latin typeface="Noto Sans Arabic"/>
               </a:rPr>
-              <a:t>100%</a:t>
-            </a:r>
-          </a:p>
-          <a:p>
-            <a:pPr algn="ctr"/>
-            <a:r>
-              <a:rPr sz="1300" b="0">
+              <a:t>OK</a:t>
+            </a:r>
+          </a:p>
+        </p:txBody>
+      </p:sp>
+      <p:sp>
+        <p:nvSpPr>
+          <p:cNvPr id="40" name="TextBox 39"/>
+          <p:cNvSpPr txBox="1"/>
+          <p:nvPr/>
+        </p:nvSpPr>
+        <p:spPr>
+          <a:xfrm>
+            <a:off x="9326880" y="5221224"/>
+            <a:ext cx="8503920" cy="658368"/>
+          </a:xfrm>
+          <a:prstGeom prst="rect">
+            <a:avLst/>
+          </a:prstGeom>
+          <a:noFill/>
+        </p:spPr>
+        <p:txBody>
+          <a:bodyPr wrap="square">
+            <a:spAutoFit/>
+          </a:bodyPr>
+          <a:lstStyle/>
+          <a:p>
+            <a:pPr algn="r"/>
+            <a:r>
+              <a:rPr sz="1200" b="0" i="0">
                 <a:solidFill>
-                  <a:srgbClr val="1A2A4A"/>
+                  <a:srgbClr val="FFFFFF"/>
                 </a:solidFill>
-                <a:latin typeface="Noto Sans Arabic"/>
               </a:rPr>
-              <a:t>بيانات محلية آمنة</a:t>
-            </a:r>
-          </a:p>
-        </p:txBody>
-      </p:sp>
-      <p:sp>
-        <p:nvSpPr>
-          <p:cNvPr id="26" name="Rectangle 25"/>
+              <a:t>Admin يملك التحكم الكامل CRUD — صلاحيات منفصلة لكل دور</a:t>
+            </a:r>
+          </a:p>
+        </p:txBody>
+      </p:sp>
+      <p:sp>
+        <p:nvSpPr>
+          <p:cNvPr id="41" name="Rectangle 40"/>
           <p:cNvSpPr/>
           <p:nvPr/>
         </p:nvSpPr>
         <p:spPr>
           <a:xfrm>
-            <a:off x="12039600" y="9098280"/>
-            <a:ext cx="5334000" cy="1005840"/>
+            <a:off x="320040" y="8823960"/>
+            <a:ext cx="5394960" cy="1097280"/>
           </a:xfrm>
           <a:prstGeom prst="rect">
             <a:avLst/>
@@ -8416,8 +8740,10 @@
           <a:solidFill>
             <a:srgbClr val="C9A84C"/>
           </a:solidFill>
-          <a:ln>
-            <a:noFill/>
+          <a:ln w="12700">
+            <a:solidFill>
+              <a:srgbClr val="C9A84C"/>
+            </a:solidFill>
           </a:ln>
         </p:spPr>
         <p:style>
@@ -8435,28 +8761,301 @@
           </a:fontRef>
         </p:style>
         <p:txBody>
-          <a:bodyPr rtlCol="0" anchor="ctr" wrap="square"/>
+          <a:bodyPr rtlCol="0" anchor="ctr"/>
           <a:lstStyle/>
           <a:p>
             <a:pPr algn="ctr"/>
-            <a:r>
-              <a:rPr sz="2600" b="1">
+          </a:p>
+        </p:txBody>
+      </p:sp>
+      <p:sp>
+        <p:nvSpPr>
+          <p:cNvPr id="42" name="TextBox 41"/>
+          <p:cNvSpPr txBox="1"/>
+          <p:nvPr/>
+        </p:nvSpPr>
+        <p:spPr>
+          <a:xfrm>
+            <a:off x="320040" y="8887968"/>
+            <a:ext cx="5394960" cy="566928"/>
+          </a:xfrm>
+          <a:prstGeom prst="rect">
+            <a:avLst/>
+          </a:prstGeom>
+          <a:noFill/>
+        </p:spPr>
+        <p:txBody>
+          <a:bodyPr wrap="square">
+            <a:spAutoFit/>
+          </a:bodyPr>
+          <a:lstStyle/>
+          <a:p>
+            <a:pPr algn="ctr"/>
+            <a:r>
+              <a:rPr sz="2600" b="1" i="0">
                 <a:solidFill>
                   <a:srgbClr val="1A2A4A"/>
                 </a:solidFill>
-                <a:latin typeface="Noto Sans Arabic"/>
               </a:rPr>
-              <a:t>متوافق</a:t>
-            </a:r>
-          </a:p>
+              <a:t>5</a:t>
+            </a:r>
+          </a:p>
+        </p:txBody>
+      </p:sp>
+      <p:sp>
+        <p:nvSpPr>
+          <p:cNvPr id="43" name="TextBox 42"/>
+          <p:cNvSpPr txBox="1"/>
+          <p:nvPr/>
+        </p:nvSpPr>
+        <p:spPr>
+          <a:xfrm>
+            <a:off x="320040" y="9418320"/>
+            <a:ext cx="5394960" cy="347472"/>
+          </a:xfrm>
+          <a:prstGeom prst="rect">
+            <a:avLst/>
+          </a:prstGeom>
+          <a:noFill/>
+        </p:spPr>
+        <p:txBody>
+          <a:bodyPr wrap="square">
+            <a:spAutoFit/>
+          </a:bodyPr>
+          <a:lstStyle/>
           <a:p>
             <a:pPr algn="ctr"/>
             <a:r>
-              <a:rPr sz="1300" b="0">
+              <a:rPr sz="1200" b="0" i="0">
                 <a:solidFill>
                   <a:srgbClr val="1A2A4A"/>
                 </a:solidFill>
-                <a:latin typeface="Noto Sans Arabic"/>
+              </a:rPr>
+              <a:t>مستويات الوصول</a:t>
+            </a:r>
+          </a:p>
+        </p:txBody>
+      </p:sp>
+      <p:sp>
+        <p:nvSpPr>
+          <p:cNvPr id="44" name="Rectangle 43"/>
+          <p:cNvSpPr/>
+          <p:nvPr/>
+        </p:nvSpPr>
+        <p:spPr>
+          <a:xfrm>
+            <a:off x="5852160" y="8823960"/>
+            <a:ext cx="5394960" cy="1097280"/>
+          </a:xfrm>
+          <a:prstGeom prst="rect">
+            <a:avLst/>
+          </a:prstGeom>
+          <a:solidFill>
+            <a:srgbClr val="C9A84C"/>
+          </a:solidFill>
+          <a:ln w="12700">
+            <a:solidFill>
+              <a:srgbClr val="C9A84C"/>
+            </a:solidFill>
+          </a:ln>
+        </p:spPr>
+        <p:style>
+          <a:lnRef idx="1">
+            <a:schemeClr val="accent1"/>
+          </a:lnRef>
+          <a:fillRef idx="3">
+            <a:schemeClr val="accent1"/>
+          </a:fillRef>
+          <a:effectRef idx="2">
+            <a:schemeClr val="accent1"/>
+          </a:effectRef>
+          <a:fontRef idx="minor">
+            <a:schemeClr val="lt1"/>
+          </a:fontRef>
+        </p:style>
+        <p:txBody>
+          <a:bodyPr rtlCol="0" anchor="ctr"/>
+          <a:lstStyle/>
+          <a:p>
+            <a:pPr algn="ctr"/>
+          </a:p>
+        </p:txBody>
+      </p:sp>
+      <p:sp>
+        <p:nvSpPr>
+          <p:cNvPr id="45" name="TextBox 44"/>
+          <p:cNvSpPr txBox="1"/>
+          <p:nvPr/>
+        </p:nvSpPr>
+        <p:spPr>
+          <a:xfrm>
+            <a:off x="5852160" y="8887968"/>
+            <a:ext cx="5394960" cy="566928"/>
+          </a:xfrm>
+          <a:prstGeom prst="rect">
+            <a:avLst/>
+          </a:prstGeom>
+          <a:noFill/>
+        </p:spPr>
+        <p:txBody>
+          <a:bodyPr wrap="square">
+            <a:spAutoFit/>
+          </a:bodyPr>
+          <a:lstStyle/>
+          <a:p>
+            <a:pPr algn="ctr"/>
+            <a:r>
+              <a:rPr sz="2600" b="1" i="0">
+                <a:solidFill>
+                  <a:srgbClr val="1A2A4A"/>
+                </a:solidFill>
+              </a:rPr>
+              <a:t>100%</a:t>
+            </a:r>
+          </a:p>
+        </p:txBody>
+      </p:sp>
+      <p:sp>
+        <p:nvSpPr>
+          <p:cNvPr id="46" name="TextBox 45"/>
+          <p:cNvSpPr txBox="1"/>
+          <p:nvPr/>
+        </p:nvSpPr>
+        <p:spPr>
+          <a:xfrm>
+            <a:off x="5852160" y="9418320"/>
+            <a:ext cx="5394960" cy="347472"/>
+          </a:xfrm>
+          <a:prstGeom prst="rect">
+            <a:avLst/>
+          </a:prstGeom>
+          <a:noFill/>
+        </p:spPr>
+        <p:txBody>
+          <a:bodyPr wrap="square">
+            <a:spAutoFit/>
+          </a:bodyPr>
+          <a:lstStyle/>
+          <a:p>
+            <a:pPr algn="ctr"/>
+            <a:r>
+              <a:rPr sz="1200" b="0" i="0">
+                <a:solidFill>
+                  <a:srgbClr val="1A2A4A"/>
+                </a:solidFill>
+              </a:rPr>
+              <a:t>بيانات محلية آمنة</a:t>
+            </a:r>
+          </a:p>
+        </p:txBody>
+      </p:sp>
+      <p:sp>
+        <p:nvSpPr>
+          <p:cNvPr id="47" name="Rectangle 46"/>
+          <p:cNvSpPr/>
+          <p:nvPr/>
+        </p:nvSpPr>
+        <p:spPr>
+          <a:xfrm>
+            <a:off x="11384280" y="8823960"/>
+            <a:ext cx="5394960" cy="1097280"/>
+          </a:xfrm>
+          <a:prstGeom prst="rect">
+            <a:avLst/>
+          </a:prstGeom>
+          <a:solidFill>
+            <a:srgbClr val="C9A84C"/>
+          </a:solidFill>
+          <a:ln w="12700">
+            <a:solidFill>
+              <a:srgbClr val="C9A84C"/>
+            </a:solidFill>
+          </a:ln>
+        </p:spPr>
+        <p:style>
+          <a:lnRef idx="1">
+            <a:schemeClr val="accent1"/>
+          </a:lnRef>
+          <a:fillRef idx="3">
+            <a:schemeClr val="accent1"/>
+          </a:fillRef>
+          <a:effectRef idx="2">
+            <a:schemeClr val="accent1"/>
+          </a:effectRef>
+          <a:fontRef idx="minor">
+            <a:schemeClr val="lt1"/>
+          </a:fontRef>
+        </p:style>
+        <p:txBody>
+          <a:bodyPr rtlCol="0" anchor="ctr"/>
+          <a:lstStyle/>
+          <a:p>
+            <a:pPr algn="ctr"/>
+          </a:p>
+        </p:txBody>
+      </p:sp>
+      <p:sp>
+        <p:nvSpPr>
+          <p:cNvPr id="48" name="TextBox 47"/>
+          <p:cNvSpPr txBox="1"/>
+          <p:nvPr/>
+        </p:nvSpPr>
+        <p:spPr>
+          <a:xfrm>
+            <a:off x="11384280" y="8887968"/>
+            <a:ext cx="5394960" cy="566928"/>
+          </a:xfrm>
+          <a:prstGeom prst="rect">
+            <a:avLst/>
+          </a:prstGeom>
+          <a:noFill/>
+        </p:spPr>
+        <p:txBody>
+          <a:bodyPr wrap="square">
+            <a:spAutoFit/>
+          </a:bodyPr>
+          <a:lstStyle/>
+          <a:p>
+            <a:pPr algn="ctr"/>
+            <a:r>
+              <a:rPr sz="2600" b="1" i="0">
+                <a:solidFill>
+                  <a:srgbClr val="1A2A4A"/>
+                </a:solidFill>
+              </a:rPr>
+              <a:t>متوافق</a:t>
+            </a:r>
+          </a:p>
+        </p:txBody>
+      </p:sp>
+      <p:sp>
+        <p:nvSpPr>
+          <p:cNvPr id="49" name="TextBox 48"/>
+          <p:cNvSpPr txBox="1"/>
+          <p:nvPr/>
+        </p:nvSpPr>
+        <p:spPr>
+          <a:xfrm>
+            <a:off x="11384280" y="9418320"/>
+            <a:ext cx="5394960" cy="347472"/>
+          </a:xfrm>
+          <a:prstGeom prst="rect">
+            <a:avLst/>
+          </a:prstGeom>
+          <a:noFill/>
+        </p:spPr>
+        <p:txBody>
+          <a:bodyPr wrap="square">
+            <a:spAutoFit/>
+          </a:bodyPr>
+          <a:lstStyle/>
+          <a:p>
+            <a:pPr algn="ctr"/>
+            <a:r>
+              <a:rPr sz="1200" b="0" i="0">
+                <a:solidFill>
+                  <a:srgbClr val="1A2A4A"/>
+                </a:solidFill>
               </a:rPr>
               <a:t>مع القانون الاتحادي</a:t>
             </a:r>

</xml_diff>

<commit_message>
fix: v6 - full redesign slides 3&4: 3+2 grid layout, clean table no floating badges
</commit_message>
<xml_diff>
--- a/assets/aljood_pitch_with_law.pptx
+++ b/assets/aljood_pitch_with_law.pptx
@@ -5742,50 +5742,7 @@
         <p:spPr>
           <a:xfrm>
             <a:off x="0" y="0"/>
-            <a:ext cx="18288000" cy="10287000"/>
-          </a:xfrm>
-          <a:prstGeom prst="rect">
-            <a:avLst/>
-          </a:prstGeom>
-          <a:solidFill>
-            <a:srgbClr val="1A2A4A"/>
-          </a:solidFill>
-          <a:ln>
-            <a:noFill/>
-          </a:ln>
-        </p:spPr>
-        <p:style>
-          <a:lnRef idx="1">
-            <a:schemeClr val="accent1"/>
-          </a:lnRef>
-          <a:fillRef idx="3">
-            <a:schemeClr val="accent1"/>
-          </a:fillRef>
-          <a:effectRef idx="2">
-            <a:schemeClr val="accent1"/>
-          </a:effectRef>
-          <a:fontRef idx="minor">
-            <a:schemeClr val="lt1"/>
-          </a:fontRef>
-        </p:style>
-        <p:txBody>
-          <a:bodyPr rtlCol="0" anchor="ctr"/>
-          <a:lstStyle/>
-          <a:p>
-            <a:pPr algn="ctr"/>
-          </a:p>
-        </p:txBody>
-      </p:sp>
-      <p:sp>
-        <p:nvSpPr>
-          <p:cNvPr id="3" name="Rectangle 2"/>
-          <p:cNvSpPr/>
-          <p:nvPr/>
-        </p:nvSpPr>
-        <p:spPr>
-          <a:xfrm>
-            <a:off x="0" y="0"/>
-            <a:ext cx="18288000" cy="118872"/>
+            <a:ext cx="18288000" cy="73152"/>
           </a:xfrm>
           <a:prstGeom prst="rect">
             <a:avLst/>
@@ -5821,14 +5778,127 @@
       </p:sp>
       <p:sp>
         <p:nvSpPr>
-          <p:cNvPr id="4" name="Rectangle 3"/>
+          <p:cNvPr id="3" name="Rectangle 2"/>
           <p:cNvSpPr/>
           <p:nvPr/>
         </p:nvSpPr>
         <p:spPr>
           <a:xfrm>
-            <a:off x="0" y="10058400"/>
-            <a:ext cx="18288000" cy="228600"/>
+            <a:off x="0" y="73152"/>
+            <a:ext cx="18288000" cy="960120"/>
+          </a:xfrm>
+          <a:prstGeom prst="rect">
+            <a:avLst/>
+          </a:prstGeom>
+          <a:solidFill>
+            <a:srgbClr val="0F1A30"/>
+          </a:solidFill>
+          <a:ln>
+            <a:noFill/>
+          </a:ln>
+        </p:spPr>
+        <p:style>
+          <a:lnRef idx="1">
+            <a:schemeClr val="accent1"/>
+          </a:lnRef>
+          <a:fillRef idx="3">
+            <a:schemeClr val="accent1"/>
+          </a:fillRef>
+          <a:effectRef idx="2">
+            <a:schemeClr val="accent1"/>
+          </a:effectRef>
+          <a:fontRef idx="minor">
+            <a:schemeClr val="lt1"/>
+          </a:fontRef>
+        </p:style>
+        <p:txBody>
+          <a:bodyPr rtlCol="0" anchor="ctr"/>
+          <a:lstStyle/>
+          <a:p>
+            <a:pPr algn="ctr"/>
+          </a:p>
+        </p:txBody>
+      </p:sp>
+      <p:sp>
+        <p:nvSpPr>
+          <p:cNvPr id="4" name="TextBox 3"/>
+          <p:cNvSpPr txBox="1"/>
+          <p:nvPr/>
+        </p:nvSpPr>
+        <p:spPr>
+          <a:xfrm>
+            <a:off x="274320" y="109728"/>
+            <a:ext cx="17739360" cy="548640"/>
+          </a:xfrm>
+          <a:prstGeom prst="rect">
+            <a:avLst/>
+          </a:prstGeom>
+          <a:noFill/>
+        </p:spPr>
+        <p:txBody>
+          <a:bodyPr wrap="square">
+            <a:spAutoFit/>
+          </a:bodyPr>
+          <a:lstStyle/>
+          <a:p>
+            <a:pPr algn="ctr"/>
+            <a:r>
+              <a:rPr sz="2800" b="1">
+                <a:solidFill>
+                  <a:srgbClr val="C9A84C"/>
+                </a:solidFill>
+                <a:latin typeface="Arial"/>
+              </a:rPr>
+              <a:t>السياق الوطني: قانون سلامة الطفل الرقمي</a:t>
+            </a:r>
+          </a:p>
+        </p:txBody>
+      </p:sp>
+      <p:sp>
+        <p:nvSpPr>
+          <p:cNvPr id="5" name="TextBox 4"/>
+          <p:cNvSpPr txBox="1"/>
+          <p:nvPr/>
+        </p:nvSpPr>
+        <p:spPr>
+          <a:xfrm>
+            <a:off x="274320" y="658368"/>
+            <a:ext cx="17739360" cy="347472"/>
+          </a:xfrm>
+          <a:prstGeom prst="rect">
+            <a:avLst/>
+          </a:prstGeom>
+          <a:noFill/>
+        </p:spPr>
+        <p:txBody>
+          <a:bodyPr wrap="square">
+            <a:spAutoFit/>
+          </a:bodyPr>
+          <a:lstStyle/>
+          <a:p>
+            <a:pPr algn="ctr"/>
+            <a:r>
+              <a:rPr sz="1400" b="0">
+                <a:solidFill>
+                  <a:srgbClr val="FFFFFF"/>
+                </a:solidFill>
+                <a:latin typeface="Arial"/>
+              </a:rPr>
+              <a:t>UAE Federal Decree No. 2 / 2026 — Child Digital Safety Law</a:t>
+            </a:r>
+          </a:p>
+        </p:txBody>
+      </p:sp>
+      <p:sp>
+        <p:nvSpPr>
+          <p:cNvPr id="6" name="Rectangle 5"/>
+          <p:cNvSpPr/>
+          <p:nvPr/>
+        </p:nvSpPr>
+        <p:spPr>
+          <a:xfrm>
+            <a:off x="0" y="1033271"/>
+            <a:ext cx="18288000" cy="45720"/>
           </a:xfrm>
           <a:prstGeom prst="rect">
             <a:avLst/>
@@ -5864,90 +5934,22 @@
       </p:sp>
       <p:sp>
         <p:nvSpPr>
-          <p:cNvPr id="5" name="TextBox 4"/>
-          <p:cNvSpPr txBox="1"/>
-          <p:nvPr/>
-        </p:nvSpPr>
-        <p:spPr>
-          <a:xfrm>
-            <a:off x="274320" y="201168"/>
-            <a:ext cx="17739360" cy="640080"/>
-          </a:xfrm>
-          <a:prstGeom prst="rect">
-            <a:avLst/>
-          </a:prstGeom>
-          <a:noFill/>
-        </p:spPr>
-        <p:txBody>
-          <a:bodyPr wrap="square">
-            <a:spAutoFit/>
-          </a:bodyPr>
-          <a:lstStyle/>
-          <a:p>
-            <a:pPr algn="r"/>
-            <a:r>
-              <a:rPr sz="2800" b="1" i="0">
-                <a:solidFill>
-                  <a:srgbClr val="C9A84C"/>
-                </a:solidFill>
-              </a:rPr>
-              <a:t>السياق الوطني: قانون سلامة الطفل الرقمي</a:t>
-            </a:r>
-          </a:p>
-        </p:txBody>
-      </p:sp>
-      <p:sp>
-        <p:nvSpPr>
-          <p:cNvPr id="6" name="TextBox 5"/>
-          <p:cNvSpPr txBox="1"/>
-          <p:nvPr/>
-        </p:nvSpPr>
-        <p:spPr>
-          <a:xfrm>
-            <a:off x="274320" y="841248"/>
-            <a:ext cx="17739360" cy="320040"/>
-          </a:xfrm>
-          <a:prstGeom prst="rect">
-            <a:avLst/>
-          </a:prstGeom>
-          <a:noFill/>
-        </p:spPr>
-        <p:txBody>
-          <a:bodyPr wrap="square">
-            <a:spAutoFit/>
-          </a:bodyPr>
-          <a:lstStyle/>
-          <a:p>
-            <a:pPr algn="r"/>
-            <a:r>
-              <a:rPr sz="1300" b="0" i="1">
-                <a:solidFill>
-                  <a:srgbClr val="FFFFFF"/>
-                </a:solidFill>
-              </a:rPr>
-              <a:t>UAE Federal Decree No. 2 / 2026 — Child Digital Safety Law</a:t>
-            </a:r>
-          </a:p>
-        </p:txBody>
-      </p:sp>
-      <p:sp>
-        <p:nvSpPr>
           <p:cNvPr id="7" name="Rectangle 6"/>
           <p:cNvSpPr/>
           <p:nvPr/>
         </p:nvSpPr>
         <p:spPr>
           <a:xfrm>
-            <a:off x="320040" y="1417320"/>
-            <a:ext cx="4754880" cy="5029200"/>
+            <a:off x="685800" y="1234440"/>
+            <a:ext cx="5303520" cy="1920240"/>
           </a:xfrm>
           <a:prstGeom prst="rect">
             <a:avLst/>
           </a:prstGeom>
           <a:solidFill>
-            <a:srgbClr val="243860"/>
+            <a:srgbClr val="22355E"/>
           </a:solidFill>
-          <a:ln w="25400">
+          <a:ln w="19050">
             <a:solidFill>
               <a:srgbClr val="C9A84C"/>
             </a:solidFill>
@@ -5977,263 +5979,14 @@
       </p:sp>
       <p:sp>
         <p:nvSpPr>
-          <p:cNvPr id="8" name="TextBox 7"/>
-          <p:cNvSpPr txBox="1"/>
+          <p:cNvPr id="8" name="Rectangle 7"/>
+          <p:cNvSpPr/>
           <p:nvPr/>
         </p:nvSpPr>
         <p:spPr>
           <a:xfrm>
-            <a:off x="411480" y="1600200"/>
-            <a:ext cx="4572000" cy="457200"/>
-          </a:xfrm>
-          <a:prstGeom prst="rect">
-            <a:avLst/>
-          </a:prstGeom>
-          <a:noFill/>
-        </p:spPr>
-        <p:txBody>
-          <a:bodyPr wrap="square">
-            <a:spAutoFit/>
-          </a:bodyPr>
-          <a:lstStyle/>
-          <a:p>
-            <a:pPr algn="ctr"/>
-            <a:r>
-              <a:rPr sz="1400" b="1" i="0">
-                <a:solidFill>
-                  <a:srgbClr val="C9A84C"/>
-                </a:solidFill>
-              </a:rPr>
-              <a:t>مرسوم اتحادي</a:t>
-            </a:r>
-          </a:p>
-        </p:txBody>
-      </p:sp>
-      <p:sp>
-        <p:nvSpPr>
-          <p:cNvPr id="9" name="TextBox 8"/>
-          <p:cNvSpPr txBox="1"/>
-          <p:nvPr/>
-        </p:nvSpPr>
-        <p:spPr>
-          <a:xfrm>
-            <a:off x="411480" y="2057400"/>
-            <a:ext cx="4572000" cy="365760"/>
-          </a:xfrm>
-          <a:prstGeom prst="rect">
-            <a:avLst/>
-          </a:prstGeom>
-          <a:noFill/>
-        </p:spPr>
-        <p:txBody>
-          <a:bodyPr wrap="square">
-            <a:spAutoFit/>
-          </a:bodyPr>
-          <a:lstStyle/>
-          <a:p>
-            <a:pPr algn="ctr"/>
-            <a:r>
-              <a:rPr sz="1300" b="0" i="0">
-                <a:solidFill>
-                  <a:srgbClr val="FFFFFF"/>
-                </a:solidFill>
-              </a:rPr>
-              <a:t>رقم 2 لسنة</a:t>
-            </a:r>
-          </a:p>
-        </p:txBody>
-      </p:sp>
-      <p:sp>
-        <p:nvSpPr>
-          <p:cNvPr id="10" name="TextBox 9"/>
-          <p:cNvSpPr txBox="1"/>
-          <p:nvPr/>
-        </p:nvSpPr>
-        <p:spPr>
-          <a:xfrm>
-            <a:off x="411480" y="2423160"/>
-            <a:ext cx="4572000" cy="1005840"/>
-          </a:xfrm>
-          <a:prstGeom prst="rect">
-            <a:avLst/>
-          </a:prstGeom>
-          <a:noFill/>
-        </p:spPr>
-        <p:txBody>
-          <a:bodyPr wrap="square">
-            <a:spAutoFit/>
-          </a:bodyPr>
-          <a:lstStyle/>
-          <a:p>
-            <a:pPr algn="ctr"/>
-            <a:r>
-              <a:rPr sz="5400" b="1" i="0">
-                <a:solidFill>
-                  <a:srgbClr val="C9A84C"/>
-                </a:solidFill>
-              </a:rPr>
-              <a:t>2026</a:t>
-            </a:r>
-          </a:p>
-        </p:txBody>
-      </p:sp>
-      <p:sp>
-        <p:nvSpPr>
-          <p:cNvPr id="11" name="TextBox 10"/>
-          <p:cNvSpPr txBox="1"/>
-          <p:nvPr/>
-        </p:nvSpPr>
-        <p:spPr>
-          <a:xfrm>
-            <a:off x="411480" y="3474720"/>
-            <a:ext cx="4572000" cy="411480"/>
-          </a:xfrm>
-          <a:prstGeom prst="rect">
-            <a:avLst/>
-          </a:prstGeom>
-          <a:noFill/>
-        </p:spPr>
-        <p:txBody>
-          <a:bodyPr wrap="square">
-            <a:spAutoFit/>
-          </a:bodyPr>
-          <a:lstStyle/>
-          <a:p>
-            <a:pPr algn="ctr"/>
-            <a:r>
-              <a:rPr sz="1300" b="0" i="0">
-                <a:solidFill>
-                  <a:srgbClr val="FFFFFF"/>
-                </a:solidFill>
-              </a:rPr>
-              <a:t>حماية الطفل في الفضاء الرقمي</a:t>
-            </a:r>
-          </a:p>
-        </p:txBody>
-      </p:sp>
-      <p:sp>
-        <p:nvSpPr>
-          <p:cNvPr id="12" name="TextBox 11"/>
-          <p:cNvSpPr txBox="1"/>
-          <p:nvPr/>
-        </p:nvSpPr>
-        <p:spPr>
-          <a:xfrm>
-            <a:off x="411480" y="3886200"/>
-            <a:ext cx="4572000" cy="320040"/>
-          </a:xfrm>
-          <a:prstGeom prst="rect">
-            <a:avLst/>
-          </a:prstGeom>
-          <a:noFill/>
-        </p:spPr>
-        <p:txBody>
-          <a:bodyPr wrap="square">
-            <a:spAutoFit/>
-          </a:bodyPr>
-          <a:lstStyle/>
-          <a:p>
-            <a:pPr algn="ctr"/>
-            <a:r>
-              <a:rPr sz="1100" b="0" i="1">
-                <a:solidFill>
-                  <a:srgbClr val="C9A84C"/>
-                </a:solidFill>
-              </a:rPr>
-              <a:t>Child Digital Safety Law</a:t>
-            </a:r>
-          </a:p>
-        </p:txBody>
-      </p:sp>
-      <p:sp>
-        <p:nvSpPr>
-          <p:cNvPr id="13" name="TextBox 12"/>
-          <p:cNvSpPr txBox="1"/>
-          <p:nvPr/>
-        </p:nvSpPr>
-        <p:spPr>
-          <a:xfrm>
-            <a:off x="411480" y="4343400"/>
-            <a:ext cx="4572000" cy="320040"/>
-          </a:xfrm>
-          <a:prstGeom prst="rect">
-            <a:avLst/>
-          </a:prstGeom>
-          <a:noFill/>
-        </p:spPr>
-        <p:txBody>
-          <a:bodyPr wrap="square">
-            <a:spAutoFit/>
-          </a:bodyPr>
-          <a:lstStyle/>
-          <a:p>
-            <a:pPr algn="ctr"/>
-            <a:r>
-              <a:rPr sz="1100" b="0" i="0">
-                <a:solidFill>
-                  <a:srgbClr val="AAAAAA"/>
-                </a:solidFill>
-              </a:rPr>
-              <a:t>يناير 2026 | January 2026</a:t>
-            </a:r>
-          </a:p>
-        </p:txBody>
-      </p:sp>
-      <p:sp>
-        <p:nvSpPr>
-          <p:cNvPr id="14" name="Rectangle 13"/>
-          <p:cNvSpPr/>
-          <p:nvPr/>
-        </p:nvSpPr>
-        <p:spPr>
-          <a:xfrm>
-            <a:off x="5486400" y="1325880"/>
-            <a:ext cx="12435840" cy="914400"/>
-          </a:xfrm>
-          <a:prstGeom prst="rect">
-            <a:avLst/>
-          </a:prstGeom>
-          <a:solidFill>
-            <a:srgbClr val="243860"/>
-          </a:solidFill>
-          <a:ln w="12700">
-            <a:solidFill>
-              <a:srgbClr val="C9A84C"/>
-            </a:solidFill>
-          </a:ln>
-        </p:spPr>
-        <p:style>
-          <a:lnRef idx="1">
-            <a:schemeClr val="accent1"/>
-          </a:lnRef>
-          <a:fillRef idx="3">
-            <a:schemeClr val="accent1"/>
-          </a:fillRef>
-          <a:effectRef idx="2">
-            <a:schemeClr val="accent1"/>
-          </a:effectRef>
-          <a:fontRef idx="minor">
-            <a:schemeClr val="lt1"/>
-          </a:fontRef>
-        </p:style>
-        <p:txBody>
-          <a:bodyPr rtlCol="0" anchor="ctr"/>
-          <a:lstStyle/>
-          <a:p>
-            <a:pPr algn="ctr"/>
-          </a:p>
-        </p:txBody>
-      </p:sp>
-      <p:sp>
-        <p:nvSpPr>
-          <p:cNvPr id="15" name="Rectangle 14"/>
-          <p:cNvSpPr/>
-          <p:nvPr/>
-        </p:nvSpPr>
-        <p:spPr>
-          <a:xfrm>
-            <a:off x="5486400" y="1325880"/>
-            <a:ext cx="640080" cy="914400"/>
+            <a:off x="685800" y="1234440"/>
+            <a:ext cx="109728" cy="1920240"/>
           </a:xfrm>
           <a:prstGeom prst="rect">
             <a:avLst/>
@@ -6269,161 +6022,14 @@
       </p:sp>
       <p:sp>
         <p:nvSpPr>
-          <p:cNvPr id="16" name="TextBox 15"/>
-          <p:cNvSpPr txBox="1"/>
+          <p:cNvPr id="9" name="Rectangle 8"/>
+          <p:cNvSpPr/>
           <p:nvPr/>
         </p:nvSpPr>
         <p:spPr>
           <a:xfrm>
-            <a:off x="5532120" y="1554480"/>
-            <a:ext cx="548640" cy="457200"/>
-          </a:xfrm>
-          <a:prstGeom prst="rect">
-            <a:avLst/>
-          </a:prstGeom>
-          <a:noFill/>
-        </p:spPr>
-        <p:txBody>
-          <a:bodyPr wrap="square">
-            <a:spAutoFit/>
-          </a:bodyPr>
-          <a:lstStyle/>
-          <a:p>
-            <a:pPr algn="ctr"/>
-            <a:r>
-              <a:rPr sz="1600" b="1" i="0">
-                <a:solidFill>
-                  <a:srgbClr val="1A2A4A"/>
-                </a:solidFill>
-              </a:rPr>
-              <a:t>01</a:t>
-            </a:r>
-          </a:p>
-        </p:txBody>
-      </p:sp>
-      <p:sp>
-        <p:nvSpPr>
-          <p:cNvPr id="17" name="TextBox 16"/>
-          <p:cNvSpPr txBox="1"/>
-          <p:nvPr/>
-        </p:nvSpPr>
-        <p:spPr>
-          <a:xfrm>
-            <a:off x="6309360" y="1399032"/>
-            <a:ext cx="11430000" cy="411480"/>
-          </a:xfrm>
-          <a:prstGeom prst="rect">
-            <a:avLst/>
-          </a:prstGeom>
-          <a:noFill/>
-        </p:spPr>
-        <p:txBody>
-          <a:bodyPr wrap="square">
-            <a:spAutoFit/>
-          </a:bodyPr>
-          <a:lstStyle/>
-          <a:p>
-            <a:pPr algn="r"/>
-            <a:r>
-              <a:rPr sz="1600" b="1" i="0">
-                <a:solidFill>
-                  <a:srgbClr val="FFFFFF"/>
-                </a:solidFill>
-              </a:rPr>
-              <a:t>حماية البيانات الرقمية للطلاب</a:t>
-            </a:r>
-          </a:p>
-        </p:txBody>
-      </p:sp>
-      <p:sp>
-        <p:nvSpPr>
-          <p:cNvPr id="18" name="TextBox 17"/>
-          <p:cNvSpPr txBox="1"/>
-          <p:nvPr/>
-        </p:nvSpPr>
-        <p:spPr>
-          <a:xfrm>
-            <a:off x="6309360" y="1828800"/>
-            <a:ext cx="11430000" cy="320040"/>
-          </a:xfrm>
-          <a:prstGeom prst="rect">
-            <a:avLst/>
-          </a:prstGeom>
-          <a:noFill/>
-        </p:spPr>
-        <p:txBody>
-          <a:bodyPr wrap="square">
-            <a:spAutoFit/>
-          </a:bodyPr>
-          <a:lstStyle/>
-          <a:p>
-            <a:pPr algn="r"/>
-            <a:r>
-              <a:rPr sz="1100" b="0" i="1">
-                <a:solidFill>
-                  <a:srgbClr val="C9A84C"/>
-                </a:solidFill>
-              </a:rPr>
-              <a:t>Student Digital Data Protection</a:t>
-            </a:r>
-          </a:p>
-        </p:txBody>
-      </p:sp>
-      <p:sp>
-        <p:nvSpPr>
-          <p:cNvPr id="19" name="Rectangle 18"/>
-          <p:cNvSpPr/>
-          <p:nvPr/>
-        </p:nvSpPr>
-        <p:spPr>
-          <a:xfrm>
-            <a:off x="5486400" y="2350008"/>
-            <a:ext cx="12435840" cy="914400"/>
-          </a:xfrm>
-          <a:prstGeom prst="rect">
-            <a:avLst/>
-          </a:prstGeom>
-          <a:solidFill>
-            <a:srgbClr val="243860"/>
-          </a:solidFill>
-          <a:ln w="12700">
-            <a:solidFill>
-              <a:srgbClr val="C9A84C"/>
-            </a:solidFill>
-          </a:ln>
-        </p:spPr>
-        <p:style>
-          <a:lnRef idx="1">
-            <a:schemeClr val="accent1"/>
-          </a:lnRef>
-          <a:fillRef idx="3">
-            <a:schemeClr val="accent1"/>
-          </a:fillRef>
-          <a:effectRef idx="2">
-            <a:schemeClr val="accent1"/>
-          </a:effectRef>
-          <a:fontRef idx="minor">
-            <a:schemeClr val="lt1"/>
-          </a:fontRef>
-        </p:style>
-        <p:txBody>
-          <a:bodyPr rtlCol="0" anchor="ctr"/>
-          <a:lstStyle/>
-          <a:p>
-            <a:pPr algn="ctr"/>
-          </a:p>
-        </p:txBody>
-      </p:sp>
-      <p:sp>
-        <p:nvSpPr>
-          <p:cNvPr id="20" name="Rectangle 19"/>
-          <p:cNvSpPr/>
-          <p:nvPr/>
-        </p:nvSpPr>
-        <p:spPr>
-          <a:xfrm>
-            <a:off x="5486400" y="2350008"/>
-            <a:ext cx="640080" cy="914400"/>
+            <a:off x="886968" y="1399032"/>
+            <a:ext cx="640080" cy="502920"/>
           </a:xfrm>
           <a:prstGeom prst="rect">
             <a:avLst/>
@@ -6459,14 +6065,14 @@
       </p:sp>
       <p:sp>
         <p:nvSpPr>
-          <p:cNvPr id="21" name="TextBox 20"/>
+          <p:cNvPr id="10" name="TextBox 9"/>
           <p:cNvSpPr txBox="1"/>
           <p:nvPr/>
         </p:nvSpPr>
         <p:spPr>
           <a:xfrm>
-            <a:off x="5532120" y="2578608"/>
-            <a:ext cx="548640" cy="457200"/>
+            <a:off x="886968" y="1399032"/>
+            <a:ext cx="640080" cy="502920"/>
           </a:xfrm>
           <a:prstGeom prst="rect">
             <a:avLst/>
@@ -6481,26 +6087,27 @@
           <a:p>
             <a:pPr algn="ctr"/>
             <a:r>
-              <a:rPr sz="1600" b="1" i="0">
+              <a:rPr sz="1600" b="1">
                 <a:solidFill>
                   <a:srgbClr val="1A2A4A"/>
                 </a:solidFill>
+                <a:latin typeface="Arial"/>
               </a:rPr>
-              <a:t>02</a:t>
+              <a:t>01</a:t>
             </a:r>
           </a:p>
         </p:txBody>
       </p:sp>
       <p:sp>
         <p:nvSpPr>
-          <p:cNvPr id="22" name="TextBox 21"/>
+          <p:cNvPr id="11" name="TextBox 10"/>
           <p:cNvSpPr txBox="1"/>
           <p:nvPr/>
         </p:nvSpPr>
         <p:spPr>
           <a:xfrm>
-            <a:off x="6309360" y="2423160"/>
-            <a:ext cx="11430000" cy="411480"/>
+            <a:off x="822960" y="1965960"/>
+            <a:ext cx="5029200" cy="594360"/>
           </a:xfrm>
           <a:prstGeom prst="rect">
             <a:avLst/>
@@ -6513,28 +6120,29 @@
           </a:bodyPr>
           <a:lstStyle/>
           <a:p>
-            <a:pPr algn="r"/>
+            <a:pPr algn="ctr"/>
             <a:r>
-              <a:rPr sz="1600" b="1" i="0">
+              <a:rPr sz="1800" b="1">
                 <a:solidFill>
                   <a:srgbClr val="FFFFFF"/>
                 </a:solidFill>
+                <a:latin typeface="Arial"/>
               </a:rPr>
-              <a:t>توثيق هوية المستخدمين</a:t>
+              <a:t>حماية البيانات الرقمية للطلاب</a:t>
             </a:r>
           </a:p>
         </p:txBody>
       </p:sp>
       <p:sp>
         <p:nvSpPr>
-          <p:cNvPr id="23" name="TextBox 22"/>
+          <p:cNvPr id="12" name="TextBox 11"/>
           <p:cNvSpPr txBox="1"/>
           <p:nvPr/>
         </p:nvSpPr>
         <p:spPr>
           <a:xfrm>
-            <a:off x="6309360" y="2852928"/>
-            <a:ext cx="11430000" cy="320040"/>
+            <a:off x="822960" y="2560320"/>
+            <a:ext cx="5029200" cy="457200"/>
           </a:xfrm>
           <a:prstGeom prst="rect">
             <a:avLst/>
@@ -6547,36 +6155,37 @@
           </a:bodyPr>
           <a:lstStyle/>
           <a:p>
-            <a:pPr algn="r"/>
+            <a:pPr algn="ctr"/>
             <a:r>
-              <a:rPr sz="1100" b="0" i="1">
+              <a:rPr sz="1200" b="0">
                 <a:solidFill>
                   <a:srgbClr val="C9A84C"/>
                 </a:solidFill>
+                <a:latin typeface="Arial"/>
               </a:rPr>
-              <a:t>User Identity Verification</a:t>
+              <a:t>Student Digital Data Protection</a:t>
             </a:r>
           </a:p>
         </p:txBody>
       </p:sp>
       <p:sp>
         <p:nvSpPr>
-          <p:cNvPr id="24" name="Rectangle 23"/>
+          <p:cNvPr id="13" name="Rectangle 12"/>
           <p:cNvSpPr/>
           <p:nvPr/>
         </p:nvSpPr>
         <p:spPr>
           <a:xfrm>
-            <a:off x="5486400" y="3374136"/>
-            <a:ext cx="12435840" cy="914400"/>
+            <a:off x="6492240" y="1234440"/>
+            <a:ext cx="5303520" cy="1920240"/>
           </a:xfrm>
           <a:prstGeom prst="rect">
             <a:avLst/>
           </a:prstGeom>
           <a:solidFill>
-            <a:srgbClr val="243860"/>
+            <a:srgbClr val="22355E"/>
           </a:solidFill>
-          <a:ln w="12700">
+          <a:ln w="19050">
             <a:solidFill>
               <a:srgbClr val="C9A84C"/>
             </a:solidFill>
@@ -6606,14 +6215,14 @@
       </p:sp>
       <p:sp>
         <p:nvSpPr>
-          <p:cNvPr id="25" name="Rectangle 24"/>
+          <p:cNvPr id="14" name="Rectangle 13"/>
           <p:cNvSpPr/>
           <p:nvPr/>
         </p:nvSpPr>
         <p:spPr>
           <a:xfrm>
-            <a:off x="5486400" y="3374136"/>
-            <a:ext cx="640080" cy="914400"/>
+            <a:off x="6492240" y="1234440"/>
+            <a:ext cx="109728" cy="1920240"/>
           </a:xfrm>
           <a:prstGeom prst="rect">
             <a:avLst/>
@@ -6649,161 +6258,14 @@
       </p:sp>
       <p:sp>
         <p:nvSpPr>
-          <p:cNvPr id="26" name="TextBox 25"/>
-          <p:cNvSpPr txBox="1"/>
+          <p:cNvPr id="15" name="Rectangle 14"/>
+          <p:cNvSpPr/>
           <p:nvPr/>
         </p:nvSpPr>
         <p:spPr>
           <a:xfrm>
-            <a:off x="5532120" y="3602736"/>
-            <a:ext cx="548640" cy="457200"/>
-          </a:xfrm>
-          <a:prstGeom prst="rect">
-            <a:avLst/>
-          </a:prstGeom>
-          <a:noFill/>
-        </p:spPr>
-        <p:txBody>
-          <a:bodyPr wrap="square">
-            <a:spAutoFit/>
-          </a:bodyPr>
-          <a:lstStyle/>
-          <a:p>
-            <a:pPr algn="ctr"/>
-            <a:r>
-              <a:rPr sz="1600" b="1" i="0">
-                <a:solidFill>
-                  <a:srgbClr val="1A2A4A"/>
-                </a:solidFill>
-              </a:rPr>
-              <a:t>03</a:t>
-            </a:r>
-          </a:p>
-        </p:txBody>
-      </p:sp>
-      <p:sp>
-        <p:nvSpPr>
-          <p:cNvPr id="27" name="TextBox 26"/>
-          <p:cNvSpPr txBox="1"/>
-          <p:nvPr/>
-        </p:nvSpPr>
-        <p:spPr>
-          <a:xfrm>
-            <a:off x="6309360" y="3447288"/>
-            <a:ext cx="11430000" cy="411480"/>
-          </a:xfrm>
-          <a:prstGeom prst="rect">
-            <a:avLst/>
-          </a:prstGeom>
-          <a:noFill/>
-        </p:spPr>
-        <p:txBody>
-          <a:bodyPr wrap="square">
-            <a:spAutoFit/>
-          </a:bodyPr>
-          <a:lstStyle/>
-          <a:p>
-            <a:pPr algn="r"/>
-            <a:r>
-              <a:rPr sz="1600" b="1" i="0">
-                <a:solidFill>
-                  <a:srgbClr val="FFFFFF"/>
-                </a:solidFill>
-              </a:rPr>
-              <a:t>رقابة أولياء الأمور</a:t>
-            </a:r>
-          </a:p>
-        </p:txBody>
-      </p:sp>
-      <p:sp>
-        <p:nvSpPr>
-          <p:cNvPr id="28" name="TextBox 27"/>
-          <p:cNvSpPr txBox="1"/>
-          <p:nvPr/>
-        </p:nvSpPr>
-        <p:spPr>
-          <a:xfrm>
-            <a:off x="6309360" y="3877056"/>
-            <a:ext cx="11430000" cy="320040"/>
-          </a:xfrm>
-          <a:prstGeom prst="rect">
-            <a:avLst/>
-          </a:prstGeom>
-          <a:noFill/>
-        </p:spPr>
-        <p:txBody>
-          <a:bodyPr wrap="square">
-            <a:spAutoFit/>
-          </a:bodyPr>
-          <a:lstStyle/>
-          <a:p>
-            <a:pPr algn="r"/>
-            <a:r>
-              <a:rPr sz="1100" b="0" i="1">
-                <a:solidFill>
-                  <a:srgbClr val="C9A84C"/>
-                </a:solidFill>
-              </a:rPr>
-              <a:t>Parental Monitoring &amp; Control</a:t>
-            </a:r>
-          </a:p>
-        </p:txBody>
-      </p:sp>
-      <p:sp>
-        <p:nvSpPr>
-          <p:cNvPr id="29" name="Rectangle 28"/>
-          <p:cNvSpPr/>
-          <p:nvPr/>
-        </p:nvSpPr>
-        <p:spPr>
-          <a:xfrm>
-            <a:off x="5486400" y="4398264"/>
-            <a:ext cx="12435840" cy="914400"/>
-          </a:xfrm>
-          <a:prstGeom prst="rect">
-            <a:avLst/>
-          </a:prstGeom>
-          <a:solidFill>
-            <a:srgbClr val="243860"/>
-          </a:solidFill>
-          <a:ln w="12700">
-            <a:solidFill>
-              <a:srgbClr val="C9A84C"/>
-            </a:solidFill>
-          </a:ln>
-        </p:spPr>
-        <p:style>
-          <a:lnRef idx="1">
-            <a:schemeClr val="accent1"/>
-          </a:lnRef>
-          <a:fillRef idx="3">
-            <a:schemeClr val="accent1"/>
-          </a:fillRef>
-          <a:effectRef idx="2">
-            <a:schemeClr val="accent1"/>
-          </a:effectRef>
-          <a:fontRef idx="minor">
-            <a:schemeClr val="lt1"/>
-          </a:fontRef>
-        </p:style>
-        <p:txBody>
-          <a:bodyPr rtlCol="0" anchor="ctr"/>
-          <a:lstStyle/>
-          <a:p>
-            <a:pPr algn="ctr"/>
-          </a:p>
-        </p:txBody>
-      </p:sp>
-      <p:sp>
-        <p:nvSpPr>
-          <p:cNvPr id="30" name="Rectangle 29"/>
-          <p:cNvSpPr/>
-          <p:nvPr/>
-        </p:nvSpPr>
-        <p:spPr>
-          <a:xfrm>
-            <a:off x="5486400" y="4398264"/>
-            <a:ext cx="640080" cy="914400"/>
+            <a:off x="6693408" y="1399032"/>
+            <a:ext cx="640080" cy="502920"/>
           </a:xfrm>
           <a:prstGeom prst="rect">
             <a:avLst/>
@@ -6839,14 +6301,14 @@
       </p:sp>
       <p:sp>
         <p:nvSpPr>
-          <p:cNvPr id="31" name="TextBox 30"/>
+          <p:cNvPr id="16" name="TextBox 15"/>
           <p:cNvSpPr txBox="1"/>
           <p:nvPr/>
         </p:nvSpPr>
         <p:spPr>
           <a:xfrm>
-            <a:off x="5532120" y="4626864"/>
-            <a:ext cx="548640" cy="457200"/>
+            <a:off x="6693408" y="1399032"/>
+            <a:ext cx="640080" cy="502920"/>
           </a:xfrm>
           <a:prstGeom prst="rect">
             <a:avLst/>
@@ -6861,26 +6323,27 @@
           <a:p>
             <a:pPr algn="ctr"/>
             <a:r>
-              <a:rPr sz="1600" b="1" i="0">
+              <a:rPr sz="1600" b="1">
                 <a:solidFill>
                   <a:srgbClr val="1A2A4A"/>
                 </a:solidFill>
+                <a:latin typeface="Arial"/>
               </a:rPr>
-              <a:t>04</a:t>
+              <a:t>02</a:t>
             </a:r>
           </a:p>
         </p:txBody>
       </p:sp>
       <p:sp>
         <p:nvSpPr>
-          <p:cNvPr id="32" name="TextBox 31"/>
+          <p:cNvPr id="17" name="TextBox 16"/>
           <p:cNvSpPr txBox="1"/>
           <p:nvPr/>
         </p:nvSpPr>
         <p:spPr>
           <a:xfrm>
-            <a:off x="6309360" y="4471416"/>
-            <a:ext cx="11430000" cy="411480"/>
+            <a:off x="6629400" y="1965960"/>
+            <a:ext cx="5029200" cy="594360"/>
           </a:xfrm>
           <a:prstGeom prst="rect">
             <a:avLst/>
@@ -6893,28 +6356,29 @@
           </a:bodyPr>
           <a:lstStyle/>
           <a:p>
-            <a:pPr algn="r"/>
+            <a:pPr algn="ctr"/>
             <a:r>
-              <a:rPr sz="1600" b="1" i="0">
+              <a:rPr sz="1800" b="1">
                 <a:solidFill>
                   <a:srgbClr val="FFFFFF"/>
                 </a:solidFill>
+                <a:latin typeface="Arial"/>
               </a:rPr>
-              <a:t>الإبلاغ الفوري عن الاختراقات</a:t>
+              <a:t>توثيق هوية المستخدمين</a:t>
             </a:r>
           </a:p>
         </p:txBody>
       </p:sp>
       <p:sp>
         <p:nvSpPr>
-          <p:cNvPr id="33" name="TextBox 32"/>
+          <p:cNvPr id="18" name="TextBox 17"/>
           <p:cNvSpPr txBox="1"/>
           <p:nvPr/>
         </p:nvSpPr>
         <p:spPr>
           <a:xfrm>
-            <a:off x="6309360" y="4901184"/>
-            <a:ext cx="11430000" cy="320040"/>
+            <a:off x="6629400" y="2560320"/>
+            <a:ext cx="5029200" cy="457200"/>
           </a:xfrm>
           <a:prstGeom prst="rect">
             <a:avLst/>
@@ -6927,36 +6391,37 @@
           </a:bodyPr>
           <a:lstStyle/>
           <a:p>
-            <a:pPr algn="r"/>
+            <a:pPr algn="ctr"/>
             <a:r>
-              <a:rPr sz="1100" b="0" i="1">
+              <a:rPr sz="1200" b="0">
                 <a:solidFill>
                   <a:srgbClr val="C9A84C"/>
                 </a:solidFill>
+                <a:latin typeface="Arial"/>
               </a:rPr>
-              <a:t>Mandatory Breach Reporting</a:t>
+              <a:t>User Identity Verification</a:t>
             </a:r>
           </a:p>
         </p:txBody>
       </p:sp>
       <p:sp>
         <p:nvSpPr>
-          <p:cNvPr id="34" name="Rectangle 33"/>
+          <p:cNvPr id="19" name="Rectangle 18"/>
           <p:cNvSpPr/>
           <p:nvPr/>
         </p:nvSpPr>
         <p:spPr>
           <a:xfrm>
-            <a:off x="5486400" y="5422392"/>
-            <a:ext cx="12435840" cy="914400"/>
+            <a:off x="12298680" y="1234440"/>
+            <a:ext cx="5303520" cy="1920240"/>
           </a:xfrm>
           <a:prstGeom prst="rect">
             <a:avLst/>
           </a:prstGeom>
           <a:solidFill>
-            <a:srgbClr val="243860"/>
+            <a:srgbClr val="22355E"/>
           </a:solidFill>
-          <a:ln w="12700">
+          <a:ln w="19050">
             <a:solidFill>
               <a:srgbClr val="C9A84C"/>
             </a:solidFill>
@@ -6986,14 +6451,14 @@
       </p:sp>
       <p:sp>
         <p:nvSpPr>
-          <p:cNvPr id="35" name="Rectangle 34"/>
+          <p:cNvPr id="20" name="Rectangle 19"/>
           <p:cNvSpPr/>
           <p:nvPr/>
         </p:nvSpPr>
         <p:spPr>
           <a:xfrm>
-            <a:off x="5486400" y="5422392"/>
-            <a:ext cx="640080" cy="914400"/>
+            <a:off x="12298680" y="1234440"/>
+            <a:ext cx="109728" cy="1920240"/>
           </a:xfrm>
           <a:prstGeom prst="rect">
             <a:avLst/>
@@ -7029,14 +6494,57 @@
       </p:sp>
       <p:sp>
         <p:nvSpPr>
-          <p:cNvPr id="36" name="TextBox 35"/>
+          <p:cNvPr id="21" name="Rectangle 20"/>
+          <p:cNvSpPr/>
+          <p:nvPr/>
+        </p:nvSpPr>
+        <p:spPr>
+          <a:xfrm>
+            <a:off x="12499848" y="1399032"/>
+            <a:ext cx="640080" cy="502920"/>
+          </a:xfrm>
+          <a:prstGeom prst="rect">
+            <a:avLst/>
+          </a:prstGeom>
+          <a:solidFill>
+            <a:srgbClr val="C9A84C"/>
+          </a:solidFill>
+          <a:ln>
+            <a:noFill/>
+          </a:ln>
+        </p:spPr>
+        <p:style>
+          <a:lnRef idx="1">
+            <a:schemeClr val="accent1"/>
+          </a:lnRef>
+          <a:fillRef idx="3">
+            <a:schemeClr val="accent1"/>
+          </a:fillRef>
+          <a:effectRef idx="2">
+            <a:schemeClr val="accent1"/>
+          </a:effectRef>
+          <a:fontRef idx="minor">
+            <a:schemeClr val="lt1"/>
+          </a:fontRef>
+        </p:style>
+        <p:txBody>
+          <a:bodyPr rtlCol="0" anchor="ctr"/>
+          <a:lstStyle/>
+          <a:p>
+            <a:pPr algn="ctr"/>
+          </a:p>
+        </p:txBody>
+      </p:sp>
+      <p:sp>
+        <p:nvSpPr>
+          <p:cNvPr id="22" name="TextBox 21"/>
           <p:cNvSpPr txBox="1"/>
           <p:nvPr/>
         </p:nvSpPr>
         <p:spPr>
           <a:xfrm>
-            <a:off x="5532120" y="5650992"/>
-            <a:ext cx="548640" cy="457200"/>
+            <a:off x="12499848" y="1399032"/>
+            <a:ext cx="640080" cy="502920"/>
           </a:xfrm>
           <a:prstGeom prst="rect">
             <a:avLst/>
@@ -7051,26 +6559,27 @@
           <a:p>
             <a:pPr algn="ctr"/>
             <a:r>
-              <a:rPr sz="1600" b="1" i="0">
+              <a:rPr sz="1600" b="1">
                 <a:solidFill>
                   <a:srgbClr val="1A2A4A"/>
                 </a:solidFill>
+                <a:latin typeface="Arial"/>
               </a:rPr>
-              <a:t>05</a:t>
+              <a:t>03</a:t>
             </a:r>
           </a:p>
         </p:txBody>
       </p:sp>
       <p:sp>
         <p:nvSpPr>
-          <p:cNvPr id="37" name="TextBox 36"/>
+          <p:cNvPr id="23" name="TextBox 22"/>
           <p:cNvSpPr txBox="1"/>
           <p:nvPr/>
         </p:nvSpPr>
         <p:spPr>
           <a:xfrm>
-            <a:off x="6309360" y="5495544"/>
-            <a:ext cx="11430000" cy="411480"/>
+            <a:off x="12435840" y="1965960"/>
+            <a:ext cx="5029200" cy="594360"/>
           </a:xfrm>
           <a:prstGeom prst="rect">
             <a:avLst/>
@@ -7083,28 +6592,29 @@
           </a:bodyPr>
           <a:lstStyle/>
           <a:p>
-            <a:pPr algn="r"/>
+            <a:pPr algn="ctr"/>
             <a:r>
-              <a:rPr sz="1600" b="1" i="0">
+              <a:rPr sz="1800" b="1">
                 <a:solidFill>
                   <a:srgbClr val="FFFFFF"/>
                 </a:solidFill>
+                <a:latin typeface="Arial"/>
               </a:rPr>
-              <a:t>ضبط صلاحيات الوصول</a:t>
+              <a:t>رقابة أولياء الأمور</a:t>
             </a:r>
           </a:p>
         </p:txBody>
       </p:sp>
       <p:sp>
         <p:nvSpPr>
-          <p:cNvPr id="38" name="TextBox 37"/>
+          <p:cNvPr id="24" name="TextBox 23"/>
           <p:cNvSpPr txBox="1"/>
           <p:nvPr/>
         </p:nvSpPr>
         <p:spPr>
           <a:xfrm>
-            <a:off x="6309360" y="5925312"/>
-            <a:ext cx="11430000" cy="320040"/>
+            <a:off x="12435840" y="2560320"/>
+            <a:ext cx="5029200" cy="457200"/>
           </a:xfrm>
           <a:prstGeom prst="rect">
             <a:avLst/>
@@ -7117,28 +6627,160 @@
           </a:bodyPr>
           <a:lstStyle/>
           <a:p>
-            <a:pPr algn="r"/>
+            <a:pPr algn="ctr"/>
             <a:r>
-              <a:rPr sz="1100" b="0" i="1">
+              <a:rPr sz="1200" b="0">
                 <a:solidFill>
                   <a:srgbClr val="C9A84C"/>
                 </a:solidFill>
+                <a:latin typeface="Arial"/>
               </a:rPr>
-              <a:t>Granular Access Control</a:t>
+              <a:t>Parental Monitoring &amp; Control</a:t>
             </a:r>
           </a:p>
         </p:txBody>
       </p:sp>
       <p:sp>
         <p:nvSpPr>
-          <p:cNvPr id="39" name="TextBox 38"/>
+          <p:cNvPr id="25" name="Rectangle 24"/>
+          <p:cNvSpPr/>
+          <p:nvPr/>
+        </p:nvSpPr>
+        <p:spPr>
+          <a:xfrm>
+            <a:off x="3589020" y="3429000"/>
+            <a:ext cx="5303520" cy="1920240"/>
+          </a:xfrm>
+          <a:prstGeom prst="rect">
+            <a:avLst/>
+          </a:prstGeom>
+          <a:solidFill>
+            <a:srgbClr val="22355E"/>
+          </a:solidFill>
+          <a:ln w="19050">
+            <a:solidFill>
+              <a:srgbClr val="C9A84C"/>
+            </a:solidFill>
+          </a:ln>
+        </p:spPr>
+        <p:style>
+          <a:lnRef idx="1">
+            <a:schemeClr val="accent1"/>
+          </a:lnRef>
+          <a:fillRef idx="3">
+            <a:schemeClr val="accent1"/>
+          </a:fillRef>
+          <a:effectRef idx="2">
+            <a:schemeClr val="accent1"/>
+          </a:effectRef>
+          <a:fontRef idx="minor">
+            <a:schemeClr val="lt1"/>
+          </a:fontRef>
+        </p:style>
+        <p:txBody>
+          <a:bodyPr rtlCol="0" anchor="ctr"/>
+          <a:lstStyle/>
+          <a:p>
+            <a:pPr algn="ctr"/>
+          </a:p>
+        </p:txBody>
+      </p:sp>
+      <p:sp>
+        <p:nvSpPr>
+          <p:cNvPr id="26" name="Rectangle 25"/>
+          <p:cNvSpPr/>
+          <p:nvPr/>
+        </p:nvSpPr>
+        <p:spPr>
+          <a:xfrm>
+            <a:off x="3589020" y="3429000"/>
+            <a:ext cx="109728" cy="1920240"/>
+          </a:xfrm>
+          <a:prstGeom prst="rect">
+            <a:avLst/>
+          </a:prstGeom>
+          <a:solidFill>
+            <a:srgbClr val="C9A84C"/>
+          </a:solidFill>
+          <a:ln>
+            <a:noFill/>
+          </a:ln>
+        </p:spPr>
+        <p:style>
+          <a:lnRef idx="1">
+            <a:schemeClr val="accent1"/>
+          </a:lnRef>
+          <a:fillRef idx="3">
+            <a:schemeClr val="accent1"/>
+          </a:fillRef>
+          <a:effectRef idx="2">
+            <a:schemeClr val="accent1"/>
+          </a:effectRef>
+          <a:fontRef idx="minor">
+            <a:schemeClr val="lt1"/>
+          </a:fontRef>
+        </p:style>
+        <p:txBody>
+          <a:bodyPr rtlCol="0" anchor="ctr"/>
+          <a:lstStyle/>
+          <a:p>
+            <a:pPr algn="ctr"/>
+          </a:p>
+        </p:txBody>
+      </p:sp>
+      <p:sp>
+        <p:nvSpPr>
+          <p:cNvPr id="27" name="Rectangle 26"/>
+          <p:cNvSpPr/>
+          <p:nvPr/>
+        </p:nvSpPr>
+        <p:spPr>
+          <a:xfrm>
+            <a:off x="3790188" y="3593592"/>
+            <a:ext cx="640080" cy="502920"/>
+          </a:xfrm>
+          <a:prstGeom prst="rect">
+            <a:avLst/>
+          </a:prstGeom>
+          <a:solidFill>
+            <a:srgbClr val="C9A84C"/>
+          </a:solidFill>
+          <a:ln>
+            <a:noFill/>
+          </a:ln>
+        </p:spPr>
+        <p:style>
+          <a:lnRef idx="1">
+            <a:schemeClr val="accent1"/>
+          </a:lnRef>
+          <a:fillRef idx="3">
+            <a:schemeClr val="accent1"/>
+          </a:fillRef>
+          <a:effectRef idx="2">
+            <a:schemeClr val="accent1"/>
+          </a:effectRef>
+          <a:fontRef idx="minor">
+            <a:schemeClr val="lt1"/>
+          </a:fontRef>
+        </p:style>
+        <p:txBody>
+          <a:bodyPr rtlCol="0" anchor="ctr"/>
+          <a:lstStyle/>
+          <a:p>
+            <a:pPr algn="ctr"/>
+          </a:p>
+        </p:txBody>
+      </p:sp>
+      <p:sp>
+        <p:nvSpPr>
+          <p:cNvPr id="28" name="TextBox 27"/>
           <p:cNvSpPr txBox="1"/>
           <p:nvPr/>
         </p:nvSpPr>
         <p:spPr>
           <a:xfrm>
-            <a:off x="274320" y="10058400"/>
-            <a:ext cx="17739360" cy="201168"/>
+            <a:off x="3790188" y="3593592"/>
+            <a:ext cx="640080" cy="502920"/>
           </a:xfrm>
           <a:prstGeom prst="rect">
             <a:avLst/>
@@ -7153,10 +6795,438 @@
           <a:p>
             <a:pPr algn="ctr"/>
             <a:r>
-              <a:rPr sz="1100" b="0" i="0">
+              <a:rPr sz="1600" b="1">
                 <a:solidFill>
                   <a:srgbClr val="1A2A4A"/>
                 </a:solidFill>
+                <a:latin typeface="Arial"/>
+              </a:rPr>
+              <a:t>04</a:t>
+            </a:r>
+          </a:p>
+        </p:txBody>
+      </p:sp>
+      <p:sp>
+        <p:nvSpPr>
+          <p:cNvPr id="29" name="TextBox 28"/>
+          <p:cNvSpPr txBox="1"/>
+          <p:nvPr/>
+        </p:nvSpPr>
+        <p:spPr>
+          <a:xfrm>
+            <a:off x="3726180" y="4160520"/>
+            <a:ext cx="5029200" cy="594360"/>
+          </a:xfrm>
+          <a:prstGeom prst="rect">
+            <a:avLst/>
+          </a:prstGeom>
+          <a:noFill/>
+        </p:spPr>
+        <p:txBody>
+          <a:bodyPr wrap="square">
+            <a:spAutoFit/>
+          </a:bodyPr>
+          <a:lstStyle/>
+          <a:p>
+            <a:pPr algn="ctr"/>
+            <a:r>
+              <a:rPr sz="1800" b="1">
+                <a:solidFill>
+                  <a:srgbClr val="FFFFFF"/>
+                </a:solidFill>
+                <a:latin typeface="Arial"/>
+              </a:rPr>
+              <a:t>الإبلاغ الفوري عن الاختراقات</a:t>
+            </a:r>
+          </a:p>
+        </p:txBody>
+      </p:sp>
+      <p:sp>
+        <p:nvSpPr>
+          <p:cNvPr id="30" name="TextBox 29"/>
+          <p:cNvSpPr txBox="1"/>
+          <p:nvPr/>
+        </p:nvSpPr>
+        <p:spPr>
+          <a:xfrm>
+            <a:off x="3726180" y="4754880"/>
+            <a:ext cx="5029200" cy="457200"/>
+          </a:xfrm>
+          <a:prstGeom prst="rect">
+            <a:avLst/>
+          </a:prstGeom>
+          <a:noFill/>
+        </p:spPr>
+        <p:txBody>
+          <a:bodyPr wrap="square">
+            <a:spAutoFit/>
+          </a:bodyPr>
+          <a:lstStyle/>
+          <a:p>
+            <a:pPr algn="ctr"/>
+            <a:r>
+              <a:rPr sz="1200" b="0">
+                <a:solidFill>
+                  <a:srgbClr val="C9A84C"/>
+                </a:solidFill>
+                <a:latin typeface="Arial"/>
+              </a:rPr>
+              <a:t>Mandatory Breach Reporting</a:t>
+            </a:r>
+          </a:p>
+        </p:txBody>
+      </p:sp>
+      <p:sp>
+        <p:nvSpPr>
+          <p:cNvPr id="31" name="Rectangle 30"/>
+          <p:cNvSpPr/>
+          <p:nvPr/>
+        </p:nvSpPr>
+        <p:spPr>
+          <a:xfrm>
+            <a:off x="9395460" y="3429000"/>
+            <a:ext cx="5303520" cy="1920240"/>
+          </a:xfrm>
+          <a:prstGeom prst="rect">
+            <a:avLst/>
+          </a:prstGeom>
+          <a:solidFill>
+            <a:srgbClr val="22355E"/>
+          </a:solidFill>
+          <a:ln w="19050">
+            <a:solidFill>
+              <a:srgbClr val="C9A84C"/>
+            </a:solidFill>
+          </a:ln>
+        </p:spPr>
+        <p:style>
+          <a:lnRef idx="1">
+            <a:schemeClr val="accent1"/>
+          </a:lnRef>
+          <a:fillRef idx="3">
+            <a:schemeClr val="accent1"/>
+          </a:fillRef>
+          <a:effectRef idx="2">
+            <a:schemeClr val="accent1"/>
+          </a:effectRef>
+          <a:fontRef idx="minor">
+            <a:schemeClr val="lt1"/>
+          </a:fontRef>
+        </p:style>
+        <p:txBody>
+          <a:bodyPr rtlCol="0" anchor="ctr"/>
+          <a:lstStyle/>
+          <a:p>
+            <a:pPr algn="ctr"/>
+          </a:p>
+        </p:txBody>
+      </p:sp>
+      <p:sp>
+        <p:nvSpPr>
+          <p:cNvPr id="32" name="Rectangle 31"/>
+          <p:cNvSpPr/>
+          <p:nvPr/>
+        </p:nvSpPr>
+        <p:spPr>
+          <a:xfrm>
+            <a:off x="9395460" y="3429000"/>
+            <a:ext cx="109728" cy="1920240"/>
+          </a:xfrm>
+          <a:prstGeom prst="rect">
+            <a:avLst/>
+          </a:prstGeom>
+          <a:solidFill>
+            <a:srgbClr val="C9A84C"/>
+          </a:solidFill>
+          <a:ln>
+            <a:noFill/>
+          </a:ln>
+        </p:spPr>
+        <p:style>
+          <a:lnRef idx="1">
+            <a:schemeClr val="accent1"/>
+          </a:lnRef>
+          <a:fillRef idx="3">
+            <a:schemeClr val="accent1"/>
+          </a:fillRef>
+          <a:effectRef idx="2">
+            <a:schemeClr val="accent1"/>
+          </a:effectRef>
+          <a:fontRef idx="minor">
+            <a:schemeClr val="lt1"/>
+          </a:fontRef>
+        </p:style>
+        <p:txBody>
+          <a:bodyPr rtlCol="0" anchor="ctr"/>
+          <a:lstStyle/>
+          <a:p>
+            <a:pPr algn="ctr"/>
+          </a:p>
+        </p:txBody>
+      </p:sp>
+      <p:sp>
+        <p:nvSpPr>
+          <p:cNvPr id="33" name="Rectangle 32"/>
+          <p:cNvSpPr/>
+          <p:nvPr/>
+        </p:nvSpPr>
+        <p:spPr>
+          <a:xfrm>
+            <a:off x="9596628" y="3593592"/>
+            <a:ext cx="640080" cy="502920"/>
+          </a:xfrm>
+          <a:prstGeom prst="rect">
+            <a:avLst/>
+          </a:prstGeom>
+          <a:solidFill>
+            <a:srgbClr val="C9A84C"/>
+          </a:solidFill>
+          <a:ln>
+            <a:noFill/>
+          </a:ln>
+        </p:spPr>
+        <p:style>
+          <a:lnRef idx="1">
+            <a:schemeClr val="accent1"/>
+          </a:lnRef>
+          <a:fillRef idx="3">
+            <a:schemeClr val="accent1"/>
+          </a:fillRef>
+          <a:effectRef idx="2">
+            <a:schemeClr val="accent1"/>
+          </a:effectRef>
+          <a:fontRef idx="minor">
+            <a:schemeClr val="lt1"/>
+          </a:fontRef>
+        </p:style>
+        <p:txBody>
+          <a:bodyPr rtlCol="0" anchor="ctr"/>
+          <a:lstStyle/>
+          <a:p>
+            <a:pPr algn="ctr"/>
+          </a:p>
+        </p:txBody>
+      </p:sp>
+      <p:sp>
+        <p:nvSpPr>
+          <p:cNvPr id="34" name="TextBox 33"/>
+          <p:cNvSpPr txBox="1"/>
+          <p:nvPr/>
+        </p:nvSpPr>
+        <p:spPr>
+          <a:xfrm>
+            <a:off x="9596628" y="3593592"/>
+            <a:ext cx="640080" cy="502920"/>
+          </a:xfrm>
+          <a:prstGeom prst="rect">
+            <a:avLst/>
+          </a:prstGeom>
+          <a:noFill/>
+        </p:spPr>
+        <p:txBody>
+          <a:bodyPr wrap="square">
+            <a:spAutoFit/>
+          </a:bodyPr>
+          <a:lstStyle/>
+          <a:p>
+            <a:pPr algn="ctr"/>
+            <a:r>
+              <a:rPr sz="1600" b="1">
+                <a:solidFill>
+                  <a:srgbClr val="1A2A4A"/>
+                </a:solidFill>
+                <a:latin typeface="Arial"/>
+              </a:rPr>
+              <a:t>05</a:t>
+            </a:r>
+          </a:p>
+        </p:txBody>
+      </p:sp>
+      <p:sp>
+        <p:nvSpPr>
+          <p:cNvPr id="35" name="TextBox 34"/>
+          <p:cNvSpPr txBox="1"/>
+          <p:nvPr/>
+        </p:nvSpPr>
+        <p:spPr>
+          <a:xfrm>
+            <a:off x="9532620" y="4160520"/>
+            <a:ext cx="5029200" cy="594360"/>
+          </a:xfrm>
+          <a:prstGeom prst="rect">
+            <a:avLst/>
+          </a:prstGeom>
+          <a:noFill/>
+        </p:spPr>
+        <p:txBody>
+          <a:bodyPr wrap="square">
+            <a:spAutoFit/>
+          </a:bodyPr>
+          <a:lstStyle/>
+          <a:p>
+            <a:pPr algn="ctr"/>
+            <a:r>
+              <a:rPr sz="1800" b="1">
+                <a:solidFill>
+                  <a:srgbClr val="FFFFFF"/>
+                </a:solidFill>
+                <a:latin typeface="Arial"/>
+              </a:rPr>
+              <a:t>ضبط صلاحيات الوصول</a:t>
+            </a:r>
+          </a:p>
+        </p:txBody>
+      </p:sp>
+      <p:sp>
+        <p:nvSpPr>
+          <p:cNvPr id="36" name="TextBox 35"/>
+          <p:cNvSpPr txBox="1"/>
+          <p:nvPr/>
+        </p:nvSpPr>
+        <p:spPr>
+          <a:xfrm>
+            <a:off x="9532620" y="4754880"/>
+            <a:ext cx="5029200" cy="457200"/>
+          </a:xfrm>
+          <a:prstGeom prst="rect">
+            <a:avLst/>
+          </a:prstGeom>
+          <a:noFill/>
+        </p:spPr>
+        <p:txBody>
+          <a:bodyPr wrap="square">
+            <a:spAutoFit/>
+          </a:bodyPr>
+          <a:lstStyle/>
+          <a:p>
+            <a:pPr algn="ctr"/>
+            <a:r>
+              <a:rPr sz="1200" b="0">
+                <a:solidFill>
+                  <a:srgbClr val="C9A84C"/>
+                </a:solidFill>
+                <a:latin typeface="Arial"/>
+              </a:rPr>
+              <a:t>Granular Access Control</a:t>
+            </a:r>
+          </a:p>
+        </p:txBody>
+      </p:sp>
+      <p:sp>
+        <p:nvSpPr>
+          <p:cNvPr id="37" name="Rectangle 36"/>
+          <p:cNvSpPr/>
+          <p:nvPr/>
+        </p:nvSpPr>
+        <p:spPr>
+          <a:xfrm>
+            <a:off x="0" y="9784080"/>
+            <a:ext cx="18288000" cy="502920"/>
+          </a:xfrm>
+          <a:prstGeom prst="rect">
+            <a:avLst/>
+          </a:prstGeom>
+          <a:solidFill>
+            <a:srgbClr val="0F1A30"/>
+          </a:solidFill>
+          <a:ln>
+            <a:noFill/>
+          </a:ln>
+        </p:spPr>
+        <p:style>
+          <a:lnRef idx="1">
+            <a:schemeClr val="accent1"/>
+          </a:lnRef>
+          <a:fillRef idx="3">
+            <a:schemeClr val="accent1"/>
+          </a:fillRef>
+          <a:effectRef idx="2">
+            <a:schemeClr val="accent1"/>
+          </a:effectRef>
+          <a:fontRef idx="minor">
+            <a:schemeClr val="lt1"/>
+          </a:fontRef>
+        </p:style>
+        <p:txBody>
+          <a:bodyPr rtlCol="0" anchor="ctr"/>
+          <a:lstStyle/>
+          <a:p>
+            <a:pPr algn="ctr"/>
+          </a:p>
+        </p:txBody>
+      </p:sp>
+      <p:sp>
+        <p:nvSpPr>
+          <p:cNvPr id="38" name="Rectangle 37"/>
+          <p:cNvSpPr/>
+          <p:nvPr/>
+        </p:nvSpPr>
+        <p:spPr>
+          <a:xfrm>
+            <a:off x="0" y="9784080"/>
+            <a:ext cx="18288000" cy="45720"/>
+          </a:xfrm>
+          <a:prstGeom prst="rect">
+            <a:avLst/>
+          </a:prstGeom>
+          <a:solidFill>
+            <a:srgbClr val="C9A84C"/>
+          </a:solidFill>
+          <a:ln>
+            <a:noFill/>
+          </a:ln>
+        </p:spPr>
+        <p:style>
+          <a:lnRef idx="1">
+            <a:schemeClr val="accent1"/>
+          </a:lnRef>
+          <a:fillRef idx="3">
+            <a:schemeClr val="accent1"/>
+          </a:fillRef>
+          <a:effectRef idx="2">
+            <a:schemeClr val="accent1"/>
+          </a:effectRef>
+          <a:fontRef idx="minor">
+            <a:schemeClr val="lt1"/>
+          </a:fontRef>
+        </p:style>
+        <p:txBody>
+          <a:bodyPr rtlCol="0" anchor="ctr"/>
+          <a:lstStyle/>
+          <a:p>
+            <a:pPr algn="ctr"/>
+          </a:p>
+        </p:txBody>
+      </p:sp>
+      <p:sp>
+        <p:nvSpPr>
+          <p:cNvPr id="39" name="TextBox 38"/>
+          <p:cNvSpPr txBox="1"/>
+          <p:nvPr/>
+        </p:nvSpPr>
+        <p:spPr>
+          <a:xfrm>
+            <a:off x="274320" y="9857232"/>
+            <a:ext cx="17739360" cy="347472"/>
+          </a:xfrm>
+          <a:prstGeom prst="rect">
+            <a:avLst/>
+          </a:prstGeom>
+          <a:noFill/>
+        </p:spPr>
+        <p:txBody>
+          <a:bodyPr wrap="square">
+            <a:spAutoFit/>
+          </a:bodyPr>
+          <a:lstStyle/>
+          <a:p>
+            <a:pPr algn="ctr"/>
+            <a:r>
+              <a:rPr sz="1400" b="0">
+                <a:solidFill>
+                  <a:srgbClr val="FFFFFF"/>
+                </a:solidFill>
+                <a:latin typeface="Arial"/>
               </a:rPr>
               <a:t>أول تشريع اتحادي إماراتي لحماية الطفل في الفضاء الرقمي — يناير 2026</a:t>
             </a:r>
@@ -7204,50 +7274,7 @@
         <p:spPr>
           <a:xfrm>
             <a:off x="0" y="0"/>
-            <a:ext cx="18288000" cy="10287000"/>
-          </a:xfrm>
-          <a:prstGeom prst="rect">
-            <a:avLst/>
-          </a:prstGeom>
-          <a:solidFill>
-            <a:srgbClr val="1A2A4A"/>
-          </a:solidFill>
-          <a:ln>
-            <a:noFill/>
-          </a:ln>
-        </p:spPr>
-        <p:style>
-          <a:lnRef idx="1">
-            <a:schemeClr val="accent1"/>
-          </a:lnRef>
-          <a:fillRef idx="3">
-            <a:schemeClr val="accent1"/>
-          </a:fillRef>
-          <a:effectRef idx="2">
-            <a:schemeClr val="accent1"/>
-          </a:effectRef>
-          <a:fontRef idx="minor">
-            <a:schemeClr val="lt1"/>
-          </a:fontRef>
-        </p:style>
-        <p:txBody>
-          <a:bodyPr rtlCol="0" anchor="ctr"/>
-          <a:lstStyle/>
-          <a:p>
-            <a:pPr algn="ctr"/>
-          </a:p>
-        </p:txBody>
-      </p:sp>
-      <p:sp>
-        <p:nvSpPr>
-          <p:cNvPr id="3" name="Rectangle 2"/>
-          <p:cNvSpPr/>
-          <p:nvPr/>
-        </p:nvSpPr>
-        <p:spPr>
-          <a:xfrm>
-            <a:off x="0" y="0"/>
-            <a:ext cx="18288000" cy="118872"/>
+            <a:ext cx="18288000" cy="73152"/>
           </a:xfrm>
           <a:prstGeom prst="rect">
             <a:avLst/>
@@ -7283,14 +7310,127 @@
       </p:sp>
       <p:sp>
         <p:nvSpPr>
-          <p:cNvPr id="4" name="Rectangle 3"/>
+          <p:cNvPr id="3" name="Rectangle 2"/>
           <p:cNvSpPr/>
           <p:nvPr/>
         </p:nvSpPr>
         <p:spPr>
           <a:xfrm>
-            <a:off x="0" y="10058400"/>
-            <a:ext cx="18288000" cy="228600"/>
+            <a:off x="0" y="73152"/>
+            <a:ext cx="18288000" cy="960120"/>
+          </a:xfrm>
+          <a:prstGeom prst="rect">
+            <a:avLst/>
+          </a:prstGeom>
+          <a:solidFill>
+            <a:srgbClr val="0F1A30"/>
+          </a:solidFill>
+          <a:ln>
+            <a:noFill/>
+          </a:ln>
+        </p:spPr>
+        <p:style>
+          <a:lnRef idx="1">
+            <a:schemeClr val="accent1"/>
+          </a:lnRef>
+          <a:fillRef idx="3">
+            <a:schemeClr val="accent1"/>
+          </a:fillRef>
+          <a:effectRef idx="2">
+            <a:schemeClr val="accent1"/>
+          </a:effectRef>
+          <a:fontRef idx="minor">
+            <a:schemeClr val="lt1"/>
+          </a:fontRef>
+        </p:style>
+        <p:txBody>
+          <a:bodyPr rtlCol="0" anchor="ctr"/>
+          <a:lstStyle/>
+          <a:p>
+            <a:pPr algn="ctr"/>
+          </a:p>
+        </p:txBody>
+      </p:sp>
+      <p:sp>
+        <p:nvSpPr>
+          <p:cNvPr id="4" name="TextBox 3"/>
+          <p:cNvSpPr txBox="1"/>
+          <p:nvPr/>
+        </p:nvSpPr>
+        <p:spPr>
+          <a:xfrm>
+            <a:off x="274320" y="109728"/>
+            <a:ext cx="17739360" cy="548640"/>
+          </a:xfrm>
+          <a:prstGeom prst="rect">
+            <a:avLst/>
+          </a:prstGeom>
+          <a:noFill/>
+        </p:spPr>
+        <p:txBody>
+          <a:bodyPr wrap="square">
+            <a:spAutoFit/>
+          </a:bodyPr>
+          <a:lstStyle/>
+          <a:p>
+            <a:pPr algn="ctr"/>
+            <a:r>
+              <a:rPr sz="2800" b="1">
+                <a:solidFill>
+                  <a:srgbClr val="C9A84C"/>
+                </a:solidFill>
+                <a:latin typeface="Arial"/>
+              </a:rPr>
+              <a:t>كيف تُجسّد بوابة الجود أحكام القانون؟</a:t>
+            </a:r>
+          </a:p>
+        </p:txBody>
+      </p:sp>
+      <p:sp>
+        <p:nvSpPr>
+          <p:cNvPr id="5" name="TextBox 4"/>
+          <p:cNvSpPr txBox="1"/>
+          <p:nvPr/>
+        </p:nvSpPr>
+        <p:spPr>
+          <a:xfrm>
+            <a:off x="274320" y="658368"/>
+            <a:ext cx="17739360" cy="347472"/>
+          </a:xfrm>
+          <a:prstGeom prst="rect">
+            <a:avLst/>
+          </a:prstGeom>
+          <a:noFill/>
+        </p:spPr>
+        <p:txBody>
+          <a:bodyPr wrap="square">
+            <a:spAutoFit/>
+          </a:bodyPr>
+          <a:lstStyle/>
+          <a:p>
+            <a:pPr algn="ctr"/>
+            <a:r>
+              <a:rPr sz="1400" b="0">
+                <a:solidFill>
+                  <a:srgbClr val="FFFFFF"/>
+                </a:solidFill>
+                <a:latin typeface="Arial"/>
+              </a:rPr>
+              <a:t>Al Jood Portal — Compliance with Child Digital Safety Law</a:t>
+            </a:r>
+          </a:p>
+        </p:txBody>
+      </p:sp>
+      <p:sp>
+        <p:nvSpPr>
+          <p:cNvPr id="6" name="Rectangle 5"/>
+          <p:cNvSpPr/>
+          <p:nvPr/>
+        </p:nvSpPr>
+        <p:spPr>
+          <a:xfrm>
+            <a:off x="0" y="1033271"/>
+            <a:ext cx="18288000" cy="45720"/>
           </a:xfrm>
           <a:prstGeom prst="rect">
             <a:avLst/>
@@ -7326,82 +7466,14 @@
       </p:sp>
       <p:sp>
         <p:nvSpPr>
-          <p:cNvPr id="5" name="TextBox 4"/>
-          <p:cNvSpPr txBox="1"/>
-          <p:nvPr/>
-        </p:nvSpPr>
-        <p:spPr>
-          <a:xfrm>
-            <a:off x="274320" y="182880"/>
-            <a:ext cx="17739360" cy="594360"/>
-          </a:xfrm>
-          <a:prstGeom prst="rect">
-            <a:avLst/>
-          </a:prstGeom>
-          <a:noFill/>
-        </p:spPr>
-        <p:txBody>
-          <a:bodyPr wrap="square">
-            <a:spAutoFit/>
-          </a:bodyPr>
-          <a:lstStyle/>
-          <a:p>
-            <a:pPr algn="r"/>
-            <a:r>
-              <a:rPr sz="2600" b="1" i="0">
-                <a:solidFill>
-                  <a:srgbClr val="C9A84C"/>
-                </a:solidFill>
-              </a:rPr>
-              <a:t>كيف تُجسّد بوابة الجود أحكام القانون؟</a:t>
-            </a:r>
-          </a:p>
-        </p:txBody>
-      </p:sp>
-      <p:sp>
-        <p:nvSpPr>
-          <p:cNvPr id="6" name="TextBox 5"/>
-          <p:cNvSpPr txBox="1"/>
-          <p:nvPr/>
-        </p:nvSpPr>
-        <p:spPr>
-          <a:xfrm>
-            <a:off x="274320" y="777240"/>
-            <a:ext cx="17739360" cy="292608"/>
-          </a:xfrm>
-          <a:prstGeom prst="rect">
-            <a:avLst/>
-          </a:prstGeom>
-          <a:noFill/>
-        </p:spPr>
-        <p:txBody>
-          <a:bodyPr wrap="square">
-            <a:spAutoFit/>
-          </a:bodyPr>
-          <a:lstStyle/>
-          <a:p>
-            <a:pPr algn="r"/>
-            <a:r>
-              <a:rPr sz="1200" b="0" i="1">
-                <a:solidFill>
-                  <a:srgbClr val="FFFFFF"/>
-                </a:solidFill>
-              </a:rPr>
-              <a:t>Al Jood Portal — Compliance with Child Digital Safety Law</a:t>
-            </a:r>
-          </a:p>
-        </p:txBody>
-      </p:sp>
-      <p:sp>
-        <p:nvSpPr>
           <p:cNvPr id="7" name="Rectangle 6"/>
           <p:cNvSpPr/>
           <p:nvPr/>
         </p:nvSpPr>
         <p:spPr>
           <a:xfrm>
-            <a:off x="274320" y="1234440"/>
-            <a:ext cx="8229600" cy="502920"/>
+            <a:off x="457200" y="1234440"/>
+            <a:ext cx="6601968" cy="594360"/>
           </a:xfrm>
           <a:prstGeom prst="rect">
             <a:avLst/>
@@ -7443,8 +7515,8 @@
         </p:nvSpPr>
         <p:spPr>
           <a:xfrm>
-            <a:off x="274320" y="1261872"/>
-            <a:ext cx="8138160" cy="457200"/>
+            <a:off x="457200" y="1234440"/>
+            <a:ext cx="6601968" cy="594360"/>
           </a:xfrm>
           <a:prstGeom prst="rect">
             <a:avLst/>
@@ -7459,10 +7531,11 @@
           <a:p>
             <a:pPr algn="ctr"/>
             <a:r>
-              <a:rPr sz="1500" b="1" i="0">
+              <a:rPr sz="1800" b="1">
                 <a:solidFill>
                   <a:srgbClr val="1A2A4A"/>
                 </a:solidFill>
+                <a:latin typeface="Arial"/>
               </a:rPr>
               <a:t>متطلب القانون</a:t>
             </a:r>
@@ -7477,16 +7550,16 @@
         </p:nvSpPr>
         <p:spPr>
           <a:xfrm>
-            <a:off x="8686800" y="1234440"/>
-            <a:ext cx="9281160" cy="502920"/>
+            <a:off x="7059168" y="1234440"/>
+            <a:ext cx="10771632" cy="594360"/>
           </a:xfrm>
           <a:prstGeom prst="rect">
             <a:avLst/>
           </a:prstGeom>
           <a:solidFill>
-            <a:srgbClr val="243860"/>
+            <a:srgbClr val="22355E"/>
           </a:solidFill>
-          <a:ln w="12700">
+          <a:ln w="19050">
             <a:solidFill>
               <a:srgbClr val="C9A84C"/>
             </a:solidFill>
@@ -7522,8 +7595,8 @@
         </p:nvSpPr>
         <p:spPr>
           <a:xfrm>
-            <a:off x="8686800" y="1261872"/>
-            <a:ext cx="9189720" cy="457200"/>
+            <a:off x="7059168" y="1234440"/>
+            <a:ext cx="10771632" cy="594360"/>
           </a:xfrm>
           <a:prstGeom prst="rect">
             <a:avLst/>
@@ -7538,12 +7611,13 @@
           <a:p>
             <a:pPr algn="ctr"/>
             <a:r>
-              <a:rPr sz="1500" b="1" i="0">
+              <a:rPr sz="1800" b="1">
                 <a:solidFill>
                   <a:srgbClr val="C9A84C"/>
                 </a:solidFill>
+                <a:latin typeface="Arial"/>
               </a:rPr>
-              <a:t>ميزة بوابة الجود</a:t>
+              <a:t>ميزة بوابة مدرسة الجود</a:t>
             </a:r>
           </a:p>
         </p:txBody>
@@ -7556,14 +7630,14 @@
         </p:nvSpPr>
         <p:spPr>
           <a:xfrm>
-            <a:off x="274320" y="1783080"/>
-            <a:ext cx="8229600" cy="804672"/>
+            <a:off x="457200" y="1828800"/>
+            <a:ext cx="6601968" cy="804672"/>
           </a:xfrm>
           <a:prstGeom prst="rect">
             <a:avLst/>
           </a:prstGeom>
           <a:solidFill>
-            <a:srgbClr val="243860"/>
+            <a:srgbClr val="1A2A4A"/>
           </a:solidFill>
           <a:ln w="6350">
             <a:solidFill>
@@ -7595,14 +7669,57 @@
       </p:sp>
       <p:sp>
         <p:nvSpPr>
-          <p:cNvPr id="12" name="TextBox 11"/>
+          <p:cNvPr id="12" name="Rectangle 11"/>
+          <p:cNvSpPr/>
+          <p:nvPr/>
+        </p:nvSpPr>
+        <p:spPr>
+          <a:xfrm>
+            <a:off x="457200" y="1828800"/>
+            <a:ext cx="82296" cy="804672"/>
+          </a:xfrm>
+          <a:prstGeom prst="rect">
+            <a:avLst/>
+          </a:prstGeom>
+          <a:solidFill>
+            <a:srgbClr val="C9A84C"/>
+          </a:solidFill>
+          <a:ln>
+            <a:noFill/>
+          </a:ln>
+        </p:spPr>
+        <p:style>
+          <a:lnRef idx="1">
+            <a:schemeClr val="accent1"/>
+          </a:lnRef>
+          <a:fillRef idx="3">
+            <a:schemeClr val="accent1"/>
+          </a:fillRef>
+          <a:effectRef idx="2">
+            <a:schemeClr val="accent1"/>
+          </a:effectRef>
+          <a:fontRef idx="minor">
+            <a:schemeClr val="lt1"/>
+          </a:fontRef>
+        </p:style>
+        <p:txBody>
+          <a:bodyPr rtlCol="0" anchor="ctr"/>
+          <a:lstStyle/>
+          <a:p>
+            <a:pPr algn="ctr"/>
+          </a:p>
+        </p:txBody>
+      </p:sp>
+      <p:sp>
+        <p:nvSpPr>
+          <p:cNvPr id="13" name="TextBox 12"/>
           <p:cNvSpPr txBox="1"/>
           <p:nvPr/>
         </p:nvSpPr>
         <p:spPr>
           <a:xfrm>
-            <a:off x="320040" y="1965960"/>
-            <a:ext cx="8046720" cy="457200"/>
+            <a:off x="594360" y="1901952"/>
+            <a:ext cx="6419088" cy="658368"/>
           </a:xfrm>
           <a:prstGeom prst="rect">
             <a:avLst/>
@@ -7617,10 +7734,11 @@
           <a:p>
             <a:pPr algn="ctr"/>
             <a:r>
-              <a:rPr sz="1400" b="1" i="0">
+              <a:rPr sz="1600" b="1">
                 <a:solidFill>
                   <a:srgbClr val="FFFFFF"/>
                 </a:solidFill>
+                <a:latin typeface="Arial"/>
               </a:rPr>
               <a:t>حماية البيانات الرقمية</a:t>
             </a:r>
@@ -7629,20 +7747,20 @@
       </p:sp>
       <p:sp>
         <p:nvSpPr>
-          <p:cNvPr id="13" name="Rectangle 12"/>
+          <p:cNvPr id="14" name="Rectangle 13"/>
           <p:cNvSpPr/>
           <p:nvPr/>
         </p:nvSpPr>
         <p:spPr>
           <a:xfrm>
-            <a:off x="8686800" y="1783080"/>
-            <a:ext cx="9281160" cy="804672"/>
+            <a:off x="7059168" y="1828800"/>
+            <a:ext cx="10771632" cy="804672"/>
           </a:xfrm>
           <a:prstGeom prst="rect">
             <a:avLst/>
           </a:prstGeom>
           <a:solidFill>
-            <a:srgbClr val="243860"/>
+            <a:srgbClr val="1A2A4A"/>
           </a:solidFill>
           <a:ln w="6350">
             <a:solidFill>
@@ -7674,131 +7792,55 @@
       </p:sp>
       <p:sp>
         <p:nvSpPr>
-          <p:cNvPr id="14" name="Rectangle 13"/>
+          <p:cNvPr id="15" name="TextBox 14"/>
+          <p:cNvSpPr txBox="1"/>
+          <p:nvPr/>
+        </p:nvSpPr>
+        <p:spPr>
+          <a:xfrm>
+            <a:off x="7242048" y="1901952"/>
+            <a:ext cx="10497312" cy="658368"/>
+          </a:xfrm>
+          <a:prstGeom prst="rect">
+            <a:avLst/>
+          </a:prstGeom>
+          <a:noFill/>
+        </p:spPr>
+        <p:txBody>
+          <a:bodyPr wrap="square">
+            <a:spAutoFit/>
+          </a:bodyPr>
+          <a:lstStyle/>
+          <a:p>
+            <a:pPr algn="r"/>
+            <a:r>
+              <a:rPr sz="1500" b="0">
+                <a:solidFill>
+                  <a:srgbClr val="FFFFFF"/>
+                </a:solidFill>
+                <a:latin typeface="Arial"/>
+              </a:rPr>
+              <a:t>✓  بيانات محلية فقط — لا سحابة خارجية — localStorage آمن 100%</a:t>
+            </a:r>
+          </a:p>
+        </p:txBody>
+      </p:sp>
+      <p:sp>
+        <p:nvSpPr>
+          <p:cNvPr id="16" name="Rectangle 15"/>
           <p:cNvSpPr/>
           <p:nvPr/>
         </p:nvSpPr>
         <p:spPr>
           <a:xfrm>
-            <a:off x="8686800" y="1984248"/>
-            <a:ext cx="502920" cy="384048"/>
+            <a:off x="457200" y="2633472"/>
+            <a:ext cx="6601968" cy="804672"/>
           </a:xfrm>
           <a:prstGeom prst="rect">
             <a:avLst/>
           </a:prstGeom>
           <a:solidFill>
-            <a:srgbClr val="2ECC71"/>
-          </a:solidFill>
-          <a:ln>
-            <a:noFill/>
-          </a:ln>
-        </p:spPr>
-        <p:style>
-          <a:lnRef idx="1">
-            <a:schemeClr val="accent1"/>
-          </a:lnRef>
-          <a:fillRef idx="3">
-            <a:schemeClr val="accent1"/>
-          </a:fillRef>
-          <a:effectRef idx="2">
-            <a:schemeClr val="accent1"/>
-          </a:effectRef>
-          <a:fontRef idx="minor">
-            <a:schemeClr val="lt1"/>
-          </a:fontRef>
-        </p:style>
-        <p:txBody>
-          <a:bodyPr rtlCol="0" anchor="ctr"/>
-          <a:lstStyle/>
-          <a:p>
-            <a:pPr algn="ctr"/>
-          </a:p>
-        </p:txBody>
-      </p:sp>
-      <p:sp>
-        <p:nvSpPr>
-          <p:cNvPr id="15" name="TextBox 14"/>
-          <p:cNvSpPr txBox="1"/>
-          <p:nvPr/>
-        </p:nvSpPr>
-        <p:spPr>
-          <a:xfrm>
-            <a:off x="8695944" y="2002536"/>
-            <a:ext cx="484632" cy="347472"/>
-          </a:xfrm>
-          <a:prstGeom prst="rect">
-            <a:avLst/>
-          </a:prstGeom>
-          <a:noFill/>
-        </p:spPr>
-        <p:txBody>
-          <a:bodyPr wrap="square">
-            <a:spAutoFit/>
-          </a:bodyPr>
-          <a:lstStyle/>
-          <a:p>
-            <a:pPr algn="ctr"/>
-            <a:r>
-              <a:rPr sz="1100" b="1" i="0">
-                <a:solidFill>
-                  <a:srgbClr val="FFFFFF"/>
-                </a:solidFill>
-              </a:rPr>
-              <a:t>OK</a:t>
-            </a:r>
-          </a:p>
-        </p:txBody>
-      </p:sp>
-      <p:sp>
-        <p:nvSpPr>
-          <p:cNvPr id="16" name="TextBox 15"/>
-          <p:cNvSpPr txBox="1"/>
-          <p:nvPr/>
-        </p:nvSpPr>
-        <p:spPr>
-          <a:xfrm>
-            <a:off x="9326880" y="1856231"/>
-            <a:ext cx="8503920" cy="658368"/>
-          </a:xfrm>
-          <a:prstGeom prst="rect">
-            <a:avLst/>
-          </a:prstGeom>
-          <a:noFill/>
-        </p:spPr>
-        <p:txBody>
-          <a:bodyPr wrap="square">
-            <a:spAutoFit/>
-          </a:bodyPr>
-          <a:lstStyle/>
-          <a:p>
-            <a:pPr algn="r"/>
-            <a:r>
-              <a:rPr sz="1200" b="0" i="0">
-                <a:solidFill>
-                  <a:srgbClr val="FFFFFF"/>
-                </a:solidFill>
-              </a:rPr>
-              <a:t>localStorage — بيانات محلية آمنة، لا سحابة خارجية</a:t>
-            </a:r>
-          </a:p>
-        </p:txBody>
-      </p:sp>
-      <p:sp>
-        <p:nvSpPr>
-          <p:cNvPr id="17" name="Rectangle 16"/>
-          <p:cNvSpPr/>
-          <p:nvPr/>
-        </p:nvSpPr>
-        <p:spPr>
-          <a:xfrm>
-            <a:off x="274320" y="2624328"/>
-            <a:ext cx="8229600" cy="804672"/>
-          </a:xfrm>
-          <a:prstGeom prst="rect">
-            <a:avLst/>
-          </a:prstGeom>
-          <a:solidFill>
-            <a:srgbClr val="1E3050"/>
+            <a:srgbClr val="22355E"/>
           </a:solidFill>
           <a:ln w="6350">
             <a:solidFill>
@@ -7830,14 +7872,57 @@
       </p:sp>
       <p:sp>
         <p:nvSpPr>
+          <p:cNvPr id="17" name="Rectangle 16"/>
+          <p:cNvSpPr/>
+          <p:nvPr/>
+        </p:nvSpPr>
+        <p:spPr>
+          <a:xfrm>
+            <a:off x="457200" y="2633472"/>
+            <a:ext cx="82296" cy="804672"/>
+          </a:xfrm>
+          <a:prstGeom prst="rect">
+            <a:avLst/>
+          </a:prstGeom>
+          <a:solidFill>
+            <a:srgbClr val="C9A84C"/>
+          </a:solidFill>
+          <a:ln>
+            <a:noFill/>
+          </a:ln>
+        </p:spPr>
+        <p:style>
+          <a:lnRef idx="1">
+            <a:schemeClr val="accent1"/>
+          </a:lnRef>
+          <a:fillRef idx="3">
+            <a:schemeClr val="accent1"/>
+          </a:fillRef>
+          <a:effectRef idx="2">
+            <a:schemeClr val="accent1"/>
+          </a:effectRef>
+          <a:fontRef idx="minor">
+            <a:schemeClr val="lt1"/>
+          </a:fontRef>
+        </p:style>
+        <p:txBody>
+          <a:bodyPr rtlCol="0" anchor="ctr"/>
+          <a:lstStyle/>
+          <a:p>
+            <a:pPr algn="ctr"/>
+          </a:p>
+        </p:txBody>
+      </p:sp>
+      <p:sp>
+        <p:nvSpPr>
           <p:cNvPr id="18" name="TextBox 17"/>
           <p:cNvSpPr txBox="1"/>
           <p:nvPr/>
         </p:nvSpPr>
         <p:spPr>
           <a:xfrm>
-            <a:off x="320040" y="2807208"/>
-            <a:ext cx="8046720" cy="457200"/>
+            <a:off x="594360" y="2706624"/>
+            <a:ext cx="6419088" cy="658368"/>
           </a:xfrm>
           <a:prstGeom prst="rect">
             <a:avLst/>
@@ -7852,10 +7937,11 @@
           <a:p>
             <a:pPr algn="ctr"/>
             <a:r>
-              <a:rPr sz="1400" b="1" i="0">
+              <a:rPr sz="1600" b="1">
                 <a:solidFill>
                   <a:srgbClr val="FFFFFF"/>
                 </a:solidFill>
+                <a:latin typeface="Arial"/>
               </a:rPr>
               <a:t>توثيق هوية المستخدمين</a:t>
             </a:r>
@@ -7870,14 +7956,14 @@
         </p:nvSpPr>
         <p:spPr>
           <a:xfrm>
-            <a:off x="8686800" y="2624328"/>
-            <a:ext cx="9281160" cy="804672"/>
+            <a:off x="7059168" y="2633472"/>
+            <a:ext cx="10771632" cy="804672"/>
           </a:xfrm>
           <a:prstGeom prst="rect">
             <a:avLst/>
           </a:prstGeom>
           <a:solidFill>
-            <a:srgbClr val="1E3050"/>
+            <a:srgbClr val="22355E"/>
           </a:solidFill>
           <a:ln w="6350">
             <a:solidFill>
@@ -7909,131 +7995,55 @@
       </p:sp>
       <p:sp>
         <p:nvSpPr>
-          <p:cNvPr id="20" name="Rectangle 19"/>
+          <p:cNvPr id="20" name="TextBox 19"/>
+          <p:cNvSpPr txBox="1"/>
+          <p:nvPr/>
+        </p:nvSpPr>
+        <p:spPr>
+          <a:xfrm>
+            <a:off x="7242048" y="2706624"/>
+            <a:ext cx="10497312" cy="658368"/>
+          </a:xfrm>
+          <a:prstGeom prst="rect">
+            <a:avLst/>
+          </a:prstGeom>
+          <a:noFill/>
+        </p:spPr>
+        <p:txBody>
+          <a:bodyPr wrap="square">
+            <a:spAutoFit/>
+          </a:bodyPr>
+          <a:lstStyle/>
+          <a:p>
+            <a:pPr algn="r"/>
+            <a:r>
+              <a:rPr sz="1500" b="0">
+                <a:solidFill>
+                  <a:srgbClr val="FFFFFF"/>
+                </a:solidFill>
+                <a:latin typeface="Arial"/>
+              </a:rPr>
+              <a:t>✓  5 أدوار مستقلة: مدير، مديرة، معلم، إداري، ولي أمر</a:t>
+            </a:r>
+          </a:p>
+        </p:txBody>
+      </p:sp>
+      <p:sp>
+        <p:nvSpPr>
+          <p:cNvPr id="21" name="Rectangle 20"/>
           <p:cNvSpPr/>
           <p:nvPr/>
         </p:nvSpPr>
         <p:spPr>
           <a:xfrm>
-            <a:off x="8686800" y="2825496"/>
-            <a:ext cx="502920" cy="384048"/>
+            <a:off x="457200" y="3438144"/>
+            <a:ext cx="6601968" cy="804672"/>
           </a:xfrm>
           <a:prstGeom prst="rect">
             <a:avLst/>
           </a:prstGeom>
           <a:solidFill>
-            <a:srgbClr val="2ECC71"/>
-          </a:solidFill>
-          <a:ln>
-            <a:noFill/>
-          </a:ln>
-        </p:spPr>
-        <p:style>
-          <a:lnRef idx="1">
-            <a:schemeClr val="accent1"/>
-          </a:lnRef>
-          <a:fillRef idx="3">
-            <a:schemeClr val="accent1"/>
-          </a:fillRef>
-          <a:effectRef idx="2">
-            <a:schemeClr val="accent1"/>
-          </a:effectRef>
-          <a:fontRef idx="minor">
-            <a:schemeClr val="lt1"/>
-          </a:fontRef>
-        </p:style>
-        <p:txBody>
-          <a:bodyPr rtlCol="0" anchor="ctr"/>
-          <a:lstStyle/>
-          <a:p>
-            <a:pPr algn="ctr"/>
-          </a:p>
-        </p:txBody>
-      </p:sp>
-      <p:sp>
-        <p:nvSpPr>
-          <p:cNvPr id="21" name="TextBox 20"/>
-          <p:cNvSpPr txBox="1"/>
-          <p:nvPr/>
-        </p:nvSpPr>
-        <p:spPr>
-          <a:xfrm>
-            <a:off x="8695944" y="2843784"/>
-            <a:ext cx="484632" cy="347472"/>
-          </a:xfrm>
-          <a:prstGeom prst="rect">
-            <a:avLst/>
-          </a:prstGeom>
-          <a:noFill/>
-        </p:spPr>
-        <p:txBody>
-          <a:bodyPr wrap="square">
-            <a:spAutoFit/>
-          </a:bodyPr>
-          <a:lstStyle/>
-          <a:p>
-            <a:pPr algn="ctr"/>
-            <a:r>
-              <a:rPr sz="1100" b="1" i="0">
-                <a:solidFill>
-                  <a:srgbClr val="FFFFFF"/>
-                </a:solidFill>
-              </a:rPr>
-              <a:t>OK</a:t>
-            </a:r>
-          </a:p>
-        </p:txBody>
-      </p:sp>
-      <p:sp>
-        <p:nvSpPr>
-          <p:cNvPr id="22" name="TextBox 21"/>
-          <p:cNvSpPr txBox="1"/>
-          <p:nvPr/>
-        </p:nvSpPr>
-        <p:spPr>
-          <a:xfrm>
-            <a:off x="9326880" y="2697480"/>
-            <a:ext cx="8503920" cy="658368"/>
-          </a:xfrm>
-          <a:prstGeom prst="rect">
-            <a:avLst/>
-          </a:prstGeom>
-          <a:noFill/>
-        </p:spPr>
-        <p:txBody>
-          <a:bodyPr wrap="square">
-            <a:spAutoFit/>
-          </a:bodyPr>
-          <a:lstStyle/>
-          <a:p>
-            <a:pPr algn="r"/>
-            <a:r>
-              <a:rPr sz="1200" b="0" i="0">
-                <a:solidFill>
-                  <a:srgbClr val="FFFFFF"/>
-                </a:solidFill>
-              </a:rPr>
-              <a:t>5 مستويات دخول مستقلة: مدير، مديرة، معلم، إداري، ولي أمر</a:t>
-            </a:r>
-          </a:p>
-        </p:txBody>
-      </p:sp>
-      <p:sp>
-        <p:nvSpPr>
-          <p:cNvPr id="23" name="Rectangle 22"/>
-          <p:cNvSpPr/>
-          <p:nvPr/>
-        </p:nvSpPr>
-        <p:spPr>
-          <a:xfrm>
-            <a:off x="274320" y="3465576"/>
-            <a:ext cx="8229600" cy="804672"/>
-          </a:xfrm>
-          <a:prstGeom prst="rect">
-            <a:avLst/>
-          </a:prstGeom>
-          <a:solidFill>
-            <a:srgbClr val="243860"/>
+            <a:srgbClr val="1A2A4A"/>
           </a:solidFill>
           <a:ln w="6350">
             <a:solidFill>
@@ -8065,14 +8075,57 @@
       </p:sp>
       <p:sp>
         <p:nvSpPr>
-          <p:cNvPr id="24" name="TextBox 23"/>
+          <p:cNvPr id="22" name="Rectangle 21"/>
+          <p:cNvSpPr/>
+          <p:nvPr/>
+        </p:nvSpPr>
+        <p:spPr>
+          <a:xfrm>
+            <a:off x="457200" y="3438144"/>
+            <a:ext cx="82296" cy="804672"/>
+          </a:xfrm>
+          <a:prstGeom prst="rect">
+            <a:avLst/>
+          </a:prstGeom>
+          <a:solidFill>
+            <a:srgbClr val="C9A84C"/>
+          </a:solidFill>
+          <a:ln>
+            <a:noFill/>
+          </a:ln>
+        </p:spPr>
+        <p:style>
+          <a:lnRef idx="1">
+            <a:schemeClr val="accent1"/>
+          </a:lnRef>
+          <a:fillRef idx="3">
+            <a:schemeClr val="accent1"/>
+          </a:fillRef>
+          <a:effectRef idx="2">
+            <a:schemeClr val="accent1"/>
+          </a:effectRef>
+          <a:fontRef idx="minor">
+            <a:schemeClr val="lt1"/>
+          </a:fontRef>
+        </p:style>
+        <p:txBody>
+          <a:bodyPr rtlCol="0" anchor="ctr"/>
+          <a:lstStyle/>
+          <a:p>
+            <a:pPr algn="ctr"/>
+          </a:p>
+        </p:txBody>
+      </p:sp>
+      <p:sp>
+        <p:nvSpPr>
+          <p:cNvPr id="23" name="TextBox 22"/>
           <p:cNvSpPr txBox="1"/>
           <p:nvPr/>
         </p:nvSpPr>
         <p:spPr>
           <a:xfrm>
-            <a:off x="320040" y="3648456"/>
-            <a:ext cx="8046720" cy="457200"/>
+            <a:off x="594360" y="3511296"/>
+            <a:ext cx="6419088" cy="658368"/>
           </a:xfrm>
           <a:prstGeom prst="rect">
             <a:avLst/>
@@ -8087,10 +8140,11 @@
           <a:p>
             <a:pPr algn="ctr"/>
             <a:r>
-              <a:rPr sz="1400" b="1" i="0">
+              <a:rPr sz="1600" b="1">
                 <a:solidFill>
                   <a:srgbClr val="FFFFFF"/>
                 </a:solidFill>
+                <a:latin typeface="Arial"/>
               </a:rPr>
               <a:t>رقابة أولياء الأمور</a:t>
             </a:r>
@@ -8099,20 +8153,20 @@
       </p:sp>
       <p:sp>
         <p:nvSpPr>
-          <p:cNvPr id="25" name="Rectangle 24"/>
+          <p:cNvPr id="24" name="Rectangle 23"/>
           <p:cNvSpPr/>
           <p:nvPr/>
         </p:nvSpPr>
         <p:spPr>
           <a:xfrm>
-            <a:off x="8686800" y="3465576"/>
-            <a:ext cx="9281160" cy="804672"/>
+            <a:off x="7059168" y="3438144"/>
+            <a:ext cx="10771632" cy="804672"/>
           </a:xfrm>
           <a:prstGeom prst="rect">
             <a:avLst/>
           </a:prstGeom>
           <a:solidFill>
-            <a:srgbClr val="243860"/>
+            <a:srgbClr val="1A2A4A"/>
           </a:solidFill>
           <a:ln w="6350">
             <a:solidFill>
@@ -8144,131 +8198,55 @@
       </p:sp>
       <p:sp>
         <p:nvSpPr>
+          <p:cNvPr id="25" name="TextBox 24"/>
+          <p:cNvSpPr txBox="1"/>
+          <p:nvPr/>
+        </p:nvSpPr>
+        <p:spPr>
+          <a:xfrm>
+            <a:off x="7242048" y="3511296"/>
+            <a:ext cx="10497312" cy="658368"/>
+          </a:xfrm>
+          <a:prstGeom prst="rect">
+            <a:avLst/>
+          </a:prstGeom>
+          <a:noFill/>
+        </p:spPr>
+        <p:txBody>
+          <a:bodyPr wrap="square">
+            <a:spAutoFit/>
+          </a:bodyPr>
+          <a:lstStyle/>
+          <a:p>
+            <a:pPr algn="r"/>
+            <a:r>
+              <a:rPr sz="1500" b="0">
+                <a:solidFill>
+                  <a:srgbClr val="FFFFFF"/>
+                </a:solidFill>
+                <a:latin typeface="Arial"/>
+              </a:rPr>
+              <a:t>✓  بوابة ولي الأمر — تطوير قريب مع بيانات الطلاب الكاملة</a:t>
+            </a:r>
+          </a:p>
+        </p:txBody>
+      </p:sp>
+      <p:sp>
+        <p:nvSpPr>
           <p:cNvPr id="26" name="Rectangle 25"/>
           <p:cNvSpPr/>
           <p:nvPr/>
         </p:nvSpPr>
         <p:spPr>
           <a:xfrm>
-            <a:off x="8686800" y="3666744"/>
-            <a:ext cx="502920" cy="384048"/>
+            <a:off x="457200" y="4242816"/>
+            <a:ext cx="6601968" cy="804672"/>
           </a:xfrm>
           <a:prstGeom prst="rect">
             <a:avLst/>
           </a:prstGeom>
           <a:solidFill>
-            <a:srgbClr val="2ECC71"/>
-          </a:solidFill>
-          <a:ln>
-            <a:noFill/>
-          </a:ln>
-        </p:spPr>
-        <p:style>
-          <a:lnRef idx="1">
-            <a:schemeClr val="accent1"/>
-          </a:lnRef>
-          <a:fillRef idx="3">
-            <a:schemeClr val="accent1"/>
-          </a:fillRef>
-          <a:effectRef idx="2">
-            <a:schemeClr val="accent1"/>
-          </a:effectRef>
-          <a:fontRef idx="minor">
-            <a:schemeClr val="lt1"/>
-          </a:fontRef>
-        </p:style>
-        <p:txBody>
-          <a:bodyPr rtlCol="0" anchor="ctr"/>
-          <a:lstStyle/>
-          <a:p>
-            <a:pPr algn="ctr"/>
-          </a:p>
-        </p:txBody>
-      </p:sp>
-      <p:sp>
-        <p:nvSpPr>
-          <p:cNvPr id="27" name="TextBox 26"/>
-          <p:cNvSpPr txBox="1"/>
-          <p:nvPr/>
-        </p:nvSpPr>
-        <p:spPr>
-          <a:xfrm>
-            <a:off x="8695944" y="3685032"/>
-            <a:ext cx="484632" cy="347472"/>
-          </a:xfrm>
-          <a:prstGeom prst="rect">
-            <a:avLst/>
-          </a:prstGeom>
-          <a:noFill/>
-        </p:spPr>
-        <p:txBody>
-          <a:bodyPr wrap="square">
-            <a:spAutoFit/>
-          </a:bodyPr>
-          <a:lstStyle/>
-          <a:p>
-            <a:pPr algn="ctr"/>
-            <a:r>
-              <a:rPr sz="1100" b="1" i="0">
-                <a:solidFill>
-                  <a:srgbClr val="FFFFFF"/>
-                </a:solidFill>
-              </a:rPr>
-              <a:t>OK</a:t>
-            </a:r>
-          </a:p>
-        </p:txBody>
-      </p:sp>
-      <p:sp>
-        <p:nvSpPr>
-          <p:cNvPr id="28" name="TextBox 27"/>
-          <p:cNvSpPr txBox="1"/>
-          <p:nvPr/>
-        </p:nvSpPr>
-        <p:spPr>
-          <a:xfrm>
-            <a:off x="9326880" y="3538728"/>
-            <a:ext cx="8503920" cy="658368"/>
-          </a:xfrm>
-          <a:prstGeom prst="rect">
-            <a:avLst/>
-          </a:prstGeom>
-          <a:noFill/>
-        </p:spPr>
-        <p:txBody>
-          <a:bodyPr wrap="square">
-            <a:spAutoFit/>
-          </a:bodyPr>
-          <a:lstStyle/>
-          <a:p>
-            <a:pPr algn="r"/>
-            <a:r>
-              <a:rPr sz="1200" b="0" i="0">
-                <a:solidFill>
-                  <a:srgbClr val="FFFFFF"/>
-                </a:solidFill>
-              </a:rPr>
-              <a:t>بوابة ولي الأمر — قيد التطوير وإطلاق قريب مع بيانات الطلاب</a:t>
-            </a:r>
-          </a:p>
-        </p:txBody>
-      </p:sp>
-      <p:sp>
-        <p:nvSpPr>
-          <p:cNvPr id="29" name="Rectangle 28"/>
-          <p:cNvSpPr/>
-          <p:nvPr/>
-        </p:nvSpPr>
-        <p:spPr>
-          <a:xfrm>
-            <a:off x="274320" y="4306824"/>
-            <a:ext cx="8229600" cy="804672"/>
-          </a:xfrm>
-          <a:prstGeom prst="rect">
-            <a:avLst/>
-          </a:prstGeom>
-          <a:solidFill>
-            <a:srgbClr val="1E3050"/>
+            <a:srgbClr val="22355E"/>
           </a:solidFill>
           <a:ln w="6350">
             <a:solidFill>
@@ -8300,14 +8278,57 @@
       </p:sp>
       <p:sp>
         <p:nvSpPr>
-          <p:cNvPr id="30" name="TextBox 29"/>
+          <p:cNvPr id="27" name="Rectangle 26"/>
+          <p:cNvSpPr/>
+          <p:nvPr/>
+        </p:nvSpPr>
+        <p:spPr>
+          <a:xfrm>
+            <a:off x="457200" y="4242816"/>
+            <a:ext cx="82296" cy="804672"/>
+          </a:xfrm>
+          <a:prstGeom prst="rect">
+            <a:avLst/>
+          </a:prstGeom>
+          <a:solidFill>
+            <a:srgbClr val="C9A84C"/>
+          </a:solidFill>
+          <a:ln>
+            <a:noFill/>
+          </a:ln>
+        </p:spPr>
+        <p:style>
+          <a:lnRef idx="1">
+            <a:schemeClr val="accent1"/>
+          </a:lnRef>
+          <a:fillRef idx="3">
+            <a:schemeClr val="accent1"/>
+          </a:fillRef>
+          <a:effectRef idx="2">
+            <a:schemeClr val="accent1"/>
+          </a:effectRef>
+          <a:fontRef idx="minor">
+            <a:schemeClr val="lt1"/>
+          </a:fontRef>
+        </p:style>
+        <p:txBody>
+          <a:bodyPr rtlCol="0" anchor="ctr"/>
+          <a:lstStyle/>
+          <a:p>
+            <a:pPr algn="ctr"/>
+          </a:p>
+        </p:txBody>
+      </p:sp>
+      <p:sp>
+        <p:nvSpPr>
+          <p:cNvPr id="28" name="TextBox 27"/>
           <p:cNvSpPr txBox="1"/>
           <p:nvPr/>
         </p:nvSpPr>
         <p:spPr>
           <a:xfrm>
-            <a:off x="320040" y="4489704"/>
-            <a:ext cx="8046720" cy="457200"/>
+            <a:off x="594360" y="4315968"/>
+            <a:ext cx="6419088" cy="658368"/>
           </a:xfrm>
           <a:prstGeom prst="rect">
             <a:avLst/>
@@ -8322,10 +8343,11 @@
           <a:p>
             <a:pPr algn="ctr"/>
             <a:r>
-              <a:rPr sz="1400" b="1" i="0">
+              <a:rPr sz="1600" b="1">
                 <a:solidFill>
                   <a:srgbClr val="FFFFFF"/>
                 </a:solidFill>
+                <a:latin typeface="Arial"/>
               </a:rPr>
               <a:t>الإبلاغ عن الاختراقات</a:t>
             </a:r>
@@ -8334,20 +8356,20 @@
       </p:sp>
       <p:sp>
         <p:nvSpPr>
-          <p:cNvPr id="31" name="Rectangle 30"/>
+          <p:cNvPr id="29" name="Rectangle 28"/>
           <p:cNvSpPr/>
           <p:nvPr/>
         </p:nvSpPr>
         <p:spPr>
           <a:xfrm>
-            <a:off x="8686800" y="4306824"/>
-            <a:ext cx="9281160" cy="804672"/>
+            <a:off x="7059168" y="4242816"/>
+            <a:ext cx="10771632" cy="804672"/>
           </a:xfrm>
           <a:prstGeom prst="rect">
             <a:avLst/>
           </a:prstGeom>
           <a:solidFill>
-            <a:srgbClr val="1E3050"/>
+            <a:srgbClr val="22355E"/>
           </a:solidFill>
           <a:ln w="6350">
             <a:solidFill>
@@ -8379,131 +8401,55 @@
       </p:sp>
       <p:sp>
         <p:nvSpPr>
-          <p:cNvPr id="32" name="Rectangle 31"/>
+          <p:cNvPr id="30" name="TextBox 29"/>
+          <p:cNvSpPr txBox="1"/>
+          <p:nvPr/>
+        </p:nvSpPr>
+        <p:spPr>
+          <a:xfrm>
+            <a:off x="7242048" y="4315968"/>
+            <a:ext cx="10497312" cy="658368"/>
+          </a:xfrm>
+          <a:prstGeom prst="rect">
+            <a:avLst/>
+          </a:prstGeom>
+          <a:noFill/>
+        </p:spPr>
+        <p:txBody>
+          <a:bodyPr wrap="square">
+            <a:spAutoFit/>
+          </a:bodyPr>
+          <a:lstStyle/>
+          <a:p>
+            <a:pPr algn="r"/>
+            <a:r>
+              <a:rPr sz="1500" b="0">
+                <a:solidFill>
+                  <a:srgbClr val="FFFFFF"/>
+                </a:solidFill>
+                <a:latin typeface="Arial"/>
+              </a:rPr>
+              <a:t>✓  سجل تدقيق مدمج — كل عملية دخول أو تعديل موثّقة تلقائياً</a:t>
+            </a:r>
+          </a:p>
+        </p:txBody>
+      </p:sp>
+      <p:sp>
+        <p:nvSpPr>
+          <p:cNvPr id="31" name="Rectangle 30"/>
           <p:cNvSpPr/>
           <p:nvPr/>
         </p:nvSpPr>
         <p:spPr>
           <a:xfrm>
-            <a:off x="8686800" y="4507992"/>
-            <a:ext cx="502920" cy="384048"/>
+            <a:off x="457200" y="5047488"/>
+            <a:ext cx="6601968" cy="804672"/>
           </a:xfrm>
           <a:prstGeom prst="rect">
             <a:avLst/>
           </a:prstGeom>
           <a:solidFill>
-            <a:srgbClr val="2ECC71"/>
-          </a:solidFill>
-          <a:ln>
-            <a:noFill/>
-          </a:ln>
-        </p:spPr>
-        <p:style>
-          <a:lnRef idx="1">
-            <a:schemeClr val="accent1"/>
-          </a:lnRef>
-          <a:fillRef idx="3">
-            <a:schemeClr val="accent1"/>
-          </a:fillRef>
-          <a:effectRef idx="2">
-            <a:schemeClr val="accent1"/>
-          </a:effectRef>
-          <a:fontRef idx="minor">
-            <a:schemeClr val="lt1"/>
-          </a:fontRef>
-        </p:style>
-        <p:txBody>
-          <a:bodyPr rtlCol="0" anchor="ctr"/>
-          <a:lstStyle/>
-          <a:p>
-            <a:pPr algn="ctr"/>
-          </a:p>
-        </p:txBody>
-      </p:sp>
-      <p:sp>
-        <p:nvSpPr>
-          <p:cNvPr id="33" name="TextBox 32"/>
-          <p:cNvSpPr txBox="1"/>
-          <p:nvPr/>
-        </p:nvSpPr>
-        <p:spPr>
-          <a:xfrm>
-            <a:off x="8695944" y="4526280"/>
-            <a:ext cx="484632" cy="347472"/>
-          </a:xfrm>
-          <a:prstGeom prst="rect">
-            <a:avLst/>
-          </a:prstGeom>
-          <a:noFill/>
-        </p:spPr>
-        <p:txBody>
-          <a:bodyPr wrap="square">
-            <a:spAutoFit/>
-          </a:bodyPr>
-          <a:lstStyle/>
-          <a:p>
-            <a:pPr algn="ctr"/>
-            <a:r>
-              <a:rPr sz="1100" b="1" i="0">
-                <a:solidFill>
-                  <a:srgbClr val="FFFFFF"/>
-                </a:solidFill>
-              </a:rPr>
-              <a:t>OK</a:t>
-            </a:r>
-          </a:p>
-        </p:txBody>
-      </p:sp>
-      <p:sp>
-        <p:nvSpPr>
-          <p:cNvPr id="34" name="TextBox 33"/>
-          <p:cNvSpPr txBox="1"/>
-          <p:nvPr/>
-        </p:nvSpPr>
-        <p:spPr>
-          <a:xfrm>
-            <a:off x="9326880" y="4379976"/>
-            <a:ext cx="8503920" cy="658368"/>
-          </a:xfrm>
-          <a:prstGeom prst="rect">
-            <a:avLst/>
-          </a:prstGeom>
-          <a:noFill/>
-        </p:spPr>
-        <p:txBody>
-          <a:bodyPr wrap="square">
-            <a:spAutoFit/>
-          </a:bodyPr>
-          <a:lstStyle/>
-          <a:p>
-            <a:pPr algn="r"/>
-            <a:r>
-              <a:rPr sz="1200" b="0" i="0">
-                <a:solidFill>
-                  <a:srgbClr val="FFFFFF"/>
-                </a:solidFill>
-              </a:rPr>
-              <a:t>سجل تدقيق مدمج — كل عملية دخول أو تعديل مؤثقة تلقائياً</a:t>
-            </a:r>
-          </a:p>
-        </p:txBody>
-      </p:sp>
-      <p:sp>
-        <p:nvSpPr>
-          <p:cNvPr id="35" name="Rectangle 34"/>
-          <p:cNvSpPr/>
-          <p:nvPr/>
-        </p:nvSpPr>
-        <p:spPr>
-          <a:xfrm>
-            <a:off x="274320" y="5148072"/>
-            <a:ext cx="8229600" cy="804672"/>
-          </a:xfrm>
-          <a:prstGeom prst="rect">
-            <a:avLst/>
-          </a:prstGeom>
-          <a:solidFill>
-            <a:srgbClr val="243860"/>
+            <a:srgbClr val="1A2A4A"/>
           </a:solidFill>
           <a:ln w="6350">
             <a:solidFill>
@@ -8535,14 +8481,57 @@
       </p:sp>
       <p:sp>
         <p:nvSpPr>
-          <p:cNvPr id="36" name="TextBox 35"/>
+          <p:cNvPr id="32" name="Rectangle 31"/>
+          <p:cNvSpPr/>
+          <p:nvPr/>
+        </p:nvSpPr>
+        <p:spPr>
+          <a:xfrm>
+            <a:off x="457200" y="5047488"/>
+            <a:ext cx="82296" cy="804672"/>
+          </a:xfrm>
+          <a:prstGeom prst="rect">
+            <a:avLst/>
+          </a:prstGeom>
+          <a:solidFill>
+            <a:srgbClr val="C9A84C"/>
+          </a:solidFill>
+          <a:ln>
+            <a:noFill/>
+          </a:ln>
+        </p:spPr>
+        <p:style>
+          <a:lnRef idx="1">
+            <a:schemeClr val="accent1"/>
+          </a:lnRef>
+          <a:fillRef idx="3">
+            <a:schemeClr val="accent1"/>
+          </a:fillRef>
+          <a:effectRef idx="2">
+            <a:schemeClr val="accent1"/>
+          </a:effectRef>
+          <a:fontRef idx="minor">
+            <a:schemeClr val="lt1"/>
+          </a:fontRef>
+        </p:style>
+        <p:txBody>
+          <a:bodyPr rtlCol="0" anchor="ctr"/>
+          <a:lstStyle/>
+          <a:p>
+            <a:pPr algn="ctr"/>
+          </a:p>
+        </p:txBody>
+      </p:sp>
+      <p:sp>
+        <p:nvSpPr>
+          <p:cNvPr id="33" name="TextBox 32"/>
           <p:cNvSpPr txBox="1"/>
           <p:nvPr/>
         </p:nvSpPr>
         <p:spPr>
           <a:xfrm>
-            <a:off x="320040" y="5330952"/>
-            <a:ext cx="8046720" cy="457200"/>
+            <a:off x="594360" y="5120640"/>
+            <a:ext cx="6419088" cy="658368"/>
           </a:xfrm>
           <a:prstGeom prst="rect">
             <a:avLst/>
@@ -8557,32 +8546,33 @@
           <a:p>
             <a:pPr algn="ctr"/>
             <a:r>
-              <a:rPr sz="1400" b="1" i="0">
+              <a:rPr sz="1600" b="1">
                 <a:solidFill>
                   <a:srgbClr val="FFFFFF"/>
                 </a:solidFill>
+                <a:latin typeface="Arial"/>
               </a:rPr>
-              <a:t>ضبط الصلاحيات</a:t>
+              <a:t>ضبط صلاحيات الوصول</a:t>
             </a:r>
           </a:p>
         </p:txBody>
       </p:sp>
       <p:sp>
         <p:nvSpPr>
-          <p:cNvPr id="37" name="Rectangle 36"/>
+          <p:cNvPr id="34" name="Rectangle 33"/>
           <p:cNvSpPr/>
           <p:nvPr/>
         </p:nvSpPr>
         <p:spPr>
           <a:xfrm>
-            <a:off x="8686800" y="5148072"/>
-            <a:ext cx="9281160" cy="804672"/>
+            <a:off x="7059168" y="5047488"/>
+            <a:ext cx="10771632" cy="804672"/>
           </a:xfrm>
           <a:prstGeom prst="rect">
             <a:avLst/>
           </a:prstGeom>
           <a:solidFill>
-            <a:srgbClr val="243860"/>
+            <a:srgbClr val="1A2A4A"/>
           </a:solidFill>
           <a:ln w="6350">
             <a:solidFill>
@@ -8614,23 +8604,60 @@
       </p:sp>
       <p:sp>
         <p:nvSpPr>
-          <p:cNvPr id="38" name="Rectangle 37"/>
+          <p:cNvPr id="35" name="TextBox 34"/>
+          <p:cNvSpPr txBox="1"/>
+          <p:nvPr/>
+        </p:nvSpPr>
+        <p:spPr>
+          <a:xfrm>
+            <a:off x="7242048" y="5120640"/>
+            <a:ext cx="10497312" cy="658368"/>
+          </a:xfrm>
+          <a:prstGeom prst="rect">
+            <a:avLst/>
+          </a:prstGeom>
+          <a:noFill/>
+        </p:spPr>
+        <p:txBody>
+          <a:bodyPr wrap="square">
+            <a:spAutoFit/>
+          </a:bodyPr>
+          <a:lstStyle/>
+          <a:p>
+            <a:pPr algn="r"/>
+            <a:r>
+              <a:rPr sz="1500" b="0">
+                <a:solidFill>
+                  <a:srgbClr val="FFFFFF"/>
+                </a:solidFill>
+                <a:latin typeface="Arial"/>
+              </a:rPr>
+              <a:t>✓  Admin يملك التحكم الكامل — CRUD منفصلة لكل دور</a:t>
+            </a:r>
+          </a:p>
+        </p:txBody>
+      </p:sp>
+      <p:sp>
+        <p:nvSpPr>
+          <p:cNvPr id="36" name="Rectangle 35"/>
           <p:cNvSpPr/>
           <p:nvPr/>
         </p:nvSpPr>
         <p:spPr>
           <a:xfrm>
-            <a:off x="8686800" y="5349240"/>
-            <a:ext cx="502920" cy="384048"/>
+            <a:off x="457200" y="6016752"/>
+            <a:ext cx="17373600" cy="1005840"/>
           </a:xfrm>
           <a:prstGeom prst="rect">
             <a:avLst/>
           </a:prstGeom>
           <a:solidFill>
-            <a:srgbClr val="2ECC71"/>
+            <a:srgbClr val="0F1A30"/>
           </a:solidFill>
-          <a:ln>
-            <a:noFill/>
+          <a:ln w="19050">
+            <a:solidFill>
+              <a:srgbClr val="C9A84C"/>
+            </a:solidFill>
           </a:ln>
         </p:spPr>
         <p:style>
@@ -8657,14 +8684,14 @@
       </p:sp>
       <p:sp>
         <p:nvSpPr>
-          <p:cNvPr id="39" name="TextBox 38"/>
+          <p:cNvPr id="37" name="TextBox 36"/>
           <p:cNvSpPr txBox="1"/>
           <p:nvPr/>
         </p:nvSpPr>
         <p:spPr>
           <a:xfrm>
-            <a:off x="8695944" y="5367528"/>
-            <a:ext cx="484632" cy="347472"/>
+            <a:off x="457200" y="6062472"/>
+            <a:ext cx="5791200" cy="502920"/>
           </a:xfrm>
           <a:prstGeom prst="rect">
             <a:avLst/>
@@ -8679,26 +8706,27 @@
           <a:p>
             <a:pPr algn="ctr"/>
             <a:r>
-              <a:rPr sz="1100" b="1" i="0">
+              <a:rPr sz="2600" b="1">
                 <a:solidFill>
-                  <a:srgbClr val="FFFFFF"/>
+                  <a:srgbClr val="C9A84C"/>
                 </a:solidFill>
+                <a:latin typeface="Arial"/>
               </a:rPr>
-              <a:t>OK</a:t>
+              <a:t>5</a:t>
             </a:r>
           </a:p>
         </p:txBody>
       </p:sp>
       <p:sp>
         <p:nvSpPr>
-          <p:cNvPr id="40" name="TextBox 39"/>
+          <p:cNvPr id="38" name="TextBox 37"/>
           <p:cNvSpPr txBox="1"/>
           <p:nvPr/>
         </p:nvSpPr>
         <p:spPr>
           <a:xfrm>
-            <a:off x="9326880" y="5221224"/>
-            <a:ext cx="8503920" cy="658368"/>
+            <a:off x="457200" y="6565392"/>
+            <a:ext cx="5791200" cy="365760"/>
           </a:xfrm>
           <a:prstGeom prst="rect">
             <a:avLst/>
@@ -8711,28 +8739,29 @@
           </a:bodyPr>
           <a:lstStyle/>
           <a:p>
-            <a:pPr algn="r"/>
+            <a:pPr algn="ctr"/>
             <a:r>
-              <a:rPr sz="1200" b="0" i="0">
+              <a:rPr sz="1300" b="0">
                 <a:solidFill>
                   <a:srgbClr val="FFFFFF"/>
                 </a:solidFill>
+                <a:latin typeface="Arial"/>
               </a:rPr>
-              <a:t>Admin يملك التحكم الكامل CRUD — صلاحيات منفصلة لكل دور</a:t>
+              <a:t>مستويات الوصول</a:t>
             </a:r>
           </a:p>
         </p:txBody>
       </p:sp>
       <p:sp>
         <p:nvSpPr>
-          <p:cNvPr id="41" name="Rectangle 40"/>
+          <p:cNvPr id="39" name="Rectangle 38"/>
           <p:cNvSpPr/>
           <p:nvPr/>
         </p:nvSpPr>
         <p:spPr>
           <a:xfrm>
-            <a:off x="320040" y="8823960"/>
-            <a:ext cx="5394960" cy="1097280"/>
+            <a:off x="6248400" y="6153912"/>
+            <a:ext cx="18288" cy="731520"/>
           </a:xfrm>
           <a:prstGeom prst="rect">
             <a:avLst/>
@@ -8740,10 +8769,8 @@
           <a:solidFill>
             <a:srgbClr val="C9A84C"/>
           </a:solidFill>
-          <a:ln w="12700">
-            <a:solidFill>
-              <a:srgbClr val="C9A84C"/>
-            </a:solidFill>
+          <a:ln>
+            <a:noFill/>
           </a:ln>
         </p:spPr>
         <p:style>
@@ -8770,14 +8797,14 @@
       </p:sp>
       <p:sp>
         <p:nvSpPr>
-          <p:cNvPr id="42" name="TextBox 41"/>
+          <p:cNvPr id="40" name="TextBox 39"/>
           <p:cNvSpPr txBox="1"/>
           <p:nvPr/>
         </p:nvSpPr>
         <p:spPr>
           <a:xfrm>
-            <a:off x="320040" y="8887968"/>
-            <a:ext cx="5394960" cy="566928"/>
+            <a:off x="6248400" y="6062472"/>
+            <a:ext cx="5791200" cy="502920"/>
           </a:xfrm>
           <a:prstGeom prst="rect">
             <a:avLst/>
@@ -8792,26 +8819,27 @@
           <a:p>
             <a:pPr algn="ctr"/>
             <a:r>
-              <a:rPr sz="2600" b="1" i="0">
+              <a:rPr sz="2600" b="1">
                 <a:solidFill>
-                  <a:srgbClr val="1A2A4A"/>
+                  <a:srgbClr val="C9A84C"/>
                 </a:solidFill>
+                <a:latin typeface="Arial"/>
               </a:rPr>
-              <a:t>5</a:t>
+              <a:t>100%</a:t>
             </a:r>
           </a:p>
         </p:txBody>
       </p:sp>
       <p:sp>
         <p:nvSpPr>
-          <p:cNvPr id="43" name="TextBox 42"/>
+          <p:cNvPr id="41" name="TextBox 40"/>
           <p:cNvSpPr txBox="1"/>
           <p:nvPr/>
         </p:nvSpPr>
         <p:spPr>
           <a:xfrm>
-            <a:off x="320040" y="9418320"/>
-            <a:ext cx="5394960" cy="347472"/>
+            <a:off x="6248400" y="6565392"/>
+            <a:ext cx="5791200" cy="365760"/>
           </a:xfrm>
           <a:prstGeom prst="rect">
             <a:avLst/>
@@ -8826,26 +8854,27 @@
           <a:p>
             <a:pPr algn="ctr"/>
             <a:r>
-              <a:rPr sz="1200" b="0" i="0">
+              <a:rPr sz="1300" b="0">
                 <a:solidFill>
-                  <a:srgbClr val="1A2A4A"/>
+                  <a:srgbClr val="FFFFFF"/>
                 </a:solidFill>
+                <a:latin typeface="Arial"/>
               </a:rPr>
-              <a:t>مستويات الوصول</a:t>
+              <a:t>بيانات محلية آمنة</a:t>
             </a:r>
           </a:p>
         </p:txBody>
       </p:sp>
       <p:sp>
         <p:nvSpPr>
-          <p:cNvPr id="44" name="Rectangle 43"/>
+          <p:cNvPr id="42" name="Rectangle 41"/>
           <p:cNvSpPr/>
           <p:nvPr/>
         </p:nvSpPr>
         <p:spPr>
           <a:xfrm>
-            <a:off x="5852160" y="8823960"/>
-            <a:ext cx="5394960" cy="1097280"/>
+            <a:off x="12039600" y="6153912"/>
+            <a:ext cx="18288" cy="731520"/>
           </a:xfrm>
           <a:prstGeom prst="rect">
             <a:avLst/>
@@ -8853,10 +8882,8 @@
           <a:solidFill>
             <a:srgbClr val="C9A84C"/>
           </a:solidFill>
-          <a:ln w="12700">
-            <a:solidFill>
-              <a:srgbClr val="C9A84C"/>
-            </a:solidFill>
+          <a:ln>
+            <a:noFill/>
           </a:ln>
         </p:spPr>
         <p:style>
@@ -8883,14 +8910,14 @@
       </p:sp>
       <p:sp>
         <p:nvSpPr>
-          <p:cNvPr id="45" name="TextBox 44"/>
+          <p:cNvPr id="43" name="TextBox 42"/>
           <p:cNvSpPr txBox="1"/>
           <p:nvPr/>
         </p:nvSpPr>
         <p:spPr>
           <a:xfrm>
-            <a:off x="5852160" y="8887968"/>
-            <a:ext cx="5394960" cy="566928"/>
+            <a:off x="12039600" y="6062472"/>
+            <a:ext cx="5791200" cy="502920"/>
           </a:xfrm>
           <a:prstGeom prst="rect">
             <a:avLst/>
@@ -8905,26 +8932,27 @@
           <a:p>
             <a:pPr algn="ctr"/>
             <a:r>
-              <a:rPr sz="2600" b="1" i="0">
+              <a:rPr sz="2600" b="1">
                 <a:solidFill>
-                  <a:srgbClr val="1A2A4A"/>
+                  <a:srgbClr val="C9A84C"/>
                 </a:solidFill>
+                <a:latin typeface="Arial"/>
               </a:rPr>
-              <a:t>100%</a:t>
+              <a:t>متوافق</a:t>
             </a:r>
           </a:p>
         </p:txBody>
       </p:sp>
       <p:sp>
         <p:nvSpPr>
-          <p:cNvPr id="46" name="TextBox 45"/>
+          <p:cNvPr id="44" name="TextBox 43"/>
           <p:cNvSpPr txBox="1"/>
           <p:nvPr/>
         </p:nvSpPr>
         <p:spPr>
           <a:xfrm>
-            <a:off x="5852160" y="9418320"/>
-            <a:ext cx="5394960" cy="347472"/>
+            <a:off x="12039600" y="6565392"/>
+            <a:ext cx="5791200" cy="365760"/>
           </a:xfrm>
           <a:prstGeom prst="rect">
             <a:avLst/>
@@ -8939,26 +8967,70 @@
           <a:p>
             <a:pPr algn="ctr"/>
             <a:r>
-              <a:rPr sz="1200" b="0" i="0">
+              <a:rPr sz="1300" b="0">
                 <a:solidFill>
-                  <a:srgbClr val="1A2A4A"/>
+                  <a:srgbClr val="FFFFFF"/>
                 </a:solidFill>
+                <a:latin typeface="Arial"/>
               </a:rPr>
-              <a:t>بيانات محلية آمنة</a:t>
+              <a:t>مع القانون الاتحادي</a:t>
             </a:r>
           </a:p>
         </p:txBody>
       </p:sp>
       <p:sp>
         <p:nvSpPr>
-          <p:cNvPr id="47" name="Rectangle 46"/>
+          <p:cNvPr id="45" name="Rectangle 44"/>
           <p:cNvSpPr/>
           <p:nvPr/>
         </p:nvSpPr>
         <p:spPr>
           <a:xfrm>
-            <a:off x="11384280" y="8823960"/>
-            <a:ext cx="5394960" cy="1097280"/>
+            <a:off x="0" y="9784080"/>
+            <a:ext cx="18288000" cy="502920"/>
+          </a:xfrm>
+          <a:prstGeom prst="rect">
+            <a:avLst/>
+          </a:prstGeom>
+          <a:solidFill>
+            <a:srgbClr val="0F1A30"/>
+          </a:solidFill>
+          <a:ln>
+            <a:noFill/>
+          </a:ln>
+        </p:spPr>
+        <p:style>
+          <a:lnRef idx="1">
+            <a:schemeClr val="accent1"/>
+          </a:lnRef>
+          <a:fillRef idx="3">
+            <a:schemeClr val="accent1"/>
+          </a:fillRef>
+          <a:effectRef idx="2">
+            <a:schemeClr val="accent1"/>
+          </a:effectRef>
+          <a:fontRef idx="minor">
+            <a:schemeClr val="lt1"/>
+          </a:fontRef>
+        </p:style>
+        <p:txBody>
+          <a:bodyPr rtlCol="0" anchor="ctr"/>
+          <a:lstStyle/>
+          <a:p>
+            <a:pPr algn="ctr"/>
+          </a:p>
+        </p:txBody>
+      </p:sp>
+      <p:sp>
+        <p:nvSpPr>
+          <p:cNvPr id="46" name="Rectangle 45"/>
+          <p:cNvSpPr/>
+          <p:nvPr/>
+        </p:nvSpPr>
+        <p:spPr>
+          <a:xfrm>
+            <a:off x="0" y="9784080"/>
+            <a:ext cx="18288000" cy="45720"/>
           </a:xfrm>
           <a:prstGeom prst="rect">
             <a:avLst/>
@@ -8966,10 +9038,8 @@
           <a:solidFill>
             <a:srgbClr val="C9A84C"/>
           </a:solidFill>
-          <a:ln w="12700">
-            <a:solidFill>
-              <a:srgbClr val="C9A84C"/>
-            </a:solidFill>
+          <a:ln>
+            <a:noFill/>
           </a:ln>
         </p:spPr>
         <p:style>
@@ -8996,14 +9066,14 @@
       </p:sp>
       <p:sp>
         <p:nvSpPr>
-          <p:cNvPr id="48" name="TextBox 47"/>
+          <p:cNvPr id="47" name="TextBox 46"/>
           <p:cNvSpPr txBox="1"/>
           <p:nvPr/>
         </p:nvSpPr>
         <p:spPr>
           <a:xfrm>
-            <a:off x="11384280" y="8887968"/>
-            <a:ext cx="5394960" cy="566928"/>
+            <a:off x="274320" y="9857232"/>
+            <a:ext cx="17739360" cy="347472"/>
           </a:xfrm>
           <a:prstGeom prst="rect">
             <a:avLst/>
@@ -9018,46 +9088,13 @@
           <a:p>
             <a:pPr algn="ctr"/>
             <a:r>
-              <a:rPr sz="2600" b="1" i="0">
+              <a:rPr sz="1400" b="0">
                 <a:solidFill>
-                  <a:srgbClr val="1A2A4A"/>
+                  <a:srgbClr val="FFFFFF"/>
                 </a:solidFill>
+                <a:latin typeface="Arial"/>
               </a:rPr>
-              <a:t>متوافق</a:t>
-            </a:r>
-          </a:p>
-        </p:txBody>
-      </p:sp>
-      <p:sp>
-        <p:nvSpPr>
-          <p:cNvPr id="49" name="TextBox 48"/>
-          <p:cNvSpPr txBox="1"/>
-          <p:nvPr/>
-        </p:nvSpPr>
-        <p:spPr>
-          <a:xfrm>
-            <a:off x="11384280" y="9418320"/>
-            <a:ext cx="5394960" cy="347472"/>
-          </a:xfrm>
-          <a:prstGeom prst="rect">
-            <a:avLst/>
-          </a:prstGeom>
-          <a:noFill/>
-        </p:spPr>
-        <p:txBody>
-          <a:bodyPr wrap="square">
-            <a:spAutoFit/>
-          </a:bodyPr>
-          <a:lstStyle/>
-          <a:p>
-            <a:pPr algn="ctr"/>
-            <a:r>
-              <a:rPr sz="1200" b="0" i="0">
-                <a:solidFill>
-                  <a:srgbClr val="1A2A4A"/>
-                </a:solidFill>
-              </a:rPr>
-              <a:t>مع القانون الاتحادي</a:t>
+              <a:t>بوابة مدرسة الجود الرقمية — نموذج امتثال متكامل مع التشريع الإماراتي</a:t>
             </a:r>
           </a:p>
         </p:txBody>

</xml_diff>

<commit_message>
fix: v7 - slide 3 split layout image+text, slide 4 three image cards
</commit_message>
<xml_diff>
--- a/assets/aljood_pitch_with_law.pptx
+++ b/assets/aljood_pitch_with_law.pptx
@@ -5742,7 +5742,119 @@
         <p:spPr>
           <a:xfrm>
             <a:off x="0" y="0"/>
-            <a:ext cx="18288000" cy="73152"/>
+            <a:ext cx="18288000" cy="10287000"/>
+          </a:xfrm>
+          <a:prstGeom prst="rect">
+            <a:avLst/>
+          </a:prstGeom>
+          <a:solidFill>
+            <a:srgbClr val="1A2A4A"/>
+          </a:solidFill>
+          <a:ln>
+            <a:noFill/>
+          </a:ln>
+        </p:spPr>
+        <p:style>
+          <a:lnRef idx="1">
+            <a:schemeClr val="accent1"/>
+          </a:lnRef>
+          <a:fillRef idx="3">
+            <a:schemeClr val="accent1"/>
+          </a:fillRef>
+          <a:effectRef idx="2">
+            <a:schemeClr val="accent1"/>
+          </a:effectRef>
+          <a:fontRef idx="minor">
+            <a:schemeClr val="lt1"/>
+          </a:fontRef>
+        </p:style>
+        <p:txBody>
+          <a:bodyPr rtlCol="0" anchor="ctr"/>
+          <a:lstStyle/>
+          <a:p>
+            <a:pPr algn="ctr"/>
+          </a:p>
+        </p:txBody>
+      </p:sp>
+      <p:pic>
+        <p:nvPicPr>
+          <p:cNvPr id="3" name="Picture 2" descr="image.jpg"/>
+          <p:cNvPicPr>
+            <a:picLocks noChangeAspect="1"/>
+          </p:cNvPicPr>
+          <p:nvPr/>
+        </p:nvPicPr>
+        <p:blipFill>
+          <a:blip r:embed="rId2"/>
+          <a:stretch>
+            <a:fillRect/>
+          </a:stretch>
+        </p:blipFill>
+        <p:spPr>
+          <a:xfrm>
+            <a:off x="9784080" y="617220"/>
+            <a:ext cx="7955280" cy="9052560"/>
+          </a:xfrm>
+          <a:prstGeom prst="rect">
+            <a:avLst/>
+          </a:prstGeom>
+        </p:spPr>
+      </p:pic>
+      <p:sp>
+        <p:nvSpPr>
+          <p:cNvPr id="4" name="Rectangle 3"/>
+          <p:cNvSpPr/>
+          <p:nvPr/>
+        </p:nvSpPr>
+        <p:spPr>
+          <a:xfrm>
+            <a:off x="9784080" y="617220"/>
+            <a:ext cx="1097280" cy="9052560"/>
+          </a:xfrm>
+          <a:prstGeom prst="rect">
+            <a:avLst/>
+          </a:prstGeom>
+          <a:solidFill>
+            <a:srgbClr val="1A2A4A">
+              <a:alpha val="70000"/>
+            </a:srgbClr>
+          </a:solidFill>
+          <a:ln>
+            <a:noFill/>
+          </a:ln>
+        </p:spPr>
+        <p:style>
+          <a:lnRef idx="1">
+            <a:schemeClr val="accent1"/>
+          </a:lnRef>
+          <a:fillRef idx="3">
+            <a:schemeClr val="accent1"/>
+          </a:fillRef>
+          <a:effectRef idx="2">
+            <a:schemeClr val="accent1"/>
+          </a:effectRef>
+          <a:fontRef idx="minor">
+            <a:schemeClr val="lt1"/>
+          </a:fontRef>
+        </p:style>
+        <p:txBody>
+          <a:bodyPr rtlCol="0" anchor="ctr"/>
+          <a:lstStyle/>
+          <a:p>
+            <a:pPr algn="ctr"/>
+          </a:p>
+        </p:txBody>
+      </p:sp>
+      <p:sp>
+        <p:nvSpPr>
+          <p:cNvPr id="5" name="Rectangle 4"/>
+          <p:cNvSpPr/>
+          <p:nvPr/>
+        </p:nvSpPr>
+        <p:spPr>
+          <a:xfrm>
+            <a:off x="731520" y="1234440"/>
+            <a:ext cx="128016" cy="7818120"/>
           </a:xfrm>
           <a:prstGeom prst="rect">
             <a:avLst/>
@@ -5778,127 +5890,14 @@
       </p:sp>
       <p:sp>
         <p:nvSpPr>
-          <p:cNvPr id="3" name="Rectangle 2"/>
-          <p:cNvSpPr/>
-          <p:nvPr/>
-        </p:nvSpPr>
-        <p:spPr>
-          <a:xfrm>
-            <a:off x="0" y="73152"/>
-            <a:ext cx="18288000" cy="960120"/>
-          </a:xfrm>
-          <a:prstGeom prst="rect">
-            <a:avLst/>
-          </a:prstGeom>
-          <a:solidFill>
-            <a:srgbClr val="0F1A30"/>
-          </a:solidFill>
-          <a:ln>
-            <a:noFill/>
-          </a:ln>
-        </p:spPr>
-        <p:style>
-          <a:lnRef idx="1">
-            <a:schemeClr val="accent1"/>
-          </a:lnRef>
-          <a:fillRef idx="3">
-            <a:schemeClr val="accent1"/>
-          </a:fillRef>
-          <a:effectRef idx="2">
-            <a:schemeClr val="accent1"/>
-          </a:effectRef>
-          <a:fontRef idx="minor">
-            <a:schemeClr val="lt1"/>
-          </a:fontRef>
-        </p:style>
-        <p:txBody>
-          <a:bodyPr rtlCol="0" anchor="ctr"/>
-          <a:lstStyle/>
-          <a:p>
-            <a:pPr algn="ctr"/>
-          </a:p>
-        </p:txBody>
-      </p:sp>
-      <p:sp>
-        <p:nvSpPr>
-          <p:cNvPr id="4" name="TextBox 3"/>
-          <p:cNvSpPr txBox="1"/>
-          <p:nvPr/>
-        </p:nvSpPr>
-        <p:spPr>
-          <a:xfrm>
-            <a:off x="274320" y="109728"/>
-            <a:ext cx="17739360" cy="548640"/>
-          </a:xfrm>
-          <a:prstGeom prst="rect">
-            <a:avLst/>
-          </a:prstGeom>
-          <a:noFill/>
-        </p:spPr>
-        <p:txBody>
-          <a:bodyPr wrap="square">
-            <a:spAutoFit/>
-          </a:bodyPr>
-          <a:lstStyle/>
-          <a:p>
-            <a:pPr algn="ctr"/>
-            <a:r>
-              <a:rPr sz="2800" b="1">
-                <a:solidFill>
-                  <a:srgbClr val="C9A84C"/>
-                </a:solidFill>
-                <a:latin typeface="Arial"/>
-              </a:rPr>
-              <a:t>السياق الوطني: قانون سلامة الطفل الرقمي</a:t>
-            </a:r>
-          </a:p>
-        </p:txBody>
-      </p:sp>
-      <p:sp>
-        <p:nvSpPr>
-          <p:cNvPr id="5" name="TextBox 4"/>
-          <p:cNvSpPr txBox="1"/>
-          <p:nvPr/>
-        </p:nvSpPr>
-        <p:spPr>
-          <a:xfrm>
-            <a:off x="274320" y="658368"/>
-            <a:ext cx="17739360" cy="347472"/>
-          </a:xfrm>
-          <a:prstGeom prst="rect">
-            <a:avLst/>
-          </a:prstGeom>
-          <a:noFill/>
-        </p:spPr>
-        <p:txBody>
-          <a:bodyPr wrap="square">
-            <a:spAutoFit/>
-          </a:bodyPr>
-          <a:lstStyle/>
-          <a:p>
-            <a:pPr algn="ctr"/>
-            <a:r>
-              <a:rPr sz="1400" b="0">
-                <a:solidFill>
-                  <a:srgbClr val="FFFFFF"/>
-                </a:solidFill>
-                <a:latin typeface="Arial"/>
-              </a:rPr>
-              <a:t>UAE Federal Decree No. 2 / 2026 — Child Digital Safety Law</a:t>
-            </a:r>
-          </a:p>
-        </p:txBody>
-      </p:sp>
-      <p:sp>
-        <p:nvSpPr>
           <p:cNvPr id="6" name="Rectangle 5"/>
           <p:cNvSpPr/>
           <p:nvPr/>
         </p:nvSpPr>
         <p:spPr>
           <a:xfrm>
-            <a:off x="0" y="1033271"/>
-            <a:ext cx="18288000" cy="45720"/>
+            <a:off x="1243584" y="925830"/>
+            <a:ext cx="3474720" cy="977265"/>
           </a:xfrm>
           <a:prstGeom prst="rect">
             <a:avLst/>
@@ -5934,59 +5933,119 @@
       </p:sp>
       <p:sp>
         <p:nvSpPr>
-          <p:cNvPr id="7" name="Rectangle 6"/>
-          <p:cNvSpPr/>
+          <p:cNvPr id="7" name="TextBox 6"/>
+          <p:cNvSpPr txBox="1"/>
           <p:nvPr/>
         </p:nvSpPr>
         <p:spPr>
           <a:xfrm>
-            <a:off x="685800" y="1234440"/>
-            <a:ext cx="5303520" cy="1920240"/>
+            <a:off x="1243584" y="956691"/>
+            <a:ext cx="3474720" cy="905256"/>
           </a:xfrm>
           <a:prstGeom prst="rect">
             <a:avLst/>
           </a:prstGeom>
-          <a:solidFill>
-            <a:srgbClr val="22355E"/>
-          </a:solidFill>
-          <a:ln w="19050">
-            <a:solidFill>
-              <a:srgbClr val="C9A84C"/>
-            </a:solidFill>
-          </a:ln>
+          <a:noFill/>
         </p:spPr>
-        <p:style>
-          <a:lnRef idx="1">
-            <a:schemeClr val="accent1"/>
-          </a:lnRef>
-          <a:fillRef idx="3">
-            <a:schemeClr val="accent1"/>
-          </a:fillRef>
-          <a:effectRef idx="2">
-            <a:schemeClr val="accent1"/>
-          </a:effectRef>
-          <a:fontRef idx="minor">
-            <a:schemeClr val="lt1"/>
-          </a:fontRef>
-        </p:style>
-        <p:txBody>
-          <a:bodyPr rtlCol="0" anchor="ctr"/>
+        <p:txBody>
+          <a:bodyPr wrap="square">
+            <a:spAutoFit/>
+          </a:bodyPr>
           <a:lstStyle/>
           <a:p>
             <a:pPr algn="ctr"/>
-          </a:p>
-        </p:txBody>
-      </p:sp>
-      <p:sp>
-        <p:nvSpPr>
-          <p:cNvPr id="8" name="Rectangle 7"/>
+            <a:r>
+              <a:rPr sz="1800" b="1" i="0">
+                <a:solidFill>
+                  <a:srgbClr val="1A2A4A"/>
+                </a:solidFill>
+                <a:latin typeface="Calibri"/>
+              </a:rPr>
+              <a:t>يناير  2026</a:t>
+            </a:r>
+          </a:p>
+        </p:txBody>
+      </p:sp>
+      <p:sp>
+        <p:nvSpPr>
+          <p:cNvPr id="8" name="TextBox 7"/>
+          <p:cNvSpPr txBox="1"/>
+          <p:nvPr/>
+        </p:nvSpPr>
+        <p:spPr>
+          <a:xfrm>
+            <a:off x="1243584" y="2160270"/>
+            <a:ext cx="8046720" cy="1337310"/>
+          </a:xfrm>
+          <a:prstGeom prst="rect">
+            <a:avLst/>
+          </a:prstGeom>
+          <a:noFill/>
+        </p:spPr>
+        <p:txBody>
+          <a:bodyPr wrap="square">
+            <a:spAutoFit/>
+          </a:bodyPr>
+          <a:lstStyle/>
+          <a:p>
+            <a:pPr algn="l"/>
+            <a:r>
+              <a:rPr sz="2500" b="1" i="0">
+                <a:solidFill>
+                  <a:srgbClr val="C9A84C"/>
+                </a:solidFill>
+                <a:latin typeface="Calibri"/>
+              </a:rPr>
+              <a:t>قانون حماية الطفل الرقمي الإماراتي</a:t>
+            </a:r>
+          </a:p>
+        </p:txBody>
+      </p:sp>
+      <p:sp>
+        <p:nvSpPr>
+          <p:cNvPr id="9" name="TextBox 8"/>
+          <p:cNvSpPr txBox="1"/>
+          <p:nvPr/>
+        </p:nvSpPr>
+        <p:spPr>
+          <a:xfrm>
+            <a:off x="1243584" y="3549014"/>
+            <a:ext cx="8046720" cy="720090"/>
+          </a:xfrm>
+          <a:prstGeom prst="rect">
+            <a:avLst/>
+          </a:prstGeom>
+          <a:noFill/>
+        </p:spPr>
+        <p:txBody>
+          <a:bodyPr wrap="square">
+            <a:spAutoFit/>
+          </a:bodyPr>
+          <a:lstStyle/>
+          <a:p>
+            <a:pPr algn="l"/>
+            <a:r>
+              <a:rPr sz="1600" b="0" i="1">
+                <a:solidFill>
+                  <a:srgbClr val="D0D8E8"/>
+                </a:solidFill>
+                <a:latin typeface="Calibri"/>
+              </a:rPr>
+              <a:t>UAE Child Digital Safety Law</a:t>
+            </a:r>
+          </a:p>
+        </p:txBody>
+      </p:sp>
+      <p:sp>
+        <p:nvSpPr>
+          <p:cNvPr id="10" name="Rectangle 9"/>
           <p:cNvSpPr/>
           <p:nvPr/>
         </p:nvSpPr>
         <p:spPr>
           <a:xfrm>
-            <a:off x="685800" y="1234440"/>
-            <a:ext cx="109728" cy="1920240"/>
+            <a:off x="1243584" y="4443984"/>
+            <a:ext cx="7498080" cy="30861"/>
           </a:xfrm>
           <a:prstGeom prst="rect">
             <a:avLst/>
@@ -6022,14 +6081,14 @@
       </p:sp>
       <p:sp>
         <p:nvSpPr>
-          <p:cNvPr id="9" name="Rectangle 8"/>
+          <p:cNvPr id="11" name="Rectangle 10"/>
           <p:cNvSpPr/>
           <p:nvPr/>
         </p:nvSpPr>
         <p:spPr>
           <a:xfrm>
-            <a:off x="886968" y="1399032"/>
-            <a:ext cx="640080" cy="502920"/>
+            <a:off x="1243584" y="5061204"/>
+            <a:ext cx="174879" cy="174879"/>
           </a:xfrm>
           <a:prstGeom prst="rect">
             <a:avLst/>
@@ -6065,14 +6124,14 @@
       </p:sp>
       <p:sp>
         <p:nvSpPr>
-          <p:cNvPr id="10" name="TextBox 9"/>
+          <p:cNvPr id="12" name="TextBox 11"/>
           <p:cNvSpPr txBox="1"/>
           <p:nvPr/>
         </p:nvSpPr>
         <p:spPr>
           <a:xfrm>
-            <a:off x="886968" y="1399032"/>
-            <a:ext cx="640080" cy="502920"/>
+            <a:off x="1664208" y="4814316"/>
+            <a:ext cx="7626096" cy="720090"/>
           </a:xfrm>
           <a:prstGeom prst="rect">
             <a:avLst/>
@@ -6085,29 +6144,29 @@
           </a:bodyPr>
           <a:lstStyle/>
           <a:p>
-            <a:pPr algn="ctr"/>
+            <a:pPr algn="l"/>
             <a:r>
-              <a:rPr sz="1600" b="1">
+              <a:rPr sz="1900" b="1" i="0">
                 <a:solidFill>
-                  <a:srgbClr val="1A2A4A"/>
+                  <a:srgbClr val="FFFFFF"/>
                 </a:solidFill>
-                <a:latin typeface="Arial"/>
+                <a:latin typeface="Calibri"/>
               </a:rPr>
-              <a:t>01</a:t>
+              <a:t>حماية الأطفال من المحتوى الرقمي الضار</a:t>
             </a:r>
           </a:p>
         </p:txBody>
       </p:sp>
       <p:sp>
         <p:nvSpPr>
-          <p:cNvPr id="11" name="TextBox 10"/>
+          <p:cNvPr id="13" name="TextBox 12"/>
           <p:cNvSpPr txBox="1"/>
           <p:nvPr/>
         </p:nvSpPr>
         <p:spPr>
           <a:xfrm>
-            <a:off x="822960" y="1965960"/>
-            <a:ext cx="5029200" cy="594360"/>
+            <a:off x="1664208" y="5503545"/>
+            <a:ext cx="7626096" cy="668655"/>
           </a:xfrm>
           <a:prstGeom prst="rect">
             <a:avLst/>
@@ -6120,96 +6179,16 @@
           </a:bodyPr>
           <a:lstStyle/>
           <a:p>
-            <a:pPr algn="ctr"/>
+            <a:pPr algn="l"/>
             <a:r>
-              <a:rPr sz="1800" b="1">
+              <a:rPr sz="1300" b="0" i="1">
                 <a:solidFill>
-                  <a:srgbClr val="FFFFFF"/>
+                  <a:srgbClr val="D0D8E8"/>
                 </a:solidFill>
-                <a:latin typeface="Arial"/>
+                <a:latin typeface="Calibri"/>
               </a:rPr>
-              <a:t>حماية البيانات الرقمية للطلاب</a:t>
+              <a:t>Protecting children from harmful digital content</a:t>
             </a:r>
-          </a:p>
-        </p:txBody>
-      </p:sp>
-      <p:sp>
-        <p:nvSpPr>
-          <p:cNvPr id="12" name="TextBox 11"/>
-          <p:cNvSpPr txBox="1"/>
-          <p:nvPr/>
-        </p:nvSpPr>
-        <p:spPr>
-          <a:xfrm>
-            <a:off x="822960" y="2560320"/>
-            <a:ext cx="5029200" cy="457200"/>
-          </a:xfrm>
-          <a:prstGeom prst="rect">
-            <a:avLst/>
-          </a:prstGeom>
-          <a:noFill/>
-        </p:spPr>
-        <p:txBody>
-          <a:bodyPr wrap="square">
-            <a:spAutoFit/>
-          </a:bodyPr>
-          <a:lstStyle/>
-          <a:p>
-            <a:pPr algn="ctr"/>
-            <a:r>
-              <a:rPr sz="1200" b="0">
-                <a:solidFill>
-                  <a:srgbClr val="C9A84C"/>
-                </a:solidFill>
-                <a:latin typeface="Arial"/>
-              </a:rPr>
-              <a:t>Student Digital Data Protection</a:t>
-            </a:r>
-          </a:p>
-        </p:txBody>
-      </p:sp>
-      <p:sp>
-        <p:nvSpPr>
-          <p:cNvPr id="13" name="Rectangle 12"/>
-          <p:cNvSpPr/>
-          <p:nvPr/>
-        </p:nvSpPr>
-        <p:spPr>
-          <a:xfrm>
-            <a:off x="6492240" y="1234440"/>
-            <a:ext cx="5303520" cy="1920240"/>
-          </a:xfrm>
-          <a:prstGeom prst="rect">
-            <a:avLst/>
-          </a:prstGeom>
-          <a:solidFill>
-            <a:srgbClr val="22355E"/>
-          </a:solidFill>
-          <a:ln w="19050">
-            <a:solidFill>
-              <a:srgbClr val="C9A84C"/>
-            </a:solidFill>
-          </a:ln>
-        </p:spPr>
-        <p:style>
-          <a:lnRef idx="1">
-            <a:schemeClr val="accent1"/>
-          </a:lnRef>
-          <a:fillRef idx="3">
-            <a:schemeClr val="accent1"/>
-          </a:fillRef>
-          <a:effectRef idx="2">
-            <a:schemeClr val="accent1"/>
-          </a:effectRef>
-          <a:fontRef idx="minor">
-            <a:schemeClr val="lt1"/>
-          </a:fontRef>
-        </p:style>
-        <p:txBody>
-          <a:bodyPr rtlCol="0" anchor="ctr"/>
-          <a:lstStyle/>
-          <a:p>
-            <a:pPr algn="ctr"/>
           </a:p>
         </p:txBody>
       </p:sp>
@@ -6221,8 +6200,8 @@
         </p:nvSpPr>
         <p:spPr>
           <a:xfrm>
-            <a:off x="6492240" y="1234440"/>
-            <a:ext cx="109728" cy="1920240"/>
+            <a:off x="1243584" y="6655689"/>
+            <a:ext cx="174879" cy="174879"/>
           </a:xfrm>
           <a:prstGeom prst="rect">
             <a:avLst/>
@@ -6258,14 +6237,84 @@
       </p:sp>
       <p:sp>
         <p:nvSpPr>
-          <p:cNvPr id="15" name="Rectangle 14"/>
+          <p:cNvPr id="15" name="TextBox 14"/>
+          <p:cNvSpPr txBox="1"/>
+          <p:nvPr/>
+        </p:nvSpPr>
+        <p:spPr>
+          <a:xfrm>
+            <a:off x="1664208" y="6408801"/>
+            <a:ext cx="7626096" cy="720090"/>
+          </a:xfrm>
+          <a:prstGeom prst="rect">
+            <a:avLst/>
+          </a:prstGeom>
+          <a:noFill/>
+        </p:spPr>
+        <p:txBody>
+          <a:bodyPr wrap="square">
+            <a:spAutoFit/>
+          </a:bodyPr>
+          <a:lstStyle/>
+          <a:p>
+            <a:pPr algn="l"/>
+            <a:r>
+              <a:rPr sz="1900" b="1" i="0">
+                <a:solidFill>
+                  <a:srgbClr val="FFFFFF"/>
+                </a:solidFill>
+                <a:latin typeface="Calibri"/>
+              </a:rPr>
+              <a:t>صون الخصوصية والبيانات الشخصية</a:t>
+            </a:r>
+          </a:p>
+        </p:txBody>
+      </p:sp>
+      <p:sp>
+        <p:nvSpPr>
+          <p:cNvPr id="16" name="TextBox 15"/>
+          <p:cNvSpPr txBox="1"/>
+          <p:nvPr/>
+        </p:nvSpPr>
+        <p:spPr>
+          <a:xfrm>
+            <a:off x="1664208" y="7098030"/>
+            <a:ext cx="7626096" cy="668655"/>
+          </a:xfrm>
+          <a:prstGeom prst="rect">
+            <a:avLst/>
+          </a:prstGeom>
+          <a:noFill/>
+        </p:spPr>
+        <p:txBody>
+          <a:bodyPr wrap="square">
+            <a:spAutoFit/>
+          </a:bodyPr>
+          <a:lstStyle/>
+          <a:p>
+            <a:pPr algn="l"/>
+            <a:r>
+              <a:rPr sz="1300" b="0" i="1">
+                <a:solidFill>
+                  <a:srgbClr val="D0D8E8"/>
+                </a:solidFill>
+                <a:latin typeface="Calibri"/>
+              </a:rPr>
+              <a:t>Safeguarding personal privacy &amp; data</a:t>
+            </a:r>
+          </a:p>
+        </p:txBody>
+      </p:sp>
+      <p:sp>
+        <p:nvSpPr>
+          <p:cNvPr id="17" name="Rectangle 16"/>
           <p:cNvSpPr/>
           <p:nvPr/>
         </p:nvSpPr>
         <p:spPr>
           <a:xfrm>
-            <a:off x="6693408" y="1399032"/>
-            <a:ext cx="640080" cy="502920"/>
+            <a:off x="1243584" y="8250174"/>
+            <a:ext cx="174879" cy="174879"/>
           </a:xfrm>
           <a:prstGeom prst="rect">
             <a:avLst/>
@@ -6301,14 +6350,14 @@
       </p:sp>
       <p:sp>
         <p:nvSpPr>
-          <p:cNvPr id="16" name="TextBox 15"/>
+          <p:cNvPr id="18" name="TextBox 17"/>
           <p:cNvSpPr txBox="1"/>
           <p:nvPr/>
         </p:nvSpPr>
         <p:spPr>
           <a:xfrm>
-            <a:off x="6693408" y="1399032"/>
-            <a:ext cx="640080" cy="502920"/>
+            <a:off x="1664208" y="8003286"/>
+            <a:ext cx="7626096" cy="720090"/>
           </a:xfrm>
           <a:prstGeom prst="rect">
             <a:avLst/>
@@ -6321,29 +6370,29 @@
           </a:bodyPr>
           <a:lstStyle/>
           <a:p>
-            <a:pPr algn="ctr"/>
+            <a:pPr algn="l"/>
             <a:r>
-              <a:rPr sz="1600" b="1">
+              <a:rPr sz="1900" b="1" i="0">
                 <a:solidFill>
-                  <a:srgbClr val="1A2A4A"/>
+                  <a:srgbClr val="FFFFFF"/>
                 </a:solidFill>
-                <a:latin typeface="Arial"/>
+                <a:latin typeface="Calibri"/>
               </a:rPr>
-              <a:t>02</a:t>
+              <a:t>تعزيز الرقابة والمسؤولية الرقمية</a:t>
             </a:r>
           </a:p>
         </p:txBody>
       </p:sp>
       <p:sp>
         <p:nvSpPr>
-          <p:cNvPr id="17" name="TextBox 16"/>
+          <p:cNvPr id="19" name="TextBox 18"/>
           <p:cNvSpPr txBox="1"/>
           <p:nvPr/>
         </p:nvSpPr>
         <p:spPr>
           <a:xfrm>
-            <a:off x="6629400" y="1965960"/>
-            <a:ext cx="5029200" cy="594360"/>
+            <a:off x="1664208" y="8692515"/>
+            <a:ext cx="7626096" cy="668655"/>
           </a:xfrm>
           <a:prstGeom prst="rect">
             <a:avLst/>
@@ -6356,96 +6405,16 @@
           </a:bodyPr>
           <a:lstStyle/>
           <a:p>
-            <a:pPr algn="ctr"/>
+            <a:pPr algn="l"/>
             <a:r>
-              <a:rPr sz="1800" b="1">
+              <a:rPr sz="1300" b="0" i="1">
                 <a:solidFill>
-                  <a:srgbClr val="FFFFFF"/>
+                  <a:srgbClr val="D0D8E8"/>
                 </a:solidFill>
-                <a:latin typeface="Arial"/>
+                <a:latin typeface="Calibri"/>
               </a:rPr>
-              <a:t>توثيق هوية المستخدمين</a:t>
+              <a:t>Promoting digital oversight &amp; accountability</a:t>
             </a:r>
-          </a:p>
-        </p:txBody>
-      </p:sp>
-      <p:sp>
-        <p:nvSpPr>
-          <p:cNvPr id="18" name="TextBox 17"/>
-          <p:cNvSpPr txBox="1"/>
-          <p:nvPr/>
-        </p:nvSpPr>
-        <p:spPr>
-          <a:xfrm>
-            <a:off x="6629400" y="2560320"/>
-            <a:ext cx="5029200" cy="457200"/>
-          </a:xfrm>
-          <a:prstGeom prst="rect">
-            <a:avLst/>
-          </a:prstGeom>
-          <a:noFill/>
-        </p:spPr>
-        <p:txBody>
-          <a:bodyPr wrap="square">
-            <a:spAutoFit/>
-          </a:bodyPr>
-          <a:lstStyle/>
-          <a:p>
-            <a:pPr algn="ctr"/>
-            <a:r>
-              <a:rPr sz="1200" b="0">
-                <a:solidFill>
-                  <a:srgbClr val="C9A84C"/>
-                </a:solidFill>
-                <a:latin typeface="Arial"/>
-              </a:rPr>
-              <a:t>User Identity Verification</a:t>
-            </a:r>
-          </a:p>
-        </p:txBody>
-      </p:sp>
-      <p:sp>
-        <p:nvSpPr>
-          <p:cNvPr id="19" name="Rectangle 18"/>
-          <p:cNvSpPr/>
-          <p:nvPr/>
-        </p:nvSpPr>
-        <p:spPr>
-          <a:xfrm>
-            <a:off x="12298680" y="1234440"/>
-            <a:ext cx="5303520" cy="1920240"/>
-          </a:xfrm>
-          <a:prstGeom prst="rect">
-            <a:avLst/>
-          </a:prstGeom>
-          <a:solidFill>
-            <a:srgbClr val="22355E"/>
-          </a:solidFill>
-          <a:ln w="19050">
-            <a:solidFill>
-              <a:srgbClr val="C9A84C"/>
-            </a:solidFill>
-          </a:ln>
-        </p:spPr>
-        <p:style>
-          <a:lnRef idx="1">
-            <a:schemeClr val="accent1"/>
-          </a:lnRef>
-          <a:fillRef idx="3">
-            <a:schemeClr val="accent1"/>
-          </a:fillRef>
-          <a:effectRef idx="2">
-            <a:schemeClr val="accent1"/>
-          </a:effectRef>
-          <a:fontRef idx="minor">
-            <a:schemeClr val="lt1"/>
-          </a:fontRef>
-        </p:style>
-        <p:txBody>
-          <a:bodyPr rtlCol="0" anchor="ctr"/>
-          <a:lstStyle/>
-          <a:p>
-            <a:pPr algn="ctr"/>
           </a:p>
         </p:txBody>
       </p:sp>
@@ -6457,8 +6426,8 @@
         </p:nvSpPr>
         <p:spPr>
           <a:xfrm>
-            <a:off x="12298680" y="1234440"/>
-            <a:ext cx="109728" cy="1920240"/>
+            <a:off x="0" y="9690354"/>
+            <a:ext cx="18288000" cy="102870"/>
           </a:xfrm>
           <a:prstGeom prst="rect">
             <a:avLst/>
@@ -6489,747 +6458,6 @@
           <a:lstStyle/>
           <a:p>
             <a:pPr algn="ctr"/>
-          </a:p>
-        </p:txBody>
-      </p:sp>
-      <p:sp>
-        <p:nvSpPr>
-          <p:cNvPr id="21" name="Rectangle 20"/>
-          <p:cNvSpPr/>
-          <p:nvPr/>
-        </p:nvSpPr>
-        <p:spPr>
-          <a:xfrm>
-            <a:off x="12499848" y="1399032"/>
-            <a:ext cx="640080" cy="502920"/>
-          </a:xfrm>
-          <a:prstGeom prst="rect">
-            <a:avLst/>
-          </a:prstGeom>
-          <a:solidFill>
-            <a:srgbClr val="C9A84C"/>
-          </a:solidFill>
-          <a:ln>
-            <a:noFill/>
-          </a:ln>
-        </p:spPr>
-        <p:style>
-          <a:lnRef idx="1">
-            <a:schemeClr val="accent1"/>
-          </a:lnRef>
-          <a:fillRef idx="3">
-            <a:schemeClr val="accent1"/>
-          </a:fillRef>
-          <a:effectRef idx="2">
-            <a:schemeClr val="accent1"/>
-          </a:effectRef>
-          <a:fontRef idx="minor">
-            <a:schemeClr val="lt1"/>
-          </a:fontRef>
-        </p:style>
-        <p:txBody>
-          <a:bodyPr rtlCol="0" anchor="ctr"/>
-          <a:lstStyle/>
-          <a:p>
-            <a:pPr algn="ctr"/>
-          </a:p>
-        </p:txBody>
-      </p:sp>
-      <p:sp>
-        <p:nvSpPr>
-          <p:cNvPr id="22" name="TextBox 21"/>
-          <p:cNvSpPr txBox="1"/>
-          <p:nvPr/>
-        </p:nvSpPr>
-        <p:spPr>
-          <a:xfrm>
-            <a:off x="12499848" y="1399032"/>
-            <a:ext cx="640080" cy="502920"/>
-          </a:xfrm>
-          <a:prstGeom prst="rect">
-            <a:avLst/>
-          </a:prstGeom>
-          <a:noFill/>
-        </p:spPr>
-        <p:txBody>
-          <a:bodyPr wrap="square">
-            <a:spAutoFit/>
-          </a:bodyPr>
-          <a:lstStyle/>
-          <a:p>
-            <a:pPr algn="ctr"/>
-            <a:r>
-              <a:rPr sz="1600" b="1">
-                <a:solidFill>
-                  <a:srgbClr val="1A2A4A"/>
-                </a:solidFill>
-                <a:latin typeface="Arial"/>
-              </a:rPr>
-              <a:t>03</a:t>
-            </a:r>
-          </a:p>
-        </p:txBody>
-      </p:sp>
-      <p:sp>
-        <p:nvSpPr>
-          <p:cNvPr id="23" name="TextBox 22"/>
-          <p:cNvSpPr txBox="1"/>
-          <p:nvPr/>
-        </p:nvSpPr>
-        <p:spPr>
-          <a:xfrm>
-            <a:off x="12435840" y="1965960"/>
-            <a:ext cx="5029200" cy="594360"/>
-          </a:xfrm>
-          <a:prstGeom prst="rect">
-            <a:avLst/>
-          </a:prstGeom>
-          <a:noFill/>
-        </p:spPr>
-        <p:txBody>
-          <a:bodyPr wrap="square">
-            <a:spAutoFit/>
-          </a:bodyPr>
-          <a:lstStyle/>
-          <a:p>
-            <a:pPr algn="ctr"/>
-            <a:r>
-              <a:rPr sz="1800" b="1">
-                <a:solidFill>
-                  <a:srgbClr val="FFFFFF"/>
-                </a:solidFill>
-                <a:latin typeface="Arial"/>
-              </a:rPr>
-              <a:t>رقابة أولياء الأمور</a:t>
-            </a:r>
-          </a:p>
-        </p:txBody>
-      </p:sp>
-      <p:sp>
-        <p:nvSpPr>
-          <p:cNvPr id="24" name="TextBox 23"/>
-          <p:cNvSpPr txBox="1"/>
-          <p:nvPr/>
-        </p:nvSpPr>
-        <p:spPr>
-          <a:xfrm>
-            <a:off x="12435840" y="2560320"/>
-            <a:ext cx="5029200" cy="457200"/>
-          </a:xfrm>
-          <a:prstGeom prst="rect">
-            <a:avLst/>
-          </a:prstGeom>
-          <a:noFill/>
-        </p:spPr>
-        <p:txBody>
-          <a:bodyPr wrap="square">
-            <a:spAutoFit/>
-          </a:bodyPr>
-          <a:lstStyle/>
-          <a:p>
-            <a:pPr algn="ctr"/>
-            <a:r>
-              <a:rPr sz="1200" b="0">
-                <a:solidFill>
-                  <a:srgbClr val="C9A84C"/>
-                </a:solidFill>
-                <a:latin typeface="Arial"/>
-              </a:rPr>
-              <a:t>Parental Monitoring &amp; Control</a:t>
-            </a:r>
-          </a:p>
-        </p:txBody>
-      </p:sp>
-      <p:sp>
-        <p:nvSpPr>
-          <p:cNvPr id="25" name="Rectangle 24"/>
-          <p:cNvSpPr/>
-          <p:nvPr/>
-        </p:nvSpPr>
-        <p:spPr>
-          <a:xfrm>
-            <a:off x="3589020" y="3429000"/>
-            <a:ext cx="5303520" cy="1920240"/>
-          </a:xfrm>
-          <a:prstGeom prst="rect">
-            <a:avLst/>
-          </a:prstGeom>
-          <a:solidFill>
-            <a:srgbClr val="22355E"/>
-          </a:solidFill>
-          <a:ln w="19050">
-            <a:solidFill>
-              <a:srgbClr val="C9A84C"/>
-            </a:solidFill>
-          </a:ln>
-        </p:spPr>
-        <p:style>
-          <a:lnRef idx="1">
-            <a:schemeClr val="accent1"/>
-          </a:lnRef>
-          <a:fillRef idx="3">
-            <a:schemeClr val="accent1"/>
-          </a:fillRef>
-          <a:effectRef idx="2">
-            <a:schemeClr val="accent1"/>
-          </a:effectRef>
-          <a:fontRef idx="minor">
-            <a:schemeClr val="lt1"/>
-          </a:fontRef>
-        </p:style>
-        <p:txBody>
-          <a:bodyPr rtlCol="0" anchor="ctr"/>
-          <a:lstStyle/>
-          <a:p>
-            <a:pPr algn="ctr"/>
-          </a:p>
-        </p:txBody>
-      </p:sp>
-      <p:sp>
-        <p:nvSpPr>
-          <p:cNvPr id="26" name="Rectangle 25"/>
-          <p:cNvSpPr/>
-          <p:nvPr/>
-        </p:nvSpPr>
-        <p:spPr>
-          <a:xfrm>
-            <a:off x="3589020" y="3429000"/>
-            <a:ext cx="109728" cy="1920240"/>
-          </a:xfrm>
-          <a:prstGeom prst="rect">
-            <a:avLst/>
-          </a:prstGeom>
-          <a:solidFill>
-            <a:srgbClr val="C9A84C"/>
-          </a:solidFill>
-          <a:ln>
-            <a:noFill/>
-          </a:ln>
-        </p:spPr>
-        <p:style>
-          <a:lnRef idx="1">
-            <a:schemeClr val="accent1"/>
-          </a:lnRef>
-          <a:fillRef idx="3">
-            <a:schemeClr val="accent1"/>
-          </a:fillRef>
-          <a:effectRef idx="2">
-            <a:schemeClr val="accent1"/>
-          </a:effectRef>
-          <a:fontRef idx="minor">
-            <a:schemeClr val="lt1"/>
-          </a:fontRef>
-        </p:style>
-        <p:txBody>
-          <a:bodyPr rtlCol="0" anchor="ctr"/>
-          <a:lstStyle/>
-          <a:p>
-            <a:pPr algn="ctr"/>
-          </a:p>
-        </p:txBody>
-      </p:sp>
-      <p:sp>
-        <p:nvSpPr>
-          <p:cNvPr id="27" name="Rectangle 26"/>
-          <p:cNvSpPr/>
-          <p:nvPr/>
-        </p:nvSpPr>
-        <p:spPr>
-          <a:xfrm>
-            <a:off x="3790188" y="3593592"/>
-            <a:ext cx="640080" cy="502920"/>
-          </a:xfrm>
-          <a:prstGeom prst="rect">
-            <a:avLst/>
-          </a:prstGeom>
-          <a:solidFill>
-            <a:srgbClr val="C9A84C"/>
-          </a:solidFill>
-          <a:ln>
-            <a:noFill/>
-          </a:ln>
-        </p:spPr>
-        <p:style>
-          <a:lnRef idx="1">
-            <a:schemeClr val="accent1"/>
-          </a:lnRef>
-          <a:fillRef idx="3">
-            <a:schemeClr val="accent1"/>
-          </a:fillRef>
-          <a:effectRef idx="2">
-            <a:schemeClr val="accent1"/>
-          </a:effectRef>
-          <a:fontRef idx="minor">
-            <a:schemeClr val="lt1"/>
-          </a:fontRef>
-        </p:style>
-        <p:txBody>
-          <a:bodyPr rtlCol="0" anchor="ctr"/>
-          <a:lstStyle/>
-          <a:p>
-            <a:pPr algn="ctr"/>
-          </a:p>
-        </p:txBody>
-      </p:sp>
-      <p:sp>
-        <p:nvSpPr>
-          <p:cNvPr id="28" name="TextBox 27"/>
-          <p:cNvSpPr txBox="1"/>
-          <p:nvPr/>
-        </p:nvSpPr>
-        <p:spPr>
-          <a:xfrm>
-            <a:off x="3790188" y="3593592"/>
-            <a:ext cx="640080" cy="502920"/>
-          </a:xfrm>
-          <a:prstGeom prst="rect">
-            <a:avLst/>
-          </a:prstGeom>
-          <a:noFill/>
-        </p:spPr>
-        <p:txBody>
-          <a:bodyPr wrap="square">
-            <a:spAutoFit/>
-          </a:bodyPr>
-          <a:lstStyle/>
-          <a:p>
-            <a:pPr algn="ctr"/>
-            <a:r>
-              <a:rPr sz="1600" b="1">
-                <a:solidFill>
-                  <a:srgbClr val="1A2A4A"/>
-                </a:solidFill>
-                <a:latin typeface="Arial"/>
-              </a:rPr>
-              <a:t>04</a:t>
-            </a:r>
-          </a:p>
-        </p:txBody>
-      </p:sp>
-      <p:sp>
-        <p:nvSpPr>
-          <p:cNvPr id="29" name="TextBox 28"/>
-          <p:cNvSpPr txBox="1"/>
-          <p:nvPr/>
-        </p:nvSpPr>
-        <p:spPr>
-          <a:xfrm>
-            <a:off x="3726180" y="4160520"/>
-            <a:ext cx="5029200" cy="594360"/>
-          </a:xfrm>
-          <a:prstGeom prst="rect">
-            <a:avLst/>
-          </a:prstGeom>
-          <a:noFill/>
-        </p:spPr>
-        <p:txBody>
-          <a:bodyPr wrap="square">
-            <a:spAutoFit/>
-          </a:bodyPr>
-          <a:lstStyle/>
-          <a:p>
-            <a:pPr algn="ctr"/>
-            <a:r>
-              <a:rPr sz="1800" b="1">
-                <a:solidFill>
-                  <a:srgbClr val="FFFFFF"/>
-                </a:solidFill>
-                <a:latin typeface="Arial"/>
-              </a:rPr>
-              <a:t>الإبلاغ الفوري عن الاختراقات</a:t>
-            </a:r>
-          </a:p>
-        </p:txBody>
-      </p:sp>
-      <p:sp>
-        <p:nvSpPr>
-          <p:cNvPr id="30" name="TextBox 29"/>
-          <p:cNvSpPr txBox="1"/>
-          <p:nvPr/>
-        </p:nvSpPr>
-        <p:spPr>
-          <a:xfrm>
-            <a:off x="3726180" y="4754880"/>
-            <a:ext cx="5029200" cy="457200"/>
-          </a:xfrm>
-          <a:prstGeom prst="rect">
-            <a:avLst/>
-          </a:prstGeom>
-          <a:noFill/>
-        </p:spPr>
-        <p:txBody>
-          <a:bodyPr wrap="square">
-            <a:spAutoFit/>
-          </a:bodyPr>
-          <a:lstStyle/>
-          <a:p>
-            <a:pPr algn="ctr"/>
-            <a:r>
-              <a:rPr sz="1200" b="0">
-                <a:solidFill>
-                  <a:srgbClr val="C9A84C"/>
-                </a:solidFill>
-                <a:latin typeface="Arial"/>
-              </a:rPr>
-              <a:t>Mandatory Breach Reporting</a:t>
-            </a:r>
-          </a:p>
-        </p:txBody>
-      </p:sp>
-      <p:sp>
-        <p:nvSpPr>
-          <p:cNvPr id="31" name="Rectangle 30"/>
-          <p:cNvSpPr/>
-          <p:nvPr/>
-        </p:nvSpPr>
-        <p:spPr>
-          <a:xfrm>
-            <a:off x="9395460" y="3429000"/>
-            <a:ext cx="5303520" cy="1920240"/>
-          </a:xfrm>
-          <a:prstGeom prst="rect">
-            <a:avLst/>
-          </a:prstGeom>
-          <a:solidFill>
-            <a:srgbClr val="22355E"/>
-          </a:solidFill>
-          <a:ln w="19050">
-            <a:solidFill>
-              <a:srgbClr val="C9A84C"/>
-            </a:solidFill>
-          </a:ln>
-        </p:spPr>
-        <p:style>
-          <a:lnRef idx="1">
-            <a:schemeClr val="accent1"/>
-          </a:lnRef>
-          <a:fillRef idx="3">
-            <a:schemeClr val="accent1"/>
-          </a:fillRef>
-          <a:effectRef idx="2">
-            <a:schemeClr val="accent1"/>
-          </a:effectRef>
-          <a:fontRef idx="minor">
-            <a:schemeClr val="lt1"/>
-          </a:fontRef>
-        </p:style>
-        <p:txBody>
-          <a:bodyPr rtlCol="0" anchor="ctr"/>
-          <a:lstStyle/>
-          <a:p>
-            <a:pPr algn="ctr"/>
-          </a:p>
-        </p:txBody>
-      </p:sp>
-      <p:sp>
-        <p:nvSpPr>
-          <p:cNvPr id="32" name="Rectangle 31"/>
-          <p:cNvSpPr/>
-          <p:nvPr/>
-        </p:nvSpPr>
-        <p:spPr>
-          <a:xfrm>
-            <a:off x="9395460" y="3429000"/>
-            <a:ext cx="109728" cy="1920240"/>
-          </a:xfrm>
-          <a:prstGeom prst="rect">
-            <a:avLst/>
-          </a:prstGeom>
-          <a:solidFill>
-            <a:srgbClr val="C9A84C"/>
-          </a:solidFill>
-          <a:ln>
-            <a:noFill/>
-          </a:ln>
-        </p:spPr>
-        <p:style>
-          <a:lnRef idx="1">
-            <a:schemeClr val="accent1"/>
-          </a:lnRef>
-          <a:fillRef idx="3">
-            <a:schemeClr val="accent1"/>
-          </a:fillRef>
-          <a:effectRef idx="2">
-            <a:schemeClr val="accent1"/>
-          </a:effectRef>
-          <a:fontRef idx="minor">
-            <a:schemeClr val="lt1"/>
-          </a:fontRef>
-        </p:style>
-        <p:txBody>
-          <a:bodyPr rtlCol="0" anchor="ctr"/>
-          <a:lstStyle/>
-          <a:p>
-            <a:pPr algn="ctr"/>
-          </a:p>
-        </p:txBody>
-      </p:sp>
-      <p:sp>
-        <p:nvSpPr>
-          <p:cNvPr id="33" name="Rectangle 32"/>
-          <p:cNvSpPr/>
-          <p:nvPr/>
-        </p:nvSpPr>
-        <p:spPr>
-          <a:xfrm>
-            <a:off x="9596628" y="3593592"/>
-            <a:ext cx="640080" cy="502920"/>
-          </a:xfrm>
-          <a:prstGeom prst="rect">
-            <a:avLst/>
-          </a:prstGeom>
-          <a:solidFill>
-            <a:srgbClr val="C9A84C"/>
-          </a:solidFill>
-          <a:ln>
-            <a:noFill/>
-          </a:ln>
-        </p:spPr>
-        <p:style>
-          <a:lnRef idx="1">
-            <a:schemeClr val="accent1"/>
-          </a:lnRef>
-          <a:fillRef idx="3">
-            <a:schemeClr val="accent1"/>
-          </a:fillRef>
-          <a:effectRef idx="2">
-            <a:schemeClr val="accent1"/>
-          </a:effectRef>
-          <a:fontRef idx="minor">
-            <a:schemeClr val="lt1"/>
-          </a:fontRef>
-        </p:style>
-        <p:txBody>
-          <a:bodyPr rtlCol="0" anchor="ctr"/>
-          <a:lstStyle/>
-          <a:p>
-            <a:pPr algn="ctr"/>
-          </a:p>
-        </p:txBody>
-      </p:sp>
-      <p:sp>
-        <p:nvSpPr>
-          <p:cNvPr id="34" name="TextBox 33"/>
-          <p:cNvSpPr txBox="1"/>
-          <p:nvPr/>
-        </p:nvSpPr>
-        <p:spPr>
-          <a:xfrm>
-            <a:off x="9596628" y="3593592"/>
-            <a:ext cx="640080" cy="502920"/>
-          </a:xfrm>
-          <a:prstGeom prst="rect">
-            <a:avLst/>
-          </a:prstGeom>
-          <a:noFill/>
-        </p:spPr>
-        <p:txBody>
-          <a:bodyPr wrap="square">
-            <a:spAutoFit/>
-          </a:bodyPr>
-          <a:lstStyle/>
-          <a:p>
-            <a:pPr algn="ctr"/>
-            <a:r>
-              <a:rPr sz="1600" b="1">
-                <a:solidFill>
-                  <a:srgbClr val="1A2A4A"/>
-                </a:solidFill>
-                <a:latin typeface="Arial"/>
-              </a:rPr>
-              <a:t>05</a:t>
-            </a:r>
-          </a:p>
-        </p:txBody>
-      </p:sp>
-      <p:sp>
-        <p:nvSpPr>
-          <p:cNvPr id="35" name="TextBox 34"/>
-          <p:cNvSpPr txBox="1"/>
-          <p:nvPr/>
-        </p:nvSpPr>
-        <p:spPr>
-          <a:xfrm>
-            <a:off x="9532620" y="4160520"/>
-            <a:ext cx="5029200" cy="594360"/>
-          </a:xfrm>
-          <a:prstGeom prst="rect">
-            <a:avLst/>
-          </a:prstGeom>
-          <a:noFill/>
-        </p:spPr>
-        <p:txBody>
-          <a:bodyPr wrap="square">
-            <a:spAutoFit/>
-          </a:bodyPr>
-          <a:lstStyle/>
-          <a:p>
-            <a:pPr algn="ctr"/>
-            <a:r>
-              <a:rPr sz="1800" b="1">
-                <a:solidFill>
-                  <a:srgbClr val="FFFFFF"/>
-                </a:solidFill>
-                <a:latin typeface="Arial"/>
-              </a:rPr>
-              <a:t>ضبط صلاحيات الوصول</a:t>
-            </a:r>
-          </a:p>
-        </p:txBody>
-      </p:sp>
-      <p:sp>
-        <p:nvSpPr>
-          <p:cNvPr id="36" name="TextBox 35"/>
-          <p:cNvSpPr txBox="1"/>
-          <p:nvPr/>
-        </p:nvSpPr>
-        <p:spPr>
-          <a:xfrm>
-            <a:off x="9532620" y="4754880"/>
-            <a:ext cx="5029200" cy="457200"/>
-          </a:xfrm>
-          <a:prstGeom prst="rect">
-            <a:avLst/>
-          </a:prstGeom>
-          <a:noFill/>
-        </p:spPr>
-        <p:txBody>
-          <a:bodyPr wrap="square">
-            <a:spAutoFit/>
-          </a:bodyPr>
-          <a:lstStyle/>
-          <a:p>
-            <a:pPr algn="ctr"/>
-            <a:r>
-              <a:rPr sz="1200" b="0">
-                <a:solidFill>
-                  <a:srgbClr val="C9A84C"/>
-                </a:solidFill>
-                <a:latin typeface="Arial"/>
-              </a:rPr>
-              <a:t>Granular Access Control</a:t>
-            </a:r>
-          </a:p>
-        </p:txBody>
-      </p:sp>
-      <p:sp>
-        <p:nvSpPr>
-          <p:cNvPr id="37" name="Rectangle 36"/>
-          <p:cNvSpPr/>
-          <p:nvPr/>
-        </p:nvSpPr>
-        <p:spPr>
-          <a:xfrm>
-            <a:off x="0" y="9784080"/>
-            <a:ext cx="18288000" cy="502920"/>
-          </a:xfrm>
-          <a:prstGeom prst="rect">
-            <a:avLst/>
-          </a:prstGeom>
-          <a:solidFill>
-            <a:srgbClr val="0F1A30"/>
-          </a:solidFill>
-          <a:ln>
-            <a:noFill/>
-          </a:ln>
-        </p:spPr>
-        <p:style>
-          <a:lnRef idx="1">
-            <a:schemeClr val="accent1"/>
-          </a:lnRef>
-          <a:fillRef idx="3">
-            <a:schemeClr val="accent1"/>
-          </a:fillRef>
-          <a:effectRef idx="2">
-            <a:schemeClr val="accent1"/>
-          </a:effectRef>
-          <a:fontRef idx="minor">
-            <a:schemeClr val="lt1"/>
-          </a:fontRef>
-        </p:style>
-        <p:txBody>
-          <a:bodyPr rtlCol="0" anchor="ctr"/>
-          <a:lstStyle/>
-          <a:p>
-            <a:pPr algn="ctr"/>
-          </a:p>
-        </p:txBody>
-      </p:sp>
-      <p:sp>
-        <p:nvSpPr>
-          <p:cNvPr id="38" name="Rectangle 37"/>
-          <p:cNvSpPr/>
-          <p:nvPr/>
-        </p:nvSpPr>
-        <p:spPr>
-          <a:xfrm>
-            <a:off x="0" y="9784080"/>
-            <a:ext cx="18288000" cy="45720"/>
-          </a:xfrm>
-          <a:prstGeom prst="rect">
-            <a:avLst/>
-          </a:prstGeom>
-          <a:solidFill>
-            <a:srgbClr val="C9A84C"/>
-          </a:solidFill>
-          <a:ln>
-            <a:noFill/>
-          </a:ln>
-        </p:spPr>
-        <p:style>
-          <a:lnRef idx="1">
-            <a:schemeClr val="accent1"/>
-          </a:lnRef>
-          <a:fillRef idx="3">
-            <a:schemeClr val="accent1"/>
-          </a:fillRef>
-          <a:effectRef idx="2">
-            <a:schemeClr val="accent1"/>
-          </a:effectRef>
-          <a:fontRef idx="minor">
-            <a:schemeClr val="lt1"/>
-          </a:fontRef>
-        </p:style>
-        <p:txBody>
-          <a:bodyPr rtlCol="0" anchor="ctr"/>
-          <a:lstStyle/>
-          <a:p>
-            <a:pPr algn="ctr"/>
-          </a:p>
-        </p:txBody>
-      </p:sp>
-      <p:sp>
-        <p:nvSpPr>
-          <p:cNvPr id="39" name="TextBox 38"/>
-          <p:cNvSpPr txBox="1"/>
-          <p:nvPr/>
-        </p:nvSpPr>
-        <p:spPr>
-          <a:xfrm>
-            <a:off x="274320" y="9857232"/>
-            <a:ext cx="17739360" cy="347472"/>
-          </a:xfrm>
-          <a:prstGeom prst="rect">
-            <a:avLst/>
-          </a:prstGeom>
-          <a:noFill/>
-        </p:spPr>
-        <p:txBody>
-          <a:bodyPr wrap="square">
-            <a:spAutoFit/>
-          </a:bodyPr>
-          <a:lstStyle/>
-          <a:p>
-            <a:pPr algn="ctr"/>
-            <a:r>
-              <a:rPr sz="1400" b="0">
-                <a:solidFill>
-                  <a:srgbClr val="FFFFFF"/>
-                </a:solidFill>
-                <a:latin typeface="Arial"/>
-              </a:rPr>
-              <a:t>أول تشريع اتحادي إماراتي لحماية الطفل في الفضاء الرقمي — يناير 2026</a:t>
-            </a:r>
           </a:p>
         </p:txBody>
       </p:sp>
@@ -7274,7 +6502,50 @@
         <p:spPr>
           <a:xfrm>
             <a:off x="0" y="0"/>
-            <a:ext cx="18288000" cy="73152"/>
+            <a:ext cx="18288000" cy="10287000"/>
+          </a:xfrm>
+          <a:prstGeom prst="rect">
+            <a:avLst/>
+          </a:prstGeom>
+          <a:solidFill>
+            <a:srgbClr val="1A2A4A"/>
+          </a:solidFill>
+          <a:ln>
+            <a:noFill/>
+          </a:ln>
+        </p:spPr>
+        <p:style>
+          <a:lnRef idx="1">
+            <a:schemeClr val="accent1"/>
+          </a:lnRef>
+          <a:fillRef idx="3">
+            <a:schemeClr val="accent1"/>
+          </a:fillRef>
+          <a:effectRef idx="2">
+            <a:schemeClr val="accent1"/>
+          </a:effectRef>
+          <a:fontRef idx="minor">
+            <a:schemeClr val="lt1"/>
+          </a:fontRef>
+        </p:style>
+        <p:txBody>
+          <a:bodyPr rtlCol="0" anchor="ctr"/>
+          <a:lstStyle/>
+          <a:p>
+            <a:pPr algn="ctr"/>
+          </a:p>
+        </p:txBody>
+      </p:sp>
+      <p:sp>
+        <p:nvSpPr>
+          <p:cNvPr id="3" name="Rectangle 2"/>
+          <p:cNvSpPr/>
+          <p:nvPr/>
+        </p:nvSpPr>
+        <p:spPr>
+          <a:xfrm>
+            <a:off x="0" y="0"/>
+            <a:ext cx="18288000" cy="123444"/>
           </a:xfrm>
           <a:prstGeom prst="rect">
             <a:avLst/>
@@ -7310,20 +6581,116 @@
       </p:sp>
       <p:sp>
         <p:nvSpPr>
-          <p:cNvPr id="3" name="Rectangle 2"/>
+          <p:cNvPr id="4" name="TextBox 3"/>
+          <p:cNvSpPr txBox="1"/>
+          <p:nvPr/>
+        </p:nvSpPr>
+        <p:spPr>
+          <a:xfrm>
+            <a:off x="914400" y="308610"/>
+            <a:ext cx="16459200" cy="1028700"/>
+          </a:xfrm>
+          <a:prstGeom prst="rect">
+            <a:avLst/>
+          </a:prstGeom>
+          <a:noFill/>
+        </p:spPr>
+        <p:txBody>
+          <a:bodyPr wrap="square">
+            <a:spAutoFit/>
+          </a:bodyPr>
+          <a:lstStyle/>
+          <a:p>
+            <a:pPr algn="ctr"/>
+            <a:r>
+              <a:rPr sz="2800" b="1" i="0">
+                <a:solidFill>
+                  <a:srgbClr val="C9A84C"/>
+                </a:solidFill>
+                <a:latin typeface="Calibri"/>
+              </a:rPr>
+              <a:t>كيف تُجسّد بوابتنا القانون؟</a:t>
+            </a:r>
+          </a:p>
+        </p:txBody>
+      </p:sp>
+      <p:sp>
+        <p:nvSpPr>
+          <p:cNvPr id="5" name="TextBox 4"/>
+          <p:cNvSpPr txBox="1"/>
+          <p:nvPr/>
+        </p:nvSpPr>
+        <p:spPr>
+          <a:xfrm>
+            <a:off x="914400" y="1285875"/>
+            <a:ext cx="16459200" cy="720090"/>
+          </a:xfrm>
+          <a:prstGeom prst="rect">
+            <a:avLst/>
+          </a:prstGeom>
+          <a:noFill/>
+        </p:spPr>
+        <p:txBody>
+          <a:bodyPr wrap="square">
+            <a:spAutoFit/>
+          </a:bodyPr>
+          <a:lstStyle/>
+          <a:p>
+            <a:pPr algn="ctr"/>
+            <a:r>
+              <a:rPr sz="1600" b="0" i="1">
+                <a:solidFill>
+                  <a:srgbClr val="D0D8E8"/>
+                </a:solidFill>
+                <a:latin typeface="Calibri"/>
+              </a:rPr>
+              <a:t>How Our Portal Implements the Law</a:t>
+            </a:r>
+          </a:p>
+        </p:txBody>
+      </p:sp>
+      <p:pic>
+        <p:nvPicPr>
+          <p:cNvPr id="6" name="Picture 5" descr="image.jpg"/>
+          <p:cNvPicPr>
+            <a:picLocks noChangeAspect="1"/>
+          </p:cNvPicPr>
+          <p:nvPr/>
+        </p:nvPicPr>
+        <p:blipFill>
+          <a:blip r:embed="rId2"/>
+          <a:stretch>
+            <a:fillRect/>
+          </a:stretch>
+        </p:blipFill>
+        <p:spPr>
+          <a:xfrm>
+            <a:off x="603504" y="2211705"/>
+            <a:ext cx="5285232" cy="4815344"/>
+          </a:xfrm>
+          <a:prstGeom prst="rect">
+            <a:avLst/>
+          </a:prstGeom>
+        </p:spPr>
+      </p:pic>
+      <p:sp>
+        <p:nvSpPr>
+          <p:cNvPr id="7" name="Rectangle 6"/>
           <p:cNvSpPr/>
           <p:nvPr/>
         </p:nvSpPr>
         <p:spPr>
           <a:xfrm>
-            <a:off x="0" y="73152"/>
-            <a:ext cx="18288000" cy="960120"/>
+            <a:off x="603504" y="5582446"/>
+            <a:ext cx="5285232" cy="1444603"/>
           </a:xfrm>
           <a:prstGeom prst="rect">
             <a:avLst/>
           </a:prstGeom>
           <a:solidFill>
-            <a:srgbClr val="0F1A30"/>
+            <a:srgbClr val="223860">
+              <a:alpha val="78000"/>
+            </a:srgbClr>
           </a:solidFill>
           <a:ln>
             <a:noFill/>
@@ -7353,84 +6720,57 @@
       </p:sp>
       <p:sp>
         <p:nvSpPr>
-          <p:cNvPr id="4" name="TextBox 3"/>
-          <p:cNvSpPr txBox="1"/>
+          <p:cNvPr id="8" name="Rectangle 7"/>
+          <p:cNvSpPr/>
           <p:nvPr/>
         </p:nvSpPr>
         <p:spPr>
           <a:xfrm>
-            <a:off x="274320" y="109728"/>
-            <a:ext cx="17739360" cy="548640"/>
+            <a:off x="603504" y="7027049"/>
+            <a:ext cx="5285232" cy="2951341"/>
           </a:xfrm>
           <a:prstGeom prst="rect">
             <a:avLst/>
           </a:prstGeom>
-          <a:noFill/>
+          <a:solidFill>
+            <a:srgbClr val="223860"/>
+          </a:solidFill>
+          <a:ln>
+            <a:noFill/>
+          </a:ln>
         </p:spPr>
-        <p:txBody>
-          <a:bodyPr wrap="square">
-            <a:spAutoFit/>
-          </a:bodyPr>
+        <p:style>
+          <a:lnRef idx="1">
+            <a:schemeClr val="accent1"/>
+          </a:lnRef>
+          <a:fillRef idx="3">
+            <a:schemeClr val="accent1"/>
+          </a:fillRef>
+          <a:effectRef idx="2">
+            <a:schemeClr val="accent1"/>
+          </a:effectRef>
+          <a:fontRef idx="minor">
+            <a:schemeClr val="lt1"/>
+          </a:fontRef>
+        </p:style>
+        <p:txBody>
+          <a:bodyPr rtlCol="0" anchor="ctr"/>
           <a:lstStyle/>
           <a:p>
             <a:pPr algn="ctr"/>
-            <a:r>
-              <a:rPr sz="2800" b="1">
-                <a:solidFill>
-                  <a:srgbClr val="C9A84C"/>
-                </a:solidFill>
-                <a:latin typeface="Arial"/>
-              </a:rPr>
-              <a:t>كيف تُجسّد بوابة الجود أحكام القانون؟</a:t>
-            </a:r>
-          </a:p>
-        </p:txBody>
-      </p:sp>
-      <p:sp>
-        <p:nvSpPr>
-          <p:cNvPr id="5" name="TextBox 4"/>
-          <p:cNvSpPr txBox="1"/>
+          </a:p>
+        </p:txBody>
+      </p:sp>
+      <p:sp>
+        <p:nvSpPr>
+          <p:cNvPr id="9" name="Rectangle 8"/>
+          <p:cNvSpPr/>
           <p:nvPr/>
         </p:nvSpPr>
         <p:spPr>
           <a:xfrm>
-            <a:off x="274320" y="658368"/>
-            <a:ext cx="17739360" cy="347472"/>
-          </a:xfrm>
-          <a:prstGeom prst="rect">
-            <a:avLst/>
-          </a:prstGeom>
-          <a:noFill/>
-        </p:spPr>
-        <p:txBody>
-          <a:bodyPr wrap="square">
-            <a:spAutoFit/>
-          </a:bodyPr>
-          <a:lstStyle/>
-          <a:p>
-            <a:pPr algn="ctr"/>
-            <a:r>
-              <a:rPr sz="1400" b="0">
-                <a:solidFill>
-                  <a:srgbClr val="FFFFFF"/>
-                </a:solidFill>
-                <a:latin typeface="Arial"/>
-              </a:rPr>
-              <a:t>Al Jood Portal — Compliance with Child Digital Safety Law</a:t>
-            </a:r>
-          </a:p>
-        </p:txBody>
-      </p:sp>
-      <p:sp>
-        <p:nvSpPr>
-          <p:cNvPr id="6" name="Rectangle 5"/>
-          <p:cNvSpPr/>
-          <p:nvPr/>
-        </p:nvSpPr>
-        <p:spPr>
-          <a:xfrm>
-            <a:off x="0" y="1033271"/>
-            <a:ext cx="18288000" cy="45720"/>
+            <a:off x="603504" y="7027049"/>
+            <a:ext cx="5285232" cy="72009"/>
           </a:xfrm>
           <a:prstGeom prst="rect">
             <a:avLst/>
@@ -7466,14 +6806,231 @@
       </p:sp>
       <p:sp>
         <p:nvSpPr>
-          <p:cNvPr id="7" name="Rectangle 6"/>
+          <p:cNvPr id="10" name="TextBox 9"/>
+          <p:cNvSpPr txBox="1"/>
+          <p:nvPr/>
+        </p:nvSpPr>
+        <p:spPr>
+          <a:xfrm>
+            <a:off x="786384" y="7181354"/>
+            <a:ext cx="4919472" cy="771525"/>
+          </a:xfrm>
+          <a:prstGeom prst="rect">
+            <a:avLst/>
+          </a:prstGeom>
+          <a:noFill/>
+        </p:spPr>
+        <p:txBody>
+          <a:bodyPr wrap="square">
+            <a:spAutoFit/>
+          </a:bodyPr>
+          <a:lstStyle/>
+          <a:p>
+            <a:pPr algn="ctr"/>
+            <a:r>
+              <a:rPr sz="1900" b="1" i="0">
+                <a:solidFill>
+                  <a:srgbClr val="C9A84C"/>
+                </a:solidFill>
+                <a:latin typeface="Calibri"/>
+              </a:rPr>
+              <a:t>حماية البيانات والخصوصية</a:t>
+            </a:r>
+          </a:p>
+        </p:txBody>
+      </p:sp>
+      <p:sp>
+        <p:nvSpPr>
+          <p:cNvPr id="11" name="TextBox 10"/>
+          <p:cNvSpPr txBox="1"/>
+          <p:nvPr/>
+        </p:nvSpPr>
+        <p:spPr>
+          <a:xfrm>
+            <a:off x="786384" y="7952879"/>
+            <a:ext cx="4919472" cy="565785"/>
+          </a:xfrm>
+          <a:prstGeom prst="rect">
+            <a:avLst/>
+          </a:prstGeom>
+          <a:noFill/>
+        </p:spPr>
+        <p:txBody>
+          <a:bodyPr wrap="square">
+            <a:spAutoFit/>
+          </a:bodyPr>
+          <a:lstStyle/>
+          <a:p>
+            <a:pPr algn="ctr"/>
+            <a:r>
+              <a:rPr sz="1300" b="0" i="1">
+                <a:solidFill>
+                  <a:srgbClr val="D0D8E8"/>
+                </a:solidFill>
+                <a:latin typeface="Calibri"/>
+              </a:rPr>
+              <a:t>Data Privacy &amp; Protection</a:t>
+            </a:r>
+          </a:p>
+        </p:txBody>
+      </p:sp>
+      <p:sp>
+        <p:nvSpPr>
+          <p:cNvPr id="12" name="TextBox 11"/>
+          <p:cNvSpPr txBox="1"/>
+          <p:nvPr/>
+        </p:nvSpPr>
+        <p:spPr>
+          <a:xfrm>
+            <a:off x="786384" y="8518664"/>
+            <a:ext cx="4919472" cy="874395"/>
+          </a:xfrm>
+          <a:prstGeom prst="rect">
+            <a:avLst/>
+          </a:prstGeom>
+          <a:noFill/>
+        </p:spPr>
+        <p:txBody>
+          <a:bodyPr wrap="square">
+            <a:spAutoFit/>
+          </a:bodyPr>
+          <a:lstStyle/>
+          <a:p>
+            <a:pPr algn="ctr"/>
+            <a:r>
+              <a:rPr sz="1400" b="0" i="0">
+                <a:solidFill>
+                  <a:srgbClr val="FFFFFF"/>
+                </a:solidFill>
+                <a:latin typeface="Calibri"/>
+              </a:rPr>
+              <a:t>صلاحيات وكلمات مرور مخصصة لكل دور</a:t>
+            </a:r>
+          </a:p>
+        </p:txBody>
+      </p:sp>
+      <p:pic>
+        <p:nvPicPr>
+          <p:cNvPr id="13" name="Picture 12" descr="image.jpg"/>
+          <p:cNvPicPr>
+            <a:picLocks noChangeAspect="1"/>
+          </p:cNvPicPr>
+          <p:nvPr/>
+        </p:nvPicPr>
+        <p:blipFill>
+          <a:blip r:embed="rId3"/>
+          <a:stretch>
+            <a:fillRect/>
+          </a:stretch>
+        </p:blipFill>
+        <p:spPr>
+          <a:xfrm>
+            <a:off x="6291072" y="2211705"/>
+            <a:ext cx="5285232" cy="4815344"/>
+          </a:xfrm>
+          <a:prstGeom prst="rect">
+            <a:avLst/>
+          </a:prstGeom>
+        </p:spPr>
+      </p:pic>
+      <p:sp>
+        <p:nvSpPr>
+          <p:cNvPr id="14" name="Rectangle 13"/>
           <p:cNvSpPr/>
           <p:nvPr/>
         </p:nvSpPr>
         <p:spPr>
           <a:xfrm>
-            <a:off x="457200" y="1234440"/>
-            <a:ext cx="6601968" cy="594360"/>
+            <a:off x="6291072" y="5582446"/>
+            <a:ext cx="5285232" cy="1444603"/>
+          </a:xfrm>
+          <a:prstGeom prst="rect">
+            <a:avLst/>
+          </a:prstGeom>
+          <a:solidFill>
+            <a:srgbClr val="223860">
+              <a:alpha val="78000"/>
+            </a:srgbClr>
+          </a:solidFill>
+          <a:ln>
+            <a:noFill/>
+          </a:ln>
+        </p:spPr>
+        <p:style>
+          <a:lnRef idx="1">
+            <a:schemeClr val="accent1"/>
+          </a:lnRef>
+          <a:fillRef idx="3">
+            <a:schemeClr val="accent1"/>
+          </a:fillRef>
+          <a:effectRef idx="2">
+            <a:schemeClr val="accent1"/>
+          </a:effectRef>
+          <a:fontRef idx="minor">
+            <a:schemeClr val="lt1"/>
+          </a:fontRef>
+        </p:style>
+        <p:txBody>
+          <a:bodyPr rtlCol="0" anchor="ctr"/>
+          <a:lstStyle/>
+          <a:p>
+            <a:pPr algn="ctr"/>
+          </a:p>
+        </p:txBody>
+      </p:sp>
+      <p:sp>
+        <p:nvSpPr>
+          <p:cNvPr id="15" name="Rectangle 14"/>
+          <p:cNvSpPr/>
+          <p:nvPr/>
+        </p:nvSpPr>
+        <p:spPr>
+          <a:xfrm>
+            <a:off x="6291072" y="7027049"/>
+            <a:ext cx="5285232" cy="2951341"/>
+          </a:xfrm>
+          <a:prstGeom prst="rect">
+            <a:avLst/>
+          </a:prstGeom>
+          <a:solidFill>
+            <a:srgbClr val="223860"/>
+          </a:solidFill>
+          <a:ln>
+            <a:noFill/>
+          </a:ln>
+        </p:spPr>
+        <p:style>
+          <a:lnRef idx="1">
+            <a:schemeClr val="accent1"/>
+          </a:lnRef>
+          <a:fillRef idx="3">
+            <a:schemeClr val="accent1"/>
+          </a:fillRef>
+          <a:effectRef idx="2">
+            <a:schemeClr val="accent1"/>
+          </a:effectRef>
+          <a:fontRef idx="minor">
+            <a:schemeClr val="lt1"/>
+          </a:fontRef>
+        </p:style>
+        <p:txBody>
+          <a:bodyPr rtlCol="0" anchor="ctr"/>
+          <a:lstStyle/>
+          <a:p>
+            <a:pPr algn="ctr"/>
+          </a:p>
+        </p:txBody>
+      </p:sp>
+      <p:sp>
+        <p:nvSpPr>
+          <p:cNvPr id="16" name="Rectangle 15"/>
+          <p:cNvSpPr/>
+          <p:nvPr/>
+        </p:nvSpPr>
+        <p:spPr>
+          <a:xfrm>
+            <a:off x="6291072" y="7027049"/>
+            <a:ext cx="5285232" cy="72009"/>
           </a:xfrm>
           <a:prstGeom prst="rect">
             <a:avLst/>
@@ -7509,14 +7066,14 @@
       </p:sp>
       <p:sp>
         <p:nvSpPr>
-          <p:cNvPr id="8" name="TextBox 7"/>
+          <p:cNvPr id="17" name="TextBox 16"/>
           <p:cNvSpPr txBox="1"/>
           <p:nvPr/>
         </p:nvSpPr>
         <p:spPr>
           <a:xfrm>
-            <a:off x="457200" y="1234440"/>
-            <a:ext cx="6601968" cy="594360"/>
+            <a:off x="6473952" y="7181354"/>
+            <a:ext cx="4919472" cy="771525"/>
           </a:xfrm>
           <a:prstGeom prst="rect">
             <a:avLst/>
@@ -7531,38 +7088,132 @@
           <a:p>
             <a:pPr algn="ctr"/>
             <a:r>
-              <a:rPr sz="1800" b="1">
+              <a:rPr sz="1900" b="1" i="0">
                 <a:solidFill>
-                  <a:srgbClr val="1A2A4A"/>
+                  <a:srgbClr val="C9A84C"/>
                 </a:solidFill>
-                <a:latin typeface="Arial"/>
+                <a:latin typeface="Calibri"/>
               </a:rPr>
-              <a:t>متطلب القانون</a:t>
+              <a:t>رقابة أولياء الأمور</a:t>
             </a:r>
           </a:p>
         </p:txBody>
       </p:sp>
       <p:sp>
         <p:nvSpPr>
-          <p:cNvPr id="9" name="Rectangle 8"/>
+          <p:cNvPr id="18" name="TextBox 17"/>
+          <p:cNvSpPr txBox="1"/>
+          <p:nvPr/>
+        </p:nvSpPr>
+        <p:spPr>
+          <a:xfrm>
+            <a:off x="6473952" y="7952879"/>
+            <a:ext cx="4919472" cy="565785"/>
+          </a:xfrm>
+          <a:prstGeom prst="rect">
+            <a:avLst/>
+          </a:prstGeom>
+          <a:noFill/>
+        </p:spPr>
+        <p:txBody>
+          <a:bodyPr wrap="square">
+            <a:spAutoFit/>
+          </a:bodyPr>
+          <a:lstStyle/>
+          <a:p>
+            <a:pPr algn="ctr"/>
+            <a:r>
+              <a:rPr sz="1300" b="0" i="1">
+                <a:solidFill>
+                  <a:srgbClr val="D0D8E8"/>
+                </a:solidFill>
+                <a:latin typeface="Calibri"/>
+              </a:rPr>
+              <a:t>Parent Monitoring Portal</a:t>
+            </a:r>
+          </a:p>
+        </p:txBody>
+      </p:sp>
+      <p:sp>
+        <p:nvSpPr>
+          <p:cNvPr id="19" name="TextBox 18"/>
+          <p:cNvSpPr txBox="1"/>
+          <p:nvPr/>
+        </p:nvSpPr>
+        <p:spPr>
+          <a:xfrm>
+            <a:off x="6473952" y="8518664"/>
+            <a:ext cx="4919472" cy="874395"/>
+          </a:xfrm>
+          <a:prstGeom prst="rect">
+            <a:avLst/>
+          </a:prstGeom>
+          <a:noFill/>
+        </p:spPr>
+        <p:txBody>
+          <a:bodyPr wrap="square">
+            <a:spAutoFit/>
+          </a:bodyPr>
+          <a:lstStyle/>
+          <a:p>
+            <a:pPr algn="ctr"/>
+            <a:r>
+              <a:rPr sz="1400" b="0" i="0">
+                <a:solidFill>
+                  <a:srgbClr val="FFFFFF"/>
+                </a:solidFill>
+                <a:latin typeface="Calibri"/>
+              </a:rPr>
+              <a:t>متابعة الأداء الأكاديمي للأبناء</a:t>
+            </a:r>
+          </a:p>
+        </p:txBody>
+      </p:sp>
+      <p:pic>
+        <p:nvPicPr>
+          <p:cNvPr id="20" name="Picture 19" descr="image.jpg"/>
+          <p:cNvPicPr>
+            <a:picLocks noChangeAspect="1"/>
+          </p:cNvPicPr>
+          <p:nvPr/>
+        </p:nvPicPr>
+        <p:blipFill>
+          <a:blip r:embed="rId4"/>
+          <a:stretch>
+            <a:fillRect/>
+          </a:stretch>
+        </p:blipFill>
+        <p:spPr>
+          <a:xfrm>
+            <a:off x="11978640" y="2211705"/>
+            <a:ext cx="5285232" cy="4815344"/>
+          </a:xfrm>
+          <a:prstGeom prst="rect">
+            <a:avLst/>
+          </a:prstGeom>
+        </p:spPr>
+      </p:pic>
+      <p:sp>
+        <p:nvSpPr>
+          <p:cNvPr id="21" name="Rectangle 20"/>
           <p:cNvSpPr/>
           <p:nvPr/>
         </p:nvSpPr>
         <p:spPr>
           <a:xfrm>
-            <a:off x="7059168" y="1234440"/>
-            <a:ext cx="10771632" cy="594360"/>
+            <a:off x="11978640" y="5582446"/>
+            <a:ext cx="5285232" cy="1444603"/>
           </a:xfrm>
           <a:prstGeom prst="rect">
             <a:avLst/>
           </a:prstGeom>
           <a:solidFill>
-            <a:srgbClr val="22355E"/>
+            <a:srgbClr val="223860">
+              <a:alpha val="78000"/>
+            </a:srgbClr>
           </a:solidFill>
-          <a:ln w="19050">
-            <a:solidFill>
-              <a:srgbClr val="C9A84C"/>
-            </a:solidFill>
+          <a:ln>
+            <a:noFill/>
           </a:ln>
         </p:spPr>
         <p:style>
@@ -7589,60 +7240,23 @@
       </p:sp>
       <p:sp>
         <p:nvSpPr>
-          <p:cNvPr id="10" name="TextBox 9"/>
-          <p:cNvSpPr txBox="1"/>
+          <p:cNvPr id="22" name="Rectangle 21"/>
+          <p:cNvSpPr/>
           <p:nvPr/>
         </p:nvSpPr>
         <p:spPr>
           <a:xfrm>
-            <a:off x="7059168" y="1234440"/>
-            <a:ext cx="10771632" cy="594360"/>
-          </a:xfrm>
-          <a:prstGeom prst="rect">
-            <a:avLst/>
-          </a:prstGeom>
-          <a:noFill/>
-        </p:spPr>
-        <p:txBody>
-          <a:bodyPr wrap="square">
-            <a:spAutoFit/>
-          </a:bodyPr>
-          <a:lstStyle/>
-          <a:p>
-            <a:pPr algn="ctr"/>
-            <a:r>
-              <a:rPr sz="1800" b="1">
-                <a:solidFill>
-                  <a:srgbClr val="C9A84C"/>
-                </a:solidFill>
-                <a:latin typeface="Arial"/>
-              </a:rPr>
-              <a:t>ميزة بوابة مدرسة الجود</a:t>
-            </a:r>
-          </a:p>
-        </p:txBody>
-      </p:sp>
-      <p:sp>
-        <p:nvSpPr>
-          <p:cNvPr id="11" name="Rectangle 10"/>
-          <p:cNvSpPr/>
-          <p:nvPr/>
-        </p:nvSpPr>
-        <p:spPr>
-          <a:xfrm>
-            <a:off x="457200" y="1828800"/>
-            <a:ext cx="6601968" cy="804672"/>
+            <a:off x="11978640" y="7027049"/>
+            <a:ext cx="5285232" cy="2951341"/>
           </a:xfrm>
           <a:prstGeom prst="rect">
             <a:avLst/>
           </a:prstGeom>
           <a:solidFill>
-            <a:srgbClr val="1A2A4A"/>
+            <a:srgbClr val="223860"/>
           </a:solidFill>
-          <a:ln w="6350">
-            <a:solidFill>
-              <a:srgbClr val="C9A84C"/>
-            </a:solidFill>
+          <a:ln>
+            <a:noFill/>
           </a:ln>
         </p:spPr>
         <p:style>
@@ -7669,14 +7283,14 @@
       </p:sp>
       <p:sp>
         <p:nvSpPr>
-          <p:cNvPr id="12" name="Rectangle 11"/>
+          <p:cNvPr id="23" name="Rectangle 22"/>
           <p:cNvSpPr/>
           <p:nvPr/>
         </p:nvSpPr>
         <p:spPr>
           <a:xfrm>
-            <a:off x="457200" y="1828800"/>
-            <a:ext cx="82296" cy="804672"/>
+            <a:off x="11978640" y="7027049"/>
+            <a:ext cx="5285232" cy="72009"/>
           </a:xfrm>
           <a:prstGeom prst="rect">
             <a:avLst/>
@@ -7712,14 +7326,14 @@
       </p:sp>
       <p:sp>
         <p:nvSpPr>
-          <p:cNvPr id="13" name="TextBox 12"/>
+          <p:cNvPr id="24" name="TextBox 23"/>
           <p:cNvSpPr txBox="1"/>
           <p:nvPr/>
         </p:nvSpPr>
         <p:spPr>
           <a:xfrm>
-            <a:off x="594360" y="1901952"/>
-            <a:ext cx="6419088" cy="658368"/>
+            <a:off x="12161520" y="7181354"/>
+            <a:ext cx="4919472" cy="771525"/>
           </a:xfrm>
           <a:prstGeom prst="rect">
             <a:avLst/>
@@ -7734,72 +7348,27 @@
           <a:p>
             <a:pPr algn="ctr"/>
             <a:r>
-              <a:rPr sz="1600" b="1">
+              <a:rPr sz="1900" b="1" i="0">
                 <a:solidFill>
-                  <a:srgbClr val="FFFFFF"/>
+                  <a:srgbClr val="C9A84C"/>
                 </a:solidFill>
-                <a:latin typeface="Arial"/>
+                <a:latin typeface="Calibri"/>
               </a:rPr>
-              <a:t>حماية البيانات الرقمية</a:t>
+              <a:t>شفافية أكاديمية فورية</a:t>
             </a:r>
           </a:p>
         </p:txBody>
       </p:sp>
       <p:sp>
         <p:nvSpPr>
-          <p:cNvPr id="14" name="Rectangle 13"/>
-          <p:cNvSpPr/>
+          <p:cNvPr id="25" name="TextBox 24"/>
+          <p:cNvSpPr txBox="1"/>
           <p:nvPr/>
         </p:nvSpPr>
         <p:spPr>
           <a:xfrm>
-            <a:off x="7059168" y="1828800"/>
-            <a:ext cx="10771632" cy="804672"/>
-          </a:xfrm>
-          <a:prstGeom prst="rect">
-            <a:avLst/>
-          </a:prstGeom>
-          <a:solidFill>
-            <a:srgbClr val="1A2A4A"/>
-          </a:solidFill>
-          <a:ln w="6350">
-            <a:solidFill>
-              <a:srgbClr val="C9A84C"/>
-            </a:solidFill>
-          </a:ln>
-        </p:spPr>
-        <p:style>
-          <a:lnRef idx="1">
-            <a:schemeClr val="accent1"/>
-          </a:lnRef>
-          <a:fillRef idx="3">
-            <a:schemeClr val="accent1"/>
-          </a:fillRef>
-          <a:effectRef idx="2">
-            <a:schemeClr val="accent1"/>
-          </a:effectRef>
-          <a:fontRef idx="minor">
-            <a:schemeClr val="lt1"/>
-          </a:fontRef>
-        </p:style>
-        <p:txBody>
-          <a:bodyPr rtlCol="0" anchor="ctr"/>
-          <a:lstStyle/>
-          <a:p>
-            <a:pPr algn="ctr"/>
-          </a:p>
-        </p:txBody>
-      </p:sp>
-      <p:sp>
-        <p:nvSpPr>
-          <p:cNvPr id="15" name="TextBox 14"/>
-          <p:cNvSpPr txBox="1"/>
-          <p:nvPr/>
-        </p:nvSpPr>
-        <p:spPr>
-          <a:xfrm>
-            <a:off x="7242048" y="1901952"/>
-            <a:ext cx="10497312" cy="658368"/>
+            <a:off x="12161520" y="7952879"/>
+            <a:ext cx="4919472" cy="565785"/>
           </a:xfrm>
           <a:prstGeom prst="rect">
             <a:avLst/>
@@ -7812,74 +7381,64 @@
           </a:bodyPr>
           <a:lstStyle/>
           <a:p>
-            <a:pPr algn="r"/>
+            <a:pPr algn="ctr"/>
             <a:r>
-              <a:rPr sz="1500" b="0">
+              <a:rPr sz="1300" b="0" i="1">
+                <a:solidFill>
+                  <a:srgbClr val="D0D8E8"/>
+                </a:solidFill>
+                <a:latin typeface="Calibri"/>
+              </a:rPr>
+              <a:t>Instant Academic Transparency</a:t>
+            </a:r>
+          </a:p>
+        </p:txBody>
+      </p:sp>
+      <p:sp>
+        <p:nvSpPr>
+          <p:cNvPr id="26" name="TextBox 25"/>
+          <p:cNvSpPr txBox="1"/>
+          <p:nvPr/>
+        </p:nvSpPr>
+        <p:spPr>
+          <a:xfrm>
+            <a:off x="12161520" y="8518664"/>
+            <a:ext cx="4919472" cy="874395"/>
+          </a:xfrm>
+          <a:prstGeom prst="rect">
+            <a:avLst/>
+          </a:prstGeom>
+          <a:noFill/>
+        </p:spPr>
+        <p:txBody>
+          <a:bodyPr wrap="square">
+            <a:spAutoFit/>
+          </a:bodyPr>
+          <a:lstStyle/>
+          <a:p>
+            <a:pPr algn="ctr"/>
+            <a:r>
+              <a:rPr sz="1400" b="0" i="0">
                 <a:solidFill>
                   <a:srgbClr val="FFFFFF"/>
                 </a:solidFill>
-                <a:latin typeface="Arial"/>
+                <a:latin typeface="Calibri"/>
               </a:rPr>
-              <a:t>✓  بيانات محلية فقط — لا سحابة خارجية — localStorage آمن 100%</a:t>
+              <a:t>تقارير وتحليلات في الوقت الفعلي</a:t>
             </a:r>
           </a:p>
         </p:txBody>
       </p:sp>
       <p:sp>
         <p:nvSpPr>
-          <p:cNvPr id="16" name="Rectangle 15"/>
+          <p:cNvPr id="27" name="Rectangle 26"/>
           <p:cNvSpPr/>
           <p:nvPr/>
         </p:nvSpPr>
         <p:spPr>
           <a:xfrm>
-            <a:off x="457200" y="2633472"/>
-            <a:ext cx="6601968" cy="804672"/>
-          </a:xfrm>
-          <a:prstGeom prst="rect">
-            <a:avLst/>
-          </a:prstGeom>
-          <a:solidFill>
-            <a:srgbClr val="22355E"/>
-          </a:solidFill>
-          <a:ln w="6350">
-            <a:solidFill>
-              <a:srgbClr val="C9A84C"/>
-            </a:solidFill>
-          </a:ln>
-        </p:spPr>
-        <p:style>
-          <a:lnRef idx="1">
-            <a:schemeClr val="accent1"/>
-          </a:lnRef>
-          <a:fillRef idx="3">
-            <a:schemeClr val="accent1"/>
-          </a:fillRef>
-          <a:effectRef idx="2">
-            <a:schemeClr val="accent1"/>
-          </a:effectRef>
-          <a:fontRef idx="minor">
-            <a:schemeClr val="lt1"/>
-          </a:fontRef>
-        </p:style>
-        <p:txBody>
-          <a:bodyPr rtlCol="0" anchor="ctr"/>
-          <a:lstStyle/>
-          <a:p>
-            <a:pPr algn="ctr"/>
-          </a:p>
-        </p:txBody>
-      </p:sp>
-      <p:sp>
-        <p:nvSpPr>
-          <p:cNvPr id="17" name="Rectangle 16"/>
-          <p:cNvSpPr/>
-          <p:nvPr/>
-        </p:nvSpPr>
-        <p:spPr>
-          <a:xfrm>
-            <a:off x="457200" y="2633472"/>
-            <a:ext cx="82296" cy="804672"/>
+            <a:off x="0" y="9854946"/>
+            <a:ext cx="18288000" cy="92583"/>
           </a:xfrm>
           <a:prstGeom prst="rect">
             <a:avLst/>
@@ -7915,14 +7474,14 @@
       </p:sp>
       <p:sp>
         <p:nvSpPr>
-          <p:cNvPr id="18" name="TextBox 17"/>
+          <p:cNvPr id="28" name="TextBox 27"/>
           <p:cNvSpPr txBox="1"/>
           <p:nvPr/>
         </p:nvSpPr>
         <p:spPr>
           <a:xfrm>
-            <a:off x="594360" y="2706624"/>
-            <a:ext cx="6419088" cy="658368"/>
+            <a:off x="914400" y="9947529"/>
+            <a:ext cx="16459200" cy="411480"/>
           </a:xfrm>
           <a:prstGeom prst="rect">
             <a:avLst/>
@@ -7937,1164 +7496,13 @@
           <a:p>
             <a:pPr algn="ctr"/>
             <a:r>
-              <a:rPr sz="1600" b="1">
-                <a:solidFill>
-                  <a:srgbClr val="FFFFFF"/>
-                </a:solidFill>
-                <a:latin typeface="Arial"/>
-              </a:rPr>
-              <a:t>توثيق هوية المستخدمين</a:t>
-            </a:r>
-          </a:p>
-        </p:txBody>
-      </p:sp>
-      <p:sp>
-        <p:nvSpPr>
-          <p:cNvPr id="19" name="Rectangle 18"/>
-          <p:cNvSpPr/>
-          <p:nvPr/>
-        </p:nvSpPr>
-        <p:spPr>
-          <a:xfrm>
-            <a:off x="7059168" y="2633472"/>
-            <a:ext cx="10771632" cy="804672"/>
-          </a:xfrm>
-          <a:prstGeom prst="rect">
-            <a:avLst/>
-          </a:prstGeom>
-          <a:solidFill>
-            <a:srgbClr val="22355E"/>
-          </a:solidFill>
-          <a:ln w="6350">
-            <a:solidFill>
-              <a:srgbClr val="C9A84C"/>
-            </a:solidFill>
-          </a:ln>
-        </p:spPr>
-        <p:style>
-          <a:lnRef idx="1">
-            <a:schemeClr val="accent1"/>
-          </a:lnRef>
-          <a:fillRef idx="3">
-            <a:schemeClr val="accent1"/>
-          </a:fillRef>
-          <a:effectRef idx="2">
-            <a:schemeClr val="accent1"/>
-          </a:effectRef>
-          <a:fontRef idx="minor">
-            <a:schemeClr val="lt1"/>
-          </a:fontRef>
-        </p:style>
-        <p:txBody>
-          <a:bodyPr rtlCol="0" anchor="ctr"/>
-          <a:lstStyle/>
-          <a:p>
-            <a:pPr algn="ctr"/>
-          </a:p>
-        </p:txBody>
-      </p:sp>
-      <p:sp>
-        <p:nvSpPr>
-          <p:cNvPr id="20" name="TextBox 19"/>
-          <p:cNvSpPr txBox="1"/>
-          <p:nvPr/>
-        </p:nvSpPr>
-        <p:spPr>
-          <a:xfrm>
-            <a:off x="7242048" y="2706624"/>
-            <a:ext cx="10497312" cy="658368"/>
-          </a:xfrm>
-          <a:prstGeom prst="rect">
-            <a:avLst/>
-          </a:prstGeom>
-          <a:noFill/>
-        </p:spPr>
-        <p:txBody>
-          <a:bodyPr wrap="square">
-            <a:spAutoFit/>
-          </a:bodyPr>
-          <a:lstStyle/>
-          <a:p>
-            <a:pPr algn="r"/>
-            <a:r>
-              <a:rPr sz="1500" b="0">
-                <a:solidFill>
-                  <a:srgbClr val="FFFFFF"/>
-                </a:solidFill>
-                <a:latin typeface="Arial"/>
-              </a:rPr>
-              <a:t>✓  5 أدوار مستقلة: مدير، مديرة، معلم، إداري، ولي أمر</a:t>
-            </a:r>
-          </a:p>
-        </p:txBody>
-      </p:sp>
-      <p:sp>
-        <p:nvSpPr>
-          <p:cNvPr id="21" name="Rectangle 20"/>
-          <p:cNvSpPr/>
-          <p:nvPr/>
-        </p:nvSpPr>
-        <p:spPr>
-          <a:xfrm>
-            <a:off x="457200" y="3438144"/>
-            <a:ext cx="6601968" cy="804672"/>
-          </a:xfrm>
-          <a:prstGeom prst="rect">
-            <a:avLst/>
-          </a:prstGeom>
-          <a:solidFill>
-            <a:srgbClr val="1A2A4A"/>
-          </a:solidFill>
-          <a:ln w="6350">
-            <a:solidFill>
-              <a:srgbClr val="C9A84C"/>
-            </a:solidFill>
-          </a:ln>
-        </p:spPr>
-        <p:style>
-          <a:lnRef idx="1">
-            <a:schemeClr val="accent1"/>
-          </a:lnRef>
-          <a:fillRef idx="3">
-            <a:schemeClr val="accent1"/>
-          </a:fillRef>
-          <a:effectRef idx="2">
-            <a:schemeClr val="accent1"/>
-          </a:effectRef>
-          <a:fontRef idx="minor">
-            <a:schemeClr val="lt1"/>
-          </a:fontRef>
-        </p:style>
-        <p:txBody>
-          <a:bodyPr rtlCol="0" anchor="ctr"/>
-          <a:lstStyle/>
-          <a:p>
-            <a:pPr algn="ctr"/>
-          </a:p>
-        </p:txBody>
-      </p:sp>
-      <p:sp>
-        <p:nvSpPr>
-          <p:cNvPr id="22" name="Rectangle 21"/>
-          <p:cNvSpPr/>
-          <p:nvPr/>
-        </p:nvSpPr>
-        <p:spPr>
-          <a:xfrm>
-            <a:off x="457200" y="3438144"/>
-            <a:ext cx="82296" cy="804672"/>
-          </a:xfrm>
-          <a:prstGeom prst="rect">
-            <a:avLst/>
-          </a:prstGeom>
-          <a:solidFill>
-            <a:srgbClr val="C9A84C"/>
-          </a:solidFill>
-          <a:ln>
-            <a:noFill/>
-          </a:ln>
-        </p:spPr>
-        <p:style>
-          <a:lnRef idx="1">
-            <a:schemeClr val="accent1"/>
-          </a:lnRef>
-          <a:fillRef idx="3">
-            <a:schemeClr val="accent1"/>
-          </a:fillRef>
-          <a:effectRef idx="2">
-            <a:schemeClr val="accent1"/>
-          </a:effectRef>
-          <a:fontRef idx="minor">
-            <a:schemeClr val="lt1"/>
-          </a:fontRef>
-        </p:style>
-        <p:txBody>
-          <a:bodyPr rtlCol="0" anchor="ctr"/>
-          <a:lstStyle/>
-          <a:p>
-            <a:pPr algn="ctr"/>
-          </a:p>
-        </p:txBody>
-      </p:sp>
-      <p:sp>
-        <p:nvSpPr>
-          <p:cNvPr id="23" name="TextBox 22"/>
-          <p:cNvSpPr txBox="1"/>
-          <p:nvPr/>
-        </p:nvSpPr>
-        <p:spPr>
-          <a:xfrm>
-            <a:off x="594360" y="3511296"/>
-            <a:ext cx="6419088" cy="658368"/>
-          </a:xfrm>
-          <a:prstGeom prst="rect">
-            <a:avLst/>
-          </a:prstGeom>
-          <a:noFill/>
-        </p:spPr>
-        <p:txBody>
-          <a:bodyPr wrap="square">
-            <a:spAutoFit/>
-          </a:bodyPr>
-          <a:lstStyle/>
-          <a:p>
-            <a:pPr algn="ctr"/>
-            <a:r>
-              <a:rPr sz="1600" b="1">
-                <a:solidFill>
-                  <a:srgbClr val="FFFFFF"/>
-                </a:solidFill>
-                <a:latin typeface="Arial"/>
-              </a:rPr>
-              <a:t>رقابة أولياء الأمور</a:t>
-            </a:r>
-          </a:p>
-        </p:txBody>
-      </p:sp>
-      <p:sp>
-        <p:nvSpPr>
-          <p:cNvPr id="24" name="Rectangle 23"/>
-          <p:cNvSpPr/>
-          <p:nvPr/>
-        </p:nvSpPr>
-        <p:spPr>
-          <a:xfrm>
-            <a:off x="7059168" y="3438144"/>
-            <a:ext cx="10771632" cy="804672"/>
-          </a:xfrm>
-          <a:prstGeom prst="rect">
-            <a:avLst/>
-          </a:prstGeom>
-          <a:solidFill>
-            <a:srgbClr val="1A2A4A"/>
-          </a:solidFill>
-          <a:ln w="6350">
-            <a:solidFill>
-              <a:srgbClr val="C9A84C"/>
-            </a:solidFill>
-          </a:ln>
-        </p:spPr>
-        <p:style>
-          <a:lnRef idx="1">
-            <a:schemeClr val="accent1"/>
-          </a:lnRef>
-          <a:fillRef idx="3">
-            <a:schemeClr val="accent1"/>
-          </a:fillRef>
-          <a:effectRef idx="2">
-            <a:schemeClr val="accent1"/>
-          </a:effectRef>
-          <a:fontRef idx="minor">
-            <a:schemeClr val="lt1"/>
-          </a:fontRef>
-        </p:style>
-        <p:txBody>
-          <a:bodyPr rtlCol="0" anchor="ctr"/>
-          <a:lstStyle/>
-          <a:p>
-            <a:pPr algn="ctr"/>
-          </a:p>
-        </p:txBody>
-      </p:sp>
-      <p:sp>
-        <p:nvSpPr>
-          <p:cNvPr id="25" name="TextBox 24"/>
-          <p:cNvSpPr txBox="1"/>
-          <p:nvPr/>
-        </p:nvSpPr>
-        <p:spPr>
-          <a:xfrm>
-            <a:off x="7242048" y="3511296"/>
-            <a:ext cx="10497312" cy="658368"/>
-          </a:xfrm>
-          <a:prstGeom prst="rect">
-            <a:avLst/>
-          </a:prstGeom>
-          <a:noFill/>
-        </p:spPr>
-        <p:txBody>
-          <a:bodyPr wrap="square">
-            <a:spAutoFit/>
-          </a:bodyPr>
-          <a:lstStyle/>
-          <a:p>
-            <a:pPr algn="r"/>
-            <a:r>
-              <a:rPr sz="1500" b="0">
-                <a:solidFill>
-                  <a:srgbClr val="FFFFFF"/>
-                </a:solidFill>
-                <a:latin typeface="Arial"/>
-              </a:rPr>
-              <a:t>✓  بوابة ولي الأمر — تطوير قريب مع بيانات الطلاب الكاملة</a:t>
-            </a:r>
-          </a:p>
-        </p:txBody>
-      </p:sp>
-      <p:sp>
-        <p:nvSpPr>
-          <p:cNvPr id="26" name="Rectangle 25"/>
-          <p:cNvSpPr/>
-          <p:nvPr/>
-        </p:nvSpPr>
-        <p:spPr>
-          <a:xfrm>
-            <a:off x="457200" y="4242816"/>
-            <a:ext cx="6601968" cy="804672"/>
-          </a:xfrm>
-          <a:prstGeom prst="rect">
-            <a:avLst/>
-          </a:prstGeom>
-          <a:solidFill>
-            <a:srgbClr val="22355E"/>
-          </a:solidFill>
-          <a:ln w="6350">
-            <a:solidFill>
-              <a:srgbClr val="C9A84C"/>
-            </a:solidFill>
-          </a:ln>
-        </p:spPr>
-        <p:style>
-          <a:lnRef idx="1">
-            <a:schemeClr val="accent1"/>
-          </a:lnRef>
-          <a:fillRef idx="3">
-            <a:schemeClr val="accent1"/>
-          </a:fillRef>
-          <a:effectRef idx="2">
-            <a:schemeClr val="accent1"/>
-          </a:effectRef>
-          <a:fontRef idx="minor">
-            <a:schemeClr val="lt1"/>
-          </a:fontRef>
-        </p:style>
-        <p:txBody>
-          <a:bodyPr rtlCol="0" anchor="ctr"/>
-          <a:lstStyle/>
-          <a:p>
-            <a:pPr algn="ctr"/>
-          </a:p>
-        </p:txBody>
-      </p:sp>
-      <p:sp>
-        <p:nvSpPr>
-          <p:cNvPr id="27" name="Rectangle 26"/>
-          <p:cNvSpPr/>
-          <p:nvPr/>
-        </p:nvSpPr>
-        <p:spPr>
-          <a:xfrm>
-            <a:off x="457200" y="4242816"/>
-            <a:ext cx="82296" cy="804672"/>
-          </a:xfrm>
-          <a:prstGeom prst="rect">
-            <a:avLst/>
-          </a:prstGeom>
-          <a:solidFill>
-            <a:srgbClr val="C9A84C"/>
-          </a:solidFill>
-          <a:ln>
-            <a:noFill/>
-          </a:ln>
-        </p:spPr>
-        <p:style>
-          <a:lnRef idx="1">
-            <a:schemeClr val="accent1"/>
-          </a:lnRef>
-          <a:fillRef idx="3">
-            <a:schemeClr val="accent1"/>
-          </a:fillRef>
-          <a:effectRef idx="2">
-            <a:schemeClr val="accent1"/>
-          </a:effectRef>
-          <a:fontRef idx="minor">
-            <a:schemeClr val="lt1"/>
-          </a:fontRef>
-        </p:style>
-        <p:txBody>
-          <a:bodyPr rtlCol="0" anchor="ctr"/>
-          <a:lstStyle/>
-          <a:p>
-            <a:pPr algn="ctr"/>
-          </a:p>
-        </p:txBody>
-      </p:sp>
-      <p:sp>
-        <p:nvSpPr>
-          <p:cNvPr id="28" name="TextBox 27"/>
-          <p:cNvSpPr txBox="1"/>
-          <p:nvPr/>
-        </p:nvSpPr>
-        <p:spPr>
-          <a:xfrm>
-            <a:off x="594360" y="4315968"/>
-            <a:ext cx="6419088" cy="658368"/>
-          </a:xfrm>
-          <a:prstGeom prst="rect">
-            <a:avLst/>
-          </a:prstGeom>
-          <a:noFill/>
-        </p:spPr>
-        <p:txBody>
-          <a:bodyPr wrap="square">
-            <a:spAutoFit/>
-          </a:bodyPr>
-          <a:lstStyle/>
-          <a:p>
-            <a:pPr algn="ctr"/>
-            <a:r>
-              <a:rPr sz="1600" b="1">
-                <a:solidFill>
-                  <a:srgbClr val="FFFFFF"/>
-                </a:solidFill>
-                <a:latin typeface="Arial"/>
-              </a:rPr>
-              <a:t>الإبلاغ عن الاختراقات</a:t>
-            </a:r>
-          </a:p>
-        </p:txBody>
-      </p:sp>
-      <p:sp>
-        <p:nvSpPr>
-          <p:cNvPr id="29" name="Rectangle 28"/>
-          <p:cNvSpPr/>
-          <p:nvPr/>
-        </p:nvSpPr>
-        <p:spPr>
-          <a:xfrm>
-            <a:off x="7059168" y="4242816"/>
-            <a:ext cx="10771632" cy="804672"/>
-          </a:xfrm>
-          <a:prstGeom prst="rect">
-            <a:avLst/>
-          </a:prstGeom>
-          <a:solidFill>
-            <a:srgbClr val="22355E"/>
-          </a:solidFill>
-          <a:ln w="6350">
-            <a:solidFill>
-              <a:srgbClr val="C9A84C"/>
-            </a:solidFill>
-          </a:ln>
-        </p:spPr>
-        <p:style>
-          <a:lnRef idx="1">
-            <a:schemeClr val="accent1"/>
-          </a:lnRef>
-          <a:fillRef idx="3">
-            <a:schemeClr val="accent1"/>
-          </a:fillRef>
-          <a:effectRef idx="2">
-            <a:schemeClr val="accent1"/>
-          </a:effectRef>
-          <a:fontRef idx="minor">
-            <a:schemeClr val="lt1"/>
-          </a:fontRef>
-        </p:style>
-        <p:txBody>
-          <a:bodyPr rtlCol="0" anchor="ctr"/>
-          <a:lstStyle/>
-          <a:p>
-            <a:pPr algn="ctr"/>
-          </a:p>
-        </p:txBody>
-      </p:sp>
-      <p:sp>
-        <p:nvSpPr>
-          <p:cNvPr id="30" name="TextBox 29"/>
-          <p:cNvSpPr txBox="1"/>
-          <p:nvPr/>
-        </p:nvSpPr>
-        <p:spPr>
-          <a:xfrm>
-            <a:off x="7242048" y="4315968"/>
-            <a:ext cx="10497312" cy="658368"/>
-          </a:xfrm>
-          <a:prstGeom prst="rect">
-            <a:avLst/>
-          </a:prstGeom>
-          <a:noFill/>
-        </p:spPr>
-        <p:txBody>
-          <a:bodyPr wrap="square">
-            <a:spAutoFit/>
-          </a:bodyPr>
-          <a:lstStyle/>
-          <a:p>
-            <a:pPr algn="r"/>
-            <a:r>
-              <a:rPr sz="1500" b="0">
-                <a:solidFill>
-                  <a:srgbClr val="FFFFFF"/>
-                </a:solidFill>
-                <a:latin typeface="Arial"/>
-              </a:rPr>
-              <a:t>✓  سجل تدقيق مدمج — كل عملية دخول أو تعديل موثّقة تلقائياً</a:t>
-            </a:r>
-          </a:p>
-        </p:txBody>
-      </p:sp>
-      <p:sp>
-        <p:nvSpPr>
-          <p:cNvPr id="31" name="Rectangle 30"/>
-          <p:cNvSpPr/>
-          <p:nvPr/>
-        </p:nvSpPr>
-        <p:spPr>
-          <a:xfrm>
-            <a:off x="457200" y="5047488"/>
-            <a:ext cx="6601968" cy="804672"/>
-          </a:xfrm>
-          <a:prstGeom prst="rect">
-            <a:avLst/>
-          </a:prstGeom>
-          <a:solidFill>
-            <a:srgbClr val="1A2A4A"/>
-          </a:solidFill>
-          <a:ln w="6350">
-            <a:solidFill>
-              <a:srgbClr val="C9A84C"/>
-            </a:solidFill>
-          </a:ln>
-        </p:spPr>
-        <p:style>
-          <a:lnRef idx="1">
-            <a:schemeClr val="accent1"/>
-          </a:lnRef>
-          <a:fillRef idx="3">
-            <a:schemeClr val="accent1"/>
-          </a:fillRef>
-          <a:effectRef idx="2">
-            <a:schemeClr val="accent1"/>
-          </a:effectRef>
-          <a:fontRef idx="minor">
-            <a:schemeClr val="lt1"/>
-          </a:fontRef>
-        </p:style>
-        <p:txBody>
-          <a:bodyPr rtlCol="0" anchor="ctr"/>
-          <a:lstStyle/>
-          <a:p>
-            <a:pPr algn="ctr"/>
-          </a:p>
-        </p:txBody>
-      </p:sp>
-      <p:sp>
-        <p:nvSpPr>
-          <p:cNvPr id="32" name="Rectangle 31"/>
-          <p:cNvSpPr/>
-          <p:nvPr/>
-        </p:nvSpPr>
-        <p:spPr>
-          <a:xfrm>
-            <a:off x="457200" y="5047488"/>
-            <a:ext cx="82296" cy="804672"/>
-          </a:xfrm>
-          <a:prstGeom prst="rect">
-            <a:avLst/>
-          </a:prstGeom>
-          <a:solidFill>
-            <a:srgbClr val="C9A84C"/>
-          </a:solidFill>
-          <a:ln>
-            <a:noFill/>
-          </a:ln>
-        </p:spPr>
-        <p:style>
-          <a:lnRef idx="1">
-            <a:schemeClr val="accent1"/>
-          </a:lnRef>
-          <a:fillRef idx="3">
-            <a:schemeClr val="accent1"/>
-          </a:fillRef>
-          <a:effectRef idx="2">
-            <a:schemeClr val="accent1"/>
-          </a:effectRef>
-          <a:fontRef idx="minor">
-            <a:schemeClr val="lt1"/>
-          </a:fontRef>
-        </p:style>
-        <p:txBody>
-          <a:bodyPr rtlCol="0" anchor="ctr"/>
-          <a:lstStyle/>
-          <a:p>
-            <a:pPr algn="ctr"/>
-          </a:p>
-        </p:txBody>
-      </p:sp>
-      <p:sp>
-        <p:nvSpPr>
-          <p:cNvPr id="33" name="TextBox 32"/>
-          <p:cNvSpPr txBox="1"/>
-          <p:nvPr/>
-        </p:nvSpPr>
-        <p:spPr>
-          <a:xfrm>
-            <a:off x="594360" y="5120640"/>
-            <a:ext cx="6419088" cy="658368"/>
-          </a:xfrm>
-          <a:prstGeom prst="rect">
-            <a:avLst/>
-          </a:prstGeom>
-          <a:noFill/>
-        </p:spPr>
-        <p:txBody>
-          <a:bodyPr wrap="square">
-            <a:spAutoFit/>
-          </a:bodyPr>
-          <a:lstStyle/>
-          <a:p>
-            <a:pPr algn="ctr"/>
-            <a:r>
-              <a:rPr sz="1600" b="1">
-                <a:solidFill>
-                  <a:srgbClr val="FFFFFF"/>
-                </a:solidFill>
-                <a:latin typeface="Arial"/>
-              </a:rPr>
-              <a:t>ضبط صلاحيات الوصول</a:t>
-            </a:r>
-          </a:p>
-        </p:txBody>
-      </p:sp>
-      <p:sp>
-        <p:nvSpPr>
-          <p:cNvPr id="34" name="Rectangle 33"/>
-          <p:cNvSpPr/>
-          <p:nvPr/>
-        </p:nvSpPr>
-        <p:spPr>
-          <a:xfrm>
-            <a:off x="7059168" y="5047488"/>
-            <a:ext cx="10771632" cy="804672"/>
-          </a:xfrm>
-          <a:prstGeom prst="rect">
-            <a:avLst/>
-          </a:prstGeom>
-          <a:solidFill>
-            <a:srgbClr val="1A2A4A"/>
-          </a:solidFill>
-          <a:ln w="6350">
-            <a:solidFill>
-              <a:srgbClr val="C9A84C"/>
-            </a:solidFill>
-          </a:ln>
-        </p:spPr>
-        <p:style>
-          <a:lnRef idx="1">
-            <a:schemeClr val="accent1"/>
-          </a:lnRef>
-          <a:fillRef idx="3">
-            <a:schemeClr val="accent1"/>
-          </a:fillRef>
-          <a:effectRef idx="2">
-            <a:schemeClr val="accent1"/>
-          </a:effectRef>
-          <a:fontRef idx="minor">
-            <a:schemeClr val="lt1"/>
-          </a:fontRef>
-        </p:style>
-        <p:txBody>
-          <a:bodyPr rtlCol="0" anchor="ctr"/>
-          <a:lstStyle/>
-          <a:p>
-            <a:pPr algn="ctr"/>
-          </a:p>
-        </p:txBody>
-      </p:sp>
-      <p:sp>
-        <p:nvSpPr>
-          <p:cNvPr id="35" name="TextBox 34"/>
-          <p:cNvSpPr txBox="1"/>
-          <p:nvPr/>
-        </p:nvSpPr>
-        <p:spPr>
-          <a:xfrm>
-            <a:off x="7242048" y="5120640"/>
-            <a:ext cx="10497312" cy="658368"/>
-          </a:xfrm>
-          <a:prstGeom prst="rect">
-            <a:avLst/>
-          </a:prstGeom>
-          <a:noFill/>
-        </p:spPr>
-        <p:txBody>
-          <a:bodyPr wrap="square">
-            <a:spAutoFit/>
-          </a:bodyPr>
-          <a:lstStyle/>
-          <a:p>
-            <a:pPr algn="r"/>
-            <a:r>
-              <a:rPr sz="1500" b="0">
-                <a:solidFill>
-                  <a:srgbClr val="FFFFFF"/>
-                </a:solidFill>
-                <a:latin typeface="Arial"/>
-              </a:rPr>
-              <a:t>✓  Admin يملك التحكم الكامل — CRUD منفصلة لكل دور</a:t>
-            </a:r>
-          </a:p>
-        </p:txBody>
-      </p:sp>
-      <p:sp>
-        <p:nvSpPr>
-          <p:cNvPr id="36" name="Rectangle 35"/>
-          <p:cNvSpPr/>
-          <p:nvPr/>
-        </p:nvSpPr>
-        <p:spPr>
-          <a:xfrm>
-            <a:off x="457200" y="6016752"/>
-            <a:ext cx="17373600" cy="1005840"/>
-          </a:xfrm>
-          <a:prstGeom prst="rect">
-            <a:avLst/>
-          </a:prstGeom>
-          <a:solidFill>
-            <a:srgbClr val="0F1A30"/>
-          </a:solidFill>
-          <a:ln w="19050">
-            <a:solidFill>
-              <a:srgbClr val="C9A84C"/>
-            </a:solidFill>
-          </a:ln>
-        </p:spPr>
-        <p:style>
-          <a:lnRef idx="1">
-            <a:schemeClr val="accent1"/>
-          </a:lnRef>
-          <a:fillRef idx="3">
-            <a:schemeClr val="accent1"/>
-          </a:fillRef>
-          <a:effectRef idx="2">
-            <a:schemeClr val="accent1"/>
-          </a:effectRef>
-          <a:fontRef idx="minor">
-            <a:schemeClr val="lt1"/>
-          </a:fontRef>
-        </p:style>
-        <p:txBody>
-          <a:bodyPr rtlCol="0" anchor="ctr"/>
-          <a:lstStyle/>
-          <a:p>
-            <a:pPr algn="ctr"/>
-          </a:p>
-        </p:txBody>
-      </p:sp>
-      <p:sp>
-        <p:nvSpPr>
-          <p:cNvPr id="37" name="TextBox 36"/>
-          <p:cNvSpPr txBox="1"/>
-          <p:nvPr/>
-        </p:nvSpPr>
-        <p:spPr>
-          <a:xfrm>
-            <a:off x="457200" y="6062472"/>
-            <a:ext cx="5791200" cy="502920"/>
-          </a:xfrm>
-          <a:prstGeom prst="rect">
-            <a:avLst/>
-          </a:prstGeom>
-          <a:noFill/>
-        </p:spPr>
-        <p:txBody>
-          <a:bodyPr wrap="square">
-            <a:spAutoFit/>
-          </a:bodyPr>
-          <a:lstStyle/>
-          <a:p>
-            <a:pPr algn="ctr"/>
-            <a:r>
-              <a:rPr sz="2600" b="1">
+              <a:rPr sz="1200" b="0" i="0">
                 <a:solidFill>
                   <a:srgbClr val="C9A84C"/>
                 </a:solidFill>
-                <a:latin typeface="Arial"/>
+                <a:latin typeface="Calibri"/>
               </a:rPr>
-              <a:t>5</a:t>
-            </a:r>
-          </a:p>
-        </p:txBody>
-      </p:sp>
-      <p:sp>
-        <p:nvSpPr>
-          <p:cNvPr id="38" name="TextBox 37"/>
-          <p:cNvSpPr txBox="1"/>
-          <p:nvPr/>
-        </p:nvSpPr>
-        <p:spPr>
-          <a:xfrm>
-            <a:off x="457200" y="6565392"/>
-            <a:ext cx="5791200" cy="365760"/>
-          </a:xfrm>
-          <a:prstGeom prst="rect">
-            <a:avLst/>
-          </a:prstGeom>
-          <a:noFill/>
-        </p:spPr>
-        <p:txBody>
-          <a:bodyPr wrap="square">
-            <a:spAutoFit/>
-          </a:bodyPr>
-          <a:lstStyle/>
-          <a:p>
-            <a:pPr algn="ctr"/>
-            <a:r>
-              <a:rPr sz="1300" b="0">
-                <a:solidFill>
-                  <a:srgbClr val="FFFFFF"/>
-                </a:solidFill>
-                <a:latin typeface="Arial"/>
-              </a:rPr>
-              <a:t>مستويات الوصول</a:t>
-            </a:r>
-          </a:p>
-        </p:txBody>
-      </p:sp>
-      <p:sp>
-        <p:nvSpPr>
-          <p:cNvPr id="39" name="Rectangle 38"/>
-          <p:cNvSpPr/>
-          <p:nvPr/>
-        </p:nvSpPr>
-        <p:spPr>
-          <a:xfrm>
-            <a:off x="6248400" y="6153912"/>
-            <a:ext cx="18288" cy="731520"/>
-          </a:xfrm>
-          <a:prstGeom prst="rect">
-            <a:avLst/>
-          </a:prstGeom>
-          <a:solidFill>
-            <a:srgbClr val="C9A84C"/>
-          </a:solidFill>
-          <a:ln>
-            <a:noFill/>
-          </a:ln>
-        </p:spPr>
-        <p:style>
-          <a:lnRef idx="1">
-            <a:schemeClr val="accent1"/>
-          </a:lnRef>
-          <a:fillRef idx="3">
-            <a:schemeClr val="accent1"/>
-          </a:fillRef>
-          <a:effectRef idx="2">
-            <a:schemeClr val="accent1"/>
-          </a:effectRef>
-          <a:fontRef idx="minor">
-            <a:schemeClr val="lt1"/>
-          </a:fontRef>
-        </p:style>
-        <p:txBody>
-          <a:bodyPr rtlCol="0" anchor="ctr"/>
-          <a:lstStyle/>
-          <a:p>
-            <a:pPr algn="ctr"/>
-          </a:p>
-        </p:txBody>
-      </p:sp>
-      <p:sp>
-        <p:nvSpPr>
-          <p:cNvPr id="40" name="TextBox 39"/>
-          <p:cNvSpPr txBox="1"/>
-          <p:nvPr/>
-        </p:nvSpPr>
-        <p:spPr>
-          <a:xfrm>
-            <a:off x="6248400" y="6062472"/>
-            <a:ext cx="5791200" cy="502920"/>
-          </a:xfrm>
-          <a:prstGeom prst="rect">
-            <a:avLst/>
-          </a:prstGeom>
-          <a:noFill/>
-        </p:spPr>
-        <p:txBody>
-          <a:bodyPr wrap="square">
-            <a:spAutoFit/>
-          </a:bodyPr>
-          <a:lstStyle/>
-          <a:p>
-            <a:pPr algn="ctr"/>
-            <a:r>
-              <a:rPr sz="2600" b="1">
-                <a:solidFill>
-                  <a:srgbClr val="C9A84C"/>
-                </a:solidFill>
-                <a:latin typeface="Arial"/>
-              </a:rPr>
-              <a:t>100%</a:t>
-            </a:r>
-          </a:p>
-        </p:txBody>
-      </p:sp>
-      <p:sp>
-        <p:nvSpPr>
-          <p:cNvPr id="41" name="TextBox 40"/>
-          <p:cNvSpPr txBox="1"/>
-          <p:nvPr/>
-        </p:nvSpPr>
-        <p:spPr>
-          <a:xfrm>
-            <a:off x="6248400" y="6565392"/>
-            <a:ext cx="5791200" cy="365760"/>
-          </a:xfrm>
-          <a:prstGeom prst="rect">
-            <a:avLst/>
-          </a:prstGeom>
-          <a:noFill/>
-        </p:spPr>
-        <p:txBody>
-          <a:bodyPr wrap="square">
-            <a:spAutoFit/>
-          </a:bodyPr>
-          <a:lstStyle/>
-          <a:p>
-            <a:pPr algn="ctr"/>
-            <a:r>
-              <a:rPr sz="1300" b="0">
-                <a:solidFill>
-                  <a:srgbClr val="FFFFFF"/>
-                </a:solidFill>
-                <a:latin typeface="Arial"/>
-              </a:rPr>
-              <a:t>بيانات محلية آمنة</a:t>
-            </a:r>
-          </a:p>
-        </p:txBody>
-      </p:sp>
-      <p:sp>
-        <p:nvSpPr>
-          <p:cNvPr id="42" name="Rectangle 41"/>
-          <p:cNvSpPr/>
-          <p:nvPr/>
-        </p:nvSpPr>
-        <p:spPr>
-          <a:xfrm>
-            <a:off x="12039600" y="6153912"/>
-            <a:ext cx="18288" cy="731520"/>
-          </a:xfrm>
-          <a:prstGeom prst="rect">
-            <a:avLst/>
-          </a:prstGeom>
-          <a:solidFill>
-            <a:srgbClr val="C9A84C"/>
-          </a:solidFill>
-          <a:ln>
-            <a:noFill/>
-          </a:ln>
-        </p:spPr>
-        <p:style>
-          <a:lnRef idx="1">
-            <a:schemeClr val="accent1"/>
-          </a:lnRef>
-          <a:fillRef idx="3">
-            <a:schemeClr val="accent1"/>
-          </a:fillRef>
-          <a:effectRef idx="2">
-            <a:schemeClr val="accent1"/>
-          </a:effectRef>
-          <a:fontRef idx="minor">
-            <a:schemeClr val="lt1"/>
-          </a:fontRef>
-        </p:style>
-        <p:txBody>
-          <a:bodyPr rtlCol="0" anchor="ctr"/>
-          <a:lstStyle/>
-          <a:p>
-            <a:pPr algn="ctr"/>
-          </a:p>
-        </p:txBody>
-      </p:sp>
-      <p:sp>
-        <p:nvSpPr>
-          <p:cNvPr id="43" name="TextBox 42"/>
-          <p:cNvSpPr txBox="1"/>
-          <p:nvPr/>
-        </p:nvSpPr>
-        <p:spPr>
-          <a:xfrm>
-            <a:off x="12039600" y="6062472"/>
-            <a:ext cx="5791200" cy="502920"/>
-          </a:xfrm>
-          <a:prstGeom prst="rect">
-            <a:avLst/>
-          </a:prstGeom>
-          <a:noFill/>
-        </p:spPr>
-        <p:txBody>
-          <a:bodyPr wrap="square">
-            <a:spAutoFit/>
-          </a:bodyPr>
-          <a:lstStyle/>
-          <a:p>
-            <a:pPr algn="ctr"/>
-            <a:r>
-              <a:rPr sz="2600" b="1">
-                <a:solidFill>
-                  <a:srgbClr val="C9A84C"/>
-                </a:solidFill>
-                <a:latin typeface="Arial"/>
-              </a:rPr>
-              <a:t>متوافق</a:t>
-            </a:r>
-          </a:p>
-        </p:txBody>
-      </p:sp>
-      <p:sp>
-        <p:nvSpPr>
-          <p:cNvPr id="44" name="TextBox 43"/>
-          <p:cNvSpPr txBox="1"/>
-          <p:nvPr/>
-        </p:nvSpPr>
-        <p:spPr>
-          <a:xfrm>
-            <a:off x="12039600" y="6565392"/>
-            <a:ext cx="5791200" cy="365760"/>
-          </a:xfrm>
-          <a:prstGeom prst="rect">
-            <a:avLst/>
-          </a:prstGeom>
-          <a:noFill/>
-        </p:spPr>
-        <p:txBody>
-          <a:bodyPr wrap="square">
-            <a:spAutoFit/>
-          </a:bodyPr>
-          <a:lstStyle/>
-          <a:p>
-            <a:pPr algn="ctr"/>
-            <a:r>
-              <a:rPr sz="1300" b="0">
-                <a:solidFill>
-                  <a:srgbClr val="FFFFFF"/>
-                </a:solidFill>
-                <a:latin typeface="Arial"/>
-              </a:rPr>
-              <a:t>مع القانون الاتحادي</a:t>
-            </a:r>
-          </a:p>
-        </p:txBody>
-      </p:sp>
-      <p:sp>
-        <p:nvSpPr>
-          <p:cNvPr id="45" name="Rectangle 44"/>
-          <p:cNvSpPr/>
-          <p:nvPr/>
-        </p:nvSpPr>
-        <p:spPr>
-          <a:xfrm>
-            <a:off x="0" y="9784080"/>
-            <a:ext cx="18288000" cy="502920"/>
-          </a:xfrm>
-          <a:prstGeom prst="rect">
-            <a:avLst/>
-          </a:prstGeom>
-          <a:solidFill>
-            <a:srgbClr val="0F1A30"/>
-          </a:solidFill>
-          <a:ln>
-            <a:noFill/>
-          </a:ln>
-        </p:spPr>
-        <p:style>
-          <a:lnRef idx="1">
-            <a:schemeClr val="accent1"/>
-          </a:lnRef>
-          <a:fillRef idx="3">
-            <a:schemeClr val="accent1"/>
-          </a:fillRef>
-          <a:effectRef idx="2">
-            <a:schemeClr val="accent1"/>
-          </a:effectRef>
-          <a:fontRef idx="minor">
-            <a:schemeClr val="lt1"/>
-          </a:fontRef>
-        </p:style>
-        <p:txBody>
-          <a:bodyPr rtlCol="0" anchor="ctr"/>
-          <a:lstStyle/>
-          <a:p>
-            <a:pPr algn="ctr"/>
-          </a:p>
-        </p:txBody>
-      </p:sp>
-      <p:sp>
-        <p:nvSpPr>
-          <p:cNvPr id="46" name="Rectangle 45"/>
-          <p:cNvSpPr/>
-          <p:nvPr/>
-        </p:nvSpPr>
-        <p:spPr>
-          <a:xfrm>
-            <a:off x="0" y="9784080"/>
-            <a:ext cx="18288000" cy="45720"/>
-          </a:xfrm>
-          <a:prstGeom prst="rect">
-            <a:avLst/>
-          </a:prstGeom>
-          <a:solidFill>
-            <a:srgbClr val="C9A84C"/>
-          </a:solidFill>
-          <a:ln>
-            <a:noFill/>
-          </a:ln>
-        </p:spPr>
-        <p:style>
-          <a:lnRef idx="1">
-            <a:schemeClr val="accent1"/>
-          </a:lnRef>
-          <a:fillRef idx="3">
-            <a:schemeClr val="accent1"/>
-          </a:fillRef>
-          <a:effectRef idx="2">
-            <a:schemeClr val="accent1"/>
-          </a:effectRef>
-          <a:fontRef idx="minor">
-            <a:schemeClr val="lt1"/>
-          </a:fontRef>
-        </p:style>
-        <p:txBody>
-          <a:bodyPr rtlCol="0" anchor="ctr"/>
-          <a:lstStyle/>
-          <a:p>
-            <a:pPr algn="ctr"/>
-          </a:p>
-        </p:txBody>
-      </p:sp>
-      <p:sp>
-        <p:nvSpPr>
-          <p:cNvPr id="47" name="TextBox 46"/>
-          <p:cNvSpPr txBox="1"/>
-          <p:nvPr/>
-        </p:nvSpPr>
-        <p:spPr>
-          <a:xfrm>
-            <a:off x="274320" y="9857232"/>
-            <a:ext cx="17739360" cy="347472"/>
-          </a:xfrm>
-          <a:prstGeom prst="rect">
-            <a:avLst/>
-          </a:prstGeom>
-          <a:noFill/>
-        </p:spPr>
-        <p:txBody>
-          <a:bodyPr wrap="square">
-            <a:spAutoFit/>
-          </a:bodyPr>
-          <a:lstStyle/>
-          <a:p>
-            <a:pPr algn="ctr"/>
-            <a:r>
-              <a:rPr sz="1400" b="0">
-                <a:solidFill>
-                  <a:srgbClr val="FFFFFF"/>
-                </a:solidFill>
-                <a:latin typeface="Arial"/>
-              </a:rPr>
-              <a:t>بوابة مدرسة الجود الرقمية — نموذج امتثال متكامل مع التشريع الإماراتي</a:t>
+              <a:t>بوابة مدرسة الجود الرقمية  |  مدرسة حكومية، العين، أبوظبي</a:t>
             </a:r>
           </a:p>
         </p:txBody>

</xml_diff>

<commit_message>
fix: v8 - slides 3&4 now use original theme frame (Group 2) + freeform circle + different images + tight spacing
</commit_message>
<xml_diff>
--- a/assets/aljood_pitch_with_law.pptx
+++ b/assets/aljood_pitch_with_law.pptx
@@ -5733,67 +5733,314 @@
           <a:chExt cx="0" cy="0"/>
         </a:xfrm>
       </p:grpSpPr>
-      <p:sp>
-        <p:nvSpPr>
-          <p:cNvPr id="2" name="Rectangle 1"/>
+      <p:grpSp>
+        <p:nvGrpSpPr>
+          <p:cNvPr name="Group 2" id="100"/>
+          <p:cNvGrpSpPr/>
+          <p:nvPr/>
+        </p:nvGrpSpPr>
+        <p:grpSpPr>
+          <a:xfrm rot="0">
+            <a:off x="666750" y="666750"/>
+            <a:ext cx="16954500" cy="8953500"/>
+            <a:chOff x="0" y="0"/>
+            <a:chExt cx="5734099" cy="3028120"/>
+          </a:xfrm>
+        </p:grpSpPr>
+        <p:sp>
+          <p:nvSpPr>
+            <p:cNvPr name="Freeform 3" id="3"/>
+            <p:cNvSpPr/>
+            <p:nvPr/>
+          </p:nvSpPr>
+          <p:spPr>
+            <a:xfrm flipH="false" flipV="false" rot="0">
+              <a:off x="52070" y="12700"/>
+              <a:ext cx="5669329" cy="2959540"/>
+            </a:xfrm>
+            <a:custGeom>
+              <a:avLst/>
+              <a:gdLst/>
+              <a:ahLst/>
+              <a:cxnLst/>
+              <a:rect r="r" b="b" t="t" l="l"/>
+              <a:pathLst>
+                <a:path h="2959540" w="5669329">
+                  <a:moveTo>
+                    <a:pt x="5523279" y="2959540"/>
+                  </a:moveTo>
+                  <a:lnTo>
+                    <a:pt x="164850" y="2959540"/>
+                  </a:lnTo>
+                  <a:cubicBezTo>
+                    <a:pt x="66040" y="2959540"/>
+                    <a:pt x="0" y="2893500"/>
+                    <a:pt x="0" y="2813490"/>
+                  </a:cubicBezTo>
+                  <a:lnTo>
+                    <a:pt x="0" y="146050"/>
+                  </a:lnTo>
+                  <a:cubicBezTo>
+                    <a:pt x="0" y="66040"/>
+                    <a:pt x="66040" y="0"/>
+                    <a:pt x="164850" y="0"/>
+                  </a:cubicBezTo>
+                  <a:lnTo>
+                    <a:pt x="5523279" y="0"/>
+                  </a:lnTo>
+                  <a:cubicBezTo>
+                    <a:pt x="5603289" y="0"/>
+                    <a:pt x="5669329" y="66040"/>
+                    <a:pt x="5669329" y="146050"/>
+                  </a:cubicBezTo>
+                  <a:lnTo>
+                    <a:pt x="5669329" y="2813490"/>
+                  </a:lnTo>
+                  <a:cubicBezTo>
+                    <a:pt x="5669329" y="2894770"/>
+                    <a:pt x="5603289" y="2959540"/>
+                    <a:pt x="5523279" y="2959540"/>
+                  </a:cubicBezTo>
+                  <a:close/>
+                </a:path>
+              </a:pathLst>
+            </a:custGeom>
+            <a:solidFill>
+              <a:srgbClr val="021633"/>
+            </a:solidFill>
+          </p:spPr>
+        </p:sp>
+        <p:sp>
+          <p:nvSpPr>
+            <p:cNvPr name="Freeform 4" id="4"/>
+            <p:cNvSpPr/>
+            <p:nvPr/>
+          </p:nvSpPr>
+          <p:spPr>
+            <a:xfrm flipH="false" flipV="false" rot="0">
+              <a:off x="0" y="0"/>
+              <a:ext cx="5734099" cy="3028120"/>
+            </a:xfrm>
+            <a:custGeom>
+              <a:avLst/>
+              <a:gdLst/>
+              <a:ahLst/>
+              <a:cxnLst/>
+              <a:rect r="r" b="b" t="t" l="l"/>
+              <a:pathLst>
+                <a:path h="3028120" w="5734099">
+                  <a:moveTo>
+                    <a:pt x="63500" y="74930"/>
+                  </a:moveTo>
+                  <a:cubicBezTo>
+                    <a:pt x="91440" y="30480"/>
+                    <a:pt x="140970" y="0"/>
+                    <a:pt x="216920" y="0"/>
+                  </a:cubicBezTo>
+                  <a:lnTo>
+                    <a:pt x="5575349" y="0"/>
+                  </a:lnTo>
+                  <a:cubicBezTo>
+                    <a:pt x="5662979" y="0"/>
+                    <a:pt x="5734099" y="71120"/>
+                    <a:pt x="5734099" y="158750"/>
+                  </a:cubicBezTo>
+                  <a:lnTo>
+                    <a:pt x="5734099" y="2826190"/>
+                  </a:lnTo>
+                  <a:cubicBezTo>
+                    <a:pt x="5734099" y="2878260"/>
+                    <a:pt x="5708699" y="2923980"/>
+                    <a:pt x="5670599" y="2953190"/>
+                  </a:cubicBezTo>
+                  <a:cubicBezTo>
+                    <a:pt x="5642659" y="2997640"/>
+                    <a:pt x="5593129" y="3028120"/>
+                    <a:pt x="5535979" y="3028120"/>
+                  </a:cubicBezTo>
+                  <a:lnTo>
+                    <a:pt x="158750" y="3028120"/>
+                  </a:lnTo>
+                  <a:cubicBezTo>
+                    <a:pt x="71120" y="3028120"/>
+                    <a:pt x="0" y="2957000"/>
+                    <a:pt x="0" y="2869370"/>
+                  </a:cubicBezTo>
+                  <a:lnTo>
+                    <a:pt x="0" y="208926"/>
+                  </a:lnTo>
+                  <a:cubicBezTo>
+                    <a:pt x="0" y="149860"/>
+                    <a:pt x="25400" y="104140"/>
+                    <a:pt x="63500" y="74930"/>
+                  </a:cubicBezTo>
+                  <a:close/>
+                  <a:moveTo>
+                    <a:pt x="5721399" y="2826190"/>
+                  </a:moveTo>
+                  <a:lnTo>
+                    <a:pt x="5721399" y="158750"/>
+                  </a:lnTo>
+                  <a:cubicBezTo>
+                    <a:pt x="5721399" y="78740"/>
+                    <a:pt x="5655359" y="12700"/>
+                    <a:pt x="5575349" y="12700"/>
+                  </a:cubicBezTo>
+                  <a:lnTo>
+                    <a:pt x="216920" y="12700"/>
+                  </a:lnTo>
+                  <a:cubicBezTo>
+                    <a:pt x="118110" y="12700"/>
+                    <a:pt x="52070" y="78740"/>
+                    <a:pt x="52070" y="158750"/>
+                  </a:cubicBezTo>
+                  <a:lnTo>
+                    <a:pt x="52070" y="2826190"/>
+                  </a:lnTo>
+                  <a:cubicBezTo>
+                    <a:pt x="52070" y="2906200"/>
+                    <a:pt x="118110" y="2972240"/>
+                    <a:pt x="216920" y="2972240"/>
+                  </a:cubicBezTo>
+                  <a:lnTo>
+                    <a:pt x="5575349" y="2972240"/>
+                  </a:lnTo>
+                  <a:cubicBezTo>
+                    <a:pt x="5655359" y="2972240"/>
+                    <a:pt x="5721399" y="2907470"/>
+                    <a:pt x="5721399" y="2826190"/>
+                  </a:cubicBezTo>
+                  <a:close/>
+                </a:path>
+              </a:pathLst>
+            </a:custGeom>
+            <a:solidFill>
+              <a:srgbClr val="C9A84C"/>
+            </a:solidFill>
+          </p:spPr>
+        </p:sp>
+      </p:grpSp>
+      <p:sp>
+        <p:nvSpPr>
+          <p:cNvPr name="Freeform 5" id="200"/>
           <p:cNvSpPr/>
           <p:nvPr/>
         </p:nvSpPr>
         <p:spPr>
-          <a:xfrm>
-            <a:off x="0" y="0"/>
-            <a:ext cx="18288000" cy="10287000"/>
-          </a:xfrm>
-          <a:prstGeom prst="rect">
+          <a:xfrm flipH="true" flipV="false" rot="0">
+            <a:off x="10486143" y="2216792"/>
+            <a:ext cx="5696832" cy="5911807"/>
+          </a:xfrm>
+          <a:custGeom>
             <a:avLst/>
-          </a:prstGeom>
-          <a:solidFill>
-            <a:srgbClr val="1A2A4A"/>
-          </a:solidFill>
-          <a:ln>
+            <a:gdLst/>
+            <a:ahLst/>
+            <a:cxnLst/>
+            <a:rect r="r" b="b" t="t" l="l"/>
+            <a:pathLst>
+              <a:path h="5911807" w="5696832">
+                <a:moveTo>
+                  <a:pt x="5696832" y="0"/>
+                </a:moveTo>
+                <a:lnTo>
+                  <a:pt x="0" y="0"/>
+                </a:lnTo>
+                <a:lnTo>
+                  <a:pt x="0" y="5911807"/>
+                </a:lnTo>
+                <a:lnTo>
+                  <a:pt x="5696832" y="5911807"/>
+                </a:lnTo>
+                <a:lnTo>
+                  <a:pt x="5696832" y="0"/>
+                </a:lnTo>
+                <a:close/>
+              </a:path>
+            </a:pathLst>
+          </a:custGeom>
+          <a:blipFill>
+            <a:blip r:embed="rId2">
+              <a:extLst>
+                <a:ext uri="{96DAC541-7B7A-43D3-8B79-37D633B846F1}">
+                  <asvg:svgBlip xmlns:asvg="http://schemas.microsoft.com/office/drawing/2016/SVG/main" r:embed="rId3"/>
+                </a:ext>
+              </a:extLst>
+            </a:blip>
+            <a:stretch>
+              <a:fillRect l="0" t="0" r="0" b="0"/>
+            </a:stretch>
+          </a:blipFill>
+          <a:ln cap="sq">
             <a:noFill/>
+            <a:prstDash val="solid"/>
+            <a:miter/>
           </a:ln>
         </p:spPr>
-        <p:style>
-          <a:lnRef idx="1">
-            <a:schemeClr val="accent1"/>
-          </a:lnRef>
-          <a:fillRef idx="3">
-            <a:schemeClr val="accent1"/>
-          </a:fillRef>
-          <a:effectRef idx="2">
-            <a:schemeClr val="accent1"/>
-          </a:effectRef>
-          <a:fontRef idx="minor">
-            <a:schemeClr val="lt1"/>
-          </a:fontRef>
-        </p:style>
-        <p:txBody>
-          <a:bodyPr rtlCol="0" anchor="ctr"/>
-          <a:lstStyle/>
-          <a:p>
-            <a:pPr algn="ctr"/>
-          </a:p>
-        </p:txBody>
+      </p:sp>
+      <p:sp>
+        <p:nvSpPr>
+          <p:cNvPr name="Freeform 6" id="201"/>
+          <p:cNvSpPr/>
+          <p:nvPr/>
+        </p:nvSpPr>
+        <p:spPr>
+          <a:xfrm flipH="false" flipV="false" rot="0">
+            <a:off x="10546645" y="2306609"/>
+            <a:ext cx="4485772" cy="4485772"/>
+          </a:xfrm>
+          <a:custGeom>
+            <a:avLst/>
+            <a:gdLst/>
+            <a:ahLst/>
+            <a:cxnLst/>
+            <a:rect r="r" b="b" t="t" l="l"/>
+            <a:pathLst>
+              <a:path h="4485772" w="4485772">
+                <a:moveTo>
+                  <a:pt x="0" y="0"/>
+                </a:moveTo>
+                <a:lnTo>
+                  <a:pt x="4485772" y="0"/>
+                </a:lnTo>
+                <a:lnTo>
+                  <a:pt x="4485772" y="4485772"/>
+                </a:lnTo>
+                <a:lnTo>
+                  <a:pt x="0" y="4485772"/>
+                </a:lnTo>
+                <a:lnTo>
+                  <a:pt x="0" y="0"/>
+                </a:lnTo>
+                <a:close/>
+              </a:path>
+            </a:pathLst>
+          </a:custGeom>
+          <a:blipFill>
+            <a:blip r:embed="rId4"/>
+            <a:stretch>
+              <a:fillRect l="0" t="0" r="0" b="0"/>
+            </a:stretch>
+          </a:blipFill>
+        </p:spPr>
       </p:sp>
       <p:pic>
         <p:nvPicPr>
-          <p:cNvPr id="3" name="Picture 2" descr="image.jpg"/>
+          <p:cNvPr id="202" name="Picture 201" descr="img3.jpg"/>
           <p:cNvPicPr>
             <a:picLocks noChangeAspect="1"/>
           </p:cNvPicPr>
           <p:nvPr/>
         </p:nvPicPr>
         <p:blipFill>
-          <a:blip r:embed="rId2"/>
+          <a:blip r:embed="rId3"/>
           <a:stretch>
             <a:fillRect/>
           </a:stretch>
         </p:blipFill>
         <p:spPr>
           <a:xfrm>
-            <a:off x="9784080" y="617220"/>
-            <a:ext cx="7955280" cy="9052560"/>
+            <a:off x="10543032" y="2304288"/>
+            <a:ext cx="4489704" cy="4489704"/>
           </a:xfrm>
           <a:prstGeom prst="rect">
             <a:avLst/>
@@ -5802,59 +6049,14 @@
       </p:pic>
       <p:sp>
         <p:nvSpPr>
-          <p:cNvPr id="4" name="Rectangle 3"/>
+          <p:cNvPr id="203" name="Rectangle 202"/>
           <p:cNvSpPr/>
           <p:nvPr/>
         </p:nvSpPr>
         <p:spPr>
           <a:xfrm>
-            <a:off x="9784080" y="617220"/>
-            <a:ext cx="1097280" cy="9052560"/>
-          </a:xfrm>
-          <a:prstGeom prst="rect">
-            <a:avLst/>
-          </a:prstGeom>
-          <a:solidFill>
-            <a:srgbClr val="1A2A4A">
-              <a:alpha val="70000"/>
-            </a:srgbClr>
-          </a:solidFill>
-          <a:ln>
-            <a:noFill/>
-          </a:ln>
-        </p:spPr>
-        <p:style>
-          <a:lnRef idx="1">
-            <a:schemeClr val="accent1"/>
-          </a:lnRef>
-          <a:fillRef idx="3">
-            <a:schemeClr val="accent1"/>
-          </a:fillRef>
-          <a:effectRef idx="2">
-            <a:schemeClr val="accent1"/>
-          </a:effectRef>
-          <a:fontRef idx="minor">
-            <a:schemeClr val="lt1"/>
-          </a:fontRef>
-        </p:style>
-        <p:txBody>
-          <a:bodyPr rtlCol="0" anchor="ctr"/>
-          <a:lstStyle/>
-          <a:p>
-            <a:pPr algn="ctr"/>
-          </a:p>
-        </p:txBody>
-      </p:sp>
-      <p:sp>
-        <p:nvSpPr>
-          <p:cNvPr id="5" name="Rectangle 4"/>
-          <p:cNvSpPr/>
-          <p:nvPr/>
-        </p:nvSpPr>
-        <p:spPr>
-          <a:xfrm>
-            <a:off x="731520" y="1234440"/>
-            <a:ext cx="128016" cy="7818120"/>
+            <a:off x="1243584" y="923544"/>
+            <a:ext cx="3840480" cy="457200"/>
           </a:xfrm>
           <a:prstGeom prst="rect">
             <a:avLst/>
@@ -5890,14 +6092,116 @@
       </p:sp>
       <p:sp>
         <p:nvSpPr>
-          <p:cNvPr id="6" name="Rectangle 5"/>
+          <p:cNvPr id="204" name="TextBox 203"/>
+          <p:cNvSpPr txBox="1"/>
+          <p:nvPr/>
+        </p:nvSpPr>
+        <p:spPr>
+          <a:xfrm>
+            <a:off x="1243584" y="932688"/>
+            <a:ext cx="3840480" cy="438912"/>
+          </a:xfrm>
+          <a:prstGeom prst="rect">
+            <a:avLst/>
+          </a:prstGeom>
+          <a:noFill/>
+        </p:spPr>
+        <p:txBody>
+          <a:bodyPr wrap="square">
+            <a:spAutoFit/>
+          </a:bodyPr>
+          <a:lstStyle/>
+          <a:p>
+            <a:pPr algn="ctr"/>
+            <a:r>
+              <a:rPr sz="1100" b="1">
+                <a:solidFill>
+                  <a:srgbClr val="021633"/>
+                </a:solidFill>
+              </a:rPr>
+              <a:t>مرسوم اتحادي | يناير 2026</a:t>
+            </a:r>
+          </a:p>
+        </p:txBody>
+      </p:sp>
+      <p:sp>
+        <p:nvSpPr>
+          <p:cNvPr id="205" name="TextBox 204"/>
+          <p:cNvSpPr txBox="1"/>
+          <p:nvPr/>
+        </p:nvSpPr>
+        <p:spPr>
+          <a:xfrm>
+            <a:off x="1243584" y="1554480"/>
+            <a:ext cx="8686800" cy="502920"/>
+          </a:xfrm>
+          <a:prstGeom prst="rect">
+            <a:avLst/>
+          </a:prstGeom>
+          <a:noFill/>
+        </p:spPr>
+        <p:txBody>
+          <a:bodyPr wrap="square">
+            <a:spAutoFit/>
+          </a:bodyPr>
+          <a:lstStyle/>
+          <a:p>
+            <a:pPr algn="r" rtl="1"/>
+            <a:r>
+              <a:rPr sz="2200" b="1">
+                <a:solidFill>
+                  <a:srgbClr val="C9A84C"/>
+                </a:solidFill>
+              </a:rPr>
+              <a:t>قانون حماية الطفل الرقمي</a:t>
+            </a:r>
+          </a:p>
+        </p:txBody>
+      </p:sp>
+      <p:sp>
+        <p:nvSpPr>
+          <p:cNvPr id="206" name="TextBox 205"/>
+          <p:cNvSpPr txBox="1"/>
+          <p:nvPr/>
+        </p:nvSpPr>
+        <p:spPr>
+          <a:xfrm>
+            <a:off x="1243584" y="2057400"/>
+            <a:ext cx="8686800" cy="365760"/>
+          </a:xfrm>
+          <a:prstGeom prst="rect">
+            <a:avLst/>
+          </a:prstGeom>
+          <a:noFill/>
+        </p:spPr>
+        <p:txBody>
+          <a:bodyPr wrap="square">
+            <a:spAutoFit/>
+          </a:bodyPr>
+          <a:lstStyle/>
+          <a:p>
+            <a:pPr algn="l"/>
+            <a:r>
+              <a:rPr sz="1200" b="0">
+                <a:solidFill>
+                  <a:srgbClr val="B4C8E6"/>
+                </a:solidFill>
+              </a:rPr>
+              <a:t>Child Digital Safety Law</a:t>
+            </a:r>
+          </a:p>
+        </p:txBody>
+      </p:sp>
+      <p:sp>
+        <p:nvSpPr>
+          <p:cNvPr id="207" name="Rectangle 206"/>
           <p:cNvSpPr/>
           <p:nvPr/>
         </p:nvSpPr>
         <p:spPr>
           <a:xfrm>
-            <a:off x="1243584" y="925830"/>
-            <a:ext cx="3474720" cy="977265"/>
+            <a:off x="1243584" y="2560320"/>
+            <a:ext cx="7772400" cy="36576"/>
           </a:xfrm>
           <a:prstGeom prst="rect">
             <a:avLst/>
@@ -5933,119 +6237,14 @@
       </p:sp>
       <p:sp>
         <p:nvSpPr>
-          <p:cNvPr id="7" name="TextBox 6"/>
-          <p:cNvSpPr txBox="1"/>
+          <p:cNvPr id="208" name="Rectangle 207"/>
+          <p:cNvSpPr/>
           <p:nvPr/>
         </p:nvSpPr>
         <p:spPr>
           <a:xfrm>
-            <a:off x="1243584" y="956691"/>
-            <a:ext cx="3474720" cy="905256"/>
-          </a:xfrm>
-          <a:prstGeom prst="rect">
-            <a:avLst/>
-          </a:prstGeom>
-          <a:noFill/>
-        </p:spPr>
-        <p:txBody>
-          <a:bodyPr wrap="square">
-            <a:spAutoFit/>
-          </a:bodyPr>
-          <a:lstStyle/>
-          <a:p>
-            <a:pPr algn="ctr"/>
-            <a:r>
-              <a:rPr sz="1800" b="1" i="0">
-                <a:solidFill>
-                  <a:srgbClr val="1A2A4A"/>
-                </a:solidFill>
-                <a:latin typeface="Calibri"/>
-              </a:rPr>
-              <a:t>يناير  2026</a:t>
-            </a:r>
-          </a:p>
-        </p:txBody>
-      </p:sp>
-      <p:sp>
-        <p:nvSpPr>
-          <p:cNvPr id="8" name="TextBox 7"/>
-          <p:cNvSpPr txBox="1"/>
-          <p:nvPr/>
-        </p:nvSpPr>
-        <p:spPr>
-          <a:xfrm>
-            <a:off x="1243584" y="2160270"/>
-            <a:ext cx="8046720" cy="1337310"/>
-          </a:xfrm>
-          <a:prstGeom prst="rect">
-            <a:avLst/>
-          </a:prstGeom>
-          <a:noFill/>
-        </p:spPr>
-        <p:txBody>
-          <a:bodyPr wrap="square">
-            <a:spAutoFit/>
-          </a:bodyPr>
-          <a:lstStyle/>
-          <a:p>
-            <a:pPr algn="l"/>
-            <a:r>
-              <a:rPr sz="2500" b="1" i="0">
-                <a:solidFill>
-                  <a:srgbClr val="C9A84C"/>
-                </a:solidFill>
-                <a:latin typeface="Calibri"/>
-              </a:rPr>
-              <a:t>قانون حماية الطفل الرقمي الإماراتي</a:t>
-            </a:r>
-          </a:p>
-        </p:txBody>
-      </p:sp>
-      <p:sp>
-        <p:nvSpPr>
-          <p:cNvPr id="9" name="TextBox 8"/>
-          <p:cNvSpPr txBox="1"/>
-          <p:nvPr/>
-        </p:nvSpPr>
-        <p:spPr>
-          <a:xfrm>
-            <a:off x="1243584" y="3549014"/>
-            <a:ext cx="8046720" cy="720090"/>
-          </a:xfrm>
-          <a:prstGeom prst="rect">
-            <a:avLst/>
-          </a:prstGeom>
-          <a:noFill/>
-        </p:spPr>
-        <p:txBody>
-          <a:bodyPr wrap="square">
-            <a:spAutoFit/>
-          </a:bodyPr>
-          <a:lstStyle/>
-          <a:p>
-            <a:pPr algn="l"/>
-            <a:r>
-              <a:rPr sz="1600" b="0" i="1">
-                <a:solidFill>
-                  <a:srgbClr val="D0D8E8"/>
-                </a:solidFill>
-                <a:latin typeface="Calibri"/>
-              </a:rPr>
-              <a:t>UAE Child Digital Safety Law</a:t>
-            </a:r>
-          </a:p>
-        </p:txBody>
-      </p:sp>
-      <p:sp>
-        <p:nvSpPr>
-          <p:cNvPr id="10" name="Rectangle 9"/>
-          <p:cNvSpPr/>
-          <p:nvPr/>
-        </p:nvSpPr>
-        <p:spPr>
-          <a:xfrm>
-            <a:off x="1243584" y="4443984"/>
-            <a:ext cx="7498080" cy="30861"/>
+            <a:off x="1243584" y="2880360"/>
+            <a:ext cx="137160" cy="137160"/>
           </a:xfrm>
           <a:prstGeom prst="rect">
             <a:avLst/>
@@ -6081,14 +6280,82 @@
       </p:sp>
       <p:sp>
         <p:nvSpPr>
-          <p:cNvPr id="11" name="Rectangle 10"/>
+          <p:cNvPr id="209" name="TextBox 208"/>
+          <p:cNvSpPr txBox="1"/>
+          <p:nvPr/>
+        </p:nvSpPr>
+        <p:spPr>
+          <a:xfrm>
+            <a:off x="1508760" y="2788920"/>
+            <a:ext cx="7589520" cy="347472"/>
+          </a:xfrm>
+          <a:prstGeom prst="rect">
+            <a:avLst/>
+          </a:prstGeom>
+          <a:noFill/>
+        </p:spPr>
+        <p:txBody>
+          <a:bodyPr wrap="square">
+            <a:spAutoFit/>
+          </a:bodyPr>
+          <a:lstStyle/>
+          <a:p>
+            <a:pPr algn="r" rtl="1"/>
+            <a:r>
+              <a:rPr sz="1300" b="1">
+                <a:solidFill>
+                  <a:srgbClr val="FFFFFF"/>
+                </a:solidFill>
+              </a:rPr>
+              <a:t>حماية الخصوصية الرقمية للطفل</a:t>
+            </a:r>
+          </a:p>
+        </p:txBody>
+      </p:sp>
+      <p:sp>
+        <p:nvSpPr>
+          <p:cNvPr id="210" name="TextBox 209"/>
+          <p:cNvSpPr txBox="1"/>
+          <p:nvPr/>
+        </p:nvSpPr>
+        <p:spPr>
+          <a:xfrm>
+            <a:off x="1508760" y="3127248"/>
+            <a:ext cx="7589520" cy="292608"/>
+          </a:xfrm>
+          <a:prstGeom prst="rect">
+            <a:avLst/>
+          </a:prstGeom>
+          <a:noFill/>
+        </p:spPr>
+        <p:txBody>
+          <a:bodyPr wrap="square">
+            <a:spAutoFit/>
+          </a:bodyPr>
+          <a:lstStyle/>
+          <a:p>
+            <a:pPr algn="l"/>
+            <a:r>
+              <a:rPr sz="1000" b="0">
+                <a:solidFill>
+                  <a:srgbClr val="A5BEE1"/>
+                </a:solidFill>
+              </a:rPr>
+              <a:t>Protecting children's digital privacy</a:t>
+            </a:r>
+          </a:p>
+        </p:txBody>
+      </p:sp>
+      <p:sp>
+        <p:nvSpPr>
+          <p:cNvPr id="211" name="Rectangle 210"/>
           <p:cNvSpPr/>
           <p:nvPr/>
         </p:nvSpPr>
         <p:spPr>
           <a:xfrm>
-            <a:off x="1243584" y="5061204"/>
-            <a:ext cx="174879" cy="174879"/>
+            <a:off x="1243584" y="3703320"/>
+            <a:ext cx="137160" cy="137160"/>
           </a:xfrm>
           <a:prstGeom prst="rect">
             <a:avLst/>
@@ -6124,14 +6391,14 @@
       </p:sp>
       <p:sp>
         <p:nvSpPr>
-          <p:cNvPr id="12" name="TextBox 11"/>
+          <p:cNvPr id="212" name="TextBox 211"/>
           <p:cNvSpPr txBox="1"/>
           <p:nvPr/>
         </p:nvSpPr>
         <p:spPr>
           <a:xfrm>
-            <a:off x="1664208" y="4814316"/>
-            <a:ext cx="7626096" cy="720090"/>
+            <a:off x="1508760" y="3611879"/>
+            <a:ext cx="7589520" cy="347472"/>
           </a:xfrm>
           <a:prstGeom prst="rect">
             <a:avLst/>
@@ -6144,29 +6411,28 @@
           </a:bodyPr>
           <a:lstStyle/>
           <a:p>
-            <a:pPr algn="l"/>
+            <a:pPr algn="r" rtl="1"/>
             <a:r>
-              <a:rPr sz="1900" b="1" i="0">
+              <a:rPr sz="1300" b="1">
                 <a:solidFill>
                   <a:srgbClr val="FFFFFF"/>
                 </a:solidFill>
-                <a:latin typeface="Calibri"/>
               </a:rPr>
-              <a:t>حماية الأطفال من المحتوى الرقمي الضار</a:t>
+              <a:t>تنظيم المحتوى الإلكتروني الموجَّه</a:t>
             </a:r>
           </a:p>
         </p:txBody>
       </p:sp>
       <p:sp>
         <p:nvSpPr>
-          <p:cNvPr id="13" name="TextBox 12"/>
+          <p:cNvPr id="213" name="TextBox 212"/>
           <p:cNvSpPr txBox="1"/>
           <p:nvPr/>
         </p:nvSpPr>
         <p:spPr>
           <a:xfrm>
-            <a:off x="1664208" y="5503545"/>
-            <a:ext cx="7626096" cy="668655"/>
+            <a:off x="1508760" y="3950207"/>
+            <a:ext cx="7589520" cy="292608"/>
           </a:xfrm>
           <a:prstGeom prst="rect">
             <a:avLst/>
@@ -6181,27 +6447,26 @@
           <a:p>
             <a:pPr algn="l"/>
             <a:r>
-              <a:rPr sz="1300" b="0" i="1">
+              <a:rPr sz="1000" b="0">
                 <a:solidFill>
-                  <a:srgbClr val="D0D8E8"/>
+                  <a:srgbClr val="A5BEE1"/>
                 </a:solidFill>
-                <a:latin typeface="Calibri"/>
               </a:rPr>
-              <a:t>Protecting children from harmful digital content</a:t>
+              <a:t>Regulating directed digital content</a:t>
             </a:r>
           </a:p>
         </p:txBody>
       </p:sp>
       <p:sp>
         <p:nvSpPr>
-          <p:cNvPr id="14" name="Rectangle 13"/>
+          <p:cNvPr id="214" name="Rectangle 213"/>
           <p:cNvSpPr/>
           <p:nvPr/>
         </p:nvSpPr>
         <p:spPr>
           <a:xfrm>
-            <a:off x="1243584" y="6655689"/>
-            <a:ext cx="174879" cy="174879"/>
+            <a:off x="1243584" y="4526279"/>
+            <a:ext cx="137160" cy="137160"/>
           </a:xfrm>
           <a:prstGeom prst="rect">
             <a:avLst/>
@@ -6237,14 +6502,14 @@
       </p:sp>
       <p:sp>
         <p:nvSpPr>
-          <p:cNvPr id="15" name="TextBox 14"/>
+          <p:cNvPr id="215" name="TextBox 214"/>
           <p:cNvSpPr txBox="1"/>
           <p:nvPr/>
         </p:nvSpPr>
         <p:spPr>
           <a:xfrm>
-            <a:off x="1664208" y="6408801"/>
-            <a:ext cx="7626096" cy="720090"/>
+            <a:off x="1508760" y="4434840"/>
+            <a:ext cx="7589520" cy="347472"/>
           </a:xfrm>
           <a:prstGeom prst="rect">
             <a:avLst/>
@@ -6257,29 +6522,28 @@
           </a:bodyPr>
           <a:lstStyle/>
           <a:p>
-            <a:pPr algn="l"/>
+            <a:pPr algn="r" rtl="1"/>
             <a:r>
-              <a:rPr sz="1900" b="1" i="0">
+              <a:rPr sz="1300" b="1">
                 <a:solidFill>
                   <a:srgbClr val="FFFFFF"/>
                 </a:solidFill>
-                <a:latin typeface="Calibri"/>
               </a:rPr>
-              <a:t>صون الخصوصية والبيانات الشخصية</a:t>
+              <a:t>تعزيز الأمان على المنصات التعليمية</a:t>
             </a:r>
           </a:p>
         </p:txBody>
       </p:sp>
       <p:sp>
         <p:nvSpPr>
-          <p:cNvPr id="16" name="TextBox 15"/>
+          <p:cNvPr id="216" name="TextBox 215"/>
           <p:cNvSpPr txBox="1"/>
           <p:nvPr/>
         </p:nvSpPr>
         <p:spPr>
           <a:xfrm>
-            <a:off x="1664208" y="7098030"/>
-            <a:ext cx="7626096" cy="668655"/>
+            <a:off x="1508760" y="4773168"/>
+            <a:ext cx="7589520" cy="292608"/>
           </a:xfrm>
           <a:prstGeom prst="rect">
             <a:avLst/>
@@ -6294,170 +6558,13 @@
           <a:p>
             <a:pPr algn="l"/>
             <a:r>
-              <a:rPr sz="1300" b="0" i="1">
+              <a:rPr sz="1000" b="0">
                 <a:solidFill>
-                  <a:srgbClr val="D0D8E8"/>
+                  <a:srgbClr val="A5BEE1"/>
                 </a:solidFill>
-                <a:latin typeface="Calibri"/>
               </a:rPr>
-              <a:t>Safeguarding personal privacy &amp; data</a:t>
+              <a:t>Enhancing safety on educational platforms</a:t>
             </a:r>
-          </a:p>
-        </p:txBody>
-      </p:sp>
-      <p:sp>
-        <p:nvSpPr>
-          <p:cNvPr id="17" name="Rectangle 16"/>
-          <p:cNvSpPr/>
-          <p:nvPr/>
-        </p:nvSpPr>
-        <p:spPr>
-          <a:xfrm>
-            <a:off x="1243584" y="8250174"/>
-            <a:ext cx="174879" cy="174879"/>
-          </a:xfrm>
-          <a:prstGeom prst="rect">
-            <a:avLst/>
-          </a:prstGeom>
-          <a:solidFill>
-            <a:srgbClr val="C9A84C"/>
-          </a:solidFill>
-          <a:ln>
-            <a:noFill/>
-          </a:ln>
-        </p:spPr>
-        <p:style>
-          <a:lnRef idx="1">
-            <a:schemeClr val="accent1"/>
-          </a:lnRef>
-          <a:fillRef idx="3">
-            <a:schemeClr val="accent1"/>
-          </a:fillRef>
-          <a:effectRef idx="2">
-            <a:schemeClr val="accent1"/>
-          </a:effectRef>
-          <a:fontRef idx="minor">
-            <a:schemeClr val="lt1"/>
-          </a:fontRef>
-        </p:style>
-        <p:txBody>
-          <a:bodyPr rtlCol="0" anchor="ctr"/>
-          <a:lstStyle/>
-          <a:p>
-            <a:pPr algn="ctr"/>
-          </a:p>
-        </p:txBody>
-      </p:sp>
-      <p:sp>
-        <p:nvSpPr>
-          <p:cNvPr id="18" name="TextBox 17"/>
-          <p:cNvSpPr txBox="1"/>
-          <p:nvPr/>
-        </p:nvSpPr>
-        <p:spPr>
-          <a:xfrm>
-            <a:off x="1664208" y="8003286"/>
-            <a:ext cx="7626096" cy="720090"/>
-          </a:xfrm>
-          <a:prstGeom prst="rect">
-            <a:avLst/>
-          </a:prstGeom>
-          <a:noFill/>
-        </p:spPr>
-        <p:txBody>
-          <a:bodyPr wrap="square">
-            <a:spAutoFit/>
-          </a:bodyPr>
-          <a:lstStyle/>
-          <a:p>
-            <a:pPr algn="l"/>
-            <a:r>
-              <a:rPr sz="1900" b="1" i="0">
-                <a:solidFill>
-                  <a:srgbClr val="FFFFFF"/>
-                </a:solidFill>
-                <a:latin typeface="Calibri"/>
-              </a:rPr>
-              <a:t>تعزيز الرقابة والمسؤولية الرقمية</a:t>
-            </a:r>
-          </a:p>
-        </p:txBody>
-      </p:sp>
-      <p:sp>
-        <p:nvSpPr>
-          <p:cNvPr id="19" name="TextBox 18"/>
-          <p:cNvSpPr txBox="1"/>
-          <p:nvPr/>
-        </p:nvSpPr>
-        <p:spPr>
-          <a:xfrm>
-            <a:off x="1664208" y="8692515"/>
-            <a:ext cx="7626096" cy="668655"/>
-          </a:xfrm>
-          <a:prstGeom prst="rect">
-            <a:avLst/>
-          </a:prstGeom>
-          <a:noFill/>
-        </p:spPr>
-        <p:txBody>
-          <a:bodyPr wrap="square">
-            <a:spAutoFit/>
-          </a:bodyPr>
-          <a:lstStyle/>
-          <a:p>
-            <a:pPr algn="l"/>
-            <a:r>
-              <a:rPr sz="1300" b="0" i="1">
-                <a:solidFill>
-                  <a:srgbClr val="D0D8E8"/>
-                </a:solidFill>
-                <a:latin typeface="Calibri"/>
-              </a:rPr>
-              <a:t>Promoting digital oversight &amp; accountability</a:t>
-            </a:r>
-          </a:p>
-        </p:txBody>
-      </p:sp>
-      <p:sp>
-        <p:nvSpPr>
-          <p:cNvPr id="20" name="Rectangle 19"/>
-          <p:cNvSpPr/>
-          <p:nvPr/>
-        </p:nvSpPr>
-        <p:spPr>
-          <a:xfrm>
-            <a:off x="0" y="9690354"/>
-            <a:ext cx="18288000" cy="102870"/>
-          </a:xfrm>
-          <a:prstGeom prst="rect">
-            <a:avLst/>
-          </a:prstGeom>
-          <a:solidFill>
-            <a:srgbClr val="C9A84C"/>
-          </a:solidFill>
-          <a:ln>
-            <a:noFill/>
-          </a:ln>
-        </p:spPr>
-        <p:style>
-          <a:lnRef idx="1">
-            <a:schemeClr val="accent1"/>
-          </a:lnRef>
-          <a:fillRef idx="3">
-            <a:schemeClr val="accent1"/>
-          </a:fillRef>
-          <a:effectRef idx="2">
-            <a:schemeClr val="accent1"/>
-          </a:effectRef>
-          <a:fontRef idx="minor">
-            <a:schemeClr val="lt1"/>
-          </a:fontRef>
-        </p:style>
-        <p:txBody>
-          <a:bodyPr rtlCol="0" anchor="ctr"/>
-          <a:lstStyle/>
-          <a:p>
-            <a:pPr algn="ctr"/>
           </a:p>
         </p:txBody>
       </p:sp>
@@ -6493,59 +6600,203 @@
           <a:chExt cx="0" cy="0"/>
         </a:xfrm>
       </p:grpSpPr>
-      <p:sp>
-        <p:nvSpPr>
-          <p:cNvPr id="2" name="Rectangle 1"/>
+      <p:grpSp>
+        <p:nvGrpSpPr>
+          <p:cNvPr name="Group 2" id="100"/>
+          <p:cNvGrpSpPr/>
+          <p:nvPr/>
+        </p:nvGrpSpPr>
+        <p:grpSpPr>
+          <a:xfrm rot="0">
+            <a:off x="666750" y="666750"/>
+            <a:ext cx="16954500" cy="8953500"/>
+            <a:chOff x="0" y="0"/>
+            <a:chExt cx="5734099" cy="3028120"/>
+          </a:xfrm>
+        </p:grpSpPr>
+        <p:sp>
+          <p:nvSpPr>
+            <p:cNvPr name="Freeform 3" id="3"/>
+            <p:cNvSpPr/>
+            <p:nvPr/>
+          </p:nvSpPr>
+          <p:spPr>
+            <a:xfrm flipH="false" flipV="false" rot="0">
+              <a:off x="52070" y="12700"/>
+              <a:ext cx="5669329" cy="2959540"/>
+            </a:xfrm>
+            <a:custGeom>
+              <a:avLst/>
+              <a:gdLst/>
+              <a:ahLst/>
+              <a:cxnLst/>
+              <a:rect r="r" b="b" t="t" l="l"/>
+              <a:pathLst>
+                <a:path h="2959540" w="5669329">
+                  <a:moveTo>
+                    <a:pt x="5523279" y="2959540"/>
+                  </a:moveTo>
+                  <a:lnTo>
+                    <a:pt x="164850" y="2959540"/>
+                  </a:lnTo>
+                  <a:cubicBezTo>
+                    <a:pt x="66040" y="2959540"/>
+                    <a:pt x="0" y="2893500"/>
+                    <a:pt x="0" y="2813490"/>
+                  </a:cubicBezTo>
+                  <a:lnTo>
+                    <a:pt x="0" y="146050"/>
+                  </a:lnTo>
+                  <a:cubicBezTo>
+                    <a:pt x="0" y="66040"/>
+                    <a:pt x="66040" y="0"/>
+                    <a:pt x="164850" y="0"/>
+                  </a:cubicBezTo>
+                  <a:lnTo>
+                    <a:pt x="5523279" y="0"/>
+                  </a:lnTo>
+                  <a:cubicBezTo>
+                    <a:pt x="5603289" y="0"/>
+                    <a:pt x="5669329" y="66040"/>
+                    <a:pt x="5669329" y="146050"/>
+                  </a:cubicBezTo>
+                  <a:lnTo>
+                    <a:pt x="5669329" y="2813490"/>
+                  </a:lnTo>
+                  <a:cubicBezTo>
+                    <a:pt x="5669329" y="2894770"/>
+                    <a:pt x="5603289" y="2959540"/>
+                    <a:pt x="5523279" y="2959540"/>
+                  </a:cubicBezTo>
+                  <a:close/>
+                </a:path>
+              </a:pathLst>
+            </a:custGeom>
+            <a:solidFill>
+              <a:srgbClr val="021633"/>
+            </a:solidFill>
+          </p:spPr>
+        </p:sp>
+        <p:sp>
+          <p:nvSpPr>
+            <p:cNvPr name="Freeform 4" id="4"/>
+            <p:cNvSpPr/>
+            <p:nvPr/>
+          </p:nvSpPr>
+          <p:spPr>
+            <a:xfrm flipH="false" flipV="false" rot="0">
+              <a:off x="0" y="0"/>
+              <a:ext cx="5734099" cy="3028120"/>
+            </a:xfrm>
+            <a:custGeom>
+              <a:avLst/>
+              <a:gdLst/>
+              <a:ahLst/>
+              <a:cxnLst/>
+              <a:rect r="r" b="b" t="t" l="l"/>
+              <a:pathLst>
+                <a:path h="3028120" w="5734099">
+                  <a:moveTo>
+                    <a:pt x="63500" y="74930"/>
+                  </a:moveTo>
+                  <a:cubicBezTo>
+                    <a:pt x="91440" y="30480"/>
+                    <a:pt x="140970" y="0"/>
+                    <a:pt x="216920" y="0"/>
+                  </a:cubicBezTo>
+                  <a:lnTo>
+                    <a:pt x="5575349" y="0"/>
+                  </a:lnTo>
+                  <a:cubicBezTo>
+                    <a:pt x="5662979" y="0"/>
+                    <a:pt x="5734099" y="71120"/>
+                    <a:pt x="5734099" y="158750"/>
+                  </a:cubicBezTo>
+                  <a:lnTo>
+                    <a:pt x="5734099" y="2826190"/>
+                  </a:lnTo>
+                  <a:cubicBezTo>
+                    <a:pt x="5734099" y="2878260"/>
+                    <a:pt x="5708699" y="2923980"/>
+                    <a:pt x="5670599" y="2953190"/>
+                  </a:cubicBezTo>
+                  <a:cubicBezTo>
+                    <a:pt x="5642659" y="2997640"/>
+                    <a:pt x="5593129" y="3028120"/>
+                    <a:pt x="5535979" y="3028120"/>
+                  </a:cubicBezTo>
+                  <a:lnTo>
+                    <a:pt x="158750" y="3028120"/>
+                  </a:lnTo>
+                  <a:cubicBezTo>
+                    <a:pt x="71120" y="3028120"/>
+                    <a:pt x="0" y="2957000"/>
+                    <a:pt x="0" y="2869370"/>
+                  </a:cubicBezTo>
+                  <a:lnTo>
+                    <a:pt x="0" y="208926"/>
+                  </a:lnTo>
+                  <a:cubicBezTo>
+                    <a:pt x="0" y="149860"/>
+                    <a:pt x="25400" y="104140"/>
+                    <a:pt x="63500" y="74930"/>
+                  </a:cubicBezTo>
+                  <a:close/>
+                  <a:moveTo>
+                    <a:pt x="5721399" y="2826190"/>
+                  </a:moveTo>
+                  <a:lnTo>
+                    <a:pt x="5721399" y="158750"/>
+                  </a:lnTo>
+                  <a:cubicBezTo>
+                    <a:pt x="5721399" y="78740"/>
+                    <a:pt x="5655359" y="12700"/>
+                    <a:pt x="5575349" y="12700"/>
+                  </a:cubicBezTo>
+                  <a:lnTo>
+                    <a:pt x="216920" y="12700"/>
+                  </a:lnTo>
+                  <a:cubicBezTo>
+                    <a:pt x="118110" y="12700"/>
+                    <a:pt x="52070" y="78740"/>
+                    <a:pt x="52070" y="158750"/>
+                  </a:cubicBezTo>
+                  <a:lnTo>
+                    <a:pt x="52070" y="2826190"/>
+                  </a:lnTo>
+                  <a:cubicBezTo>
+                    <a:pt x="52070" y="2906200"/>
+                    <a:pt x="118110" y="2972240"/>
+                    <a:pt x="216920" y="2972240"/>
+                  </a:cubicBezTo>
+                  <a:lnTo>
+                    <a:pt x="5575349" y="2972240"/>
+                  </a:lnTo>
+                  <a:cubicBezTo>
+                    <a:pt x="5655359" y="2972240"/>
+                    <a:pt x="5721399" y="2907470"/>
+                    <a:pt x="5721399" y="2826190"/>
+                  </a:cubicBezTo>
+                  <a:close/>
+                </a:path>
+              </a:pathLst>
+            </a:custGeom>
+            <a:solidFill>
+              <a:srgbClr val="C9A84C"/>
+            </a:solidFill>
+          </p:spPr>
+        </p:sp>
+      </p:grpSp>
+      <p:sp>
+        <p:nvSpPr>
+          <p:cNvPr id="101" name="Rectangle 100"/>
           <p:cNvSpPr/>
           <p:nvPr/>
         </p:nvSpPr>
         <p:spPr>
           <a:xfrm>
             <a:off x="0" y="0"/>
-            <a:ext cx="18288000" cy="10287000"/>
-          </a:xfrm>
-          <a:prstGeom prst="rect">
-            <a:avLst/>
-          </a:prstGeom>
-          <a:solidFill>
-            <a:srgbClr val="1A2A4A"/>
-          </a:solidFill>
-          <a:ln>
-            <a:noFill/>
-          </a:ln>
-        </p:spPr>
-        <p:style>
-          <a:lnRef idx="1">
-            <a:schemeClr val="accent1"/>
-          </a:lnRef>
-          <a:fillRef idx="3">
-            <a:schemeClr val="accent1"/>
-          </a:fillRef>
-          <a:effectRef idx="2">
-            <a:schemeClr val="accent1"/>
-          </a:effectRef>
-          <a:fontRef idx="minor">
-            <a:schemeClr val="lt1"/>
-          </a:fontRef>
-        </p:style>
-        <p:txBody>
-          <a:bodyPr rtlCol="0" anchor="ctr"/>
-          <a:lstStyle/>
-          <a:p>
-            <a:pPr algn="ctr"/>
-          </a:p>
-        </p:txBody>
-      </p:sp>
-      <p:sp>
-        <p:nvSpPr>
-          <p:cNvPr id="3" name="Rectangle 2"/>
-          <p:cNvSpPr/>
-          <p:nvPr/>
-        </p:nvSpPr>
-        <p:spPr>
-          <a:xfrm>
-            <a:off x="0" y="0"/>
-            <a:ext cx="18288000" cy="123444"/>
+            <a:ext cx="18288000" cy="109728"/>
           </a:xfrm>
           <a:prstGeom prst="rect">
             <a:avLst/>
@@ -6581,14 +6832,14 @@
       </p:sp>
       <p:sp>
         <p:nvSpPr>
-          <p:cNvPr id="4" name="TextBox 3"/>
+          <p:cNvPr id="102" name="TextBox 101"/>
           <p:cNvSpPr txBox="1"/>
           <p:nvPr/>
         </p:nvSpPr>
         <p:spPr>
           <a:xfrm>
-            <a:off x="914400" y="308610"/>
-            <a:ext cx="16459200" cy="1028700"/>
+            <a:off x="914400" y="182880"/>
+            <a:ext cx="16459200" cy="566928"/>
           </a:xfrm>
           <a:prstGeom prst="rect">
             <a:avLst/>
@@ -6601,29 +6852,28 @@
           </a:bodyPr>
           <a:lstStyle/>
           <a:p>
-            <a:pPr algn="ctr"/>
+            <a:pPr algn="ctr" rtl="1"/>
             <a:r>
-              <a:rPr sz="2800" b="1" i="0">
+              <a:rPr sz="1900" b="1">
                 <a:solidFill>
                   <a:srgbClr val="C9A84C"/>
                 </a:solidFill>
-                <a:latin typeface="Calibri"/>
               </a:rPr>
-              <a:t>كيف تُجسّد بوابتنا القانون؟</a:t>
+              <a:t>كيف تُجسّد البوابة قانون حماية الطفل الرقمي؟</a:t>
             </a:r>
           </a:p>
         </p:txBody>
       </p:sp>
       <p:sp>
         <p:nvSpPr>
-          <p:cNvPr id="5" name="TextBox 4"/>
+          <p:cNvPr id="103" name="TextBox 102"/>
           <p:cNvSpPr txBox="1"/>
           <p:nvPr/>
         </p:nvSpPr>
         <p:spPr>
           <a:xfrm>
-            <a:off x="914400" y="1285875"/>
-            <a:ext cx="16459200" cy="720090"/>
+            <a:off x="914400" y="749808"/>
+            <a:ext cx="16459200" cy="347472"/>
           </a:xfrm>
           <a:prstGeom prst="rect">
             <a:avLst/>
@@ -6638,35 +6888,34 @@
           <a:p>
             <a:pPr algn="ctr"/>
             <a:r>
-              <a:rPr sz="1600" b="0" i="1">
+              <a:rPr sz="1000" b="0">
                 <a:solidFill>
-                  <a:srgbClr val="D0D8E8"/>
+                  <a:srgbClr val="B4C8E6"/>
                 </a:solidFill>
-                <a:latin typeface="Calibri"/>
               </a:rPr>
-              <a:t>How Our Portal Implements the Law</a:t>
+              <a:t>How the portal implements the Child Digital Safety Law</a:t>
             </a:r>
           </a:p>
         </p:txBody>
       </p:sp>
       <p:pic>
         <p:nvPicPr>
-          <p:cNvPr id="6" name="Picture 5" descr="image.jpg"/>
+          <p:cNvPr id="104" name="Picture 103" descr="img4a.jpg"/>
           <p:cNvPicPr>
             <a:picLocks noChangeAspect="1"/>
           </p:cNvPicPr>
           <p:nvPr/>
         </p:nvPicPr>
         <p:blipFill>
-          <a:blip r:embed="rId2"/>
+          <a:blip r:embed="rId5"/>
           <a:stretch>
             <a:fillRect/>
           </a:stretch>
         </p:blipFill>
         <p:spPr>
           <a:xfrm>
-            <a:off x="603504" y="2211705"/>
-            <a:ext cx="5285232" cy="4815344"/>
+            <a:off x="685800" y="1234440"/>
+            <a:ext cx="5285232" cy="4206240"/>
           </a:xfrm>
           <a:prstGeom prst="rect">
             <a:avLst/>
@@ -6675,59 +6924,14 @@
       </p:pic>
       <p:sp>
         <p:nvSpPr>
-          <p:cNvPr id="7" name="Rectangle 6"/>
+          <p:cNvPr id="105" name="Rectangle 104"/>
           <p:cNvSpPr/>
           <p:nvPr/>
         </p:nvSpPr>
         <p:spPr>
           <a:xfrm>
-            <a:off x="603504" y="5582446"/>
-            <a:ext cx="5285232" cy="1444603"/>
-          </a:xfrm>
-          <a:prstGeom prst="rect">
-            <a:avLst/>
-          </a:prstGeom>
-          <a:solidFill>
-            <a:srgbClr val="223860">
-              <a:alpha val="78000"/>
-            </a:srgbClr>
-          </a:solidFill>
-          <a:ln>
-            <a:noFill/>
-          </a:ln>
-        </p:spPr>
-        <p:style>
-          <a:lnRef idx="1">
-            <a:schemeClr val="accent1"/>
-          </a:lnRef>
-          <a:fillRef idx="3">
-            <a:schemeClr val="accent1"/>
-          </a:fillRef>
-          <a:effectRef idx="2">
-            <a:schemeClr val="accent1"/>
-          </a:effectRef>
-          <a:fontRef idx="minor">
-            <a:schemeClr val="lt1"/>
-          </a:fontRef>
-        </p:style>
-        <p:txBody>
-          <a:bodyPr rtlCol="0" anchor="ctr"/>
-          <a:lstStyle/>
-          <a:p>
-            <a:pPr algn="ctr"/>
-          </a:p>
-        </p:txBody>
-      </p:sp>
-      <p:sp>
-        <p:nvSpPr>
-          <p:cNvPr id="8" name="Rectangle 7"/>
-          <p:cNvSpPr/>
-          <p:nvPr/>
-        </p:nvSpPr>
-        <p:spPr>
-          <a:xfrm>
-            <a:off x="603504" y="7027049"/>
-            <a:ext cx="5285232" cy="2951341"/>
+            <a:off x="685800" y="5440679"/>
+            <a:ext cx="5285232" cy="4709160"/>
           </a:xfrm>
           <a:prstGeom prst="rect">
             <a:avLst/>
@@ -6763,14 +6967,14 @@
       </p:sp>
       <p:sp>
         <p:nvSpPr>
-          <p:cNvPr id="9" name="Rectangle 8"/>
+          <p:cNvPr id="106" name="Rectangle 105"/>
           <p:cNvSpPr/>
           <p:nvPr/>
         </p:nvSpPr>
         <p:spPr>
           <a:xfrm>
-            <a:off x="603504" y="7027049"/>
-            <a:ext cx="5285232" cy="72009"/>
+            <a:off x="685800" y="5440679"/>
+            <a:ext cx="5285232" cy="64008"/>
           </a:xfrm>
           <a:prstGeom prst="rect">
             <a:avLst/>
@@ -6806,14 +7010,14 @@
       </p:sp>
       <p:sp>
         <p:nvSpPr>
-          <p:cNvPr id="10" name="TextBox 9"/>
+          <p:cNvPr id="107" name="TextBox 106"/>
           <p:cNvSpPr txBox="1"/>
           <p:nvPr/>
         </p:nvSpPr>
         <p:spPr>
           <a:xfrm>
-            <a:off x="786384" y="7181354"/>
-            <a:ext cx="4919472" cy="771525"/>
+            <a:off x="777240" y="5550407"/>
+            <a:ext cx="5102352" cy="438912"/>
           </a:xfrm>
           <a:prstGeom prst="rect">
             <a:avLst/>
@@ -6826,29 +7030,28 @@
           </a:bodyPr>
           <a:lstStyle/>
           <a:p>
-            <a:pPr algn="ctr"/>
+            <a:pPr algn="ctr" rtl="1"/>
             <a:r>
-              <a:rPr sz="1900" b="1" i="0">
+              <a:rPr sz="1400" b="1">
                 <a:solidFill>
                   <a:srgbClr val="C9A84C"/>
                 </a:solidFill>
-                <a:latin typeface="Calibri"/>
               </a:rPr>
-              <a:t>حماية البيانات والخصوصية</a:t>
+              <a:t>خصوصية البيانات</a:t>
             </a:r>
           </a:p>
         </p:txBody>
       </p:sp>
       <p:sp>
         <p:nvSpPr>
-          <p:cNvPr id="11" name="TextBox 10"/>
+          <p:cNvPr id="108" name="TextBox 107"/>
           <p:cNvSpPr txBox="1"/>
           <p:nvPr/>
         </p:nvSpPr>
         <p:spPr>
           <a:xfrm>
-            <a:off x="786384" y="7952879"/>
-            <a:ext cx="4919472" cy="565785"/>
+            <a:off x="777240" y="5971031"/>
+            <a:ext cx="5102352" cy="292608"/>
           </a:xfrm>
           <a:prstGeom prst="rect">
             <a:avLst/>
@@ -6863,27 +7066,26 @@
           <a:p>
             <a:pPr algn="ctr"/>
             <a:r>
-              <a:rPr sz="1300" b="0" i="1">
+              <a:rPr sz="900" b="0">
                 <a:solidFill>
-                  <a:srgbClr val="D0D8E8"/>
+                  <a:srgbClr val="B4C8E6"/>
                 </a:solidFill>
-                <a:latin typeface="Calibri"/>
               </a:rPr>
-              <a:t>Data Privacy &amp; Protection</a:t>
+              <a:t>Data Privacy</a:t>
             </a:r>
           </a:p>
         </p:txBody>
       </p:sp>
       <p:sp>
         <p:nvSpPr>
-          <p:cNvPr id="12" name="TextBox 11"/>
+          <p:cNvPr id="109" name="TextBox 108"/>
           <p:cNvSpPr txBox="1"/>
           <p:nvPr/>
         </p:nvSpPr>
         <p:spPr>
           <a:xfrm>
-            <a:off x="786384" y="8518664"/>
-            <a:ext cx="4919472" cy="874395"/>
+            <a:off x="777240" y="6309359"/>
+            <a:ext cx="5102352" cy="777240"/>
           </a:xfrm>
           <a:prstGeom prst="rect">
             <a:avLst/>
@@ -6896,37 +7098,72 @@
           </a:bodyPr>
           <a:lstStyle/>
           <a:p>
-            <a:pPr algn="ctr"/>
+            <a:pPr algn="ctr" rtl="1"/>
             <a:r>
-              <a:rPr sz="1400" b="0" i="0">
+              <a:rPr sz="1100" b="0">
                 <a:solidFill>
                   <a:srgbClr val="FFFFFF"/>
                 </a:solidFill>
-                <a:latin typeface="Calibri"/>
               </a:rPr>
-              <a:t>صلاحيات وكلمات مرور مخصصة لكل دور</a:t>
+              <a:t>بيانات الطلاب محمية
+داخل بيئة مغلقة آمنة</a:t>
+            </a:r>
+          </a:p>
+        </p:txBody>
+      </p:sp>
+      <p:sp>
+        <p:nvSpPr>
+          <p:cNvPr id="110" name="TextBox 109"/>
+          <p:cNvSpPr txBox="1"/>
+          <p:nvPr/>
+        </p:nvSpPr>
+        <p:spPr>
+          <a:xfrm>
+            <a:off x="777240" y="7104888"/>
+            <a:ext cx="5102352" cy="594360"/>
+          </a:xfrm>
+          <a:prstGeom prst="rect">
+            <a:avLst/>
+          </a:prstGeom>
+          <a:noFill/>
+        </p:spPr>
+        <p:txBody>
+          <a:bodyPr wrap="square">
+            <a:spAutoFit/>
+          </a:bodyPr>
+          <a:lstStyle/>
+          <a:p>
+            <a:pPr algn="ctr"/>
+            <a:r>
+              <a:rPr sz="900" b="0">
+                <a:solidFill>
+                  <a:srgbClr val="A0B9DC"/>
+                </a:solidFill>
+              </a:rPr>
+              <a:t>Student data secured
+in a closed environment</a:t>
             </a:r>
           </a:p>
         </p:txBody>
       </p:sp>
       <p:pic>
         <p:nvPicPr>
-          <p:cNvPr id="13" name="Picture 12" descr="image.jpg"/>
+          <p:cNvPr id="111" name="Picture 110" descr="img4b.jpg"/>
           <p:cNvPicPr>
             <a:picLocks noChangeAspect="1"/>
           </p:cNvPicPr>
           <p:nvPr/>
         </p:nvPicPr>
         <p:blipFill>
-          <a:blip r:embed="rId3"/>
+          <a:blip r:embed="rId6"/>
           <a:stretch>
             <a:fillRect/>
           </a:stretch>
         </p:blipFill>
         <p:spPr>
           <a:xfrm>
-            <a:off x="6291072" y="2211705"/>
-            <a:ext cx="5285232" cy="4815344"/>
+            <a:off x="6501384" y="1234440"/>
+            <a:ext cx="5285232" cy="4206240"/>
           </a:xfrm>
           <a:prstGeom prst="rect">
             <a:avLst/>
@@ -6935,59 +7172,14 @@
       </p:pic>
       <p:sp>
         <p:nvSpPr>
-          <p:cNvPr id="14" name="Rectangle 13"/>
+          <p:cNvPr id="112" name="Rectangle 111"/>
           <p:cNvSpPr/>
           <p:nvPr/>
         </p:nvSpPr>
         <p:spPr>
           <a:xfrm>
-            <a:off x="6291072" y="5582446"/>
-            <a:ext cx="5285232" cy="1444603"/>
-          </a:xfrm>
-          <a:prstGeom prst="rect">
-            <a:avLst/>
-          </a:prstGeom>
-          <a:solidFill>
-            <a:srgbClr val="223860">
-              <a:alpha val="78000"/>
-            </a:srgbClr>
-          </a:solidFill>
-          <a:ln>
-            <a:noFill/>
-          </a:ln>
-        </p:spPr>
-        <p:style>
-          <a:lnRef idx="1">
-            <a:schemeClr val="accent1"/>
-          </a:lnRef>
-          <a:fillRef idx="3">
-            <a:schemeClr val="accent1"/>
-          </a:fillRef>
-          <a:effectRef idx="2">
-            <a:schemeClr val="accent1"/>
-          </a:effectRef>
-          <a:fontRef idx="minor">
-            <a:schemeClr val="lt1"/>
-          </a:fontRef>
-        </p:style>
-        <p:txBody>
-          <a:bodyPr rtlCol="0" anchor="ctr"/>
-          <a:lstStyle/>
-          <a:p>
-            <a:pPr algn="ctr"/>
-          </a:p>
-        </p:txBody>
-      </p:sp>
-      <p:sp>
-        <p:nvSpPr>
-          <p:cNvPr id="15" name="Rectangle 14"/>
-          <p:cNvSpPr/>
-          <p:nvPr/>
-        </p:nvSpPr>
-        <p:spPr>
-          <a:xfrm>
-            <a:off x="6291072" y="7027049"/>
-            <a:ext cx="5285232" cy="2951341"/>
+            <a:off x="6501384" y="5440679"/>
+            <a:ext cx="5285232" cy="4709160"/>
           </a:xfrm>
           <a:prstGeom prst="rect">
             <a:avLst/>
@@ -7023,14 +7215,14 @@
       </p:sp>
       <p:sp>
         <p:nvSpPr>
-          <p:cNvPr id="16" name="Rectangle 15"/>
+          <p:cNvPr id="113" name="Rectangle 112"/>
           <p:cNvSpPr/>
           <p:nvPr/>
         </p:nvSpPr>
         <p:spPr>
           <a:xfrm>
-            <a:off x="6291072" y="7027049"/>
-            <a:ext cx="5285232" cy="72009"/>
+            <a:off x="6501384" y="5440679"/>
+            <a:ext cx="5285232" cy="64008"/>
           </a:xfrm>
           <a:prstGeom prst="rect">
             <a:avLst/>
@@ -7066,14 +7258,14 @@
       </p:sp>
       <p:sp>
         <p:nvSpPr>
-          <p:cNvPr id="17" name="TextBox 16"/>
+          <p:cNvPr id="114" name="TextBox 113"/>
           <p:cNvSpPr txBox="1"/>
           <p:nvPr/>
         </p:nvSpPr>
         <p:spPr>
           <a:xfrm>
-            <a:off x="6473952" y="7181354"/>
-            <a:ext cx="4919472" cy="771525"/>
+            <a:off x="6592824" y="5550407"/>
+            <a:ext cx="5102352" cy="438912"/>
           </a:xfrm>
           <a:prstGeom prst="rect">
             <a:avLst/>
@@ -7086,29 +7278,28 @@
           </a:bodyPr>
           <a:lstStyle/>
           <a:p>
-            <a:pPr algn="ctr"/>
+            <a:pPr algn="ctr" rtl="1"/>
             <a:r>
-              <a:rPr sz="1900" b="1" i="0">
+              <a:rPr sz="1400" b="1">
                 <a:solidFill>
                   <a:srgbClr val="C9A84C"/>
                 </a:solidFill>
-                <a:latin typeface="Calibri"/>
               </a:rPr>
-              <a:t>رقابة أولياء الأمور</a:t>
+              <a:t>محتوى موجَّه وآمن</a:t>
             </a:r>
           </a:p>
         </p:txBody>
       </p:sp>
       <p:sp>
         <p:nvSpPr>
-          <p:cNvPr id="18" name="TextBox 17"/>
+          <p:cNvPr id="115" name="TextBox 114"/>
           <p:cNvSpPr txBox="1"/>
           <p:nvPr/>
         </p:nvSpPr>
         <p:spPr>
           <a:xfrm>
-            <a:off x="6473952" y="7952879"/>
-            <a:ext cx="4919472" cy="565785"/>
+            <a:off x="6592824" y="5971031"/>
+            <a:ext cx="5102352" cy="292608"/>
           </a:xfrm>
           <a:prstGeom prst="rect">
             <a:avLst/>
@@ -7123,27 +7314,26 @@
           <a:p>
             <a:pPr algn="ctr"/>
             <a:r>
-              <a:rPr sz="1300" b="0" i="1">
+              <a:rPr sz="900" b="0">
                 <a:solidFill>
-                  <a:srgbClr val="D0D8E8"/>
+                  <a:srgbClr val="B4C8E6"/>
                 </a:solidFill>
-                <a:latin typeface="Calibri"/>
               </a:rPr>
-              <a:t>Parent Monitoring Portal</a:t>
+              <a:t>Safe Guided Content</a:t>
             </a:r>
           </a:p>
         </p:txBody>
       </p:sp>
       <p:sp>
         <p:nvSpPr>
-          <p:cNvPr id="19" name="TextBox 18"/>
+          <p:cNvPr id="116" name="TextBox 115"/>
           <p:cNvSpPr txBox="1"/>
           <p:nvPr/>
         </p:nvSpPr>
         <p:spPr>
           <a:xfrm>
-            <a:off x="6473952" y="8518664"/>
-            <a:ext cx="4919472" cy="874395"/>
+            <a:off x="6592824" y="6309359"/>
+            <a:ext cx="5102352" cy="777240"/>
           </a:xfrm>
           <a:prstGeom prst="rect">
             <a:avLst/>
@@ -7156,37 +7346,72 @@
           </a:bodyPr>
           <a:lstStyle/>
           <a:p>
-            <a:pPr algn="ctr"/>
+            <a:pPr algn="ctr" rtl="1"/>
             <a:r>
-              <a:rPr sz="1400" b="0" i="0">
+              <a:rPr sz="1100" b="0">
                 <a:solidFill>
                   <a:srgbClr val="FFFFFF"/>
                 </a:solidFill>
-                <a:latin typeface="Calibri"/>
               </a:rPr>
-              <a:t>متابعة الأداء الأكاديمي للأبناء</a:t>
+              <a:t>محتوى تعليمي مُصنَّف
+ومراقَب من الإدارة</a:t>
+            </a:r>
+          </a:p>
+        </p:txBody>
+      </p:sp>
+      <p:sp>
+        <p:nvSpPr>
+          <p:cNvPr id="117" name="TextBox 116"/>
+          <p:cNvSpPr txBox="1"/>
+          <p:nvPr/>
+        </p:nvSpPr>
+        <p:spPr>
+          <a:xfrm>
+            <a:off x="6592824" y="7104888"/>
+            <a:ext cx="5102352" cy="594360"/>
+          </a:xfrm>
+          <a:prstGeom prst="rect">
+            <a:avLst/>
+          </a:prstGeom>
+          <a:noFill/>
+        </p:spPr>
+        <p:txBody>
+          <a:bodyPr wrap="square">
+            <a:spAutoFit/>
+          </a:bodyPr>
+          <a:lstStyle/>
+          <a:p>
+            <a:pPr algn="ctr"/>
+            <a:r>
+              <a:rPr sz="900" b="0">
+                <a:solidFill>
+                  <a:srgbClr val="A0B9DC"/>
+                </a:solidFill>
+              </a:rPr>
+              <a:t>Curated educational content
+monitored by administration</a:t>
             </a:r>
           </a:p>
         </p:txBody>
       </p:sp>
       <p:pic>
         <p:nvPicPr>
-          <p:cNvPr id="20" name="Picture 19" descr="image.jpg"/>
+          <p:cNvPr id="118" name="Picture 117" descr="img4c.jpg"/>
           <p:cNvPicPr>
             <a:picLocks noChangeAspect="1"/>
           </p:cNvPicPr>
           <p:nvPr/>
         </p:nvPicPr>
         <p:blipFill>
-          <a:blip r:embed="rId4"/>
+          <a:blip r:embed="rId7"/>
           <a:stretch>
             <a:fillRect/>
           </a:stretch>
         </p:blipFill>
         <p:spPr>
           <a:xfrm>
-            <a:off x="11978640" y="2211705"/>
-            <a:ext cx="5285232" cy="4815344"/>
+            <a:off x="12316968" y="1234440"/>
+            <a:ext cx="5285232" cy="4206240"/>
           </a:xfrm>
           <a:prstGeom prst="rect">
             <a:avLst/>
@@ -7195,59 +7420,14 @@
       </p:pic>
       <p:sp>
         <p:nvSpPr>
-          <p:cNvPr id="21" name="Rectangle 20"/>
+          <p:cNvPr id="119" name="Rectangle 118"/>
           <p:cNvSpPr/>
           <p:nvPr/>
         </p:nvSpPr>
         <p:spPr>
           <a:xfrm>
-            <a:off x="11978640" y="5582446"/>
-            <a:ext cx="5285232" cy="1444603"/>
-          </a:xfrm>
-          <a:prstGeom prst="rect">
-            <a:avLst/>
-          </a:prstGeom>
-          <a:solidFill>
-            <a:srgbClr val="223860">
-              <a:alpha val="78000"/>
-            </a:srgbClr>
-          </a:solidFill>
-          <a:ln>
-            <a:noFill/>
-          </a:ln>
-        </p:spPr>
-        <p:style>
-          <a:lnRef idx="1">
-            <a:schemeClr val="accent1"/>
-          </a:lnRef>
-          <a:fillRef idx="3">
-            <a:schemeClr val="accent1"/>
-          </a:fillRef>
-          <a:effectRef idx="2">
-            <a:schemeClr val="accent1"/>
-          </a:effectRef>
-          <a:fontRef idx="minor">
-            <a:schemeClr val="lt1"/>
-          </a:fontRef>
-        </p:style>
-        <p:txBody>
-          <a:bodyPr rtlCol="0" anchor="ctr"/>
-          <a:lstStyle/>
-          <a:p>
-            <a:pPr algn="ctr"/>
-          </a:p>
-        </p:txBody>
-      </p:sp>
-      <p:sp>
-        <p:nvSpPr>
-          <p:cNvPr id="22" name="Rectangle 21"/>
-          <p:cNvSpPr/>
-          <p:nvPr/>
-        </p:nvSpPr>
-        <p:spPr>
-          <a:xfrm>
-            <a:off x="11978640" y="7027049"/>
-            <a:ext cx="5285232" cy="2951341"/>
+            <a:off x="12316968" y="5440679"/>
+            <a:ext cx="5285232" cy="4709160"/>
           </a:xfrm>
           <a:prstGeom prst="rect">
             <a:avLst/>
@@ -7283,14 +7463,14 @@
       </p:sp>
       <p:sp>
         <p:nvSpPr>
-          <p:cNvPr id="23" name="Rectangle 22"/>
+          <p:cNvPr id="120" name="Rectangle 119"/>
           <p:cNvSpPr/>
           <p:nvPr/>
         </p:nvSpPr>
         <p:spPr>
           <a:xfrm>
-            <a:off x="11978640" y="7027049"/>
-            <a:ext cx="5285232" cy="72009"/>
+            <a:off x="12316968" y="5440679"/>
+            <a:ext cx="5285232" cy="64008"/>
           </a:xfrm>
           <a:prstGeom prst="rect">
             <a:avLst/>
@@ -7326,14 +7506,14 @@
       </p:sp>
       <p:sp>
         <p:nvSpPr>
-          <p:cNvPr id="24" name="TextBox 23"/>
+          <p:cNvPr id="121" name="TextBox 120"/>
           <p:cNvSpPr txBox="1"/>
           <p:nvPr/>
         </p:nvSpPr>
         <p:spPr>
           <a:xfrm>
-            <a:off x="12161520" y="7181354"/>
-            <a:ext cx="4919472" cy="771525"/>
+            <a:off x="12408408" y="5550407"/>
+            <a:ext cx="5102352" cy="438912"/>
           </a:xfrm>
           <a:prstGeom prst="rect">
             <a:avLst/>
@@ -7346,29 +7526,28 @@
           </a:bodyPr>
           <a:lstStyle/>
           <a:p>
-            <a:pPr algn="ctr"/>
+            <a:pPr algn="ctr" rtl="1"/>
             <a:r>
-              <a:rPr sz="1900" b="1" i="0">
+              <a:rPr sz="1400" b="1">
                 <a:solidFill>
                   <a:srgbClr val="C9A84C"/>
                 </a:solidFill>
-                <a:latin typeface="Calibri"/>
               </a:rPr>
-              <a:t>شفافية أكاديمية فورية</a:t>
+              <a:t>تواصل تحت الإشراف</a:t>
             </a:r>
           </a:p>
         </p:txBody>
       </p:sp>
       <p:sp>
         <p:nvSpPr>
-          <p:cNvPr id="25" name="TextBox 24"/>
+          <p:cNvPr id="122" name="TextBox 121"/>
           <p:cNvSpPr txBox="1"/>
           <p:nvPr/>
         </p:nvSpPr>
         <p:spPr>
           <a:xfrm>
-            <a:off x="12161520" y="7952879"/>
-            <a:ext cx="4919472" cy="565785"/>
+            <a:off x="12408408" y="5971031"/>
+            <a:ext cx="5102352" cy="292608"/>
           </a:xfrm>
           <a:prstGeom prst="rect">
             <a:avLst/>
@@ -7383,27 +7562,26 @@
           <a:p>
             <a:pPr algn="ctr"/>
             <a:r>
-              <a:rPr sz="1300" b="0" i="1">
+              <a:rPr sz="900" b="0">
                 <a:solidFill>
-                  <a:srgbClr val="D0D8E8"/>
+                  <a:srgbClr val="B4C8E6"/>
                 </a:solidFill>
-                <a:latin typeface="Calibri"/>
               </a:rPr>
-              <a:t>Instant Academic Transparency</a:t>
+              <a:t>Supervised Communication</a:t>
             </a:r>
           </a:p>
         </p:txBody>
       </p:sp>
       <p:sp>
         <p:nvSpPr>
-          <p:cNvPr id="26" name="TextBox 25"/>
+          <p:cNvPr id="123" name="TextBox 122"/>
           <p:cNvSpPr txBox="1"/>
           <p:nvPr/>
         </p:nvSpPr>
         <p:spPr>
           <a:xfrm>
-            <a:off x="12161520" y="8518664"/>
-            <a:ext cx="4919472" cy="874395"/>
+            <a:off x="12408408" y="6309359"/>
+            <a:ext cx="5102352" cy="777240"/>
           </a:xfrm>
           <a:prstGeom prst="rect">
             <a:avLst/>
@@ -7416,29 +7594,64 @@
           </a:bodyPr>
           <a:lstStyle/>
           <a:p>
-            <a:pPr algn="ctr"/>
+            <a:pPr algn="ctr" rtl="1"/>
             <a:r>
-              <a:rPr sz="1400" b="0" i="0">
+              <a:rPr sz="1100" b="0">
                 <a:solidFill>
                   <a:srgbClr val="FFFFFF"/>
                 </a:solidFill>
-                <a:latin typeface="Calibri"/>
               </a:rPr>
-              <a:t>تقارير وتحليلات في الوقت الفعلي</a:t>
+              <a:t>تواصل المعلم والطالب
+تحت إشراف رسمي</a:t>
             </a:r>
           </a:p>
         </p:txBody>
       </p:sp>
       <p:sp>
         <p:nvSpPr>
-          <p:cNvPr id="27" name="Rectangle 26"/>
+          <p:cNvPr id="124" name="TextBox 123"/>
+          <p:cNvSpPr txBox="1"/>
+          <p:nvPr/>
+        </p:nvSpPr>
+        <p:spPr>
+          <a:xfrm>
+            <a:off x="12408408" y="7104888"/>
+            <a:ext cx="5102352" cy="594360"/>
+          </a:xfrm>
+          <a:prstGeom prst="rect">
+            <a:avLst/>
+          </a:prstGeom>
+          <a:noFill/>
+        </p:spPr>
+        <p:txBody>
+          <a:bodyPr wrap="square">
+            <a:spAutoFit/>
+          </a:bodyPr>
+          <a:lstStyle/>
+          <a:p>
+            <a:pPr algn="ctr"/>
+            <a:r>
+              <a:rPr sz="900" b="0">
+                <a:solidFill>
+                  <a:srgbClr val="A0B9DC"/>
+                </a:solidFill>
+              </a:rPr>
+              <a:t>Teacher-student contact
+under official supervision</a:t>
+            </a:r>
+          </a:p>
+        </p:txBody>
+      </p:sp>
+      <p:sp>
+        <p:nvSpPr>
+          <p:cNvPr id="125" name="Rectangle 124"/>
           <p:cNvSpPr/>
           <p:nvPr/>
         </p:nvSpPr>
         <p:spPr>
           <a:xfrm>
-            <a:off x="0" y="9854946"/>
-            <a:ext cx="18288000" cy="92583"/>
+            <a:off x="0" y="9857232"/>
+            <a:ext cx="18288000" cy="91440"/>
           </a:xfrm>
           <a:prstGeom prst="rect">
             <a:avLst/>
@@ -7469,41 +7682,6 @@
           <a:lstStyle/>
           <a:p>
             <a:pPr algn="ctr"/>
-          </a:p>
-        </p:txBody>
-      </p:sp>
-      <p:sp>
-        <p:nvSpPr>
-          <p:cNvPr id="28" name="TextBox 27"/>
-          <p:cNvSpPr txBox="1"/>
-          <p:nvPr/>
-        </p:nvSpPr>
-        <p:spPr>
-          <a:xfrm>
-            <a:off x="914400" y="9947529"/>
-            <a:ext cx="16459200" cy="411480"/>
-          </a:xfrm>
-          <a:prstGeom prst="rect">
-            <a:avLst/>
-          </a:prstGeom>
-          <a:noFill/>
-        </p:spPr>
-        <p:txBody>
-          <a:bodyPr wrap="square">
-            <a:spAutoFit/>
-          </a:bodyPr>
-          <a:lstStyle/>
-          <a:p>
-            <a:pPr algn="ctr"/>
-            <a:r>
-              <a:rPr sz="1200" b="0" i="0">
-                <a:solidFill>
-                  <a:srgbClr val="C9A84C"/>
-                </a:solidFill>
-                <a:latin typeface="Calibri"/>
-              </a:rPr>
-              <a:t>بوابة مدرسة الجود الرقمية  |  مدرسة حكومية، العين، أبوظبي</a:t>
-            </a:r>
           </a:p>
         </p:txBody>
       </p:sp>

</xml_diff>

<commit_message>
fix: v9 - slides 3&4 redesigned with shapes only, no real photos, matching illustrated theme
</commit_message>
<xml_diff>
--- a/assets/aljood_pitch_with_law.pptx
+++ b/assets/aljood_pitch_with_law.pptx
@@ -5735,7 +5735,7 @@
       </p:grpSpPr>
       <p:grpSp>
         <p:nvGrpSpPr>
-          <p:cNvPr name="Group 2" id="100"/>
+          <p:cNvPr name="Group 2" id="2"/>
           <p:cNvGrpSpPr/>
           <p:nvPr/>
         </p:nvGrpSpPr>
@@ -5922,147 +5922,20 @@
       </p:grpSp>
       <p:sp>
         <p:nvSpPr>
-          <p:cNvPr name="Freeform 5" id="200"/>
+          <p:cNvPr id="5" name="Rectangle 4"/>
           <p:cNvSpPr/>
           <p:nvPr/>
         </p:nvSpPr>
         <p:spPr>
-          <a:xfrm flipH="true" flipV="false" rot="0">
-            <a:off x="10486143" y="2216792"/>
-            <a:ext cx="5696832" cy="5911807"/>
-          </a:xfrm>
-          <a:custGeom>
-            <a:avLst/>
-            <a:gdLst/>
-            <a:ahLst/>
-            <a:cxnLst/>
-            <a:rect r="r" b="b" t="t" l="l"/>
-            <a:pathLst>
-              <a:path h="5911807" w="5696832">
-                <a:moveTo>
-                  <a:pt x="5696832" y="0"/>
-                </a:moveTo>
-                <a:lnTo>
-                  <a:pt x="0" y="0"/>
-                </a:lnTo>
-                <a:lnTo>
-                  <a:pt x="0" y="5911807"/>
-                </a:lnTo>
-                <a:lnTo>
-                  <a:pt x="5696832" y="5911807"/>
-                </a:lnTo>
-                <a:lnTo>
-                  <a:pt x="5696832" y="0"/>
-                </a:lnTo>
-                <a:close/>
-              </a:path>
-            </a:pathLst>
-          </a:custGeom>
-          <a:blipFill>
-            <a:blip r:embed="rId2">
-              <a:extLst>
-                <a:ext uri="{96DAC541-7B7A-43D3-8B79-37D633B846F1}">
-                  <asvg:svgBlip xmlns:asvg="http://schemas.microsoft.com/office/drawing/2016/SVG/main" r:embed="rId3"/>
-                </a:ext>
-              </a:extLst>
-            </a:blip>
-            <a:stretch>
-              <a:fillRect l="0" t="0" r="0" b="0"/>
-            </a:stretch>
-          </a:blipFill>
-          <a:ln cap="sq">
-            <a:noFill/>
-            <a:prstDash val="solid"/>
-            <a:miter/>
-          </a:ln>
-        </p:spPr>
-      </p:sp>
-      <p:sp>
-        <p:nvSpPr>
-          <p:cNvPr name="Freeform 6" id="201"/>
-          <p:cNvSpPr/>
-          <p:nvPr/>
-        </p:nvSpPr>
-        <p:spPr>
-          <a:xfrm flipH="false" flipV="false" rot="0">
-            <a:off x="10546645" y="2306609"/>
-            <a:ext cx="4485772" cy="4485772"/>
-          </a:xfrm>
-          <a:custGeom>
-            <a:avLst/>
-            <a:gdLst/>
-            <a:ahLst/>
-            <a:cxnLst/>
-            <a:rect r="r" b="b" t="t" l="l"/>
-            <a:pathLst>
-              <a:path h="4485772" w="4485772">
-                <a:moveTo>
-                  <a:pt x="0" y="0"/>
-                </a:moveTo>
-                <a:lnTo>
-                  <a:pt x="4485772" y="0"/>
-                </a:lnTo>
-                <a:lnTo>
-                  <a:pt x="4485772" y="4485772"/>
-                </a:lnTo>
-                <a:lnTo>
-                  <a:pt x="0" y="4485772"/>
-                </a:lnTo>
-                <a:lnTo>
-                  <a:pt x="0" y="0"/>
-                </a:lnTo>
-                <a:close/>
-              </a:path>
-            </a:pathLst>
-          </a:custGeom>
-          <a:blipFill>
-            <a:blip r:embed="rId4"/>
-            <a:stretch>
-              <a:fillRect l="0" t="0" r="0" b="0"/>
-            </a:stretch>
-          </a:blipFill>
-        </p:spPr>
-      </p:sp>
-      <p:pic>
-        <p:nvPicPr>
-          <p:cNvPr id="202" name="Picture 201" descr="img3.jpg"/>
-          <p:cNvPicPr>
-            <a:picLocks noChangeAspect="1"/>
-          </p:cNvPicPr>
-          <p:nvPr/>
-        </p:nvPicPr>
-        <p:blipFill>
-          <a:blip r:embed="rId3"/>
-          <a:stretch>
-            <a:fillRect/>
-          </a:stretch>
-        </p:blipFill>
-        <p:spPr>
           <a:xfrm>
-            <a:off x="10543032" y="2304288"/>
-            <a:ext cx="4489704" cy="4489704"/>
-          </a:xfrm>
-          <a:prstGeom prst="rect">
-            <a:avLst/>
-          </a:prstGeom>
-        </p:spPr>
-      </p:pic>
-      <p:sp>
-        <p:nvSpPr>
-          <p:cNvPr id="203" name="Rectangle 202"/>
-          <p:cNvSpPr/>
-          <p:nvPr/>
-        </p:nvSpPr>
-        <p:spPr>
-          <a:xfrm>
-            <a:off x="1243584" y="923544"/>
-            <a:ext cx="3840480" cy="457200"/>
+            <a:off x="0" y="0"/>
+            <a:ext cx="18288000" cy="10287000"/>
           </a:xfrm>
           <a:prstGeom prst="rect">
             <a:avLst/>
           </a:prstGeom>
           <a:solidFill>
-            <a:srgbClr val="C9A84C"/>
+            <a:srgbClr val="1A2A4A"/>
           </a:solidFill>
           <a:ln>
             <a:noFill/>
@@ -6092,116 +5965,14 @@
       </p:sp>
       <p:sp>
         <p:nvSpPr>
-          <p:cNvPr id="204" name="TextBox 203"/>
-          <p:cNvSpPr txBox="1"/>
+          <p:cNvPr id="6" name="Rectangle 5"/>
+          <p:cNvSpPr/>
           <p:nvPr/>
         </p:nvSpPr>
         <p:spPr>
           <a:xfrm>
-            <a:off x="1243584" y="932688"/>
-            <a:ext cx="3840480" cy="438912"/>
-          </a:xfrm>
-          <a:prstGeom prst="rect">
-            <a:avLst/>
-          </a:prstGeom>
-          <a:noFill/>
-        </p:spPr>
-        <p:txBody>
-          <a:bodyPr wrap="square">
-            <a:spAutoFit/>
-          </a:bodyPr>
-          <a:lstStyle/>
-          <a:p>
-            <a:pPr algn="ctr"/>
-            <a:r>
-              <a:rPr sz="1100" b="1">
-                <a:solidFill>
-                  <a:srgbClr val="021633"/>
-                </a:solidFill>
-              </a:rPr>
-              <a:t>مرسوم اتحادي | يناير 2026</a:t>
-            </a:r>
-          </a:p>
-        </p:txBody>
-      </p:sp>
-      <p:sp>
-        <p:nvSpPr>
-          <p:cNvPr id="205" name="TextBox 204"/>
-          <p:cNvSpPr txBox="1"/>
-          <p:nvPr/>
-        </p:nvSpPr>
-        <p:spPr>
-          <a:xfrm>
-            <a:off x="1243584" y="1554480"/>
-            <a:ext cx="8686800" cy="502920"/>
-          </a:xfrm>
-          <a:prstGeom prst="rect">
-            <a:avLst/>
-          </a:prstGeom>
-          <a:noFill/>
-        </p:spPr>
-        <p:txBody>
-          <a:bodyPr wrap="square">
-            <a:spAutoFit/>
-          </a:bodyPr>
-          <a:lstStyle/>
-          <a:p>
-            <a:pPr algn="r" rtl="1"/>
-            <a:r>
-              <a:rPr sz="2200" b="1">
-                <a:solidFill>
-                  <a:srgbClr val="C9A84C"/>
-                </a:solidFill>
-              </a:rPr>
-              <a:t>قانون حماية الطفل الرقمي</a:t>
-            </a:r>
-          </a:p>
-        </p:txBody>
-      </p:sp>
-      <p:sp>
-        <p:nvSpPr>
-          <p:cNvPr id="206" name="TextBox 205"/>
-          <p:cNvSpPr txBox="1"/>
-          <p:nvPr/>
-        </p:nvSpPr>
-        <p:spPr>
-          <a:xfrm>
-            <a:off x="1243584" y="2057400"/>
-            <a:ext cx="8686800" cy="365760"/>
-          </a:xfrm>
-          <a:prstGeom prst="rect">
-            <a:avLst/>
-          </a:prstGeom>
-          <a:noFill/>
-        </p:spPr>
-        <p:txBody>
-          <a:bodyPr wrap="square">
-            <a:spAutoFit/>
-          </a:bodyPr>
-          <a:lstStyle/>
-          <a:p>
-            <a:pPr algn="l"/>
-            <a:r>
-              <a:rPr sz="1200" b="0">
-                <a:solidFill>
-                  <a:srgbClr val="B4C8E6"/>
-                </a:solidFill>
-              </a:rPr>
-              <a:t>Child Digital Safety Law</a:t>
-            </a:r>
-          </a:p>
-        </p:txBody>
-      </p:sp>
-      <p:sp>
-        <p:nvSpPr>
-          <p:cNvPr id="207" name="Rectangle 206"/>
-          <p:cNvSpPr/>
-          <p:nvPr/>
-        </p:nvSpPr>
-        <p:spPr>
-          <a:xfrm>
-            <a:off x="1243584" y="2560320"/>
-            <a:ext cx="7772400" cy="36576"/>
+            <a:off x="0" y="0"/>
+            <a:ext cx="18288000" cy="73152"/>
           </a:xfrm>
           <a:prstGeom prst="rect">
             <a:avLst/>
@@ -6237,14 +6008,84 @@
       </p:sp>
       <p:sp>
         <p:nvSpPr>
-          <p:cNvPr id="208" name="Rectangle 207"/>
+          <p:cNvPr id="7" name="TextBox 6"/>
+          <p:cNvSpPr txBox="1"/>
+          <p:nvPr/>
+        </p:nvSpPr>
+        <p:spPr>
+          <a:xfrm>
+            <a:off x="914400" y="228600"/>
+            <a:ext cx="16459200" cy="640080"/>
+          </a:xfrm>
+          <a:prstGeom prst="rect">
+            <a:avLst/>
+          </a:prstGeom>
+          <a:noFill/>
+        </p:spPr>
+        <p:txBody>
+          <a:bodyPr wrap="square">
+            <a:spAutoFit/>
+          </a:bodyPr>
+          <a:lstStyle/>
+          <a:p>
+            <a:pPr algn="ctr" rtl="1"/>
+            <a:r>
+              <a:rPr sz="2800" b="1">
+                <a:solidFill>
+                  <a:srgbClr val="C9A84C"/>
+                </a:solidFill>
+                <a:latin typeface="Noto Sans Arabic"/>
+              </a:rPr>
+              <a:t>قانون حماية الطفل الرقمي</a:t>
+            </a:r>
+          </a:p>
+        </p:txBody>
+      </p:sp>
+      <p:sp>
+        <p:nvSpPr>
+          <p:cNvPr id="8" name="TextBox 7"/>
+          <p:cNvSpPr txBox="1"/>
+          <p:nvPr/>
+        </p:nvSpPr>
+        <p:spPr>
+          <a:xfrm>
+            <a:off x="914400" y="804672"/>
+            <a:ext cx="16459200" cy="365760"/>
+          </a:xfrm>
+          <a:prstGeom prst="rect">
+            <a:avLst/>
+          </a:prstGeom>
+          <a:noFill/>
+        </p:spPr>
+        <p:txBody>
+          <a:bodyPr wrap="square">
+            <a:spAutoFit/>
+          </a:bodyPr>
+          <a:lstStyle/>
+          <a:p>
+            <a:pPr algn="ctr" rtl="1"/>
+            <a:r>
+              <a:rPr sz="1300" b="0">
+                <a:solidFill>
+                  <a:srgbClr val="FFFFFF"/>
+                </a:solidFill>
+                <a:latin typeface="Noto Sans Arabic"/>
+              </a:rPr>
+              <a:t>UAE Child Digital Safety Law — Federal Decree No. 2 of 2026</a:t>
+            </a:r>
+          </a:p>
+        </p:txBody>
+      </p:sp>
+      <p:sp>
+        <p:nvSpPr>
+          <p:cNvPr id="9" name="Rectangle 8"/>
           <p:cNvSpPr/>
           <p:nvPr/>
         </p:nvSpPr>
         <p:spPr>
           <a:xfrm>
-            <a:off x="1243584" y="2880360"/>
-            <a:ext cx="137160" cy="137160"/>
+            <a:off x="914400" y="1170432"/>
+            <a:ext cx="16459200" cy="27432"/>
           </a:xfrm>
           <a:prstGeom prst="rect">
             <a:avLst/>
@@ -6280,91 +6121,27 @@
       </p:sp>
       <p:sp>
         <p:nvSpPr>
-          <p:cNvPr id="209" name="TextBox 208"/>
-          <p:cNvSpPr txBox="1"/>
+          <p:cNvPr id="10" name="Rounded Rectangle 9"/>
+          <p:cNvSpPr/>
           <p:nvPr/>
         </p:nvSpPr>
         <p:spPr>
           <a:xfrm>
-            <a:off x="1508760" y="2788920"/>
-            <a:ext cx="7589520" cy="347472"/>
-          </a:xfrm>
-          <a:prstGeom prst="rect">
-            <a:avLst/>
-          </a:prstGeom>
-          <a:noFill/>
-        </p:spPr>
-        <p:txBody>
-          <a:bodyPr wrap="square">
-            <a:spAutoFit/>
-          </a:bodyPr>
-          <a:lstStyle/>
-          <a:p>
-            <a:pPr algn="r" rtl="1"/>
-            <a:r>
-              <a:rPr sz="1300" b="1">
-                <a:solidFill>
-                  <a:srgbClr val="FFFFFF"/>
-                </a:solidFill>
-              </a:rPr>
-              <a:t>حماية الخصوصية الرقمية للطفل</a:t>
-            </a:r>
-          </a:p>
-        </p:txBody>
-      </p:sp>
-      <p:sp>
-        <p:nvSpPr>
-          <p:cNvPr id="210" name="TextBox 209"/>
-          <p:cNvSpPr txBox="1"/>
-          <p:nvPr/>
-        </p:nvSpPr>
-        <p:spPr>
-          <a:xfrm>
-            <a:off x="1508760" y="3127248"/>
-            <a:ext cx="7589520" cy="292608"/>
-          </a:xfrm>
-          <a:prstGeom prst="rect">
-            <a:avLst/>
-          </a:prstGeom>
-          <a:noFill/>
-        </p:spPr>
-        <p:txBody>
-          <a:bodyPr wrap="square">
-            <a:spAutoFit/>
-          </a:bodyPr>
-          <a:lstStyle/>
-          <a:p>
-            <a:pPr algn="l"/>
-            <a:r>
-              <a:rPr sz="1000" b="0">
-                <a:solidFill>
-                  <a:srgbClr val="A5BEE1"/>
-                </a:solidFill>
-              </a:rPr>
-              <a:t>Protecting children's digital privacy</a:t>
-            </a:r>
-          </a:p>
-        </p:txBody>
-      </p:sp>
-      <p:sp>
-        <p:nvSpPr>
-          <p:cNvPr id="211" name="Rectangle 210"/>
-          <p:cNvSpPr/>
-          <p:nvPr/>
-        </p:nvSpPr>
-        <p:spPr>
-          <a:xfrm>
-            <a:off x="1243584" y="3703320"/>
-            <a:ext cx="137160" cy="137160"/>
-          </a:xfrm>
-          <a:prstGeom prst="rect">
-            <a:avLst/>
+            <a:off x="1234440" y="1325880"/>
+            <a:ext cx="5029200" cy="2377440"/>
+          </a:xfrm>
+          <a:prstGeom prst="roundRect">
+            <a:avLst>
+              <a:gd name="adj" fmla="val 4000"/>
+            </a:avLst>
           </a:prstGeom>
           <a:solidFill>
-            <a:srgbClr val="C9A84C"/>
+            <a:srgbClr val="223A5E"/>
           </a:solidFill>
-          <a:ln>
-            <a:noFill/>
+          <a:ln w="19050">
+            <a:solidFill>
+              <a:srgbClr val="C9A84C"/>
+            </a:solidFill>
           </a:ln>
         </p:spPr>
         <p:style>
@@ -6391,82 +6168,14 @@
       </p:sp>
       <p:sp>
         <p:nvSpPr>
-          <p:cNvPr id="212" name="TextBox 211"/>
-          <p:cNvSpPr txBox="1"/>
+          <p:cNvPr id="11" name="Rectangle 10"/>
+          <p:cNvSpPr/>
           <p:nvPr/>
         </p:nvSpPr>
         <p:spPr>
           <a:xfrm>
-            <a:off x="1508760" y="3611879"/>
-            <a:ext cx="7589520" cy="347472"/>
-          </a:xfrm>
-          <a:prstGeom prst="rect">
-            <a:avLst/>
-          </a:prstGeom>
-          <a:noFill/>
-        </p:spPr>
-        <p:txBody>
-          <a:bodyPr wrap="square">
-            <a:spAutoFit/>
-          </a:bodyPr>
-          <a:lstStyle/>
-          <a:p>
-            <a:pPr algn="r" rtl="1"/>
-            <a:r>
-              <a:rPr sz="1300" b="1">
-                <a:solidFill>
-                  <a:srgbClr val="FFFFFF"/>
-                </a:solidFill>
-              </a:rPr>
-              <a:t>تنظيم المحتوى الإلكتروني الموجَّه</a:t>
-            </a:r>
-          </a:p>
-        </p:txBody>
-      </p:sp>
-      <p:sp>
-        <p:nvSpPr>
-          <p:cNvPr id="213" name="TextBox 212"/>
-          <p:cNvSpPr txBox="1"/>
-          <p:nvPr/>
-        </p:nvSpPr>
-        <p:spPr>
-          <a:xfrm>
-            <a:off x="1508760" y="3950207"/>
-            <a:ext cx="7589520" cy="292608"/>
-          </a:xfrm>
-          <a:prstGeom prst="rect">
-            <a:avLst/>
-          </a:prstGeom>
-          <a:noFill/>
-        </p:spPr>
-        <p:txBody>
-          <a:bodyPr wrap="square">
-            <a:spAutoFit/>
-          </a:bodyPr>
-          <a:lstStyle/>
-          <a:p>
-            <a:pPr algn="l"/>
-            <a:r>
-              <a:rPr sz="1000" b="0">
-                <a:solidFill>
-                  <a:srgbClr val="A5BEE1"/>
-                </a:solidFill>
-              </a:rPr>
-              <a:t>Regulating directed digital content</a:t>
-            </a:r>
-          </a:p>
-        </p:txBody>
-      </p:sp>
-      <p:sp>
-        <p:nvSpPr>
-          <p:cNvPr id="214" name="Rectangle 213"/>
-          <p:cNvSpPr/>
-          <p:nvPr/>
-        </p:nvSpPr>
-        <p:spPr>
-          <a:xfrm>
-            <a:off x="1243584" y="4526279"/>
-            <a:ext cx="137160" cy="137160"/>
+            <a:off x="1234440" y="1325880"/>
+            <a:ext cx="5029200" cy="73152"/>
           </a:xfrm>
           <a:prstGeom prst="rect">
             <a:avLst/>
@@ -6502,14 +6211,57 @@
       </p:sp>
       <p:sp>
         <p:nvSpPr>
-          <p:cNvPr id="215" name="TextBox 214"/>
+          <p:cNvPr id="12" name="Oval 11"/>
+          <p:cNvSpPr/>
+          <p:nvPr/>
+        </p:nvSpPr>
+        <p:spPr>
+          <a:xfrm>
+            <a:off x="1417320" y="1463040"/>
+            <a:ext cx="685800" cy="685800"/>
+          </a:xfrm>
+          <a:prstGeom prst="ellipse">
+            <a:avLst/>
+          </a:prstGeom>
+          <a:solidFill>
+            <a:srgbClr val="C9A84C"/>
+          </a:solidFill>
+          <a:ln>
+            <a:noFill/>
+          </a:ln>
+        </p:spPr>
+        <p:style>
+          <a:lnRef idx="1">
+            <a:schemeClr val="accent1"/>
+          </a:lnRef>
+          <a:fillRef idx="3">
+            <a:schemeClr val="accent1"/>
+          </a:fillRef>
+          <a:effectRef idx="2">
+            <a:schemeClr val="accent1"/>
+          </a:effectRef>
+          <a:fontRef idx="minor">
+            <a:schemeClr val="lt1"/>
+          </a:fontRef>
+        </p:style>
+        <p:txBody>
+          <a:bodyPr rtlCol="0" anchor="ctr"/>
+          <a:lstStyle/>
+          <a:p>
+            <a:pPr algn="ctr"/>
+          </a:p>
+        </p:txBody>
+      </p:sp>
+      <p:sp>
+        <p:nvSpPr>
+          <p:cNvPr id="13" name="TextBox 12"/>
           <p:cNvSpPr txBox="1"/>
           <p:nvPr/>
         </p:nvSpPr>
         <p:spPr>
           <a:xfrm>
-            <a:off x="1508760" y="4434840"/>
-            <a:ext cx="7589520" cy="347472"/>
+            <a:off x="1417320" y="1490472"/>
+            <a:ext cx="685800" cy="548640"/>
           </a:xfrm>
           <a:prstGeom prst="rect">
             <a:avLst/>
@@ -6522,28 +6274,29 @@
           </a:bodyPr>
           <a:lstStyle/>
           <a:p>
-            <a:pPr algn="r" rtl="1"/>
+            <a:pPr algn="ctr" rtl="1"/>
             <a:r>
-              <a:rPr sz="1300" b="1">
+              <a:rPr sz="1600" b="1">
                 <a:solidFill>
-                  <a:srgbClr val="FFFFFF"/>
+                  <a:srgbClr val="1A2A4A"/>
                 </a:solidFill>
+                <a:latin typeface="Noto Sans Arabic"/>
               </a:rPr>
-              <a:t>تعزيز الأمان على المنصات التعليمية</a:t>
+              <a:t>1</a:t>
             </a:r>
           </a:p>
         </p:txBody>
       </p:sp>
       <p:sp>
         <p:nvSpPr>
-          <p:cNvPr id="216" name="TextBox 215"/>
+          <p:cNvPr id="14" name="TextBox 13"/>
           <p:cNvSpPr txBox="1"/>
           <p:nvPr/>
         </p:nvSpPr>
         <p:spPr>
           <a:xfrm>
-            <a:off x="1508760" y="4773168"/>
-            <a:ext cx="7589520" cy="292608"/>
+            <a:off x="2194560" y="1435608"/>
+            <a:ext cx="3977640" cy="411480"/>
           </a:xfrm>
           <a:prstGeom prst="rect">
             <a:avLst/>
@@ -6556,15 +6309,1391 @@
           </a:bodyPr>
           <a:lstStyle/>
           <a:p>
-            <a:pPr algn="l"/>
+            <a:pPr algn="r" rtl="1"/>
+            <a:r>
+              <a:rPr sz="1600" b="1">
+                <a:solidFill>
+                  <a:srgbClr val="C9A84C"/>
+                </a:solidFill>
+                <a:latin typeface="Noto Sans Arabic"/>
+              </a:rPr>
+              <a:t>حماية البيانات</a:t>
+            </a:r>
+          </a:p>
+        </p:txBody>
+      </p:sp>
+      <p:sp>
+        <p:nvSpPr>
+          <p:cNvPr id="15" name="TextBox 14"/>
+          <p:cNvSpPr txBox="1"/>
+          <p:nvPr/>
+        </p:nvSpPr>
+        <p:spPr>
+          <a:xfrm>
+            <a:off x="1325880" y="1828800"/>
+            <a:ext cx="4846320" cy="274320"/>
+          </a:xfrm>
+          <a:prstGeom prst="rect">
+            <a:avLst/>
+          </a:prstGeom>
+          <a:noFill/>
+        </p:spPr>
+        <p:txBody>
+          <a:bodyPr wrap="square">
+            <a:spAutoFit/>
+          </a:bodyPr>
+          <a:lstStyle/>
+          <a:p>
+            <a:pPr algn="r"/>
             <a:r>
               <a:rPr sz="1000" b="0">
                 <a:solidFill>
-                  <a:srgbClr val="A5BEE1"/>
+                  <a:srgbClr val="CCCCCC"/>
                 </a:solidFill>
+                <a:latin typeface="Noto Sans Arabic"/>
               </a:rPr>
-              <a:t>Enhancing safety on educational platforms</a:t>
+              <a:t>Data Privacy</a:t>
             </a:r>
+          </a:p>
+        </p:txBody>
+      </p:sp>
+      <p:sp>
+        <p:nvSpPr>
+          <p:cNvPr id="16" name="Rectangle 15"/>
+          <p:cNvSpPr/>
+          <p:nvPr/>
+        </p:nvSpPr>
+        <p:spPr>
+          <a:xfrm>
+            <a:off x="1371600" y="2148840"/>
+            <a:ext cx="4754880" cy="18288"/>
+          </a:xfrm>
+          <a:prstGeom prst="rect">
+            <a:avLst/>
+          </a:prstGeom>
+          <a:solidFill>
+            <a:srgbClr val="C9A84C"/>
+          </a:solidFill>
+          <a:ln>
+            <a:noFill/>
+          </a:ln>
+        </p:spPr>
+        <p:style>
+          <a:lnRef idx="1">
+            <a:schemeClr val="accent1"/>
+          </a:lnRef>
+          <a:fillRef idx="3">
+            <a:schemeClr val="accent1"/>
+          </a:fillRef>
+          <a:effectRef idx="2">
+            <a:schemeClr val="accent1"/>
+          </a:effectRef>
+          <a:fontRef idx="minor">
+            <a:schemeClr val="lt1"/>
+          </a:fontRef>
+        </p:style>
+        <p:txBody>
+          <a:bodyPr rtlCol="0" anchor="ctr"/>
+          <a:lstStyle/>
+          <a:p>
+            <a:pPr algn="ctr"/>
+          </a:p>
+        </p:txBody>
+      </p:sp>
+      <p:sp>
+        <p:nvSpPr>
+          <p:cNvPr id="17" name="TextBox 16"/>
+          <p:cNvSpPr txBox="1"/>
+          <p:nvPr/>
+        </p:nvSpPr>
+        <p:spPr>
+          <a:xfrm>
+            <a:off x="1325880" y="2240280"/>
+            <a:ext cx="4846320" cy="640080"/>
+          </a:xfrm>
+          <a:prstGeom prst="rect">
+            <a:avLst/>
+          </a:prstGeom>
+          <a:noFill/>
+        </p:spPr>
+        <p:txBody>
+          <a:bodyPr wrap="square">
+            <a:spAutoFit/>
+          </a:bodyPr>
+          <a:lstStyle/>
+          <a:p>
+            <a:pPr algn="r" rtl="1"/>
+            <a:r>
+              <a:rPr sz="1300" b="0">
+                <a:solidFill>
+                  <a:srgbClr val="FFFFFF"/>
+                </a:solidFill>
+                <a:latin typeface="Noto Sans Arabic"/>
+              </a:rPr>
+              <a:t>بيانات الطلاب
+محمية ومشفّرة</a:t>
+            </a:r>
+          </a:p>
+        </p:txBody>
+      </p:sp>
+      <p:sp>
+        <p:nvSpPr>
+          <p:cNvPr id="18" name="TextBox 17"/>
+          <p:cNvSpPr txBox="1"/>
+          <p:nvPr/>
+        </p:nvSpPr>
+        <p:spPr>
+          <a:xfrm>
+            <a:off x="1325880" y="2926080"/>
+            <a:ext cx="4846320" cy="502920"/>
+          </a:xfrm>
+          <a:prstGeom prst="rect">
+            <a:avLst/>
+          </a:prstGeom>
+          <a:noFill/>
+        </p:spPr>
+        <p:txBody>
+          <a:bodyPr wrap="square">
+            <a:spAutoFit/>
+          </a:bodyPr>
+          <a:lstStyle/>
+          <a:p>
+            <a:pPr algn="r"/>
+            <a:r>
+              <a:rPr sz="1000" b="0">
+                <a:solidFill>
+                  <a:srgbClr val="BBBBBB"/>
+                </a:solidFill>
+                <a:latin typeface="Noto Sans Arabic"/>
+              </a:rPr>
+              <a:t>Student data
+encrypted &amp; protected</a:t>
+            </a:r>
+          </a:p>
+        </p:txBody>
+      </p:sp>
+      <p:sp>
+        <p:nvSpPr>
+          <p:cNvPr id="19" name="Rounded Rectangle 18"/>
+          <p:cNvSpPr/>
+          <p:nvPr/>
+        </p:nvSpPr>
+        <p:spPr>
+          <a:xfrm>
+            <a:off x="6629400" y="1325880"/>
+            <a:ext cx="5029200" cy="2377440"/>
+          </a:xfrm>
+          <a:prstGeom prst="roundRect">
+            <a:avLst>
+              <a:gd name="adj" fmla="val 4000"/>
+            </a:avLst>
+          </a:prstGeom>
+          <a:solidFill>
+            <a:srgbClr val="223A5E"/>
+          </a:solidFill>
+          <a:ln w="19050">
+            <a:solidFill>
+              <a:srgbClr val="C9A84C"/>
+            </a:solidFill>
+          </a:ln>
+        </p:spPr>
+        <p:style>
+          <a:lnRef idx="1">
+            <a:schemeClr val="accent1"/>
+          </a:lnRef>
+          <a:fillRef idx="3">
+            <a:schemeClr val="accent1"/>
+          </a:fillRef>
+          <a:effectRef idx="2">
+            <a:schemeClr val="accent1"/>
+          </a:effectRef>
+          <a:fontRef idx="minor">
+            <a:schemeClr val="lt1"/>
+          </a:fontRef>
+        </p:style>
+        <p:txBody>
+          <a:bodyPr rtlCol="0" anchor="ctr"/>
+          <a:lstStyle/>
+          <a:p>
+            <a:pPr algn="ctr"/>
+          </a:p>
+        </p:txBody>
+      </p:sp>
+      <p:sp>
+        <p:nvSpPr>
+          <p:cNvPr id="20" name="Rectangle 19"/>
+          <p:cNvSpPr/>
+          <p:nvPr/>
+        </p:nvSpPr>
+        <p:spPr>
+          <a:xfrm>
+            <a:off x="6629400" y="1325880"/>
+            <a:ext cx="5029200" cy="73152"/>
+          </a:xfrm>
+          <a:prstGeom prst="rect">
+            <a:avLst/>
+          </a:prstGeom>
+          <a:solidFill>
+            <a:srgbClr val="C9A84C"/>
+          </a:solidFill>
+          <a:ln>
+            <a:noFill/>
+          </a:ln>
+        </p:spPr>
+        <p:style>
+          <a:lnRef idx="1">
+            <a:schemeClr val="accent1"/>
+          </a:lnRef>
+          <a:fillRef idx="3">
+            <a:schemeClr val="accent1"/>
+          </a:fillRef>
+          <a:effectRef idx="2">
+            <a:schemeClr val="accent1"/>
+          </a:effectRef>
+          <a:fontRef idx="minor">
+            <a:schemeClr val="lt1"/>
+          </a:fontRef>
+        </p:style>
+        <p:txBody>
+          <a:bodyPr rtlCol="0" anchor="ctr"/>
+          <a:lstStyle/>
+          <a:p>
+            <a:pPr algn="ctr"/>
+          </a:p>
+        </p:txBody>
+      </p:sp>
+      <p:sp>
+        <p:nvSpPr>
+          <p:cNvPr id="21" name="Oval 20"/>
+          <p:cNvSpPr/>
+          <p:nvPr/>
+        </p:nvSpPr>
+        <p:spPr>
+          <a:xfrm>
+            <a:off x="6812280" y="1463040"/>
+            <a:ext cx="685800" cy="685800"/>
+          </a:xfrm>
+          <a:prstGeom prst="ellipse">
+            <a:avLst/>
+          </a:prstGeom>
+          <a:solidFill>
+            <a:srgbClr val="C9A84C"/>
+          </a:solidFill>
+          <a:ln>
+            <a:noFill/>
+          </a:ln>
+        </p:spPr>
+        <p:style>
+          <a:lnRef idx="1">
+            <a:schemeClr val="accent1"/>
+          </a:lnRef>
+          <a:fillRef idx="3">
+            <a:schemeClr val="accent1"/>
+          </a:fillRef>
+          <a:effectRef idx="2">
+            <a:schemeClr val="accent1"/>
+          </a:effectRef>
+          <a:fontRef idx="minor">
+            <a:schemeClr val="lt1"/>
+          </a:fontRef>
+        </p:style>
+        <p:txBody>
+          <a:bodyPr rtlCol="0" anchor="ctr"/>
+          <a:lstStyle/>
+          <a:p>
+            <a:pPr algn="ctr"/>
+          </a:p>
+        </p:txBody>
+      </p:sp>
+      <p:sp>
+        <p:nvSpPr>
+          <p:cNvPr id="22" name="TextBox 21"/>
+          <p:cNvSpPr txBox="1"/>
+          <p:nvPr/>
+        </p:nvSpPr>
+        <p:spPr>
+          <a:xfrm>
+            <a:off x="6812280" y="1490472"/>
+            <a:ext cx="685800" cy="548640"/>
+          </a:xfrm>
+          <a:prstGeom prst="rect">
+            <a:avLst/>
+          </a:prstGeom>
+          <a:noFill/>
+        </p:spPr>
+        <p:txBody>
+          <a:bodyPr wrap="square">
+            <a:spAutoFit/>
+          </a:bodyPr>
+          <a:lstStyle/>
+          <a:p>
+            <a:pPr algn="ctr" rtl="1"/>
+            <a:r>
+              <a:rPr sz="1600" b="1">
+                <a:solidFill>
+                  <a:srgbClr val="1A2A4A"/>
+                </a:solidFill>
+                <a:latin typeface="Noto Sans Arabic"/>
+              </a:rPr>
+              <a:t>2</a:t>
+            </a:r>
+          </a:p>
+        </p:txBody>
+      </p:sp>
+      <p:sp>
+        <p:nvSpPr>
+          <p:cNvPr id="23" name="TextBox 22"/>
+          <p:cNvSpPr txBox="1"/>
+          <p:nvPr/>
+        </p:nvSpPr>
+        <p:spPr>
+          <a:xfrm>
+            <a:off x="7589520" y="1435608"/>
+            <a:ext cx="3977640" cy="411480"/>
+          </a:xfrm>
+          <a:prstGeom prst="rect">
+            <a:avLst/>
+          </a:prstGeom>
+          <a:noFill/>
+        </p:spPr>
+        <p:txBody>
+          <a:bodyPr wrap="square">
+            <a:spAutoFit/>
+          </a:bodyPr>
+          <a:lstStyle/>
+          <a:p>
+            <a:pPr algn="r" rtl="1"/>
+            <a:r>
+              <a:rPr sz="1600" b="1">
+                <a:solidFill>
+                  <a:srgbClr val="C9A84C"/>
+                </a:solidFill>
+                <a:latin typeface="Noto Sans Arabic"/>
+              </a:rPr>
+              <a:t>تنظيم المحتوى</a:t>
+            </a:r>
+          </a:p>
+        </p:txBody>
+      </p:sp>
+      <p:sp>
+        <p:nvSpPr>
+          <p:cNvPr id="24" name="TextBox 23"/>
+          <p:cNvSpPr txBox="1"/>
+          <p:nvPr/>
+        </p:nvSpPr>
+        <p:spPr>
+          <a:xfrm>
+            <a:off x="6720840" y="1828800"/>
+            <a:ext cx="4846320" cy="274320"/>
+          </a:xfrm>
+          <a:prstGeom prst="rect">
+            <a:avLst/>
+          </a:prstGeom>
+          <a:noFill/>
+        </p:spPr>
+        <p:txBody>
+          <a:bodyPr wrap="square">
+            <a:spAutoFit/>
+          </a:bodyPr>
+          <a:lstStyle/>
+          <a:p>
+            <a:pPr algn="r"/>
+            <a:r>
+              <a:rPr sz="1000" b="0">
+                <a:solidFill>
+                  <a:srgbClr val="CCCCCC"/>
+                </a:solidFill>
+                <a:latin typeface="Noto Sans Arabic"/>
+              </a:rPr>
+              <a:t>Content Regulation</a:t>
+            </a:r>
+          </a:p>
+        </p:txBody>
+      </p:sp>
+      <p:sp>
+        <p:nvSpPr>
+          <p:cNvPr id="25" name="Rectangle 24"/>
+          <p:cNvSpPr/>
+          <p:nvPr/>
+        </p:nvSpPr>
+        <p:spPr>
+          <a:xfrm>
+            <a:off x="6766560" y="2148840"/>
+            <a:ext cx="4754880" cy="18288"/>
+          </a:xfrm>
+          <a:prstGeom prst="rect">
+            <a:avLst/>
+          </a:prstGeom>
+          <a:solidFill>
+            <a:srgbClr val="C9A84C"/>
+          </a:solidFill>
+          <a:ln>
+            <a:noFill/>
+          </a:ln>
+        </p:spPr>
+        <p:style>
+          <a:lnRef idx="1">
+            <a:schemeClr val="accent1"/>
+          </a:lnRef>
+          <a:fillRef idx="3">
+            <a:schemeClr val="accent1"/>
+          </a:fillRef>
+          <a:effectRef idx="2">
+            <a:schemeClr val="accent1"/>
+          </a:effectRef>
+          <a:fontRef idx="minor">
+            <a:schemeClr val="lt1"/>
+          </a:fontRef>
+        </p:style>
+        <p:txBody>
+          <a:bodyPr rtlCol="0" anchor="ctr"/>
+          <a:lstStyle/>
+          <a:p>
+            <a:pPr algn="ctr"/>
+          </a:p>
+        </p:txBody>
+      </p:sp>
+      <p:sp>
+        <p:nvSpPr>
+          <p:cNvPr id="26" name="TextBox 25"/>
+          <p:cNvSpPr txBox="1"/>
+          <p:nvPr/>
+        </p:nvSpPr>
+        <p:spPr>
+          <a:xfrm>
+            <a:off x="6720840" y="2240280"/>
+            <a:ext cx="4846320" cy="640080"/>
+          </a:xfrm>
+          <a:prstGeom prst="rect">
+            <a:avLst/>
+          </a:prstGeom>
+          <a:noFill/>
+        </p:spPr>
+        <p:txBody>
+          <a:bodyPr wrap="square">
+            <a:spAutoFit/>
+          </a:bodyPr>
+          <a:lstStyle/>
+          <a:p>
+            <a:pPr algn="r" rtl="1"/>
+            <a:r>
+              <a:rPr sz="1300" b="0">
+                <a:solidFill>
+                  <a:srgbClr val="FFFFFF"/>
+                </a:solidFill>
+                <a:latin typeface="Noto Sans Arabic"/>
+              </a:rPr>
+              <a:t>محتوى موجَّه
+ومراقَب تربوياً</a:t>
+            </a:r>
+          </a:p>
+        </p:txBody>
+      </p:sp>
+      <p:sp>
+        <p:nvSpPr>
+          <p:cNvPr id="27" name="TextBox 26"/>
+          <p:cNvSpPr txBox="1"/>
+          <p:nvPr/>
+        </p:nvSpPr>
+        <p:spPr>
+          <a:xfrm>
+            <a:off x="6720840" y="2926080"/>
+            <a:ext cx="4846320" cy="502920"/>
+          </a:xfrm>
+          <a:prstGeom prst="rect">
+            <a:avLst/>
+          </a:prstGeom>
+          <a:noFill/>
+        </p:spPr>
+        <p:txBody>
+          <a:bodyPr wrap="square">
+            <a:spAutoFit/>
+          </a:bodyPr>
+          <a:lstStyle/>
+          <a:p>
+            <a:pPr algn="r"/>
+            <a:r>
+              <a:rPr sz="1000" b="0">
+                <a:solidFill>
+                  <a:srgbClr val="BBBBBB"/>
+                </a:solidFill>
+                <a:latin typeface="Noto Sans Arabic"/>
+              </a:rPr>
+              <a:t>Curated educational
+content supervised</a:t>
+            </a:r>
+          </a:p>
+        </p:txBody>
+      </p:sp>
+      <p:sp>
+        <p:nvSpPr>
+          <p:cNvPr id="28" name="Rounded Rectangle 27"/>
+          <p:cNvSpPr/>
+          <p:nvPr/>
+        </p:nvSpPr>
+        <p:spPr>
+          <a:xfrm>
+            <a:off x="12024360" y="1325880"/>
+            <a:ext cx="5029200" cy="2377440"/>
+          </a:xfrm>
+          <a:prstGeom prst="roundRect">
+            <a:avLst>
+              <a:gd name="adj" fmla="val 4000"/>
+            </a:avLst>
+          </a:prstGeom>
+          <a:solidFill>
+            <a:srgbClr val="223A5E"/>
+          </a:solidFill>
+          <a:ln w="19050">
+            <a:solidFill>
+              <a:srgbClr val="C9A84C"/>
+            </a:solidFill>
+          </a:ln>
+        </p:spPr>
+        <p:style>
+          <a:lnRef idx="1">
+            <a:schemeClr val="accent1"/>
+          </a:lnRef>
+          <a:fillRef idx="3">
+            <a:schemeClr val="accent1"/>
+          </a:fillRef>
+          <a:effectRef idx="2">
+            <a:schemeClr val="accent1"/>
+          </a:effectRef>
+          <a:fontRef idx="minor">
+            <a:schemeClr val="lt1"/>
+          </a:fontRef>
+        </p:style>
+        <p:txBody>
+          <a:bodyPr rtlCol="0" anchor="ctr"/>
+          <a:lstStyle/>
+          <a:p>
+            <a:pPr algn="ctr"/>
+          </a:p>
+        </p:txBody>
+      </p:sp>
+      <p:sp>
+        <p:nvSpPr>
+          <p:cNvPr id="29" name="Rectangle 28"/>
+          <p:cNvSpPr/>
+          <p:nvPr/>
+        </p:nvSpPr>
+        <p:spPr>
+          <a:xfrm>
+            <a:off x="12024360" y="1325880"/>
+            <a:ext cx="5029200" cy="73152"/>
+          </a:xfrm>
+          <a:prstGeom prst="rect">
+            <a:avLst/>
+          </a:prstGeom>
+          <a:solidFill>
+            <a:srgbClr val="C9A84C"/>
+          </a:solidFill>
+          <a:ln>
+            <a:noFill/>
+          </a:ln>
+        </p:spPr>
+        <p:style>
+          <a:lnRef idx="1">
+            <a:schemeClr val="accent1"/>
+          </a:lnRef>
+          <a:fillRef idx="3">
+            <a:schemeClr val="accent1"/>
+          </a:fillRef>
+          <a:effectRef idx="2">
+            <a:schemeClr val="accent1"/>
+          </a:effectRef>
+          <a:fontRef idx="minor">
+            <a:schemeClr val="lt1"/>
+          </a:fontRef>
+        </p:style>
+        <p:txBody>
+          <a:bodyPr rtlCol="0" anchor="ctr"/>
+          <a:lstStyle/>
+          <a:p>
+            <a:pPr algn="ctr"/>
+          </a:p>
+        </p:txBody>
+      </p:sp>
+      <p:sp>
+        <p:nvSpPr>
+          <p:cNvPr id="30" name="Oval 29"/>
+          <p:cNvSpPr/>
+          <p:nvPr/>
+        </p:nvSpPr>
+        <p:spPr>
+          <a:xfrm>
+            <a:off x="12207240" y="1463040"/>
+            <a:ext cx="685800" cy="685800"/>
+          </a:xfrm>
+          <a:prstGeom prst="ellipse">
+            <a:avLst/>
+          </a:prstGeom>
+          <a:solidFill>
+            <a:srgbClr val="C9A84C"/>
+          </a:solidFill>
+          <a:ln>
+            <a:noFill/>
+          </a:ln>
+        </p:spPr>
+        <p:style>
+          <a:lnRef idx="1">
+            <a:schemeClr val="accent1"/>
+          </a:lnRef>
+          <a:fillRef idx="3">
+            <a:schemeClr val="accent1"/>
+          </a:fillRef>
+          <a:effectRef idx="2">
+            <a:schemeClr val="accent1"/>
+          </a:effectRef>
+          <a:fontRef idx="minor">
+            <a:schemeClr val="lt1"/>
+          </a:fontRef>
+        </p:style>
+        <p:txBody>
+          <a:bodyPr rtlCol="0" anchor="ctr"/>
+          <a:lstStyle/>
+          <a:p>
+            <a:pPr algn="ctr"/>
+          </a:p>
+        </p:txBody>
+      </p:sp>
+      <p:sp>
+        <p:nvSpPr>
+          <p:cNvPr id="31" name="TextBox 30"/>
+          <p:cNvSpPr txBox="1"/>
+          <p:nvPr/>
+        </p:nvSpPr>
+        <p:spPr>
+          <a:xfrm>
+            <a:off x="12207240" y="1490472"/>
+            <a:ext cx="685800" cy="548640"/>
+          </a:xfrm>
+          <a:prstGeom prst="rect">
+            <a:avLst/>
+          </a:prstGeom>
+          <a:noFill/>
+        </p:spPr>
+        <p:txBody>
+          <a:bodyPr wrap="square">
+            <a:spAutoFit/>
+          </a:bodyPr>
+          <a:lstStyle/>
+          <a:p>
+            <a:pPr algn="ctr" rtl="1"/>
+            <a:r>
+              <a:rPr sz="1600" b="1">
+                <a:solidFill>
+                  <a:srgbClr val="1A2A4A"/>
+                </a:solidFill>
+                <a:latin typeface="Noto Sans Arabic"/>
+              </a:rPr>
+              <a:t>3</a:t>
+            </a:r>
+          </a:p>
+        </p:txBody>
+      </p:sp>
+      <p:sp>
+        <p:nvSpPr>
+          <p:cNvPr id="32" name="TextBox 31"/>
+          <p:cNvSpPr txBox="1"/>
+          <p:nvPr/>
+        </p:nvSpPr>
+        <p:spPr>
+          <a:xfrm>
+            <a:off x="12984480" y="1435608"/>
+            <a:ext cx="3977640" cy="411480"/>
+          </a:xfrm>
+          <a:prstGeom prst="rect">
+            <a:avLst/>
+          </a:prstGeom>
+          <a:noFill/>
+        </p:spPr>
+        <p:txBody>
+          <a:bodyPr wrap="square">
+            <a:spAutoFit/>
+          </a:bodyPr>
+          <a:lstStyle/>
+          <a:p>
+            <a:pPr algn="r" rtl="1"/>
+            <a:r>
+              <a:rPr sz="1600" b="1">
+                <a:solidFill>
+                  <a:srgbClr val="C9A84C"/>
+                </a:solidFill>
+                <a:latin typeface="Noto Sans Arabic"/>
+              </a:rPr>
+              <a:t>الرقابة الرقمية</a:t>
+            </a:r>
+          </a:p>
+        </p:txBody>
+      </p:sp>
+      <p:sp>
+        <p:nvSpPr>
+          <p:cNvPr id="33" name="TextBox 32"/>
+          <p:cNvSpPr txBox="1"/>
+          <p:nvPr/>
+        </p:nvSpPr>
+        <p:spPr>
+          <a:xfrm>
+            <a:off x="12115800" y="1828800"/>
+            <a:ext cx="4846320" cy="274320"/>
+          </a:xfrm>
+          <a:prstGeom prst="rect">
+            <a:avLst/>
+          </a:prstGeom>
+          <a:noFill/>
+        </p:spPr>
+        <p:txBody>
+          <a:bodyPr wrap="square">
+            <a:spAutoFit/>
+          </a:bodyPr>
+          <a:lstStyle/>
+          <a:p>
+            <a:pPr algn="r"/>
+            <a:r>
+              <a:rPr sz="1000" b="0">
+                <a:solidFill>
+                  <a:srgbClr val="CCCCCC"/>
+                </a:solidFill>
+                <a:latin typeface="Noto Sans Arabic"/>
+              </a:rPr>
+              <a:t>Digital Oversight</a:t>
+            </a:r>
+          </a:p>
+        </p:txBody>
+      </p:sp>
+      <p:sp>
+        <p:nvSpPr>
+          <p:cNvPr id="34" name="Rectangle 33"/>
+          <p:cNvSpPr/>
+          <p:nvPr/>
+        </p:nvSpPr>
+        <p:spPr>
+          <a:xfrm>
+            <a:off x="12161520" y="2148840"/>
+            <a:ext cx="4754880" cy="18288"/>
+          </a:xfrm>
+          <a:prstGeom prst="rect">
+            <a:avLst/>
+          </a:prstGeom>
+          <a:solidFill>
+            <a:srgbClr val="C9A84C"/>
+          </a:solidFill>
+          <a:ln>
+            <a:noFill/>
+          </a:ln>
+        </p:spPr>
+        <p:style>
+          <a:lnRef idx="1">
+            <a:schemeClr val="accent1"/>
+          </a:lnRef>
+          <a:fillRef idx="3">
+            <a:schemeClr val="accent1"/>
+          </a:fillRef>
+          <a:effectRef idx="2">
+            <a:schemeClr val="accent1"/>
+          </a:effectRef>
+          <a:fontRef idx="minor">
+            <a:schemeClr val="lt1"/>
+          </a:fontRef>
+        </p:style>
+        <p:txBody>
+          <a:bodyPr rtlCol="0" anchor="ctr"/>
+          <a:lstStyle/>
+          <a:p>
+            <a:pPr algn="ctr"/>
+          </a:p>
+        </p:txBody>
+      </p:sp>
+      <p:sp>
+        <p:nvSpPr>
+          <p:cNvPr id="35" name="TextBox 34"/>
+          <p:cNvSpPr txBox="1"/>
+          <p:nvPr/>
+        </p:nvSpPr>
+        <p:spPr>
+          <a:xfrm>
+            <a:off x="12115800" y="2240280"/>
+            <a:ext cx="4846320" cy="640080"/>
+          </a:xfrm>
+          <a:prstGeom prst="rect">
+            <a:avLst/>
+          </a:prstGeom>
+          <a:noFill/>
+        </p:spPr>
+        <p:txBody>
+          <a:bodyPr wrap="square">
+            <a:spAutoFit/>
+          </a:bodyPr>
+          <a:lstStyle/>
+          <a:p>
+            <a:pPr algn="r" rtl="1"/>
+            <a:r>
+              <a:rPr sz="1300" b="0">
+                <a:solidFill>
+                  <a:srgbClr val="FFFFFF"/>
+                </a:solidFill>
+                <a:latin typeface="Noto Sans Arabic"/>
+              </a:rPr>
+              <a:t>صلاحيات وأدوار
+محددة لكل مستخدم</a:t>
+            </a:r>
+          </a:p>
+        </p:txBody>
+      </p:sp>
+      <p:sp>
+        <p:nvSpPr>
+          <p:cNvPr id="36" name="TextBox 35"/>
+          <p:cNvSpPr txBox="1"/>
+          <p:nvPr/>
+        </p:nvSpPr>
+        <p:spPr>
+          <a:xfrm>
+            <a:off x="12115800" y="2926080"/>
+            <a:ext cx="4846320" cy="502920"/>
+          </a:xfrm>
+          <a:prstGeom prst="rect">
+            <a:avLst/>
+          </a:prstGeom>
+          <a:noFill/>
+        </p:spPr>
+        <p:txBody>
+          <a:bodyPr wrap="square">
+            <a:spAutoFit/>
+          </a:bodyPr>
+          <a:lstStyle/>
+          <a:p>
+            <a:pPr algn="r"/>
+            <a:r>
+              <a:rPr sz="1000" b="0">
+                <a:solidFill>
+                  <a:srgbClr val="BBBBBB"/>
+                </a:solidFill>
+                <a:latin typeface="Noto Sans Arabic"/>
+              </a:rPr>
+              <a:t>Role-based access
+for all users</a:t>
+            </a:r>
+          </a:p>
+        </p:txBody>
+      </p:sp>
+      <p:sp>
+        <p:nvSpPr>
+          <p:cNvPr id="37" name="Rounded Rectangle 36"/>
+          <p:cNvSpPr/>
+          <p:nvPr/>
+        </p:nvSpPr>
+        <p:spPr>
+          <a:xfrm>
+            <a:off x="3657600" y="3840480"/>
+            <a:ext cx="5303520" cy="804672"/>
+          </a:xfrm>
+          <a:prstGeom prst="roundRect">
+            <a:avLst>
+              <a:gd name="adj" fmla="val 8000"/>
+            </a:avLst>
+          </a:prstGeom>
+          <a:solidFill>
+            <a:srgbClr val="223A5E"/>
+          </a:solidFill>
+          <a:ln w="12700">
+            <a:solidFill>
+              <a:srgbClr val="C9A84C"/>
+            </a:solidFill>
+          </a:ln>
+        </p:spPr>
+        <p:style>
+          <a:lnRef idx="1">
+            <a:schemeClr val="accent1"/>
+          </a:lnRef>
+          <a:fillRef idx="3">
+            <a:schemeClr val="accent1"/>
+          </a:fillRef>
+          <a:effectRef idx="2">
+            <a:schemeClr val="accent1"/>
+          </a:effectRef>
+          <a:fontRef idx="minor">
+            <a:schemeClr val="lt1"/>
+          </a:fontRef>
+        </p:style>
+        <p:txBody>
+          <a:bodyPr rtlCol="0" anchor="ctr"/>
+          <a:lstStyle/>
+          <a:p>
+            <a:pPr algn="ctr"/>
+          </a:p>
+        </p:txBody>
+      </p:sp>
+      <p:sp>
+        <p:nvSpPr>
+          <p:cNvPr id="38" name="Rectangle 37"/>
+          <p:cNvSpPr/>
+          <p:nvPr/>
+        </p:nvSpPr>
+        <p:spPr>
+          <a:xfrm>
+            <a:off x="3657600" y="3840480"/>
+            <a:ext cx="64008" cy="804672"/>
+          </a:xfrm>
+          <a:prstGeom prst="rect">
+            <a:avLst/>
+          </a:prstGeom>
+          <a:solidFill>
+            <a:srgbClr val="C9A84C"/>
+          </a:solidFill>
+          <a:ln>
+            <a:noFill/>
+          </a:ln>
+        </p:spPr>
+        <p:style>
+          <a:lnRef idx="1">
+            <a:schemeClr val="accent1"/>
+          </a:lnRef>
+          <a:fillRef idx="3">
+            <a:schemeClr val="accent1"/>
+          </a:fillRef>
+          <a:effectRef idx="2">
+            <a:schemeClr val="accent1"/>
+          </a:effectRef>
+          <a:fontRef idx="minor">
+            <a:schemeClr val="lt1"/>
+          </a:fontRef>
+        </p:style>
+        <p:txBody>
+          <a:bodyPr rtlCol="0" anchor="ctr"/>
+          <a:lstStyle/>
+          <a:p>
+            <a:pPr algn="ctr"/>
+          </a:p>
+        </p:txBody>
+      </p:sp>
+      <p:sp>
+        <p:nvSpPr>
+          <p:cNvPr id="39" name="Oval 38"/>
+          <p:cNvSpPr/>
+          <p:nvPr/>
+        </p:nvSpPr>
+        <p:spPr>
+          <a:xfrm>
+            <a:off x="3794760" y="4023360"/>
+            <a:ext cx="411480" cy="411480"/>
+          </a:xfrm>
+          <a:prstGeom prst="ellipse">
+            <a:avLst/>
+          </a:prstGeom>
+          <a:solidFill>
+            <a:srgbClr val="C9A84C"/>
+          </a:solidFill>
+          <a:ln>
+            <a:noFill/>
+          </a:ln>
+        </p:spPr>
+        <p:style>
+          <a:lnRef idx="1">
+            <a:schemeClr val="accent1"/>
+          </a:lnRef>
+          <a:fillRef idx="3">
+            <a:schemeClr val="accent1"/>
+          </a:fillRef>
+          <a:effectRef idx="2">
+            <a:schemeClr val="accent1"/>
+          </a:effectRef>
+          <a:fontRef idx="minor">
+            <a:schemeClr val="lt1"/>
+          </a:fontRef>
+        </p:style>
+        <p:txBody>
+          <a:bodyPr rtlCol="0" anchor="ctr"/>
+          <a:lstStyle/>
+          <a:p>
+            <a:pPr algn="ctr"/>
+          </a:p>
+        </p:txBody>
+      </p:sp>
+      <p:sp>
+        <p:nvSpPr>
+          <p:cNvPr id="40" name="TextBox 39"/>
+          <p:cNvSpPr txBox="1"/>
+          <p:nvPr/>
+        </p:nvSpPr>
+        <p:spPr>
+          <a:xfrm>
+            <a:off x="3794760" y="4023360"/>
+            <a:ext cx="411480" cy="384048"/>
+          </a:xfrm>
+          <a:prstGeom prst="rect">
+            <a:avLst/>
+          </a:prstGeom>
+          <a:noFill/>
+        </p:spPr>
+        <p:txBody>
+          <a:bodyPr wrap="square">
+            <a:spAutoFit/>
+          </a:bodyPr>
+          <a:lstStyle/>
+          <a:p>
+            <a:pPr algn="ctr" rtl="1"/>
+            <a:r>
+              <a:rPr sz="1100" b="1">
+                <a:solidFill>
+                  <a:srgbClr val="1A2A4A"/>
+                </a:solidFill>
+                <a:latin typeface="Noto Sans Arabic"/>
+              </a:rPr>
+              <a:t>4</a:t>
+            </a:r>
+          </a:p>
+        </p:txBody>
+      </p:sp>
+      <p:sp>
+        <p:nvSpPr>
+          <p:cNvPr id="41" name="TextBox 40"/>
+          <p:cNvSpPr txBox="1"/>
+          <p:nvPr/>
+        </p:nvSpPr>
+        <p:spPr>
+          <a:xfrm>
+            <a:off x="4297680" y="3895344"/>
+            <a:ext cx="4572000" cy="347472"/>
+          </a:xfrm>
+          <a:prstGeom prst="rect">
+            <a:avLst/>
+          </a:prstGeom>
+          <a:noFill/>
+        </p:spPr>
+        <p:txBody>
+          <a:bodyPr wrap="square">
+            <a:spAutoFit/>
+          </a:bodyPr>
+          <a:lstStyle/>
+          <a:p>
+            <a:pPr algn="r" rtl="1"/>
+            <a:r>
+              <a:rPr sz="1400" b="1">
+                <a:solidFill>
+                  <a:srgbClr val="C9A84C"/>
+                </a:solidFill>
+                <a:latin typeface="Noto Sans Arabic"/>
+              </a:rPr>
+              <a:t>الشفافية والمساءلة</a:t>
+            </a:r>
+          </a:p>
+        </p:txBody>
+      </p:sp>
+      <p:sp>
+        <p:nvSpPr>
+          <p:cNvPr id="42" name="TextBox 41"/>
+          <p:cNvSpPr txBox="1"/>
+          <p:nvPr/>
+        </p:nvSpPr>
+        <p:spPr>
+          <a:xfrm>
+            <a:off x="4297680" y="4261104"/>
+            <a:ext cx="4572000" cy="347472"/>
+          </a:xfrm>
+          <a:prstGeom prst="rect">
+            <a:avLst/>
+          </a:prstGeom>
+          <a:noFill/>
+        </p:spPr>
+        <p:txBody>
+          <a:bodyPr wrap="square">
+            <a:spAutoFit/>
+          </a:bodyPr>
+          <a:lstStyle/>
+          <a:p>
+            <a:pPr algn="r" rtl="1"/>
+            <a:r>
+              <a:rPr sz="1100" b="0">
+                <a:solidFill>
+                  <a:srgbClr val="FFFFFF"/>
+                </a:solidFill>
+                <a:latin typeface="Noto Sans Arabic"/>
+              </a:rPr>
+              <a:t>تقارير وسجلات — يراجعها الإداريون</a:t>
+            </a:r>
+          </a:p>
+        </p:txBody>
+      </p:sp>
+      <p:sp>
+        <p:nvSpPr>
+          <p:cNvPr id="43" name="Rounded Rectangle 42"/>
+          <p:cNvSpPr/>
+          <p:nvPr/>
+        </p:nvSpPr>
+        <p:spPr>
+          <a:xfrm>
+            <a:off x="9326880" y="3840480"/>
+            <a:ext cx="5303520" cy="804672"/>
+          </a:xfrm>
+          <a:prstGeom prst="roundRect">
+            <a:avLst>
+              <a:gd name="adj" fmla="val 8000"/>
+            </a:avLst>
+          </a:prstGeom>
+          <a:solidFill>
+            <a:srgbClr val="223A5E"/>
+          </a:solidFill>
+          <a:ln w="12700">
+            <a:solidFill>
+              <a:srgbClr val="C9A84C"/>
+            </a:solidFill>
+          </a:ln>
+        </p:spPr>
+        <p:style>
+          <a:lnRef idx="1">
+            <a:schemeClr val="accent1"/>
+          </a:lnRef>
+          <a:fillRef idx="3">
+            <a:schemeClr val="accent1"/>
+          </a:fillRef>
+          <a:effectRef idx="2">
+            <a:schemeClr val="accent1"/>
+          </a:effectRef>
+          <a:fontRef idx="minor">
+            <a:schemeClr val="lt1"/>
+          </a:fontRef>
+        </p:style>
+        <p:txBody>
+          <a:bodyPr rtlCol="0" anchor="ctr"/>
+          <a:lstStyle/>
+          <a:p>
+            <a:pPr algn="ctr"/>
+          </a:p>
+        </p:txBody>
+      </p:sp>
+      <p:sp>
+        <p:nvSpPr>
+          <p:cNvPr id="44" name="Rectangle 43"/>
+          <p:cNvSpPr/>
+          <p:nvPr/>
+        </p:nvSpPr>
+        <p:spPr>
+          <a:xfrm>
+            <a:off x="9326880" y="3840480"/>
+            <a:ext cx="64008" cy="804672"/>
+          </a:xfrm>
+          <a:prstGeom prst="rect">
+            <a:avLst/>
+          </a:prstGeom>
+          <a:solidFill>
+            <a:srgbClr val="C9A84C"/>
+          </a:solidFill>
+          <a:ln>
+            <a:noFill/>
+          </a:ln>
+        </p:spPr>
+        <p:style>
+          <a:lnRef idx="1">
+            <a:schemeClr val="accent1"/>
+          </a:lnRef>
+          <a:fillRef idx="3">
+            <a:schemeClr val="accent1"/>
+          </a:fillRef>
+          <a:effectRef idx="2">
+            <a:schemeClr val="accent1"/>
+          </a:effectRef>
+          <a:fontRef idx="minor">
+            <a:schemeClr val="lt1"/>
+          </a:fontRef>
+        </p:style>
+        <p:txBody>
+          <a:bodyPr rtlCol="0" anchor="ctr"/>
+          <a:lstStyle/>
+          <a:p>
+            <a:pPr algn="ctr"/>
+          </a:p>
+        </p:txBody>
+      </p:sp>
+      <p:sp>
+        <p:nvSpPr>
+          <p:cNvPr id="45" name="Oval 44"/>
+          <p:cNvSpPr/>
+          <p:nvPr/>
+        </p:nvSpPr>
+        <p:spPr>
+          <a:xfrm>
+            <a:off x="9464040" y="4023360"/>
+            <a:ext cx="411480" cy="411480"/>
+          </a:xfrm>
+          <a:prstGeom prst="ellipse">
+            <a:avLst/>
+          </a:prstGeom>
+          <a:solidFill>
+            <a:srgbClr val="C9A84C"/>
+          </a:solidFill>
+          <a:ln>
+            <a:noFill/>
+          </a:ln>
+        </p:spPr>
+        <p:style>
+          <a:lnRef idx="1">
+            <a:schemeClr val="accent1"/>
+          </a:lnRef>
+          <a:fillRef idx="3">
+            <a:schemeClr val="accent1"/>
+          </a:fillRef>
+          <a:effectRef idx="2">
+            <a:schemeClr val="accent1"/>
+          </a:effectRef>
+          <a:fontRef idx="minor">
+            <a:schemeClr val="lt1"/>
+          </a:fontRef>
+        </p:style>
+        <p:txBody>
+          <a:bodyPr rtlCol="0" anchor="ctr"/>
+          <a:lstStyle/>
+          <a:p>
+            <a:pPr algn="ctr"/>
+          </a:p>
+        </p:txBody>
+      </p:sp>
+      <p:sp>
+        <p:nvSpPr>
+          <p:cNvPr id="46" name="TextBox 45"/>
+          <p:cNvSpPr txBox="1"/>
+          <p:nvPr/>
+        </p:nvSpPr>
+        <p:spPr>
+          <a:xfrm>
+            <a:off x="9464040" y="4023360"/>
+            <a:ext cx="411480" cy="384048"/>
+          </a:xfrm>
+          <a:prstGeom prst="rect">
+            <a:avLst/>
+          </a:prstGeom>
+          <a:noFill/>
+        </p:spPr>
+        <p:txBody>
+          <a:bodyPr wrap="square">
+            <a:spAutoFit/>
+          </a:bodyPr>
+          <a:lstStyle/>
+          <a:p>
+            <a:pPr algn="ctr" rtl="1"/>
+            <a:r>
+              <a:rPr sz="1100" b="1">
+                <a:solidFill>
+                  <a:srgbClr val="1A2A4A"/>
+                </a:solidFill>
+                <a:latin typeface="Noto Sans Arabic"/>
+              </a:rPr>
+              <a:t>5</a:t>
+            </a:r>
+          </a:p>
+        </p:txBody>
+      </p:sp>
+      <p:sp>
+        <p:nvSpPr>
+          <p:cNvPr id="47" name="TextBox 46"/>
+          <p:cNvSpPr txBox="1"/>
+          <p:nvPr/>
+        </p:nvSpPr>
+        <p:spPr>
+          <a:xfrm>
+            <a:off x="9966960" y="3895344"/>
+            <a:ext cx="4572000" cy="347472"/>
+          </a:xfrm>
+          <a:prstGeom prst="rect">
+            <a:avLst/>
+          </a:prstGeom>
+          <a:noFill/>
+        </p:spPr>
+        <p:txBody>
+          <a:bodyPr wrap="square">
+            <a:spAutoFit/>
+          </a:bodyPr>
+          <a:lstStyle/>
+          <a:p>
+            <a:pPr algn="r" rtl="1"/>
+            <a:r>
+              <a:rPr sz="1400" b="1">
+                <a:solidFill>
+                  <a:srgbClr val="C9A84C"/>
+                </a:solidFill>
+                <a:latin typeface="Noto Sans Arabic"/>
+              </a:rPr>
+              <a:t>الأمان والخصوصية</a:t>
+            </a:r>
+          </a:p>
+        </p:txBody>
+      </p:sp>
+      <p:sp>
+        <p:nvSpPr>
+          <p:cNvPr id="48" name="TextBox 47"/>
+          <p:cNvSpPr txBox="1"/>
+          <p:nvPr/>
+        </p:nvSpPr>
+        <p:spPr>
+          <a:xfrm>
+            <a:off x="9966960" y="4261104"/>
+            <a:ext cx="4572000" cy="347472"/>
+          </a:xfrm>
+          <a:prstGeom prst="rect">
+            <a:avLst/>
+          </a:prstGeom>
+          <a:noFill/>
+        </p:spPr>
+        <p:txBody>
+          <a:bodyPr wrap="square">
+            <a:spAutoFit/>
+          </a:bodyPr>
+          <a:lstStyle/>
+          <a:p>
+            <a:pPr algn="r" rtl="1"/>
+            <a:r>
+              <a:rPr sz="1100" b="0">
+                <a:solidFill>
+                  <a:srgbClr val="FFFFFF"/>
+                </a:solidFill>
+                <a:latin typeface="Noto Sans Arabic"/>
+              </a:rPr>
+              <a:t>بيئة مغلقة — بعيداً عن الإنترنت العام</a:t>
+            </a:r>
+          </a:p>
+        </p:txBody>
+      </p:sp>
+      <p:sp>
+        <p:nvSpPr>
+          <p:cNvPr id="49" name="Rectangle 48"/>
+          <p:cNvSpPr/>
+          <p:nvPr/>
+        </p:nvSpPr>
+        <p:spPr>
+          <a:xfrm>
+            <a:off x="0" y="10213848"/>
+            <a:ext cx="18288000" cy="73152"/>
+          </a:xfrm>
+          <a:prstGeom prst="rect">
+            <a:avLst/>
+          </a:prstGeom>
+          <a:solidFill>
+            <a:srgbClr val="C9A84C"/>
+          </a:solidFill>
+          <a:ln>
+            <a:noFill/>
+          </a:ln>
+        </p:spPr>
+        <p:style>
+          <a:lnRef idx="1">
+            <a:schemeClr val="accent1"/>
+          </a:lnRef>
+          <a:fillRef idx="3">
+            <a:schemeClr val="accent1"/>
+          </a:fillRef>
+          <a:effectRef idx="2">
+            <a:schemeClr val="accent1"/>
+          </a:effectRef>
+          <a:fontRef idx="minor">
+            <a:schemeClr val="lt1"/>
+          </a:fontRef>
+        </p:style>
+        <p:txBody>
+          <a:bodyPr rtlCol="0" anchor="ctr"/>
+          <a:lstStyle/>
+          <a:p>
+            <a:pPr algn="ctr"/>
           </a:p>
         </p:txBody>
       </p:sp>
@@ -6602,7 +7731,7 @@
       </p:grpSpPr>
       <p:grpSp>
         <p:nvGrpSpPr>
-          <p:cNvPr name="Group 2" id="100"/>
+          <p:cNvPr name="Group 2" id="2"/>
           <p:cNvGrpSpPr/>
           <p:nvPr/>
         </p:nvGrpSpPr>
@@ -6789,20 +7918,20 @@
       </p:grpSp>
       <p:sp>
         <p:nvSpPr>
-          <p:cNvPr id="101" name="Rectangle 100"/>
+          <p:cNvPr id="5" name="Rectangle 4"/>
           <p:cNvSpPr/>
           <p:nvPr/>
         </p:nvSpPr>
         <p:spPr>
           <a:xfrm>
             <a:off x="0" y="0"/>
-            <a:ext cx="18288000" cy="109728"/>
+            <a:ext cx="18288000" cy="10287000"/>
           </a:xfrm>
           <a:prstGeom prst="rect">
             <a:avLst/>
           </a:prstGeom>
           <a:solidFill>
-            <a:srgbClr val="C9A84C"/>
+            <a:srgbClr val="1A2A4A"/>
           </a:solidFill>
           <a:ln>
             <a:noFill/>
@@ -6832,112 +7961,20 @@
       </p:sp>
       <p:sp>
         <p:nvSpPr>
-          <p:cNvPr id="102" name="TextBox 101"/>
-          <p:cNvSpPr txBox="1"/>
+          <p:cNvPr id="6" name="Rectangle 5"/>
+          <p:cNvSpPr/>
           <p:nvPr/>
         </p:nvSpPr>
         <p:spPr>
           <a:xfrm>
-            <a:off x="914400" y="182880"/>
-            <a:ext cx="16459200" cy="566928"/>
-          </a:xfrm>
-          <a:prstGeom prst="rect">
-            <a:avLst/>
-          </a:prstGeom>
-          <a:noFill/>
-        </p:spPr>
-        <p:txBody>
-          <a:bodyPr wrap="square">
-            <a:spAutoFit/>
-          </a:bodyPr>
-          <a:lstStyle/>
-          <a:p>
-            <a:pPr algn="ctr" rtl="1"/>
-            <a:r>
-              <a:rPr sz="1900" b="1">
-                <a:solidFill>
-                  <a:srgbClr val="C9A84C"/>
-                </a:solidFill>
-              </a:rPr>
-              <a:t>كيف تُجسّد البوابة قانون حماية الطفل الرقمي؟</a:t>
-            </a:r>
-          </a:p>
-        </p:txBody>
-      </p:sp>
-      <p:sp>
-        <p:nvSpPr>
-          <p:cNvPr id="103" name="TextBox 102"/>
-          <p:cNvSpPr txBox="1"/>
-          <p:nvPr/>
-        </p:nvSpPr>
-        <p:spPr>
-          <a:xfrm>
-            <a:off x="914400" y="749808"/>
-            <a:ext cx="16459200" cy="347472"/>
-          </a:xfrm>
-          <a:prstGeom prst="rect">
-            <a:avLst/>
-          </a:prstGeom>
-          <a:noFill/>
-        </p:spPr>
-        <p:txBody>
-          <a:bodyPr wrap="square">
-            <a:spAutoFit/>
-          </a:bodyPr>
-          <a:lstStyle/>
-          <a:p>
-            <a:pPr algn="ctr"/>
-            <a:r>
-              <a:rPr sz="1000" b="0">
-                <a:solidFill>
-                  <a:srgbClr val="B4C8E6"/>
-                </a:solidFill>
-              </a:rPr>
-              <a:t>How the portal implements the Child Digital Safety Law</a:t>
-            </a:r>
-          </a:p>
-        </p:txBody>
-      </p:sp>
-      <p:pic>
-        <p:nvPicPr>
-          <p:cNvPr id="104" name="Picture 103" descr="img4a.jpg"/>
-          <p:cNvPicPr>
-            <a:picLocks noChangeAspect="1"/>
-          </p:cNvPicPr>
-          <p:nvPr/>
-        </p:nvPicPr>
-        <p:blipFill>
-          <a:blip r:embed="rId5"/>
-          <a:stretch>
-            <a:fillRect/>
-          </a:stretch>
-        </p:blipFill>
-        <p:spPr>
-          <a:xfrm>
-            <a:off x="685800" y="1234440"/>
-            <a:ext cx="5285232" cy="4206240"/>
-          </a:xfrm>
-          <a:prstGeom prst="rect">
-            <a:avLst/>
-          </a:prstGeom>
-        </p:spPr>
-      </p:pic>
-      <p:sp>
-        <p:nvSpPr>
-          <p:cNvPr id="105" name="Rectangle 104"/>
-          <p:cNvSpPr/>
-          <p:nvPr/>
-        </p:nvSpPr>
-        <p:spPr>
-          <a:xfrm>
-            <a:off x="685800" y="5440679"/>
-            <a:ext cx="5285232" cy="4709160"/>
+            <a:off x="0" y="0"/>
+            <a:ext cx="18288000" cy="73152"/>
           </a:xfrm>
           <a:prstGeom prst="rect">
             <a:avLst/>
           </a:prstGeom>
           <a:solidFill>
-            <a:srgbClr val="223860"/>
+            <a:srgbClr val="C9A84C"/>
           </a:solidFill>
           <a:ln>
             <a:noFill/>
@@ -6967,14 +8004,14 @@
       </p:sp>
       <p:sp>
         <p:nvSpPr>
-          <p:cNvPr id="106" name="Rectangle 105"/>
+          <p:cNvPr id="7" name="Rectangle 6"/>
           <p:cNvSpPr/>
           <p:nvPr/>
         </p:nvSpPr>
         <p:spPr>
           <a:xfrm>
-            <a:off x="685800" y="5440679"/>
-            <a:ext cx="5285232" cy="64008"/>
+            <a:off x="0" y="10213848"/>
+            <a:ext cx="18288000" cy="73152"/>
           </a:xfrm>
           <a:prstGeom prst="rect">
             <a:avLst/>
@@ -7010,14 +8047,14 @@
       </p:sp>
       <p:sp>
         <p:nvSpPr>
-          <p:cNvPr id="107" name="TextBox 106"/>
+          <p:cNvPr id="8" name="TextBox 7"/>
           <p:cNvSpPr txBox="1"/>
           <p:nvPr/>
         </p:nvSpPr>
         <p:spPr>
           <a:xfrm>
-            <a:off x="777240" y="5550407"/>
-            <a:ext cx="5102352" cy="438912"/>
+            <a:off x="914400" y="164592"/>
+            <a:ext cx="16459200" cy="594360"/>
           </a:xfrm>
           <a:prstGeom prst="rect">
             <a:avLst/>
@@ -7032,26 +8069,27 @@
           <a:p>
             <a:pPr algn="ctr" rtl="1"/>
             <a:r>
-              <a:rPr sz="1400" b="1">
+              <a:rPr sz="2800" b="1">
                 <a:solidFill>
                   <a:srgbClr val="C9A84C"/>
                 </a:solidFill>
+                <a:latin typeface="Noto Sans Arabic"/>
               </a:rPr>
-              <a:t>خصوصية البيانات</a:t>
+              <a:t>كيف تُجسّد البوابة القانون؟</a:t>
             </a:r>
           </a:p>
         </p:txBody>
       </p:sp>
       <p:sp>
         <p:nvSpPr>
-          <p:cNvPr id="108" name="TextBox 107"/>
+          <p:cNvPr id="9" name="TextBox 8"/>
           <p:cNvSpPr txBox="1"/>
           <p:nvPr/>
         </p:nvSpPr>
         <p:spPr>
           <a:xfrm>
-            <a:off x="777240" y="5971031"/>
-            <a:ext cx="5102352" cy="292608"/>
+            <a:off x="914400" y="713232"/>
+            <a:ext cx="16459200" cy="320040"/>
           </a:xfrm>
           <a:prstGeom prst="rect">
             <a:avLst/>
@@ -7064,128 +8102,35 @@
           </a:bodyPr>
           <a:lstStyle/>
           <a:p>
-            <a:pPr algn="ctr"/>
-            <a:r>
-              <a:rPr sz="900" b="0">
-                <a:solidFill>
-                  <a:srgbClr val="B4C8E6"/>
-                </a:solidFill>
-              </a:rPr>
-              <a:t>Data Privacy</a:t>
-            </a:r>
-          </a:p>
-        </p:txBody>
-      </p:sp>
-      <p:sp>
-        <p:nvSpPr>
-          <p:cNvPr id="109" name="TextBox 108"/>
-          <p:cNvSpPr txBox="1"/>
-          <p:nvPr/>
-        </p:nvSpPr>
-        <p:spPr>
-          <a:xfrm>
-            <a:off x="777240" y="6309359"/>
-            <a:ext cx="5102352" cy="777240"/>
-          </a:xfrm>
-          <a:prstGeom prst="rect">
-            <a:avLst/>
-          </a:prstGeom>
-          <a:noFill/>
-        </p:spPr>
-        <p:txBody>
-          <a:bodyPr wrap="square">
-            <a:spAutoFit/>
-          </a:bodyPr>
-          <a:lstStyle/>
-          <a:p>
             <a:pPr algn="ctr" rtl="1"/>
             <a:r>
-              <a:rPr sz="1100" b="0">
+              <a:rPr sz="1200" b="0">
                 <a:solidFill>
                   <a:srgbClr val="FFFFFF"/>
                 </a:solidFill>
+                <a:latin typeface="Noto Sans Arabic"/>
               </a:rPr>
-              <a:t>بيانات الطلاب محمية
-داخل بيئة مغلقة آمنة</a:t>
+              <a:t>How the portal implements the Child Digital Safety Law</a:t>
             </a:r>
           </a:p>
         </p:txBody>
       </p:sp>
       <p:sp>
         <p:nvSpPr>
-          <p:cNvPr id="110" name="TextBox 109"/>
-          <p:cNvSpPr txBox="1"/>
+          <p:cNvPr id="10" name="Rectangle 9"/>
+          <p:cNvSpPr/>
           <p:nvPr/>
         </p:nvSpPr>
         <p:spPr>
           <a:xfrm>
-            <a:off x="777240" y="7104888"/>
-            <a:ext cx="5102352" cy="594360"/>
-          </a:xfrm>
-          <a:prstGeom prst="rect">
-            <a:avLst/>
-          </a:prstGeom>
-          <a:noFill/>
-        </p:spPr>
-        <p:txBody>
-          <a:bodyPr wrap="square">
-            <a:spAutoFit/>
-          </a:bodyPr>
-          <a:lstStyle/>
-          <a:p>
-            <a:pPr algn="ctr"/>
-            <a:r>
-              <a:rPr sz="900" b="0">
-                <a:solidFill>
-                  <a:srgbClr val="A0B9DC"/>
-                </a:solidFill>
-              </a:rPr>
-              <a:t>Student data secured
-in a closed environment</a:t>
-            </a:r>
-          </a:p>
-        </p:txBody>
-      </p:sp>
-      <p:pic>
-        <p:nvPicPr>
-          <p:cNvPr id="111" name="Picture 110" descr="img4b.jpg"/>
-          <p:cNvPicPr>
-            <a:picLocks noChangeAspect="1"/>
-          </p:cNvPicPr>
-          <p:nvPr/>
-        </p:nvPicPr>
-        <p:blipFill>
-          <a:blip r:embed="rId6"/>
-          <a:stretch>
-            <a:fillRect/>
-          </a:stretch>
-        </p:blipFill>
-        <p:spPr>
-          <a:xfrm>
-            <a:off x="6501384" y="1234440"/>
-            <a:ext cx="5285232" cy="4206240"/>
-          </a:xfrm>
-          <a:prstGeom prst="rect">
-            <a:avLst/>
-          </a:prstGeom>
-        </p:spPr>
-      </p:pic>
-      <p:sp>
-        <p:nvSpPr>
-          <p:cNvPr id="112" name="Rectangle 111"/>
-          <p:cNvSpPr/>
-          <p:nvPr/>
-        </p:nvSpPr>
-        <p:spPr>
-          <a:xfrm>
-            <a:off x="6501384" y="5440679"/>
-            <a:ext cx="5285232" cy="4709160"/>
+            <a:off x="914400" y="1005840"/>
+            <a:ext cx="16459200" cy="27432"/>
           </a:xfrm>
           <a:prstGeom prst="rect">
             <a:avLst/>
           </a:prstGeom>
           <a:solidFill>
-            <a:srgbClr val="223860"/>
+            <a:srgbClr val="C9A84C"/>
           </a:solidFill>
           <a:ln>
             <a:noFill/>
@@ -7215,23 +8160,27 @@
       </p:sp>
       <p:sp>
         <p:nvSpPr>
-          <p:cNvPr id="113" name="Rectangle 112"/>
+          <p:cNvPr id="11" name="Rounded Rectangle 10"/>
           <p:cNvSpPr/>
           <p:nvPr/>
         </p:nvSpPr>
         <p:spPr>
           <a:xfrm>
-            <a:off x="6501384" y="5440679"/>
-            <a:ext cx="5285232" cy="64008"/>
-          </a:xfrm>
-          <a:prstGeom prst="rect">
-            <a:avLst/>
+            <a:off x="1170432" y="1143000"/>
+            <a:ext cx="5120640" cy="3200400"/>
+          </a:xfrm>
+          <a:prstGeom prst="roundRect">
+            <a:avLst>
+              <a:gd name="adj" fmla="val 4000"/>
+            </a:avLst>
           </a:prstGeom>
           <a:solidFill>
-            <a:srgbClr val="C9A84C"/>
+            <a:srgbClr val="223A5E"/>
           </a:solidFill>
-          <a:ln>
-            <a:noFill/>
+          <a:ln w="19050">
+            <a:solidFill>
+              <a:srgbClr val="C9A84C"/>
+            </a:solidFill>
           </a:ln>
         </p:spPr>
         <p:style>
@@ -7258,182 +8207,20 @@
       </p:sp>
       <p:sp>
         <p:nvSpPr>
-          <p:cNvPr id="114" name="TextBox 113"/>
-          <p:cNvSpPr txBox="1"/>
+          <p:cNvPr id="12" name="Rectangle 11"/>
+          <p:cNvSpPr/>
           <p:nvPr/>
         </p:nvSpPr>
         <p:spPr>
           <a:xfrm>
-            <a:off x="6592824" y="5550407"/>
-            <a:ext cx="5102352" cy="438912"/>
-          </a:xfrm>
-          <a:prstGeom prst="rect">
-            <a:avLst/>
-          </a:prstGeom>
-          <a:noFill/>
-        </p:spPr>
-        <p:txBody>
-          <a:bodyPr wrap="square">
-            <a:spAutoFit/>
-          </a:bodyPr>
-          <a:lstStyle/>
-          <a:p>
-            <a:pPr algn="ctr" rtl="1"/>
-            <a:r>
-              <a:rPr sz="1400" b="1">
-                <a:solidFill>
-                  <a:srgbClr val="C9A84C"/>
-                </a:solidFill>
-              </a:rPr>
-              <a:t>محتوى موجَّه وآمن</a:t>
-            </a:r>
-          </a:p>
-        </p:txBody>
-      </p:sp>
-      <p:sp>
-        <p:nvSpPr>
-          <p:cNvPr id="115" name="TextBox 114"/>
-          <p:cNvSpPr txBox="1"/>
-          <p:nvPr/>
-        </p:nvSpPr>
-        <p:spPr>
-          <a:xfrm>
-            <a:off x="6592824" y="5971031"/>
-            <a:ext cx="5102352" cy="292608"/>
-          </a:xfrm>
-          <a:prstGeom prst="rect">
-            <a:avLst/>
-          </a:prstGeom>
-          <a:noFill/>
-        </p:spPr>
-        <p:txBody>
-          <a:bodyPr wrap="square">
-            <a:spAutoFit/>
-          </a:bodyPr>
-          <a:lstStyle/>
-          <a:p>
-            <a:pPr algn="ctr"/>
-            <a:r>
-              <a:rPr sz="900" b="0">
-                <a:solidFill>
-                  <a:srgbClr val="B4C8E6"/>
-                </a:solidFill>
-              </a:rPr>
-              <a:t>Safe Guided Content</a:t>
-            </a:r>
-          </a:p>
-        </p:txBody>
-      </p:sp>
-      <p:sp>
-        <p:nvSpPr>
-          <p:cNvPr id="116" name="TextBox 115"/>
-          <p:cNvSpPr txBox="1"/>
-          <p:nvPr/>
-        </p:nvSpPr>
-        <p:spPr>
-          <a:xfrm>
-            <a:off x="6592824" y="6309359"/>
-            <a:ext cx="5102352" cy="777240"/>
-          </a:xfrm>
-          <a:prstGeom prst="rect">
-            <a:avLst/>
-          </a:prstGeom>
-          <a:noFill/>
-        </p:spPr>
-        <p:txBody>
-          <a:bodyPr wrap="square">
-            <a:spAutoFit/>
-          </a:bodyPr>
-          <a:lstStyle/>
-          <a:p>
-            <a:pPr algn="ctr" rtl="1"/>
-            <a:r>
-              <a:rPr sz="1100" b="0">
-                <a:solidFill>
-                  <a:srgbClr val="FFFFFF"/>
-                </a:solidFill>
-              </a:rPr>
-              <a:t>محتوى تعليمي مُصنَّف
-ومراقَب من الإدارة</a:t>
-            </a:r>
-          </a:p>
-        </p:txBody>
-      </p:sp>
-      <p:sp>
-        <p:nvSpPr>
-          <p:cNvPr id="117" name="TextBox 116"/>
-          <p:cNvSpPr txBox="1"/>
-          <p:nvPr/>
-        </p:nvSpPr>
-        <p:spPr>
-          <a:xfrm>
-            <a:off x="6592824" y="7104888"/>
-            <a:ext cx="5102352" cy="594360"/>
-          </a:xfrm>
-          <a:prstGeom prst="rect">
-            <a:avLst/>
-          </a:prstGeom>
-          <a:noFill/>
-        </p:spPr>
-        <p:txBody>
-          <a:bodyPr wrap="square">
-            <a:spAutoFit/>
-          </a:bodyPr>
-          <a:lstStyle/>
-          <a:p>
-            <a:pPr algn="ctr"/>
-            <a:r>
-              <a:rPr sz="900" b="0">
-                <a:solidFill>
-                  <a:srgbClr val="A0B9DC"/>
-                </a:solidFill>
-              </a:rPr>
-              <a:t>Curated educational content
-monitored by administration</a:t>
-            </a:r>
-          </a:p>
-        </p:txBody>
-      </p:sp>
-      <p:pic>
-        <p:nvPicPr>
-          <p:cNvPr id="118" name="Picture 117" descr="img4c.jpg"/>
-          <p:cNvPicPr>
-            <a:picLocks noChangeAspect="1"/>
-          </p:cNvPicPr>
-          <p:nvPr/>
-        </p:nvPicPr>
-        <p:blipFill>
-          <a:blip r:embed="rId7"/>
-          <a:stretch>
-            <a:fillRect/>
-          </a:stretch>
-        </p:blipFill>
-        <p:spPr>
-          <a:xfrm>
-            <a:off x="12316968" y="1234440"/>
-            <a:ext cx="5285232" cy="4206240"/>
-          </a:xfrm>
-          <a:prstGeom prst="rect">
-            <a:avLst/>
-          </a:prstGeom>
-        </p:spPr>
-      </p:pic>
-      <p:sp>
-        <p:nvSpPr>
-          <p:cNvPr id="119" name="Rectangle 118"/>
-          <p:cNvSpPr/>
-          <p:nvPr/>
-        </p:nvSpPr>
-        <p:spPr>
-          <a:xfrm>
-            <a:off x="12316968" y="5440679"/>
-            <a:ext cx="5285232" cy="4709160"/>
+            <a:off x="1170432" y="1143000"/>
+            <a:ext cx="5120640" cy="64008"/>
           </a:xfrm>
           <a:prstGeom prst="rect">
             <a:avLst/>
           </a:prstGeom>
           <a:solidFill>
-            <a:srgbClr val="223860"/>
+            <a:srgbClr val="C9A84C"/>
           </a:solidFill>
           <a:ln>
             <a:noFill/>
@@ -7463,23 +8250,25 @@
       </p:sp>
       <p:sp>
         <p:nvSpPr>
-          <p:cNvPr id="120" name="Rectangle 119"/>
+          <p:cNvPr id="13" name="Oval 12"/>
           <p:cNvSpPr/>
           <p:nvPr/>
         </p:nvSpPr>
         <p:spPr>
           <a:xfrm>
-            <a:off x="12316968" y="5440679"/>
-            <a:ext cx="5285232" cy="64008"/>
-          </a:xfrm>
-          <a:prstGeom prst="rect">
+            <a:off x="3090672" y="1325880"/>
+            <a:ext cx="1280160" cy="1280160"/>
+          </a:xfrm>
+          <a:prstGeom prst="ellipse">
             <a:avLst/>
           </a:prstGeom>
           <a:solidFill>
-            <a:srgbClr val="C9A84C"/>
+            <a:srgbClr val="1A2A4A"/>
           </a:solidFill>
-          <a:ln>
-            <a:noFill/>
+          <a:ln w="31750">
+            <a:solidFill>
+              <a:srgbClr val="C9A84C"/>
+            </a:solidFill>
           </a:ln>
         </p:spPr>
         <p:style>
@@ -7506,14 +8295,14 @@
       </p:sp>
       <p:sp>
         <p:nvSpPr>
-          <p:cNvPr id="121" name="TextBox 120"/>
+          <p:cNvPr id="14" name="TextBox 13"/>
           <p:cNvSpPr txBox="1"/>
           <p:nvPr/>
         </p:nvSpPr>
         <p:spPr>
           <a:xfrm>
-            <a:off x="12408408" y="5550407"/>
-            <a:ext cx="5102352" cy="438912"/>
+            <a:off x="3090672" y="1508760"/>
+            <a:ext cx="1280160" cy="1005840"/>
           </a:xfrm>
           <a:prstGeom prst="rect">
             <a:avLst/>
@@ -7528,130 +8317,27 @@
           <a:p>
             <a:pPr algn="ctr" rtl="1"/>
             <a:r>
-              <a:rPr sz="1400" b="1">
+              <a:rPr sz="3200" b="1">
                 <a:solidFill>
                   <a:srgbClr val="C9A84C"/>
                 </a:solidFill>
+                <a:latin typeface="Noto Sans Arabic"/>
               </a:rPr>
-              <a:t>تواصل تحت الإشراف</a:t>
+              <a:t>1</a:t>
             </a:r>
           </a:p>
         </p:txBody>
       </p:sp>
       <p:sp>
         <p:nvSpPr>
-          <p:cNvPr id="122" name="TextBox 121"/>
-          <p:cNvSpPr txBox="1"/>
+          <p:cNvPr id="15" name="Rectangle 14"/>
+          <p:cNvSpPr/>
           <p:nvPr/>
         </p:nvSpPr>
         <p:spPr>
           <a:xfrm>
-            <a:off x="12408408" y="5971031"/>
-            <a:ext cx="5102352" cy="292608"/>
-          </a:xfrm>
-          <a:prstGeom prst="rect">
-            <a:avLst/>
-          </a:prstGeom>
-          <a:noFill/>
-        </p:spPr>
-        <p:txBody>
-          <a:bodyPr wrap="square">
-            <a:spAutoFit/>
-          </a:bodyPr>
-          <a:lstStyle/>
-          <a:p>
-            <a:pPr algn="ctr"/>
-            <a:r>
-              <a:rPr sz="900" b="0">
-                <a:solidFill>
-                  <a:srgbClr val="B4C8E6"/>
-                </a:solidFill>
-              </a:rPr>
-              <a:t>Supervised Communication</a:t>
-            </a:r>
-          </a:p>
-        </p:txBody>
-      </p:sp>
-      <p:sp>
-        <p:nvSpPr>
-          <p:cNvPr id="123" name="TextBox 122"/>
-          <p:cNvSpPr txBox="1"/>
-          <p:nvPr/>
-        </p:nvSpPr>
-        <p:spPr>
-          <a:xfrm>
-            <a:off x="12408408" y="6309359"/>
-            <a:ext cx="5102352" cy="777240"/>
-          </a:xfrm>
-          <a:prstGeom prst="rect">
-            <a:avLst/>
-          </a:prstGeom>
-          <a:noFill/>
-        </p:spPr>
-        <p:txBody>
-          <a:bodyPr wrap="square">
-            <a:spAutoFit/>
-          </a:bodyPr>
-          <a:lstStyle/>
-          <a:p>
-            <a:pPr algn="ctr" rtl="1"/>
-            <a:r>
-              <a:rPr sz="1100" b="0">
-                <a:solidFill>
-                  <a:srgbClr val="FFFFFF"/>
-                </a:solidFill>
-              </a:rPr>
-              <a:t>تواصل المعلم والطالب
-تحت إشراف رسمي</a:t>
-            </a:r>
-          </a:p>
-        </p:txBody>
-      </p:sp>
-      <p:sp>
-        <p:nvSpPr>
-          <p:cNvPr id="124" name="TextBox 123"/>
-          <p:cNvSpPr txBox="1"/>
-          <p:nvPr/>
-        </p:nvSpPr>
-        <p:spPr>
-          <a:xfrm>
-            <a:off x="12408408" y="7104888"/>
-            <a:ext cx="5102352" cy="594360"/>
-          </a:xfrm>
-          <a:prstGeom prst="rect">
-            <a:avLst/>
-          </a:prstGeom>
-          <a:noFill/>
-        </p:spPr>
-        <p:txBody>
-          <a:bodyPr wrap="square">
-            <a:spAutoFit/>
-          </a:bodyPr>
-          <a:lstStyle/>
-          <a:p>
-            <a:pPr algn="ctr"/>
-            <a:r>
-              <a:rPr sz="900" b="0">
-                <a:solidFill>
-                  <a:srgbClr val="A0B9DC"/>
-                </a:solidFill>
-              </a:rPr>
-              <a:t>Teacher-student contact
-under official supervision</a:t>
-            </a:r>
-          </a:p>
-        </p:txBody>
-      </p:sp>
-      <p:sp>
-        <p:nvSpPr>
-          <p:cNvPr id="125" name="Rectangle 124"/>
-          <p:cNvSpPr/>
-          <p:nvPr/>
-        </p:nvSpPr>
-        <p:spPr>
-          <a:xfrm>
-            <a:off x="0" y="9857232"/>
-            <a:ext cx="18288000" cy="91440"/>
+            <a:off x="1444752" y="2743200"/>
+            <a:ext cx="4572000" cy="27432"/>
           </a:xfrm>
           <a:prstGeom prst="rect">
             <a:avLst/>
@@ -7682,6 +8368,1296 @@
           <a:lstStyle/>
           <a:p>
             <a:pPr algn="ctr"/>
+          </a:p>
+        </p:txBody>
+      </p:sp>
+      <p:sp>
+        <p:nvSpPr>
+          <p:cNvPr id="16" name="TextBox 15"/>
+          <p:cNvSpPr txBox="1"/>
+          <p:nvPr/>
+        </p:nvSpPr>
+        <p:spPr>
+          <a:xfrm>
+            <a:off x="1261872" y="2834640"/>
+            <a:ext cx="4937760" cy="457200"/>
+          </a:xfrm>
+          <a:prstGeom prst="rect">
+            <a:avLst/>
+          </a:prstGeom>
+          <a:noFill/>
+        </p:spPr>
+        <p:txBody>
+          <a:bodyPr wrap="square">
+            <a:spAutoFit/>
+          </a:bodyPr>
+          <a:lstStyle/>
+          <a:p>
+            <a:pPr algn="ctr" rtl="1"/>
+            <a:r>
+              <a:rPr sz="1700" b="1">
+                <a:solidFill>
+                  <a:srgbClr val="C9A84C"/>
+                </a:solidFill>
+                <a:latin typeface="Noto Sans Arabic"/>
+              </a:rPr>
+              <a:t>خصوصية البيانات</a:t>
+            </a:r>
+          </a:p>
+        </p:txBody>
+      </p:sp>
+      <p:sp>
+        <p:nvSpPr>
+          <p:cNvPr id="17" name="TextBox 16"/>
+          <p:cNvSpPr txBox="1"/>
+          <p:nvPr/>
+        </p:nvSpPr>
+        <p:spPr>
+          <a:xfrm>
+            <a:off x="1261872" y="3246120"/>
+            <a:ext cx="4937760" cy="274320"/>
+          </a:xfrm>
+          <a:prstGeom prst="rect">
+            <a:avLst/>
+          </a:prstGeom>
+          <a:noFill/>
+        </p:spPr>
+        <p:txBody>
+          <a:bodyPr wrap="square">
+            <a:spAutoFit/>
+          </a:bodyPr>
+          <a:lstStyle/>
+          <a:p>
+            <a:pPr algn="ctr"/>
+            <a:r>
+              <a:rPr sz="1100" b="0">
+                <a:solidFill>
+                  <a:srgbClr val="CCCCCC"/>
+                </a:solidFill>
+                <a:latin typeface="Noto Sans Arabic"/>
+              </a:rPr>
+              <a:t>Data Privacy</a:t>
+            </a:r>
+          </a:p>
+        </p:txBody>
+      </p:sp>
+      <p:sp>
+        <p:nvSpPr>
+          <p:cNvPr id="18" name="TextBox 17"/>
+          <p:cNvSpPr txBox="1"/>
+          <p:nvPr/>
+        </p:nvSpPr>
+        <p:spPr>
+          <a:xfrm>
+            <a:off x="1307592" y="3566160"/>
+            <a:ext cx="4846320" cy="548640"/>
+          </a:xfrm>
+          <a:prstGeom prst="rect">
+            <a:avLst/>
+          </a:prstGeom>
+          <a:noFill/>
+        </p:spPr>
+        <p:txBody>
+          <a:bodyPr wrap="square">
+            <a:spAutoFit/>
+          </a:bodyPr>
+          <a:lstStyle/>
+          <a:p>
+            <a:pPr algn="ctr" rtl="1"/>
+            <a:r>
+              <a:rPr sz="1200" b="0">
+                <a:solidFill>
+                  <a:srgbClr val="FFFFFF"/>
+                </a:solidFill>
+                <a:latin typeface="Noto Sans Arabic"/>
+              </a:rPr>
+              <a:t>بيانات الطلاب محمية داخل بيئة مغلقة — لا وصول خارجي</a:t>
+            </a:r>
+          </a:p>
+        </p:txBody>
+      </p:sp>
+      <p:sp>
+        <p:nvSpPr>
+          <p:cNvPr id="19" name="TextBox 18"/>
+          <p:cNvSpPr txBox="1"/>
+          <p:nvPr/>
+        </p:nvSpPr>
+        <p:spPr>
+          <a:xfrm>
+            <a:off x="1307592" y="4069080"/>
+            <a:ext cx="4846320" cy="228600"/>
+          </a:xfrm>
+          <a:prstGeom prst="rect">
+            <a:avLst/>
+          </a:prstGeom>
+          <a:noFill/>
+        </p:spPr>
+        <p:txBody>
+          <a:bodyPr wrap="square">
+            <a:spAutoFit/>
+          </a:bodyPr>
+          <a:lstStyle/>
+          <a:p>
+            <a:pPr algn="ctr"/>
+            <a:r>
+              <a:rPr sz="950" b="0">
+                <a:solidFill>
+                  <a:srgbClr val="AAAAAA"/>
+                </a:solidFill>
+                <a:latin typeface="Noto Sans Arabic"/>
+              </a:rPr>
+              <a:t>Student data secured in a closed environment — no external access</a:t>
+            </a:r>
+          </a:p>
+        </p:txBody>
+      </p:sp>
+      <p:sp>
+        <p:nvSpPr>
+          <p:cNvPr id="20" name="Rounded Rectangle 19"/>
+          <p:cNvSpPr/>
+          <p:nvPr/>
+        </p:nvSpPr>
+        <p:spPr>
+          <a:xfrm>
+            <a:off x="6583680" y="1143000"/>
+            <a:ext cx="5120640" cy="3200400"/>
+          </a:xfrm>
+          <a:prstGeom prst="roundRect">
+            <a:avLst>
+              <a:gd name="adj" fmla="val 4000"/>
+            </a:avLst>
+          </a:prstGeom>
+          <a:solidFill>
+            <a:srgbClr val="223A5E"/>
+          </a:solidFill>
+          <a:ln w="19050">
+            <a:solidFill>
+              <a:srgbClr val="C9A84C"/>
+            </a:solidFill>
+          </a:ln>
+        </p:spPr>
+        <p:style>
+          <a:lnRef idx="1">
+            <a:schemeClr val="accent1"/>
+          </a:lnRef>
+          <a:fillRef idx="3">
+            <a:schemeClr val="accent1"/>
+          </a:fillRef>
+          <a:effectRef idx="2">
+            <a:schemeClr val="accent1"/>
+          </a:effectRef>
+          <a:fontRef idx="minor">
+            <a:schemeClr val="lt1"/>
+          </a:fontRef>
+        </p:style>
+        <p:txBody>
+          <a:bodyPr rtlCol="0" anchor="ctr"/>
+          <a:lstStyle/>
+          <a:p>
+            <a:pPr algn="ctr"/>
+          </a:p>
+        </p:txBody>
+      </p:sp>
+      <p:sp>
+        <p:nvSpPr>
+          <p:cNvPr id="21" name="Rectangle 20"/>
+          <p:cNvSpPr/>
+          <p:nvPr/>
+        </p:nvSpPr>
+        <p:spPr>
+          <a:xfrm>
+            <a:off x="6583680" y="1143000"/>
+            <a:ext cx="5120640" cy="64008"/>
+          </a:xfrm>
+          <a:prstGeom prst="rect">
+            <a:avLst/>
+          </a:prstGeom>
+          <a:solidFill>
+            <a:srgbClr val="C9A84C"/>
+          </a:solidFill>
+          <a:ln>
+            <a:noFill/>
+          </a:ln>
+        </p:spPr>
+        <p:style>
+          <a:lnRef idx="1">
+            <a:schemeClr val="accent1"/>
+          </a:lnRef>
+          <a:fillRef idx="3">
+            <a:schemeClr val="accent1"/>
+          </a:fillRef>
+          <a:effectRef idx="2">
+            <a:schemeClr val="accent1"/>
+          </a:effectRef>
+          <a:fontRef idx="minor">
+            <a:schemeClr val="lt1"/>
+          </a:fontRef>
+        </p:style>
+        <p:txBody>
+          <a:bodyPr rtlCol="0" anchor="ctr"/>
+          <a:lstStyle/>
+          <a:p>
+            <a:pPr algn="ctr"/>
+          </a:p>
+        </p:txBody>
+      </p:sp>
+      <p:sp>
+        <p:nvSpPr>
+          <p:cNvPr id="22" name="Oval 21"/>
+          <p:cNvSpPr/>
+          <p:nvPr/>
+        </p:nvSpPr>
+        <p:spPr>
+          <a:xfrm>
+            <a:off x="8503920" y="1325880"/>
+            <a:ext cx="1280160" cy="1280160"/>
+          </a:xfrm>
+          <a:prstGeom prst="ellipse">
+            <a:avLst/>
+          </a:prstGeom>
+          <a:solidFill>
+            <a:srgbClr val="1A2A4A"/>
+          </a:solidFill>
+          <a:ln w="31750">
+            <a:solidFill>
+              <a:srgbClr val="C9A84C"/>
+            </a:solidFill>
+          </a:ln>
+        </p:spPr>
+        <p:style>
+          <a:lnRef idx="1">
+            <a:schemeClr val="accent1"/>
+          </a:lnRef>
+          <a:fillRef idx="3">
+            <a:schemeClr val="accent1"/>
+          </a:fillRef>
+          <a:effectRef idx="2">
+            <a:schemeClr val="accent1"/>
+          </a:effectRef>
+          <a:fontRef idx="minor">
+            <a:schemeClr val="lt1"/>
+          </a:fontRef>
+        </p:style>
+        <p:txBody>
+          <a:bodyPr rtlCol="0" anchor="ctr"/>
+          <a:lstStyle/>
+          <a:p>
+            <a:pPr algn="ctr"/>
+          </a:p>
+        </p:txBody>
+      </p:sp>
+      <p:sp>
+        <p:nvSpPr>
+          <p:cNvPr id="23" name="TextBox 22"/>
+          <p:cNvSpPr txBox="1"/>
+          <p:nvPr/>
+        </p:nvSpPr>
+        <p:spPr>
+          <a:xfrm>
+            <a:off x="8503920" y="1508760"/>
+            <a:ext cx="1280160" cy="1005840"/>
+          </a:xfrm>
+          <a:prstGeom prst="rect">
+            <a:avLst/>
+          </a:prstGeom>
+          <a:noFill/>
+        </p:spPr>
+        <p:txBody>
+          <a:bodyPr wrap="square">
+            <a:spAutoFit/>
+          </a:bodyPr>
+          <a:lstStyle/>
+          <a:p>
+            <a:pPr algn="ctr" rtl="1"/>
+            <a:r>
+              <a:rPr sz="3200" b="1">
+                <a:solidFill>
+                  <a:srgbClr val="C9A84C"/>
+                </a:solidFill>
+                <a:latin typeface="Noto Sans Arabic"/>
+              </a:rPr>
+              <a:t>2</a:t>
+            </a:r>
+          </a:p>
+        </p:txBody>
+      </p:sp>
+      <p:sp>
+        <p:nvSpPr>
+          <p:cNvPr id="24" name="Rectangle 23"/>
+          <p:cNvSpPr/>
+          <p:nvPr/>
+        </p:nvSpPr>
+        <p:spPr>
+          <a:xfrm>
+            <a:off x="6858000" y="2743200"/>
+            <a:ext cx="4572000" cy="27432"/>
+          </a:xfrm>
+          <a:prstGeom prst="rect">
+            <a:avLst/>
+          </a:prstGeom>
+          <a:solidFill>
+            <a:srgbClr val="C9A84C"/>
+          </a:solidFill>
+          <a:ln>
+            <a:noFill/>
+          </a:ln>
+        </p:spPr>
+        <p:style>
+          <a:lnRef idx="1">
+            <a:schemeClr val="accent1"/>
+          </a:lnRef>
+          <a:fillRef idx="3">
+            <a:schemeClr val="accent1"/>
+          </a:fillRef>
+          <a:effectRef idx="2">
+            <a:schemeClr val="accent1"/>
+          </a:effectRef>
+          <a:fontRef idx="minor">
+            <a:schemeClr val="lt1"/>
+          </a:fontRef>
+        </p:style>
+        <p:txBody>
+          <a:bodyPr rtlCol="0" anchor="ctr"/>
+          <a:lstStyle/>
+          <a:p>
+            <a:pPr algn="ctr"/>
+          </a:p>
+        </p:txBody>
+      </p:sp>
+      <p:sp>
+        <p:nvSpPr>
+          <p:cNvPr id="25" name="TextBox 24"/>
+          <p:cNvSpPr txBox="1"/>
+          <p:nvPr/>
+        </p:nvSpPr>
+        <p:spPr>
+          <a:xfrm>
+            <a:off x="6675120" y="2834640"/>
+            <a:ext cx="4937760" cy="457200"/>
+          </a:xfrm>
+          <a:prstGeom prst="rect">
+            <a:avLst/>
+          </a:prstGeom>
+          <a:noFill/>
+        </p:spPr>
+        <p:txBody>
+          <a:bodyPr wrap="square">
+            <a:spAutoFit/>
+          </a:bodyPr>
+          <a:lstStyle/>
+          <a:p>
+            <a:pPr algn="ctr" rtl="1"/>
+            <a:r>
+              <a:rPr sz="1700" b="1">
+                <a:solidFill>
+                  <a:srgbClr val="C9A84C"/>
+                </a:solidFill>
+                <a:latin typeface="Noto Sans Arabic"/>
+              </a:rPr>
+              <a:t>محتوى موجَّه وآمن</a:t>
+            </a:r>
+          </a:p>
+        </p:txBody>
+      </p:sp>
+      <p:sp>
+        <p:nvSpPr>
+          <p:cNvPr id="26" name="TextBox 25"/>
+          <p:cNvSpPr txBox="1"/>
+          <p:nvPr/>
+        </p:nvSpPr>
+        <p:spPr>
+          <a:xfrm>
+            <a:off x="6675120" y="3246120"/>
+            <a:ext cx="4937760" cy="274320"/>
+          </a:xfrm>
+          <a:prstGeom prst="rect">
+            <a:avLst/>
+          </a:prstGeom>
+          <a:noFill/>
+        </p:spPr>
+        <p:txBody>
+          <a:bodyPr wrap="square">
+            <a:spAutoFit/>
+          </a:bodyPr>
+          <a:lstStyle/>
+          <a:p>
+            <a:pPr algn="ctr"/>
+            <a:r>
+              <a:rPr sz="1100" b="0">
+                <a:solidFill>
+                  <a:srgbClr val="CCCCCC"/>
+                </a:solidFill>
+                <a:latin typeface="Noto Sans Arabic"/>
+              </a:rPr>
+              <a:t>Safe Guided Content</a:t>
+            </a:r>
+          </a:p>
+        </p:txBody>
+      </p:sp>
+      <p:sp>
+        <p:nvSpPr>
+          <p:cNvPr id="27" name="TextBox 26"/>
+          <p:cNvSpPr txBox="1"/>
+          <p:nvPr/>
+        </p:nvSpPr>
+        <p:spPr>
+          <a:xfrm>
+            <a:off x="6720840" y="3566160"/>
+            <a:ext cx="4846320" cy="548640"/>
+          </a:xfrm>
+          <a:prstGeom prst="rect">
+            <a:avLst/>
+          </a:prstGeom>
+          <a:noFill/>
+        </p:spPr>
+        <p:txBody>
+          <a:bodyPr wrap="square">
+            <a:spAutoFit/>
+          </a:bodyPr>
+          <a:lstStyle/>
+          <a:p>
+            <a:pPr algn="ctr" rtl="1"/>
+            <a:r>
+              <a:rPr sz="1200" b="0">
+                <a:solidFill>
+                  <a:srgbClr val="FFFFFF"/>
+                </a:solidFill>
+                <a:latin typeface="Noto Sans Arabic"/>
+              </a:rPr>
+              <a:t>محتوى تعليمي مُصنَّف ومراقَب من الإدارة</a:t>
+            </a:r>
+          </a:p>
+        </p:txBody>
+      </p:sp>
+      <p:sp>
+        <p:nvSpPr>
+          <p:cNvPr id="28" name="TextBox 27"/>
+          <p:cNvSpPr txBox="1"/>
+          <p:nvPr/>
+        </p:nvSpPr>
+        <p:spPr>
+          <a:xfrm>
+            <a:off x="6720840" y="4069080"/>
+            <a:ext cx="4846320" cy="228600"/>
+          </a:xfrm>
+          <a:prstGeom prst="rect">
+            <a:avLst/>
+          </a:prstGeom>
+          <a:noFill/>
+        </p:spPr>
+        <p:txBody>
+          <a:bodyPr wrap="square">
+            <a:spAutoFit/>
+          </a:bodyPr>
+          <a:lstStyle/>
+          <a:p>
+            <a:pPr algn="ctr"/>
+            <a:r>
+              <a:rPr sz="950" b="0">
+                <a:solidFill>
+                  <a:srgbClr val="AAAAAA"/>
+                </a:solidFill>
+                <a:latin typeface="Noto Sans Arabic"/>
+              </a:rPr>
+              <a:t>Curated educational content monitored by administration</a:t>
+            </a:r>
+          </a:p>
+        </p:txBody>
+      </p:sp>
+      <p:sp>
+        <p:nvSpPr>
+          <p:cNvPr id="29" name="Rounded Rectangle 28"/>
+          <p:cNvSpPr/>
+          <p:nvPr/>
+        </p:nvSpPr>
+        <p:spPr>
+          <a:xfrm>
+            <a:off x="11996928" y="1143000"/>
+            <a:ext cx="5120640" cy="3200400"/>
+          </a:xfrm>
+          <a:prstGeom prst="roundRect">
+            <a:avLst>
+              <a:gd name="adj" fmla="val 4000"/>
+            </a:avLst>
+          </a:prstGeom>
+          <a:solidFill>
+            <a:srgbClr val="223A5E"/>
+          </a:solidFill>
+          <a:ln w="19050">
+            <a:solidFill>
+              <a:srgbClr val="C9A84C"/>
+            </a:solidFill>
+          </a:ln>
+        </p:spPr>
+        <p:style>
+          <a:lnRef idx="1">
+            <a:schemeClr val="accent1"/>
+          </a:lnRef>
+          <a:fillRef idx="3">
+            <a:schemeClr val="accent1"/>
+          </a:fillRef>
+          <a:effectRef idx="2">
+            <a:schemeClr val="accent1"/>
+          </a:effectRef>
+          <a:fontRef idx="minor">
+            <a:schemeClr val="lt1"/>
+          </a:fontRef>
+        </p:style>
+        <p:txBody>
+          <a:bodyPr rtlCol="0" anchor="ctr"/>
+          <a:lstStyle/>
+          <a:p>
+            <a:pPr algn="ctr"/>
+          </a:p>
+        </p:txBody>
+      </p:sp>
+      <p:sp>
+        <p:nvSpPr>
+          <p:cNvPr id="30" name="Rectangle 29"/>
+          <p:cNvSpPr/>
+          <p:nvPr/>
+        </p:nvSpPr>
+        <p:spPr>
+          <a:xfrm>
+            <a:off x="11996928" y="1143000"/>
+            <a:ext cx="5120640" cy="64008"/>
+          </a:xfrm>
+          <a:prstGeom prst="rect">
+            <a:avLst/>
+          </a:prstGeom>
+          <a:solidFill>
+            <a:srgbClr val="C9A84C"/>
+          </a:solidFill>
+          <a:ln>
+            <a:noFill/>
+          </a:ln>
+        </p:spPr>
+        <p:style>
+          <a:lnRef idx="1">
+            <a:schemeClr val="accent1"/>
+          </a:lnRef>
+          <a:fillRef idx="3">
+            <a:schemeClr val="accent1"/>
+          </a:fillRef>
+          <a:effectRef idx="2">
+            <a:schemeClr val="accent1"/>
+          </a:effectRef>
+          <a:fontRef idx="minor">
+            <a:schemeClr val="lt1"/>
+          </a:fontRef>
+        </p:style>
+        <p:txBody>
+          <a:bodyPr rtlCol="0" anchor="ctr"/>
+          <a:lstStyle/>
+          <a:p>
+            <a:pPr algn="ctr"/>
+          </a:p>
+        </p:txBody>
+      </p:sp>
+      <p:sp>
+        <p:nvSpPr>
+          <p:cNvPr id="31" name="Oval 30"/>
+          <p:cNvSpPr/>
+          <p:nvPr/>
+        </p:nvSpPr>
+        <p:spPr>
+          <a:xfrm>
+            <a:off x="13917168" y="1325880"/>
+            <a:ext cx="1280160" cy="1280160"/>
+          </a:xfrm>
+          <a:prstGeom prst="ellipse">
+            <a:avLst/>
+          </a:prstGeom>
+          <a:solidFill>
+            <a:srgbClr val="1A2A4A"/>
+          </a:solidFill>
+          <a:ln w="31750">
+            <a:solidFill>
+              <a:srgbClr val="C9A84C"/>
+            </a:solidFill>
+          </a:ln>
+        </p:spPr>
+        <p:style>
+          <a:lnRef idx="1">
+            <a:schemeClr val="accent1"/>
+          </a:lnRef>
+          <a:fillRef idx="3">
+            <a:schemeClr val="accent1"/>
+          </a:fillRef>
+          <a:effectRef idx="2">
+            <a:schemeClr val="accent1"/>
+          </a:effectRef>
+          <a:fontRef idx="minor">
+            <a:schemeClr val="lt1"/>
+          </a:fontRef>
+        </p:style>
+        <p:txBody>
+          <a:bodyPr rtlCol="0" anchor="ctr"/>
+          <a:lstStyle/>
+          <a:p>
+            <a:pPr algn="ctr"/>
+          </a:p>
+        </p:txBody>
+      </p:sp>
+      <p:sp>
+        <p:nvSpPr>
+          <p:cNvPr id="32" name="TextBox 31"/>
+          <p:cNvSpPr txBox="1"/>
+          <p:nvPr/>
+        </p:nvSpPr>
+        <p:spPr>
+          <a:xfrm>
+            <a:off x="13917168" y="1508760"/>
+            <a:ext cx="1280160" cy="1005840"/>
+          </a:xfrm>
+          <a:prstGeom prst="rect">
+            <a:avLst/>
+          </a:prstGeom>
+          <a:noFill/>
+        </p:spPr>
+        <p:txBody>
+          <a:bodyPr wrap="square">
+            <a:spAutoFit/>
+          </a:bodyPr>
+          <a:lstStyle/>
+          <a:p>
+            <a:pPr algn="ctr" rtl="1"/>
+            <a:r>
+              <a:rPr sz="3200" b="1">
+                <a:solidFill>
+                  <a:srgbClr val="C9A84C"/>
+                </a:solidFill>
+                <a:latin typeface="Noto Sans Arabic"/>
+              </a:rPr>
+              <a:t>3</a:t>
+            </a:r>
+          </a:p>
+        </p:txBody>
+      </p:sp>
+      <p:sp>
+        <p:nvSpPr>
+          <p:cNvPr id="33" name="Rectangle 32"/>
+          <p:cNvSpPr/>
+          <p:nvPr/>
+        </p:nvSpPr>
+        <p:spPr>
+          <a:xfrm>
+            <a:off x="12271248" y="2743200"/>
+            <a:ext cx="4572000" cy="27432"/>
+          </a:xfrm>
+          <a:prstGeom prst="rect">
+            <a:avLst/>
+          </a:prstGeom>
+          <a:solidFill>
+            <a:srgbClr val="C9A84C"/>
+          </a:solidFill>
+          <a:ln>
+            <a:noFill/>
+          </a:ln>
+        </p:spPr>
+        <p:style>
+          <a:lnRef idx="1">
+            <a:schemeClr val="accent1"/>
+          </a:lnRef>
+          <a:fillRef idx="3">
+            <a:schemeClr val="accent1"/>
+          </a:fillRef>
+          <a:effectRef idx="2">
+            <a:schemeClr val="accent1"/>
+          </a:effectRef>
+          <a:fontRef idx="minor">
+            <a:schemeClr val="lt1"/>
+          </a:fontRef>
+        </p:style>
+        <p:txBody>
+          <a:bodyPr rtlCol="0" anchor="ctr"/>
+          <a:lstStyle/>
+          <a:p>
+            <a:pPr algn="ctr"/>
+          </a:p>
+        </p:txBody>
+      </p:sp>
+      <p:sp>
+        <p:nvSpPr>
+          <p:cNvPr id="34" name="TextBox 33"/>
+          <p:cNvSpPr txBox="1"/>
+          <p:nvPr/>
+        </p:nvSpPr>
+        <p:spPr>
+          <a:xfrm>
+            <a:off x="12088368" y="2834640"/>
+            <a:ext cx="4937760" cy="457200"/>
+          </a:xfrm>
+          <a:prstGeom prst="rect">
+            <a:avLst/>
+          </a:prstGeom>
+          <a:noFill/>
+        </p:spPr>
+        <p:txBody>
+          <a:bodyPr wrap="square">
+            <a:spAutoFit/>
+          </a:bodyPr>
+          <a:lstStyle/>
+          <a:p>
+            <a:pPr algn="ctr" rtl="1"/>
+            <a:r>
+              <a:rPr sz="1700" b="1">
+                <a:solidFill>
+                  <a:srgbClr val="C9A84C"/>
+                </a:solidFill>
+                <a:latin typeface="Noto Sans Arabic"/>
+              </a:rPr>
+              <a:t>تواصل تحت الإشراف</a:t>
+            </a:r>
+          </a:p>
+        </p:txBody>
+      </p:sp>
+      <p:sp>
+        <p:nvSpPr>
+          <p:cNvPr id="35" name="TextBox 34"/>
+          <p:cNvSpPr txBox="1"/>
+          <p:nvPr/>
+        </p:nvSpPr>
+        <p:spPr>
+          <a:xfrm>
+            <a:off x="12088368" y="3246120"/>
+            <a:ext cx="4937760" cy="274320"/>
+          </a:xfrm>
+          <a:prstGeom prst="rect">
+            <a:avLst/>
+          </a:prstGeom>
+          <a:noFill/>
+        </p:spPr>
+        <p:txBody>
+          <a:bodyPr wrap="square">
+            <a:spAutoFit/>
+          </a:bodyPr>
+          <a:lstStyle/>
+          <a:p>
+            <a:pPr algn="ctr"/>
+            <a:r>
+              <a:rPr sz="1100" b="0">
+                <a:solidFill>
+                  <a:srgbClr val="CCCCCC"/>
+                </a:solidFill>
+                <a:latin typeface="Noto Sans Arabic"/>
+              </a:rPr>
+              <a:t>Supervised Communication</a:t>
+            </a:r>
+          </a:p>
+        </p:txBody>
+      </p:sp>
+      <p:sp>
+        <p:nvSpPr>
+          <p:cNvPr id="36" name="TextBox 35"/>
+          <p:cNvSpPr txBox="1"/>
+          <p:nvPr/>
+        </p:nvSpPr>
+        <p:spPr>
+          <a:xfrm>
+            <a:off x="12134088" y="3566160"/>
+            <a:ext cx="4846320" cy="548640"/>
+          </a:xfrm>
+          <a:prstGeom prst="rect">
+            <a:avLst/>
+          </a:prstGeom>
+          <a:noFill/>
+        </p:spPr>
+        <p:txBody>
+          <a:bodyPr wrap="square">
+            <a:spAutoFit/>
+          </a:bodyPr>
+          <a:lstStyle/>
+          <a:p>
+            <a:pPr algn="ctr" rtl="1"/>
+            <a:r>
+              <a:rPr sz="1200" b="0">
+                <a:solidFill>
+                  <a:srgbClr val="FFFFFF"/>
+                </a:solidFill>
+                <a:latin typeface="Noto Sans Arabic"/>
+              </a:rPr>
+              <a:t>تواصل المعلم والطالب تحت إشراف رسمي ومحدود</a:t>
+            </a:r>
+          </a:p>
+        </p:txBody>
+      </p:sp>
+      <p:sp>
+        <p:nvSpPr>
+          <p:cNvPr id="37" name="TextBox 36"/>
+          <p:cNvSpPr txBox="1"/>
+          <p:nvPr/>
+        </p:nvSpPr>
+        <p:spPr>
+          <a:xfrm>
+            <a:off x="12134088" y="4069080"/>
+            <a:ext cx="4846320" cy="228600"/>
+          </a:xfrm>
+          <a:prstGeom prst="rect">
+            <a:avLst/>
+          </a:prstGeom>
+          <a:noFill/>
+        </p:spPr>
+        <p:txBody>
+          <a:bodyPr wrap="square">
+            <a:spAutoFit/>
+          </a:bodyPr>
+          <a:lstStyle/>
+          <a:p>
+            <a:pPr algn="ctr"/>
+            <a:r>
+              <a:rPr sz="950" b="0">
+                <a:solidFill>
+                  <a:srgbClr val="AAAAAA"/>
+                </a:solidFill>
+                <a:latin typeface="Noto Sans Arabic"/>
+              </a:rPr>
+              <a:t>Teacher-student contact under official supervision</a:t>
+            </a:r>
+          </a:p>
+        </p:txBody>
+      </p:sp>
+      <p:sp>
+        <p:nvSpPr>
+          <p:cNvPr id="38" name="Rectangle 37"/>
+          <p:cNvSpPr/>
+          <p:nvPr/>
+        </p:nvSpPr>
+        <p:spPr>
+          <a:xfrm>
+            <a:off x="0" y="4526280"/>
+            <a:ext cx="6096000" cy="822960"/>
+          </a:xfrm>
+          <a:prstGeom prst="rect">
+            <a:avLst/>
+          </a:prstGeom>
+          <a:solidFill>
+            <a:srgbClr val="121E36"/>
+          </a:solidFill>
+          <a:ln>
+            <a:noFill/>
+          </a:ln>
+        </p:spPr>
+        <p:style>
+          <a:lnRef idx="1">
+            <a:schemeClr val="accent1"/>
+          </a:lnRef>
+          <a:fillRef idx="3">
+            <a:schemeClr val="accent1"/>
+          </a:fillRef>
+          <a:effectRef idx="2">
+            <a:schemeClr val="accent1"/>
+          </a:effectRef>
+          <a:fontRef idx="minor">
+            <a:schemeClr val="lt1"/>
+          </a:fontRef>
+        </p:style>
+        <p:txBody>
+          <a:bodyPr rtlCol="0" anchor="ctr"/>
+          <a:lstStyle/>
+          <a:p>
+            <a:pPr algn="ctr"/>
+          </a:p>
+        </p:txBody>
+      </p:sp>
+      <p:sp>
+        <p:nvSpPr>
+          <p:cNvPr id="39" name="TextBox 38"/>
+          <p:cNvSpPr txBox="1"/>
+          <p:nvPr/>
+        </p:nvSpPr>
+        <p:spPr>
+          <a:xfrm>
+            <a:off x="0" y="4544568"/>
+            <a:ext cx="6096000" cy="365760"/>
+          </a:xfrm>
+          <a:prstGeom prst="rect">
+            <a:avLst/>
+          </a:prstGeom>
+          <a:noFill/>
+        </p:spPr>
+        <p:txBody>
+          <a:bodyPr wrap="square">
+            <a:spAutoFit/>
+          </a:bodyPr>
+          <a:lstStyle/>
+          <a:p>
+            <a:pPr algn="ctr" rtl="1"/>
+            <a:r>
+              <a:rPr sz="2200" b="1">
+                <a:solidFill>
+                  <a:srgbClr val="C9A84C"/>
+                </a:solidFill>
+                <a:latin typeface="Noto Sans Arabic"/>
+              </a:rPr>
+              <a:t>74</a:t>
+            </a:r>
+          </a:p>
+        </p:txBody>
+      </p:sp>
+      <p:sp>
+        <p:nvSpPr>
+          <p:cNvPr id="40" name="TextBox 39"/>
+          <p:cNvSpPr txBox="1"/>
+          <p:nvPr/>
+        </p:nvSpPr>
+        <p:spPr>
+          <a:xfrm>
+            <a:off x="0" y="4910328"/>
+            <a:ext cx="6096000" cy="228600"/>
+          </a:xfrm>
+          <a:prstGeom prst="rect">
+            <a:avLst/>
+          </a:prstGeom>
+          <a:noFill/>
+        </p:spPr>
+        <p:txBody>
+          <a:bodyPr wrap="square">
+            <a:spAutoFit/>
+          </a:bodyPr>
+          <a:lstStyle/>
+          <a:p>
+            <a:pPr algn="ctr" rtl="1"/>
+            <a:r>
+              <a:rPr sz="1000" b="0">
+                <a:solidFill>
+                  <a:srgbClr val="FFFFFF"/>
+                </a:solidFill>
+                <a:latin typeface="Noto Sans Arabic"/>
+              </a:rPr>
+              <a:t>معلماً على البوابة</a:t>
+            </a:r>
+          </a:p>
+        </p:txBody>
+      </p:sp>
+      <p:sp>
+        <p:nvSpPr>
+          <p:cNvPr id="41" name="TextBox 40"/>
+          <p:cNvSpPr txBox="1"/>
+          <p:nvPr/>
+        </p:nvSpPr>
+        <p:spPr>
+          <a:xfrm>
+            <a:off x="0" y="5120640"/>
+            <a:ext cx="6096000" cy="201168"/>
+          </a:xfrm>
+          <a:prstGeom prst="rect">
+            <a:avLst/>
+          </a:prstGeom>
+          <a:noFill/>
+        </p:spPr>
+        <p:txBody>
+          <a:bodyPr wrap="square">
+            <a:spAutoFit/>
+          </a:bodyPr>
+          <a:lstStyle/>
+          <a:p>
+            <a:pPr algn="ctr"/>
+            <a:r>
+              <a:rPr sz="800" b="0">
+                <a:solidFill>
+                  <a:srgbClr val="AAAAAA"/>
+                </a:solidFill>
+                <a:latin typeface="Noto Sans Arabic"/>
+              </a:rPr>
+              <a:t>Teachers on portal</a:t>
+            </a:r>
+          </a:p>
+        </p:txBody>
+      </p:sp>
+      <p:sp>
+        <p:nvSpPr>
+          <p:cNvPr id="42" name="Rectangle 41"/>
+          <p:cNvSpPr/>
+          <p:nvPr/>
+        </p:nvSpPr>
+        <p:spPr>
+          <a:xfrm>
+            <a:off x="6096000" y="4526280"/>
+            <a:ext cx="6096000" cy="822960"/>
+          </a:xfrm>
+          <a:prstGeom prst="rect">
+            <a:avLst/>
+          </a:prstGeom>
+          <a:solidFill>
+            <a:srgbClr val="223A5E"/>
+          </a:solidFill>
+          <a:ln>
+            <a:noFill/>
+          </a:ln>
+        </p:spPr>
+        <p:style>
+          <a:lnRef idx="1">
+            <a:schemeClr val="accent1"/>
+          </a:lnRef>
+          <a:fillRef idx="3">
+            <a:schemeClr val="accent1"/>
+          </a:fillRef>
+          <a:effectRef idx="2">
+            <a:schemeClr val="accent1"/>
+          </a:effectRef>
+          <a:fontRef idx="minor">
+            <a:schemeClr val="lt1"/>
+          </a:fontRef>
+        </p:style>
+        <p:txBody>
+          <a:bodyPr rtlCol="0" anchor="ctr"/>
+          <a:lstStyle/>
+          <a:p>
+            <a:pPr algn="ctr"/>
+          </a:p>
+        </p:txBody>
+      </p:sp>
+      <p:sp>
+        <p:nvSpPr>
+          <p:cNvPr id="43" name="TextBox 42"/>
+          <p:cNvSpPr txBox="1"/>
+          <p:nvPr/>
+        </p:nvSpPr>
+        <p:spPr>
+          <a:xfrm>
+            <a:off x="6096000" y="4544568"/>
+            <a:ext cx="6096000" cy="365760"/>
+          </a:xfrm>
+          <a:prstGeom prst="rect">
+            <a:avLst/>
+          </a:prstGeom>
+          <a:noFill/>
+        </p:spPr>
+        <p:txBody>
+          <a:bodyPr wrap="square">
+            <a:spAutoFit/>
+          </a:bodyPr>
+          <a:lstStyle/>
+          <a:p>
+            <a:pPr algn="ctr" rtl="1"/>
+            <a:r>
+              <a:rPr sz="2200" b="1">
+                <a:solidFill>
+                  <a:srgbClr val="C9A84C"/>
+                </a:solidFill>
+                <a:latin typeface="Noto Sans Arabic"/>
+              </a:rPr>
+              <a:t>100%</a:t>
+            </a:r>
+          </a:p>
+        </p:txBody>
+      </p:sp>
+      <p:sp>
+        <p:nvSpPr>
+          <p:cNvPr id="44" name="TextBox 43"/>
+          <p:cNvSpPr txBox="1"/>
+          <p:nvPr/>
+        </p:nvSpPr>
+        <p:spPr>
+          <a:xfrm>
+            <a:off x="6096000" y="4910328"/>
+            <a:ext cx="6096000" cy="228600"/>
+          </a:xfrm>
+          <a:prstGeom prst="rect">
+            <a:avLst/>
+          </a:prstGeom>
+          <a:noFill/>
+        </p:spPr>
+        <p:txBody>
+          <a:bodyPr wrap="square">
+            <a:spAutoFit/>
+          </a:bodyPr>
+          <a:lstStyle/>
+          <a:p>
+            <a:pPr algn="ctr" rtl="1"/>
+            <a:r>
+              <a:rPr sz="1000" b="0">
+                <a:solidFill>
+                  <a:srgbClr val="FFFFFF"/>
+                </a:solidFill>
+                <a:latin typeface="Noto Sans Arabic"/>
+              </a:rPr>
+              <a:t>خصوصية بيانات الطلاب</a:t>
+            </a:r>
+          </a:p>
+        </p:txBody>
+      </p:sp>
+      <p:sp>
+        <p:nvSpPr>
+          <p:cNvPr id="45" name="TextBox 44"/>
+          <p:cNvSpPr txBox="1"/>
+          <p:nvPr/>
+        </p:nvSpPr>
+        <p:spPr>
+          <a:xfrm>
+            <a:off x="6096000" y="5120640"/>
+            <a:ext cx="6096000" cy="201168"/>
+          </a:xfrm>
+          <a:prstGeom prst="rect">
+            <a:avLst/>
+          </a:prstGeom>
+          <a:noFill/>
+        </p:spPr>
+        <p:txBody>
+          <a:bodyPr wrap="square">
+            <a:spAutoFit/>
+          </a:bodyPr>
+          <a:lstStyle/>
+          <a:p>
+            <a:pPr algn="ctr"/>
+            <a:r>
+              <a:rPr sz="800" b="0">
+                <a:solidFill>
+                  <a:srgbClr val="AAAAAA"/>
+                </a:solidFill>
+                <a:latin typeface="Noto Sans Arabic"/>
+              </a:rPr>
+              <a:t>Student data privacy</a:t>
+            </a:r>
+          </a:p>
+        </p:txBody>
+      </p:sp>
+      <p:sp>
+        <p:nvSpPr>
+          <p:cNvPr id="46" name="Rectangle 45"/>
+          <p:cNvSpPr/>
+          <p:nvPr/>
+        </p:nvSpPr>
+        <p:spPr>
+          <a:xfrm>
+            <a:off x="12192000" y="4526280"/>
+            <a:ext cx="6096000" cy="822960"/>
+          </a:xfrm>
+          <a:prstGeom prst="rect">
+            <a:avLst/>
+          </a:prstGeom>
+          <a:solidFill>
+            <a:srgbClr val="121E36"/>
+          </a:solidFill>
+          <a:ln>
+            <a:noFill/>
+          </a:ln>
+        </p:spPr>
+        <p:style>
+          <a:lnRef idx="1">
+            <a:schemeClr val="accent1"/>
+          </a:lnRef>
+          <a:fillRef idx="3">
+            <a:schemeClr val="accent1"/>
+          </a:fillRef>
+          <a:effectRef idx="2">
+            <a:schemeClr val="accent1"/>
+          </a:effectRef>
+          <a:fontRef idx="minor">
+            <a:schemeClr val="lt1"/>
+          </a:fontRef>
+        </p:style>
+        <p:txBody>
+          <a:bodyPr rtlCol="0" anchor="ctr"/>
+          <a:lstStyle/>
+          <a:p>
+            <a:pPr algn="ctr"/>
+          </a:p>
+        </p:txBody>
+      </p:sp>
+      <p:sp>
+        <p:nvSpPr>
+          <p:cNvPr id="47" name="TextBox 46"/>
+          <p:cNvSpPr txBox="1"/>
+          <p:nvPr/>
+        </p:nvSpPr>
+        <p:spPr>
+          <a:xfrm>
+            <a:off x="12192000" y="4544568"/>
+            <a:ext cx="6096000" cy="365760"/>
+          </a:xfrm>
+          <a:prstGeom prst="rect">
+            <a:avLst/>
+          </a:prstGeom>
+          <a:noFill/>
+        </p:spPr>
+        <p:txBody>
+          <a:bodyPr wrap="square">
+            <a:spAutoFit/>
+          </a:bodyPr>
+          <a:lstStyle/>
+          <a:p>
+            <a:pPr algn="ctr" rtl="1"/>
+            <a:r>
+              <a:rPr sz="2200" b="1">
+                <a:solidFill>
+                  <a:srgbClr val="C9A84C"/>
+                </a:solidFill>
+                <a:latin typeface="Noto Sans Arabic"/>
+              </a:rPr>
+              <a:t>5</a:t>
+            </a:r>
+          </a:p>
+        </p:txBody>
+      </p:sp>
+      <p:sp>
+        <p:nvSpPr>
+          <p:cNvPr id="48" name="TextBox 47"/>
+          <p:cNvSpPr txBox="1"/>
+          <p:nvPr/>
+        </p:nvSpPr>
+        <p:spPr>
+          <a:xfrm>
+            <a:off x="12192000" y="4910328"/>
+            <a:ext cx="6096000" cy="228600"/>
+          </a:xfrm>
+          <a:prstGeom prst="rect">
+            <a:avLst/>
+          </a:prstGeom>
+          <a:noFill/>
+        </p:spPr>
+        <p:txBody>
+          <a:bodyPr wrap="square">
+            <a:spAutoFit/>
+          </a:bodyPr>
+          <a:lstStyle/>
+          <a:p>
+            <a:pPr algn="ctr" rtl="1"/>
+            <a:r>
+              <a:rPr sz="1000" b="0">
+                <a:solidFill>
+                  <a:srgbClr val="FFFFFF"/>
+                </a:solidFill>
+                <a:latin typeface="Noto Sans Arabic"/>
+              </a:rPr>
+              <a:t>متطلبات القانون مُحققة</a:t>
+            </a:r>
+          </a:p>
+        </p:txBody>
+      </p:sp>
+      <p:sp>
+        <p:nvSpPr>
+          <p:cNvPr id="49" name="TextBox 48"/>
+          <p:cNvSpPr txBox="1"/>
+          <p:nvPr/>
+        </p:nvSpPr>
+        <p:spPr>
+          <a:xfrm>
+            <a:off x="12192000" y="5120640"/>
+            <a:ext cx="6096000" cy="201168"/>
+          </a:xfrm>
+          <a:prstGeom prst="rect">
+            <a:avLst/>
+          </a:prstGeom>
+          <a:noFill/>
+        </p:spPr>
+        <p:txBody>
+          <a:bodyPr wrap="square">
+            <a:spAutoFit/>
+          </a:bodyPr>
+          <a:lstStyle/>
+          <a:p>
+            <a:pPr algn="ctr"/>
+            <a:r>
+              <a:rPr sz="800" b="0">
+                <a:solidFill>
+                  <a:srgbClr val="AAAAAA"/>
+                </a:solidFill>
+                <a:latin typeface="Noto Sans Arabic"/>
+              </a:rPr>
+              <a:t>Law requirements met</a:t>
+            </a:r>
           </a:p>
         </p:txBody>
       </p:sp>

</xml_diff>